<commit_message>
Add Sniper & SupportDrone
</commit_message>
<xml_diff>
--- a/image process/drawings sifi.pptx
+++ b/image process/drawings sifi.pptx
@@ -15618,6 +15618,1599 @@
           </p:sp>
         </p:grpSp>
       </p:grpSp>
+      <p:grpSp>
+        <p:nvGrpSpPr>
+          <p:cNvPr id="313" name="Group 312">
+            <a:extLst>
+              <a:ext uri="{FF2B5EF4-FFF2-40B4-BE49-F238E27FC236}">
+                <a16:creationId xmlns:a16="http://schemas.microsoft.com/office/drawing/2014/main" id="{4B513A1D-2CCC-EF6A-93BC-E0617E3D96F5}"/>
+              </a:ext>
+            </a:extLst>
+          </p:cNvPr>
+          <p:cNvGrpSpPr/>
+          <p:nvPr/>
+        </p:nvGrpSpPr>
+        <p:grpSpPr>
+          <a:xfrm>
+            <a:off x="5304150" y="3827635"/>
+            <a:ext cx="1143909" cy="1520774"/>
+            <a:chOff x="3363817" y="813583"/>
+            <a:chExt cx="2044395" cy="2717927"/>
+          </a:xfrm>
+        </p:grpSpPr>
+        <p:sp>
+          <p:nvSpPr>
+            <p:cNvPr id="314" name="Diamond 313">
+              <a:extLst>
+                <a:ext uri="{FF2B5EF4-FFF2-40B4-BE49-F238E27FC236}">
+                  <a16:creationId xmlns:a16="http://schemas.microsoft.com/office/drawing/2014/main" id="{7A672C02-9737-5135-5BA6-1AF03FF3762D}"/>
+                </a:ext>
+              </a:extLst>
+            </p:cNvPr>
+            <p:cNvSpPr/>
+            <p:nvPr/>
+          </p:nvSpPr>
+          <p:spPr>
+            <a:xfrm>
+              <a:off x="3975100" y="1439970"/>
+              <a:ext cx="816608" cy="1449279"/>
+            </a:xfrm>
+            <a:prstGeom prst="diamond">
+              <a:avLst/>
+            </a:prstGeom>
+          </p:spPr>
+          <p:style>
+            <a:lnRef idx="2">
+              <a:schemeClr val="dk1">
+                <a:shade val="50000"/>
+              </a:schemeClr>
+            </a:lnRef>
+            <a:fillRef idx="1">
+              <a:schemeClr val="dk1"/>
+            </a:fillRef>
+            <a:effectRef idx="0">
+              <a:schemeClr val="dk1"/>
+            </a:effectRef>
+            <a:fontRef idx="minor">
+              <a:schemeClr val="lt1"/>
+            </a:fontRef>
+          </p:style>
+          <p:txBody>
+            <a:bodyPr rtlCol="0" anchor="ctr"/>
+            <a:lstStyle/>
+            <a:p>
+              <a:pPr algn="ctr"/>
+              <a:endParaRPr lang="en-US"/>
+            </a:p>
+          </p:txBody>
+        </p:sp>
+        <p:grpSp>
+          <p:nvGrpSpPr>
+            <p:cNvPr id="315" name="Group 314">
+              <a:extLst>
+                <a:ext uri="{FF2B5EF4-FFF2-40B4-BE49-F238E27FC236}">
+                  <a16:creationId xmlns:a16="http://schemas.microsoft.com/office/drawing/2014/main" id="{4A1AD818-C367-9D21-7F04-D309CB3408B0}"/>
+                </a:ext>
+              </a:extLst>
+            </p:cNvPr>
+            <p:cNvGrpSpPr/>
+            <p:nvPr/>
+          </p:nvGrpSpPr>
+          <p:grpSpPr>
+            <a:xfrm>
+              <a:off x="3363817" y="813583"/>
+              <a:ext cx="935545" cy="2708402"/>
+              <a:chOff x="3363817" y="813583"/>
+              <a:chExt cx="935545" cy="2708402"/>
+            </a:xfrm>
+          </p:grpSpPr>
+          <p:sp>
+            <p:nvSpPr>
+              <p:cNvPr id="344" name="Oval 343">
+                <a:extLst>
+                  <a:ext uri="{FF2B5EF4-FFF2-40B4-BE49-F238E27FC236}">
+                    <a16:creationId xmlns:a16="http://schemas.microsoft.com/office/drawing/2014/main" id="{A39745CB-08C6-1697-B7E5-574690AAE96B}"/>
+                  </a:ext>
+                </a:extLst>
+              </p:cNvPr>
+              <p:cNvSpPr/>
+              <p:nvPr/>
+            </p:nvSpPr>
+            <p:spPr>
+              <a:xfrm rot="1729643">
+                <a:off x="3363818" y="813583"/>
+                <a:ext cx="935544" cy="1529359"/>
+              </a:xfrm>
+              <a:prstGeom prst="ellipse">
+                <a:avLst/>
+              </a:prstGeom>
+              <a:ln>
+                <a:noFill/>
+              </a:ln>
+            </p:spPr>
+            <p:style>
+              <a:lnRef idx="2">
+                <a:schemeClr val="dk1"/>
+              </a:lnRef>
+              <a:fillRef idx="1">
+                <a:schemeClr val="lt1"/>
+              </a:fillRef>
+              <a:effectRef idx="0">
+                <a:schemeClr val="dk1"/>
+              </a:effectRef>
+              <a:fontRef idx="minor">
+                <a:schemeClr val="dk1"/>
+              </a:fontRef>
+            </p:style>
+            <p:txBody>
+              <a:bodyPr rtlCol="0" anchor="ctr"/>
+              <a:lstStyle/>
+              <a:p>
+                <a:pPr algn="ctr"/>
+                <a:endParaRPr lang="en-US"/>
+              </a:p>
+            </p:txBody>
+          </p:sp>
+          <p:sp>
+            <p:nvSpPr>
+              <p:cNvPr id="345" name="Oval 344">
+                <a:extLst>
+                  <a:ext uri="{FF2B5EF4-FFF2-40B4-BE49-F238E27FC236}">
+                    <a16:creationId xmlns:a16="http://schemas.microsoft.com/office/drawing/2014/main" id="{30334C54-BAC3-39A0-9D89-09DC125581C0}"/>
+                  </a:ext>
+                </a:extLst>
+              </p:cNvPr>
+              <p:cNvSpPr/>
+              <p:nvPr/>
+            </p:nvSpPr>
+            <p:spPr>
+              <a:xfrm rot="19870357" flipV="1">
+                <a:off x="3363817" y="1992626"/>
+                <a:ext cx="935544" cy="1529359"/>
+              </a:xfrm>
+              <a:prstGeom prst="ellipse">
+                <a:avLst/>
+              </a:prstGeom>
+              <a:ln>
+                <a:noFill/>
+              </a:ln>
+            </p:spPr>
+            <p:style>
+              <a:lnRef idx="2">
+                <a:schemeClr val="dk1"/>
+              </a:lnRef>
+              <a:fillRef idx="1">
+                <a:schemeClr val="lt1"/>
+              </a:fillRef>
+              <a:effectRef idx="0">
+                <a:schemeClr val="dk1"/>
+              </a:effectRef>
+              <a:fontRef idx="minor">
+                <a:schemeClr val="dk1"/>
+              </a:fontRef>
+            </p:style>
+            <p:txBody>
+              <a:bodyPr rtlCol="0" anchor="ctr"/>
+              <a:lstStyle/>
+              <a:p>
+                <a:pPr algn="ctr"/>
+                <a:endParaRPr lang="en-US"/>
+              </a:p>
+            </p:txBody>
+          </p:sp>
+        </p:grpSp>
+        <p:grpSp>
+          <p:nvGrpSpPr>
+            <p:cNvPr id="336" name="Group 335">
+              <a:extLst>
+                <a:ext uri="{FF2B5EF4-FFF2-40B4-BE49-F238E27FC236}">
+                  <a16:creationId xmlns:a16="http://schemas.microsoft.com/office/drawing/2014/main" id="{E8149E00-3552-BEC3-8D28-7397C814E243}"/>
+                </a:ext>
+              </a:extLst>
+            </p:cNvPr>
+            <p:cNvGrpSpPr/>
+            <p:nvPr/>
+          </p:nvGrpSpPr>
+          <p:grpSpPr>
+            <a:xfrm flipH="1">
+              <a:off x="4472667" y="823108"/>
+              <a:ext cx="935545" cy="2708402"/>
+              <a:chOff x="3363817" y="813583"/>
+              <a:chExt cx="935545" cy="2708402"/>
+            </a:xfrm>
+          </p:grpSpPr>
+          <p:sp>
+            <p:nvSpPr>
+              <p:cNvPr id="342" name="Oval 341">
+                <a:extLst>
+                  <a:ext uri="{FF2B5EF4-FFF2-40B4-BE49-F238E27FC236}">
+                    <a16:creationId xmlns:a16="http://schemas.microsoft.com/office/drawing/2014/main" id="{85EF25FD-C6A2-2A37-0976-FC12EAFCDEF6}"/>
+                  </a:ext>
+                </a:extLst>
+              </p:cNvPr>
+              <p:cNvSpPr/>
+              <p:nvPr/>
+            </p:nvSpPr>
+            <p:spPr>
+              <a:xfrm rot="1729643">
+                <a:off x="3363818" y="813583"/>
+                <a:ext cx="935544" cy="1529359"/>
+              </a:xfrm>
+              <a:prstGeom prst="ellipse">
+                <a:avLst/>
+              </a:prstGeom>
+              <a:ln>
+                <a:noFill/>
+              </a:ln>
+            </p:spPr>
+            <p:style>
+              <a:lnRef idx="2">
+                <a:schemeClr val="dk1"/>
+              </a:lnRef>
+              <a:fillRef idx="1">
+                <a:schemeClr val="lt1"/>
+              </a:fillRef>
+              <a:effectRef idx="0">
+                <a:schemeClr val="dk1"/>
+              </a:effectRef>
+              <a:fontRef idx="minor">
+                <a:schemeClr val="dk1"/>
+              </a:fontRef>
+            </p:style>
+            <p:txBody>
+              <a:bodyPr rtlCol="0" anchor="ctr"/>
+              <a:lstStyle/>
+              <a:p>
+                <a:pPr algn="ctr"/>
+                <a:endParaRPr lang="en-US"/>
+              </a:p>
+            </p:txBody>
+          </p:sp>
+          <p:sp>
+            <p:nvSpPr>
+              <p:cNvPr id="343" name="Oval 342">
+                <a:extLst>
+                  <a:ext uri="{FF2B5EF4-FFF2-40B4-BE49-F238E27FC236}">
+                    <a16:creationId xmlns:a16="http://schemas.microsoft.com/office/drawing/2014/main" id="{15A388CC-FA78-6A13-CF9E-4C283C272804}"/>
+                  </a:ext>
+                </a:extLst>
+              </p:cNvPr>
+              <p:cNvSpPr/>
+              <p:nvPr/>
+            </p:nvSpPr>
+            <p:spPr>
+              <a:xfrm rot="19870357" flipV="1">
+                <a:off x="3363817" y="1992626"/>
+                <a:ext cx="935544" cy="1529359"/>
+              </a:xfrm>
+              <a:prstGeom prst="ellipse">
+                <a:avLst/>
+              </a:prstGeom>
+              <a:ln>
+                <a:noFill/>
+              </a:ln>
+            </p:spPr>
+            <p:style>
+              <a:lnRef idx="2">
+                <a:schemeClr val="dk1"/>
+              </a:lnRef>
+              <a:fillRef idx="1">
+                <a:schemeClr val="lt1"/>
+              </a:fillRef>
+              <a:effectRef idx="0">
+                <a:schemeClr val="dk1"/>
+              </a:effectRef>
+              <a:fontRef idx="minor">
+                <a:schemeClr val="dk1"/>
+              </a:fontRef>
+            </p:style>
+            <p:txBody>
+              <a:bodyPr rtlCol="0" anchor="ctr"/>
+              <a:lstStyle/>
+              <a:p>
+                <a:pPr algn="ctr"/>
+                <a:endParaRPr lang="en-US"/>
+              </a:p>
+            </p:txBody>
+          </p:sp>
+        </p:grpSp>
+        <p:sp>
+          <p:nvSpPr>
+            <p:cNvPr id="337" name="Rectangle 336">
+              <a:extLst>
+                <a:ext uri="{FF2B5EF4-FFF2-40B4-BE49-F238E27FC236}">
+                  <a16:creationId xmlns:a16="http://schemas.microsoft.com/office/drawing/2014/main" id="{70A353CF-583C-F469-D83F-694B20FC2505}"/>
+                </a:ext>
+              </a:extLst>
+            </p:cNvPr>
+            <p:cNvSpPr/>
+            <p:nvPr/>
+          </p:nvSpPr>
+          <p:spPr>
+            <a:xfrm>
+              <a:off x="3683000" y="2068915"/>
+              <a:ext cx="1397000" cy="279400"/>
+            </a:xfrm>
+            <a:prstGeom prst="rect">
+              <a:avLst/>
+            </a:prstGeom>
+          </p:spPr>
+          <p:style>
+            <a:lnRef idx="2">
+              <a:schemeClr val="dk1">
+                <a:shade val="50000"/>
+              </a:schemeClr>
+            </a:lnRef>
+            <a:fillRef idx="1">
+              <a:schemeClr val="dk1"/>
+            </a:fillRef>
+            <a:effectRef idx="0">
+              <a:schemeClr val="dk1"/>
+            </a:effectRef>
+            <a:fontRef idx="minor">
+              <a:schemeClr val="lt1"/>
+            </a:fontRef>
+          </p:style>
+          <p:txBody>
+            <a:bodyPr rtlCol="0" anchor="ctr"/>
+            <a:lstStyle/>
+            <a:p>
+              <a:pPr algn="ctr"/>
+              <a:endParaRPr lang="en-US"/>
+            </a:p>
+          </p:txBody>
+        </p:sp>
+        <p:sp>
+          <p:nvSpPr>
+            <p:cNvPr id="338" name="Rectangle 337">
+              <a:extLst>
+                <a:ext uri="{FF2B5EF4-FFF2-40B4-BE49-F238E27FC236}">
+                  <a16:creationId xmlns:a16="http://schemas.microsoft.com/office/drawing/2014/main" id="{783DD2F9-A0D2-9A30-B40B-28E4C4B25B57}"/>
+                </a:ext>
+              </a:extLst>
+            </p:cNvPr>
+            <p:cNvSpPr/>
+            <p:nvPr/>
+          </p:nvSpPr>
+          <p:spPr>
+            <a:xfrm>
+              <a:off x="3756163" y="1876629"/>
+              <a:ext cx="181606" cy="663971"/>
+            </a:xfrm>
+            <a:prstGeom prst="rect">
+              <a:avLst/>
+            </a:prstGeom>
+          </p:spPr>
+          <p:style>
+            <a:lnRef idx="2">
+              <a:schemeClr val="dk1"/>
+            </a:lnRef>
+            <a:fillRef idx="1">
+              <a:schemeClr val="lt1"/>
+            </a:fillRef>
+            <a:effectRef idx="0">
+              <a:schemeClr val="dk1"/>
+            </a:effectRef>
+            <a:fontRef idx="minor">
+              <a:schemeClr val="dk1"/>
+            </a:fontRef>
+          </p:style>
+          <p:txBody>
+            <a:bodyPr rtlCol="0" anchor="ctr"/>
+            <a:lstStyle/>
+            <a:p>
+              <a:pPr algn="ctr"/>
+              <a:endParaRPr lang="en-US"/>
+            </a:p>
+          </p:txBody>
+        </p:sp>
+        <p:sp>
+          <p:nvSpPr>
+            <p:cNvPr id="339" name="Rectangle 338">
+              <a:extLst>
+                <a:ext uri="{FF2B5EF4-FFF2-40B4-BE49-F238E27FC236}">
+                  <a16:creationId xmlns:a16="http://schemas.microsoft.com/office/drawing/2014/main" id="{2E533B33-5B76-1638-3440-B4995CC510A7}"/>
+                </a:ext>
+              </a:extLst>
+            </p:cNvPr>
+            <p:cNvSpPr/>
+            <p:nvPr/>
+          </p:nvSpPr>
+          <p:spPr>
+            <a:xfrm>
+              <a:off x="4823219" y="1861841"/>
+              <a:ext cx="181606" cy="663971"/>
+            </a:xfrm>
+            <a:prstGeom prst="rect">
+              <a:avLst/>
+            </a:prstGeom>
+          </p:spPr>
+          <p:style>
+            <a:lnRef idx="2">
+              <a:schemeClr val="dk1"/>
+            </a:lnRef>
+            <a:fillRef idx="1">
+              <a:schemeClr val="lt1"/>
+            </a:fillRef>
+            <a:effectRef idx="0">
+              <a:schemeClr val="dk1"/>
+            </a:effectRef>
+            <a:fontRef idx="minor">
+              <a:schemeClr val="dk1"/>
+            </a:fontRef>
+          </p:style>
+          <p:txBody>
+            <a:bodyPr rtlCol="0" anchor="ctr"/>
+            <a:lstStyle/>
+            <a:p>
+              <a:pPr algn="ctr"/>
+              <a:endParaRPr lang="en-US"/>
+            </a:p>
+          </p:txBody>
+        </p:sp>
+        <p:sp>
+          <p:nvSpPr>
+            <p:cNvPr id="340" name="Cross 339">
+              <a:extLst>
+                <a:ext uri="{FF2B5EF4-FFF2-40B4-BE49-F238E27FC236}">
+                  <a16:creationId xmlns:a16="http://schemas.microsoft.com/office/drawing/2014/main" id="{279329A5-23D7-552E-2E7F-2F9A6C57923E}"/>
+                </a:ext>
+              </a:extLst>
+            </p:cNvPr>
+            <p:cNvSpPr/>
+            <p:nvPr/>
+          </p:nvSpPr>
+          <p:spPr>
+            <a:xfrm>
+              <a:off x="4610101" y="1555630"/>
+              <a:ext cx="277271" cy="263881"/>
+            </a:xfrm>
+            <a:prstGeom prst="plus">
+              <a:avLst>
+                <a:gd name="adj" fmla="val 37697"/>
+              </a:avLst>
+            </a:prstGeom>
+          </p:spPr>
+          <p:style>
+            <a:lnRef idx="2">
+              <a:schemeClr val="dk1">
+                <a:shade val="50000"/>
+              </a:schemeClr>
+            </a:lnRef>
+            <a:fillRef idx="1">
+              <a:schemeClr val="dk1"/>
+            </a:fillRef>
+            <a:effectRef idx="0">
+              <a:schemeClr val="dk1"/>
+            </a:effectRef>
+            <a:fontRef idx="minor">
+              <a:schemeClr val="lt1"/>
+            </a:fontRef>
+          </p:style>
+          <p:txBody>
+            <a:bodyPr rtlCol="0" anchor="ctr"/>
+            <a:lstStyle/>
+            <a:p>
+              <a:pPr algn="ctr"/>
+              <a:endParaRPr lang="en-US"/>
+            </a:p>
+          </p:txBody>
+        </p:sp>
+        <p:sp>
+          <p:nvSpPr>
+            <p:cNvPr id="341" name="Cross 340">
+              <a:extLst>
+                <a:ext uri="{FF2B5EF4-FFF2-40B4-BE49-F238E27FC236}">
+                  <a16:creationId xmlns:a16="http://schemas.microsoft.com/office/drawing/2014/main" id="{ED1DAF97-8F33-5282-959F-454BD2C6C5E0}"/>
+                </a:ext>
+              </a:extLst>
+            </p:cNvPr>
+            <p:cNvSpPr/>
+            <p:nvPr/>
+          </p:nvSpPr>
+          <p:spPr>
+            <a:xfrm>
+              <a:off x="4784233" y="1414162"/>
+              <a:ext cx="185026" cy="176091"/>
+            </a:xfrm>
+            <a:prstGeom prst="plus">
+              <a:avLst>
+                <a:gd name="adj" fmla="val 37697"/>
+              </a:avLst>
+            </a:prstGeom>
+          </p:spPr>
+          <p:style>
+            <a:lnRef idx="2">
+              <a:schemeClr val="dk1">
+                <a:shade val="50000"/>
+              </a:schemeClr>
+            </a:lnRef>
+            <a:fillRef idx="1">
+              <a:schemeClr val="dk1"/>
+            </a:fillRef>
+            <a:effectRef idx="0">
+              <a:schemeClr val="dk1"/>
+            </a:effectRef>
+            <a:fontRef idx="minor">
+              <a:schemeClr val="lt1"/>
+            </a:fontRef>
+          </p:style>
+          <p:txBody>
+            <a:bodyPr rtlCol="0" anchor="ctr"/>
+            <a:lstStyle/>
+            <a:p>
+              <a:pPr algn="ctr"/>
+              <a:endParaRPr lang="en-US"/>
+            </a:p>
+          </p:txBody>
+        </p:sp>
+      </p:grpSp>
+      <p:grpSp>
+        <p:nvGrpSpPr>
+          <p:cNvPr id="346" name="Group 345">
+            <a:extLst>
+              <a:ext uri="{FF2B5EF4-FFF2-40B4-BE49-F238E27FC236}">
+                <a16:creationId xmlns:a16="http://schemas.microsoft.com/office/drawing/2014/main" id="{A87E1107-DACA-E244-17C7-C4B29E932667}"/>
+              </a:ext>
+            </a:extLst>
+          </p:cNvPr>
+          <p:cNvGrpSpPr/>
+          <p:nvPr/>
+        </p:nvGrpSpPr>
+        <p:grpSpPr>
+          <a:xfrm>
+            <a:off x="5190305" y="3897729"/>
+            <a:ext cx="1371600" cy="1371600"/>
+            <a:chOff x="1298501" y="962272"/>
+            <a:chExt cx="1371600" cy="1371600"/>
+          </a:xfrm>
+        </p:grpSpPr>
+        <p:sp>
+          <p:nvSpPr>
+            <p:cNvPr id="347" name="Rectangle 346">
+              <a:extLst>
+                <a:ext uri="{FF2B5EF4-FFF2-40B4-BE49-F238E27FC236}">
+                  <a16:creationId xmlns:a16="http://schemas.microsoft.com/office/drawing/2014/main" id="{B2AF726B-211F-464E-2DB1-FDEC9CE26139}"/>
+                </a:ext>
+              </a:extLst>
+            </p:cNvPr>
+            <p:cNvSpPr/>
+            <p:nvPr/>
+          </p:nvSpPr>
+          <p:spPr>
+            <a:xfrm>
+              <a:off x="1298501" y="962272"/>
+              <a:ext cx="1371600" cy="1371600"/>
+            </a:xfrm>
+            <a:prstGeom prst="rect">
+              <a:avLst/>
+            </a:prstGeom>
+            <a:noFill/>
+            <a:ln w="76200">
+              <a:solidFill>
+                <a:schemeClr val="tx1"/>
+              </a:solidFill>
+            </a:ln>
+          </p:spPr>
+          <p:style>
+            <a:lnRef idx="2">
+              <a:schemeClr val="accent1">
+                <a:shade val="50000"/>
+              </a:schemeClr>
+            </a:lnRef>
+            <a:fillRef idx="1">
+              <a:schemeClr val="accent1"/>
+            </a:fillRef>
+            <a:effectRef idx="0">
+              <a:schemeClr val="accent1"/>
+            </a:effectRef>
+            <a:fontRef idx="minor">
+              <a:schemeClr val="lt1"/>
+            </a:fontRef>
+          </p:style>
+          <p:txBody>
+            <a:bodyPr rtlCol="0" anchor="ctr"/>
+            <a:lstStyle/>
+            <a:p>
+              <a:pPr algn="ctr"/>
+              <a:endParaRPr lang="en-US"/>
+            </a:p>
+          </p:txBody>
+        </p:sp>
+        <p:sp>
+          <p:nvSpPr>
+            <p:cNvPr id="348" name="Arrow: Pentagon 347">
+              <a:extLst>
+                <a:ext uri="{FF2B5EF4-FFF2-40B4-BE49-F238E27FC236}">
+                  <a16:creationId xmlns:a16="http://schemas.microsoft.com/office/drawing/2014/main" id="{980D8276-CE82-A926-2594-431EC68E9E6A}"/>
+                </a:ext>
+              </a:extLst>
+            </p:cNvPr>
+            <p:cNvSpPr/>
+            <p:nvPr/>
+          </p:nvSpPr>
+          <p:spPr>
+            <a:xfrm rot="5400000">
+              <a:off x="1435661" y="1173775"/>
+              <a:ext cx="1097280" cy="1097280"/>
+            </a:xfrm>
+            <a:prstGeom prst="homePlate">
+              <a:avLst/>
+            </a:prstGeom>
+            <a:noFill/>
+            <a:ln w="38100" cap="flat" cmpd="sng" algn="ctr">
+              <a:solidFill>
+                <a:schemeClr val="dk1"/>
+              </a:solidFill>
+              <a:prstDash val="solid"/>
+              <a:round/>
+              <a:headEnd type="none" w="med" len="med"/>
+              <a:tailEnd type="none" w="med" len="med"/>
+            </a:ln>
+          </p:spPr>
+          <p:style>
+            <a:lnRef idx="0">
+              <a:scrgbClr r="0" g="0" b="0"/>
+            </a:lnRef>
+            <a:fillRef idx="0">
+              <a:scrgbClr r="0" g="0" b="0"/>
+            </a:fillRef>
+            <a:effectRef idx="0">
+              <a:scrgbClr r="0" g="0" b="0"/>
+            </a:effectRef>
+            <a:fontRef idx="minor">
+              <a:schemeClr val="dk1"/>
+            </a:fontRef>
+          </p:style>
+          <p:txBody>
+            <a:bodyPr rtlCol="0" anchor="ctr"/>
+            <a:lstStyle/>
+            <a:p>
+              <a:pPr algn="ctr"/>
+              <a:endParaRPr lang="en-US"/>
+            </a:p>
+          </p:txBody>
+        </p:sp>
+      </p:grpSp>
+      <p:grpSp>
+        <p:nvGrpSpPr>
+          <p:cNvPr id="349" name="Group 348">
+            <a:extLst>
+              <a:ext uri="{FF2B5EF4-FFF2-40B4-BE49-F238E27FC236}">
+                <a16:creationId xmlns:a16="http://schemas.microsoft.com/office/drawing/2014/main" id="{FA54B203-559E-CC5F-7B15-F1613B87A630}"/>
+              </a:ext>
+            </a:extLst>
+          </p:cNvPr>
+          <p:cNvGrpSpPr/>
+          <p:nvPr/>
+        </p:nvGrpSpPr>
+        <p:grpSpPr>
+          <a:xfrm>
+            <a:off x="6777598" y="3883442"/>
+            <a:ext cx="1371600" cy="1371600"/>
+            <a:chOff x="1298501" y="962272"/>
+            <a:chExt cx="1371600" cy="1371600"/>
+          </a:xfrm>
+        </p:grpSpPr>
+        <p:sp>
+          <p:nvSpPr>
+            <p:cNvPr id="350" name="Rectangle 349">
+              <a:extLst>
+                <a:ext uri="{FF2B5EF4-FFF2-40B4-BE49-F238E27FC236}">
+                  <a16:creationId xmlns:a16="http://schemas.microsoft.com/office/drawing/2014/main" id="{51B3470A-F1D5-ABD7-63F4-8DE2475ED1F2}"/>
+                </a:ext>
+              </a:extLst>
+            </p:cNvPr>
+            <p:cNvSpPr/>
+            <p:nvPr/>
+          </p:nvSpPr>
+          <p:spPr>
+            <a:xfrm>
+              <a:off x="1298501" y="962272"/>
+              <a:ext cx="1371600" cy="1371600"/>
+            </a:xfrm>
+            <a:prstGeom prst="rect">
+              <a:avLst/>
+            </a:prstGeom>
+            <a:noFill/>
+            <a:ln w="76200">
+              <a:solidFill>
+                <a:schemeClr val="tx1"/>
+              </a:solidFill>
+            </a:ln>
+          </p:spPr>
+          <p:style>
+            <a:lnRef idx="2">
+              <a:schemeClr val="accent1">
+                <a:shade val="50000"/>
+              </a:schemeClr>
+            </a:lnRef>
+            <a:fillRef idx="1">
+              <a:schemeClr val="accent1"/>
+            </a:fillRef>
+            <a:effectRef idx="0">
+              <a:schemeClr val="accent1"/>
+            </a:effectRef>
+            <a:fontRef idx="minor">
+              <a:schemeClr val="lt1"/>
+            </a:fontRef>
+          </p:style>
+          <p:txBody>
+            <a:bodyPr rtlCol="0" anchor="ctr"/>
+            <a:lstStyle/>
+            <a:p>
+              <a:pPr algn="ctr"/>
+              <a:endParaRPr lang="en-US"/>
+            </a:p>
+          </p:txBody>
+        </p:sp>
+        <p:sp>
+          <p:nvSpPr>
+            <p:cNvPr id="351" name="Arrow: Pentagon 350">
+              <a:extLst>
+                <a:ext uri="{FF2B5EF4-FFF2-40B4-BE49-F238E27FC236}">
+                  <a16:creationId xmlns:a16="http://schemas.microsoft.com/office/drawing/2014/main" id="{1FF83E73-E8BC-235B-310D-CC6CFD180A6C}"/>
+                </a:ext>
+              </a:extLst>
+            </p:cNvPr>
+            <p:cNvSpPr/>
+            <p:nvPr/>
+          </p:nvSpPr>
+          <p:spPr>
+            <a:xfrm rot="5400000">
+              <a:off x="1435661" y="1173775"/>
+              <a:ext cx="1097280" cy="1097280"/>
+            </a:xfrm>
+            <a:prstGeom prst="homePlate">
+              <a:avLst/>
+            </a:prstGeom>
+            <a:noFill/>
+            <a:ln w="38100" cap="flat" cmpd="sng" algn="ctr">
+              <a:solidFill>
+                <a:schemeClr val="dk1"/>
+              </a:solidFill>
+              <a:prstDash val="solid"/>
+              <a:round/>
+              <a:headEnd type="none" w="med" len="med"/>
+              <a:tailEnd type="none" w="med" len="med"/>
+            </a:ln>
+          </p:spPr>
+          <p:style>
+            <a:lnRef idx="0">
+              <a:scrgbClr r="0" g="0" b="0"/>
+            </a:lnRef>
+            <a:fillRef idx="0">
+              <a:scrgbClr r="0" g="0" b="0"/>
+            </a:fillRef>
+            <a:effectRef idx="0">
+              <a:scrgbClr r="0" g="0" b="0"/>
+            </a:effectRef>
+            <a:fontRef idx="minor">
+              <a:schemeClr val="dk1"/>
+            </a:fontRef>
+          </p:style>
+          <p:txBody>
+            <a:bodyPr rtlCol="0" anchor="ctr"/>
+            <a:lstStyle/>
+            <a:p>
+              <a:pPr algn="ctr"/>
+              <a:endParaRPr lang="en-US"/>
+            </a:p>
+          </p:txBody>
+        </p:sp>
+      </p:grpSp>
+      <p:pic>
+        <p:nvPicPr>
+          <p:cNvPr id="360" name="Picture 2" descr="Sniper rifle vector Images, Stock Photos &amp; Vectors | Shutterstock">
+            <a:extLst>
+              <a:ext uri="{FF2B5EF4-FFF2-40B4-BE49-F238E27FC236}">
+                <a16:creationId xmlns:a16="http://schemas.microsoft.com/office/drawing/2014/main" id="{B4CF7F24-532F-72B1-793F-E57155EF7B34}"/>
+              </a:ext>
+            </a:extLst>
+          </p:cNvPr>
+          <p:cNvPicPr>
+            <a:picLocks noChangeAspect="1" noChangeArrowheads="1"/>
+          </p:cNvPicPr>
+          <p:nvPr/>
+        </p:nvPicPr>
+        <p:blipFill rotWithShape="1">
+          <a:blip r:embed="rId6">
+            <a:extLst>
+              <a:ext uri="{28A0092B-C50C-407E-A947-70E740481C1C}">
+                <a14:useLocalDpi xmlns:a14="http://schemas.microsoft.com/office/drawing/2010/main" val="0"/>
+              </a:ext>
+            </a:extLst>
+          </a:blip>
+          <a:srcRect l="3957" t="13333" r="2963" b="12143"/>
+          <a:stretch/>
+        </p:blipFill>
+        <p:spPr bwMode="auto">
+          <a:xfrm rot="1675474" flipH="1">
+            <a:off x="8471739" y="4374492"/>
+            <a:ext cx="1046633" cy="342583"/>
+          </a:xfrm>
+          <a:prstGeom prst="rect">
+            <a:avLst/>
+          </a:prstGeom>
+          <a:noFill/>
+          <a:extLst>
+            <a:ext uri="{909E8E84-426E-40DD-AFC4-6F175D3DCCD1}">
+              <a14:hiddenFill xmlns:a14="http://schemas.microsoft.com/office/drawing/2010/main">
+                <a:solidFill>
+                  <a:srgbClr val="FFFFFF"/>
+                </a:solidFill>
+              </a14:hiddenFill>
+            </a:ext>
+          </a:extLst>
+        </p:spPr>
+      </p:pic>
+      <p:grpSp>
+        <p:nvGrpSpPr>
+          <p:cNvPr id="361" name="Group 360">
+            <a:extLst>
+              <a:ext uri="{FF2B5EF4-FFF2-40B4-BE49-F238E27FC236}">
+                <a16:creationId xmlns:a16="http://schemas.microsoft.com/office/drawing/2014/main" id="{30166513-C7A2-6888-F33C-D462D55D75FE}"/>
+              </a:ext>
+            </a:extLst>
+          </p:cNvPr>
+          <p:cNvGrpSpPr/>
+          <p:nvPr/>
+        </p:nvGrpSpPr>
+        <p:grpSpPr>
+          <a:xfrm>
+            <a:off x="8351685" y="3959505"/>
+            <a:ext cx="1371600" cy="1371600"/>
+            <a:chOff x="1298501" y="962272"/>
+            <a:chExt cx="1371600" cy="1371600"/>
+          </a:xfrm>
+        </p:grpSpPr>
+        <p:sp>
+          <p:nvSpPr>
+            <p:cNvPr id="362" name="Rectangle 361">
+              <a:extLst>
+                <a:ext uri="{FF2B5EF4-FFF2-40B4-BE49-F238E27FC236}">
+                  <a16:creationId xmlns:a16="http://schemas.microsoft.com/office/drawing/2014/main" id="{768123B9-3E7F-EF9A-147D-57B21696125C}"/>
+                </a:ext>
+              </a:extLst>
+            </p:cNvPr>
+            <p:cNvSpPr/>
+            <p:nvPr/>
+          </p:nvSpPr>
+          <p:spPr>
+            <a:xfrm>
+              <a:off x="1298501" y="962272"/>
+              <a:ext cx="1371600" cy="1371600"/>
+            </a:xfrm>
+            <a:prstGeom prst="rect">
+              <a:avLst/>
+            </a:prstGeom>
+            <a:noFill/>
+            <a:ln w="76200">
+              <a:solidFill>
+                <a:schemeClr val="tx1"/>
+              </a:solidFill>
+            </a:ln>
+          </p:spPr>
+          <p:style>
+            <a:lnRef idx="2">
+              <a:schemeClr val="accent1">
+                <a:shade val="50000"/>
+              </a:schemeClr>
+            </a:lnRef>
+            <a:fillRef idx="1">
+              <a:schemeClr val="accent1"/>
+            </a:fillRef>
+            <a:effectRef idx="0">
+              <a:schemeClr val="accent1"/>
+            </a:effectRef>
+            <a:fontRef idx="minor">
+              <a:schemeClr val="lt1"/>
+            </a:fontRef>
+          </p:style>
+          <p:txBody>
+            <a:bodyPr rtlCol="0" anchor="ctr"/>
+            <a:lstStyle/>
+            <a:p>
+              <a:pPr algn="ctr"/>
+              <a:endParaRPr lang="en-US"/>
+            </a:p>
+          </p:txBody>
+        </p:sp>
+        <p:sp>
+          <p:nvSpPr>
+            <p:cNvPr id="363" name="Arrow: Pentagon 362">
+              <a:extLst>
+                <a:ext uri="{FF2B5EF4-FFF2-40B4-BE49-F238E27FC236}">
+                  <a16:creationId xmlns:a16="http://schemas.microsoft.com/office/drawing/2014/main" id="{C7E9948F-0BB1-566D-8EF2-3BA5D3005B15}"/>
+                </a:ext>
+              </a:extLst>
+            </p:cNvPr>
+            <p:cNvSpPr/>
+            <p:nvPr/>
+          </p:nvSpPr>
+          <p:spPr>
+            <a:xfrm rot="5400000">
+              <a:off x="1435661" y="1173775"/>
+              <a:ext cx="1097280" cy="1097280"/>
+            </a:xfrm>
+            <a:prstGeom prst="homePlate">
+              <a:avLst/>
+            </a:prstGeom>
+            <a:noFill/>
+            <a:ln w="38100" cap="flat" cmpd="sng" algn="ctr">
+              <a:solidFill>
+                <a:schemeClr val="dk1"/>
+              </a:solidFill>
+              <a:prstDash val="solid"/>
+              <a:round/>
+              <a:headEnd type="none" w="med" len="med"/>
+              <a:tailEnd type="none" w="med" len="med"/>
+            </a:ln>
+          </p:spPr>
+          <p:style>
+            <a:lnRef idx="0">
+              <a:scrgbClr r="0" g="0" b="0"/>
+            </a:lnRef>
+            <a:fillRef idx="0">
+              <a:scrgbClr r="0" g="0" b="0"/>
+            </a:fillRef>
+            <a:effectRef idx="0">
+              <a:scrgbClr r="0" g="0" b="0"/>
+            </a:effectRef>
+            <a:fontRef idx="minor">
+              <a:schemeClr val="dk1"/>
+            </a:fontRef>
+          </p:style>
+          <p:txBody>
+            <a:bodyPr rtlCol="0" anchor="ctr"/>
+            <a:lstStyle/>
+            <a:p>
+              <a:pPr algn="ctr"/>
+              <a:endParaRPr lang="en-US"/>
+            </a:p>
+          </p:txBody>
+        </p:sp>
+      </p:grpSp>
+      <p:grpSp>
+        <p:nvGrpSpPr>
+          <p:cNvPr id="364" name="Group 363">
+            <a:extLst>
+              <a:ext uri="{FF2B5EF4-FFF2-40B4-BE49-F238E27FC236}">
+                <a16:creationId xmlns:a16="http://schemas.microsoft.com/office/drawing/2014/main" id="{AEC83E13-CFEB-66EB-8317-FC342E162DC9}"/>
+              </a:ext>
+            </a:extLst>
+          </p:cNvPr>
+          <p:cNvGrpSpPr/>
+          <p:nvPr/>
+        </p:nvGrpSpPr>
+        <p:grpSpPr>
+          <a:xfrm>
+            <a:off x="7060096" y="4202711"/>
+            <a:ext cx="794436" cy="794436"/>
+            <a:chOff x="6791479" y="4800533"/>
+            <a:chExt cx="514930" cy="514930"/>
+          </a:xfrm>
+        </p:grpSpPr>
+        <p:sp>
+          <p:nvSpPr>
+            <p:cNvPr id="365" name="Oval 364">
+              <a:extLst>
+                <a:ext uri="{FF2B5EF4-FFF2-40B4-BE49-F238E27FC236}">
+                  <a16:creationId xmlns:a16="http://schemas.microsoft.com/office/drawing/2014/main" id="{30EF48A3-5B08-11AA-0084-02FDDB66A024}"/>
+                </a:ext>
+              </a:extLst>
+            </p:cNvPr>
+            <p:cNvSpPr/>
+            <p:nvPr/>
+          </p:nvSpPr>
+          <p:spPr>
+            <a:xfrm>
+              <a:off x="6885419" y="4892733"/>
+              <a:ext cx="327050" cy="327050"/>
+            </a:xfrm>
+            <a:prstGeom prst="ellipse">
+              <a:avLst/>
+            </a:prstGeom>
+            <a:noFill/>
+            <a:ln w="28575"/>
+          </p:spPr>
+          <p:style>
+            <a:lnRef idx="2">
+              <a:schemeClr val="dk1"/>
+            </a:lnRef>
+            <a:fillRef idx="1">
+              <a:schemeClr val="lt1"/>
+            </a:fillRef>
+            <a:effectRef idx="0">
+              <a:schemeClr val="dk1"/>
+            </a:effectRef>
+            <a:fontRef idx="minor">
+              <a:schemeClr val="dk1"/>
+            </a:fontRef>
+          </p:style>
+          <p:txBody>
+            <a:bodyPr rtlCol="0" anchor="ctr"/>
+            <a:lstStyle/>
+            <a:p>
+              <a:pPr algn="ctr"/>
+              <a:endParaRPr lang="en-US" dirty="0"/>
+            </a:p>
+          </p:txBody>
+        </p:sp>
+        <p:sp>
+          <p:nvSpPr>
+            <p:cNvPr id="366" name="Oval 365">
+              <a:extLst>
+                <a:ext uri="{FF2B5EF4-FFF2-40B4-BE49-F238E27FC236}">
+                  <a16:creationId xmlns:a16="http://schemas.microsoft.com/office/drawing/2014/main" id="{9ACE968B-343C-F2EC-6056-037742F8AD6C}"/>
+                </a:ext>
+              </a:extLst>
+            </p:cNvPr>
+            <p:cNvSpPr/>
+            <p:nvPr/>
+          </p:nvSpPr>
+          <p:spPr>
+            <a:xfrm>
+              <a:off x="7026609" y="5035571"/>
+              <a:ext cx="45720" cy="45720"/>
+            </a:xfrm>
+            <a:prstGeom prst="ellipse">
+              <a:avLst/>
+            </a:prstGeom>
+            <a:solidFill>
+              <a:schemeClr val="tx1"/>
+            </a:solidFill>
+            <a:ln w="3175"/>
+          </p:spPr>
+          <p:style>
+            <a:lnRef idx="2">
+              <a:schemeClr val="dk1"/>
+            </a:lnRef>
+            <a:fillRef idx="1">
+              <a:schemeClr val="lt1"/>
+            </a:fillRef>
+            <a:effectRef idx="0">
+              <a:schemeClr val="dk1"/>
+            </a:effectRef>
+            <a:fontRef idx="minor">
+              <a:schemeClr val="dk1"/>
+            </a:fontRef>
+          </p:style>
+          <p:txBody>
+            <a:bodyPr rtlCol="0" anchor="ctr"/>
+            <a:lstStyle/>
+            <a:p>
+              <a:pPr algn="ctr"/>
+              <a:endParaRPr lang="en-US"/>
+            </a:p>
+          </p:txBody>
+        </p:sp>
+        <p:sp>
+          <p:nvSpPr>
+            <p:cNvPr id="367" name="Rectangle: Rounded Corners 366">
+              <a:extLst>
+                <a:ext uri="{FF2B5EF4-FFF2-40B4-BE49-F238E27FC236}">
+                  <a16:creationId xmlns:a16="http://schemas.microsoft.com/office/drawing/2014/main" id="{F7475214-9BED-C97F-EDE6-2DBE904021E1}"/>
+                </a:ext>
+              </a:extLst>
+            </p:cNvPr>
+            <p:cNvSpPr/>
+            <p:nvPr/>
+          </p:nvSpPr>
+          <p:spPr>
+            <a:xfrm>
+              <a:off x="7038745" y="4800533"/>
+              <a:ext cx="20398" cy="184400"/>
+            </a:xfrm>
+            <a:prstGeom prst="roundRect">
+              <a:avLst/>
+            </a:prstGeom>
+          </p:spPr>
+          <p:style>
+            <a:lnRef idx="2">
+              <a:schemeClr val="dk1">
+                <a:shade val="50000"/>
+              </a:schemeClr>
+            </a:lnRef>
+            <a:fillRef idx="1">
+              <a:schemeClr val="dk1"/>
+            </a:fillRef>
+            <a:effectRef idx="0">
+              <a:schemeClr val="dk1"/>
+            </a:effectRef>
+            <a:fontRef idx="minor">
+              <a:schemeClr val="lt1"/>
+            </a:fontRef>
+          </p:style>
+          <p:txBody>
+            <a:bodyPr rtlCol="0" anchor="ctr"/>
+            <a:lstStyle/>
+            <a:p>
+              <a:pPr algn="ctr"/>
+              <a:endParaRPr lang="en-US"/>
+            </a:p>
+          </p:txBody>
+        </p:sp>
+        <p:sp>
+          <p:nvSpPr>
+            <p:cNvPr id="368" name="Rectangle: Rounded Corners 367">
+              <a:extLst>
+                <a:ext uri="{FF2B5EF4-FFF2-40B4-BE49-F238E27FC236}">
+                  <a16:creationId xmlns:a16="http://schemas.microsoft.com/office/drawing/2014/main" id="{55F32FB3-2597-26CE-2278-7EA2AE28C745}"/>
+                </a:ext>
+              </a:extLst>
+            </p:cNvPr>
+            <p:cNvSpPr/>
+            <p:nvPr/>
+          </p:nvSpPr>
+          <p:spPr>
+            <a:xfrm>
+              <a:off x="7038745" y="5131063"/>
+              <a:ext cx="20398" cy="184400"/>
+            </a:xfrm>
+            <a:prstGeom prst="roundRect">
+              <a:avLst/>
+            </a:prstGeom>
+          </p:spPr>
+          <p:style>
+            <a:lnRef idx="2">
+              <a:schemeClr val="dk1">
+                <a:shade val="50000"/>
+              </a:schemeClr>
+            </a:lnRef>
+            <a:fillRef idx="1">
+              <a:schemeClr val="dk1"/>
+            </a:fillRef>
+            <a:effectRef idx="0">
+              <a:schemeClr val="dk1"/>
+            </a:effectRef>
+            <a:fontRef idx="minor">
+              <a:schemeClr val="lt1"/>
+            </a:fontRef>
+          </p:style>
+          <p:txBody>
+            <a:bodyPr rtlCol="0" anchor="ctr"/>
+            <a:lstStyle/>
+            <a:p>
+              <a:pPr algn="ctr"/>
+              <a:endParaRPr lang="en-US"/>
+            </a:p>
+          </p:txBody>
+        </p:sp>
+        <p:grpSp>
+          <p:nvGrpSpPr>
+            <p:cNvPr id="369" name="Group 368">
+              <a:extLst>
+                <a:ext uri="{FF2B5EF4-FFF2-40B4-BE49-F238E27FC236}">
+                  <a16:creationId xmlns:a16="http://schemas.microsoft.com/office/drawing/2014/main" id="{602761F3-63EE-3F11-D7BC-1B997EDC2CDF}"/>
+                </a:ext>
+              </a:extLst>
+            </p:cNvPr>
+            <p:cNvGrpSpPr/>
+            <p:nvPr/>
+          </p:nvGrpSpPr>
+          <p:grpSpPr>
+            <a:xfrm rot="16200000">
+              <a:off x="7038745" y="4798793"/>
+              <a:ext cx="20398" cy="514930"/>
+              <a:chOff x="5815666" y="3167062"/>
+              <a:chExt cx="55844" cy="1409701"/>
+            </a:xfrm>
+          </p:grpSpPr>
+          <p:sp>
+            <p:nvSpPr>
+              <p:cNvPr id="370" name="Rectangle: Rounded Corners 369">
+                <a:extLst>
+                  <a:ext uri="{FF2B5EF4-FFF2-40B4-BE49-F238E27FC236}">
+                    <a16:creationId xmlns:a16="http://schemas.microsoft.com/office/drawing/2014/main" id="{4A801049-1FE7-4BF3-4737-0145267EB8D0}"/>
+                  </a:ext>
+                </a:extLst>
+              </p:cNvPr>
+              <p:cNvSpPr/>
+              <p:nvPr/>
+            </p:nvSpPr>
+            <p:spPr>
+              <a:xfrm>
+                <a:off x="5815666" y="3167062"/>
+                <a:ext cx="55844" cy="504825"/>
+              </a:xfrm>
+              <a:prstGeom prst="roundRect">
+                <a:avLst/>
+              </a:prstGeom>
+            </p:spPr>
+            <p:style>
+              <a:lnRef idx="2">
+                <a:schemeClr val="dk1">
+                  <a:shade val="50000"/>
+                </a:schemeClr>
+              </a:lnRef>
+              <a:fillRef idx="1">
+                <a:schemeClr val="dk1"/>
+              </a:fillRef>
+              <a:effectRef idx="0">
+                <a:schemeClr val="dk1"/>
+              </a:effectRef>
+              <a:fontRef idx="minor">
+                <a:schemeClr val="lt1"/>
+              </a:fontRef>
+            </p:style>
+            <p:txBody>
+              <a:bodyPr rtlCol="0" anchor="ctr"/>
+              <a:lstStyle/>
+              <a:p>
+                <a:pPr algn="ctr"/>
+                <a:endParaRPr lang="en-US"/>
+              </a:p>
+            </p:txBody>
+          </p:sp>
+          <p:sp>
+            <p:nvSpPr>
+              <p:cNvPr id="371" name="Rectangle: Rounded Corners 370">
+                <a:extLst>
+                  <a:ext uri="{FF2B5EF4-FFF2-40B4-BE49-F238E27FC236}">
+                    <a16:creationId xmlns:a16="http://schemas.microsoft.com/office/drawing/2014/main" id="{D2DC7F5D-B1A7-FFEA-ED36-56BFCE066180}"/>
+                  </a:ext>
+                </a:extLst>
+              </p:cNvPr>
+              <p:cNvSpPr/>
+              <p:nvPr/>
+            </p:nvSpPr>
+            <p:spPr>
+              <a:xfrm>
+                <a:off x="5815666" y="4071938"/>
+                <a:ext cx="55844" cy="504825"/>
+              </a:xfrm>
+              <a:prstGeom prst="roundRect">
+                <a:avLst/>
+              </a:prstGeom>
+            </p:spPr>
+            <p:style>
+              <a:lnRef idx="2">
+                <a:schemeClr val="dk1">
+                  <a:shade val="50000"/>
+                </a:schemeClr>
+              </a:lnRef>
+              <a:fillRef idx="1">
+                <a:schemeClr val="dk1"/>
+              </a:fillRef>
+              <a:effectRef idx="0">
+                <a:schemeClr val="dk1"/>
+              </a:effectRef>
+              <a:fontRef idx="minor">
+                <a:schemeClr val="lt1"/>
+              </a:fontRef>
+            </p:style>
+            <p:txBody>
+              <a:bodyPr rtlCol="0" anchor="ctr"/>
+              <a:lstStyle/>
+              <a:p>
+                <a:pPr algn="ctr"/>
+                <a:endParaRPr lang="en-US"/>
+              </a:p>
+            </p:txBody>
+          </p:sp>
+        </p:grpSp>
+      </p:grpSp>
+      <p:grpSp>
+        <p:nvGrpSpPr>
+          <p:cNvPr id="352" name="Group 351">
+            <a:extLst>
+              <a:ext uri="{FF2B5EF4-FFF2-40B4-BE49-F238E27FC236}">
+                <a16:creationId xmlns:a16="http://schemas.microsoft.com/office/drawing/2014/main" id="{7975261B-F0A3-A2C2-C8FD-5C0E9453C925}"/>
+              </a:ext>
+            </a:extLst>
+          </p:cNvPr>
+          <p:cNvGrpSpPr/>
+          <p:nvPr/>
+        </p:nvGrpSpPr>
+        <p:grpSpPr>
+          <a:xfrm>
+            <a:off x="8833936" y="4658676"/>
+            <a:ext cx="390985" cy="390985"/>
+            <a:chOff x="6791479" y="4800533"/>
+            <a:chExt cx="514930" cy="514930"/>
+          </a:xfrm>
+        </p:grpSpPr>
+        <p:sp>
+          <p:nvSpPr>
+            <p:cNvPr id="353" name="Oval 352">
+              <a:extLst>
+                <a:ext uri="{FF2B5EF4-FFF2-40B4-BE49-F238E27FC236}">
+                  <a16:creationId xmlns:a16="http://schemas.microsoft.com/office/drawing/2014/main" id="{9F96B78D-50C4-CF68-90D2-1E54B57DCDE0}"/>
+                </a:ext>
+              </a:extLst>
+            </p:cNvPr>
+            <p:cNvSpPr/>
+            <p:nvPr/>
+          </p:nvSpPr>
+          <p:spPr>
+            <a:xfrm>
+              <a:off x="6885419" y="4892733"/>
+              <a:ext cx="327050" cy="327050"/>
+            </a:xfrm>
+            <a:prstGeom prst="ellipse">
+              <a:avLst/>
+            </a:prstGeom>
+            <a:noFill/>
+            <a:ln w="28575"/>
+          </p:spPr>
+          <p:style>
+            <a:lnRef idx="2">
+              <a:schemeClr val="dk1"/>
+            </a:lnRef>
+            <a:fillRef idx="1">
+              <a:schemeClr val="lt1"/>
+            </a:fillRef>
+            <a:effectRef idx="0">
+              <a:schemeClr val="dk1"/>
+            </a:effectRef>
+            <a:fontRef idx="minor">
+              <a:schemeClr val="dk1"/>
+            </a:fontRef>
+          </p:style>
+          <p:txBody>
+            <a:bodyPr rtlCol="0" anchor="ctr"/>
+            <a:lstStyle/>
+            <a:p>
+              <a:pPr algn="ctr"/>
+              <a:endParaRPr lang="en-US" dirty="0"/>
+            </a:p>
+          </p:txBody>
+        </p:sp>
+        <p:sp>
+          <p:nvSpPr>
+            <p:cNvPr id="354" name="Oval 353">
+              <a:extLst>
+                <a:ext uri="{FF2B5EF4-FFF2-40B4-BE49-F238E27FC236}">
+                  <a16:creationId xmlns:a16="http://schemas.microsoft.com/office/drawing/2014/main" id="{38C76F8A-2AAA-EA1F-9CE8-48FA18DE6D68}"/>
+                </a:ext>
+              </a:extLst>
+            </p:cNvPr>
+            <p:cNvSpPr/>
+            <p:nvPr/>
+          </p:nvSpPr>
+          <p:spPr>
+            <a:xfrm>
+              <a:off x="7026609" y="5035571"/>
+              <a:ext cx="45720" cy="45720"/>
+            </a:xfrm>
+            <a:prstGeom prst="ellipse">
+              <a:avLst/>
+            </a:prstGeom>
+            <a:solidFill>
+              <a:schemeClr val="tx1"/>
+            </a:solidFill>
+            <a:ln w="3175"/>
+          </p:spPr>
+          <p:style>
+            <a:lnRef idx="2">
+              <a:schemeClr val="dk1"/>
+            </a:lnRef>
+            <a:fillRef idx="1">
+              <a:schemeClr val="lt1"/>
+            </a:fillRef>
+            <a:effectRef idx="0">
+              <a:schemeClr val="dk1"/>
+            </a:effectRef>
+            <a:fontRef idx="minor">
+              <a:schemeClr val="dk1"/>
+            </a:fontRef>
+          </p:style>
+          <p:txBody>
+            <a:bodyPr rtlCol="0" anchor="ctr"/>
+            <a:lstStyle/>
+            <a:p>
+              <a:pPr algn="ctr"/>
+              <a:endParaRPr lang="en-US"/>
+            </a:p>
+          </p:txBody>
+        </p:sp>
+        <p:sp>
+          <p:nvSpPr>
+            <p:cNvPr id="355" name="Rectangle: Rounded Corners 354">
+              <a:extLst>
+                <a:ext uri="{FF2B5EF4-FFF2-40B4-BE49-F238E27FC236}">
+                  <a16:creationId xmlns:a16="http://schemas.microsoft.com/office/drawing/2014/main" id="{C53B2A92-99B0-21DE-121E-F35844E82C88}"/>
+                </a:ext>
+              </a:extLst>
+            </p:cNvPr>
+            <p:cNvSpPr/>
+            <p:nvPr/>
+          </p:nvSpPr>
+          <p:spPr>
+            <a:xfrm>
+              <a:off x="7038745" y="4800533"/>
+              <a:ext cx="20398" cy="184400"/>
+            </a:xfrm>
+            <a:prstGeom prst="roundRect">
+              <a:avLst/>
+            </a:prstGeom>
+          </p:spPr>
+          <p:style>
+            <a:lnRef idx="2">
+              <a:schemeClr val="dk1">
+                <a:shade val="50000"/>
+              </a:schemeClr>
+            </a:lnRef>
+            <a:fillRef idx="1">
+              <a:schemeClr val="dk1"/>
+            </a:fillRef>
+            <a:effectRef idx="0">
+              <a:schemeClr val="dk1"/>
+            </a:effectRef>
+            <a:fontRef idx="minor">
+              <a:schemeClr val="lt1"/>
+            </a:fontRef>
+          </p:style>
+          <p:txBody>
+            <a:bodyPr rtlCol="0" anchor="ctr"/>
+            <a:lstStyle/>
+            <a:p>
+              <a:pPr algn="ctr"/>
+              <a:endParaRPr lang="en-US"/>
+            </a:p>
+          </p:txBody>
+        </p:sp>
+        <p:sp>
+          <p:nvSpPr>
+            <p:cNvPr id="356" name="Rectangle: Rounded Corners 355">
+              <a:extLst>
+                <a:ext uri="{FF2B5EF4-FFF2-40B4-BE49-F238E27FC236}">
+                  <a16:creationId xmlns:a16="http://schemas.microsoft.com/office/drawing/2014/main" id="{65B4F66E-E337-04A4-DAED-68C243536C04}"/>
+                </a:ext>
+              </a:extLst>
+            </p:cNvPr>
+            <p:cNvSpPr/>
+            <p:nvPr/>
+          </p:nvSpPr>
+          <p:spPr>
+            <a:xfrm>
+              <a:off x="7038745" y="5131063"/>
+              <a:ext cx="20398" cy="184400"/>
+            </a:xfrm>
+            <a:prstGeom prst="roundRect">
+              <a:avLst/>
+            </a:prstGeom>
+          </p:spPr>
+          <p:style>
+            <a:lnRef idx="2">
+              <a:schemeClr val="dk1">
+                <a:shade val="50000"/>
+              </a:schemeClr>
+            </a:lnRef>
+            <a:fillRef idx="1">
+              <a:schemeClr val="dk1"/>
+            </a:fillRef>
+            <a:effectRef idx="0">
+              <a:schemeClr val="dk1"/>
+            </a:effectRef>
+            <a:fontRef idx="minor">
+              <a:schemeClr val="lt1"/>
+            </a:fontRef>
+          </p:style>
+          <p:txBody>
+            <a:bodyPr rtlCol="0" anchor="ctr"/>
+            <a:lstStyle/>
+            <a:p>
+              <a:pPr algn="ctr"/>
+              <a:endParaRPr lang="en-US"/>
+            </a:p>
+          </p:txBody>
+        </p:sp>
+        <p:grpSp>
+          <p:nvGrpSpPr>
+            <p:cNvPr id="357" name="Group 356">
+              <a:extLst>
+                <a:ext uri="{FF2B5EF4-FFF2-40B4-BE49-F238E27FC236}">
+                  <a16:creationId xmlns:a16="http://schemas.microsoft.com/office/drawing/2014/main" id="{195A7780-E781-2BA1-860F-FCA60B830359}"/>
+                </a:ext>
+              </a:extLst>
+            </p:cNvPr>
+            <p:cNvGrpSpPr/>
+            <p:nvPr/>
+          </p:nvGrpSpPr>
+          <p:grpSpPr>
+            <a:xfrm rot="16200000">
+              <a:off x="7038745" y="4798793"/>
+              <a:ext cx="20398" cy="514930"/>
+              <a:chOff x="5815666" y="3167062"/>
+              <a:chExt cx="55844" cy="1409701"/>
+            </a:xfrm>
+          </p:grpSpPr>
+          <p:sp>
+            <p:nvSpPr>
+              <p:cNvPr id="358" name="Rectangle: Rounded Corners 357">
+                <a:extLst>
+                  <a:ext uri="{FF2B5EF4-FFF2-40B4-BE49-F238E27FC236}">
+                    <a16:creationId xmlns:a16="http://schemas.microsoft.com/office/drawing/2014/main" id="{665C9D39-F57C-7D67-285D-44E28976F8C4}"/>
+                  </a:ext>
+                </a:extLst>
+              </p:cNvPr>
+              <p:cNvSpPr/>
+              <p:nvPr/>
+            </p:nvSpPr>
+            <p:spPr>
+              <a:xfrm>
+                <a:off x="5815666" y="3167062"/>
+                <a:ext cx="55844" cy="504825"/>
+              </a:xfrm>
+              <a:prstGeom prst="roundRect">
+                <a:avLst/>
+              </a:prstGeom>
+            </p:spPr>
+            <p:style>
+              <a:lnRef idx="2">
+                <a:schemeClr val="dk1">
+                  <a:shade val="50000"/>
+                </a:schemeClr>
+              </a:lnRef>
+              <a:fillRef idx="1">
+                <a:schemeClr val="dk1"/>
+              </a:fillRef>
+              <a:effectRef idx="0">
+                <a:schemeClr val="dk1"/>
+              </a:effectRef>
+              <a:fontRef idx="minor">
+                <a:schemeClr val="lt1"/>
+              </a:fontRef>
+            </p:style>
+            <p:txBody>
+              <a:bodyPr rtlCol="0" anchor="ctr"/>
+              <a:lstStyle/>
+              <a:p>
+                <a:pPr algn="ctr"/>
+                <a:endParaRPr lang="en-US"/>
+              </a:p>
+            </p:txBody>
+          </p:sp>
+          <p:sp>
+            <p:nvSpPr>
+              <p:cNvPr id="359" name="Rectangle: Rounded Corners 358">
+                <a:extLst>
+                  <a:ext uri="{FF2B5EF4-FFF2-40B4-BE49-F238E27FC236}">
+                    <a16:creationId xmlns:a16="http://schemas.microsoft.com/office/drawing/2014/main" id="{58A05DA4-8278-E679-F59F-D271FA8CB18E}"/>
+                  </a:ext>
+                </a:extLst>
+              </p:cNvPr>
+              <p:cNvSpPr/>
+              <p:nvPr/>
+            </p:nvSpPr>
+            <p:spPr>
+              <a:xfrm>
+                <a:off x="5815666" y="4071938"/>
+                <a:ext cx="55844" cy="504825"/>
+              </a:xfrm>
+              <a:prstGeom prst="roundRect">
+                <a:avLst/>
+              </a:prstGeom>
+            </p:spPr>
+            <p:style>
+              <a:lnRef idx="2">
+                <a:schemeClr val="dk1">
+                  <a:shade val="50000"/>
+                </a:schemeClr>
+              </a:lnRef>
+              <a:fillRef idx="1">
+                <a:schemeClr val="dk1"/>
+              </a:fillRef>
+              <a:effectRef idx="0">
+                <a:schemeClr val="dk1"/>
+              </a:effectRef>
+              <a:fontRef idx="minor">
+                <a:schemeClr val="lt1"/>
+              </a:fontRef>
+            </p:style>
+            <p:txBody>
+              <a:bodyPr rtlCol="0" anchor="ctr"/>
+              <a:lstStyle/>
+              <a:p>
+                <a:pPr algn="ctr"/>
+                <a:endParaRPr lang="en-US"/>
+              </a:p>
+            </p:txBody>
+          </p:sp>
+        </p:grpSp>
+      </p:grpSp>
     </p:spTree>
     <p:extLst>
       <p:ext uri="{BB962C8B-B14F-4D97-AF65-F5344CB8AC3E}">
@@ -15648,6 +17241,51 @@
           <a:chExt cx="0" cy="0"/>
         </a:xfrm>
       </p:grpSpPr>
+      <p:pic>
+        <p:nvPicPr>
+          <p:cNvPr id="1026" name="Picture 2" descr="Sniper rifle vector Images, Stock Photos &amp; Vectors | Shutterstock">
+            <a:extLst>
+              <a:ext uri="{FF2B5EF4-FFF2-40B4-BE49-F238E27FC236}">
+                <a16:creationId xmlns:a16="http://schemas.microsoft.com/office/drawing/2014/main" id="{32B415FD-D9B9-075D-6565-2F67902D516F}"/>
+              </a:ext>
+            </a:extLst>
+          </p:cNvPr>
+          <p:cNvPicPr>
+            <a:picLocks noChangeAspect="1" noChangeArrowheads="1"/>
+          </p:cNvPicPr>
+          <p:nvPr/>
+        </p:nvPicPr>
+        <p:blipFill rotWithShape="1">
+          <a:blip r:embed="rId2">
+            <a:extLst>
+              <a:ext uri="{28A0092B-C50C-407E-A947-70E740481C1C}">
+                <a14:useLocalDpi xmlns:a14="http://schemas.microsoft.com/office/drawing/2010/main" val="0"/>
+              </a:ext>
+            </a:extLst>
+          </a:blip>
+          <a:srcRect l="3957" t="13333" r="2963" b="12143"/>
+          <a:stretch/>
+        </p:blipFill>
+        <p:spPr bwMode="auto">
+          <a:xfrm rot="19924526">
+            <a:off x="664183" y="699761"/>
+            <a:ext cx="1046633" cy="342583"/>
+          </a:xfrm>
+          <a:prstGeom prst="rect">
+            <a:avLst/>
+          </a:prstGeom>
+          <a:noFill/>
+          <a:extLst>
+            <a:ext uri="{909E8E84-426E-40DD-AFC4-6F175D3DCCD1}">
+              <a14:hiddenFill xmlns:a14="http://schemas.microsoft.com/office/drawing/2010/main">
+                <a:solidFill>
+                  <a:srgbClr val="FFFFFF"/>
+                </a:solidFill>
+              </a14:hiddenFill>
+            </a:ext>
+          </a:extLst>
+        </p:spPr>
+      </p:pic>
       <p:grpSp>
         <p:nvGrpSpPr>
           <p:cNvPr id="14" name="Group 13">
@@ -15774,706 +17412,6 @@
             </a:p>
           </p:txBody>
         </p:sp>
-      </p:grpSp>
-      <p:grpSp>
-        <p:nvGrpSpPr>
-          <p:cNvPr id="90" name="Group 89">
-            <a:extLst>
-              <a:ext uri="{FF2B5EF4-FFF2-40B4-BE49-F238E27FC236}">
-                <a16:creationId xmlns:a16="http://schemas.microsoft.com/office/drawing/2014/main" id="{90CFE9EA-7180-B24D-626B-8F0220F9CB85}"/>
-              </a:ext>
-            </a:extLst>
-          </p:cNvPr>
-          <p:cNvGrpSpPr/>
-          <p:nvPr/>
-        </p:nvGrpSpPr>
-        <p:grpSpPr>
-          <a:xfrm>
-            <a:off x="684024" y="534589"/>
-            <a:ext cx="870414" cy="803280"/>
-            <a:chOff x="2841994" y="930562"/>
-            <a:chExt cx="3529486" cy="3257264"/>
-          </a:xfrm>
-        </p:grpSpPr>
-        <p:sp>
-          <p:nvSpPr>
-            <p:cNvPr id="71" name="Oval 70">
-              <a:extLst>
-                <a:ext uri="{FF2B5EF4-FFF2-40B4-BE49-F238E27FC236}">
-                  <a16:creationId xmlns:a16="http://schemas.microsoft.com/office/drawing/2014/main" id="{D19F045B-D5CF-5692-F8ED-B3998977D532}"/>
-                </a:ext>
-              </a:extLst>
-            </p:cNvPr>
-            <p:cNvSpPr/>
-            <p:nvPr/>
-          </p:nvSpPr>
-          <p:spPr>
-            <a:xfrm>
-              <a:off x="4305300" y="930562"/>
-              <a:ext cx="590550" cy="3181350"/>
-            </a:xfrm>
-            <a:prstGeom prst="ellipse">
-              <a:avLst/>
-            </a:prstGeom>
-            <a:ln/>
-          </p:spPr>
-          <p:style>
-            <a:lnRef idx="2">
-              <a:schemeClr val="dk1">
-                <a:shade val="50000"/>
-              </a:schemeClr>
-            </a:lnRef>
-            <a:fillRef idx="1">
-              <a:schemeClr val="dk1"/>
-            </a:fillRef>
-            <a:effectRef idx="0">
-              <a:schemeClr val="dk1"/>
-            </a:effectRef>
-            <a:fontRef idx="minor">
-              <a:schemeClr val="lt1"/>
-            </a:fontRef>
-          </p:style>
-          <p:txBody>
-            <a:bodyPr rtlCol="0" anchor="ctr"/>
-            <a:lstStyle/>
-            <a:p>
-              <a:pPr algn="ctr"/>
-              <a:endParaRPr lang="en-US"/>
-            </a:p>
-          </p:txBody>
-        </p:sp>
-        <p:sp>
-          <p:nvSpPr>
-            <p:cNvPr id="72" name="Isosceles Triangle 71">
-              <a:extLst>
-                <a:ext uri="{FF2B5EF4-FFF2-40B4-BE49-F238E27FC236}">
-                  <a16:creationId xmlns:a16="http://schemas.microsoft.com/office/drawing/2014/main" id="{DC47E2F9-DD91-CC65-D2E0-0C66D2C42895}"/>
-                </a:ext>
-              </a:extLst>
-            </p:cNvPr>
-            <p:cNvSpPr/>
-            <p:nvPr/>
-          </p:nvSpPr>
-          <p:spPr>
-            <a:xfrm rot="15097803">
-              <a:off x="3816522" y="3530601"/>
-              <a:ext cx="590550" cy="723900"/>
-            </a:xfrm>
-            <a:prstGeom prst="triangle">
-              <a:avLst/>
-            </a:prstGeom>
-          </p:spPr>
-          <p:style>
-            <a:lnRef idx="2">
-              <a:schemeClr val="dk1">
-                <a:shade val="50000"/>
-              </a:schemeClr>
-            </a:lnRef>
-            <a:fillRef idx="1">
-              <a:schemeClr val="dk1"/>
-            </a:fillRef>
-            <a:effectRef idx="0">
-              <a:schemeClr val="dk1"/>
-            </a:effectRef>
-            <a:fontRef idx="minor">
-              <a:schemeClr val="lt1"/>
-            </a:fontRef>
-          </p:style>
-          <p:txBody>
-            <a:bodyPr rtlCol="0" anchor="ctr"/>
-            <a:lstStyle/>
-            <a:p>
-              <a:pPr algn="ctr"/>
-              <a:endParaRPr lang="en-US"/>
-            </a:p>
-          </p:txBody>
-        </p:sp>
-        <p:sp>
-          <p:nvSpPr>
-            <p:cNvPr id="73" name="Isosceles Triangle 72">
-              <a:extLst>
-                <a:ext uri="{FF2B5EF4-FFF2-40B4-BE49-F238E27FC236}">
-                  <a16:creationId xmlns:a16="http://schemas.microsoft.com/office/drawing/2014/main" id="{1D41C8E3-B0EC-3063-76E9-F9FC03818F39}"/>
-                </a:ext>
-              </a:extLst>
-            </p:cNvPr>
-            <p:cNvSpPr/>
-            <p:nvPr/>
-          </p:nvSpPr>
-          <p:spPr>
-            <a:xfrm rot="6456753">
-              <a:off x="4789963" y="3527597"/>
-              <a:ext cx="590550" cy="723900"/>
-            </a:xfrm>
-            <a:prstGeom prst="triangle">
-              <a:avLst/>
-            </a:prstGeom>
-          </p:spPr>
-          <p:style>
-            <a:lnRef idx="2">
-              <a:schemeClr val="dk1">
-                <a:shade val="50000"/>
-              </a:schemeClr>
-            </a:lnRef>
-            <a:fillRef idx="1">
-              <a:schemeClr val="dk1"/>
-            </a:fillRef>
-            <a:effectRef idx="0">
-              <a:schemeClr val="dk1"/>
-            </a:effectRef>
-            <a:fontRef idx="minor">
-              <a:schemeClr val="lt1"/>
-            </a:fontRef>
-          </p:style>
-          <p:txBody>
-            <a:bodyPr rtlCol="0" anchor="ctr"/>
-            <a:lstStyle/>
-            <a:p>
-              <a:pPr algn="ctr"/>
-              <a:endParaRPr lang="en-US"/>
-            </a:p>
-          </p:txBody>
-        </p:sp>
-        <p:grpSp>
-          <p:nvGrpSpPr>
-            <p:cNvPr id="83" name="Group 82">
-              <a:extLst>
-                <a:ext uri="{FF2B5EF4-FFF2-40B4-BE49-F238E27FC236}">
-                  <a16:creationId xmlns:a16="http://schemas.microsoft.com/office/drawing/2014/main" id="{B46AD532-33DF-3A32-6AF3-10E363352270}"/>
-                </a:ext>
-              </a:extLst>
-            </p:cNvPr>
-            <p:cNvGrpSpPr/>
-            <p:nvPr/>
-          </p:nvGrpSpPr>
-          <p:grpSpPr>
-            <a:xfrm>
-              <a:off x="2841994" y="1514299"/>
-              <a:ext cx="1562063" cy="1372483"/>
-              <a:chOff x="2841994" y="1514299"/>
-              <a:chExt cx="1562063" cy="1372483"/>
-            </a:xfrm>
-          </p:grpSpPr>
-          <p:sp>
-            <p:nvSpPr>
-              <p:cNvPr id="81" name="Rectangle 80">
-                <a:extLst>
-                  <a:ext uri="{FF2B5EF4-FFF2-40B4-BE49-F238E27FC236}">
-                    <a16:creationId xmlns:a16="http://schemas.microsoft.com/office/drawing/2014/main" id="{A576555C-ECED-A69E-2AA5-9C9C040766A6}"/>
-                  </a:ext>
-                </a:extLst>
-              </p:cNvPr>
-              <p:cNvSpPr/>
-              <p:nvPr/>
-            </p:nvSpPr>
-            <p:spPr>
-              <a:xfrm>
-                <a:off x="3453258" y="1667895"/>
-                <a:ext cx="241300" cy="1016415"/>
-              </a:xfrm>
-              <a:prstGeom prst="rect">
-                <a:avLst/>
-              </a:prstGeom>
-            </p:spPr>
-            <p:style>
-              <a:lnRef idx="2">
-                <a:schemeClr val="dk1"/>
-              </a:lnRef>
-              <a:fillRef idx="1">
-                <a:schemeClr val="lt1"/>
-              </a:fillRef>
-              <a:effectRef idx="0">
-                <a:schemeClr val="dk1"/>
-              </a:effectRef>
-              <a:fontRef idx="minor">
-                <a:schemeClr val="dk1"/>
-              </a:fontRef>
-            </p:style>
-            <p:txBody>
-              <a:bodyPr rtlCol="0" anchor="ctr"/>
-              <a:lstStyle/>
-              <a:p>
-                <a:pPr algn="ctr"/>
-                <a:endParaRPr lang="en-US"/>
-              </a:p>
-            </p:txBody>
-          </p:sp>
-          <p:sp>
-            <p:nvSpPr>
-              <p:cNvPr id="82" name="Rectangle 81">
-                <a:extLst>
-                  <a:ext uri="{FF2B5EF4-FFF2-40B4-BE49-F238E27FC236}">
-                    <a16:creationId xmlns:a16="http://schemas.microsoft.com/office/drawing/2014/main" id="{0F1A57D8-5827-B6EC-A49E-990EE25B294A}"/>
-                  </a:ext>
-                </a:extLst>
-              </p:cNvPr>
-              <p:cNvSpPr/>
-              <p:nvPr/>
-            </p:nvSpPr>
-            <p:spPr>
-              <a:xfrm>
-                <a:off x="3879279" y="1514299"/>
-                <a:ext cx="241300" cy="1016415"/>
-              </a:xfrm>
-              <a:prstGeom prst="rect">
-                <a:avLst/>
-              </a:prstGeom>
-            </p:spPr>
-            <p:style>
-              <a:lnRef idx="2">
-                <a:schemeClr val="dk1"/>
-              </a:lnRef>
-              <a:fillRef idx="1">
-                <a:schemeClr val="lt1"/>
-              </a:fillRef>
-              <a:effectRef idx="0">
-                <a:schemeClr val="dk1"/>
-              </a:effectRef>
-              <a:fontRef idx="minor">
-                <a:schemeClr val="dk1"/>
-              </a:fontRef>
-            </p:style>
-            <p:txBody>
-              <a:bodyPr rtlCol="0" anchor="ctr"/>
-              <a:lstStyle/>
-              <a:p>
-                <a:pPr algn="ctr"/>
-                <a:endParaRPr lang="en-US"/>
-              </a:p>
-            </p:txBody>
-          </p:sp>
-          <p:sp>
-            <p:nvSpPr>
-              <p:cNvPr id="74" name="Trapezoid 73">
-                <a:extLst>
-                  <a:ext uri="{FF2B5EF4-FFF2-40B4-BE49-F238E27FC236}">
-                    <a16:creationId xmlns:a16="http://schemas.microsoft.com/office/drawing/2014/main" id="{30420B43-5CDB-E385-B3CA-3E77CCA73958}"/>
-                  </a:ext>
-                </a:extLst>
-              </p:cNvPr>
-              <p:cNvSpPr/>
-              <p:nvPr/>
-            </p:nvSpPr>
-            <p:spPr>
-              <a:xfrm rot="15639411">
-                <a:off x="3588611" y="1898339"/>
-                <a:ext cx="806450" cy="824442"/>
-              </a:xfrm>
-              <a:prstGeom prst="trapezoid">
-                <a:avLst>
-                  <a:gd name="adj" fmla="val 15303"/>
-                </a:avLst>
-              </a:prstGeom>
-            </p:spPr>
-            <p:style>
-              <a:lnRef idx="2">
-                <a:schemeClr val="dk1">
-                  <a:shade val="50000"/>
-                </a:schemeClr>
-              </a:lnRef>
-              <a:fillRef idx="1">
-                <a:schemeClr val="dk1"/>
-              </a:fillRef>
-              <a:effectRef idx="0">
-                <a:schemeClr val="dk1"/>
-              </a:effectRef>
-              <a:fontRef idx="minor">
-                <a:schemeClr val="lt1"/>
-              </a:fontRef>
-            </p:style>
-            <p:txBody>
-              <a:bodyPr rtlCol="0" anchor="ctr"/>
-              <a:lstStyle/>
-              <a:p>
-                <a:pPr algn="ctr"/>
-                <a:endParaRPr lang="en-US"/>
-              </a:p>
-            </p:txBody>
-          </p:sp>
-          <p:sp>
-            <p:nvSpPr>
-              <p:cNvPr id="77" name="Isosceles Triangle 76">
-                <a:extLst>
-                  <a:ext uri="{FF2B5EF4-FFF2-40B4-BE49-F238E27FC236}">
-                    <a16:creationId xmlns:a16="http://schemas.microsoft.com/office/drawing/2014/main" id="{7601BBF1-31EB-4668-75E9-E8E7786A318A}"/>
-                  </a:ext>
-                </a:extLst>
-              </p:cNvPr>
-              <p:cNvSpPr/>
-              <p:nvPr/>
-            </p:nvSpPr>
-            <p:spPr>
-              <a:xfrm rot="14248003">
-                <a:off x="2851235" y="2409712"/>
-                <a:ext cx="388815" cy="407297"/>
-              </a:xfrm>
-              <a:prstGeom prst="triangle">
-                <a:avLst/>
-              </a:prstGeom>
-            </p:spPr>
-            <p:style>
-              <a:lnRef idx="2">
-                <a:schemeClr val="dk1">
-                  <a:shade val="50000"/>
-                </a:schemeClr>
-              </a:lnRef>
-              <a:fillRef idx="1">
-                <a:schemeClr val="dk1"/>
-              </a:fillRef>
-              <a:effectRef idx="0">
-                <a:schemeClr val="dk1"/>
-              </a:effectRef>
-              <a:fontRef idx="minor">
-                <a:schemeClr val="lt1"/>
-              </a:fontRef>
-            </p:style>
-            <p:txBody>
-              <a:bodyPr rtlCol="0" anchor="ctr"/>
-              <a:lstStyle/>
-              <a:p>
-                <a:pPr algn="ctr"/>
-                <a:endParaRPr lang="en-US"/>
-              </a:p>
-            </p:txBody>
-          </p:sp>
-          <p:sp>
-            <p:nvSpPr>
-              <p:cNvPr id="76" name="Oval 75">
-                <a:extLst>
-                  <a:ext uri="{FF2B5EF4-FFF2-40B4-BE49-F238E27FC236}">
-                    <a16:creationId xmlns:a16="http://schemas.microsoft.com/office/drawing/2014/main" id="{5D9EAB30-49D5-555A-31D5-8D3193FB1DE0}"/>
-                  </a:ext>
-                </a:extLst>
-              </p:cNvPr>
-              <p:cNvSpPr/>
-              <p:nvPr/>
-            </p:nvSpPr>
-            <p:spPr>
-              <a:xfrm>
-                <a:off x="3087822" y="1907372"/>
-                <a:ext cx="979410" cy="979410"/>
-              </a:xfrm>
-              <a:prstGeom prst="ellipse">
-                <a:avLst/>
-              </a:prstGeom>
-              <a:ln w="19050"/>
-            </p:spPr>
-            <p:style>
-              <a:lnRef idx="2">
-                <a:schemeClr val="dk1"/>
-              </a:lnRef>
-              <a:fillRef idx="1">
-                <a:schemeClr val="lt1"/>
-              </a:fillRef>
-              <a:effectRef idx="0">
-                <a:schemeClr val="dk1"/>
-              </a:effectRef>
-              <a:fontRef idx="minor">
-                <a:schemeClr val="dk1"/>
-              </a:fontRef>
-            </p:style>
-            <p:txBody>
-              <a:bodyPr rtlCol="0" anchor="ctr"/>
-              <a:lstStyle/>
-              <a:p>
-                <a:pPr algn="ctr"/>
-                <a:endParaRPr lang="en-US"/>
-              </a:p>
-            </p:txBody>
-          </p:sp>
-        </p:grpSp>
-        <p:sp>
-          <p:nvSpPr>
-            <p:cNvPr id="79" name="Trapezoid 78">
-              <a:extLst>
-                <a:ext uri="{FF2B5EF4-FFF2-40B4-BE49-F238E27FC236}">
-                  <a16:creationId xmlns:a16="http://schemas.microsoft.com/office/drawing/2014/main" id="{CC2BF88B-AB8E-C872-6384-A5DC1F6008FA}"/>
-                </a:ext>
-              </a:extLst>
-            </p:cNvPr>
-            <p:cNvSpPr/>
-            <p:nvPr/>
-          </p:nvSpPr>
-          <p:spPr>
-            <a:xfrm>
-              <a:off x="4391733" y="1120756"/>
-              <a:ext cx="417684" cy="428229"/>
-            </a:xfrm>
-            <a:prstGeom prst="trapezoid">
-              <a:avLst/>
-            </a:prstGeom>
-          </p:spPr>
-          <p:style>
-            <a:lnRef idx="2">
-              <a:schemeClr val="dk1"/>
-            </a:lnRef>
-            <a:fillRef idx="1">
-              <a:schemeClr val="lt1"/>
-            </a:fillRef>
-            <a:effectRef idx="0">
-              <a:schemeClr val="dk1"/>
-            </a:effectRef>
-            <a:fontRef idx="minor">
-              <a:schemeClr val="dk1"/>
-            </a:fontRef>
-          </p:style>
-          <p:txBody>
-            <a:bodyPr rtlCol="0" anchor="ctr"/>
-            <a:lstStyle/>
-            <a:p>
-              <a:pPr algn="ctr"/>
-              <a:endParaRPr lang="en-US"/>
-            </a:p>
-          </p:txBody>
-        </p:sp>
-        <p:grpSp>
-          <p:nvGrpSpPr>
-            <p:cNvPr id="84" name="Group 83">
-              <a:extLst>
-                <a:ext uri="{FF2B5EF4-FFF2-40B4-BE49-F238E27FC236}">
-                  <a16:creationId xmlns:a16="http://schemas.microsoft.com/office/drawing/2014/main" id="{54471559-76A8-0495-2483-E454885D680C}"/>
-                </a:ext>
-              </a:extLst>
-            </p:cNvPr>
-            <p:cNvGrpSpPr/>
-            <p:nvPr/>
-          </p:nvGrpSpPr>
-          <p:grpSpPr>
-            <a:xfrm flipH="1">
-              <a:off x="4809417" y="1514012"/>
-              <a:ext cx="1562063" cy="1372483"/>
-              <a:chOff x="2841994" y="1514299"/>
-              <a:chExt cx="1562063" cy="1372483"/>
-            </a:xfrm>
-          </p:grpSpPr>
-          <p:sp>
-            <p:nvSpPr>
-              <p:cNvPr id="85" name="Rectangle 84">
-                <a:extLst>
-                  <a:ext uri="{FF2B5EF4-FFF2-40B4-BE49-F238E27FC236}">
-                    <a16:creationId xmlns:a16="http://schemas.microsoft.com/office/drawing/2014/main" id="{765EE275-187C-9030-20D4-CAFEB7BF5373}"/>
-                  </a:ext>
-                </a:extLst>
-              </p:cNvPr>
-              <p:cNvSpPr/>
-              <p:nvPr/>
-            </p:nvSpPr>
-            <p:spPr>
-              <a:xfrm>
-                <a:off x="3453258" y="1667895"/>
-                <a:ext cx="241300" cy="1016415"/>
-              </a:xfrm>
-              <a:prstGeom prst="rect">
-                <a:avLst/>
-              </a:prstGeom>
-            </p:spPr>
-            <p:style>
-              <a:lnRef idx="2">
-                <a:schemeClr val="dk1"/>
-              </a:lnRef>
-              <a:fillRef idx="1">
-                <a:schemeClr val="lt1"/>
-              </a:fillRef>
-              <a:effectRef idx="0">
-                <a:schemeClr val="dk1"/>
-              </a:effectRef>
-              <a:fontRef idx="minor">
-                <a:schemeClr val="dk1"/>
-              </a:fontRef>
-            </p:style>
-            <p:txBody>
-              <a:bodyPr rtlCol="0" anchor="ctr"/>
-              <a:lstStyle/>
-              <a:p>
-                <a:pPr algn="ctr"/>
-                <a:endParaRPr lang="en-US"/>
-              </a:p>
-            </p:txBody>
-          </p:sp>
-          <p:sp>
-            <p:nvSpPr>
-              <p:cNvPr id="86" name="Rectangle 85">
-                <a:extLst>
-                  <a:ext uri="{FF2B5EF4-FFF2-40B4-BE49-F238E27FC236}">
-                    <a16:creationId xmlns:a16="http://schemas.microsoft.com/office/drawing/2014/main" id="{EA0449D4-6BE1-A022-D55A-CB15F248CF42}"/>
-                  </a:ext>
-                </a:extLst>
-              </p:cNvPr>
-              <p:cNvSpPr/>
-              <p:nvPr/>
-            </p:nvSpPr>
-            <p:spPr>
-              <a:xfrm>
-                <a:off x="3879279" y="1514299"/>
-                <a:ext cx="241300" cy="1016415"/>
-              </a:xfrm>
-              <a:prstGeom prst="rect">
-                <a:avLst/>
-              </a:prstGeom>
-            </p:spPr>
-            <p:style>
-              <a:lnRef idx="2">
-                <a:schemeClr val="dk1"/>
-              </a:lnRef>
-              <a:fillRef idx="1">
-                <a:schemeClr val="lt1"/>
-              </a:fillRef>
-              <a:effectRef idx="0">
-                <a:schemeClr val="dk1"/>
-              </a:effectRef>
-              <a:fontRef idx="minor">
-                <a:schemeClr val="dk1"/>
-              </a:fontRef>
-            </p:style>
-            <p:txBody>
-              <a:bodyPr rtlCol="0" anchor="ctr"/>
-              <a:lstStyle/>
-              <a:p>
-                <a:pPr algn="ctr"/>
-                <a:endParaRPr lang="en-US"/>
-              </a:p>
-            </p:txBody>
-          </p:sp>
-          <p:sp>
-            <p:nvSpPr>
-              <p:cNvPr id="87" name="Trapezoid 86">
-                <a:extLst>
-                  <a:ext uri="{FF2B5EF4-FFF2-40B4-BE49-F238E27FC236}">
-                    <a16:creationId xmlns:a16="http://schemas.microsoft.com/office/drawing/2014/main" id="{AD5C3D9B-3DC5-9188-F181-FF8ABE1F6E44}"/>
-                  </a:ext>
-                </a:extLst>
-              </p:cNvPr>
-              <p:cNvSpPr/>
-              <p:nvPr/>
-            </p:nvSpPr>
-            <p:spPr>
-              <a:xfrm rot="15639411">
-                <a:off x="3588611" y="1898339"/>
-                <a:ext cx="806450" cy="824442"/>
-              </a:xfrm>
-              <a:prstGeom prst="trapezoid">
-                <a:avLst>
-                  <a:gd name="adj" fmla="val 15303"/>
-                </a:avLst>
-              </a:prstGeom>
-            </p:spPr>
-            <p:style>
-              <a:lnRef idx="2">
-                <a:schemeClr val="dk1">
-                  <a:shade val="50000"/>
-                </a:schemeClr>
-              </a:lnRef>
-              <a:fillRef idx="1">
-                <a:schemeClr val="dk1"/>
-              </a:fillRef>
-              <a:effectRef idx="0">
-                <a:schemeClr val="dk1"/>
-              </a:effectRef>
-              <a:fontRef idx="minor">
-                <a:schemeClr val="lt1"/>
-              </a:fontRef>
-            </p:style>
-            <p:txBody>
-              <a:bodyPr rtlCol="0" anchor="ctr"/>
-              <a:lstStyle/>
-              <a:p>
-                <a:pPr algn="ctr"/>
-                <a:endParaRPr lang="en-US"/>
-              </a:p>
-            </p:txBody>
-          </p:sp>
-          <p:sp>
-            <p:nvSpPr>
-              <p:cNvPr id="88" name="Isosceles Triangle 87">
-                <a:extLst>
-                  <a:ext uri="{FF2B5EF4-FFF2-40B4-BE49-F238E27FC236}">
-                    <a16:creationId xmlns:a16="http://schemas.microsoft.com/office/drawing/2014/main" id="{E1A7F761-3124-8F6C-95DA-D2FFD02DDCA1}"/>
-                  </a:ext>
-                </a:extLst>
-              </p:cNvPr>
-              <p:cNvSpPr/>
-              <p:nvPr/>
-            </p:nvSpPr>
-            <p:spPr>
-              <a:xfrm rot="14248003">
-                <a:off x="2851235" y="2409712"/>
-                <a:ext cx="388815" cy="407297"/>
-              </a:xfrm>
-              <a:prstGeom prst="triangle">
-                <a:avLst/>
-              </a:prstGeom>
-            </p:spPr>
-            <p:style>
-              <a:lnRef idx="2">
-                <a:schemeClr val="dk1">
-                  <a:shade val="50000"/>
-                </a:schemeClr>
-              </a:lnRef>
-              <a:fillRef idx="1">
-                <a:schemeClr val="dk1"/>
-              </a:fillRef>
-              <a:effectRef idx="0">
-                <a:schemeClr val="dk1"/>
-              </a:effectRef>
-              <a:fontRef idx="minor">
-                <a:schemeClr val="lt1"/>
-              </a:fontRef>
-            </p:style>
-            <p:txBody>
-              <a:bodyPr rtlCol="0" anchor="ctr"/>
-              <a:lstStyle/>
-              <a:p>
-                <a:pPr algn="ctr"/>
-                <a:endParaRPr lang="en-US"/>
-              </a:p>
-            </p:txBody>
-          </p:sp>
-          <p:sp>
-            <p:nvSpPr>
-              <p:cNvPr id="89" name="Oval 88">
-                <a:extLst>
-                  <a:ext uri="{FF2B5EF4-FFF2-40B4-BE49-F238E27FC236}">
-                    <a16:creationId xmlns:a16="http://schemas.microsoft.com/office/drawing/2014/main" id="{E48ABA8F-3BB8-3304-80D4-82564456A528}"/>
-                  </a:ext>
-                </a:extLst>
-              </p:cNvPr>
-              <p:cNvSpPr/>
-              <p:nvPr/>
-            </p:nvSpPr>
-            <p:spPr>
-              <a:xfrm>
-                <a:off x="3087822" y="1907372"/>
-                <a:ext cx="979410" cy="979410"/>
-              </a:xfrm>
-              <a:prstGeom prst="ellipse">
-                <a:avLst/>
-              </a:prstGeom>
-              <a:ln w="19050"/>
-            </p:spPr>
-            <p:style>
-              <a:lnRef idx="2">
-                <a:schemeClr val="dk1"/>
-              </a:lnRef>
-              <a:fillRef idx="1">
-                <a:schemeClr val="lt1"/>
-              </a:fillRef>
-              <a:effectRef idx="0">
-                <a:schemeClr val="dk1"/>
-              </a:effectRef>
-              <a:fontRef idx="minor">
-                <a:schemeClr val="dk1"/>
-              </a:fontRef>
-            </p:style>
-            <p:txBody>
-              <a:bodyPr rtlCol="0" anchor="ctr"/>
-              <a:lstStyle/>
-              <a:p>
-                <a:pPr algn="ctr"/>
-                <a:endParaRPr lang="en-US"/>
-              </a:p>
-            </p:txBody>
-          </p:sp>
-        </p:grpSp>
       </p:grpSp>
     </p:spTree>
     <p:extLst>

</xml_diff>

<commit_message>
Add ParagardeShield & GoldenTitan & CurseTitan
</commit_message>
<xml_diff>
--- a/image process/drawings sifi.pptx
+++ b/image process/drawings sifi.pptx
@@ -200,7 +200,7 @@
           <a:p>
             <a:fld id="{7700C406-2328-4788-AE79-437B6607AD22}" type="datetimeFigureOut">
               <a:rPr lang="en-US" smtClean="0"/>
-              <a:t>6/3/2022</a:t>
+              <a:t>6/4/2022</a:t>
             </a:fld>
             <a:endParaRPr lang="en-US"/>
           </a:p>
@@ -614,7 +614,7 @@
           <a:p>
             <a:fld id="{9EC8CD53-0620-48F2-A3BB-2B10BDA60E52}" type="datetimeFigureOut">
               <a:rPr lang="en-US" smtClean="0"/>
-              <a:t>6/3/2022</a:t>
+              <a:t>6/4/2022</a:t>
             </a:fld>
             <a:endParaRPr lang="en-US"/>
           </a:p>
@@ -812,7 +812,7 @@
           <a:p>
             <a:fld id="{9EC8CD53-0620-48F2-A3BB-2B10BDA60E52}" type="datetimeFigureOut">
               <a:rPr lang="en-US" smtClean="0"/>
-              <a:t>6/3/2022</a:t>
+              <a:t>6/4/2022</a:t>
             </a:fld>
             <a:endParaRPr lang="en-US"/>
           </a:p>
@@ -1020,7 +1020,7 @@
           <a:p>
             <a:fld id="{9EC8CD53-0620-48F2-A3BB-2B10BDA60E52}" type="datetimeFigureOut">
               <a:rPr lang="en-US" smtClean="0"/>
-              <a:t>6/3/2022</a:t>
+              <a:t>6/4/2022</a:t>
             </a:fld>
             <a:endParaRPr lang="en-US"/>
           </a:p>
@@ -1218,7 +1218,7 @@
           <a:p>
             <a:fld id="{9EC8CD53-0620-48F2-A3BB-2B10BDA60E52}" type="datetimeFigureOut">
               <a:rPr lang="en-US" smtClean="0"/>
-              <a:t>6/3/2022</a:t>
+              <a:t>6/4/2022</a:t>
             </a:fld>
             <a:endParaRPr lang="en-US"/>
           </a:p>
@@ -1493,7 +1493,7 @@
           <a:p>
             <a:fld id="{9EC8CD53-0620-48F2-A3BB-2B10BDA60E52}" type="datetimeFigureOut">
               <a:rPr lang="en-US" smtClean="0"/>
-              <a:t>6/3/2022</a:t>
+              <a:t>6/4/2022</a:t>
             </a:fld>
             <a:endParaRPr lang="en-US"/>
           </a:p>
@@ -1758,7 +1758,7 @@
           <a:p>
             <a:fld id="{9EC8CD53-0620-48F2-A3BB-2B10BDA60E52}" type="datetimeFigureOut">
               <a:rPr lang="en-US" smtClean="0"/>
-              <a:t>6/3/2022</a:t>
+              <a:t>6/4/2022</a:t>
             </a:fld>
             <a:endParaRPr lang="en-US"/>
           </a:p>
@@ -2170,7 +2170,7 @@
           <a:p>
             <a:fld id="{9EC8CD53-0620-48F2-A3BB-2B10BDA60E52}" type="datetimeFigureOut">
               <a:rPr lang="en-US" smtClean="0"/>
-              <a:t>6/3/2022</a:t>
+              <a:t>6/4/2022</a:t>
             </a:fld>
             <a:endParaRPr lang="en-US"/>
           </a:p>
@@ -2311,7 +2311,7 @@
           <a:p>
             <a:fld id="{9EC8CD53-0620-48F2-A3BB-2B10BDA60E52}" type="datetimeFigureOut">
               <a:rPr lang="en-US" smtClean="0"/>
-              <a:t>6/3/2022</a:t>
+              <a:t>6/4/2022</a:t>
             </a:fld>
             <a:endParaRPr lang="en-US"/>
           </a:p>
@@ -2424,7 +2424,7 @@
           <a:p>
             <a:fld id="{9EC8CD53-0620-48F2-A3BB-2B10BDA60E52}" type="datetimeFigureOut">
               <a:rPr lang="en-US" smtClean="0"/>
-              <a:t>6/3/2022</a:t>
+              <a:t>6/4/2022</a:t>
             </a:fld>
             <a:endParaRPr lang="en-US"/>
           </a:p>
@@ -2735,7 +2735,7 @@
           <a:p>
             <a:fld id="{9EC8CD53-0620-48F2-A3BB-2B10BDA60E52}" type="datetimeFigureOut">
               <a:rPr lang="en-US" smtClean="0"/>
-              <a:t>6/3/2022</a:t>
+              <a:t>6/4/2022</a:t>
             </a:fld>
             <a:endParaRPr lang="en-US"/>
           </a:p>
@@ -3023,7 +3023,7 @@
           <a:p>
             <a:fld id="{9EC8CD53-0620-48F2-A3BB-2B10BDA60E52}" type="datetimeFigureOut">
               <a:rPr lang="en-US" smtClean="0"/>
-              <a:t>6/3/2022</a:t>
+              <a:t>6/4/2022</a:t>
             </a:fld>
             <a:endParaRPr lang="en-US"/>
           </a:p>
@@ -3264,7 +3264,7 @@
           <a:p>
             <a:fld id="{9EC8CD53-0620-48F2-A3BB-2B10BDA60E52}" type="datetimeFigureOut">
               <a:rPr lang="en-US" smtClean="0"/>
-              <a:t>6/3/2022</a:t>
+              <a:t>6/4/2022</a:t>
             </a:fld>
             <a:endParaRPr lang="en-US"/>
           </a:p>
@@ -17241,6 +17241,36 @@
           <a:chExt cx="0" cy="0"/>
         </a:xfrm>
       </p:grpSpPr>
+      <p:pic>
+        <p:nvPicPr>
+          <p:cNvPr id="30" name="Picture 29">
+            <a:extLst>
+              <a:ext uri="{FF2B5EF4-FFF2-40B4-BE49-F238E27FC236}">
+                <a16:creationId xmlns:a16="http://schemas.microsoft.com/office/drawing/2014/main" id="{BD0E5BCE-5376-9B10-FC7E-2D121E8F69D3}"/>
+              </a:ext>
+            </a:extLst>
+          </p:cNvPr>
+          <p:cNvPicPr>
+            <a:picLocks noChangeAspect="1"/>
+          </p:cNvPicPr>
+          <p:nvPr/>
+        </p:nvPicPr>
+        <p:blipFill>
+          <a:blip r:embed="rId2"/>
+          <a:stretch>
+            <a:fillRect/>
+          </a:stretch>
+        </p:blipFill>
+        <p:spPr>
+          <a:xfrm>
+            <a:off x="594436" y="841877"/>
+            <a:ext cx="433388" cy="444277"/>
+          </a:xfrm>
+          <a:prstGeom prst="rect">
+            <a:avLst/>
+          </a:prstGeom>
+        </p:spPr>
+      </p:pic>
       <p:grpSp>
         <p:nvGrpSpPr>
           <p:cNvPr id="13" name="Group 12">
@@ -17370,10 +17400,10 @@
       </p:grpSp>
       <p:grpSp>
         <p:nvGrpSpPr>
-          <p:cNvPr id="82" name="Group 81">
+          <p:cNvPr id="21" name="Group 20">
             <a:extLst>
               <a:ext uri="{FF2B5EF4-FFF2-40B4-BE49-F238E27FC236}">
-                <a16:creationId xmlns:a16="http://schemas.microsoft.com/office/drawing/2014/main" id="{69B2A179-E1E8-665F-F368-D461DAB87650}"/>
+                <a16:creationId xmlns:a16="http://schemas.microsoft.com/office/drawing/2014/main" id="{E2A2CBEA-E93F-5FBE-BF5E-6728063DE48D}"/>
               </a:ext>
             </a:extLst>
           </p:cNvPr>
@@ -17382,18 +17412,18 @@
         </p:nvGrpSpPr>
         <p:grpSpPr>
           <a:xfrm>
-            <a:off x="664458" y="683072"/>
-            <a:ext cx="907668" cy="622697"/>
-            <a:chOff x="2768462" y="1630604"/>
-            <a:chExt cx="3099528" cy="2126402"/>
+            <a:off x="1019174" y="536319"/>
+            <a:ext cx="441325" cy="1012069"/>
+            <a:chOff x="3248025" y="1009650"/>
+            <a:chExt cx="1390650" cy="3189114"/>
           </a:xfrm>
         </p:grpSpPr>
         <p:sp>
           <p:nvSpPr>
-            <p:cNvPr id="62" name="Rectangle 61">
-              <a:extLst>
-                <a:ext uri="{FF2B5EF4-FFF2-40B4-BE49-F238E27FC236}">
-                  <a16:creationId xmlns:a16="http://schemas.microsoft.com/office/drawing/2014/main" id="{88BD95FA-38DB-6FF3-AE61-0006E0068860}"/>
+            <p:cNvPr id="9" name="Oval 8">
+              <a:extLst>
+                <a:ext uri="{FF2B5EF4-FFF2-40B4-BE49-F238E27FC236}">
+                  <a16:creationId xmlns:a16="http://schemas.microsoft.com/office/drawing/2014/main" id="{9D5510EF-2548-EA85-62B8-9ADA85182350}"/>
                 </a:ext>
               </a:extLst>
             </p:cNvPr>
@@ -17402,10 +17432,10 @@
           </p:nvSpPr>
           <p:spPr>
             <a:xfrm>
-              <a:off x="3951162" y="3217961"/>
-              <a:ext cx="894382" cy="386255"/>
-            </a:xfrm>
-            <a:prstGeom prst="rect">
+              <a:off x="3549650" y="1009650"/>
+              <a:ext cx="787400" cy="984250"/>
+            </a:xfrm>
+            <a:prstGeom prst="ellipse">
               <a:avLst/>
             </a:prstGeom>
           </p:spPr>
@@ -17436,10 +17466,10 @@
         </p:sp>
         <p:sp>
           <p:nvSpPr>
-            <p:cNvPr id="27" name="Rectangle 26">
-              <a:extLst>
-                <a:ext uri="{FF2B5EF4-FFF2-40B4-BE49-F238E27FC236}">
-                  <a16:creationId xmlns:a16="http://schemas.microsoft.com/office/drawing/2014/main" id="{E2A2E51D-04D7-1817-DD54-31B9901A89B1}"/>
+            <p:cNvPr id="11" name="Rectangle: Rounded Corners 10">
+              <a:extLst>
+                <a:ext uri="{FF2B5EF4-FFF2-40B4-BE49-F238E27FC236}">
+                  <a16:creationId xmlns:a16="http://schemas.microsoft.com/office/drawing/2014/main" id="{104BD941-8C1D-03B6-2D46-9AD123AB3AAA}"/>
                 </a:ext>
               </a:extLst>
             </p:cNvPr>
@@ -17448,10 +17478,10 @@
           </p:nvSpPr>
           <p:spPr>
             <a:xfrm>
-              <a:off x="3745275" y="2561897"/>
-              <a:ext cx="1305472" cy="617557"/>
-            </a:xfrm>
-            <a:prstGeom prst="rect">
+              <a:off x="3600450" y="2051050"/>
+              <a:ext cx="692150" cy="292100"/>
+            </a:xfrm>
+            <a:prstGeom prst="roundRect">
               <a:avLst/>
             </a:prstGeom>
           </p:spPr>
@@ -17469,282 +17499,6 @@
             </a:effectRef>
             <a:fontRef idx="minor">
               <a:schemeClr val="lt1"/>
-            </a:fontRef>
-          </p:style>
-          <p:txBody>
-            <a:bodyPr rtlCol="0" anchor="ctr"/>
-            <a:lstStyle/>
-            <a:p>
-              <a:pPr algn="ctr"/>
-              <a:endParaRPr lang="en-US"/>
-            </a:p>
-          </p:txBody>
-        </p:sp>
-        <p:sp>
-          <p:nvSpPr>
-            <p:cNvPr id="28" name="Rectangle 27">
-              <a:extLst>
-                <a:ext uri="{FF2B5EF4-FFF2-40B4-BE49-F238E27FC236}">
-                  <a16:creationId xmlns:a16="http://schemas.microsoft.com/office/drawing/2014/main" id="{BBBFF7AA-5FD3-AC55-593C-92FE3B31594C}"/>
-                </a:ext>
-              </a:extLst>
-            </p:cNvPr>
-            <p:cNvSpPr/>
-            <p:nvPr/>
-          </p:nvSpPr>
-          <p:spPr>
-            <a:xfrm>
-              <a:off x="3786206" y="1808785"/>
-              <a:ext cx="248338" cy="464424"/>
-            </a:xfrm>
-            <a:prstGeom prst="rect">
-              <a:avLst/>
-            </a:prstGeom>
-          </p:spPr>
-          <p:style>
-            <a:lnRef idx="2">
-              <a:schemeClr val="dk1">
-                <a:shade val="50000"/>
-              </a:schemeClr>
-            </a:lnRef>
-            <a:fillRef idx="1">
-              <a:schemeClr val="dk1"/>
-            </a:fillRef>
-            <a:effectRef idx="0">
-              <a:schemeClr val="dk1"/>
-            </a:effectRef>
-            <a:fontRef idx="minor">
-              <a:schemeClr val="lt1"/>
-            </a:fontRef>
-          </p:style>
-          <p:txBody>
-            <a:bodyPr rtlCol="0" anchor="ctr"/>
-            <a:lstStyle/>
-            <a:p>
-              <a:pPr algn="ctr"/>
-              <a:endParaRPr lang="en-US"/>
-            </a:p>
-          </p:txBody>
-        </p:sp>
-        <p:sp>
-          <p:nvSpPr>
-            <p:cNvPr id="57" name="Plaque 56">
-              <a:extLst>
-                <a:ext uri="{FF2B5EF4-FFF2-40B4-BE49-F238E27FC236}">
-                  <a16:creationId xmlns:a16="http://schemas.microsoft.com/office/drawing/2014/main" id="{D3308D06-9878-B246-3449-D16662A633D4}"/>
-                </a:ext>
-              </a:extLst>
-            </p:cNvPr>
-            <p:cNvSpPr/>
-            <p:nvPr/>
-          </p:nvSpPr>
-          <p:spPr>
-            <a:xfrm>
-              <a:off x="4136527" y="1630604"/>
-              <a:ext cx="853168" cy="839875"/>
-            </a:xfrm>
-            <a:prstGeom prst="plaque">
-              <a:avLst>
-                <a:gd name="adj" fmla="val 25032"/>
-              </a:avLst>
-            </a:prstGeom>
-          </p:spPr>
-          <p:style>
-            <a:lnRef idx="2">
-              <a:schemeClr val="dk1">
-                <a:shade val="50000"/>
-              </a:schemeClr>
-            </a:lnRef>
-            <a:fillRef idx="1">
-              <a:schemeClr val="dk1"/>
-            </a:fillRef>
-            <a:effectRef idx="0">
-              <a:schemeClr val="dk1"/>
-            </a:effectRef>
-            <a:fontRef idx="minor">
-              <a:schemeClr val="lt1"/>
-            </a:fontRef>
-          </p:style>
-          <p:txBody>
-            <a:bodyPr rtlCol="0" anchor="ctr"/>
-            <a:lstStyle/>
-            <a:p>
-              <a:pPr algn="ctr"/>
-              <a:endParaRPr lang="en-US"/>
-            </a:p>
-          </p:txBody>
-        </p:sp>
-        <p:sp>
-          <p:nvSpPr>
-            <p:cNvPr id="60" name="Rectangle 59">
-              <a:extLst>
-                <a:ext uri="{FF2B5EF4-FFF2-40B4-BE49-F238E27FC236}">
-                  <a16:creationId xmlns:a16="http://schemas.microsoft.com/office/drawing/2014/main" id="{F013E3FD-8053-F657-0435-0C23988B0B0C}"/>
-                </a:ext>
-              </a:extLst>
-            </p:cNvPr>
-            <p:cNvSpPr/>
-            <p:nvPr/>
-          </p:nvSpPr>
-          <p:spPr>
-            <a:xfrm rot="20548458">
-              <a:off x="5595262" y="3142160"/>
-              <a:ext cx="272728" cy="614846"/>
-            </a:xfrm>
-            <a:prstGeom prst="rect">
-              <a:avLst/>
-            </a:prstGeom>
-          </p:spPr>
-          <p:style>
-            <a:lnRef idx="2">
-              <a:schemeClr val="dk1">
-                <a:shade val="50000"/>
-              </a:schemeClr>
-            </a:lnRef>
-            <a:fillRef idx="1">
-              <a:schemeClr val="dk1"/>
-            </a:fillRef>
-            <a:effectRef idx="0">
-              <a:schemeClr val="dk1"/>
-            </a:effectRef>
-            <a:fontRef idx="minor">
-              <a:schemeClr val="lt1"/>
-            </a:fontRef>
-          </p:style>
-          <p:txBody>
-            <a:bodyPr rtlCol="0" anchor="ctr"/>
-            <a:lstStyle/>
-            <a:p>
-              <a:pPr algn="ctr"/>
-              <a:endParaRPr lang="en-US"/>
-            </a:p>
-          </p:txBody>
-        </p:sp>
-        <p:sp>
-          <p:nvSpPr>
-            <p:cNvPr id="58" name="Rectangle 57">
-              <a:extLst>
-                <a:ext uri="{FF2B5EF4-FFF2-40B4-BE49-F238E27FC236}">
-                  <a16:creationId xmlns:a16="http://schemas.microsoft.com/office/drawing/2014/main" id="{31DEDA76-EE1A-F46C-B29C-E80E1134A795}"/>
-                </a:ext>
-              </a:extLst>
-            </p:cNvPr>
-            <p:cNvSpPr/>
-            <p:nvPr/>
-          </p:nvSpPr>
-          <p:spPr>
-            <a:xfrm rot="18038434">
-              <a:off x="5084956" y="2698459"/>
-              <a:ext cx="421902" cy="614846"/>
-            </a:xfrm>
-            <a:prstGeom prst="rect">
-              <a:avLst/>
-            </a:prstGeom>
-          </p:spPr>
-          <p:style>
-            <a:lnRef idx="2">
-              <a:schemeClr val="dk1">
-                <a:shade val="50000"/>
-              </a:schemeClr>
-            </a:lnRef>
-            <a:fillRef idx="1">
-              <a:schemeClr val="dk1"/>
-            </a:fillRef>
-            <a:effectRef idx="0">
-              <a:schemeClr val="dk1"/>
-            </a:effectRef>
-            <a:fontRef idx="minor">
-              <a:schemeClr val="lt1"/>
-            </a:fontRef>
-          </p:style>
-          <p:txBody>
-            <a:bodyPr rtlCol="0" anchor="ctr"/>
-            <a:lstStyle/>
-            <a:p>
-              <a:pPr algn="ctr"/>
-              <a:endParaRPr lang="en-US"/>
-            </a:p>
-          </p:txBody>
-        </p:sp>
-        <p:sp>
-          <p:nvSpPr>
-            <p:cNvPr id="59" name="Oval 58">
-              <a:extLst>
-                <a:ext uri="{FF2B5EF4-FFF2-40B4-BE49-F238E27FC236}">
-                  <a16:creationId xmlns:a16="http://schemas.microsoft.com/office/drawing/2014/main" id="{668655E6-A1D1-A645-459C-87F702AE7D54}"/>
-                </a:ext>
-              </a:extLst>
-            </p:cNvPr>
-            <p:cNvSpPr/>
-            <p:nvPr/>
-          </p:nvSpPr>
-          <p:spPr>
-            <a:xfrm rot="15253353">
-              <a:off x="5371321" y="2954379"/>
-              <a:ext cx="432581" cy="432581"/>
-            </a:xfrm>
-            <a:prstGeom prst="ellipse">
-              <a:avLst/>
-            </a:prstGeom>
-            <a:ln w="38100"/>
-          </p:spPr>
-          <p:style>
-            <a:lnRef idx="2">
-              <a:schemeClr val="dk1"/>
-            </a:lnRef>
-            <a:fillRef idx="1">
-              <a:schemeClr val="lt1"/>
-            </a:fillRef>
-            <a:effectRef idx="0">
-              <a:schemeClr val="dk1"/>
-            </a:effectRef>
-            <a:fontRef idx="minor">
-              <a:schemeClr val="dk1"/>
-            </a:fontRef>
-          </p:style>
-          <p:txBody>
-            <a:bodyPr rtlCol="0" anchor="ctr"/>
-            <a:lstStyle/>
-            <a:p>
-              <a:pPr algn="ctr"/>
-              <a:endParaRPr lang="en-US"/>
-            </a:p>
-          </p:txBody>
-        </p:sp>
-        <p:sp>
-          <p:nvSpPr>
-            <p:cNvPr id="56" name="Oval 55">
-              <a:extLst>
-                <a:ext uri="{FF2B5EF4-FFF2-40B4-BE49-F238E27FC236}">
-                  <a16:creationId xmlns:a16="http://schemas.microsoft.com/office/drawing/2014/main" id="{A050B2F7-858D-AC78-CC83-644C43409C38}"/>
-                </a:ext>
-              </a:extLst>
-            </p:cNvPr>
-            <p:cNvSpPr/>
-            <p:nvPr/>
-          </p:nvSpPr>
-          <p:spPr>
-            <a:xfrm rot="15710661">
-              <a:off x="4683975" y="2593993"/>
-              <a:ext cx="531646" cy="531646"/>
-            </a:xfrm>
-            <a:prstGeom prst="ellipse">
-              <a:avLst/>
-            </a:prstGeom>
-            <a:ln w="38100"/>
-          </p:spPr>
-          <p:style>
-            <a:lnRef idx="2">
-              <a:schemeClr val="dk1"/>
-            </a:lnRef>
-            <a:fillRef idx="1">
-              <a:schemeClr val="lt1"/>
-            </a:fillRef>
-            <a:effectRef idx="0">
-              <a:schemeClr val="dk1"/>
-            </a:effectRef>
-            <a:fontRef idx="minor">
-              <a:schemeClr val="dk1"/>
             </a:fontRef>
           </p:style>
           <p:txBody>
@@ -17758,10 +17512,10 @@
         </p:sp>
         <p:grpSp>
           <p:nvGrpSpPr>
-            <p:cNvPr id="75" name="Group 74">
-              <a:extLst>
-                <a:ext uri="{FF2B5EF4-FFF2-40B4-BE49-F238E27FC236}">
-                  <a16:creationId xmlns:a16="http://schemas.microsoft.com/office/drawing/2014/main" id="{9B336AC7-3972-B11B-12A3-C78C86D110B4}"/>
+            <p:cNvPr id="17" name="Group 16">
+              <a:extLst>
+                <a:ext uri="{FF2B5EF4-FFF2-40B4-BE49-F238E27FC236}">
+                  <a16:creationId xmlns:a16="http://schemas.microsoft.com/office/drawing/2014/main" id="{8D4E8C95-B2D6-2625-DFAC-E9625432CFC0}"/>
                 </a:ext>
               </a:extLst>
             </p:cNvPr>
@@ -17769,19 +17523,19 @@
             <p:nvPr/>
           </p:nvGrpSpPr>
           <p:grpSpPr>
-            <a:xfrm flipH="1">
-              <a:off x="2768462" y="2618875"/>
-              <a:ext cx="1199848" cy="1121157"/>
-              <a:chOff x="4817477" y="2615266"/>
-              <a:chExt cx="1199848" cy="1121157"/>
+            <a:xfrm>
+              <a:off x="4282383" y="2120161"/>
+              <a:ext cx="291335" cy="2073380"/>
+              <a:chOff x="4282383" y="2120161"/>
+              <a:chExt cx="291335" cy="2073380"/>
             </a:xfrm>
           </p:grpSpPr>
           <p:sp>
             <p:nvSpPr>
-              <p:cNvPr id="76" name="Rectangle 75">
+              <p:cNvPr id="12" name="Rectangle 11">
                 <a:extLst>
                   <a:ext uri="{FF2B5EF4-FFF2-40B4-BE49-F238E27FC236}">
-                    <a16:creationId xmlns:a16="http://schemas.microsoft.com/office/drawing/2014/main" id="{81AD9E0F-5324-3015-1D2B-2AE7E1CC37E6}"/>
+                    <a16:creationId xmlns:a16="http://schemas.microsoft.com/office/drawing/2014/main" id="{9B4DCC3F-3F93-BD4A-39A6-47EB5B8E46EE}"/>
                   </a:ext>
                 </a:extLst>
               </p:cNvPr>
@@ -17789,9 +17543,9 @@
               <p:nvPr/>
             </p:nvSpPr>
             <p:spPr>
-              <a:xfrm rot="20354995">
-                <a:off x="5744597" y="3121577"/>
-                <a:ext cx="272728" cy="614846"/>
+              <a:xfrm rot="3958351">
+                <a:off x="3893446" y="2509098"/>
+                <a:ext cx="996950" cy="219075"/>
               </a:xfrm>
               <a:prstGeom prst="rect">
                 <a:avLst/>
@@ -17824,10 +17578,10 @@
           </p:sp>
           <p:sp>
             <p:nvSpPr>
-              <p:cNvPr id="77" name="Rectangle 76">
+              <p:cNvPr id="14" name="Isosceles Triangle 13">
                 <a:extLst>
                   <a:ext uri="{FF2B5EF4-FFF2-40B4-BE49-F238E27FC236}">
-                    <a16:creationId xmlns:a16="http://schemas.microsoft.com/office/drawing/2014/main" id="{26693838-BBDC-965D-CC06-07BEDAB7E3E4}"/>
+                    <a16:creationId xmlns:a16="http://schemas.microsoft.com/office/drawing/2014/main" id="{1E09283E-E602-4561-BA1B-639728EE4302}"/>
                   </a:ext>
                 </a:extLst>
               </p:cNvPr>
@@ -17835,9 +17589,76 @@
               <p:nvPr/>
             </p:nvSpPr>
             <p:spPr>
-              <a:xfrm rot="17844971">
-                <a:off x="5210024" y="2703085"/>
-                <a:ext cx="421902" cy="614846"/>
+              <a:xfrm rot="11268472">
+                <a:off x="4421316" y="2942591"/>
+                <a:ext cx="152402" cy="1250950"/>
+              </a:xfrm>
+              <a:prstGeom prst="triangle">
+                <a:avLst/>
+              </a:prstGeom>
+            </p:spPr>
+            <p:style>
+              <a:lnRef idx="2">
+                <a:schemeClr val="dk1">
+                  <a:shade val="50000"/>
+                </a:schemeClr>
+              </a:lnRef>
+              <a:fillRef idx="1">
+                <a:schemeClr val="dk1"/>
+              </a:fillRef>
+              <a:effectRef idx="0">
+                <a:schemeClr val="dk1"/>
+              </a:effectRef>
+              <a:fontRef idx="minor">
+                <a:schemeClr val="lt1"/>
+              </a:fontRef>
+            </p:style>
+            <p:txBody>
+              <a:bodyPr rtlCol="0" anchor="ctr"/>
+              <a:lstStyle/>
+              <a:p>
+                <a:pPr algn="ctr"/>
+                <a:endParaRPr lang="en-US"/>
+              </a:p>
+            </p:txBody>
+          </p:sp>
+        </p:grpSp>
+        <p:grpSp>
+          <p:nvGrpSpPr>
+            <p:cNvPr id="35" name="Group 34">
+              <a:extLst>
+                <a:ext uri="{FF2B5EF4-FFF2-40B4-BE49-F238E27FC236}">
+                  <a16:creationId xmlns:a16="http://schemas.microsoft.com/office/drawing/2014/main" id="{11CE8681-7007-B528-1489-2C083FAB07E4}"/>
+                </a:ext>
+              </a:extLst>
+            </p:cNvPr>
+            <p:cNvGrpSpPr/>
+            <p:nvPr/>
+          </p:nvGrpSpPr>
+          <p:grpSpPr>
+            <a:xfrm flipH="1">
+              <a:off x="3309115" y="2124715"/>
+              <a:ext cx="291335" cy="2073380"/>
+              <a:chOff x="4282383" y="2120161"/>
+              <a:chExt cx="291335" cy="2073380"/>
+            </a:xfrm>
+          </p:grpSpPr>
+          <p:sp>
+            <p:nvSpPr>
+              <p:cNvPr id="36" name="Rectangle 35">
+                <a:extLst>
+                  <a:ext uri="{FF2B5EF4-FFF2-40B4-BE49-F238E27FC236}">
+                    <a16:creationId xmlns:a16="http://schemas.microsoft.com/office/drawing/2014/main" id="{7146EEE4-FE28-A545-C368-14A7CBAFCCD3}"/>
+                  </a:ext>
+                </a:extLst>
+              </p:cNvPr>
+              <p:cNvSpPr/>
+              <p:nvPr/>
+            </p:nvSpPr>
+            <p:spPr>
+              <a:xfrm rot="3958351">
+                <a:off x="3893446" y="2509098"/>
+                <a:ext cx="996950" cy="219075"/>
               </a:xfrm>
               <a:prstGeom prst="rect">
                 <a:avLst/>
@@ -17870,10 +17691,10 @@
           </p:sp>
           <p:sp>
             <p:nvSpPr>
-              <p:cNvPr id="78" name="Oval 77">
+              <p:cNvPr id="37" name="Isosceles Triangle 36">
                 <a:extLst>
                   <a:ext uri="{FF2B5EF4-FFF2-40B4-BE49-F238E27FC236}">
-                    <a16:creationId xmlns:a16="http://schemas.microsoft.com/office/drawing/2014/main" id="{F0691E16-B9A8-7886-F07A-EBB7B4824219}"/>
+                    <a16:creationId xmlns:a16="http://schemas.microsoft.com/office/drawing/2014/main" id="{B62C4A42-F1EE-4E15-A845-CB1E95F23D9F}"/>
                   </a:ext>
                 </a:extLst>
               </p:cNvPr>
@@ -17881,72 +17702,28 @@
               <p:nvPr/>
             </p:nvSpPr>
             <p:spPr>
-              <a:xfrm rot="15059890">
-                <a:off x="5505196" y="2942338"/>
-                <a:ext cx="432581" cy="432581"/>
+              <a:xfrm rot="11268472">
+                <a:off x="4421316" y="2942591"/>
+                <a:ext cx="152402" cy="1250950"/>
               </a:xfrm>
-              <a:prstGeom prst="ellipse">
+              <a:prstGeom prst="triangle">
                 <a:avLst/>
               </a:prstGeom>
-              <a:ln w="38100"/>
             </p:spPr>
             <p:style>
               <a:lnRef idx="2">
-                <a:schemeClr val="dk1"/>
+                <a:schemeClr val="dk1">
+                  <a:shade val="50000"/>
+                </a:schemeClr>
               </a:lnRef>
               <a:fillRef idx="1">
-                <a:schemeClr val="lt1"/>
+                <a:schemeClr val="dk1"/>
               </a:fillRef>
               <a:effectRef idx="0">
                 <a:schemeClr val="dk1"/>
               </a:effectRef>
               <a:fontRef idx="minor">
-                <a:schemeClr val="dk1"/>
-              </a:fontRef>
-            </p:style>
-            <p:txBody>
-              <a:bodyPr rtlCol="0" anchor="ctr"/>
-              <a:lstStyle/>
-              <a:p>
-                <a:pPr algn="ctr"/>
-                <a:endParaRPr lang="en-US"/>
-              </a:p>
-            </p:txBody>
-          </p:sp>
-          <p:sp>
-            <p:nvSpPr>
-              <p:cNvPr id="79" name="Oval 78">
-                <a:extLst>
-                  <a:ext uri="{FF2B5EF4-FFF2-40B4-BE49-F238E27FC236}">
-                    <a16:creationId xmlns:a16="http://schemas.microsoft.com/office/drawing/2014/main" id="{9894AF7C-2CFA-0746-1276-A4AEF1396B8E}"/>
-                  </a:ext>
-                </a:extLst>
-              </p:cNvPr>
-              <p:cNvSpPr/>
-              <p:nvPr/>
-            </p:nvSpPr>
-            <p:spPr>
-              <a:xfrm rot="14919487">
-                <a:off x="4817477" y="2615266"/>
-                <a:ext cx="531646" cy="531646"/>
-              </a:xfrm>
-              <a:prstGeom prst="ellipse">
-                <a:avLst/>
-              </a:prstGeom>
-              <a:ln w="38100"/>
-            </p:spPr>
-            <p:style>
-              <a:lnRef idx="2">
-                <a:schemeClr val="dk1"/>
-              </a:lnRef>
-              <a:fillRef idx="1">
                 <a:schemeClr val="lt1"/>
-              </a:fillRef>
-              <a:effectRef idx="0">
-                <a:schemeClr val="dk1"/>
-              </a:effectRef>
-              <a:fontRef idx="minor">
-                <a:schemeClr val="dk1"/>
               </a:fontRef>
             </p:style>
             <p:txBody>
@@ -17961,10 +17738,10 @@
         </p:grpSp>
         <p:sp>
           <p:nvSpPr>
-            <p:cNvPr id="81" name="Rectangle 80">
-              <a:extLst>
-                <a:ext uri="{FF2B5EF4-FFF2-40B4-BE49-F238E27FC236}">
-                  <a16:creationId xmlns:a16="http://schemas.microsoft.com/office/drawing/2014/main" id="{23F1AE68-0182-7D84-6B0D-4442D0AF8D56}"/>
+            <p:cNvPr id="39" name="Rectangle 38">
+              <a:extLst>
+                <a:ext uri="{FF2B5EF4-FFF2-40B4-BE49-F238E27FC236}">
+                  <a16:creationId xmlns:a16="http://schemas.microsoft.com/office/drawing/2014/main" id="{289333CA-5D8F-C6FC-1B71-A2036F1FEC27}"/>
                 </a:ext>
               </a:extLst>
             </p:cNvPr>
@@ -17972,9 +17749,9 @@
             <p:nvPr/>
           </p:nvSpPr>
           <p:spPr>
-            <a:xfrm>
-              <a:off x="3435885" y="1869791"/>
-              <a:ext cx="248338" cy="339333"/>
+            <a:xfrm rot="5400000">
+              <a:off x="3441937" y="2586038"/>
+              <a:ext cx="996950" cy="219075"/>
             </a:xfrm>
             <a:prstGeom prst="rect">
               <a:avLst/>
@@ -17994,6 +17771,140 @@
             </a:effectRef>
             <a:fontRef idx="minor">
               <a:schemeClr val="lt1"/>
+            </a:fontRef>
+          </p:style>
+          <p:txBody>
+            <a:bodyPr rtlCol="0" anchor="ctr"/>
+            <a:lstStyle/>
+            <a:p>
+              <a:pPr algn="ctr"/>
+              <a:endParaRPr lang="en-US"/>
+            </a:p>
+          </p:txBody>
+        </p:sp>
+        <p:sp>
+          <p:nvSpPr>
+            <p:cNvPr id="40" name="Isosceles Triangle 39">
+              <a:extLst>
+                <a:ext uri="{FF2B5EF4-FFF2-40B4-BE49-F238E27FC236}">
+                  <a16:creationId xmlns:a16="http://schemas.microsoft.com/office/drawing/2014/main" id="{99B87BC8-4AA1-49F4-1A86-6E5B0A124EED}"/>
+                </a:ext>
+              </a:extLst>
+            </p:cNvPr>
+            <p:cNvSpPr/>
+            <p:nvPr/>
+          </p:nvSpPr>
+          <p:spPr>
+            <a:xfrm rot="10800000">
+              <a:off x="3869157" y="2947814"/>
+              <a:ext cx="152402" cy="1250950"/>
+            </a:xfrm>
+            <a:prstGeom prst="triangle">
+              <a:avLst/>
+            </a:prstGeom>
+          </p:spPr>
+          <p:style>
+            <a:lnRef idx="2">
+              <a:schemeClr val="dk1">
+                <a:shade val="50000"/>
+              </a:schemeClr>
+            </a:lnRef>
+            <a:fillRef idx="1">
+              <a:schemeClr val="dk1"/>
+            </a:fillRef>
+            <a:effectRef idx="0">
+              <a:schemeClr val="dk1"/>
+            </a:effectRef>
+            <a:fontRef idx="minor">
+              <a:schemeClr val="lt1"/>
+            </a:fontRef>
+          </p:style>
+          <p:txBody>
+            <a:bodyPr rtlCol="0" anchor="ctr"/>
+            <a:lstStyle/>
+            <a:p>
+              <a:pPr algn="ctr"/>
+              <a:endParaRPr lang="en-US"/>
+            </a:p>
+          </p:txBody>
+        </p:sp>
+        <p:sp>
+          <p:nvSpPr>
+            <p:cNvPr id="18" name="Rectangle 17">
+              <a:extLst>
+                <a:ext uri="{FF2B5EF4-FFF2-40B4-BE49-F238E27FC236}">
+                  <a16:creationId xmlns:a16="http://schemas.microsoft.com/office/drawing/2014/main" id="{B94ABFCB-E0CF-2FE9-1D1D-847E59D4ECDC}"/>
+                </a:ext>
+              </a:extLst>
+            </p:cNvPr>
+            <p:cNvSpPr/>
+            <p:nvPr/>
+          </p:nvSpPr>
+          <p:spPr>
+            <a:xfrm>
+              <a:off x="3248025" y="1227137"/>
+              <a:ext cx="215900" cy="766763"/>
+            </a:xfrm>
+            <a:prstGeom prst="rect">
+              <a:avLst/>
+            </a:prstGeom>
+          </p:spPr>
+          <p:style>
+            <a:lnRef idx="2">
+              <a:schemeClr val="dk1"/>
+            </a:lnRef>
+            <a:fillRef idx="1">
+              <a:schemeClr val="lt1"/>
+            </a:fillRef>
+            <a:effectRef idx="0">
+              <a:schemeClr val="dk1"/>
+            </a:effectRef>
+            <a:fontRef idx="minor">
+              <a:schemeClr val="dk1"/>
+            </a:fontRef>
+          </p:style>
+          <p:txBody>
+            <a:bodyPr rtlCol="0" anchor="ctr"/>
+            <a:lstStyle/>
+            <a:p>
+              <a:pPr algn="ctr"/>
+              <a:endParaRPr lang="en-US"/>
+            </a:p>
+          </p:txBody>
+        </p:sp>
+        <p:sp>
+          <p:nvSpPr>
+            <p:cNvPr id="42" name="Rectangle 41">
+              <a:extLst>
+                <a:ext uri="{FF2B5EF4-FFF2-40B4-BE49-F238E27FC236}">
+                  <a16:creationId xmlns:a16="http://schemas.microsoft.com/office/drawing/2014/main" id="{FC055838-3FDF-25B4-2A9B-5B79F532EB71}"/>
+                </a:ext>
+              </a:extLst>
+            </p:cNvPr>
+            <p:cNvSpPr/>
+            <p:nvPr/>
+          </p:nvSpPr>
+          <p:spPr>
+            <a:xfrm>
+              <a:off x="4422775" y="1227136"/>
+              <a:ext cx="215900" cy="766764"/>
+            </a:xfrm>
+            <a:prstGeom prst="rect">
+              <a:avLst/>
+            </a:prstGeom>
+          </p:spPr>
+          <p:style>
+            <a:lnRef idx="2">
+              <a:schemeClr val="dk1"/>
+            </a:lnRef>
+            <a:fillRef idx="1">
+              <a:schemeClr val="lt1"/>
+            </a:fillRef>
+            <a:effectRef idx="0">
+              <a:schemeClr val="dk1"/>
+            </a:effectRef>
+            <a:fontRef idx="minor">
+              <a:schemeClr val="dk1"/>
             </a:fontRef>
           </p:style>
           <p:txBody>
@@ -18006,6 +17917,682 @@
           </p:txBody>
         </p:sp>
       </p:grpSp>
+      <p:grpSp>
+        <p:nvGrpSpPr>
+          <p:cNvPr id="22" name="Group 21">
+            <a:extLst>
+              <a:ext uri="{FF2B5EF4-FFF2-40B4-BE49-F238E27FC236}">
+                <a16:creationId xmlns:a16="http://schemas.microsoft.com/office/drawing/2014/main" id="{18BE5F6B-478D-573E-9C76-37A0135DBE17}"/>
+              </a:ext>
+            </a:extLst>
+          </p:cNvPr>
+          <p:cNvGrpSpPr/>
+          <p:nvPr/>
+        </p:nvGrpSpPr>
+        <p:grpSpPr>
+          <a:xfrm>
+            <a:off x="2296423" y="548069"/>
+            <a:ext cx="502920" cy="1014984"/>
+            <a:chOff x="5380031" y="966102"/>
+            <a:chExt cx="1727200" cy="3248141"/>
+          </a:xfrm>
+        </p:grpSpPr>
+        <p:sp>
+          <p:nvSpPr>
+            <p:cNvPr id="20" name="Moon 19">
+              <a:extLst>
+                <a:ext uri="{FF2B5EF4-FFF2-40B4-BE49-F238E27FC236}">
+                  <a16:creationId xmlns:a16="http://schemas.microsoft.com/office/drawing/2014/main" id="{E95D41D4-AD08-AD39-A14F-F05C5D38C635}"/>
+                </a:ext>
+              </a:extLst>
+            </p:cNvPr>
+            <p:cNvSpPr/>
+            <p:nvPr/>
+          </p:nvSpPr>
+          <p:spPr>
+            <a:xfrm rot="19627358">
+              <a:off x="5549196" y="966102"/>
+              <a:ext cx="450850" cy="984250"/>
+            </a:xfrm>
+            <a:prstGeom prst="moon">
+              <a:avLst/>
+            </a:prstGeom>
+          </p:spPr>
+          <p:style>
+            <a:lnRef idx="2">
+              <a:schemeClr val="dk1"/>
+            </a:lnRef>
+            <a:fillRef idx="1">
+              <a:schemeClr val="lt1"/>
+            </a:fillRef>
+            <a:effectRef idx="0">
+              <a:schemeClr val="dk1"/>
+            </a:effectRef>
+            <a:fontRef idx="minor">
+              <a:schemeClr val="dk1"/>
+            </a:fontRef>
+          </p:style>
+          <p:txBody>
+            <a:bodyPr rtlCol="0" anchor="ctr"/>
+            <a:lstStyle/>
+            <a:p>
+              <a:pPr algn="ctr"/>
+              <a:endParaRPr lang="en-US"/>
+            </a:p>
+          </p:txBody>
+        </p:sp>
+        <p:sp>
+          <p:nvSpPr>
+            <p:cNvPr id="61" name="Moon 60">
+              <a:extLst>
+                <a:ext uri="{FF2B5EF4-FFF2-40B4-BE49-F238E27FC236}">
+                  <a16:creationId xmlns:a16="http://schemas.microsoft.com/office/drawing/2014/main" id="{1EAC84D0-0BB6-E938-EC63-7135681FB63F}"/>
+                </a:ext>
+              </a:extLst>
+            </p:cNvPr>
+            <p:cNvSpPr/>
+            <p:nvPr/>
+          </p:nvSpPr>
+          <p:spPr>
+            <a:xfrm rot="1972642" flipH="1">
+              <a:off x="6518602" y="966104"/>
+              <a:ext cx="450850" cy="984250"/>
+            </a:xfrm>
+            <a:prstGeom prst="moon">
+              <a:avLst/>
+            </a:prstGeom>
+          </p:spPr>
+          <p:style>
+            <a:lnRef idx="2">
+              <a:schemeClr val="dk1"/>
+            </a:lnRef>
+            <a:fillRef idx="1">
+              <a:schemeClr val="lt1"/>
+            </a:fillRef>
+            <a:effectRef idx="0">
+              <a:schemeClr val="dk1"/>
+            </a:effectRef>
+            <a:fontRef idx="minor">
+              <a:schemeClr val="dk1"/>
+            </a:fontRef>
+          </p:style>
+          <p:txBody>
+            <a:bodyPr rtlCol="0" anchor="ctr"/>
+            <a:lstStyle/>
+            <a:p>
+              <a:pPr algn="ctr"/>
+              <a:endParaRPr lang="en-US"/>
+            </a:p>
+          </p:txBody>
+        </p:sp>
+        <p:sp>
+          <p:nvSpPr>
+            <p:cNvPr id="43" name="Oval 42">
+              <a:extLst>
+                <a:ext uri="{FF2B5EF4-FFF2-40B4-BE49-F238E27FC236}">
+                  <a16:creationId xmlns:a16="http://schemas.microsoft.com/office/drawing/2014/main" id="{08329DD8-9A31-5259-0D08-5C3CC972588F}"/>
+                </a:ext>
+              </a:extLst>
+            </p:cNvPr>
+            <p:cNvSpPr/>
+            <p:nvPr/>
+          </p:nvSpPr>
+          <p:spPr>
+            <a:xfrm>
+              <a:off x="5852869" y="1025129"/>
+              <a:ext cx="787400" cy="984250"/>
+            </a:xfrm>
+            <a:prstGeom prst="ellipse">
+              <a:avLst/>
+            </a:prstGeom>
+          </p:spPr>
+          <p:style>
+            <a:lnRef idx="2">
+              <a:schemeClr val="dk1">
+                <a:shade val="50000"/>
+              </a:schemeClr>
+            </a:lnRef>
+            <a:fillRef idx="1">
+              <a:schemeClr val="dk1"/>
+            </a:fillRef>
+            <a:effectRef idx="0">
+              <a:schemeClr val="dk1"/>
+            </a:effectRef>
+            <a:fontRef idx="minor">
+              <a:schemeClr val="lt1"/>
+            </a:fontRef>
+          </p:style>
+          <p:txBody>
+            <a:bodyPr rtlCol="0" anchor="ctr"/>
+            <a:lstStyle/>
+            <a:p>
+              <a:pPr algn="ctr"/>
+              <a:endParaRPr lang="en-US"/>
+            </a:p>
+          </p:txBody>
+        </p:sp>
+        <p:grpSp>
+          <p:nvGrpSpPr>
+            <p:cNvPr id="45" name="Group 44">
+              <a:extLst>
+                <a:ext uri="{FF2B5EF4-FFF2-40B4-BE49-F238E27FC236}">
+                  <a16:creationId xmlns:a16="http://schemas.microsoft.com/office/drawing/2014/main" id="{E3D82530-25BB-7B78-F396-EC90FDCFBBD1}"/>
+                </a:ext>
+              </a:extLst>
+            </p:cNvPr>
+            <p:cNvGrpSpPr/>
+            <p:nvPr/>
+          </p:nvGrpSpPr>
+          <p:grpSpPr>
+            <a:xfrm>
+              <a:off x="6585602" y="2135640"/>
+              <a:ext cx="291335" cy="2073380"/>
+              <a:chOff x="4282383" y="2120161"/>
+              <a:chExt cx="291335" cy="2073380"/>
+            </a:xfrm>
+          </p:grpSpPr>
+          <p:sp>
+            <p:nvSpPr>
+              <p:cNvPr id="46" name="Rectangle 45">
+                <a:extLst>
+                  <a:ext uri="{FF2B5EF4-FFF2-40B4-BE49-F238E27FC236}">
+                    <a16:creationId xmlns:a16="http://schemas.microsoft.com/office/drawing/2014/main" id="{23252941-D171-D4AC-9958-B7370AFD1A74}"/>
+                  </a:ext>
+                </a:extLst>
+              </p:cNvPr>
+              <p:cNvSpPr/>
+              <p:nvPr/>
+            </p:nvSpPr>
+            <p:spPr>
+              <a:xfrm rot="3958351">
+                <a:off x="3893446" y="2509098"/>
+                <a:ext cx="996950" cy="219075"/>
+              </a:xfrm>
+              <a:prstGeom prst="rect">
+                <a:avLst/>
+              </a:prstGeom>
+            </p:spPr>
+            <p:style>
+              <a:lnRef idx="2">
+                <a:schemeClr val="dk1">
+                  <a:shade val="50000"/>
+                </a:schemeClr>
+              </a:lnRef>
+              <a:fillRef idx="1">
+                <a:schemeClr val="dk1"/>
+              </a:fillRef>
+              <a:effectRef idx="0">
+                <a:schemeClr val="dk1"/>
+              </a:effectRef>
+              <a:fontRef idx="minor">
+                <a:schemeClr val="lt1"/>
+              </a:fontRef>
+            </p:style>
+            <p:txBody>
+              <a:bodyPr rtlCol="0" anchor="ctr"/>
+              <a:lstStyle/>
+              <a:p>
+                <a:pPr algn="ctr"/>
+                <a:endParaRPr lang="en-US"/>
+              </a:p>
+            </p:txBody>
+          </p:sp>
+          <p:sp>
+            <p:nvSpPr>
+              <p:cNvPr id="47" name="Isosceles Triangle 46">
+                <a:extLst>
+                  <a:ext uri="{FF2B5EF4-FFF2-40B4-BE49-F238E27FC236}">
+                    <a16:creationId xmlns:a16="http://schemas.microsoft.com/office/drawing/2014/main" id="{C4379557-A972-423D-3572-9827516BEC4C}"/>
+                  </a:ext>
+                </a:extLst>
+              </p:cNvPr>
+              <p:cNvSpPr/>
+              <p:nvPr/>
+            </p:nvSpPr>
+            <p:spPr>
+              <a:xfrm rot="11268472">
+                <a:off x="4421316" y="2942591"/>
+                <a:ext cx="152402" cy="1250950"/>
+              </a:xfrm>
+              <a:prstGeom prst="triangle">
+                <a:avLst/>
+              </a:prstGeom>
+            </p:spPr>
+            <p:style>
+              <a:lnRef idx="2">
+                <a:schemeClr val="dk1">
+                  <a:shade val="50000"/>
+                </a:schemeClr>
+              </a:lnRef>
+              <a:fillRef idx="1">
+                <a:schemeClr val="dk1"/>
+              </a:fillRef>
+              <a:effectRef idx="0">
+                <a:schemeClr val="dk1"/>
+              </a:effectRef>
+              <a:fontRef idx="minor">
+                <a:schemeClr val="lt1"/>
+              </a:fontRef>
+            </p:style>
+            <p:txBody>
+              <a:bodyPr rtlCol="0" anchor="ctr"/>
+              <a:lstStyle/>
+              <a:p>
+                <a:pPr algn="ctr"/>
+                <a:endParaRPr lang="en-US"/>
+              </a:p>
+            </p:txBody>
+          </p:sp>
+        </p:grpSp>
+        <p:grpSp>
+          <p:nvGrpSpPr>
+            <p:cNvPr id="48" name="Group 47">
+              <a:extLst>
+                <a:ext uri="{FF2B5EF4-FFF2-40B4-BE49-F238E27FC236}">
+                  <a16:creationId xmlns:a16="http://schemas.microsoft.com/office/drawing/2014/main" id="{2D2BD7C5-76A9-A619-C8B7-FE03919E99A0}"/>
+                </a:ext>
+              </a:extLst>
+            </p:cNvPr>
+            <p:cNvGrpSpPr/>
+            <p:nvPr/>
+          </p:nvGrpSpPr>
+          <p:grpSpPr>
+            <a:xfrm flipH="1">
+              <a:off x="5612334" y="2140194"/>
+              <a:ext cx="291335" cy="2073380"/>
+              <a:chOff x="4282383" y="2120161"/>
+              <a:chExt cx="291335" cy="2073380"/>
+            </a:xfrm>
+          </p:grpSpPr>
+          <p:sp>
+            <p:nvSpPr>
+              <p:cNvPr id="49" name="Rectangle 48">
+                <a:extLst>
+                  <a:ext uri="{FF2B5EF4-FFF2-40B4-BE49-F238E27FC236}">
+                    <a16:creationId xmlns:a16="http://schemas.microsoft.com/office/drawing/2014/main" id="{2FAAE068-751B-49DC-5680-34E68D0A3C9F}"/>
+                  </a:ext>
+                </a:extLst>
+              </p:cNvPr>
+              <p:cNvSpPr/>
+              <p:nvPr/>
+            </p:nvSpPr>
+            <p:spPr>
+              <a:xfrm rot="3958351">
+                <a:off x="3893446" y="2509098"/>
+                <a:ext cx="996950" cy="219075"/>
+              </a:xfrm>
+              <a:prstGeom prst="rect">
+                <a:avLst/>
+              </a:prstGeom>
+            </p:spPr>
+            <p:style>
+              <a:lnRef idx="2">
+                <a:schemeClr val="dk1">
+                  <a:shade val="50000"/>
+                </a:schemeClr>
+              </a:lnRef>
+              <a:fillRef idx="1">
+                <a:schemeClr val="dk1"/>
+              </a:fillRef>
+              <a:effectRef idx="0">
+                <a:schemeClr val="dk1"/>
+              </a:effectRef>
+              <a:fontRef idx="minor">
+                <a:schemeClr val="lt1"/>
+              </a:fontRef>
+            </p:style>
+            <p:txBody>
+              <a:bodyPr rtlCol="0" anchor="ctr"/>
+              <a:lstStyle/>
+              <a:p>
+                <a:pPr algn="ctr"/>
+                <a:endParaRPr lang="en-US"/>
+              </a:p>
+            </p:txBody>
+          </p:sp>
+          <p:sp>
+            <p:nvSpPr>
+              <p:cNvPr id="50" name="Isosceles Triangle 49">
+                <a:extLst>
+                  <a:ext uri="{FF2B5EF4-FFF2-40B4-BE49-F238E27FC236}">
+                    <a16:creationId xmlns:a16="http://schemas.microsoft.com/office/drawing/2014/main" id="{9AA4BCE5-F4F1-B611-C793-F485A6748A3A}"/>
+                  </a:ext>
+                </a:extLst>
+              </p:cNvPr>
+              <p:cNvSpPr/>
+              <p:nvPr/>
+            </p:nvSpPr>
+            <p:spPr>
+              <a:xfrm rot="11268472">
+                <a:off x="4421316" y="2942591"/>
+                <a:ext cx="152402" cy="1250950"/>
+              </a:xfrm>
+              <a:prstGeom prst="triangle">
+                <a:avLst/>
+              </a:prstGeom>
+            </p:spPr>
+            <p:style>
+              <a:lnRef idx="2">
+                <a:schemeClr val="dk1">
+                  <a:shade val="50000"/>
+                </a:schemeClr>
+              </a:lnRef>
+              <a:fillRef idx="1">
+                <a:schemeClr val="dk1"/>
+              </a:fillRef>
+              <a:effectRef idx="0">
+                <a:schemeClr val="dk1"/>
+              </a:effectRef>
+              <a:fontRef idx="minor">
+                <a:schemeClr val="lt1"/>
+              </a:fontRef>
+            </p:style>
+            <p:txBody>
+              <a:bodyPr rtlCol="0" anchor="ctr"/>
+              <a:lstStyle/>
+              <a:p>
+                <a:pPr algn="ctr"/>
+                <a:endParaRPr lang="en-US"/>
+              </a:p>
+            </p:txBody>
+          </p:sp>
+        </p:grpSp>
+        <p:sp>
+          <p:nvSpPr>
+            <p:cNvPr id="51" name="Rectangle 50">
+              <a:extLst>
+                <a:ext uri="{FF2B5EF4-FFF2-40B4-BE49-F238E27FC236}">
+                  <a16:creationId xmlns:a16="http://schemas.microsoft.com/office/drawing/2014/main" id="{0F48EA78-F7DC-B13A-6157-459D28BD6199}"/>
+                </a:ext>
+              </a:extLst>
+            </p:cNvPr>
+            <p:cNvSpPr/>
+            <p:nvPr/>
+          </p:nvSpPr>
+          <p:spPr>
+            <a:xfrm rot="5400000">
+              <a:off x="5745156" y="2601517"/>
+              <a:ext cx="996950" cy="219075"/>
+            </a:xfrm>
+            <a:prstGeom prst="rect">
+              <a:avLst/>
+            </a:prstGeom>
+          </p:spPr>
+          <p:style>
+            <a:lnRef idx="2">
+              <a:schemeClr val="dk1">
+                <a:shade val="50000"/>
+              </a:schemeClr>
+            </a:lnRef>
+            <a:fillRef idx="1">
+              <a:schemeClr val="dk1"/>
+            </a:fillRef>
+            <a:effectRef idx="0">
+              <a:schemeClr val="dk1"/>
+            </a:effectRef>
+            <a:fontRef idx="minor">
+              <a:schemeClr val="lt1"/>
+            </a:fontRef>
+          </p:style>
+          <p:txBody>
+            <a:bodyPr rtlCol="0" anchor="ctr"/>
+            <a:lstStyle/>
+            <a:p>
+              <a:pPr algn="ctr"/>
+              <a:endParaRPr lang="en-US"/>
+            </a:p>
+          </p:txBody>
+        </p:sp>
+        <p:sp>
+          <p:nvSpPr>
+            <p:cNvPr id="52" name="Isosceles Triangle 51">
+              <a:extLst>
+                <a:ext uri="{FF2B5EF4-FFF2-40B4-BE49-F238E27FC236}">
+                  <a16:creationId xmlns:a16="http://schemas.microsoft.com/office/drawing/2014/main" id="{DCFCA97B-0D8E-7C80-06D2-684CA14063C8}"/>
+                </a:ext>
+              </a:extLst>
+            </p:cNvPr>
+            <p:cNvSpPr/>
+            <p:nvPr/>
+          </p:nvSpPr>
+          <p:spPr>
+            <a:xfrm rot="10800000">
+              <a:off x="6172376" y="2963293"/>
+              <a:ext cx="152402" cy="1250950"/>
+            </a:xfrm>
+            <a:prstGeom prst="triangle">
+              <a:avLst/>
+            </a:prstGeom>
+          </p:spPr>
+          <p:style>
+            <a:lnRef idx="2">
+              <a:schemeClr val="dk1">
+                <a:shade val="50000"/>
+              </a:schemeClr>
+            </a:lnRef>
+            <a:fillRef idx="1">
+              <a:schemeClr val="dk1"/>
+            </a:fillRef>
+            <a:effectRef idx="0">
+              <a:schemeClr val="dk1"/>
+            </a:effectRef>
+            <a:fontRef idx="minor">
+              <a:schemeClr val="lt1"/>
+            </a:fontRef>
+          </p:style>
+          <p:txBody>
+            <a:bodyPr rtlCol="0" anchor="ctr"/>
+            <a:lstStyle/>
+            <a:p>
+              <a:pPr algn="ctr"/>
+              <a:endParaRPr lang="en-US"/>
+            </a:p>
+          </p:txBody>
+        </p:sp>
+        <p:sp>
+          <p:nvSpPr>
+            <p:cNvPr id="19" name="Moon 18">
+              <a:extLst>
+                <a:ext uri="{FF2B5EF4-FFF2-40B4-BE49-F238E27FC236}">
+                  <a16:creationId xmlns:a16="http://schemas.microsoft.com/office/drawing/2014/main" id="{5DFC7713-3DA5-1972-0709-F93537967C67}"/>
+                </a:ext>
+              </a:extLst>
+            </p:cNvPr>
+            <p:cNvSpPr/>
+            <p:nvPr/>
+          </p:nvSpPr>
+          <p:spPr>
+            <a:xfrm rot="16200000">
+              <a:off x="6002331" y="1326503"/>
+              <a:ext cx="482600" cy="1727200"/>
+            </a:xfrm>
+            <a:prstGeom prst="moon">
+              <a:avLst/>
+            </a:prstGeom>
+          </p:spPr>
+          <p:style>
+            <a:lnRef idx="2">
+              <a:schemeClr val="dk1">
+                <a:shade val="50000"/>
+              </a:schemeClr>
+            </a:lnRef>
+            <a:fillRef idx="1">
+              <a:schemeClr val="dk1"/>
+            </a:fillRef>
+            <a:effectRef idx="0">
+              <a:schemeClr val="dk1"/>
+            </a:effectRef>
+            <a:fontRef idx="minor">
+              <a:schemeClr val="lt1"/>
+            </a:fontRef>
+          </p:style>
+          <p:txBody>
+            <a:bodyPr rtlCol="0" anchor="ctr"/>
+            <a:lstStyle/>
+            <a:p>
+              <a:pPr algn="ctr"/>
+              <a:endParaRPr lang="en-US"/>
+            </a:p>
+          </p:txBody>
+        </p:sp>
+      </p:grpSp>
+      <p:grpSp>
+        <p:nvGrpSpPr>
+          <p:cNvPr id="63" name="Group 62">
+            <a:extLst>
+              <a:ext uri="{FF2B5EF4-FFF2-40B4-BE49-F238E27FC236}">
+                <a16:creationId xmlns:a16="http://schemas.microsoft.com/office/drawing/2014/main" id="{EDA4668C-A6C9-9F29-1BEE-74169349C720}"/>
+              </a:ext>
+            </a:extLst>
+          </p:cNvPr>
+          <p:cNvGrpSpPr/>
+          <p:nvPr/>
+        </p:nvGrpSpPr>
+        <p:grpSpPr>
+          <a:xfrm>
+            <a:off x="1944633" y="278608"/>
+            <a:ext cx="1371600" cy="1371600"/>
+            <a:chOff x="427081" y="263129"/>
+            <a:chExt cx="1371600" cy="1371600"/>
+          </a:xfrm>
+        </p:grpSpPr>
+        <p:sp>
+          <p:nvSpPr>
+            <p:cNvPr id="64" name="Rectangle 63">
+              <a:extLst>
+                <a:ext uri="{FF2B5EF4-FFF2-40B4-BE49-F238E27FC236}">
+                  <a16:creationId xmlns:a16="http://schemas.microsoft.com/office/drawing/2014/main" id="{60E49F26-BC07-08BD-7B2E-1FB683E489ED}"/>
+                </a:ext>
+              </a:extLst>
+            </p:cNvPr>
+            <p:cNvSpPr/>
+            <p:nvPr/>
+          </p:nvSpPr>
+          <p:spPr>
+            <a:xfrm>
+              <a:off x="427081" y="263129"/>
+              <a:ext cx="1371600" cy="1371600"/>
+            </a:xfrm>
+            <a:prstGeom prst="rect">
+              <a:avLst/>
+            </a:prstGeom>
+            <a:noFill/>
+            <a:ln w="76200">
+              <a:solidFill>
+                <a:schemeClr val="tx1"/>
+              </a:solidFill>
+            </a:ln>
+          </p:spPr>
+          <p:style>
+            <a:lnRef idx="2">
+              <a:schemeClr val="accent1">
+                <a:shade val="50000"/>
+              </a:schemeClr>
+            </a:lnRef>
+            <a:fillRef idx="1">
+              <a:schemeClr val="accent1"/>
+            </a:fillRef>
+            <a:effectRef idx="0">
+              <a:schemeClr val="accent1"/>
+            </a:effectRef>
+            <a:fontRef idx="minor">
+              <a:schemeClr val="lt1"/>
+            </a:fontRef>
+          </p:style>
+          <p:txBody>
+            <a:bodyPr rtlCol="0" anchor="ctr"/>
+            <a:lstStyle/>
+            <a:p>
+              <a:pPr algn="ctr"/>
+              <a:endParaRPr lang="en-US"/>
+            </a:p>
+          </p:txBody>
+        </p:sp>
+        <p:sp>
+          <p:nvSpPr>
+            <p:cNvPr id="65" name="Plaque 64">
+              <a:extLst>
+                <a:ext uri="{FF2B5EF4-FFF2-40B4-BE49-F238E27FC236}">
+                  <a16:creationId xmlns:a16="http://schemas.microsoft.com/office/drawing/2014/main" id="{15C63D43-8589-2F16-9341-F86DC4EE75BF}"/>
+                </a:ext>
+              </a:extLst>
+            </p:cNvPr>
+            <p:cNvSpPr/>
+            <p:nvPr/>
+          </p:nvSpPr>
+          <p:spPr>
+            <a:xfrm>
+              <a:off x="573033" y="478473"/>
+              <a:ext cx="1097280" cy="1097280"/>
+            </a:xfrm>
+            <a:prstGeom prst="plaque">
+              <a:avLst/>
+            </a:prstGeom>
+            <a:noFill/>
+            <a:ln w="38100" cap="flat" cmpd="sng" algn="ctr">
+              <a:solidFill>
+                <a:schemeClr val="dk1"/>
+              </a:solidFill>
+              <a:prstDash val="solid"/>
+              <a:round/>
+              <a:headEnd type="none" w="med" len="med"/>
+              <a:tailEnd type="none" w="med" len="med"/>
+            </a:ln>
+          </p:spPr>
+          <p:style>
+            <a:lnRef idx="0">
+              <a:scrgbClr r="0" g="0" b="0"/>
+            </a:lnRef>
+            <a:fillRef idx="0">
+              <a:scrgbClr r="0" g="0" b="0"/>
+            </a:fillRef>
+            <a:effectRef idx="0">
+              <a:scrgbClr r="0" g="0" b="0"/>
+            </a:effectRef>
+            <a:fontRef idx="minor">
+              <a:schemeClr val="dk1"/>
+            </a:fontRef>
+          </p:style>
+          <p:txBody>
+            <a:bodyPr rtlCol="0" anchor="ctr"/>
+            <a:lstStyle/>
+            <a:p>
+              <a:pPr algn="ctr"/>
+              <a:endParaRPr lang="en-US"/>
+            </a:p>
+          </p:txBody>
+        </p:sp>
+      </p:grpSp>
+      <p:pic>
+        <p:nvPicPr>
+          <p:cNvPr id="24" name="Picture 23">
+            <a:extLst>
+              <a:ext uri="{FF2B5EF4-FFF2-40B4-BE49-F238E27FC236}">
+                <a16:creationId xmlns:a16="http://schemas.microsoft.com/office/drawing/2014/main" id="{2F2ED8C1-53DF-F73B-F74C-0D7AC6528101}"/>
+              </a:ext>
+            </a:extLst>
+          </p:cNvPr>
+          <p:cNvPicPr>
+            <a:picLocks noChangeAspect="1"/>
+          </p:cNvPicPr>
+          <p:nvPr/>
+        </p:nvPicPr>
+        <p:blipFill>
+          <a:blip r:embed="rId3"/>
+          <a:stretch>
+            <a:fillRect/>
+          </a:stretch>
+        </p:blipFill>
+        <p:spPr>
+          <a:xfrm>
+            <a:off x="2836236" y="813118"/>
+            <a:ext cx="277209" cy="415814"/>
+          </a:xfrm>
+          <a:prstGeom prst="rect">
+            <a:avLst/>
+          </a:prstGeom>
+        </p:spPr>
+      </p:pic>
     </p:spTree>
     <p:extLst>
       <p:ext uri="{BB962C8B-B14F-4D97-AF65-F5344CB8AC3E}">
@@ -20818,6 +21405,1780 @@
           </p:txBody>
         </p:sp>
       </p:grpSp>
+      <p:grpSp>
+        <p:nvGrpSpPr>
+          <p:cNvPr id="99" name="Group 98">
+            <a:extLst>
+              <a:ext uri="{FF2B5EF4-FFF2-40B4-BE49-F238E27FC236}">
+                <a16:creationId xmlns:a16="http://schemas.microsoft.com/office/drawing/2014/main" id="{F11DB8E8-EE35-3D49-409A-FC44766739AA}"/>
+              </a:ext>
+            </a:extLst>
+          </p:cNvPr>
+          <p:cNvGrpSpPr/>
+          <p:nvPr/>
+        </p:nvGrpSpPr>
+        <p:grpSpPr>
+          <a:xfrm>
+            <a:off x="4812983" y="561579"/>
+            <a:ext cx="1371600" cy="1371600"/>
+            <a:chOff x="427081" y="263129"/>
+            <a:chExt cx="1371600" cy="1371600"/>
+          </a:xfrm>
+        </p:grpSpPr>
+        <p:sp>
+          <p:nvSpPr>
+            <p:cNvPr id="102" name="Rectangle 101">
+              <a:extLst>
+                <a:ext uri="{FF2B5EF4-FFF2-40B4-BE49-F238E27FC236}">
+                  <a16:creationId xmlns:a16="http://schemas.microsoft.com/office/drawing/2014/main" id="{4B490ED9-FCA4-4573-99ED-442C37B5CEEF}"/>
+                </a:ext>
+              </a:extLst>
+            </p:cNvPr>
+            <p:cNvSpPr/>
+            <p:nvPr/>
+          </p:nvSpPr>
+          <p:spPr>
+            <a:xfrm>
+              <a:off x="427081" y="263129"/>
+              <a:ext cx="1371600" cy="1371600"/>
+            </a:xfrm>
+            <a:prstGeom prst="rect">
+              <a:avLst/>
+            </a:prstGeom>
+            <a:noFill/>
+            <a:ln w="76200">
+              <a:solidFill>
+                <a:schemeClr val="tx1"/>
+              </a:solidFill>
+            </a:ln>
+          </p:spPr>
+          <p:style>
+            <a:lnRef idx="2">
+              <a:schemeClr val="accent1">
+                <a:shade val="50000"/>
+              </a:schemeClr>
+            </a:lnRef>
+            <a:fillRef idx="1">
+              <a:schemeClr val="accent1"/>
+            </a:fillRef>
+            <a:effectRef idx="0">
+              <a:schemeClr val="accent1"/>
+            </a:effectRef>
+            <a:fontRef idx="minor">
+              <a:schemeClr val="lt1"/>
+            </a:fontRef>
+          </p:style>
+          <p:txBody>
+            <a:bodyPr rtlCol="0" anchor="ctr"/>
+            <a:lstStyle/>
+            <a:p>
+              <a:pPr algn="ctr"/>
+              <a:endParaRPr lang="en-US"/>
+            </a:p>
+          </p:txBody>
+        </p:sp>
+        <p:sp>
+          <p:nvSpPr>
+            <p:cNvPr id="103" name="Plaque 102">
+              <a:extLst>
+                <a:ext uri="{FF2B5EF4-FFF2-40B4-BE49-F238E27FC236}">
+                  <a16:creationId xmlns:a16="http://schemas.microsoft.com/office/drawing/2014/main" id="{8C56A696-8B73-72E8-0B33-501EF34C3DA0}"/>
+                </a:ext>
+              </a:extLst>
+            </p:cNvPr>
+            <p:cNvSpPr/>
+            <p:nvPr/>
+          </p:nvSpPr>
+          <p:spPr>
+            <a:xfrm>
+              <a:off x="573033" y="478473"/>
+              <a:ext cx="1097280" cy="1097280"/>
+            </a:xfrm>
+            <a:prstGeom prst="plaque">
+              <a:avLst/>
+            </a:prstGeom>
+            <a:noFill/>
+            <a:ln w="38100" cap="flat" cmpd="sng" algn="ctr">
+              <a:solidFill>
+                <a:schemeClr val="dk1"/>
+              </a:solidFill>
+              <a:prstDash val="solid"/>
+              <a:round/>
+              <a:headEnd type="none" w="med" len="med"/>
+              <a:tailEnd type="none" w="med" len="med"/>
+            </a:ln>
+          </p:spPr>
+          <p:style>
+            <a:lnRef idx="0">
+              <a:scrgbClr r="0" g="0" b="0"/>
+            </a:lnRef>
+            <a:fillRef idx="0">
+              <a:scrgbClr r="0" g="0" b="0"/>
+            </a:fillRef>
+            <a:effectRef idx="0">
+              <a:scrgbClr r="0" g="0" b="0"/>
+            </a:effectRef>
+            <a:fontRef idx="minor">
+              <a:schemeClr val="dk1"/>
+            </a:fontRef>
+          </p:style>
+          <p:txBody>
+            <a:bodyPr rtlCol="0" anchor="ctr"/>
+            <a:lstStyle/>
+            <a:p>
+              <a:pPr algn="ctr"/>
+              <a:endParaRPr lang="en-US"/>
+            </a:p>
+          </p:txBody>
+        </p:sp>
+      </p:grpSp>
+      <p:grpSp>
+        <p:nvGrpSpPr>
+          <p:cNvPr id="104" name="Group 103">
+            <a:extLst>
+              <a:ext uri="{FF2B5EF4-FFF2-40B4-BE49-F238E27FC236}">
+                <a16:creationId xmlns:a16="http://schemas.microsoft.com/office/drawing/2014/main" id="{344850BE-B9B8-B88E-F156-006BB031DC56}"/>
+              </a:ext>
+            </a:extLst>
+          </p:cNvPr>
+          <p:cNvGrpSpPr/>
+          <p:nvPr/>
+        </p:nvGrpSpPr>
+        <p:grpSpPr>
+          <a:xfrm>
+            <a:off x="5028480" y="893686"/>
+            <a:ext cx="932742" cy="801763"/>
+            <a:chOff x="3387725" y="1634730"/>
+            <a:chExt cx="1466850" cy="1260870"/>
+          </a:xfrm>
+        </p:grpSpPr>
+        <p:sp>
+          <p:nvSpPr>
+            <p:cNvPr id="105" name="Moon 104">
+              <a:extLst>
+                <a:ext uri="{FF2B5EF4-FFF2-40B4-BE49-F238E27FC236}">
+                  <a16:creationId xmlns:a16="http://schemas.microsoft.com/office/drawing/2014/main" id="{5E4ABBEB-6C6C-B442-9BFC-B32F11B97771}"/>
+                </a:ext>
+              </a:extLst>
+            </p:cNvPr>
+            <p:cNvSpPr/>
+            <p:nvPr/>
+          </p:nvSpPr>
+          <p:spPr>
+            <a:xfrm rot="16200000">
+              <a:off x="3873500" y="1651000"/>
+              <a:ext cx="495300" cy="1466850"/>
+            </a:xfrm>
+            <a:prstGeom prst="moon">
+              <a:avLst/>
+            </a:prstGeom>
+          </p:spPr>
+          <p:style>
+            <a:lnRef idx="2">
+              <a:schemeClr val="dk1">
+                <a:shade val="50000"/>
+              </a:schemeClr>
+            </a:lnRef>
+            <a:fillRef idx="1">
+              <a:schemeClr val="dk1"/>
+            </a:fillRef>
+            <a:effectRef idx="0">
+              <a:schemeClr val="dk1"/>
+            </a:effectRef>
+            <a:fontRef idx="minor">
+              <a:schemeClr val="lt1"/>
+            </a:fontRef>
+          </p:style>
+          <p:txBody>
+            <a:bodyPr rtlCol="0" anchor="ctr"/>
+            <a:lstStyle/>
+            <a:p>
+              <a:pPr algn="ctr"/>
+              <a:endParaRPr lang="en-US"/>
+            </a:p>
+          </p:txBody>
+        </p:sp>
+        <p:sp>
+          <p:nvSpPr>
+            <p:cNvPr id="106" name="Rectangle 105">
+              <a:extLst>
+                <a:ext uri="{FF2B5EF4-FFF2-40B4-BE49-F238E27FC236}">
+                  <a16:creationId xmlns:a16="http://schemas.microsoft.com/office/drawing/2014/main" id="{5548C35D-41BC-E62E-C3D1-8FCFE763691A}"/>
+                </a:ext>
+              </a:extLst>
+            </p:cNvPr>
+            <p:cNvSpPr/>
+            <p:nvPr/>
+          </p:nvSpPr>
+          <p:spPr>
+            <a:xfrm>
+              <a:off x="3651250" y="2682875"/>
+              <a:ext cx="939800" cy="212725"/>
+            </a:xfrm>
+            <a:prstGeom prst="rect">
+              <a:avLst/>
+            </a:prstGeom>
+          </p:spPr>
+          <p:style>
+            <a:lnRef idx="2">
+              <a:schemeClr val="dk1">
+                <a:shade val="50000"/>
+              </a:schemeClr>
+            </a:lnRef>
+            <a:fillRef idx="1">
+              <a:schemeClr val="dk1"/>
+            </a:fillRef>
+            <a:effectRef idx="0">
+              <a:schemeClr val="dk1"/>
+            </a:effectRef>
+            <a:fontRef idx="minor">
+              <a:schemeClr val="lt1"/>
+            </a:fontRef>
+          </p:style>
+          <p:txBody>
+            <a:bodyPr rtlCol="0" anchor="ctr"/>
+            <a:lstStyle/>
+            <a:p>
+              <a:pPr algn="ctr"/>
+              <a:endParaRPr lang="en-US"/>
+            </a:p>
+          </p:txBody>
+        </p:sp>
+        <p:sp>
+          <p:nvSpPr>
+            <p:cNvPr id="107" name="Moon 106">
+              <a:extLst>
+                <a:ext uri="{FF2B5EF4-FFF2-40B4-BE49-F238E27FC236}">
+                  <a16:creationId xmlns:a16="http://schemas.microsoft.com/office/drawing/2014/main" id="{7ECF0F48-64CD-379B-838B-3DECE932618F}"/>
+                </a:ext>
+              </a:extLst>
+            </p:cNvPr>
+            <p:cNvSpPr/>
+            <p:nvPr/>
+          </p:nvSpPr>
+          <p:spPr>
+            <a:xfrm rot="5400000">
+              <a:off x="4025900" y="1322786"/>
+              <a:ext cx="190500" cy="814387"/>
+            </a:xfrm>
+            <a:prstGeom prst="moon">
+              <a:avLst/>
+            </a:prstGeom>
+          </p:spPr>
+          <p:style>
+            <a:lnRef idx="2">
+              <a:schemeClr val="dk1">
+                <a:shade val="50000"/>
+              </a:schemeClr>
+            </a:lnRef>
+            <a:fillRef idx="1">
+              <a:schemeClr val="dk1"/>
+            </a:fillRef>
+            <a:effectRef idx="0">
+              <a:schemeClr val="dk1"/>
+            </a:effectRef>
+            <a:fontRef idx="minor">
+              <a:schemeClr val="lt1"/>
+            </a:fontRef>
+          </p:style>
+          <p:txBody>
+            <a:bodyPr rtlCol="0" anchor="ctr"/>
+            <a:lstStyle/>
+            <a:p>
+              <a:pPr algn="ctr"/>
+              <a:endParaRPr lang="en-US"/>
+            </a:p>
+          </p:txBody>
+        </p:sp>
+        <p:sp>
+          <p:nvSpPr>
+            <p:cNvPr id="108" name="Oval 107">
+              <a:extLst>
+                <a:ext uri="{FF2B5EF4-FFF2-40B4-BE49-F238E27FC236}">
+                  <a16:creationId xmlns:a16="http://schemas.microsoft.com/office/drawing/2014/main" id="{6680EE1B-8139-1873-5A63-D46F1DED7F99}"/>
+                </a:ext>
+              </a:extLst>
+            </p:cNvPr>
+            <p:cNvSpPr/>
+            <p:nvPr/>
+          </p:nvSpPr>
+          <p:spPr>
+            <a:xfrm rot="5400000">
+              <a:off x="3919196" y="1788661"/>
+              <a:ext cx="393192" cy="390129"/>
+            </a:xfrm>
+            <a:prstGeom prst="ellipse">
+              <a:avLst/>
+            </a:prstGeom>
+          </p:spPr>
+          <p:style>
+            <a:lnRef idx="2">
+              <a:schemeClr val="dk1"/>
+            </a:lnRef>
+            <a:fillRef idx="1">
+              <a:schemeClr val="lt1"/>
+            </a:fillRef>
+            <a:effectRef idx="0">
+              <a:schemeClr val="dk1"/>
+            </a:effectRef>
+            <a:fontRef idx="minor">
+              <a:schemeClr val="dk1"/>
+            </a:fontRef>
+          </p:style>
+          <p:txBody>
+            <a:bodyPr rtlCol="0" anchor="ctr"/>
+            <a:lstStyle/>
+            <a:p>
+              <a:pPr algn="ctr"/>
+              <a:endParaRPr lang="en-US"/>
+            </a:p>
+          </p:txBody>
+        </p:sp>
+        <p:sp>
+          <p:nvSpPr>
+            <p:cNvPr id="109" name="Moon 108">
+              <a:extLst>
+                <a:ext uri="{FF2B5EF4-FFF2-40B4-BE49-F238E27FC236}">
+                  <a16:creationId xmlns:a16="http://schemas.microsoft.com/office/drawing/2014/main" id="{5A80FCAA-ED70-CC7A-D67C-3DCF76DD8165}"/>
+                </a:ext>
+              </a:extLst>
+            </p:cNvPr>
+            <p:cNvSpPr/>
+            <p:nvPr/>
+          </p:nvSpPr>
+          <p:spPr>
+            <a:xfrm rot="5400000" flipH="1">
+              <a:off x="4025901" y="1830278"/>
+              <a:ext cx="190500" cy="814387"/>
+            </a:xfrm>
+            <a:prstGeom prst="moon">
+              <a:avLst/>
+            </a:prstGeom>
+          </p:spPr>
+          <p:style>
+            <a:lnRef idx="2">
+              <a:schemeClr val="dk1">
+                <a:shade val="50000"/>
+              </a:schemeClr>
+            </a:lnRef>
+            <a:fillRef idx="1">
+              <a:schemeClr val="dk1"/>
+            </a:fillRef>
+            <a:effectRef idx="0">
+              <a:schemeClr val="dk1"/>
+            </a:effectRef>
+            <a:fontRef idx="minor">
+              <a:schemeClr val="lt1"/>
+            </a:fontRef>
+          </p:style>
+          <p:txBody>
+            <a:bodyPr rtlCol="0" anchor="ctr"/>
+            <a:lstStyle/>
+            <a:p>
+              <a:pPr algn="ctr"/>
+              <a:endParaRPr lang="en-US"/>
+            </a:p>
+          </p:txBody>
+        </p:sp>
+        <p:sp>
+          <p:nvSpPr>
+            <p:cNvPr id="110" name="Oval 109">
+              <a:extLst>
+                <a:ext uri="{FF2B5EF4-FFF2-40B4-BE49-F238E27FC236}">
+                  <a16:creationId xmlns:a16="http://schemas.microsoft.com/office/drawing/2014/main" id="{3565B637-E4BD-792D-8380-B415A9C87FB6}"/>
+                </a:ext>
+              </a:extLst>
+            </p:cNvPr>
+            <p:cNvSpPr/>
+            <p:nvPr/>
+          </p:nvSpPr>
+          <p:spPr>
+            <a:xfrm rot="5400000">
+              <a:off x="3978632" y="1843842"/>
+              <a:ext cx="274320" cy="274320"/>
+            </a:xfrm>
+            <a:prstGeom prst="ellipse">
+              <a:avLst/>
+            </a:prstGeom>
+          </p:spPr>
+          <p:style>
+            <a:lnRef idx="2">
+              <a:schemeClr val="dk1">
+                <a:shade val="50000"/>
+              </a:schemeClr>
+            </a:lnRef>
+            <a:fillRef idx="1">
+              <a:schemeClr val="dk1"/>
+            </a:fillRef>
+            <a:effectRef idx="0">
+              <a:schemeClr val="dk1"/>
+            </a:effectRef>
+            <a:fontRef idx="minor">
+              <a:schemeClr val="lt1"/>
+            </a:fontRef>
+          </p:style>
+          <p:txBody>
+            <a:bodyPr rtlCol="0" anchor="ctr"/>
+            <a:lstStyle/>
+            <a:p>
+              <a:pPr algn="ctr"/>
+              <a:endParaRPr lang="en-US"/>
+            </a:p>
+          </p:txBody>
+        </p:sp>
+      </p:grpSp>
+      <p:pic>
+        <p:nvPicPr>
+          <p:cNvPr id="111" name="Picture 110">
+            <a:extLst>
+              <a:ext uri="{FF2B5EF4-FFF2-40B4-BE49-F238E27FC236}">
+                <a16:creationId xmlns:a16="http://schemas.microsoft.com/office/drawing/2014/main" id="{79436266-120D-34F5-3032-FA2C90F7477B}"/>
+              </a:ext>
+            </a:extLst>
+          </p:cNvPr>
+          <p:cNvPicPr>
+            <a:picLocks noChangeAspect="1"/>
+          </p:cNvPicPr>
+          <p:nvPr/>
+        </p:nvPicPr>
+        <p:blipFill>
+          <a:blip r:embed="rId3"/>
+          <a:stretch>
+            <a:fillRect/>
+          </a:stretch>
+        </p:blipFill>
+        <p:spPr>
+          <a:xfrm>
+            <a:off x="6483418" y="1143969"/>
+            <a:ext cx="433388" cy="444277"/>
+          </a:xfrm>
+          <a:prstGeom prst="rect">
+            <a:avLst/>
+          </a:prstGeom>
+        </p:spPr>
+      </p:pic>
+      <p:grpSp>
+        <p:nvGrpSpPr>
+          <p:cNvPr id="112" name="Group 111">
+            <a:extLst>
+              <a:ext uri="{FF2B5EF4-FFF2-40B4-BE49-F238E27FC236}">
+                <a16:creationId xmlns:a16="http://schemas.microsoft.com/office/drawing/2014/main" id="{BEF675C1-49FD-3043-DD0B-02D8BC581AA9}"/>
+              </a:ext>
+            </a:extLst>
+          </p:cNvPr>
+          <p:cNvGrpSpPr/>
+          <p:nvPr/>
+        </p:nvGrpSpPr>
+        <p:grpSpPr>
+          <a:xfrm>
+            <a:off x="6316063" y="565221"/>
+            <a:ext cx="1371600" cy="1371600"/>
+            <a:chOff x="427081" y="263129"/>
+            <a:chExt cx="1371600" cy="1371600"/>
+          </a:xfrm>
+        </p:grpSpPr>
+        <p:sp>
+          <p:nvSpPr>
+            <p:cNvPr id="113" name="Rectangle 112">
+              <a:extLst>
+                <a:ext uri="{FF2B5EF4-FFF2-40B4-BE49-F238E27FC236}">
+                  <a16:creationId xmlns:a16="http://schemas.microsoft.com/office/drawing/2014/main" id="{E0EA321F-0F29-9ACF-0936-8964356B8717}"/>
+                </a:ext>
+              </a:extLst>
+            </p:cNvPr>
+            <p:cNvSpPr/>
+            <p:nvPr/>
+          </p:nvSpPr>
+          <p:spPr>
+            <a:xfrm>
+              <a:off x="427081" y="263129"/>
+              <a:ext cx="1371600" cy="1371600"/>
+            </a:xfrm>
+            <a:prstGeom prst="rect">
+              <a:avLst/>
+            </a:prstGeom>
+            <a:noFill/>
+            <a:ln w="76200">
+              <a:solidFill>
+                <a:schemeClr val="tx1"/>
+              </a:solidFill>
+            </a:ln>
+          </p:spPr>
+          <p:style>
+            <a:lnRef idx="2">
+              <a:schemeClr val="accent1">
+                <a:shade val="50000"/>
+              </a:schemeClr>
+            </a:lnRef>
+            <a:fillRef idx="1">
+              <a:schemeClr val="accent1"/>
+            </a:fillRef>
+            <a:effectRef idx="0">
+              <a:schemeClr val="accent1"/>
+            </a:effectRef>
+            <a:fontRef idx="minor">
+              <a:schemeClr val="lt1"/>
+            </a:fontRef>
+          </p:style>
+          <p:txBody>
+            <a:bodyPr rtlCol="0" anchor="ctr"/>
+            <a:lstStyle/>
+            <a:p>
+              <a:pPr algn="ctr"/>
+              <a:endParaRPr lang="en-US"/>
+            </a:p>
+          </p:txBody>
+        </p:sp>
+        <p:sp>
+          <p:nvSpPr>
+            <p:cNvPr id="114" name="Plaque 113">
+              <a:extLst>
+                <a:ext uri="{FF2B5EF4-FFF2-40B4-BE49-F238E27FC236}">
+                  <a16:creationId xmlns:a16="http://schemas.microsoft.com/office/drawing/2014/main" id="{A0A1451F-7329-6283-78CF-101E83297B9D}"/>
+                </a:ext>
+              </a:extLst>
+            </p:cNvPr>
+            <p:cNvSpPr/>
+            <p:nvPr/>
+          </p:nvSpPr>
+          <p:spPr>
+            <a:xfrm>
+              <a:off x="573033" y="478473"/>
+              <a:ext cx="1097280" cy="1097280"/>
+            </a:xfrm>
+            <a:prstGeom prst="plaque">
+              <a:avLst/>
+            </a:prstGeom>
+            <a:noFill/>
+            <a:ln w="38100" cap="flat" cmpd="sng" algn="ctr">
+              <a:solidFill>
+                <a:schemeClr val="dk1"/>
+              </a:solidFill>
+              <a:prstDash val="solid"/>
+              <a:round/>
+              <a:headEnd type="none" w="med" len="med"/>
+              <a:tailEnd type="none" w="med" len="med"/>
+            </a:ln>
+          </p:spPr>
+          <p:style>
+            <a:lnRef idx="0">
+              <a:scrgbClr r="0" g="0" b="0"/>
+            </a:lnRef>
+            <a:fillRef idx="0">
+              <a:scrgbClr r="0" g="0" b="0"/>
+            </a:fillRef>
+            <a:effectRef idx="0">
+              <a:scrgbClr r="0" g="0" b="0"/>
+            </a:effectRef>
+            <a:fontRef idx="minor">
+              <a:schemeClr val="dk1"/>
+            </a:fontRef>
+          </p:style>
+          <p:txBody>
+            <a:bodyPr rtlCol="0" anchor="ctr"/>
+            <a:lstStyle/>
+            <a:p>
+              <a:pPr algn="ctr"/>
+              <a:endParaRPr lang="en-US"/>
+            </a:p>
+          </p:txBody>
+        </p:sp>
+      </p:grpSp>
+      <p:grpSp>
+        <p:nvGrpSpPr>
+          <p:cNvPr id="115" name="Group 114">
+            <a:extLst>
+              <a:ext uri="{FF2B5EF4-FFF2-40B4-BE49-F238E27FC236}">
+                <a16:creationId xmlns:a16="http://schemas.microsoft.com/office/drawing/2014/main" id="{539B77C6-8303-82EE-0E34-097907BCE64D}"/>
+              </a:ext>
+            </a:extLst>
+          </p:cNvPr>
+          <p:cNvGrpSpPr/>
+          <p:nvPr/>
+        </p:nvGrpSpPr>
+        <p:grpSpPr>
+          <a:xfrm>
+            <a:off x="6908156" y="838411"/>
+            <a:ext cx="441325" cy="1012069"/>
+            <a:chOff x="3248025" y="1009650"/>
+            <a:chExt cx="1390650" cy="3189114"/>
+          </a:xfrm>
+        </p:grpSpPr>
+        <p:sp>
+          <p:nvSpPr>
+            <p:cNvPr id="116" name="Oval 115">
+              <a:extLst>
+                <a:ext uri="{FF2B5EF4-FFF2-40B4-BE49-F238E27FC236}">
+                  <a16:creationId xmlns:a16="http://schemas.microsoft.com/office/drawing/2014/main" id="{CCABD792-2FDA-7827-8E93-864D69CD76BD}"/>
+                </a:ext>
+              </a:extLst>
+            </p:cNvPr>
+            <p:cNvSpPr/>
+            <p:nvPr/>
+          </p:nvSpPr>
+          <p:spPr>
+            <a:xfrm>
+              <a:off x="3549650" y="1009650"/>
+              <a:ext cx="787400" cy="984250"/>
+            </a:xfrm>
+            <a:prstGeom prst="ellipse">
+              <a:avLst/>
+            </a:prstGeom>
+          </p:spPr>
+          <p:style>
+            <a:lnRef idx="2">
+              <a:schemeClr val="dk1">
+                <a:shade val="50000"/>
+              </a:schemeClr>
+            </a:lnRef>
+            <a:fillRef idx="1">
+              <a:schemeClr val="dk1"/>
+            </a:fillRef>
+            <a:effectRef idx="0">
+              <a:schemeClr val="dk1"/>
+            </a:effectRef>
+            <a:fontRef idx="minor">
+              <a:schemeClr val="lt1"/>
+            </a:fontRef>
+          </p:style>
+          <p:txBody>
+            <a:bodyPr rtlCol="0" anchor="ctr"/>
+            <a:lstStyle/>
+            <a:p>
+              <a:pPr algn="ctr"/>
+              <a:endParaRPr lang="en-US"/>
+            </a:p>
+          </p:txBody>
+        </p:sp>
+        <p:sp>
+          <p:nvSpPr>
+            <p:cNvPr id="117" name="Rectangle: Rounded Corners 116">
+              <a:extLst>
+                <a:ext uri="{FF2B5EF4-FFF2-40B4-BE49-F238E27FC236}">
+                  <a16:creationId xmlns:a16="http://schemas.microsoft.com/office/drawing/2014/main" id="{D3B1102E-ED8A-9E8A-036E-AEE12AD8CF5D}"/>
+                </a:ext>
+              </a:extLst>
+            </p:cNvPr>
+            <p:cNvSpPr/>
+            <p:nvPr/>
+          </p:nvSpPr>
+          <p:spPr>
+            <a:xfrm>
+              <a:off x="3600450" y="2051050"/>
+              <a:ext cx="692150" cy="292100"/>
+            </a:xfrm>
+            <a:prstGeom prst="roundRect">
+              <a:avLst/>
+            </a:prstGeom>
+          </p:spPr>
+          <p:style>
+            <a:lnRef idx="2">
+              <a:schemeClr val="dk1">
+                <a:shade val="50000"/>
+              </a:schemeClr>
+            </a:lnRef>
+            <a:fillRef idx="1">
+              <a:schemeClr val="dk1"/>
+            </a:fillRef>
+            <a:effectRef idx="0">
+              <a:schemeClr val="dk1"/>
+            </a:effectRef>
+            <a:fontRef idx="minor">
+              <a:schemeClr val="lt1"/>
+            </a:fontRef>
+          </p:style>
+          <p:txBody>
+            <a:bodyPr rtlCol="0" anchor="ctr"/>
+            <a:lstStyle/>
+            <a:p>
+              <a:pPr algn="ctr"/>
+              <a:endParaRPr lang="en-US"/>
+            </a:p>
+          </p:txBody>
+        </p:sp>
+        <p:grpSp>
+          <p:nvGrpSpPr>
+            <p:cNvPr id="118" name="Group 117">
+              <a:extLst>
+                <a:ext uri="{FF2B5EF4-FFF2-40B4-BE49-F238E27FC236}">
+                  <a16:creationId xmlns:a16="http://schemas.microsoft.com/office/drawing/2014/main" id="{705D1440-C936-92DD-520B-327151D33532}"/>
+                </a:ext>
+              </a:extLst>
+            </p:cNvPr>
+            <p:cNvGrpSpPr/>
+            <p:nvPr/>
+          </p:nvGrpSpPr>
+          <p:grpSpPr>
+            <a:xfrm>
+              <a:off x="4282383" y="2120161"/>
+              <a:ext cx="291335" cy="2073380"/>
+              <a:chOff x="4282383" y="2120161"/>
+              <a:chExt cx="291335" cy="2073380"/>
+            </a:xfrm>
+          </p:grpSpPr>
+          <p:sp>
+            <p:nvSpPr>
+              <p:cNvPr id="126" name="Rectangle 125">
+                <a:extLst>
+                  <a:ext uri="{FF2B5EF4-FFF2-40B4-BE49-F238E27FC236}">
+                    <a16:creationId xmlns:a16="http://schemas.microsoft.com/office/drawing/2014/main" id="{EFC745F0-08C9-D4E6-BFF4-6C2618E0AF3F}"/>
+                  </a:ext>
+                </a:extLst>
+              </p:cNvPr>
+              <p:cNvSpPr/>
+              <p:nvPr/>
+            </p:nvSpPr>
+            <p:spPr>
+              <a:xfrm rot="3958351">
+                <a:off x="3893446" y="2509098"/>
+                <a:ext cx="996950" cy="219075"/>
+              </a:xfrm>
+              <a:prstGeom prst="rect">
+                <a:avLst/>
+              </a:prstGeom>
+            </p:spPr>
+            <p:style>
+              <a:lnRef idx="2">
+                <a:schemeClr val="dk1">
+                  <a:shade val="50000"/>
+                </a:schemeClr>
+              </a:lnRef>
+              <a:fillRef idx="1">
+                <a:schemeClr val="dk1"/>
+              </a:fillRef>
+              <a:effectRef idx="0">
+                <a:schemeClr val="dk1"/>
+              </a:effectRef>
+              <a:fontRef idx="minor">
+                <a:schemeClr val="lt1"/>
+              </a:fontRef>
+            </p:style>
+            <p:txBody>
+              <a:bodyPr rtlCol="0" anchor="ctr"/>
+              <a:lstStyle/>
+              <a:p>
+                <a:pPr algn="ctr"/>
+                <a:endParaRPr lang="en-US"/>
+              </a:p>
+            </p:txBody>
+          </p:sp>
+          <p:sp>
+            <p:nvSpPr>
+              <p:cNvPr id="127" name="Isosceles Triangle 126">
+                <a:extLst>
+                  <a:ext uri="{FF2B5EF4-FFF2-40B4-BE49-F238E27FC236}">
+                    <a16:creationId xmlns:a16="http://schemas.microsoft.com/office/drawing/2014/main" id="{45EE1AE7-D978-91D4-EC1B-BBB3E66D75DA}"/>
+                  </a:ext>
+                </a:extLst>
+              </p:cNvPr>
+              <p:cNvSpPr/>
+              <p:nvPr/>
+            </p:nvSpPr>
+            <p:spPr>
+              <a:xfrm rot="11268472">
+                <a:off x="4421316" y="2942591"/>
+                <a:ext cx="152402" cy="1250950"/>
+              </a:xfrm>
+              <a:prstGeom prst="triangle">
+                <a:avLst/>
+              </a:prstGeom>
+            </p:spPr>
+            <p:style>
+              <a:lnRef idx="2">
+                <a:schemeClr val="dk1">
+                  <a:shade val="50000"/>
+                </a:schemeClr>
+              </a:lnRef>
+              <a:fillRef idx="1">
+                <a:schemeClr val="dk1"/>
+              </a:fillRef>
+              <a:effectRef idx="0">
+                <a:schemeClr val="dk1"/>
+              </a:effectRef>
+              <a:fontRef idx="minor">
+                <a:schemeClr val="lt1"/>
+              </a:fontRef>
+            </p:style>
+            <p:txBody>
+              <a:bodyPr rtlCol="0" anchor="ctr"/>
+              <a:lstStyle/>
+              <a:p>
+                <a:pPr algn="ctr"/>
+                <a:endParaRPr lang="en-US"/>
+              </a:p>
+            </p:txBody>
+          </p:sp>
+        </p:grpSp>
+        <p:grpSp>
+          <p:nvGrpSpPr>
+            <p:cNvPr id="119" name="Group 118">
+              <a:extLst>
+                <a:ext uri="{FF2B5EF4-FFF2-40B4-BE49-F238E27FC236}">
+                  <a16:creationId xmlns:a16="http://schemas.microsoft.com/office/drawing/2014/main" id="{99CA7249-E45C-C3D9-EA78-4EDA9C69BE00}"/>
+                </a:ext>
+              </a:extLst>
+            </p:cNvPr>
+            <p:cNvGrpSpPr/>
+            <p:nvPr/>
+          </p:nvGrpSpPr>
+          <p:grpSpPr>
+            <a:xfrm flipH="1">
+              <a:off x="3309115" y="2124715"/>
+              <a:ext cx="291335" cy="2073380"/>
+              <a:chOff x="4282383" y="2120161"/>
+              <a:chExt cx="291335" cy="2073380"/>
+            </a:xfrm>
+          </p:grpSpPr>
+          <p:sp>
+            <p:nvSpPr>
+              <p:cNvPr id="124" name="Rectangle 123">
+                <a:extLst>
+                  <a:ext uri="{FF2B5EF4-FFF2-40B4-BE49-F238E27FC236}">
+                    <a16:creationId xmlns:a16="http://schemas.microsoft.com/office/drawing/2014/main" id="{48646A6F-8DFD-1D0E-A891-A4FE5EF75AAD}"/>
+                  </a:ext>
+                </a:extLst>
+              </p:cNvPr>
+              <p:cNvSpPr/>
+              <p:nvPr/>
+            </p:nvSpPr>
+            <p:spPr>
+              <a:xfrm rot="3958351">
+                <a:off x="3893446" y="2509098"/>
+                <a:ext cx="996950" cy="219075"/>
+              </a:xfrm>
+              <a:prstGeom prst="rect">
+                <a:avLst/>
+              </a:prstGeom>
+            </p:spPr>
+            <p:style>
+              <a:lnRef idx="2">
+                <a:schemeClr val="dk1">
+                  <a:shade val="50000"/>
+                </a:schemeClr>
+              </a:lnRef>
+              <a:fillRef idx="1">
+                <a:schemeClr val="dk1"/>
+              </a:fillRef>
+              <a:effectRef idx="0">
+                <a:schemeClr val="dk1"/>
+              </a:effectRef>
+              <a:fontRef idx="minor">
+                <a:schemeClr val="lt1"/>
+              </a:fontRef>
+            </p:style>
+            <p:txBody>
+              <a:bodyPr rtlCol="0" anchor="ctr"/>
+              <a:lstStyle/>
+              <a:p>
+                <a:pPr algn="ctr"/>
+                <a:endParaRPr lang="en-US"/>
+              </a:p>
+            </p:txBody>
+          </p:sp>
+          <p:sp>
+            <p:nvSpPr>
+              <p:cNvPr id="125" name="Isosceles Triangle 124">
+                <a:extLst>
+                  <a:ext uri="{FF2B5EF4-FFF2-40B4-BE49-F238E27FC236}">
+                    <a16:creationId xmlns:a16="http://schemas.microsoft.com/office/drawing/2014/main" id="{87BAEFD1-5B6A-FB9D-48E0-4051514343DF}"/>
+                  </a:ext>
+                </a:extLst>
+              </p:cNvPr>
+              <p:cNvSpPr/>
+              <p:nvPr/>
+            </p:nvSpPr>
+            <p:spPr>
+              <a:xfrm rot="11268472">
+                <a:off x="4421316" y="2942591"/>
+                <a:ext cx="152402" cy="1250950"/>
+              </a:xfrm>
+              <a:prstGeom prst="triangle">
+                <a:avLst/>
+              </a:prstGeom>
+            </p:spPr>
+            <p:style>
+              <a:lnRef idx="2">
+                <a:schemeClr val="dk1">
+                  <a:shade val="50000"/>
+                </a:schemeClr>
+              </a:lnRef>
+              <a:fillRef idx="1">
+                <a:schemeClr val="dk1"/>
+              </a:fillRef>
+              <a:effectRef idx="0">
+                <a:schemeClr val="dk1"/>
+              </a:effectRef>
+              <a:fontRef idx="minor">
+                <a:schemeClr val="lt1"/>
+              </a:fontRef>
+            </p:style>
+            <p:txBody>
+              <a:bodyPr rtlCol="0" anchor="ctr"/>
+              <a:lstStyle/>
+              <a:p>
+                <a:pPr algn="ctr"/>
+                <a:endParaRPr lang="en-US"/>
+              </a:p>
+            </p:txBody>
+          </p:sp>
+        </p:grpSp>
+        <p:sp>
+          <p:nvSpPr>
+            <p:cNvPr id="120" name="Rectangle 119">
+              <a:extLst>
+                <a:ext uri="{FF2B5EF4-FFF2-40B4-BE49-F238E27FC236}">
+                  <a16:creationId xmlns:a16="http://schemas.microsoft.com/office/drawing/2014/main" id="{F39ABCC3-247B-DCB6-D696-2F3371B30E28}"/>
+                </a:ext>
+              </a:extLst>
+            </p:cNvPr>
+            <p:cNvSpPr/>
+            <p:nvPr/>
+          </p:nvSpPr>
+          <p:spPr>
+            <a:xfrm rot="5400000">
+              <a:off x="3441937" y="2586038"/>
+              <a:ext cx="996950" cy="219075"/>
+            </a:xfrm>
+            <a:prstGeom prst="rect">
+              <a:avLst/>
+            </a:prstGeom>
+          </p:spPr>
+          <p:style>
+            <a:lnRef idx="2">
+              <a:schemeClr val="dk1">
+                <a:shade val="50000"/>
+              </a:schemeClr>
+            </a:lnRef>
+            <a:fillRef idx="1">
+              <a:schemeClr val="dk1"/>
+            </a:fillRef>
+            <a:effectRef idx="0">
+              <a:schemeClr val="dk1"/>
+            </a:effectRef>
+            <a:fontRef idx="minor">
+              <a:schemeClr val="lt1"/>
+            </a:fontRef>
+          </p:style>
+          <p:txBody>
+            <a:bodyPr rtlCol="0" anchor="ctr"/>
+            <a:lstStyle/>
+            <a:p>
+              <a:pPr algn="ctr"/>
+              <a:endParaRPr lang="en-US"/>
+            </a:p>
+          </p:txBody>
+        </p:sp>
+        <p:sp>
+          <p:nvSpPr>
+            <p:cNvPr id="121" name="Isosceles Triangle 120">
+              <a:extLst>
+                <a:ext uri="{FF2B5EF4-FFF2-40B4-BE49-F238E27FC236}">
+                  <a16:creationId xmlns:a16="http://schemas.microsoft.com/office/drawing/2014/main" id="{FF5FE758-D19C-43CE-63D7-A683DFCEE47A}"/>
+                </a:ext>
+              </a:extLst>
+            </p:cNvPr>
+            <p:cNvSpPr/>
+            <p:nvPr/>
+          </p:nvSpPr>
+          <p:spPr>
+            <a:xfrm rot="10800000">
+              <a:off x="3869157" y="2947814"/>
+              <a:ext cx="152402" cy="1250950"/>
+            </a:xfrm>
+            <a:prstGeom prst="triangle">
+              <a:avLst/>
+            </a:prstGeom>
+          </p:spPr>
+          <p:style>
+            <a:lnRef idx="2">
+              <a:schemeClr val="dk1">
+                <a:shade val="50000"/>
+              </a:schemeClr>
+            </a:lnRef>
+            <a:fillRef idx="1">
+              <a:schemeClr val="dk1"/>
+            </a:fillRef>
+            <a:effectRef idx="0">
+              <a:schemeClr val="dk1"/>
+            </a:effectRef>
+            <a:fontRef idx="minor">
+              <a:schemeClr val="lt1"/>
+            </a:fontRef>
+          </p:style>
+          <p:txBody>
+            <a:bodyPr rtlCol="0" anchor="ctr"/>
+            <a:lstStyle/>
+            <a:p>
+              <a:pPr algn="ctr"/>
+              <a:endParaRPr lang="en-US"/>
+            </a:p>
+          </p:txBody>
+        </p:sp>
+        <p:sp>
+          <p:nvSpPr>
+            <p:cNvPr id="122" name="Rectangle 121">
+              <a:extLst>
+                <a:ext uri="{FF2B5EF4-FFF2-40B4-BE49-F238E27FC236}">
+                  <a16:creationId xmlns:a16="http://schemas.microsoft.com/office/drawing/2014/main" id="{5E3A751D-E390-B0CE-CE91-3372421EA670}"/>
+                </a:ext>
+              </a:extLst>
+            </p:cNvPr>
+            <p:cNvSpPr/>
+            <p:nvPr/>
+          </p:nvSpPr>
+          <p:spPr>
+            <a:xfrm>
+              <a:off x="3248025" y="1227137"/>
+              <a:ext cx="215900" cy="766763"/>
+            </a:xfrm>
+            <a:prstGeom prst="rect">
+              <a:avLst/>
+            </a:prstGeom>
+          </p:spPr>
+          <p:style>
+            <a:lnRef idx="2">
+              <a:schemeClr val="dk1"/>
+            </a:lnRef>
+            <a:fillRef idx="1">
+              <a:schemeClr val="lt1"/>
+            </a:fillRef>
+            <a:effectRef idx="0">
+              <a:schemeClr val="dk1"/>
+            </a:effectRef>
+            <a:fontRef idx="minor">
+              <a:schemeClr val="dk1"/>
+            </a:fontRef>
+          </p:style>
+          <p:txBody>
+            <a:bodyPr rtlCol="0" anchor="ctr"/>
+            <a:lstStyle/>
+            <a:p>
+              <a:pPr algn="ctr"/>
+              <a:endParaRPr lang="en-US"/>
+            </a:p>
+          </p:txBody>
+        </p:sp>
+        <p:sp>
+          <p:nvSpPr>
+            <p:cNvPr id="123" name="Rectangle 122">
+              <a:extLst>
+                <a:ext uri="{FF2B5EF4-FFF2-40B4-BE49-F238E27FC236}">
+                  <a16:creationId xmlns:a16="http://schemas.microsoft.com/office/drawing/2014/main" id="{6684F01C-868A-46F1-C59D-147B79A345FD}"/>
+                </a:ext>
+              </a:extLst>
+            </p:cNvPr>
+            <p:cNvSpPr/>
+            <p:nvPr/>
+          </p:nvSpPr>
+          <p:spPr>
+            <a:xfrm>
+              <a:off x="4422775" y="1227136"/>
+              <a:ext cx="215900" cy="766764"/>
+            </a:xfrm>
+            <a:prstGeom prst="rect">
+              <a:avLst/>
+            </a:prstGeom>
+          </p:spPr>
+          <p:style>
+            <a:lnRef idx="2">
+              <a:schemeClr val="dk1"/>
+            </a:lnRef>
+            <a:fillRef idx="1">
+              <a:schemeClr val="lt1"/>
+            </a:fillRef>
+            <a:effectRef idx="0">
+              <a:schemeClr val="dk1"/>
+            </a:effectRef>
+            <a:fontRef idx="minor">
+              <a:schemeClr val="dk1"/>
+            </a:fontRef>
+          </p:style>
+          <p:txBody>
+            <a:bodyPr rtlCol="0" anchor="ctr"/>
+            <a:lstStyle/>
+            <a:p>
+              <a:pPr algn="ctr"/>
+              <a:endParaRPr lang="en-US"/>
+            </a:p>
+          </p:txBody>
+        </p:sp>
+      </p:grpSp>
+      <p:grpSp>
+        <p:nvGrpSpPr>
+          <p:cNvPr id="128" name="Group 127">
+            <a:extLst>
+              <a:ext uri="{FF2B5EF4-FFF2-40B4-BE49-F238E27FC236}">
+                <a16:creationId xmlns:a16="http://schemas.microsoft.com/office/drawing/2014/main" id="{61FE4039-9F6C-0F3B-B9F5-4DFB51F1C2DD}"/>
+              </a:ext>
+            </a:extLst>
+          </p:cNvPr>
+          <p:cNvGrpSpPr/>
+          <p:nvPr/>
+        </p:nvGrpSpPr>
+        <p:grpSpPr>
+          <a:xfrm>
+            <a:off x="8185405" y="850161"/>
+            <a:ext cx="502920" cy="1014984"/>
+            <a:chOff x="5380031" y="966102"/>
+            <a:chExt cx="1727200" cy="3248141"/>
+          </a:xfrm>
+        </p:grpSpPr>
+        <p:sp>
+          <p:nvSpPr>
+            <p:cNvPr id="129" name="Moon 128">
+              <a:extLst>
+                <a:ext uri="{FF2B5EF4-FFF2-40B4-BE49-F238E27FC236}">
+                  <a16:creationId xmlns:a16="http://schemas.microsoft.com/office/drawing/2014/main" id="{8DDEF991-F11D-8A27-4175-D37941E0CB22}"/>
+                </a:ext>
+              </a:extLst>
+            </p:cNvPr>
+            <p:cNvSpPr/>
+            <p:nvPr/>
+          </p:nvSpPr>
+          <p:spPr>
+            <a:xfrm rot="19627358">
+              <a:off x="5549196" y="966102"/>
+              <a:ext cx="450850" cy="984250"/>
+            </a:xfrm>
+            <a:prstGeom prst="moon">
+              <a:avLst/>
+            </a:prstGeom>
+          </p:spPr>
+          <p:style>
+            <a:lnRef idx="2">
+              <a:schemeClr val="dk1"/>
+            </a:lnRef>
+            <a:fillRef idx="1">
+              <a:schemeClr val="lt1"/>
+            </a:fillRef>
+            <a:effectRef idx="0">
+              <a:schemeClr val="dk1"/>
+            </a:effectRef>
+            <a:fontRef idx="minor">
+              <a:schemeClr val="dk1"/>
+            </a:fontRef>
+          </p:style>
+          <p:txBody>
+            <a:bodyPr rtlCol="0" anchor="ctr"/>
+            <a:lstStyle/>
+            <a:p>
+              <a:pPr algn="ctr"/>
+              <a:endParaRPr lang="en-US"/>
+            </a:p>
+          </p:txBody>
+        </p:sp>
+        <p:sp>
+          <p:nvSpPr>
+            <p:cNvPr id="130" name="Moon 129">
+              <a:extLst>
+                <a:ext uri="{FF2B5EF4-FFF2-40B4-BE49-F238E27FC236}">
+                  <a16:creationId xmlns:a16="http://schemas.microsoft.com/office/drawing/2014/main" id="{C7B09D35-7F15-B3EC-FED3-3129F20C173D}"/>
+                </a:ext>
+              </a:extLst>
+            </p:cNvPr>
+            <p:cNvSpPr/>
+            <p:nvPr/>
+          </p:nvSpPr>
+          <p:spPr>
+            <a:xfrm rot="1972642" flipH="1">
+              <a:off x="6518602" y="966104"/>
+              <a:ext cx="450850" cy="984250"/>
+            </a:xfrm>
+            <a:prstGeom prst="moon">
+              <a:avLst/>
+            </a:prstGeom>
+          </p:spPr>
+          <p:style>
+            <a:lnRef idx="2">
+              <a:schemeClr val="dk1"/>
+            </a:lnRef>
+            <a:fillRef idx="1">
+              <a:schemeClr val="lt1"/>
+            </a:fillRef>
+            <a:effectRef idx="0">
+              <a:schemeClr val="dk1"/>
+            </a:effectRef>
+            <a:fontRef idx="minor">
+              <a:schemeClr val="dk1"/>
+            </a:fontRef>
+          </p:style>
+          <p:txBody>
+            <a:bodyPr rtlCol="0" anchor="ctr"/>
+            <a:lstStyle/>
+            <a:p>
+              <a:pPr algn="ctr"/>
+              <a:endParaRPr lang="en-US"/>
+            </a:p>
+          </p:txBody>
+        </p:sp>
+        <p:sp>
+          <p:nvSpPr>
+            <p:cNvPr id="131" name="Oval 130">
+              <a:extLst>
+                <a:ext uri="{FF2B5EF4-FFF2-40B4-BE49-F238E27FC236}">
+                  <a16:creationId xmlns:a16="http://schemas.microsoft.com/office/drawing/2014/main" id="{DC5E7395-5F99-9EA9-C394-AB96EEF0000A}"/>
+                </a:ext>
+              </a:extLst>
+            </p:cNvPr>
+            <p:cNvSpPr/>
+            <p:nvPr/>
+          </p:nvSpPr>
+          <p:spPr>
+            <a:xfrm>
+              <a:off x="5852869" y="1025129"/>
+              <a:ext cx="787400" cy="984250"/>
+            </a:xfrm>
+            <a:prstGeom prst="ellipse">
+              <a:avLst/>
+            </a:prstGeom>
+          </p:spPr>
+          <p:style>
+            <a:lnRef idx="2">
+              <a:schemeClr val="dk1">
+                <a:shade val="50000"/>
+              </a:schemeClr>
+            </a:lnRef>
+            <a:fillRef idx="1">
+              <a:schemeClr val="dk1"/>
+            </a:fillRef>
+            <a:effectRef idx="0">
+              <a:schemeClr val="dk1"/>
+            </a:effectRef>
+            <a:fontRef idx="minor">
+              <a:schemeClr val="lt1"/>
+            </a:fontRef>
+          </p:style>
+          <p:txBody>
+            <a:bodyPr rtlCol="0" anchor="ctr"/>
+            <a:lstStyle/>
+            <a:p>
+              <a:pPr algn="ctr"/>
+              <a:endParaRPr lang="en-US"/>
+            </a:p>
+          </p:txBody>
+        </p:sp>
+        <p:grpSp>
+          <p:nvGrpSpPr>
+            <p:cNvPr id="132" name="Group 131">
+              <a:extLst>
+                <a:ext uri="{FF2B5EF4-FFF2-40B4-BE49-F238E27FC236}">
+                  <a16:creationId xmlns:a16="http://schemas.microsoft.com/office/drawing/2014/main" id="{DB435DA5-3DDB-1AC2-1654-04F749C61787}"/>
+                </a:ext>
+              </a:extLst>
+            </p:cNvPr>
+            <p:cNvGrpSpPr/>
+            <p:nvPr/>
+          </p:nvGrpSpPr>
+          <p:grpSpPr>
+            <a:xfrm>
+              <a:off x="6585602" y="2135640"/>
+              <a:ext cx="291335" cy="2073380"/>
+              <a:chOff x="4282383" y="2120161"/>
+              <a:chExt cx="291335" cy="2073380"/>
+            </a:xfrm>
+          </p:grpSpPr>
+          <p:sp>
+            <p:nvSpPr>
+              <p:cNvPr id="139" name="Rectangle 138">
+                <a:extLst>
+                  <a:ext uri="{FF2B5EF4-FFF2-40B4-BE49-F238E27FC236}">
+                    <a16:creationId xmlns:a16="http://schemas.microsoft.com/office/drawing/2014/main" id="{2D8B5AB9-88C1-EF34-7A2C-039F754A5857}"/>
+                  </a:ext>
+                </a:extLst>
+              </p:cNvPr>
+              <p:cNvSpPr/>
+              <p:nvPr/>
+            </p:nvSpPr>
+            <p:spPr>
+              <a:xfrm rot="3958351">
+                <a:off x="3893446" y="2509098"/>
+                <a:ext cx="996950" cy="219075"/>
+              </a:xfrm>
+              <a:prstGeom prst="rect">
+                <a:avLst/>
+              </a:prstGeom>
+            </p:spPr>
+            <p:style>
+              <a:lnRef idx="2">
+                <a:schemeClr val="dk1">
+                  <a:shade val="50000"/>
+                </a:schemeClr>
+              </a:lnRef>
+              <a:fillRef idx="1">
+                <a:schemeClr val="dk1"/>
+              </a:fillRef>
+              <a:effectRef idx="0">
+                <a:schemeClr val="dk1"/>
+              </a:effectRef>
+              <a:fontRef idx="minor">
+                <a:schemeClr val="lt1"/>
+              </a:fontRef>
+            </p:style>
+            <p:txBody>
+              <a:bodyPr rtlCol="0" anchor="ctr"/>
+              <a:lstStyle/>
+              <a:p>
+                <a:pPr algn="ctr"/>
+                <a:endParaRPr lang="en-US"/>
+              </a:p>
+            </p:txBody>
+          </p:sp>
+          <p:sp>
+            <p:nvSpPr>
+              <p:cNvPr id="140" name="Isosceles Triangle 139">
+                <a:extLst>
+                  <a:ext uri="{FF2B5EF4-FFF2-40B4-BE49-F238E27FC236}">
+                    <a16:creationId xmlns:a16="http://schemas.microsoft.com/office/drawing/2014/main" id="{52F91A51-5B0D-2458-CE0B-D24E9A7D5581}"/>
+                  </a:ext>
+                </a:extLst>
+              </p:cNvPr>
+              <p:cNvSpPr/>
+              <p:nvPr/>
+            </p:nvSpPr>
+            <p:spPr>
+              <a:xfrm rot="11268472">
+                <a:off x="4421316" y="2942591"/>
+                <a:ext cx="152402" cy="1250950"/>
+              </a:xfrm>
+              <a:prstGeom prst="triangle">
+                <a:avLst/>
+              </a:prstGeom>
+            </p:spPr>
+            <p:style>
+              <a:lnRef idx="2">
+                <a:schemeClr val="dk1">
+                  <a:shade val="50000"/>
+                </a:schemeClr>
+              </a:lnRef>
+              <a:fillRef idx="1">
+                <a:schemeClr val="dk1"/>
+              </a:fillRef>
+              <a:effectRef idx="0">
+                <a:schemeClr val="dk1"/>
+              </a:effectRef>
+              <a:fontRef idx="minor">
+                <a:schemeClr val="lt1"/>
+              </a:fontRef>
+            </p:style>
+            <p:txBody>
+              <a:bodyPr rtlCol="0" anchor="ctr"/>
+              <a:lstStyle/>
+              <a:p>
+                <a:pPr algn="ctr"/>
+                <a:endParaRPr lang="en-US"/>
+              </a:p>
+            </p:txBody>
+          </p:sp>
+        </p:grpSp>
+        <p:grpSp>
+          <p:nvGrpSpPr>
+            <p:cNvPr id="133" name="Group 132">
+              <a:extLst>
+                <a:ext uri="{FF2B5EF4-FFF2-40B4-BE49-F238E27FC236}">
+                  <a16:creationId xmlns:a16="http://schemas.microsoft.com/office/drawing/2014/main" id="{E9B745D0-6FD1-62FE-D9B0-6E9D994400AF}"/>
+                </a:ext>
+              </a:extLst>
+            </p:cNvPr>
+            <p:cNvGrpSpPr/>
+            <p:nvPr/>
+          </p:nvGrpSpPr>
+          <p:grpSpPr>
+            <a:xfrm flipH="1">
+              <a:off x="5612334" y="2140194"/>
+              <a:ext cx="291335" cy="2073380"/>
+              <a:chOff x="4282383" y="2120161"/>
+              <a:chExt cx="291335" cy="2073380"/>
+            </a:xfrm>
+          </p:grpSpPr>
+          <p:sp>
+            <p:nvSpPr>
+              <p:cNvPr id="137" name="Rectangle 136">
+                <a:extLst>
+                  <a:ext uri="{FF2B5EF4-FFF2-40B4-BE49-F238E27FC236}">
+                    <a16:creationId xmlns:a16="http://schemas.microsoft.com/office/drawing/2014/main" id="{3F3411FB-E562-047A-4276-7E00D086B6D3}"/>
+                  </a:ext>
+                </a:extLst>
+              </p:cNvPr>
+              <p:cNvSpPr/>
+              <p:nvPr/>
+            </p:nvSpPr>
+            <p:spPr>
+              <a:xfrm rot="3958351">
+                <a:off x="3893446" y="2509098"/>
+                <a:ext cx="996950" cy="219075"/>
+              </a:xfrm>
+              <a:prstGeom prst="rect">
+                <a:avLst/>
+              </a:prstGeom>
+            </p:spPr>
+            <p:style>
+              <a:lnRef idx="2">
+                <a:schemeClr val="dk1">
+                  <a:shade val="50000"/>
+                </a:schemeClr>
+              </a:lnRef>
+              <a:fillRef idx="1">
+                <a:schemeClr val="dk1"/>
+              </a:fillRef>
+              <a:effectRef idx="0">
+                <a:schemeClr val="dk1"/>
+              </a:effectRef>
+              <a:fontRef idx="minor">
+                <a:schemeClr val="lt1"/>
+              </a:fontRef>
+            </p:style>
+            <p:txBody>
+              <a:bodyPr rtlCol="0" anchor="ctr"/>
+              <a:lstStyle/>
+              <a:p>
+                <a:pPr algn="ctr"/>
+                <a:endParaRPr lang="en-US"/>
+              </a:p>
+            </p:txBody>
+          </p:sp>
+          <p:sp>
+            <p:nvSpPr>
+              <p:cNvPr id="138" name="Isosceles Triangle 137">
+                <a:extLst>
+                  <a:ext uri="{FF2B5EF4-FFF2-40B4-BE49-F238E27FC236}">
+                    <a16:creationId xmlns:a16="http://schemas.microsoft.com/office/drawing/2014/main" id="{E0590651-B38F-9EA0-51A2-93AB851DACAD}"/>
+                  </a:ext>
+                </a:extLst>
+              </p:cNvPr>
+              <p:cNvSpPr/>
+              <p:nvPr/>
+            </p:nvSpPr>
+            <p:spPr>
+              <a:xfrm rot="11268472">
+                <a:off x="4421316" y="2942591"/>
+                <a:ext cx="152402" cy="1250950"/>
+              </a:xfrm>
+              <a:prstGeom prst="triangle">
+                <a:avLst/>
+              </a:prstGeom>
+            </p:spPr>
+            <p:style>
+              <a:lnRef idx="2">
+                <a:schemeClr val="dk1">
+                  <a:shade val="50000"/>
+                </a:schemeClr>
+              </a:lnRef>
+              <a:fillRef idx="1">
+                <a:schemeClr val="dk1"/>
+              </a:fillRef>
+              <a:effectRef idx="0">
+                <a:schemeClr val="dk1"/>
+              </a:effectRef>
+              <a:fontRef idx="minor">
+                <a:schemeClr val="lt1"/>
+              </a:fontRef>
+            </p:style>
+            <p:txBody>
+              <a:bodyPr rtlCol="0" anchor="ctr"/>
+              <a:lstStyle/>
+              <a:p>
+                <a:pPr algn="ctr"/>
+                <a:endParaRPr lang="en-US"/>
+              </a:p>
+            </p:txBody>
+          </p:sp>
+        </p:grpSp>
+        <p:sp>
+          <p:nvSpPr>
+            <p:cNvPr id="134" name="Rectangle 133">
+              <a:extLst>
+                <a:ext uri="{FF2B5EF4-FFF2-40B4-BE49-F238E27FC236}">
+                  <a16:creationId xmlns:a16="http://schemas.microsoft.com/office/drawing/2014/main" id="{04FB4227-1C85-B0D9-4FC1-23BCB0028BA4}"/>
+                </a:ext>
+              </a:extLst>
+            </p:cNvPr>
+            <p:cNvSpPr/>
+            <p:nvPr/>
+          </p:nvSpPr>
+          <p:spPr>
+            <a:xfrm rot="5400000">
+              <a:off x="5745156" y="2601517"/>
+              <a:ext cx="996950" cy="219075"/>
+            </a:xfrm>
+            <a:prstGeom prst="rect">
+              <a:avLst/>
+            </a:prstGeom>
+          </p:spPr>
+          <p:style>
+            <a:lnRef idx="2">
+              <a:schemeClr val="dk1">
+                <a:shade val="50000"/>
+              </a:schemeClr>
+            </a:lnRef>
+            <a:fillRef idx="1">
+              <a:schemeClr val="dk1"/>
+            </a:fillRef>
+            <a:effectRef idx="0">
+              <a:schemeClr val="dk1"/>
+            </a:effectRef>
+            <a:fontRef idx="minor">
+              <a:schemeClr val="lt1"/>
+            </a:fontRef>
+          </p:style>
+          <p:txBody>
+            <a:bodyPr rtlCol="0" anchor="ctr"/>
+            <a:lstStyle/>
+            <a:p>
+              <a:pPr algn="ctr"/>
+              <a:endParaRPr lang="en-US"/>
+            </a:p>
+          </p:txBody>
+        </p:sp>
+        <p:sp>
+          <p:nvSpPr>
+            <p:cNvPr id="135" name="Isosceles Triangle 134">
+              <a:extLst>
+                <a:ext uri="{FF2B5EF4-FFF2-40B4-BE49-F238E27FC236}">
+                  <a16:creationId xmlns:a16="http://schemas.microsoft.com/office/drawing/2014/main" id="{A668C68C-83EB-2D4C-1A77-115B8ADA7B91}"/>
+                </a:ext>
+              </a:extLst>
+            </p:cNvPr>
+            <p:cNvSpPr/>
+            <p:nvPr/>
+          </p:nvSpPr>
+          <p:spPr>
+            <a:xfrm rot="10800000">
+              <a:off x="6172376" y="2963293"/>
+              <a:ext cx="152402" cy="1250950"/>
+            </a:xfrm>
+            <a:prstGeom prst="triangle">
+              <a:avLst/>
+            </a:prstGeom>
+          </p:spPr>
+          <p:style>
+            <a:lnRef idx="2">
+              <a:schemeClr val="dk1">
+                <a:shade val="50000"/>
+              </a:schemeClr>
+            </a:lnRef>
+            <a:fillRef idx="1">
+              <a:schemeClr val="dk1"/>
+            </a:fillRef>
+            <a:effectRef idx="0">
+              <a:schemeClr val="dk1"/>
+            </a:effectRef>
+            <a:fontRef idx="minor">
+              <a:schemeClr val="lt1"/>
+            </a:fontRef>
+          </p:style>
+          <p:txBody>
+            <a:bodyPr rtlCol="0" anchor="ctr"/>
+            <a:lstStyle/>
+            <a:p>
+              <a:pPr algn="ctr"/>
+              <a:endParaRPr lang="en-US"/>
+            </a:p>
+          </p:txBody>
+        </p:sp>
+        <p:sp>
+          <p:nvSpPr>
+            <p:cNvPr id="136" name="Moon 135">
+              <a:extLst>
+                <a:ext uri="{FF2B5EF4-FFF2-40B4-BE49-F238E27FC236}">
+                  <a16:creationId xmlns:a16="http://schemas.microsoft.com/office/drawing/2014/main" id="{4B78DC09-4993-05F0-89D8-43515C7EDD76}"/>
+                </a:ext>
+              </a:extLst>
+            </p:cNvPr>
+            <p:cNvSpPr/>
+            <p:nvPr/>
+          </p:nvSpPr>
+          <p:spPr>
+            <a:xfrm rot="16200000">
+              <a:off x="6002331" y="1326503"/>
+              <a:ext cx="482600" cy="1727200"/>
+            </a:xfrm>
+            <a:prstGeom prst="moon">
+              <a:avLst/>
+            </a:prstGeom>
+          </p:spPr>
+          <p:style>
+            <a:lnRef idx="2">
+              <a:schemeClr val="dk1">
+                <a:shade val="50000"/>
+              </a:schemeClr>
+            </a:lnRef>
+            <a:fillRef idx="1">
+              <a:schemeClr val="dk1"/>
+            </a:fillRef>
+            <a:effectRef idx="0">
+              <a:schemeClr val="dk1"/>
+            </a:effectRef>
+            <a:fontRef idx="minor">
+              <a:schemeClr val="lt1"/>
+            </a:fontRef>
+          </p:style>
+          <p:txBody>
+            <a:bodyPr rtlCol="0" anchor="ctr"/>
+            <a:lstStyle/>
+            <a:p>
+              <a:pPr algn="ctr"/>
+              <a:endParaRPr lang="en-US"/>
+            </a:p>
+          </p:txBody>
+        </p:sp>
+      </p:grpSp>
+      <p:grpSp>
+        <p:nvGrpSpPr>
+          <p:cNvPr id="141" name="Group 140">
+            <a:extLst>
+              <a:ext uri="{FF2B5EF4-FFF2-40B4-BE49-F238E27FC236}">
+                <a16:creationId xmlns:a16="http://schemas.microsoft.com/office/drawing/2014/main" id="{F1CCEF7B-5E54-1244-C1B1-926CDB930713}"/>
+              </a:ext>
+            </a:extLst>
+          </p:cNvPr>
+          <p:cNvGrpSpPr/>
+          <p:nvPr/>
+        </p:nvGrpSpPr>
+        <p:grpSpPr>
+          <a:xfrm>
+            <a:off x="7833615" y="580700"/>
+            <a:ext cx="1371600" cy="1371600"/>
+            <a:chOff x="427081" y="263129"/>
+            <a:chExt cx="1371600" cy="1371600"/>
+          </a:xfrm>
+        </p:grpSpPr>
+        <p:sp>
+          <p:nvSpPr>
+            <p:cNvPr id="142" name="Rectangle 141">
+              <a:extLst>
+                <a:ext uri="{FF2B5EF4-FFF2-40B4-BE49-F238E27FC236}">
+                  <a16:creationId xmlns:a16="http://schemas.microsoft.com/office/drawing/2014/main" id="{7E99B9E7-0D24-D05E-E503-BABA5320C10A}"/>
+                </a:ext>
+              </a:extLst>
+            </p:cNvPr>
+            <p:cNvSpPr/>
+            <p:nvPr/>
+          </p:nvSpPr>
+          <p:spPr>
+            <a:xfrm>
+              <a:off x="427081" y="263129"/>
+              <a:ext cx="1371600" cy="1371600"/>
+            </a:xfrm>
+            <a:prstGeom prst="rect">
+              <a:avLst/>
+            </a:prstGeom>
+            <a:noFill/>
+            <a:ln w="76200">
+              <a:solidFill>
+                <a:schemeClr val="tx1"/>
+              </a:solidFill>
+            </a:ln>
+          </p:spPr>
+          <p:style>
+            <a:lnRef idx="2">
+              <a:schemeClr val="accent1">
+                <a:shade val="50000"/>
+              </a:schemeClr>
+            </a:lnRef>
+            <a:fillRef idx="1">
+              <a:schemeClr val="accent1"/>
+            </a:fillRef>
+            <a:effectRef idx="0">
+              <a:schemeClr val="accent1"/>
+            </a:effectRef>
+            <a:fontRef idx="minor">
+              <a:schemeClr val="lt1"/>
+            </a:fontRef>
+          </p:style>
+          <p:txBody>
+            <a:bodyPr rtlCol="0" anchor="ctr"/>
+            <a:lstStyle/>
+            <a:p>
+              <a:pPr algn="ctr"/>
+              <a:endParaRPr lang="en-US"/>
+            </a:p>
+          </p:txBody>
+        </p:sp>
+        <p:sp>
+          <p:nvSpPr>
+            <p:cNvPr id="143" name="Plaque 142">
+              <a:extLst>
+                <a:ext uri="{FF2B5EF4-FFF2-40B4-BE49-F238E27FC236}">
+                  <a16:creationId xmlns:a16="http://schemas.microsoft.com/office/drawing/2014/main" id="{3EEA1C03-1FCF-F490-764A-9B0A86A049BC}"/>
+                </a:ext>
+              </a:extLst>
+            </p:cNvPr>
+            <p:cNvSpPr/>
+            <p:nvPr/>
+          </p:nvSpPr>
+          <p:spPr>
+            <a:xfrm>
+              <a:off x="573033" y="478473"/>
+              <a:ext cx="1097280" cy="1097280"/>
+            </a:xfrm>
+            <a:prstGeom prst="plaque">
+              <a:avLst/>
+            </a:prstGeom>
+            <a:noFill/>
+            <a:ln w="38100" cap="flat" cmpd="sng" algn="ctr">
+              <a:solidFill>
+                <a:schemeClr val="dk1"/>
+              </a:solidFill>
+              <a:prstDash val="solid"/>
+              <a:round/>
+              <a:headEnd type="none" w="med" len="med"/>
+              <a:tailEnd type="none" w="med" len="med"/>
+            </a:ln>
+          </p:spPr>
+          <p:style>
+            <a:lnRef idx="0">
+              <a:scrgbClr r="0" g="0" b="0"/>
+            </a:lnRef>
+            <a:fillRef idx="0">
+              <a:scrgbClr r="0" g="0" b="0"/>
+            </a:fillRef>
+            <a:effectRef idx="0">
+              <a:scrgbClr r="0" g="0" b="0"/>
+            </a:effectRef>
+            <a:fontRef idx="minor">
+              <a:schemeClr val="dk1"/>
+            </a:fontRef>
+          </p:style>
+          <p:txBody>
+            <a:bodyPr rtlCol="0" anchor="ctr"/>
+            <a:lstStyle/>
+            <a:p>
+              <a:pPr algn="ctr"/>
+              <a:endParaRPr lang="en-US"/>
+            </a:p>
+          </p:txBody>
+        </p:sp>
+      </p:grpSp>
+      <p:pic>
+        <p:nvPicPr>
+          <p:cNvPr id="144" name="Picture 143">
+            <a:extLst>
+              <a:ext uri="{FF2B5EF4-FFF2-40B4-BE49-F238E27FC236}">
+                <a16:creationId xmlns:a16="http://schemas.microsoft.com/office/drawing/2014/main" id="{C7E93A14-ECA2-44CE-2A0A-26C4B3781477}"/>
+              </a:ext>
+            </a:extLst>
+          </p:cNvPr>
+          <p:cNvPicPr>
+            <a:picLocks noChangeAspect="1"/>
+          </p:cNvPicPr>
+          <p:nvPr/>
+        </p:nvPicPr>
+        <p:blipFill>
+          <a:blip r:embed="rId4"/>
+          <a:stretch>
+            <a:fillRect/>
+          </a:stretch>
+        </p:blipFill>
+        <p:spPr>
+          <a:xfrm>
+            <a:off x="8725218" y="1115210"/>
+            <a:ext cx="277209" cy="415814"/>
+          </a:xfrm>
+          <a:prstGeom prst="rect">
+            <a:avLst/>
+          </a:prstGeom>
+        </p:spPr>
+      </p:pic>
     </p:spTree>
     <p:extLst>
       <p:ext uri="{BB962C8B-B14F-4D97-AF65-F5344CB8AC3E}">

</xml_diff>

<commit_message>
Add SoulReaper & ThunderGuard
</commit_message>
<xml_diff>
--- a/image process/drawings sifi.pptx
+++ b/image process/drawings sifi.pptx
@@ -17243,10 +17243,10 @@
       </p:grpSpPr>
       <p:pic>
         <p:nvPicPr>
-          <p:cNvPr id="30" name="Picture 29">
+          <p:cNvPr id="28" name="Picture 27">
             <a:extLst>
               <a:ext uri="{FF2B5EF4-FFF2-40B4-BE49-F238E27FC236}">
-                <a16:creationId xmlns:a16="http://schemas.microsoft.com/office/drawing/2014/main" id="{BD0E5BCE-5376-9B10-FC7E-2D121E8F69D3}"/>
+                <a16:creationId xmlns:a16="http://schemas.microsoft.com/office/drawing/2014/main" id="{611C9ED2-34B1-652C-46AE-EF6035935DD0}"/>
               </a:ext>
             </a:extLst>
           </p:cNvPr>
@@ -17262,15 +17262,789 @@
           </a:stretch>
         </p:blipFill>
         <p:spPr>
-          <a:xfrm>
-            <a:off x="594436" y="841877"/>
-            <a:ext cx="433388" cy="444277"/>
+          <a:xfrm rot="20165155">
+            <a:off x="2293315" y="662456"/>
+            <a:ext cx="551005" cy="906820"/>
           </a:xfrm>
           <a:prstGeom prst="rect">
             <a:avLst/>
           </a:prstGeom>
         </p:spPr>
       </p:pic>
+      <p:grpSp>
+        <p:nvGrpSpPr>
+          <p:cNvPr id="26" name="Group 25">
+            <a:extLst>
+              <a:ext uri="{FF2B5EF4-FFF2-40B4-BE49-F238E27FC236}">
+                <a16:creationId xmlns:a16="http://schemas.microsoft.com/office/drawing/2014/main" id="{E6D5F2B4-CC15-2413-E222-F40E8932B52E}"/>
+              </a:ext>
+            </a:extLst>
+          </p:cNvPr>
+          <p:cNvGrpSpPr/>
+          <p:nvPr/>
+        </p:nvGrpSpPr>
+        <p:grpSpPr>
+          <a:xfrm>
+            <a:off x="608089" y="493952"/>
+            <a:ext cx="1027167" cy="1035721"/>
+            <a:chOff x="4165279" y="376316"/>
+            <a:chExt cx="4372510" cy="4408922"/>
+          </a:xfrm>
+        </p:grpSpPr>
+        <p:grpSp>
+          <p:nvGrpSpPr>
+            <p:cNvPr id="8" name="Group 7">
+              <a:extLst>
+                <a:ext uri="{FF2B5EF4-FFF2-40B4-BE49-F238E27FC236}">
+                  <a16:creationId xmlns:a16="http://schemas.microsoft.com/office/drawing/2014/main" id="{900E8C98-AB38-E16B-E603-41C7A4CC6A24}"/>
+                </a:ext>
+              </a:extLst>
+            </p:cNvPr>
+            <p:cNvGrpSpPr/>
+            <p:nvPr/>
+          </p:nvGrpSpPr>
+          <p:grpSpPr>
+            <a:xfrm>
+              <a:off x="5618932" y="1546108"/>
+              <a:ext cx="1540121" cy="2162098"/>
+              <a:chOff x="5452330" y="1708793"/>
+              <a:chExt cx="1186621" cy="1665837"/>
+            </a:xfrm>
+          </p:grpSpPr>
+          <p:sp>
+            <p:nvSpPr>
+              <p:cNvPr id="2" name="Isosceles Triangle 1">
+                <a:extLst>
+                  <a:ext uri="{FF2B5EF4-FFF2-40B4-BE49-F238E27FC236}">
+                    <a16:creationId xmlns:a16="http://schemas.microsoft.com/office/drawing/2014/main" id="{64834EAC-F76B-ADEA-3CD4-205D2CBC6386}"/>
+                  </a:ext>
+                </a:extLst>
+              </p:cNvPr>
+              <p:cNvSpPr/>
+              <p:nvPr/>
+            </p:nvSpPr>
+            <p:spPr>
+              <a:xfrm>
+                <a:off x="5794991" y="1708793"/>
+                <a:ext cx="501300" cy="440002"/>
+              </a:xfrm>
+              <a:prstGeom prst="triangle">
+                <a:avLst/>
+              </a:prstGeom>
+            </p:spPr>
+            <p:style>
+              <a:lnRef idx="2">
+                <a:schemeClr val="dk1">
+                  <a:shade val="50000"/>
+                </a:schemeClr>
+              </a:lnRef>
+              <a:fillRef idx="1">
+                <a:schemeClr val="dk1"/>
+              </a:fillRef>
+              <a:effectRef idx="0">
+                <a:schemeClr val="dk1"/>
+              </a:effectRef>
+              <a:fontRef idx="minor">
+                <a:schemeClr val="lt1"/>
+              </a:fontRef>
+            </p:style>
+            <p:txBody>
+              <a:bodyPr rtlCol="0" anchor="ctr"/>
+              <a:lstStyle/>
+              <a:p>
+                <a:pPr algn="ctr"/>
+                <a:endParaRPr lang="en-US"/>
+              </a:p>
+            </p:txBody>
+          </p:sp>
+          <p:sp>
+            <p:nvSpPr>
+              <p:cNvPr id="3" name="Isosceles Triangle 2">
+                <a:extLst>
+                  <a:ext uri="{FF2B5EF4-FFF2-40B4-BE49-F238E27FC236}">
+                    <a16:creationId xmlns:a16="http://schemas.microsoft.com/office/drawing/2014/main" id="{6AA7D6DD-0D31-13D6-8AA1-5DE532DB6F3D}"/>
+                  </a:ext>
+                </a:extLst>
+              </p:cNvPr>
+              <p:cNvSpPr/>
+              <p:nvPr/>
+            </p:nvSpPr>
+            <p:spPr>
+              <a:xfrm rot="10800000">
+                <a:off x="5794991" y="2236075"/>
+                <a:ext cx="501300" cy="1138555"/>
+              </a:xfrm>
+              <a:prstGeom prst="triangle">
+                <a:avLst/>
+              </a:prstGeom>
+            </p:spPr>
+            <p:style>
+              <a:lnRef idx="2">
+                <a:schemeClr val="dk1">
+                  <a:shade val="50000"/>
+                </a:schemeClr>
+              </a:lnRef>
+              <a:fillRef idx="1">
+                <a:schemeClr val="dk1"/>
+              </a:fillRef>
+              <a:effectRef idx="0">
+                <a:schemeClr val="dk1"/>
+              </a:effectRef>
+              <a:fontRef idx="minor">
+                <a:schemeClr val="lt1"/>
+              </a:fontRef>
+            </p:style>
+            <p:txBody>
+              <a:bodyPr rtlCol="0" anchor="ctr"/>
+              <a:lstStyle/>
+              <a:p>
+                <a:pPr algn="ctr"/>
+                <a:endParaRPr lang="en-US"/>
+              </a:p>
+            </p:txBody>
+          </p:sp>
+          <p:sp>
+            <p:nvSpPr>
+              <p:cNvPr id="4" name="Rectangle 3">
+                <a:extLst>
+                  <a:ext uri="{FF2B5EF4-FFF2-40B4-BE49-F238E27FC236}">
+                    <a16:creationId xmlns:a16="http://schemas.microsoft.com/office/drawing/2014/main" id="{05E4FBE9-446A-A891-35DC-490EF5253060}"/>
+                  </a:ext>
+                </a:extLst>
+              </p:cNvPr>
+              <p:cNvSpPr/>
+              <p:nvPr/>
+            </p:nvSpPr>
+            <p:spPr>
+              <a:xfrm rot="1172583">
+                <a:off x="5452330" y="2155246"/>
+                <a:ext cx="161133" cy="711668"/>
+              </a:xfrm>
+              <a:prstGeom prst="rect">
+                <a:avLst/>
+              </a:prstGeom>
+            </p:spPr>
+            <p:style>
+              <a:lnRef idx="2">
+                <a:schemeClr val="dk1">
+                  <a:shade val="50000"/>
+                </a:schemeClr>
+              </a:lnRef>
+              <a:fillRef idx="1">
+                <a:schemeClr val="dk1"/>
+              </a:fillRef>
+              <a:effectRef idx="0">
+                <a:schemeClr val="dk1"/>
+              </a:effectRef>
+              <a:fontRef idx="minor">
+                <a:schemeClr val="lt1"/>
+              </a:fontRef>
+            </p:style>
+            <p:txBody>
+              <a:bodyPr rtlCol="0" anchor="ctr"/>
+              <a:lstStyle/>
+              <a:p>
+                <a:pPr algn="ctr"/>
+                <a:endParaRPr lang="en-US"/>
+              </a:p>
+            </p:txBody>
+          </p:sp>
+          <p:sp>
+            <p:nvSpPr>
+              <p:cNvPr id="54" name="Rectangle 53">
+                <a:extLst>
+                  <a:ext uri="{FF2B5EF4-FFF2-40B4-BE49-F238E27FC236}">
+                    <a16:creationId xmlns:a16="http://schemas.microsoft.com/office/drawing/2014/main" id="{14509484-877F-4AC3-2064-FAE3DA3BFD62}"/>
+                  </a:ext>
+                </a:extLst>
+              </p:cNvPr>
+              <p:cNvSpPr/>
+              <p:nvPr/>
+            </p:nvSpPr>
+            <p:spPr>
+              <a:xfrm rot="20427417" flipH="1">
+                <a:off x="6477818" y="2155248"/>
+                <a:ext cx="161133" cy="711668"/>
+              </a:xfrm>
+              <a:prstGeom prst="rect">
+                <a:avLst/>
+              </a:prstGeom>
+            </p:spPr>
+            <p:style>
+              <a:lnRef idx="2">
+                <a:schemeClr val="dk1">
+                  <a:shade val="50000"/>
+                </a:schemeClr>
+              </a:lnRef>
+              <a:fillRef idx="1">
+                <a:schemeClr val="dk1"/>
+              </a:fillRef>
+              <a:effectRef idx="0">
+                <a:schemeClr val="dk1"/>
+              </a:effectRef>
+              <a:fontRef idx="minor">
+                <a:schemeClr val="lt1"/>
+              </a:fontRef>
+            </p:style>
+            <p:txBody>
+              <a:bodyPr rtlCol="0" anchor="ctr"/>
+              <a:lstStyle/>
+              <a:p>
+                <a:pPr algn="ctr"/>
+                <a:endParaRPr lang="en-US"/>
+              </a:p>
+            </p:txBody>
+          </p:sp>
+        </p:grpSp>
+        <p:grpSp>
+          <p:nvGrpSpPr>
+            <p:cNvPr id="25" name="Group 24">
+              <a:extLst>
+                <a:ext uri="{FF2B5EF4-FFF2-40B4-BE49-F238E27FC236}">
+                  <a16:creationId xmlns:a16="http://schemas.microsoft.com/office/drawing/2014/main" id="{CC6A0B7A-C9DA-21AE-0EA2-662956AA2572}"/>
+                </a:ext>
+              </a:extLst>
+            </p:cNvPr>
+            <p:cNvGrpSpPr/>
+            <p:nvPr/>
+          </p:nvGrpSpPr>
+          <p:grpSpPr>
+            <a:xfrm>
+              <a:off x="5223090" y="376316"/>
+              <a:ext cx="2327564" cy="1339103"/>
+              <a:chOff x="5223090" y="758463"/>
+              <a:chExt cx="2327564" cy="1339103"/>
+            </a:xfrm>
+          </p:grpSpPr>
+          <p:pic>
+            <p:nvPicPr>
+              <p:cNvPr id="23" name="Picture 22">
+                <a:extLst>
+                  <a:ext uri="{FF2B5EF4-FFF2-40B4-BE49-F238E27FC236}">
+                    <a16:creationId xmlns:a16="http://schemas.microsoft.com/office/drawing/2014/main" id="{6C4E511F-2CE1-6C42-C5DF-0CF42D13AAF1}"/>
+                  </a:ext>
+                </a:extLst>
+              </p:cNvPr>
+              <p:cNvPicPr>
+                <a:picLocks noChangeAspect="1"/>
+              </p:cNvPicPr>
+              <p:nvPr/>
+            </p:nvPicPr>
+            <p:blipFill rotWithShape="1">
+              <a:blip r:embed="rId3"/>
+              <a:srcRect l="7265" t="2149" r="2137"/>
+              <a:stretch/>
+            </p:blipFill>
+            <p:spPr>
+              <a:xfrm rot="9499472">
+                <a:off x="5791200" y="758463"/>
+                <a:ext cx="501300" cy="1119886"/>
+              </a:xfrm>
+              <a:prstGeom prst="rect">
+                <a:avLst/>
+              </a:prstGeom>
+            </p:spPr>
+          </p:pic>
+          <p:pic>
+            <p:nvPicPr>
+              <p:cNvPr id="76" name="Picture 75">
+                <a:extLst>
+                  <a:ext uri="{FF2B5EF4-FFF2-40B4-BE49-F238E27FC236}">
+                    <a16:creationId xmlns:a16="http://schemas.microsoft.com/office/drawing/2014/main" id="{F4985C61-0B7A-DD00-D291-D2A339C87F78}"/>
+                  </a:ext>
+                </a:extLst>
+              </p:cNvPr>
+              <p:cNvPicPr>
+                <a:picLocks noChangeAspect="1"/>
+              </p:cNvPicPr>
+              <p:nvPr/>
+            </p:nvPicPr>
+            <p:blipFill rotWithShape="1">
+              <a:blip r:embed="rId3"/>
+              <a:srcRect l="7265" t="2149" r="2137"/>
+              <a:stretch/>
+            </p:blipFill>
+            <p:spPr>
+              <a:xfrm rot="11335141">
+                <a:off x="6459893" y="776279"/>
+                <a:ext cx="501300" cy="1119886"/>
+              </a:xfrm>
+              <a:prstGeom prst="rect">
+                <a:avLst/>
+              </a:prstGeom>
+            </p:spPr>
+          </p:pic>
+          <p:pic>
+            <p:nvPicPr>
+              <p:cNvPr id="77" name="Picture 76">
+                <a:extLst>
+                  <a:ext uri="{FF2B5EF4-FFF2-40B4-BE49-F238E27FC236}">
+                    <a16:creationId xmlns:a16="http://schemas.microsoft.com/office/drawing/2014/main" id="{01C3493D-A7F6-7A3C-562A-7944049AB6F6}"/>
+                  </a:ext>
+                </a:extLst>
+              </p:cNvPr>
+              <p:cNvPicPr>
+                <a:picLocks noChangeAspect="1"/>
+              </p:cNvPicPr>
+              <p:nvPr/>
+            </p:nvPicPr>
+            <p:blipFill rotWithShape="1">
+              <a:blip r:embed="rId3"/>
+              <a:srcRect l="7265" t="2149" r="2137"/>
+              <a:stretch/>
+            </p:blipFill>
+            <p:spPr>
+              <a:xfrm rot="9323264" flipH="1">
+                <a:off x="5223090" y="977680"/>
+                <a:ext cx="501300" cy="1119886"/>
+              </a:xfrm>
+              <a:prstGeom prst="rect">
+                <a:avLst/>
+              </a:prstGeom>
+            </p:spPr>
+          </p:pic>
+          <p:pic>
+            <p:nvPicPr>
+              <p:cNvPr id="78" name="Picture 77">
+                <a:extLst>
+                  <a:ext uri="{FF2B5EF4-FFF2-40B4-BE49-F238E27FC236}">
+                    <a16:creationId xmlns:a16="http://schemas.microsoft.com/office/drawing/2014/main" id="{A371ADE2-AB8E-450C-C726-0BFE20FA3A2E}"/>
+                  </a:ext>
+                </a:extLst>
+              </p:cNvPr>
+              <p:cNvPicPr>
+                <a:picLocks noChangeAspect="1"/>
+              </p:cNvPicPr>
+              <p:nvPr/>
+            </p:nvPicPr>
+            <p:blipFill rotWithShape="1">
+              <a:blip r:embed="rId3"/>
+              <a:srcRect l="7265" t="2149" r="2137"/>
+              <a:stretch/>
+            </p:blipFill>
+            <p:spPr>
+              <a:xfrm rot="13424503" flipH="1">
+                <a:off x="7049354" y="966826"/>
+                <a:ext cx="501300" cy="1119886"/>
+              </a:xfrm>
+              <a:prstGeom prst="rect">
+                <a:avLst/>
+              </a:prstGeom>
+            </p:spPr>
+          </p:pic>
+        </p:grpSp>
+        <p:grpSp>
+          <p:nvGrpSpPr>
+            <p:cNvPr id="79" name="Group 78">
+              <a:extLst>
+                <a:ext uri="{FF2B5EF4-FFF2-40B4-BE49-F238E27FC236}">
+                  <a16:creationId xmlns:a16="http://schemas.microsoft.com/office/drawing/2014/main" id="{BCDCAAAD-9B8E-CA71-0085-48CF26E405D8}"/>
+                </a:ext>
+              </a:extLst>
+            </p:cNvPr>
+            <p:cNvGrpSpPr/>
+            <p:nvPr/>
+          </p:nvGrpSpPr>
+          <p:grpSpPr>
+            <a:xfrm rot="10800000">
+              <a:off x="5212329" y="3446135"/>
+              <a:ext cx="2327564" cy="1339103"/>
+              <a:chOff x="5223090" y="758463"/>
+              <a:chExt cx="2327564" cy="1339103"/>
+            </a:xfrm>
+          </p:grpSpPr>
+          <p:pic>
+            <p:nvPicPr>
+              <p:cNvPr id="80" name="Picture 79">
+                <a:extLst>
+                  <a:ext uri="{FF2B5EF4-FFF2-40B4-BE49-F238E27FC236}">
+                    <a16:creationId xmlns:a16="http://schemas.microsoft.com/office/drawing/2014/main" id="{5742BE29-CEBF-34A9-715C-44003FAF2AF9}"/>
+                  </a:ext>
+                </a:extLst>
+              </p:cNvPr>
+              <p:cNvPicPr>
+                <a:picLocks noChangeAspect="1"/>
+              </p:cNvPicPr>
+              <p:nvPr/>
+            </p:nvPicPr>
+            <p:blipFill rotWithShape="1">
+              <a:blip r:embed="rId3"/>
+              <a:srcRect l="7265" t="2149" r="2137"/>
+              <a:stretch/>
+            </p:blipFill>
+            <p:spPr>
+              <a:xfrm rot="9499472">
+                <a:off x="5791200" y="758463"/>
+                <a:ext cx="501300" cy="1119886"/>
+              </a:xfrm>
+              <a:prstGeom prst="rect">
+                <a:avLst/>
+              </a:prstGeom>
+            </p:spPr>
+          </p:pic>
+          <p:pic>
+            <p:nvPicPr>
+              <p:cNvPr id="81" name="Picture 80">
+                <a:extLst>
+                  <a:ext uri="{FF2B5EF4-FFF2-40B4-BE49-F238E27FC236}">
+                    <a16:creationId xmlns:a16="http://schemas.microsoft.com/office/drawing/2014/main" id="{EBF05BCA-59FD-E14C-25C9-ABFF697BB194}"/>
+                  </a:ext>
+                </a:extLst>
+              </p:cNvPr>
+              <p:cNvPicPr>
+                <a:picLocks noChangeAspect="1"/>
+              </p:cNvPicPr>
+              <p:nvPr/>
+            </p:nvPicPr>
+            <p:blipFill rotWithShape="1">
+              <a:blip r:embed="rId3"/>
+              <a:srcRect l="7265" t="2149" r="2137"/>
+              <a:stretch/>
+            </p:blipFill>
+            <p:spPr>
+              <a:xfrm rot="11335141">
+                <a:off x="6459893" y="776279"/>
+                <a:ext cx="501300" cy="1119886"/>
+              </a:xfrm>
+              <a:prstGeom prst="rect">
+                <a:avLst/>
+              </a:prstGeom>
+            </p:spPr>
+          </p:pic>
+          <p:pic>
+            <p:nvPicPr>
+              <p:cNvPr id="82" name="Picture 81">
+                <a:extLst>
+                  <a:ext uri="{FF2B5EF4-FFF2-40B4-BE49-F238E27FC236}">
+                    <a16:creationId xmlns:a16="http://schemas.microsoft.com/office/drawing/2014/main" id="{9EB53265-F1D0-58A5-73B0-6D94B5905AF2}"/>
+                  </a:ext>
+                </a:extLst>
+              </p:cNvPr>
+              <p:cNvPicPr>
+                <a:picLocks noChangeAspect="1"/>
+              </p:cNvPicPr>
+              <p:nvPr/>
+            </p:nvPicPr>
+            <p:blipFill rotWithShape="1">
+              <a:blip r:embed="rId3"/>
+              <a:srcRect l="7265" t="2149" r="2137"/>
+              <a:stretch/>
+            </p:blipFill>
+            <p:spPr>
+              <a:xfrm rot="9323264" flipH="1">
+                <a:off x="5223090" y="977680"/>
+                <a:ext cx="501300" cy="1119886"/>
+              </a:xfrm>
+              <a:prstGeom prst="rect">
+                <a:avLst/>
+              </a:prstGeom>
+            </p:spPr>
+          </p:pic>
+          <p:pic>
+            <p:nvPicPr>
+              <p:cNvPr id="83" name="Picture 82">
+                <a:extLst>
+                  <a:ext uri="{FF2B5EF4-FFF2-40B4-BE49-F238E27FC236}">
+                    <a16:creationId xmlns:a16="http://schemas.microsoft.com/office/drawing/2014/main" id="{680E964E-CEE1-1EFF-5185-C0B4782BC12F}"/>
+                  </a:ext>
+                </a:extLst>
+              </p:cNvPr>
+              <p:cNvPicPr>
+                <a:picLocks noChangeAspect="1"/>
+              </p:cNvPicPr>
+              <p:nvPr/>
+            </p:nvPicPr>
+            <p:blipFill rotWithShape="1">
+              <a:blip r:embed="rId3"/>
+              <a:srcRect l="7265" t="2149" r="2137"/>
+              <a:stretch/>
+            </p:blipFill>
+            <p:spPr>
+              <a:xfrm rot="13424503" flipH="1">
+                <a:off x="7049354" y="966826"/>
+                <a:ext cx="501300" cy="1119886"/>
+              </a:xfrm>
+              <a:prstGeom prst="rect">
+                <a:avLst/>
+              </a:prstGeom>
+            </p:spPr>
+          </p:pic>
+        </p:grpSp>
+        <p:grpSp>
+          <p:nvGrpSpPr>
+            <p:cNvPr id="84" name="Group 83">
+              <a:extLst>
+                <a:ext uri="{FF2B5EF4-FFF2-40B4-BE49-F238E27FC236}">
+                  <a16:creationId xmlns:a16="http://schemas.microsoft.com/office/drawing/2014/main" id="{FA22BA67-F0E7-33B1-9C63-A4BB9E5B0831}"/>
+                </a:ext>
+              </a:extLst>
+            </p:cNvPr>
+            <p:cNvGrpSpPr/>
+            <p:nvPr/>
+          </p:nvGrpSpPr>
+          <p:grpSpPr>
+            <a:xfrm rot="16367590">
+              <a:off x="3671049" y="1904396"/>
+              <a:ext cx="2327564" cy="1339103"/>
+              <a:chOff x="5223090" y="758463"/>
+              <a:chExt cx="2327564" cy="1339103"/>
+            </a:xfrm>
+          </p:grpSpPr>
+          <p:pic>
+            <p:nvPicPr>
+              <p:cNvPr id="85" name="Picture 84">
+                <a:extLst>
+                  <a:ext uri="{FF2B5EF4-FFF2-40B4-BE49-F238E27FC236}">
+                    <a16:creationId xmlns:a16="http://schemas.microsoft.com/office/drawing/2014/main" id="{4C16ACBF-B81A-6C1A-16F3-B566ABD3E759}"/>
+                  </a:ext>
+                </a:extLst>
+              </p:cNvPr>
+              <p:cNvPicPr>
+                <a:picLocks noChangeAspect="1"/>
+              </p:cNvPicPr>
+              <p:nvPr/>
+            </p:nvPicPr>
+            <p:blipFill rotWithShape="1">
+              <a:blip r:embed="rId3"/>
+              <a:srcRect l="7265" t="2149" r="2137"/>
+              <a:stretch/>
+            </p:blipFill>
+            <p:spPr>
+              <a:xfrm rot="9499472">
+                <a:off x="5791200" y="758463"/>
+                <a:ext cx="501300" cy="1119886"/>
+              </a:xfrm>
+              <a:prstGeom prst="rect">
+                <a:avLst/>
+              </a:prstGeom>
+            </p:spPr>
+          </p:pic>
+          <p:pic>
+            <p:nvPicPr>
+              <p:cNvPr id="86" name="Picture 85">
+                <a:extLst>
+                  <a:ext uri="{FF2B5EF4-FFF2-40B4-BE49-F238E27FC236}">
+                    <a16:creationId xmlns:a16="http://schemas.microsoft.com/office/drawing/2014/main" id="{AA831C4D-C844-073B-90BD-EAC348AE5FE1}"/>
+                  </a:ext>
+                </a:extLst>
+              </p:cNvPr>
+              <p:cNvPicPr>
+                <a:picLocks noChangeAspect="1"/>
+              </p:cNvPicPr>
+              <p:nvPr/>
+            </p:nvPicPr>
+            <p:blipFill rotWithShape="1">
+              <a:blip r:embed="rId3"/>
+              <a:srcRect l="7265" t="2149" r="2137"/>
+              <a:stretch/>
+            </p:blipFill>
+            <p:spPr>
+              <a:xfrm rot="11335141">
+                <a:off x="6459893" y="776279"/>
+                <a:ext cx="501300" cy="1119886"/>
+              </a:xfrm>
+              <a:prstGeom prst="rect">
+                <a:avLst/>
+              </a:prstGeom>
+            </p:spPr>
+          </p:pic>
+          <p:pic>
+            <p:nvPicPr>
+              <p:cNvPr id="87" name="Picture 86">
+                <a:extLst>
+                  <a:ext uri="{FF2B5EF4-FFF2-40B4-BE49-F238E27FC236}">
+                    <a16:creationId xmlns:a16="http://schemas.microsoft.com/office/drawing/2014/main" id="{330FE7B5-2CBD-164D-648F-9AFDB5E2DDC3}"/>
+                  </a:ext>
+                </a:extLst>
+              </p:cNvPr>
+              <p:cNvPicPr>
+                <a:picLocks noChangeAspect="1"/>
+              </p:cNvPicPr>
+              <p:nvPr/>
+            </p:nvPicPr>
+            <p:blipFill rotWithShape="1">
+              <a:blip r:embed="rId3"/>
+              <a:srcRect l="7265" t="2149" r="2137"/>
+              <a:stretch/>
+            </p:blipFill>
+            <p:spPr>
+              <a:xfrm rot="9323264" flipH="1">
+                <a:off x="5223090" y="977680"/>
+                <a:ext cx="501300" cy="1119886"/>
+              </a:xfrm>
+              <a:prstGeom prst="rect">
+                <a:avLst/>
+              </a:prstGeom>
+            </p:spPr>
+          </p:pic>
+          <p:pic>
+            <p:nvPicPr>
+              <p:cNvPr id="88" name="Picture 87">
+                <a:extLst>
+                  <a:ext uri="{FF2B5EF4-FFF2-40B4-BE49-F238E27FC236}">
+                    <a16:creationId xmlns:a16="http://schemas.microsoft.com/office/drawing/2014/main" id="{9D840451-CF6B-5B63-AE0E-D6A19467266D}"/>
+                  </a:ext>
+                </a:extLst>
+              </p:cNvPr>
+              <p:cNvPicPr>
+                <a:picLocks noChangeAspect="1"/>
+              </p:cNvPicPr>
+              <p:nvPr/>
+            </p:nvPicPr>
+            <p:blipFill rotWithShape="1">
+              <a:blip r:embed="rId3"/>
+              <a:srcRect l="7265" t="2149" r="2137"/>
+              <a:stretch/>
+            </p:blipFill>
+            <p:spPr>
+              <a:xfrm rot="13424503" flipH="1">
+                <a:off x="7049354" y="966826"/>
+                <a:ext cx="501300" cy="1119886"/>
+              </a:xfrm>
+              <a:prstGeom prst="rect">
+                <a:avLst/>
+              </a:prstGeom>
+            </p:spPr>
+          </p:pic>
+        </p:grpSp>
+        <p:grpSp>
+          <p:nvGrpSpPr>
+            <p:cNvPr id="89" name="Group 88">
+              <a:extLst>
+                <a:ext uri="{FF2B5EF4-FFF2-40B4-BE49-F238E27FC236}">
+                  <a16:creationId xmlns:a16="http://schemas.microsoft.com/office/drawing/2014/main" id="{FEF045B2-0948-65B1-3362-7DB766FFBBE7}"/>
+                </a:ext>
+              </a:extLst>
+            </p:cNvPr>
+            <p:cNvGrpSpPr/>
+            <p:nvPr/>
+          </p:nvGrpSpPr>
+          <p:grpSpPr>
+            <a:xfrm rot="5400000">
+              <a:off x="6704456" y="2000299"/>
+              <a:ext cx="2327564" cy="1339103"/>
+              <a:chOff x="5223090" y="758463"/>
+              <a:chExt cx="2327564" cy="1339103"/>
+            </a:xfrm>
+          </p:grpSpPr>
+          <p:pic>
+            <p:nvPicPr>
+              <p:cNvPr id="90" name="Picture 89">
+                <a:extLst>
+                  <a:ext uri="{FF2B5EF4-FFF2-40B4-BE49-F238E27FC236}">
+                    <a16:creationId xmlns:a16="http://schemas.microsoft.com/office/drawing/2014/main" id="{F04C856E-A956-D0A5-EDBC-8D14833F86DC}"/>
+                  </a:ext>
+                </a:extLst>
+              </p:cNvPr>
+              <p:cNvPicPr>
+                <a:picLocks noChangeAspect="1"/>
+              </p:cNvPicPr>
+              <p:nvPr/>
+            </p:nvPicPr>
+            <p:blipFill rotWithShape="1">
+              <a:blip r:embed="rId3"/>
+              <a:srcRect l="7265" t="2149" r="2137"/>
+              <a:stretch/>
+            </p:blipFill>
+            <p:spPr>
+              <a:xfrm rot="9499472">
+                <a:off x="5791200" y="758463"/>
+                <a:ext cx="501300" cy="1119886"/>
+              </a:xfrm>
+              <a:prstGeom prst="rect">
+                <a:avLst/>
+              </a:prstGeom>
+            </p:spPr>
+          </p:pic>
+          <p:pic>
+            <p:nvPicPr>
+              <p:cNvPr id="91" name="Picture 90">
+                <a:extLst>
+                  <a:ext uri="{FF2B5EF4-FFF2-40B4-BE49-F238E27FC236}">
+                    <a16:creationId xmlns:a16="http://schemas.microsoft.com/office/drawing/2014/main" id="{7363800B-F2BB-4F5F-FE92-1CFB48C58F42}"/>
+                  </a:ext>
+                </a:extLst>
+              </p:cNvPr>
+              <p:cNvPicPr>
+                <a:picLocks noChangeAspect="1"/>
+              </p:cNvPicPr>
+              <p:nvPr/>
+            </p:nvPicPr>
+            <p:blipFill rotWithShape="1">
+              <a:blip r:embed="rId3"/>
+              <a:srcRect l="7265" t="2149" r="2137"/>
+              <a:stretch/>
+            </p:blipFill>
+            <p:spPr>
+              <a:xfrm rot="11335141">
+                <a:off x="6459893" y="776279"/>
+                <a:ext cx="501300" cy="1119886"/>
+              </a:xfrm>
+              <a:prstGeom prst="rect">
+                <a:avLst/>
+              </a:prstGeom>
+            </p:spPr>
+          </p:pic>
+          <p:pic>
+            <p:nvPicPr>
+              <p:cNvPr id="92" name="Picture 91">
+                <a:extLst>
+                  <a:ext uri="{FF2B5EF4-FFF2-40B4-BE49-F238E27FC236}">
+                    <a16:creationId xmlns:a16="http://schemas.microsoft.com/office/drawing/2014/main" id="{1AD0E70B-066F-9828-19B3-5877D64FA2F6}"/>
+                  </a:ext>
+                </a:extLst>
+              </p:cNvPr>
+              <p:cNvPicPr>
+                <a:picLocks noChangeAspect="1"/>
+              </p:cNvPicPr>
+              <p:nvPr/>
+            </p:nvPicPr>
+            <p:blipFill rotWithShape="1">
+              <a:blip r:embed="rId3"/>
+              <a:srcRect l="7265" t="2149" r="2137"/>
+              <a:stretch/>
+            </p:blipFill>
+            <p:spPr>
+              <a:xfrm rot="9323264" flipH="1">
+                <a:off x="5223090" y="977680"/>
+                <a:ext cx="501300" cy="1119886"/>
+              </a:xfrm>
+              <a:prstGeom prst="rect">
+                <a:avLst/>
+              </a:prstGeom>
+            </p:spPr>
+          </p:pic>
+          <p:pic>
+            <p:nvPicPr>
+              <p:cNvPr id="93" name="Picture 92">
+                <a:extLst>
+                  <a:ext uri="{FF2B5EF4-FFF2-40B4-BE49-F238E27FC236}">
+                    <a16:creationId xmlns:a16="http://schemas.microsoft.com/office/drawing/2014/main" id="{77EA80CC-02E2-AA59-B36E-6C332D55C1F1}"/>
+                  </a:ext>
+                </a:extLst>
+              </p:cNvPr>
+              <p:cNvPicPr>
+                <a:picLocks noChangeAspect="1"/>
+              </p:cNvPicPr>
+              <p:nvPr/>
+            </p:nvPicPr>
+            <p:blipFill rotWithShape="1">
+              <a:blip r:embed="rId3"/>
+              <a:srcRect l="7265" t="2149" r="2137"/>
+              <a:stretch/>
+            </p:blipFill>
+            <p:spPr>
+              <a:xfrm rot="13424503" flipH="1">
+                <a:off x="7049354" y="966826"/>
+                <a:ext cx="501300" cy="1119886"/>
+              </a:xfrm>
+              <a:prstGeom prst="rect">
+                <a:avLst/>
+              </a:prstGeom>
+            </p:spPr>
+          </p:pic>
+        </p:grpSp>
+      </p:grpSp>
       <p:grpSp>
         <p:nvGrpSpPr>
           <p:cNvPr id="13" name="Group 12">
@@ -17400,1044 +18174,6 @@
       </p:grpSp>
       <p:grpSp>
         <p:nvGrpSpPr>
-          <p:cNvPr id="21" name="Group 20">
-            <a:extLst>
-              <a:ext uri="{FF2B5EF4-FFF2-40B4-BE49-F238E27FC236}">
-                <a16:creationId xmlns:a16="http://schemas.microsoft.com/office/drawing/2014/main" id="{E2A2CBEA-E93F-5FBE-BF5E-6728063DE48D}"/>
-              </a:ext>
-            </a:extLst>
-          </p:cNvPr>
-          <p:cNvGrpSpPr/>
-          <p:nvPr/>
-        </p:nvGrpSpPr>
-        <p:grpSpPr>
-          <a:xfrm>
-            <a:off x="1019174" y="536319"/>
-            <a:ext cx="441325" cy="1012069"/>
-            <a:chOff x="3248025" y="1009650"/>
-            <a:chExt cx="1390650" cy="3189114"/>
-          </a:xfrm>
-        </p:grpSpPr>
-        <p:sp>
-          <p:nvSpPr>
-            <p:cNvPr id="9" name="Oval 8">
-              <a:extLst>
-                <a:ext uri="{FF2B5EF4-FFF2-40B4-BE49-F238E27FC236}">
-                  <a16:creationId xmlns:a16="http://schemas.microsoft.com/office/drawing/2014/main" id="{9D5510EF-2548-EA85-62B8-9ADA85182350}"/>
-                </a:ext>
-              </a:extLst>
-            </p:cNvPr>
-            <p:cNvSpPr/>
-            <p:nvPr/>
-          </p:nvSpPr>
-          <p:spPr>
-            <a:xfrm>
-              <a:off x="3549650" y="1009650"/>
-              <a:ext cx="787400" cy="984250"/>
-            </a:xfrm>
-            <a:prstGeom prst="ellipse">
-              <a:avLst/>
-            </a:prstGeom>
-          </p:spPr>
-          <p:style>
-            <a:lnRef idx="2">
-              <a:schemeClr val="dk1">
-                <a:shade val="50000"/>
-              </a:schemeClr>
-            </a:lnRef>
-            <a:fillRef idx="1">
-              <a:schemeClr val="dk1"/>
-            </a:fillRef>
-            <a:effectRef idx="0">
-              <a:schemeClr val="dk1"/>
-            </a:effectRef>
-            <a:fontRef idx="minor">
-              <a:schemeClr val="lt1"/>
-            </a:fontRef>
-          </p:style>
-          <p:txBody>
-            <a:bodyPr rtlCol="0" anchor="ctr"/>
-            <a:lstStyle/>
-            <a:p>
-              <a:pPr algn="ctr"/>
-              <a:endParaRPr lang="en-US"/>
-            </a:p>
-          </p:txBody>
-        </p:sp>
-        <p:sp>
-          <p:nvSpPr>
-            <p:cNvPr id="11" name="Rectangle: Rounded Corners 10">
-              <a:extLst>
-                <a:ext uri="{FF2B5EF4-FFF2-40B4-BE49-F238E27FC236}">
-                  <a16:creationId xmlns:a16="http://schemas.microsoft.com/office/drawing/2014/main" id="{104BD941-8C1D-03B6-2D46-9AD123AB3AAA}"/>
-                </a:ext>
-              </a:extLst>
-            </p:cNvPr>
-            <p:cNvSpPr/>
-            <p:nvPr/>
-          </p:nvSpPr>
-          <p:spPr>
-            <a:xfrm>
-              <a:off x="3600450" y="2051050"/>
-              <a:ext cx="692150" cy="292100"/>
-            </a:xfrm>
-            <a:prstGeom prst="roundRect">
-              <a:avLst/>
-            </a:prstGeom>
-          </p:spPr>
-          <p:style>
-            <a:lnRef idx="2">
-              <a:schemeClr val="dk1">
-                <a:shade val="50000"/>
-              </a:schemeClr>
-            </a:lnRef>
-            <a:fillRef idx="1">
-              <a:schemeClr val="dk1"/>
-            </a:fillRef>
-            <a:effectRef idx="0">
-              <a:schemeClr val="dk1"/>
-            </a:effectRef>
-            <a:fontRef idx="minor">
-              <a:schemeClr val="lt1"/>
-            </a:fontRef>
-          </p:style>
-          <p:txBody>
-            <a:bodyPr rtlCol="0" anchor="ctr"/>
-            <a:lstStyle/>
-            <a:p>
-              <a:pPr algn="ctr"/>
-              <a:endParaRPr lang="en-US"/>
-            </a:p>
-          </p:txBody>
-        </p:sp>
-        <p:grpSp>
-          <p:nvGrpSpPr>
-            <p:cNvPr id="17" name="Group 16">
-              <a:extLst>
-                <a:ext uri="{FF2B5EF4-FFF2-40B4-BE49-F238E27FC236}">
-                  <a16:creationId xmlns:a16="http://schemas.microsoft.com/office/drawing/2014/main" id="{8D4E8C95-B2D6-2625-DFAC-E9625432CFC0}"/>
-                </a:ext>
-              </a:extLst>
-            </p:cNvPr>
-            <p:cNvGrpSpPr/>
-            <p:nvPr/>
-          </p:nvGrpSpPr>
-          <p:grpSpPr>
-            <a:xfrm>
-              <a:off x="4282383" y="2120161"/>
-              <a:ext cx="291335" cy="2073380"/>
-              <a:chOff x="4282383" y="2120161"/>
-              <a:chExt cx="291335" cy="2073380"/>
-            </a:xfrm>
-          </p:grpSpPr>
-          <p:sp>
-            <p:nvSpPr>
-              <p:cNvPr id="12" name="Rectangle 11">
-                <a:extLst>
-                  <a:ext uri="{FF2B5EF4-FFF2-40B4-BE49-F238E27FC236}">
-                    <a16:creationId xmlns:a16="http://schemas.microsoft.com/office/drawing/2014/main" id="{9B4DCC3F-3F93-BD4A-39A6-47EB5B8E46EE}"/>
-                  </a:ext>
-                </a:extLst>
-              </p:cNvPr>
-              <p:cNvSpPr/>
-              <p:nvPr/>
-            </p:nvSpPr>
-            <p:spPr>
-              <a:xfrm rot="3958351">
-                <a:off x="3893446" y="2509098"/>
-                <a:ext cx="996950" cy="219075"/>
-              </a:xfrm>
-              <a:prstGeom prst="rect">
-                <a:avLst/>
-              </a:prstGeom>
-            </p:spPr>
-            <p:style>
-              <a:lnRef idx="2">
-                <a:schemeClr val="dk1">
-                  <a:shade val="50000"/>
-                </a:schemeClr>
-              </a:lnRef>
-              <a:fillRef idx="1">
-                <a:schemeClr val="dk1"/>
-              </a:fillRef>
-              <a:effectRef idx="0">
-                <a:schemeClr val="dk1"/>
-              </a:effectRef>
-              <a:fontRef idx="minor">
-                <a:schemeClr val="lt1"/>
-              </a:fontRef>
-            </p:style>
-            <p:txBody>
-              <a:bodyPr rtlCol="0" anchor="ctr"/>
-              <a:lstStyle/>
-              <a:p>
-                <a:pPr algn="ctr"/>
-                <a:endParaRPr lang="en-US"/>
-              </a:p>
-            </p:txBody>
-          </p:sp>
-          <p:sp>
-            <p:nvSpPr>
-              <p:cNvPr id="14" name="Isosceles Triangle 13">
-                <a:extLst>
-                  <a:ext uri="{FF2B5EF4-FFF2-40B4-BE49-F238E27FC236}">
-                    <a16:creationId xmlns:a16="http://schemas.microsoft.com/office/drawing/2014/main" id="{1E09283E-E602-4561-BA1B-639728EE4302}"/>
-                  </a:ext>
-                </a:extLst>
-              </p:cNvPr>
-              <p:cNvSpPr/>
-              <p:nvPr/>
-            </p:nvSpPr>
-            <p:spPr>
-              <a:xfrm rot="11268472">
-                <a:off x="4421316" y="2942591"/>
-                <a:ext cx="152402" cy="1250950"/>
-              </a:xfrm>
-              <a:prstGeom prst="triangle">
-                <a:avLst/>
-              </a:prstGeom>
-            </p:spPr>
-            <p:style>
-              <a:lnRef idx="2">
-                <a:schemeClr val="dk1">
-                  <a:shade val="50000"/>
-                </a:schemeClr>
-              </a:lnRef>
-              <a:fillRef idx="1">
-                <a:schemeClr val="dk1"/>
-              </a:fillRef>
-              <a:effectRef idx="0">
-                <a:schemeClr val="dk1"/>
-              </a:effectRef>
-              <a:fontRef idx="minor">
-                <a:schemeClr val="lt1"/>
-              </a:fontRef>
-            </p:style>
-            <p:txBody>
-              <a:bodyPr rtlCol="0" anchor="ctr"/>
-              <a:lstStyle/>
-              <a:p>
-                <a:pPr algn="ctr"/>
-                <a:endParaRPr lang="en-US"/>
-              </a:p>
-            </p:txBody>
-          </p:sp>
-        </p:grpSp>
-        <p:grpSp>
-          <p:nvGrpSpPr>
-            <p:cNvPr id="35" name="Group 34">
-              <a:extLst>
-                <a:ext uri="{FF2B5EF4-FFF2-40B4-BE49-F238E27FC236}">
-                  <a16:creationId xmlns:a16="http://schemas.microsoft.com/office/drawing/2014/main" id="{11CE8681-7007-B528-1489-2C083FAB07E4}"/>
-                </a:ext>
-              </a:extLst>
-            </p:cNvPr>
-            <p:cNvGrpSpPr/>
-            <p:nvPr/>
-          </p:nvGrpSpPr>
-          <p:grpSpPr>
-            <a:xfrm flipH="1">
-              <a:off x="3309115" y="2124715"/>
-              <a:ext cx="291335" cy="2073380"/>
-              <a:chOff x="4282383" y="2120161"/>
-              <a:chExt cx="291335" cy="2073380"/>
-            </a:xfrm>
-          </p:grpSpPr>
-          <p:sp>
-            <p:nvSpPr>
-              <p:cNvPr id="36" name="Rectangle 35">
-                <a:extLst>
-                  <a:ext uri="{FF2B5EF4-FFF2-40B4-BE49-F238E27FC236}">
-                    <a16:creationId xmlns:a16="http://schemas.microsoft.com/office/drawing/2014/main" id="{7146EEE4-FE28-A545-C368-14A7CBAFCCD3}"/>
-                  </a:ext>
-                </a:extLst>
-              </p:cNvPr>
-              <p:cNvSpPr/>
-              <p:nvPr/>
-            </p:nvSpPr>
-            <p:spPr>
-              <a:xfrm rot="3958351">
-                <a:off x="3893446" y="2509098"/>
-                <a:ext cx="996950" cy="219075"/>
-              </a:xfrm>
-              <a:prstGeom prst="rect">
-                <a:avLst/>
-              </a:prstGeom>
-            </p:spPr>
-            <p:style>
-              <a:lnRef idx="2">
-                <a:schemeClr val="dk1">
-                  <a:shade val="50000"/>
-                </a:schemeClr>
-              </a:lnRef>
-              <a:fillRef idx="1">
-                <a:schemeClr val="dk1"/>
-              </a:fillRef>
-              <a:effectRef idx="0">
-                <a:schemeClr val="dk1"/>
-              </a:effectRef>
-              <a:fontRef idx="minor">
-                <a:schemeClr val="lt1"/>
-              </a:fontRef>
-            </p:style>
-            <p:txBody>
-              <a:bodyPr rtlCol="0" anchor="ctr"/>
-              <a:lstStyle/>
-              <a:p>
-                <a:pPr algn="ctr"/>
-                <a:endParaRPr lang="en-US"/>
-              </a:p>
-            </p:txBody>
-          </p:sp>
-          <p:sp>
-            <p:nvSpPr>
-              <p:cNvPr id="37" name="Isosceles Triangle 36">
-                <a:extLst>
-                  <a:ext uri="{FF2B5EF4-FFF2-40B4-BE49-F238E27FC236}">
-                    <a16:creationId xmlns:a16="http://schemas.microsoft.com/office/drawing/2014/main" id="{B62C4A42-F1EE-4E15-A845-CB1E95F23D9F}"/>
-                  </a:ext>
-                </a:extLst>
-              </p:cNvPr>
-              <p:cNvSpPr/>
-              <p:nvPr/>
-            </p:nvSpPr>
-            <p:spPr>
-              <a:xfrm rot="11268472">
-                <a:off x="4421316" y="2942591"/>
-                <a:ext cx="152402" cy="1250950"/>
-              </a:xfrm>
-              <a:prstGeom prst="triangle">
-                <a:avLst/>
-              </a:prstGeom>
-            </p:spPr>
-            <p:style>
-              <a:lnRef idx="2">
-                <a:schemeClr val="dk1">
-                  <a:shade val="50000"/>
-                </a:schemeClr>
-              </a:lnRef>
-              <a:fillRef idx="1">
-                <a:schemeClr val="dk1"/>
-              </a:fillRef>
-              <a:effectRef idx="0">
-                <a:schemeClr val="dk1"/>
-              </a:effectRef>
-              <a:fontRef idx="minor">
-                <a:schemeClr val="lt1"/>
-              </a:fontRef>
-            </p:style>
-            <p:txBody>
-              <a:bodyPr rtlCol="0" anchor="ctr"/>
-              <a:lstStyle/>
-              <a:p>
-                <a:pPr algn="ctr"/>
-                <a:endParaRPr lang="en-US"/>
-              </a:p>
-            </p:txBody>
-          </p:sp>
-        </p:grpSp>
-        <p:sp>
-          <p:nvSpPr>
-            <p:cNvPr id="39" name="Rectangle 38">
-              <a:extLst>
-                <a:ext uri="{FF2B5EF4-FFF2-40B4-BE49-F238E27FC236}">
-                  <a16:creationId xmlns:a16="http://schemas.microsoft.com/office/drawing/2014/main" id="{289333CA-5D8F-C6FC-1B71-A2036F1FEC27}"/>
-                </a:ext>
-              </a:extLst>
-            </p:cNvPr>
-            <p:cNvSpPr/>
-            <p:nvPr/>
-          </p:nvSpPr>
-          <p:spPr>
-            <a:xfrm rot="5400000">
-              <a:off x="3441937" y="2586038"/>
-              <a:ext cx="996950" cy="219075"/>
-            </a:xfrm>
-            <a:prstGeom prst="rect">
-              <a:avLst/>
-            </a:prstGeom>
-          </p:spPr>
-          <p:style>
-            <a:lnRef idx="2">
-              <a:schemeClr val="dk1">
-                <a:shade val="50000"/>
-              </a:schemeClr>
-            </a:lnRef>
-            <a:fillRef idx="1">
-              <a:schemeClr val="dk1"/>
-            </a:fillRef>
-            <a:effectRef idx="0">
-              <a:schemeClr val="dk1"/>
-            </a:effectRef>
-            <a:fontRef idx="minor">
-              <a:schemeClr val="lt1"/>
-            </a:fontRef>
-          </p:style>
-          <p:txBody>
-            <a:bodyPr rtlCol="0" anchor="ctr"/>
-            <a:lstStyle/>
-            <a:p>
-              <a:pPr algn="ctr"/>
-              <a:endParaRPr lang="en-US"/>
-            </a:p>
-          </p:txBody>
-        </p:sp>
-        <p:sp>
-          <p:nvSpPr>
-            <p:cNvPr id="40" name="Isosceles Triangle 39">
-              <a:extLst>
-                <a:ext uri="{FF2B5EF4-FFF2-40B4-BE49-F238E27FC236}">
-                  <a16:creationId xmlns:a16="http://schemas.microsoft.com/office/drawing/2014/main" id="{99B87BC8-4AA1-49F4-1A86-6E5B0A124EED}"/>
-                </a:ext>
-              </a:extLst>
-            </p:cNvPr>
-            <p:cNvSpPr/>
-            <p:nvPr/>
-          </p:nvSpPr>
-          <p:spPr>
-            <a:xfrm rot="10800000">
-              <a:off x="3869157" y="2947814"/>
-              <a:ext cx="152402" cy="1250950"/>
-            </a:xfrm>
-            <a:prstGeom prst="triangle">
-              <a:avLst/>
-            </a:prstGeom>
-          </p:spPr>
-          <p:style>
-            <a:lnRef idx="2">
-              <a:schemeClr val="dk1">
-                <a:shade val="50000"/>
-              </a:schemeClr>
-            </a:lnRef>
-            <a:fillRef idx="1">
-              <a:schemeClr val="dk1"/>
-            </a:fillRef>
-            <a:effectRef idx="0">
-              <a:schemeClr val="dk1"/>
-            </a:effectRef>
-            <a:fontRef idx="minor">
-              <a:schemeClr val="lt1"/>
-            </a:fontRef>
-          </p:style>
-          <p:txBody>
-            <a:bodyPr rtlCol="0" anchor="ctr"/>
-            <a:lstStyle/>
-            <a:p>
-              <a:pPr algn="ctr"/>
-              <a:endParaRPr lang="en-US"/>
-            </a:p>
-          </p:txBody>
-        </p:sp>
-        <p:sp>
-          <p:nvSpPr>
-            <p:cNvPr id="18" name="Rectangle 17">
-              <a:extLst>
-                <a:ext uri="{FF2B5EF4-FFF2-40B4-BE49-F238E27FC236}">
-                  <a16:creationId xmlns:a16="http://schemas.microsoft.com/office/drawing/2014/main" id="{B94ABFCB-E0CF-2FE9-1D1D-847E59D4ECDC}"/>
-                </a:ext>
-              </a:extLst>
-            </p:cNvPr>
-            <p:cNvSpPr/>
-            <p:nvPr/>
-          </p:nvSpPr>
-          <p:spPr>
-            <a:xfrm>
-              <a:off x="3248025" y="1227137"/>
-              <a:ext cx="215900" cy="766763"/>
-            </a:xfrm>
-            <a:prstGeom prst="rect">
-              <a:avLst/>
-            </a:prstGeom>
-          </p:spPr>
-          <p:style>
-            <a:lnRef idx="2">
-              <a:schemeClr val="dk1"/>
-            </a:lnRef>
-            <a:fillRef idx="1">
-              <a:schemeClr val="lt1"/>
-            </a:fillRef>
-            <a:effectRef idx="0">
-              <a:schemeClr val="dk1"/>
-            </a:effectRef>
-            <a:fontRef idx="minor">
-              <a:schemeClr val="dk1"/>
-            </a:fontRef>
-          </p:style>
-          <p:txBody>
-            <a:bodyPr rtlCol="0" anchor="ctr"/>
-            <a:lstStyle/>
-            <a:p>
-              <a:pPr algn="ctr"/>
-              <a:endParaRPr lang="en-US"/>
-            </a:p>
-          </p:txBody>
-        </p:sp>
-        <p:sp>
-          <p:nvSpPr>
-            <p:cNvPr id="42" name="Rectangle 41">
-              <a:extLst>
-                <a:ext uri="{FF2B5EF4-FFF2-40B4-BE49-F238E27FC236}">
-                  <a16:creationId xmlns:a16="http://schemas.microsoft.com/office/drawing/2014/main" id="{FC055838-3FDF-25B4-2A9B-5B79F532EB71}"/>
-                </a:ext>
-              </a:extLst>
-            </p:cNvPr>
-            <p:cNvSpPr/>
-            <p:nvPr/>
-          </p:nvSpPr>
-          <p:spPr>
-            <a:xfrm>
-              <a:off x="4422775" y="1227136"/>
-              <a:ext cx="215900" cy="766764"/>
-            </a:xfrm>
-            <a:prstGeom prst="rect">
-              <a:avLst/>
-            </a:prstGeom>
-          </p:spPr>
-          <p:style>
-            <a:lnRef idx="2">
-              <a:schemeClr val="dk1"/>
-            </a:lnRef>
-            <a:fillRef idx="1">
-              <a:schemeClr val="lt1"/>
-            </a:fillRef>
-            <a:effectRef idx="0">
-              <a:schemeClr val="dk1"/>
-            </a:effectRef>
-            <a:fontRef idx="minor">
-              <a:schemeClr val="dk1"/>
-            </a:fontRef>
-          </p:style>
-          <p:txBody>
-            <a:bodyPr rtlCol="0" anchor="ctr"/>
-            <a:lstStyle/>
-            <a:p>
-              <a:pPr algn="ctr"/>
-              <a:endParaRPr lang="en-US"/>
-            </a:p>
-          </p:txBody>
-        </p:sp>
-      </p:grpSp>
-      <p:grpSp>
-        <p:nvGrpSpPr>
-          <p:cNvPr id="22" name="Group 21">
-            <a:extLst>
-              <a:ext uri="{FF2B5EF4-FFF2-40B4-BE49-F238E27FC236}">
-                <a16:creationId xmlns:a16="http://schemas.microsoft.com/office/drawing/2014/main" id="{18BE5F6B-478D-573E-9C76-37A0135DBE17}"/>
-              </a:ext>
-            </a:extLst>
-          </p:cNvPr>
-          <p:cNvGrpSpPr/>
-          <p:nvPr/>
-        </p:nvGrpSpPr>
-        <p:grpSpPr>
-          <a:xfrm>
-            <a:off x="2296423" y="548069"/>
-            <a:ext cx="502920" cy="1014984"/>
-            <a:chOff x="5380031" y="966102"/>
-            <a:chExt cx="1727200" cy="3248141"/>
-          </a:xfrm>
-        </p:grpSpPr>
-        <p:sp>
-          <p:nvSpPr>
-            <p:cNvPr id="20" name="Moon 19">
-              <a:extLst>
-                <a:ext uri="{FF2B5EF4-FFF2-40B4-BE49-F238E27FC236}">
-                  <a16:creationId xmlns:a16="http://schemas.microsoft.com/office/drawing/2014/main" id="{E95D41D4-AD08-AD39-A14F-F05C5D38C635}"/>
-                </a:ext>
-              </a:extLst>
-            </p:cNvPr>
-            <p:cNvSpPr/>
-            <p:nvPr/>
-          </p:nvSpPr>
-          <p:spPr>
-            <a:xfrm rot="19627358">
-              <a:off x="5549196" y="966102"/>
-              <a:ext cx="450850" cy="984250"/>
-            </a:xfrm>
-            <a:prstGeom prst="moon">
-              <a:avLst/>
-            </a:prstGeom>
-          </p:spPr>
-          <p:style>
-            <a:lnRef idx="2">
-              <a:schemeClr val="dk1"/>
-            </a:lnRef>
-            <a:fillRef idx="1">
-              <a:schemeClr val="lt1"/>
-            </a:fillRef>
-            <a:effectRef idx="0">
-              <a:schemeClr val="dk1"/>
-            </a:effectRef>
-            <a:fontRef idx="minor">
-              <a:schemeClr val="dk1"/>
-            </a:fontRef>
-          </p:style>
-          <p:txBody>
-            <a:bodyPr rtlCol="0" anchor="ctr"/>
-            <a:lstStyle/>
-            <a:p>
-              <a:pPr algn="ctr"/>
-              <a:endParaRPr lang="en-US"/>
-            </a:p>
-          </p:txBody>
-        </p:sp>
-        <p:sp>
-          <p:nvSpPr>
-            <p:cNvPr id="61" name="Moon 60">
-              <a:extLst>
-                <a:ext uri="{FF2B5EF4-FFF2-40B4-BE49-F238E27FC236}">
-                  <a16:creationId xmlns:a16="http://schemas.microsoft.com/office/drawing/2014/main" id="{1EAC84D0-0BB6-E938-EC63-7135681FB63F}"/>
-                </a:ext>
-              </a:extLst>
-            </p:cNvPr>
-            <p:cNvSpPr/>
-            <p:nvPr/>
-          </p:nvSpPr>
-          <p:spPr>
-            <a:xfrm rot="1972642" flipH="1">
-              <a:off x="6518602" y="966104"/>
-              <a:ext cx="450850" cy="984250"/>
-            </a:xfrm>
-            <a:prstGeom prst="moon">
-              <a:avLst/>
-            </a:prstGeom>
-          </p:spPr>
-          <p:style>
-            <a:lnRef idx="2">
-              <a:schemeClr val="dk1"/>
-            </a:lnRef>
-            <a:fillRef idx="1">
-              <a:schemeClr val="lt1"/>
-            </a:fillRef>
-            <a:effectRef idx="0">
-              <a:schemeClr val="dk1"/>
-            </a:effectRef>
-            <a:fontRef idx="minor">
-              <a:schemeClr val="dk1"/>
-            </a:fontRef>
-          </p:style>
-          <p:txBody>
-            <a:bodyPr rtlCol="0" anchor="ctr"/>
-            <a:lstStyle/>
-            <a:p>
-              <a:pPr algn="ctr"/>
-              <a:endParaRPr lang="en-US"/>
-            </a:p>
-          </p:txBody>
-        </p:sp>
-        <p:sp>
-          <p:nvSpPr>
-            <p:cNvPr id="43" name="Oval 42">
-              <a:extLst>
-                <a:ext uri="{FF2B5EF4-FFF2-40B4-BE49-F238E27FC236}">
-                  <a16:creationId xmlns:a16="http://schemas.microsoft.com/office/drawing/2014/main" id="{08329DD8-9A31-5259-0D08-5C3CC972588F}"/>
-                </a:ext>
-              </a:extLst>
-            </p:cNvPr>
-            <p:cNvSpPr/>
-            <p:nvPr/>
-          </p:nvSpPr>
-          <p:spPr>
-            <a:xfrm>
-              <a:off x="5852869" y="1025129"/>
-              <a:ext cx="787400" cy="984250"/>
-            </a:xfrm>
-            <a:prstGeom prst="ellipse">
-              <a:avLst/>
-            </a:prstGeom>
-          </p:spPr>
-          <p:style>
-            <a:lnRef idx="2">
-              <a:schemeClr val="dk1">
-                <a:shade val="50000"/>
-              </a:schemeClr>
-            </a:lnRef>
-            <a:fillRef idx="1">
-              <a:schemeClr val="dk1"/>
-            </a:fillRef>
-            <a:effectRef idx="0">
-              <a:schemeClr val="dk1"/>
-            </a:effectRef>
-            <a:fontRef idx="minor">
-              <a:schemeClr val="lt1"/>
-            </a:fontRef>
-          </p:style>
-          <p:txBody>
-            <a:bodyPr rtlCol="0" anchor="ctr"/>
-            <a:lstStyle/>
-            <a:p>
-              <a:pPr algn="ctr"/>
-              <a:endParaRPr lang="en-US"/>
-            </a:p>
-          </p:txBody>
-        </p:sp>
-        <p:grpSp>
-          <p:nvGrpSpPr>
-            <p:cNvPr id="45" name="Group 44">
-              <a:extLst>
-                <a:ext uri="{FF2B5EF4-FFF2-40B4-BE49-F238E27FC236}">
-                  <a16:creationId xmlns:a16="http://schemas.microsoft.com/office/drawing/2014/main" id="{E3D82530-25BB-7B78-F396-EC90FDCFBBD1}"/>
-                </a:ext>
-              </a:extLst>
-            </p:cNvPr>
-            <p:cNvGrpSpPr/>
-            <p:nvPr/>
-          </p:nvGrpSpPr>
-          <p:grpSpPr>
-            <a:xfrm>
-              <a:off x="6585602" y="2135640"/>
-              <a:ext cx="291335" cy="2073380"/>
-              <a:chOff x="4282383" y="2120161"/>
-              <a:chExt cx="291335" cy="2073380"/>
-            </a:xfrm>
-          </p:grpSpPr>
-          <p:sp>
-            <p:nvSpPr>
-              <p:cNvPr id="46" name="Rectangle 45">
-                <a:extLst>
-                  <a:ext uri="{FF2B5EF4-FFF2-40B4-BE49-F238E27FC236}">
-                    <a16:creationId xmlns:a16="http://schemas.microsoft.com/office/drawing/2014/main" id="{23252941-D171-D4AC-9958-B7370AFD1A74}"/>
-                  </a:ext>
-                </a:extLst>
-              </p:cNvPr>
-              <p:cNvSpPr/>
-              <p:nvPr/>
-            </p:nvSpPr>
-            <p:spPr>
-              <a:xfrm rot="3958351">
-                <a:off x="3893446" y="2509098"/>
-                <a:ext cx="996950" cy="219075"/>
-              </a:xfrm>
-              <a:prstGeom prst="rect">
-                <a:avLst/>
-              </a:prstGeom>
-            </p:spPr>
-            <p:style>
-              <a:lnRef idx="2">
-                <a:schemeClr val="dk1">
-                  <a:shade val="50000"/>
-                </a:schemeClr>
-              </a:lnRef>
-              <a:fillRef idx="1">
-                <a:schemeClr val="dk1"/>
-              </a:fillRef>
-              <a:effectRef idx="0">
-                <a:schemeClr val="dk1"/>
-              </a:effectRef>
-              <a:fontRef idx="minor">
-                <a:schemeClr val="lt1"/>
-              </a:fontRef>
-            </p:style>
-            <p:txBody>
-              <a:bodyPr rtlCol="0" anchor="ctr"/>
-              <a:lstStyle/>
-              <a:p>
-                <a:pPr algn="ctr"/>
-                <a:endParaRPr lang="en-US"/>
-              </a:p>
-            </p:txBody>
-          </p:sp>
-          <p:sp>
-            <p:nvSpPr>
-              <p:cNvPr id="47" name="Isosceles Triangle 46">
-                <a:extLst>
-                  <a:ext uri="{FF2B5EF4-FFF2-40B4-BE49-F238E27FC236}">
-                    <a16:creationId xmlns:a16="http://schemas.microsoft.com/office/drawing/2014/main" id="{C4379557-A972-423D-3572-9827516BEC4C}"/>
-                  </a:ext>
-                </a:extLst>
-              </p:cNvPr>
-              <p:cNvSpPr/>
-              <p:nvPr/>
-            </p:nvSpPr>
-            <p:spPr>
-              <a:xfrm rot="11268472">
-                <a:off x="4421316" y="2942591"/>
-                <a:ext cx="152402" cy="1250950"/>
-              </a:xfrm>
-              <a:prstGeom prst="triangle">
-                <a:avLst/>
-              </a:prstGeom>
-            </p:spPr>
-            <p:style>
-              <a:lnRef idx="2">
-                <a:schemeClr val="dk1">
-                  <a:shade val="50000"/>
-                </a:schemeClr>
-              </a:lnRef>
-              <a:fillRef idx="1">
-                <a:schemeClr val="dk1"/>
-              </a:fillRef>
-              <a:effectRef idx="0">
-                <a:schemeClr val="dk1"/>
-              </a:effectRef>
-              <a:fontRef idx="minor">
-                <a:schemeClr val="lt1"/>
-              </a:fontRef>
-            </p:style>
-            <p:txBody>
-              <a:bodyPr rtlCol="0" anchor="ctr"/>
-              <a:lstStyle/>
-              <a:p>
-                <a:pPr algn="ctr"/>
-                <a:endParaRPr lang="en-US"/>
-              </a:p>
-            </p:txBody>
-          </p:sp>
-        </p:grpSp>
-        <p:grpSp>
-          <p:nvGrpSpPr>
-            <p:cNvPr id="48" name="Group 47">
-              <a:extLst>
-                <a:ext uri="{FF2B5EF4-FFF2-40B4-BE49-F238E27FC236}">
-                  <a16:creationId xmlns:a16="http://schemas.microsoft.com/office/drawing/2014/main" id="{2D2BD7C5-76A9-A619-C8B7-FE03919E99A0}"/>
-                </a:ext>
-              </a:extLst>
-            </p:cNvPr>
-            <p:cNvGrpSpPr/>
-            <p:nvPr/>
-          </p:nvGrpSpPr>
-          <p:grpSpPr>
-            <a:xfrm flipH="1">
-              <a:off x="5612334" y="2140194"/>
-              <a:ext cx="291335" cy="2073380"/>
-              <a:chOff x="4282383" y="2120161"/>
-              <a:chExt cx="291335" cy="2073380"/>
-            </a:xfrm>
-          </p:grpSpPr>
-          <p:sp>
-            <p:nvSpPr>
-              <p:cNvPr id="49" name="Rectangle 48">
-                <a:extLst>
-                  <a:ext uri="{FF2B5EF4-FFF2-40B4-BE49-F238E27FC236}">
-                    <a16:creationId xmlns:a16="http://schemas.microsoft.com/office/drawing/2014/main" id="{2FAAE068-751B-49DC-5680-34E68D0A3C9F}"/>
-                  </a:ext>
-                </a:extLst>
-              </p:cNvPr>
-              <p:cNvSpPr/>
-              <p:nvPr/>
-            </p:nvSpPr>
-            <p:spPr>
-              <a:xfrm rot="3958351">
-                <a:off x="3893446" y="2509098"/>
-                <a:ext cx="996950" cy="219075"/>
-              </a:xfrm>
-              <a:prstGeom prst="rect">
-                <a:avLst/>
-              </a:prstGeom>
-            </p:spPr>
-            <p:style>
-              <a:lnRef idx="2">
-                <a:schemeClr val="dk1">
-                  <a:shade val="50000"/>
-                </a:schemeClr>
-              </a:lnRef>
-              <a:fillRef idx="1">
-                <a:schemeClr val="dk1"/>
-              </a:fillRef>
-              <a:effectRef idx="0">
-                <a:schemeClr val="dk1"/>
-              </a:effectRef>
-              <a:fontRef idx="minor">
-                <a:schemeClr val="lt1"/>
-              </a:fontRef>
-            </p:style>
-            <p:txBody>
-              <a:bodyPr rtlCol="0" anchor="ctr"/>
-              <a:lstStyle/>
-              <a:p>
-                <a:pPr algn="ctr"/>
-                <a:endParaRPr lang="en-US"/>
-              </a:p>
-            </p:txBody>
-          </p:sp>
-          <p:sp>
-            <p:nvSpPr>
-              <p:cNvPr id="50" name="Isosceles Triangle 49">
-                <a:extLst>
-                  <a:ext uri="{FF2B5EF4-FFF2-40B4-BE49-F238E27FC236}">
-                    <a16:creationId xmlns:a16="http://schemas.microsoft.com/office/drawing/2014/main" id="{9AA4BCE5-F4F1-B611-C793-F485A6748A3A}"/>
-                  </a:ext>
-                </a:extLst>
-              </p:cNvPr>
-              <p:cNvSpPr/>
-              <p:nvPr/>
-            </p:nvSpPr>
-            <p:spPr>
-              <a:xfrm rot="11268472">
-                <a:off x="4421316" y="2942591"/>
-                <a:ext cx="152402" cy="1250950"/>
-              </a:xfrm>
-              <a:prstGeom prst="triangle">
-                <a:avLst/>
-              </a:prstGeom>
-            </p:spPr>
-            <p:style>
-              <a:lnRef idx="2">
-                <a:schemeClr val="dk1">
-                  <a:shade val="50000"/>
-                </a:schemeClr>
-              </a:lnRef>
-              <a:fillRef idx="1">
-                <a:schemeClr val="dk1"/>
-              </a:fillRef>
-              <a:effectRef idx="0">
-                <a:schemeClr val="dk1"/>
-              </a:effectRef>
-              <a:fontRef idx="minor">
-                <a:schemeClr val="lt1"/>
-              </a:fontRef>
-            </p:style>
-            <p:txBody>
-              <a:bodyPr rtlCol="0" anchor="ctr"/>
-              <a:lstStyle/>
-              <a:p>
-                <a:pPr algn="ctr"/>
-                <a:endParaRPr lang="en-US"/>
-              </a:p>
-            </p:txBody>
-          </p:sp>
-        </p:grpSp>
-        <p:sp>
-          <p:nvSpPr>
-            <p:cNvPr id="51" name="Rectangle 50">
-              <a:extLst>
-                <a:ext uri="{FF2B5EF4-FFF2-40B4-BE49-F238E27FC236}">
-                  <a16:creationId xmlns:a16="http://schemas.microsoft.com/office/drawing/2014/main" id="{0F48EA78-F7DC-B13A-6157-459D28BD6199}"/>
-                </a:ext>
-              </a:extLst>
-            </p:cNvPr>
-            <p:cNvSpPr/>
-            <p:nvPr/>
-          </p:nvSpPr>
-          <p:spPr>
-            <a:xfrm rot="5400000">
-              <a:off x="5745156" y="2601517"/>
-              <a:ext cx="996950" cy="219075"/>
-            </a:xfrm>
-            <a:prstGeom prst="rect">
-              <a:avLst/>
-            </a:prstGeom>
-          </p:spPr>
-          <p:style>
-            <a:lnRef idx="2">
-              <a:schemeClr val="dk1">
-                <a:shade val="50000"/>
-              </a:schemeClr>
-            </a:lnRef>
-            <a:fillRef idx="1">
-              <a:schemeClr val="dk1"/>
-            </a:fillRef>
-            <a:effectRef idx="0">
-              <a:schemeClr val="dk1"/>
-            </a:effectRef>
-            <a:fontRef idx="minor">
-              <a:schemeClr val="lt1"/>
-            </a:fontRef>
-          </p:style>
-          <p:txBody>
-            <a:bodyPr rtlCol="0" anchor="ctr"/>
-            <a:lstStyle/>
-            <a:p>
-              <a:pPr algn="ctr"/>
-              <a:endParaRPr lang="en-US"/>
-            </a:p>
-          </p:txBody>
-        </p:sp>
-        <p:sp>
-          <p:nvSpPr>
-            <p:cNvPr id="52" name="Isosceles Triangle 51">
-              <a:extLst>
-                <a:ext uri="{FF2B5EF4-FFF2-40B4-BE49-F238E27FC236}">
-                  <a16:creationId xmlns:a16="http://schemas.microsoft.com/office/drawing/2014/main" id="{DCFCA97B-0D8E-7C80-06D2-684CA14063C8}"/>
-                </a:ext>
-              </a:extLst>
-            </p:cNvPr>
-            <p:cNvSpPr/>
-            <p:nvPr/>
-          </p:nvSpPr>
-          <p:spPr>
-            <a:xfrm rot="10800000">
-              <a:off x="6172376" y="2963293"/>
-              <a:ext cx="152402" cy="1250950"/>
-            </a:xfrm>
-            <a:prstGeom prst="triangle">
-              <a:avLst/>
-            </a:prstGeom>
-          </p:spPr>
-          <p:style>
-            <a:lnRef idx="2">
-              <a:schemeClr val="dk1">
-                <a:shade val="50000"/>
-              </a:schemeClr>
-            </a:lnRef>
-            <a:fillRef idx="1">
-              <a:schemeClr val="dk1"/>
-            </a:fillRef>
-            <a:effectRef idx="0">
-              <a:schemeClr val="dk1"/>
-            </a:effectRef>
-            <a:fontRef idx="minor">
-              <a:schemeClr val="lt1"/>
-            </a:fontRef>
-          </p:style>
-          <p:txBody>
-            <a:bodyPr rtlCol="0" anchor="ctr"/>
-            <a:lstStyle/>
-            <a:p>
-              <a:pPr algn="ctr"/>
-              <a:endParaRPr lang="en-US"/>
-            </a:p>
-          </p:txBody>
-        </p:sp>
-        <p:sp>
-          <p:nvSpPr>
-            <p:cNvPr id="19" name="Moon 18">
-              <a:extLst>
-                <a:ext uri="{FF2B5EF4-FFF2-40B4-BE49-F238E27FC236}">
-                  <a16:creationId xmlns:a16="http://schemas.microsoft.com/office/drawing/2014/main" id="{5DFC7713-3DA5-1972-0709-F93537967C67}"/>
-                </a:ext>
-              </a:extLst>
-            </p:cNvPr>
-            <p:cNvSpPr/>
-            <p:nvPr/>
-          </p:nvSpPr>
-          <p:spPr>
-            <a:xfrm rot="16200000">
-              <a:off x="6002331" y="1326503"/>
-              <a:ext cx="482600" cy="1727200"/>
-            </a:xfrm>
-            <a:prstGeom prst="moon">
-              <a:avLst/>
-            </a:prstGeom>
-          </p:spPr>
-          <p:style>
-            <a:lnRef idx="2">
-              <a:schemeClr val="dk1">
-                <a:shade val="50000"/>
-              </a:schemeClr>
-            </a:lnRef>
-            <a:fillRef idx="1">
-              <a:schemeClr val="dk1"/>
-            </a:fillRef>
-            <a:effectRef idx="0">
-              <a:schemeClr val="dk1"/>
-            </a:effectRef>
-            <a:fontRef idx="minor">
-              <a:schemeClr val="lt1"/>
-            </a:fontRef>
-          </p:style>
-          <p:txBody>
-            <a:bodyPr rtlCol="0" anchor="ctr"/>
-            <a:lstStyle/>
-            <a:p>
-              <a:pPr algn="ctr"/>
-              <a:endParaRPr lang="en-US"/>
-            </a:p>
-          </p:txBody>
-        </p:sp>
-      </p:grpSp>
-      <p:grpSp>
-        <p:nvGrpSpPr>
           <p:cNvPr id="63" name="Group 62">
             <a:extLst>
               <a:ext uri="{FF2B5EF4-FFF2-40B4-BE49-F238E27FC236}">
@@ -18563,36 +18299,6 @@
           </p:txBody>
         </p:sp>
       </p:grpSp>
-      <p:pic>
-        <p:nvPicPr>
-          <p:cNvPr id="24" name="Picture 23">
-            <a:extLst>
-              <a:ext uri="{FF2B5EF4-FFF2-40B4-BE49-F238E27FC236}">
-                <a16:creationId xmlns:a16="http://schemas.microsoft.com/office/drawing/2014/main" id="{2F2ED8C1-53DF-F73B-F74C-0D7AC6528101}"/>
-              </a:ext>
-            </a:extLst>
-          </p:cNvPr>
-          <p:cNvPicPr>
-            <a:picLocks noChangeAspect="1"/>
-          </p:cNvPicPr>
-          <p:nvPr/>
-        </p:nvPicPr>
-        <p:blipFill>
-          <a:blip r:embed="rId3"/>
-          <a:stretch>
-            <a:fillRect/>
-          </a:stretch>
-        </p:blipFill>
-        <p:spPr>
-          <a:xfrm>
-            <a:off x="2836236" y="813118"/>
-            <a:ext cx="277209" cy="415814"/>
-          </a:xfrm>
-          <a:prstGeom prst="rect">
-            <a:avLst/>
-          </a:prstGeom>
-        </p:spPr>
-      </p:pic>
     </p:spTree>
     <p:extLst>
       <p:ext uri="{BB962C8B-B14F-4D97-AF65-F5344CB8AC3E}">
@@ -23179,6 +22885,907 @@
           </a:prstGeom>
         </p:spPr>
       </p:pic>
+      <p:grpSp>
+        <p:nvGrpSpPr>
+          <p:cNvPr id="145" name="Group 144">
+            <a:extLst>
+              <a:ext uri="{FF2B5EF4-FFF2-40B4-BE49-F238E27FC236}">
+                <a16:creationId xmlns:a16="http://schemas.microsoft.com/office/drawing/2014/main" id="{DBB0B142-B0B1-9AB0-A578-7503645128F2}"/>
+              </a:ext>
+            </a:extLst>
+          </p:cNvPr>
+          <p:cNvGrpSpPr/>
+          <p:nvPr/>
+        </p:nvGrpSpPr>
+        <p:grpSpPr>
+          <a:xfrm>
+            <a:off x="9539183" y="811523"/>
+            <a:ext cx="1027167" cy="1035721"/>
+            <a:chOff x="4165279" y="376316"/>
+            <a:chExt cx="4372510" cy="4408922"/>
+          </a:xfrm>
+        </p:grpSpPr>
+        <p:grpSp>
+          <p:nvGrpSpPr>
+            <p:cNvPr id="146" name="Group 145">
+              <a:extLst>
+                <a:ext uri="{FF2B5EF4-FFF2-40B4-BE49-F238E27FC236}">
+                  <a16:creationId xmlns:a16="http://schemas.microsoft.com/office/drawing/2014/main" id="{B4F1C6C6-B6B3-3951-8A2A-B125FDC763A1}"/>
+                </a:ext>
+              </a:extLst>
+            </p:cNvPr>
+            <p:cNvGrpSpPr/>
+            <p:nvPr/>
+          </p:nvGrpSpPr>
+          <p:grpSpPr>
+            <a:xfrm>
+              <a:off x="5618932" y="1546108"/>
+              <a:ext cx="1540121" cy="2162098"/>
+              <a:chOff x="5452330" y="1708793"/>
+              <a:chExt cx="1186621" cy="1665837"/>
+            </a:xfrm>
+          </p:grpSpPr>
+          <p:sp>
+            <p:nvSpPr>
+              <p:cNvPr id="167" name="Isosceles Triangle 166">
+                <a:extLst>
+                  <a:ext uri="{FF2B5EF4-FFF2-40B4-BE49-F238E27FC236}">
+                    <a16:creationId xmlns:a16="http://schemas.microsoft.com/office/drawing/2014/main" id="{77184497-6B7E-1444-A5CA-EA936053CBE6}"/>
+                  </a:ext>
+                </a:extLst>
+              </p:cNvPr>
+              <p:cNvSpPr/>
+              <p:nvPr/>
+            </p:nvSpPr>
+            <p:spPr>
+              <a:xfrm>
+                <a:off x="5794991" y="1708793"/>
+                <a:ext cx="501300" cy="440002"/>
+              </a:xfrm>
+              <a:prstGeom prst="triangle">
+                <a:avLst/>
+              </a:prstGeom>
+            </p:spPr>
+            <p:style>
+              <a:lnRef idx="2">
+                <a:schemeClr val="dk1">
+                  <a:shade val="50000"/>
+                </a:schemeClr>
+              </a:lnRef>
+              <a:fillRef idx="1">
+                <a:schemeClr val="dk1"/>
+              </a:fillRef>
+              <a:effectRef idx="0">
+                <a:schemeClr val="dk1"/>
+              </a:effectRef>
+              <a:fontRef idx="minor">
+                <a:schemeClr val="lt1"/>
+              </a:fontRef>
+            </p:style>
+            <p:txBody>
+              <a:bodyPr rtlCol="0" anchor="ctr"/>
+              <a:lstStyle/>
+              <a:p>
+                <a:pPr algn="ctr"/>
+                <a:endParaRPr lang="en-US"/>
+              </a:p>
+            </p:txBody>
+          </p:sp>
+          <p:sp>
+            <p:nvSpPr>
+              <p:cNvPr id="168" name="Isosceles Triangle 167">
+                <a:extLst>
+                  <a:ext uri="{FF2B5EF4-FFF2-40B4-BE49-F238E27FC236}">
+                    <a16:creationId xmlns:a16="http://schemas.microsoft.com/office/drawing/2014/main" id="{A485807E-27D8-4D66-1A94-3E2FD526D3EC}"/>
+                  </a:ext>
+                </a:extLst>
+              </p:cNvPr>
+              <p:cNvSpPr/>
+              <p:nvPr/>
+            </p:nvSpPr>
+            <p:spPr>
+              <a:xfrm rot="10800000">
+                <a:off x="5794991" y="2236075"/>
+                <a:ext cx="501300" cy="1138555"/>
+              </a:xfrm>
+              <a:prstGeom prst="triangle">
+                <a:avLst/>
+              </a:prstGeom>
+            </p:spPr>
+            <p:style>
+              <a:lnRef idx="2">
+                <a:schemeClr val="dk1">
+                  <a:shade val="50000"/>
+                </a:schemeClr>
+              </a:lnRef>
+              <a:fillRef idx="1">
+                <a:schemeClr val="dk1"/>
+              </a:fillRef>
+              <a:effectRef idx="0">
+                <a:schemeClr val="dk1"/>
+              </a:effectRef>
+              <a:fontRef idx="minor">
+                <a:schemeClr val="lt1"/>
+              </a:fontRef>
+            </p:style>
+            <p:txBody>
+              <a:bodyPr rtlCol="0" anchor="ctr"/>
+              <a:lstStyle/>
+              <a:p>
+                <a:pPr algn="ctr"/>
+                <a:endParaRPr lang="en-US"/>
+              </a:p>
+            </p:txBody>
+          </p:sp>
+          <p:sp>
+            <p:nvSpPr>
+              <p:cNvPr id="169" name="Rectangle 168">
+                <a:extLst>
+                  <a:ext uri="{FF2B5EF4-FFF2-40B4-BE49-F238E27FC236}">
+                    <a16:creationId xmlns:a16="http://schemas.microsoft.com/office/drawing/2014/main" id="{7FD55D15-2BB7-955F-D820-D4D61FC0CF10}"/>
+                  </a:ext>
+                </a:extLst>
+              </p:cNvPr>
+              <p:cNvSpPr/>
+              <p:nvPr/>
+            </p:nvSpPr>
+            <p:spPr>
+              <a:xfrm rot="1172583">
+                <a:off x="5452330" y="2155246"/>
+                <a:ext cx="161133" cy="711668"/>
+              </a:xfrm>
+              <a:prstGeom prst="rect">
+                <a:avLst/>
+              </a:prstGeom>
+            </p:spPr>
+            <p:style>
+              <a:lnRef idx="2">
+                <a:schemeClr val="dk1">
+                  <a:shade val="50000"/>
+                </a:schemeClr>
+              </a:lnRef>
+              <a:fillRef idx="1">
+                <a:schemeClr val="dk1"/>
+              </a:fillRef>
+              <a:effectRef idx="0">
+                <a:schemeClr val="dk1"/>
+              </a:effectRef>
+              <a:fontRef idx="minor">
+                <a:schemeClr val="lt1"/>
+              </a:fontRef>
+            </p:style>
+            <p:txBody>
+              <a:bodyPr rtlCol="0" anchor="ctr"/>
+              <a:lstStyle/>
+              <a:p>
+                <a:pPr algn="ctr"/>
+                <a:endParaRPr lang="en-US"/>
+              </a:p>
+            </p:txBody>
+          </p:sp>
+          <p:sp>
+            <p:nvSpPr>
+              <p:cNvPr id="170" name="Rectangle 169">
+                <a:extLst>
+                  <a:ext uri="{FF2B5EF4-FFF2-40B4-BE49-F238E27FC236}">
+                    <a16:creationId xmlns:a16="http://schemas.microsoft.com/office/drawing/2014/main" id="{EBCBB169-2CFC-856A-AE60-53A760D9C6BE}"/>
+                  </a:ext>
+                </a:extLst>
+              </p:cNvPr>
+              <p:cNvSpPr/>
+              <p:nvPr/>
+            </p:nvSpPr>
+            <p:spPr>
+              <a:xfrm rot="20427417" flipH="1">
+                <a:off x="6477818" y="2155248"/>
+                <a:ext cx="161133" cy="711668"/>
+              </a:xfrm>
+              <a:prstGeom prst="rect">
+                <a:avLst/>
+              </a:prstGeom>
+            </p:spPr>
+            <p:style>
+              <a:lnRef idx="2">
+                <a:schemeClr val="dk1">
+                  <a:shade val="50000"/>
+                </a:schemeClr>
+              </a:lnRef>
+              <a:fillRef idx="1">
+                <a:schemeClr val="dk1"/>
+              </a:fillRef>
+              <a:effectRef idx="0">
+                <a:schemeClr val="dk1"/>
+              </a:effectRef>
+              <a:fontRef idx="minor">
+                <a:schemeClr val="lt1"/>
+              </a:fontRef>
+            </p:style>
+            <p:txBody>
+              <a:bodyPr rtlCol="0" anchor="ctr"/>
+              <a:lstStyle/>
+              <a:p>
+                <a:pPr algn="ctr"/>
+                <a:endParaRPr lang="en-US"/>
+              </a:p>
+            </p:txBody>
+          </p:sp>
+        </p:grpSp>
+        <p:grpSp>
+          <p:nvGrpSpPr>
+            <p:cNvPr id="147" name="Group 146">
+              <a:extLst>
+                <a:ext uri="{FF2B5EF4-FFF2-40B4-BE49-F238E27FC236}">
+                  <a16:creationId xmlns:a16="http://schemas.microsoft.com/office/drawing/2014/main" id="{64987AF0-3461-5A21-711E-4566429B1A75}"/>
+                </a:ext>
+              </a:extLst>
+            </p:cNvPr>
+            <p:cNvGrpSpPr/>
+            <p:nvPr/>
+          </p:nvGrpSpPr>
+          <p:grpSpPr>
+            <a:xfrm>
+              <a:off x="5223090" y="376316"/>
+              <a:ext cx="2327564" cy="1339103"/>
+              <a:chOff x="5223090" y="758463"/>
+              <a:chExt cx="2327564" cy="1339103"/>
+            </a:xfrm>
+          </p:grpSpPr>
+          <p:pic>
+            <p:nvPicPr>
+              <p:cNvPr id="163" name="Picture 162">
+                <a:extLst>
+                  <a:ext uri="{FF2B5EF4-FFF2-40B4-BE49-F238E27FC236}">
+                    <a16:creationId xmlns:a16="http://schemas.microsoft.com/office/drawing/2014/main" id="{E6E2D24E-9922-BB33-168F-F4B3BA27BAFD}"/>
+                  </a:ext>
+                </a:extLst>
+              </p:cNvPr>
+              <p:cNvPicPr>
+                <a:picLocks noChangeAspect="1"/>
+              </p:cNvPicPr>
+              <p:nvPr/>
+            </p:nvPicPr>
+            <p:blipFill rotWithShape="1">
+              <a:blip r:embed="rId5"/>
+              <a:srcRect l="7265" t="2149" r="2137"/>
+              <a:stretch/>
+            </p:blipFill>
+            <p:spPr>
+              <a:xfrm rot="9499472">
+                <a:off x="5791200" y="758463"/>
+                <a:ext cx="501300" cy="1119886"/>
+              </a:xfrm>
+              <a:prstGeom prst="rect">
+                <a:avLst/>
+              </a:prstGeom>
+            </p:spPr>
+          </p:pic>
+          <p:pic>
+            <p:nvPicPr>
+              <p:cNvPr id="164" name="Picture 163">
+                <a:extLst>
+                  <a:ext uri="{FF2B5EF4-FFF2-40B4-BE49-F238E27FC236}">
+                    <a16:creationId xmlns:a16="http://schemas.microsoft.com/office/drawing/2014/main" id="{8BA8976D-786C-2F00-0C6F-4FD9BA408651}"/>
+                  </a:ext>
+                </a:extLst>
+              </p:cNvPr>
+              <p:cNvPicPr>
+                <a:picLocks noChangeAspect="1"/>
+              </p:cNvPicPr>
+              <p:nvPr/>
+            </p:nvPicPr>
+            <p:blipFill rotWithShape="1">
+              <a:blip r:embed="rId5"/>
+              <a:srcRect l="7265" t="2149" r="2137"/>
+              <a:stretch/>
+            </p:blipFill>
+            <p:spPr>
+              <a:xfrm rot="11335141">
+                <a:off x="6459893" y="776279"/>
+                <a:ext cx="501300" cy="1119886"/>
+              </a:xfrm>
+              <a:prstGeom prst="rect">
+                <a:avLst/>
+              </a:prstGeom>
+            </p:spPr>
+          </p:pic>
+          <p:pic>
+            <p:nvPicPr>
+              <p:cNvPr id="165" name="Picture 164">
+                <a:extLst>
+                  <a:ext uri="{FF2B5EF4-FFF2-40B4-BE49-F238E27FC236}">
+                    <a16:creationId xmlns:a16="http://schemas.microsoft.com/office/drawing/2014/main" id="{D3799764-8805-159B-12EF-6C6C9FAF5A7E}"/>
+                  </a:ext>
+                </a:extLst>
+              </p:cNvPr>
+              <p:cNvPicPr>
+                <a:picLocks noChangeAspect="1"/>
+              </p:cNvPicPr>
+              <p:nvPr/>
+            </p:nvPicPr>
+            <p:blipFill rotWithShape="1">
+              <a:blip r:embed="rId5"/>
+              <a:srcRect l="7265" t="2149" r="2137"/>
+              <a:stretch/>
+            </p:blipFill>
+            <p:spPr>
+              <a:xfrm rot="9323264" flipH="1">
+                <a:off x="5223090" y="977680"/>
+                <a:ext cx="501300" cy="1119886"/>
+              </a:xfrm>
+              <a:prstGeom prst="rect">
+                <a:avLst/>
+              </a:prstGeom>
+            </p:spPr>
+          </p:pic>
+          <p:pic>
+            <p:nvPicPr>
+              <p:cNvPr id="166" name="Picture 165">
+                <a:extLst>
+                  <a:ext uri="{FF2B5EF4-FFF2-40B4-BE49-F238E27FC236}">
+                    <a16:creationId xmlns:a16="http://schemas.microsoft.com/office/drawing/2014/main" id="{85540936-B0B9-39A1-7E20-A5DB9117623A}"/>
+                  </a:ext>
+                </a:extLst>
+              </p:cNvPr>
+              <p:cNvPicPr>
+                <a:picLocks noChangeAspect="1"/>
+              </p:cNvPicPr>
+              <p:nvPr/>
+            </p:nvPicPr>
+            <p:blipFill rotWithShape="1">
+              <a:blip r:embed="rId5"/>
+              <a:srcRect l="7265" t="2149" r="2137"/>
+              <a:stretch/>
+            </p:blipFill>
+            <p:spPr>
+              <a:xfrm rot="13424503" flipH="1">
+                <a:off x="7049354" y="966826"/>
+                <a:ext cx="501300" cy="1119886"/>
+              </a:xfrm>
+              <a:prstGeom prst="rect">
+                <a:avLst/>
+              </a:prstGeom>
+            </p:spPr>
+          </p:pic>
+        </p:grpSp>
+        <p:grpSp>
+          <p:nvGrpSpPr>
+            <p:cNvPr id="148" name="Group 147">
+              <a:extLst>
+                <a:ext uri="{FF2B5EF4-FFF2-40B4-BE49-F238E27FC236}">
+                  <a16:creationId xmlns:a16="http://schemas.microsoft.com/office/drawing/2014/main" id="{AD3D8339-98CF-FF7C-59A6-78E7DCA3BED8}"/>
+                </a:ext>
+              </a:extLst>
+            </p:cNvPr>
+            <p:cNvGrpSpPr/>
+            <p:nvPr/>
+          </p:nvGrpSpPr>
+          <p:grpSpPr>
+            <a:xfrm rot="10800000">
+              <a:off x="5212329" y="3446135"/>
+              <a:ext cx="2327564" cy="1339103"/>
+              <a:chOff x="5223090" y="758463"/>
+              <a:chExt cx="2327564" cy="1339103"/>
+            </a:xfrm>
+          </p:grpSpPr>
+          <p:pic>
+            <p:nvPicPr>
+              <p:cNvPr id="159" name="Picture 158">
+                <a:extLst>
+                  <a:ext uri="{FF2B5EF4-FFF2-40B4-BE49-F238E27FC236}">
+                    <a16:creationId xmlns:a16="http://schemas.microsoft.com/office/drawing/2014/main" id="{9A69E514-2B3E-9F3B-9B10-CBEBF2D7FC71}"/>
+                  </a:ext>
+                </a:extLst>
+              </p:cNvPr>
+              <p:cNvPicPr>
+                <a:picLocks noChangeAspect="1"/>
+              </p:cNvPicPr>
+              <p:nvPr/>
+            </p:nvPicPr>
+            <p:blipFill rotWithShape="1">
+              <a:blip r:embed="rId5"/>
+              <a:srcRect l="7265" t="2149" r="2137"/>
+              <a:stretch/>
+            </p:blipFill>
+            <p:spPr>
+              <a:xfrm rot="9499472">
+                <a:off x="5791200" y="758463"/>
+                <a:ext cx="501300" cy="1119886"/>
+              </a:xfrm>
+              <a:prstGeom prst="rect">
+                <a:avLst/>
+              </a:prstGeom>
+            </p:spPr>
+          </p:pic>
+          <p:pic>
+            <p:nvPicPr>
+              <p:cNvPr id="160" name="Picture 159">
+                <a:extLst>
+                  <a:ext uri="{FF2B5EF4-FFF2-40B4-BE49-F238E27FC236}">
+                    <a16:creationId xmlns:a16="http://schemas.microsoft.com/office/drawing/2014/main" id="{969C04AB-92B7-3D62-580F-2A56B8E905FE}"/>
+                  </a:ext>
+                </a:extLst>
+              </p:cNvPr>
+              <p:cNvPicPr>
+                <a:picLocks noChangeAspect="1"/>
+              </p:cNvPicPr>
+              <p:nvPr/>
+            </p:nvPicPr>
+            <p:blipFill rotWithShape="1">
+              <a:blip r:embed="rId5"/>
+              <a:srcRect l="7265" t="2149" r="2137"/>
+              <a:stretch/>
+            </p:blipFill>
+            <p:spPr>
+              <a:xfrm rot="11335141">
+                <a:off x="6459893" y="776279"/>
+                <a:ext cx="501300" cy="1119886"/>
+              </a:xfrm>
+              <a:prstGeom prst="rect">
+                <a:avLst/>
+              </a:prstGeom>
+            </p:spPr>
+          </p:pic>
+          <p:pic>
+            <p:nvPicPr>
+              <p:cNvPr id="161" name="Picture 160">
+                <a:extLst>
+                  <a:ext uri="{FF2B5EF4-FFF2-40B4-BE49-F238E27FC236}">
+                    <a16:creationId xmlns:a16="http://schemas.microsoft.com/office/drawing/2014/main" id="{08FF41A6-26AA-784D-C07D-A1DA628C17A6}"/>
+                  </a:ext>
+                </a:extLst>
+              </p:cNvPr>
+              <p:cNvPicPr>
+                <a:picLocks noChangeAspect="1"/>
+              </p:cNvPicPr>
+              <p:nvPr/>
+            </p:nvPicPr>
+            <p:blipFill rotWithShape="1">
+              <a:blip r:embed="rId5"/>
+              <a:srcRect l="7265" t="2149" r="2137"/>
+              <a:stretch/>
+            </p:blipFill>
+            <p:spPr>
+              <a:xfrm rot="9323264" flipH="1">
+                <a:off x="5223090" y="977680"/>
+                <a:ext cx="501300" cy="1119886"/>
+              </a:xfrm>
+              <a:prstGeom prst="rect">
+                <a:avLst/>
+              </a:prstGeom>
+            </p:spPr>
+          </p:pic>
+          <p:pic>
+            <p:nvPicPr>
+              <p:cNvPr id="162" name="Picture 161">
+                <a:extLst>
+                  <a:ext uri="{FF2B5EF4-FFF2-40B4-BE49-F238E27FC236}">
+                    <a16:creationId xmlns:a16="http://schemas.microsoft.com/office/drawing/2014/main" id="{DE7FDF25-4BE1-F272-4C1A-4C1860B8BA95}"/>
+                  </a:ext>
+                </a:extLst>
+              </p:cNvPr>
+              <p:cNvPicPr>
+                <a:picLocks noChangeAspect="1"/>
+              </p:cNvPicPr>
+              <p:nvPr/>
+            </p:nvPicPr>
+            <p:blipFill rotWithShape="1">
+              <a:blip r:embed="rId5"/>
+              <a:srcRect l="7265" t="2149" r="2137"/>
+              <a:stretch/>
+            </p:blipFill>
+            <p:spPr>
+              <a:xfrm rot="13424503" flipH="1">
+                <a:off x="7049354" y="966826"/>
+                <a:ext cx="501300" cy="1119886"/>
+              </a:xfrm>
+              <a:prstGeom prst="rect">
+                <a:avLst/>
+              </a:prstGeom>
+            </p:spPr>
+          </p:pic>
+        </p:grpSp>
+        <p:grpSp>
+          <p:nvGrpSpPr>
+            <p:cNvPr id="149" name="Group 148">
+              <a:extLst>
+                <a:ext uri="{FF2B5EF4-FFF2-40B4-BE49-F238E27FC236}">
+                  <a16:creationId xmlns:a16="http://schemas.microsoft.com/office/drawing/2014/main" id="{24F2669A-27A2-B41B-E16D-BAE52A2620ED}"/>
+                </a:ext>
+              </a:extLst>
+            </p:cNvPr>
+            <p:cNvGrpSpPr/>
+            <p:nvPr/>
+          </p:nvGrpSpPr>
+          <p:grpSpPr>
+            <a:xfrm rot="16367590">
+              <a:off x="3671049" y="1904396"/>
+              <a:ext cx="2327564" cy="1339103"/>
+              <a:chOff x="5223090" y="758463"/>
+              <a:chExt cx="2327564" cy="1339103"/>
+            </a:xfrm>
+          </p:grpSpPr>
+          <p:pic>
+            <p:nvPicPr>
+              <p:cNvPr id="155" name="Picture 154">
+                <a:extLst>
+                  <a:ext uri="{FF2B5EF4-FFF2-40B4-BE49-F238E27FC236}">
+                    <a16:creationId xmlns:a16="http://schemas.microsoft.com/office/drawing/2014/main" id="{48A1BEED-2797-183B-02B7-A6C29622C988}"/>
+                  </a:ext>
+                </a:extLst>
+              </p:cNvPr>
+              <p:cNvPicPr>
+                <a:picLocks noChangeAspect="1"/>
+              </p:cNvPicPr>
+              <p:nvPr/>
+            </p:nvPicPr>
+            <p:blipFill rotWithShape="1">
+              <a:blip r:embed="rId5"/>
+              <a:srcRect l="7265" t="2149" r="2137"/>
+              <a:stretch/>
+            </p:blipFill>
+            <p:spPr>
+              <a:xfrm rot="9499472">
+                <a:off x="5791200" y="758463"/>
+                <a:ext cx="501300" cy="1119886"/>
+              </a:xfrm>
+              <a:prstGeom prst="rect">
+                <a:avLst/>
+              </a:prstGeom>
+            </p:spPr>
+          </p:pic>
+          <p:pic>
+            <p:nvPicPr>
+              <p:cNvPr id="156" name="Picture 155">
+                <a:extLst>
+                  <a:ext uri="{FF2B5EF4-FFF2-40B4-BE49-F238E27FC236}">
+                    <a16:creationId xmlns:a16="http://schemas.microsoft.com/office/drawing/2014/main" id="{FCAA1D9B-2BE3-AFB6-C030-984D7845E00B}"/>
+                  </a:ext>
+                </a:extLst>
+              </p:cNvPr>
+              <p:cNvPicPr>
+                <a:picLocks noChangeAspect="1"/>
+              </p:cNvPicPr>
+              <p:nvPr/>
+            </p:nvPicPr>
+            <p:blipFill rotWithShape="1">
+              <a:blip r:embed="rId5"/>
+              <a:srcRect l="7265" t="2149" r="2137"/>
+              <a:stretch/>
+            </p:blipFill>
+            <p:spPr>
+              <a:xfrm rot="11335141">
+                <a:off x="6459893" y="776279"/>
+                <a:ext cx="501300" cy="1119886"/>
+              </a:xfrm>
+              <a:prstGeom prst="rect">
+                <a:avLst/>
+              </a:prstGeom>
+            </p:spPr>
+          </p:pic>
+          <p:pic>
+            <p:nvPicPr>
+              <p:cNvPr id="157" name="Picture 156">
+                <a:extLst>
+                  <a:ext uri="{FF2B5EF4-FFF2-40B4-BE49-F238E27FC236}">
+                    <a16:creationId xmlns:a16="http://schemas.microsoft.com/office/drawing/2014/main" id="{A1C7CBAD-5FD9-D36C-E5BF-62B057C3A0F5}"/>
+                  </a:ext>
+                </a:extLst>
+              </p:cNvPr>
+              <p:cNvPicPr>
+                <a:picLocks noChangeAspect="1"/>
+              </p:cNvPicPr>
+              <p:nvPr/>
+            </p:nvPicPr>
+            <p:blipFill rotWithShape="1">
+              <a:blip r:embed="rId5"/>
+              <a:srcRect l="7265" t="2149" r="2137"/>
+              <a:stretch/>
+            </p:blipFill>
+            <p:spPr>
+              <a:xfrm rot="9323264" flipH="1">
+                <a:off x="5223090" y="977680"/>
+                <a:ext cx="501300" cy="1119886"/>
+              </a:xfrm>
+              <a:prstGeom prst="rect">
+                <a:avLst/>
+              </a:prstGeom>
+            </p:spPr>
+          </p:pic>
+          <p:pic>
+            <p:nvPicPr>
+              <p:cNvPr id="158" name="Picture 157">
+                <a:extLst>
+                  <a:ext uri="{FF2B5EF4-FFF2-40B4-BE49-F238E27FC236}">
+                    <a16:creationId xmlns:a16="http://schemas.microsoft.com/office/drawing/2014/main" id="{3D37B3B9-EF90-D8EA-47A4-5CF6797268D9}"/>
+                  </a:ext>
+                </a:extLst>
+              </p:cNvPr>
+              <p:cNvPicPr>
+                <a:picLocks noChangeAspect="1"/>
+              </p:cNvPicPr>
+              <p:nvPr/>
+            </p:nvPicPr>
+            <p:blipFill rotWithShape="1">
+              <a:blip r:embed="rId5"/>
+              <a:srcRect l="7265" t="2149" r="2137"/>
+              <a:stretch/>
+            </p:blipFill>
+            <p:spPr>
+              <a:xfrm rot="13424503" flipH="1">
+                <a:off x="7049354" y="966826"/>
+                <a:ext cx="501300" cy="1119886"/>
+              </a:xfrm>
+              <a:prstGeom prst="rect">
+                <a:avLst/>
+              </a:prstGeom>
+            </p:spPr>
+          </p:pic>
+        </p:grpSp>
+        <p:grpSp>
+          <p:nvGrpSpPr>
+            <p:cNvPr id="150" name="Group 149">
+              <a:extLst>
+                <a:ext uri="{FF2B5EF4-FFF2-40B4-BE49-F238E27FC236}">
+                  <a16:creationId xmlns:a16="http://schemas.microsoft.com/office/drawing/2014/main" id="{9379E66C-653E-D856-F3DF-A33518A3DCB3}"/>
+                </a:ext>
+              </a:extLst>
+            </p:cNvPr>
+            <p:cNvGrpSpPr/>
+            <p:nvPr/>
+          </p:nvGrpSpPr>
+          <p:grpSpPr>
+            <a:xfrm rot="5400000">
+              <a:off x="6704456" y="2000299"/>
+              <a:ext cx="2327564" cy="1339103"/>
+              <a:chOff x="5223090" y="758463"/>
+              <a:chExt cx="2327564" cy="1339103"/>
+            </a:xfrm>
+          </p:grpSpPr>
+          <p:pic>
+            <p:nvPicPr>
+              <p:cNvPr id="151" name="Picture 150">
+                <a:extLst>
+                  <a:ext uri="{FF2B5EF4-FFF2-40B4-BE49-F238E27FC236}">
+                    <a16:creationId xmlns:a16="http://schemas.microsoft.com/office/drawing/2014/main" id="{89AA0170-CCB4-8528-4C37-16DA2701F131}"/>
+                  </a:ext>
+                </a:extLst>
+              </p:cNvPr>
+              <p:cNvPicPr>
+                <a:picLocks noChangeAspect="1"/>
+              </p:cNvPicPr>
+              <p:nvPr/>
+            </p:nvPicPr>
+            <p:blipFill rotWithShape="1">
+              <a:blip r:embed="rId5"/>
+              <a:srcRect l="7265" t="2149" r="2137"/>
+              <a:stretch/>
+            </p:blipFill>
+            <p:spPr>
+              <a:xfrm rot="9499472">
+                <a:off x="5791200" y="758463"/>
+                <a:ext cx="501300" cy="1119886"/>
+              </a:xfrm>
+              <a:prstGeom prst="rect">
+                <a:avLst/>
+              </a:prstGeom>
+            </p:spPr>
+          </p:pic>
+          <p:pic>
+            <p:nvPicPr>
+              <p:cNvPr id="152" name="Picture 151">
+                <a:extLst>
+                  <a:ext uri="{FF2B5EF4-FFF2-40B4-BE49-F238E27FC236}">
+                    <a16:creationId xmlns:a16="http://schemas.microsoft.com/office/drawing/2014/main" id="{E09E8C20-9267-B79E-DC18-D9C96C8ACDE9}"/>
+                  </a:ext>
+                </a:extLst>
+              </p:cNvPr>
+              <p:cNvPicPr>
+                <a:picLocks noChangeAspect="1"/>
+              </p:cNvPicPr>
+              <p:nvPr/>
+            </p:nvPicPr>
+            <p:blipFill rotWithShape="1">
+              <a:blip r:embed="rId5"/>
+              <a:srcRect l="7265" t="2149" r="2137"/>
+              <a:stretch/>
+            </p:blipFill>
+            <p:spPr>
+              <a:xfrm rot="11335141">
+                <a:off x="6459893" y="776279"/>
+                <a:ext cx="501300" cy="1119886"/>
+              </a:xfrm>
+              <a:prstGeom prst="rect">
+                <a:avLst/>
+              </a:prstGeom>
+            </p:spPr>
+          </p:pic>
+          <p:pic>
+            <p:nvPicPr>
+              <p:cNvPr id="153" name="Picture 152">
+                <a:extLst>
+                  <a:ext uri="{FF2B5EF4-FFF2-40B4-BE49-F238E27FC236}">
+                    <a16:creationId xmlns:a16="http://schemas.microsoft.com/office/drawing/2014/main" id="{DCA90085-B0ED-7C6F-AA98-67586961E22C}"/>
+                  </a:ext>
+                </a:extLst>
+              </p:cNvPr>
+              <p:cNvPicPr>
+                <a:picLocks noChangeAspect="1"/>
+              </p:cNvPicPr>
+              <p:nvPr/>
+            </p:nvPicPr>
+            <p:blipFill rotWithShape="1">
+              <a:blip r:embed="rId5"/>
+              <a:srcRect l="7265" t="2149" r="2137"/>
+              <a:stretch/>
+            </p:blipFill>
+            <p:spPr>
+              <a:xfrm rot="9323264" flipH="1">
+                <a:off x="5223090" y="977680"/>
+                <a:ext cx="501300" cy="1119886"/>
+              </a:xfrm>
+              <a:prstGeom prst="rect">
+                <a:avLst/>
+              </a:prstGeom>
+            </p:spPr>
+          </p:pic>
+          <p:pic>
+            <p:nvPicPr>
+              <p:cNvPr id="154" name="Picture 153">
+                <a:extLst>
+                  <a:ext uri="{FF2B5EF4-FFF2-40B4-BE49-F238E27FC236}">
+                    <a16:creationId xmlns:a16="http://schemas.microsoft.com/office/drawing/2014/main" id="{B57A8535-ECD3-455E-B1E1-AC71B9E2A843}"/>
+                  </a:ext>
+                </a:extLst>
+              </p:cNvPr>
+              <p:cNvPicPr>
+                <a:picLocks noChangeAspect="1"/>
+              </p:cNvPicPr>
+              <p:nvPr/>
+            </p:nvPicPr>
+            <p:blipFill rotWithShape="1">
+              <a:blip r:embed="rId5"/>
+              <a:srcRect l="7265" t="2149" r="2137"/>
+              <a:stretch/>
+            </p:blipFill>
+            <p:spPr>
+              <a:xfrm rot="13424503" flipH="1">
+                <a:off x="7049354" y="966826"/>
+                <a:ext cx="501300" cy="1119886"/>
+              </a:xfrm>
+              <a:prstGeom prst="rect">
+                <a:avLst/>
+              </a:prstGeom>
+            </p:spPr>
+          </p:pic>
+        </p:grpSp>
+      </p:grpSp>
+      <p:grpSp>
+        <p:nvGrpSpPr>
+          <p:cNvPr id="171" name="Group 170">
+            <a:extLst>
+              <a:ext uri="{FF2B5EF4-FFF2-40B4-BE49-F238E27FC236}">
+                <a16:creationId xmlns:a16="http://schemas.microsoft.com/office/drawing/2014/main" id="{51292E69-46B4-6A7D-4379-5C53511BFD90}"/>
+              </a:ext>
+            </a:extLst>
+          </p:cNvPr>
+          <p:cNvGrpSpPr/>
+          <p:nvPr/>
+        </p:nvGrpSpPr>
+        <p:grpSpPr>
+          <a:xfrm>
+            <a:off x="9358175" y="580700"/>
+            <a:ext cx="1371600" cy="1371600"/>
+            <a:chOff x="427081" y="263129"/>
+            <a:chExt cx="1371600" cy="1371600"/>
+          </a:xfrm>
+        </p:grpSpPr>
+        <p:sp>
+          <p:nvSpPr>
+            <p:cNvPr id="172" name="Rectangle 171">
+              <a:extLst>
+                <a:ext uri="{FF2B5EF4-FFF2-40B4-BE49-F238E27FC236}">
+                  <a16:creationId xmlns:a16="http://schemas.microsoft.com/office/drawing/2014/main" id="{F88DE9E8-A6EE-5604-FBE1-A5854BCB701D}"/>
+                </a:ext>
+              </a:extLst>
+            </p:cNvPr>
+            <p:cNvSpPr/>
+            <p:nvPr/>
+          </p:nvSpPr>
+          <p:spPr>
+            <a:xfrm>
+              <a:off x="427081" y="263129"/>
+              <a:ext cx="1371600" cy="1371600"/>
+            </a:xfrm>
+            <a:prstGeom prst="rect">
+              <a:avLst/>
+            </a:prstGeom>
+            <a:noFill/>
+            <a:ln w="76200">
+              <a:solidFill>
+                <a:schemeClr val="tx1"/>
+              </a:solidFill>
+            </a:ln>
+          </p:spPr>
+          <p:style>
+            <a:lnRef idx="2">
+              <a:schemeClr val="accent1">
+                <a:shade val="50000"/>
+              </a:schemeClr>
+            </a:lnRef>
+            <a:fillRef idx="1">
+              <a:schemeClr val="accent1"/>
+            </a:fillRef>
+            <a:effectRef idx="0">
+              <a:schemeClr val="accent1"/>
+            </a:effectRef>
+            <a:fontRef idx="minor">
+              <a:schemeClr val="lt1"/>
+            </a:fontRef>
+          </p:style>
+          <p:txBody>
+            <a:bodyPr rtlCol="0" anchor="ctr"/>
+            <a:lstStyle/>
+            <a:p>
+              <a:pPr algn="ctr"/>
+              <a:endParaRPr lang="en-US"/>
+            </a:p>
+          </p:txBody>
+        </p:sp>
+        <p:sp>
+          <p:nvSpPr>
+            <p:cNvPr id="173" name="Plaque 172">
+              <a:extLst>
+                <a:ext uri="{FF2B5EF4-FFF2-40B4-BE49-F238E27FC236}">
+                  <a16:creationId xmlns:a16="http://schemas.microsoft.com/office/drawing/2014/main" id="{370ADBE4-6701-B452-B189-D65C68DF8CAB}"/>
+                </a:ext>
+              </a:extLst>
+            </p:cNvPr>
+            <p:cNvSpPr/>
+            <p:nvPr/>
+          </p:nvSpPr>
+          <p:spPr>
+            <a:xfrm>
+              <a:off x="573033" y="478473"/>
+              <a:ext cx="1097280" cy="1097280"/>
+            </a:xfrm>
+            <a:prstGeom prst="plaque">
+              <a:avLst/>
+            </a:prstGeom>
+            <a:noFill/>
+            <a:ln w="38100" cap="flat" cmpd="sng" algn="ctr">
+              <a:solidFill>
+                <a:schemeClr val="dk1"/>
+              </a:solidFill>
+              <a:prstDash val="solid"/>
+              <a:round/>
+              <a:headEnd type="none" w="med" len="med"/>
+              <a:tailEnd type="none" w="med" len="med"/>
+            </a:ln>
+          </p:spPr>
+          <p:style>
+            <a:lnRef idx="0">
+              <a:scrgbClr r="0" g="0" b="0"/>
+            </a:lnRef>
+            <a:fillRef idx="0">
+              <a:scrgbClr r="0" g="0" b="0"/>
+            </a:fillRef>
+            <a:effectRef idx="0">
+              <a:scrgbClr r="0" g="0" b="0"/>
+            </a:effectRef>
+            <a:fontRef idx="minor">
+              <a:schemeClr val="dk1"/>
+            </a:fontRef>
+          </p:style>
+          <p:txBody>
+            <a:bodyPr rtlCol="0" anchor="ctr"/>
+            <a:lstStyle/>
+            <a:p>
+              <a:pPr algn="ctr"/>
+              <a:endParaRPr lang="en-US"/>
+            </a:p>
+          </p:txBody>
+        </p:sp>
+      </p:grpSp>
     </p:spTree>
     <p:extLst>
       <p:ext uri="{BB962C8B-B14F-4D97-AF65-F5344CB8AC3E}">

</xml_diff>

<commit_message>
Add StarLight& HeliosFrigate & HurricaneBattleship
</commit_message>
<xml_diff>
--- a/image process/drawings sifi.pptx
+++ b/image process/drawings sifi.pptx
@@ -200,7 +200,7 @@
           <a:p>
             <a:fld id="{7700C406-2328-4788-AE79-437B6607AD22}" type="datetimeFigureOut">
               <a:rPr lang="en-US" smtClean="0"/>
-              <a:t>6/4/2022</a:t>
+              <a:t>6/6/2022</a:t>
             </a:fld>
             <a:endParaRPr lang="en-US"/>
           </a:p>
@@ -614,7 +614,7 @@
           <a:p>
             <a:fld id="{9EC8CD53-0620-48F2-A3BB-2B10BDA60E52}" type="datetimeFigureOut">
               <a:rPr lang="en-US" smtClean="0"/>
-              <a:t>6/4/2022</a:t>
+              <a:t>6/6/2022</a:t>
             </a:fld>
             <a:endParaRPr lang="en-US"/>
           </a:p>
@@ -812,7 +812,7 @@
           <a:p>
             <a:fld id="{9EC8CD53-0620-48F2-A3BB-2B10BDA60E52}" type="datetimeFigureOut">
               <a:rPr lang="en-US" smtClean="0"/>
-              <a:t>6/4/2022</a:t>
+              <a:t>6/6/2022</a:t>
             </a:fld>
             <a:endParaRPr lang="en-US"/>
           </a:p>
@@ -1020,7 +1020,7 @@
           <a:p>
             <a:fld id="{9EC8CD53-0620-48F2-A3BB-2B10BDA60E52}" type="datetimeFigureOut">
               <a:rPr lang="en-US" smtClean="0"/>
-              <a:t>6/4/2022</a:t>
+              <a:t>6/6/2022</a:t>
             </a:fld>
             <a:endParaRPr lang="en-US"/>
           </a:p>
@@ -1218,7 +1218,7 @@
           <a:p>
             <a:fld id="{9EC8CD53-0620-48F2-A3BB-2B10BDA60E52}" type="datetimeFigureOut">
               <a:rPr lang="en-US" smtClean="0"/>
-              <a:t>6/4/2022</a:t>
+              <a:t>6/6/2022</a:t>
             </a:fld>
             <a:endParaRPr lang="en-US"/>
           </a:p>
@@ -1493,7 +1493,7 @@
           <a:p>
             <a:fld id="{9EC8CD53-0620-48F2-A3BB-2B10BDA60E52}" type="datetimeFigureOut">
               <a:rPr lang="en-US" smtClean="0"/>
-              <a:t>6/4/2022</a:t>
+              <a:t>6/6/2022</a:t>
             </a:fld>
             <a:endParaRPr lang="en-US"/>
           </a:p>
@@ -1758,7 +1758,7 @@
           <a:p>
             <a:fld id="{9EC8CD53-0620-48F2-A3BB-2B10BDA60E52}" type="datetimeFigureOut">
               <a:rPr lang="en-US" smtClean="0"/>
-              <a:t>6/4/2022</a:t>
+              <a:t>6/6/2022</a:t>
             </a:fld>
             <a:endParaRPr lang="en-US"/>
           </a:p>
@@ -2170,7 +2170,7 @@
           <a:p>
             <a:fld id="{9EC8CD53-0620-48F2-A3BB-2B10BDA60E52}" type="datetimeFigureOut">
               <a:rPr lang="en-US" smtClean="0"/>
-              <a:t>6/4/2022</a:t>
+              <a:t>6/6/2022</a:t>
             </a:fld>
             <a:endParaRPr lang="en-US"/>
           </a:p>
@@ -2311,7 +2311,7 @@
           <a:p>
             <a:fld id="{9EC8CD53-0620-48F2-A3BB-2B10BDA60E52}" type="datetimeFigureOut">
               <a:rPr lang="en-US" smtClean="0"/>
-              <a:t>6/4/2022</a:t>
+              <a:t>6/6/2022</a:t>
             </a:fld>
             <a:endParaRPr lang="en-US"/>
           </a:p>
@@ -2424,7 +2424,7 @@
           <a:p>
             <a:fld id="{9EC8CD53-0620-48F2-A3BB-2B10BDA60E52}" type="datetimeFigureOut">
               <a:rPr lang="en-US" smtClean="0"/>
-              <a:t>6/4/2022</a:t>
+              <a:t>6/6/2022</a:t>
             </a:fld>
             <a:endParaRPr lang="en-US"/>
           </a:p>
@@ -2735,7 +2735,7 @@
           <a:p>
             <a:fld id="{9EC8CD53-0620-48F2-A3BB-2B10BDA60E52}" type="datetimeFigureOut">
               <a:rPr lang="en-US" smtClean="0"/>
-              <a:t>6/4/2022</a:t>
+              <a:t>6/6/2022</a:t>
             </a:fld>
             <a:endParaRPr lang="en-US"/>
           </a:p>
@@ -3023,7 +3023,7 @@
           <a:p>
             <a:fld id="{9EC8CD53-0620-48F2-A3BB-2B10BDA60E52}" type="datetimeFigureOut">
               <a:rPr lang="en-US" smtClean="0"/>
-              <a:t>6/4/2022</a:t>
+              <a:t>6/6/2022</a:t>
             </a:fld>
             <a:endParaRPr lang="en-US"/>
           </a:p>
@@ -3264,7 +3264,7 @@
           <a:p>
             <a:fld id="{9EC8CD53-0620-48F2-A3BB-2B10BDA60E52}" type="datetimeFigureOut">
               <a:rPr lang="en-US" smtClean="0"/>
-              <a:t>6/4/2022</a:t>
+              <a:t>6/6/2022</a:t>
             </a:fld>
             <a:endParaRPr lang="en-US"/>
           </a:p>
@@ -17241,810 +17241,6 @@
           <a:chExt cx="0" cy="0"/>
         </a:xfrm>
       </p:grpSpPr>
-      <p:pic>
-        <p:nvPicPr>
-          <p:cNvPr id="28" name="Picture 27">
-            <a:extLst>
-              <a:ext uri="{FF2B5EF4-FFF2-40B4-BE49-F238E27FC236}">
-                <a16:creationId xmlns:a16="http://schemas.microsoft.com/office/drawing/2014/main" id="{611C9ED2-34B1-652C-46AE-EF6035935DD0}"/>
-              </a:ext>
-            </a:extLst>
-          </p:cNvPr>
-          <p:cNvPicPr>
-            <a:picLocks noChangeAspect="1"/>
-          </p:cNvPicPr>
-          <p:nvPr/>
-        </p:nvPicPr>
-        <p:blipFill>
-          <a:blip r:embed="rId2"/>
-          <a:stretch>
-            <a:fillRect/>
-          </a:stretch>
-        </p:blipFill>
-        <p:spPr>
-          <a:xfrm rot="20165155">
-            <a:off x="2293315" y="662456"/>
-            <a:ext cx="551005" cy="906820"/>
-          </a:xfrm>
-          <a:prstGeom prst="rect">
-            <a:avLst/>
-          </a:prstGeom>
-        </p:spPr>
-      </p:pic>
-      <p:grpSp>
-        <p:nvGrpSpPr>
-          <p:cNvPr id="26" name="Group 25">
-            <a:extLst>
-              <a:ext uri="{FF2B5EF4-FFF2-40B4-BE49-F238E27FC236}">
-                <a16:creationId xmlns:a16="http://schemas.microsoft.com/office/drawing/2014/main" id="{E6D5F2B4-CC15-2413-E222-F40E8932B52E}"/>
-              </a:ext>
-            </a:extLst>
-          </p:cNvPr>
-          <p:cNvGrpSpPr/>
-          <p:nvPr/>
-        </p:nvGrpSpPr>
-        <p:grpSpPr>
-          <a:xfrm>
-            <a:off x="608089" y="493952"/>
-            <a:ext cx="1027167" cy="1035721"/>
-            <a:chOff x="4165279" y="376316"/>
-            <a:chExt cx="4372510" cy="4408922"/>
-          </a:xfrm>
-        </p:grpSpPr>
-        <p:grpSp>
-          <p:nvGrpSpPr>
-            <p:cNvPr id="8" name="Group 7">
-              <a:extLst>
-                <a:ext uri="{FF2B5EF4-FFF2-40B4-BE49-F238E27FC236}">
-                  <a16:creationId xmlns:a16="http://schemas.microsoft.com/office/drawing/2014/main" id="{900E8C98-AB38-E16B-E603-41C7A4CC6A24}"/>
-                </a:ext>
-              </a:extLst>
-            </p:cNvPr>
-            <p:cNvGrpSpPr/>
-            <p:nvPr/>
-          </p:nvGrpSpPr>
-          <p:grpSpPr>
-            <a:xfrm>
-              <a:off x="5618932" y="1546108"/>
-              <a:ext cx="1540121" cy="2162098"/>
-              <a:chOff x="5452330" y="1708793"/>
-              <a:chExt cx="1186621" cy="1665837"/>
-            </a:xfrm>
-          </p:grpSpPr>
-          <p:sp>
-            <p:nvSpPr>
-              <p:cNvPr id="2" name="Isosceles Triangle 1">
-                <a:extLst>
-                  <a:ext uri="{FF2B5EF4-FFF2-40B4-BE49-F238E27FC236}">
-                    <a16:creationId xmlns:a16="http://schemas.microsoft.com/office/drawing/2014/main" id="{64834EAC-F76B-ADEA-3CD4-205D2CBC6386}"/>
-                  </a:ext>
-                </a:extLst>
-              </p:cNvPr>
-              <p:cNvSpPr/>
-              <p:nvPr/>
-            </p:nvSpPr>
-            <p:spPr>
-              <a:xfrm>
-                <a:off x="5794991" y="1708793"/>
-                <a:ext cx="501300" cy="440002"/>
-              </a:xfrm>
-              <a:prstGeom prst="triangle">
-                <a:avLst/>
-              </a:prstGeom>
-            </p:spPr>
-            <p:style>
-              <a:lnRef idx="2">
-                <a:schemeClr val="dk1">
-                  <a:shade val="50000"/>
-                </a:schemeClr>
-              </a:lnRef>
-              <a:fillRef idx="1">
-                <a:schemeClr val="dk1"/>
-              </a:fillRef>
-              <a:effectRef idx="0">
-                <a:schemeClr val="dk1"/>
-              </a:effectRef>
-              <a:fontRef idx="minor">
-                <a:schemeClr val="lt1"/>
-              </a:fontRef>
-            </p:style>
-            <p:txBody>
-              <a:bodyPr rtlCol="0" anchor="ctr"/>
-              <a:lstStyle/>
-              <a:p>
-                <a:pPr algn="ctr"/>
-                <a:endParaRPr lang="en-US"/>
-              </a:p>
-            </p:txBody>
-          </p:sp>
-          <p:sp>
-            <p:nvSpPr>
-              <p:cNvPr id="3" name="Isosceles Triangle 2">
-                <a:extLst>
-                  <a:ext uri="{FF2B5EF4-FFF2-40B4-BE49-F238E27FC236}">
-                    <a16:creationId xmlns:a16="http://schemas.microsoft.com/office/drawing/2014/main" id="{6AA7D6DD-0D31-13D6-8AA1-5DE532DB6F3D}"/>
-                  </a:ext>
-                </a:extLst>
-              </p:cNvPr>
-              <p:cNvSpPr/>
-              <p:nvPr/>
-            </p:nvSpPr>
-            <p:spPr>
-              <a:xfrm rot="10800000">
-                <a:off x="5794991" y="2236075"/>
-                <a:ext cx="501300" cy="1138555"/>
-              </a:xfrm>
-              <a:prstGeom prst="triangle">
-                <a:avLst/>
-              </a:prstGeom>
-            </p:spPr>
-            <p:style>
-              <a:lnRef idx="2">
-                <a:schemeClr val="dk1">
-                  <a:shade val="50000"/>
-                </a:schemeClr>
-              </a:lnRef>
-              <a:fillRef idx="1">
-                <a:schemeClr val="dk1"/>
-              </a:fillRef>
-              <a:effectRef idx="0">
-                <a:schemeClr val="dk1"/>
-              </a:effectRef>
-              <a:fontRef idx="minor">
-                <a:schemeClr val="lt1"/>
-              </a:fontRef>
-            </p:style>
-            <p:txBody>
-              <a:bodyPr rtlCol="0" anchor="ctr"/>
-              <a:lstStyle/>
-              <a:p>
-                <a:pPr algn="ctr"/>
-                <a:endParaRPr lang="en-US"/>
-              </a:p>
-            </p:txBody>
-          </p:sp>
-          <p:sp>
-            <p:nvSpPr>
-              <p:cNvPr id="4" name="Rectangle 3">
-                <a:extLst>
-                  <a:ext uri="{FF2B5EF4-FFF2-40B4-BE49-F238E27FC236}">
-                    <a16:creationId xmlns:a16="http://schemas.microsoft.com/office/drawing/2014/main" id="{05E4FBE9-446A-A891-35DC-490EF5253060}"/>
-                  </a:ext>
-                </a:extLst>
-              </p:cNvPr>
-              <p:cNvSpPr/>
-              <p:nvPr/>
-            </p:nvSpPr>
-            <p:spPr>
-              <a:xfrm rot="1172583">
-                <a:off x="5452330" y="2155246"/>
-                <a:ext cx="161133" cy="711668"/>
-              </a:xfrm>
-              <a:prstGeom prst="rect">
-                <a:avLst/>
-              </a:prstGeom>
-            </p:spPr>
-            <p:style>
-              <a:lnRef idx="2">
-                <a:schemeClr val="dk1">
-                  <a:shade val="50000"/>
-                </a:schemeClr>
-              </a:lnRef>
-              <a:fillRef idx="1">
-                <a:schemeClr val="dk1"/>
-              </a:fillRef>
-              <a:effectRef idx="0">
-                <a:schemeClr val="dk1"/>
-              </a:effectRef>
-              <a:fontRef idx="minor">
-                <a:schemeClr val="lt1"/>
-              </a:fontRef>
-            </p:style>
-            <p:txBody>
-              <a:bodyPr rtlCol="0" anchor="ctr"/>
-              <a:lstStyle/>
-              <a:p>
-                <a:pPr algn="ctr"/>
-                <a:endParaRPr lang="en-US"/>
-              </a:p>
-            </p:txBody>
-          </p:sp>
-          <p:sp>
-            <p:nvSpPr>
-              <p:cNvPr id="54" name="Rectangle 53">
-                <a:extLst>
-                  <a:ext uri="{FF2B5EF4-FFF2-40B4-BE49-F238E27FC236}">
-                    <a16:creationId xmlns:a16="http://schemas.microsoft.com/office/drawing/2014/main" id="{14509484-877F-4AC3-2064-FAE3DA3BFD62}"/>
-                  </a:ext>
-                </a:extLst>
-              </p:cNvPr>
-              <p:cNvSpPr/>
-              <p:nvPr/>
-            </p:nvSpPr>
-            <p:spPr>
-              <a:xfrm rot="20427417" flipH="1">
-                <a:off x="6477818" y="2155248"/>
-                <a:ext cx="161133" cy="711668"/>
-              </a:xfrm>
-              <a:prstGeom prst="rect">
-                <a:avLst/>
-              </a:prstGeom>
-            </p:spPr>
-            <p:style>
-              <a:lnRef idx="2">
-                <a:schemeClr val="dk1">
-                  <a:shade val="50000"/>
-                </a:schemeClr>
-              </a:lnRef>
-              <a:fillRef idx="1">
-                <a:schemeClr val="dk1"/>
-              </a:fillRef>
-              <a:effectRef idx="0">
-                <a:schemeClr val="dk1"/>
-              </a:effectRef>
-              <a:fontRef idx="minor">
-                <a:schemeClr val="lt1"/>
-              </a:fontRef>
-            </p:style>
-            <p:txBody>
-              <a:bodyPr rtlCol="0" anchor="ctr"/>
-              <a:lstStyle/>
-              <a:p>
-                <a:pPr algn="ctr"/>
-                <a:endParaRPr lang="en-US"/>
-              </a:p>
-            </p:txBody>
-          </p:sp>
-        </p:grpSp>
-        <p:grpSp>
-          <p:nvGrpSpPr>
-            <p:cNvPr id="25" name="Group 24">
-              <a:extLst>
-                <a:ext uri="{FF2B5EF4-FFF2-40B4-BE49-F238E27FC236}">
-                  <a16:creationId xmlns:a16="http://schemas.microsoft.com/office/drawing/2014/main" id="{CC6A0B7A-C9DA-21AE-0EA2-662956AA2572}"/>
-                </a:ext>
-              </a:extLst>
-            </p:cNvPr>
-            <p:cNvGrpSpPr/>
-            <p:nvPr/>
-          </p:nvGrpSpPr>
-          <p:grpSpPr>
-            <a:xfrm>
-              <a:off x="5223090" y="376316"/>
-              <a:ext cx="2327564" cy="1339103"/>
-              <a:chOff x="5223090" y="758463"/>
-              <a:chExt cx="2327564" cy="1339103"/>
-            </a:xfrm>
-          </p:grpSpPr>
-          <p:pic>
-            <p:nvPicPr>
-              <p:cNvPr id="23" name="Picture 22">
-                <a:extLst>
-                  <a:ext uri="{FF2B5EF4-FFF2-40B4-BE49-F238E27FC236}">
-                    <a16:creationId xmlns:a16="http://schemas.microsoft.com/office/drawing/2014/main" id="{6C4E511F-2CE1-6C42-C5DF-0CF42D13AAF1}"/>
-                  </a:ext>
-                </a:extLst>
-              </p:cNvPr>
-              <p:cNvPicPr>
-                <a:picLocks noChangeAspect="1"/>
-              </p:cNvPicPr>
-              <p:nvPr/>
-            </p:nvPicPr>
-            <p:blipFill rotWithShape="1">
-              <a:blip r:embed="rId3"/>
-              <a:srcRect l="7265" t="2149" r="2137"/>
-              <a:stretch/>
-            </p:blipFill>
-            <p:spPr>
-              <a:xfrm rot="9499472">
-                <a:off x="5791200" y="758463"/>
-                <a:ext cx="501300" cy="1119886"/>
-              </a:xfrm>
-              <a:prstGeom prst="rect">
-                <a:avLst/>
-              </a:prstGeom>
-            </p:spPr>
-          </p:pic>
-          <p:pic>
-            <p:nvPicPr>
-              <p:cNvPr id="76" name="Picture 75">
-                <a:extLst>
-                  <a:ext uri="{FF2B5EF4-FFF2-40B4-BE49-F238E27FC236}">
-                    <a16:creationId xmlns:a16="http://schemas.microsoft.com/office/drawing/2014/main" id="{F4985C61-0B7A-DD00-D291-D2A339C87F78}"/>
-                  </a:ext>
-                </a:extLst>
-              </p:cNvPr>
-              <p:cNvPicPr>
-                <a:picLocks noChangeAspect="1"/>
-              </p:cNvPicPr>
-              <p:nvPr/>
-            </p:nvPicPr>
-            <p:blipFill rotWithShape="1">
-              <a:blip r:embed="rId3"/>
-              <a:srcRect l="7265" t="2149" r="2137"/>
-              <a:stretch/>
-            </p:blipFill>
-            <p:spPr>
-              <a:xfrm rot="11335141">
-                <a:off x="6459893" y="776279"/>
-                <a:ext cx="501300" cy="1119886"/>
-              </a:xfrm>
-              <a:prstGeom prst="rect">
-                <a:avLst/>
-              </a:prstGeom>
-            </p:spPr>
-          </p:pic>
-          <p:pic>
-            <p:nvPicPr>
-              <p:cNvPr id="77" name="Picture 76">
-                <a:extLst>
-                  <a:ext uri="{FF2B5EF4-FFF2-40B4-BE49-F238E27FC236}">
-                    <a16:creationId xmlns:a16="http://schemas.microsoft.com/office/drawing/2014/main" id="{01C3493D-A7F6-7A3C-562A-7944049AB6F6}"/>
-                  </a:ext>
-                </a:extLst>
-              </p:cNvPr>
-              <p:cNvPicPr>
-                <a:picLocks noChangeAspect="1"/>
-              </p:cNvPicPr>
-              <p:nvPr/>
-            </p:nvPicPr>
-            <p:blipFill rotWithShape="1">
-              <a:blip r:embed="rId3"/>
-              <a:srcRect l="7265" t="2149" r="2137"/>
-              <a:stretch/>
-            </p:blipFill>
-            <p:spPr>
-              <a:xfrm rot="9323264" flipH="1">
-                <a:off x="5223090" y="977680"/>
-                <a:ext cx="501300" cy="1119886"/>
-              </a:xfrm>
-              <a:prstGeom prst="rect">
-                <a:avLst/>
-              </a:prstGeom>
-            </p:spPr>
-          </p:pic>
-          <p:pic>
-            <p:nvPicPr>
-              <p:cNvPr id="78" name="Picture 77">
-                <a:extLst>
-                  <a:ext uri="{FF2B5EF4-FFF2-40B4-BE49-F238E27FC236}">
-                    <a16:creationId xmlns:a16="http://schemas.microsoft.com/office/drawing/2014/main" id="{A371ADE2-AB8E-450C-C726-0BFE20FA3A2E}"/>
-                  </a:ext>
-                </a:extLst>
-              </p:cNvPr>
-              <p:cNvPicPr>
-                <a:picLocks noChangeAspect="1"/>
-              </p:cNvPicPr>
-              <p:nvPr/>
-            </p:nvPicPr>
-            <p:blipFill rotWithShape="1">
-              <a:blip r:embed="rId3"/>
-              <a:srcRect l="7265" t="2149" r="2137"/>
-              <a:stretch/>
-            </p:blipFill>
-            <p:spPr>
-              <a:xfrm rot="13424503" flipH="1">
-                <a:off x="7049354" y="966826"/>
-                <a:ext cx="501300" cy="1119886"/>
-              </a:xfrm>
-              <a:prstGeom prst="rect">
-                <a:avLst/>
-              </a:prstGeom>
-            </p:spPr>
-          </p:pic>
-        </p:grpSp>
-        <p:grpSp>
-          <p:nvGrpSpPr>
-            <p:cNvPr id="79" name="Group 78">
-              <a:extLst>
-                <a:ext uri="{FF2B5EF4-FFF2-40B4-BE49-F238E27FC236}">
-                  <a16:creationId xmlns:a16="http://schemas.microsoft.com/office/drawing/2014/main" id="{BCDCAAAD-9B8E-CA71-0085-48CF26E405D8}"/>
-                </a:ext>
-              </a:extLst>
-            </p:cNvPr>
-            <p:cNvGrpSpPr/>
-            <p:nvPr/>
-          </p:nvGrpSpPr>
-          <p:grpSpPr>
-            <a:xfrm rot="10800000">
-              <a:off x="5212329" y="3446135"/>
-              <a:ext cx="2327564" cy="1339103"/>
-              <a:chOff x="5223090" y="758463"/>
-              <a:chExt cx="2327564" cy="1339103"/>
-            </a:xfrm>
-          </p:grpSpPr>
-          <p:pic>
-            <p:nvPicPr>
-              <p:cNvPr id="80" name="Picture 79">
-                <a:extLst>
-                  <a:ext uri="{FF2B5EF4-FFF2-40B4-BE49-F238E27FC236}">
-                    <a16:creationId xmlns:a16="http://schemas.microsoft.com/office/drawing/2014/main" id="{5742BE29-CEBF-34A9-715C-44003FAF2AF9}"/>
-                  </a:ext>
-                </a:extLst>
-              </p:cNvPr>
-              <p:cNvPicPr>
-                <a:picLocks noChangeAspect="1"/>
-              </p:cNvPicPr>
-              <p:nvPr/>
-            </p:nvPicPr>
-            <p:blipFill rotWithShape="1">
-              <a:blip r:embed="rId3"/>
-              <a:srcRect l="7265" t="2149" r="2137"/>
-              <a:stretch/>
-            </p:blipFill>
-            <p:spPr>
-              <a:xfrm rot="9499472">
-                <a:off x="5791200" y="758463"/>
-                <a:ext cx="501300" cy="1119886"/>
-              </a:xfrm>
-              <a:prstGeom prst="rect">
-                <a:avLst/>
-              </a:prstGeom>
-            </p:spPr>
-          </p:pic>
-          <p:pic>
-            <p:nvPicPr>
-              <p:cNvPr id="81" name="Picture 80">
-                <a:extLst>
-                  <a:ext uri="{FF2B5EF4-FFF2-40B4-BE49-F238E27FC236}">
-                    <a16:creationId xmlns:a16="http://schemas.microsoft.com/office/drawing/2014/main" id="{EBF05BCA-59FD-E14C-25C9-ABFF697BB194}"/>
-                  </a:ext>
-                </a:extLst>
-              </p:cNvPr>
-              <p:cNvPicPr>
-                <a:picLocks noChangeAspect="1"/>
-              </p:cNvPicPr>
-              <p:nvPr/>
-            </p:nvPicPr>
-            <p:blipFill rotWithShape="1">
-              <a:blip r:embed="rId3"/>
-              <a:srcRect l="7265" t="2149" r="2137"/>
-              <a:stretch/>
-            </p:blipFill>
-            <p:spPr>
-              <a:xfrm rot="11335141">
-                <a:off x="6459893" y="776279"/>
-                <a:ext cx="501300" cy="1119886"/>
-              </a:xfrm>
-              <a:prstGeom prst="rect">
-                <a:avLst/>
-              </a:prstGeom>
-            </p:spPr>
-          </p:pic>
-          <p:pic>
-            <p:nvPicPr>
-              <p:cNvPr id="82" name="Picture 81">
-                <a:extLst>
-                  <a:ext uri="{FF2B5EF4-FFF2-40B4-BE49-F238E27FC236}">
-                    <a16:creationId xmlns:a16="http://schemas.microsoft.com/office/drawing/2014/main" id="{9EB53265-F1D0-58A5-73B0-6D94B5905AF2}"/>
-                  </a:ext>
-                </a:extLst>
-              </p:cNvPr>
-              <p:cNvPicPr>
-                <a:picLocks noChangeAspect="1"/>
-              </p:cNvPicPr>
-              <p:nvPr/>
-            </p:nvPicPr>
-            <p:blipFill rotWithShape="1">
-              <a:blip r:embed="rId3"/>
-              <a:srcRect l="7265" t="2149" r="2137"/>
-              <a:stretch/>
-            </p:blipFill>
-            <p:spPr>
-              <a:xfrm rot="9323264" flipH="1">
-                <a:off x="5223090" y="977680"/>
-                <a:ext cx="501300" cy="1119886"/>
-              </a:xfrm>
-              <a:prstGeom prst="rect">
-                <a:avLst/>
-              </a:prstGeom>
-            </p:spPr>
-          </p:pic>
-          <p:pic>
-            <p:nvPicPr>
-              <p:cNvPr id="83" name="Picture 82">
-                <a:extLst>
-                  <a:ext uri="{FF2B5EF4-FFF2-40B4-BE49-F238E27FC236}">
-                    <a16:creationId xmlns:a16="http://schemas.microsoft.com/office/drawing/2014/main" id="{680E964E-CEE1-1EFF-5185-C0B4782BC12F}"/>
-                  </a:ext>
-                </a:extLst>
-              </p:cNvPr>
-              <p:cNvPicPr>
-                <a:picLocks noChangeAspect="1"/>
-              </p:cNvPicPr>
-              <p:nvPr/>
-            </p:nvPicPr>
-            <p:blipFill rotWithShape="1">
-              <a:blip r:embed="rId3"/>
-              <a:srcRect l="7265" t="2149" r="2137"/>
-              <a:stretch/>
-            </p:blipFill>
-            <p:spPr>
-              <a:xfrm rot="13424503" flipH="1">
-                <a:off x="7049354" y="966826"/>
-                <a:ext cx="501300" cy="1119886"/>
-              </a:xfrm>
-              <a:prstGeom prst="rect">
-                <a:avLst/>
-              </a:prstGeom>
-            </p:spPr>
-          </p:pic>
-        </p:grpSp>
-        <p:grpSp>
-          <p:nvGrpSpPr>
-            <p:cNvPr id="84" name="Group 83">
-              <a:extLst>
-                <a:ext uri="{FF2B5EF4-FFF2-40B4-BE49-F238E27FC236}">
-                  <a16:creationId xmlns:a16="http://schemas.microsoft.com/office/drawing/2014/main" id="{FA22BA67-F0E7-33B1-9C63-A4BB9E5B0831}"/>
-                </a:ext>
-              </a:extLst>
-            </p:cNvPr>
-            <p:cNvGrpSpPr/>
-            <p:nvPr/>
-          </p:nvGrpSpPr>
-          <p:grpSpPr>
-            <a:xfrm rot="16367590">
-              <a:off x="3671049" y="1904396"/>
-              <a:ext cx="2327564" cy="1339103"/>
-              <a:chOff x="5223090" y="758463"/>
-              <a:chExt cx="2327564" cy="1339103"/>
-            </a:xfrm>
-          </p:grpSpPr>
-          <p:pic>
-            <p:nvPicPr>
-              <p:cNvPr id="85" name="Picture 84">
-                <a:extLst>
-                  <a:ext uri="{FF2B5EF4-FFF2-40B4-BE49-F238E27FC236}">
-                    <a16:creationId xmlns:a16="http://schemas.microsoft.com/office/drawing/2014/main" id="{4C16ACBF-B81A-6C1A-16F3-B566ABD3E759}"/>
-                  </a:ext>
-                </a:extLst>
-              </p:cNvPr>
-              <p:cNvPicPr>
-                <a:picLocks noChangeAspect="1"/>
-              </p:cNvPicPr>
-              <p:nvPr/>
-            </p:nvPicPr>
-            <p:blipFill rotWithShape="1">
-              <a:blip r:embed="rId3"/>
-              <a:srcRect l="7265" t="2149" r="2137"/>
-              <a:stretch/>
-            </p:blipFill>
-            <p:spPr>
-              <a:xfrm rot="9499472">
-                <a:off x="5791200" y="758463"/>
-                <a:ext cx="501300" cy="1119886"/>
-              </a:xfrm>
-              <a:prstGeom prst="rect">
-                <a:avLst/>
-              </a:prstGeom>
-            </p:spPr>
-          </p:pic>
-          <p:pic>
-            <p:nvPicPr>
-              <p:cNvPr id="86" name="Picture 85">
-                <a:extLst>
-                  <a:ext uri="{FF2B5EF4-FFF2-40B4-BE49-F238E27FC236}">
-                    <a16:creationId xmlns:a16="http://schemas.microsoft.com/office/drawing/2014/main" id="{AA831C4D-C844-073B-90BD-EAC348AE5FE1}"/>
-                  </a:ext>
-                </a:extLst>
-              </p:cNvPr>
-              <p:cNvPicPr>
-                <a:picLocks noChangeAspect="1"/>
-              </p:cNvPicPr>
-              <p:nvPr/>
-            </p:nvPicPr>
-            <p:blipFill rotWithShape="1">
-              <a:blip r:embed="rId3"/>
-              <a:srcRect l="7265" t="2149" r="2137"/>
-              <a:stretch/>
-            </p:blipFill>
-            <p:spPr>
-              <a:xfrm rot="11335141">
-                <a:off x="6459893" y="776279"/>
-                <a:ext cx="501300" cy="1119886"/>
-              </a:xfrm>
-              <a:prstGeom prst="rect">
-                <a:avLst/>
-              </a:prstGeom>
-            </p:spPr>
-          </p:pic>
-          <p:pic>
-            <p:nvPicPr>
-              <p:cNvPr id="87" name="Picture 86">
-                <a:extLst>
-                  <a:ext uri="{FF2B5EF4-FFF2-40B4-BE49-F238E27FC236}">
-                    <a16:creationId xmlns:a16="http://schemas.microsoft.com/office/drawing/2014/main" id="{330FE7B5-2CBD-164D-648F-9AFDB5E2DDC3}"/>
-                  </a:ext>
-                </a:extLst>
-              </p:cNvPr>
-              <p:cNvPicPr>
-                <a:picLocks noChangeAspect="1"/>
-              </p:cNvPicPr>
-              <p:nvPr/>
-            </p:nvPicPr>
-            <p:blipFill rotWithShape="1">
-              <a:blip r:embed="rId3"/>
-              <a:srcRect l="7265" t="2149" r="2137"/>
-              <a:stretch/>
-            </p:blipFill>
-            <p:spPr>
-              <a:xfrm rot="9323264" flipH="1">
-                <a:off x="5223090" y="977680"/>
-                <a:ext cx="501300" cy="1119886"/>
-              </a:xfrm>
-              <a:prstGeom prst="rect">
-                <a:avLst/>
-              </a:prstGeom>
-            </p:spPr>
-          </p:pic>
-          <p:pic>
-            <p:nvPicPr>
-              <p:cNvPr id="88" name="Picture 87">
-                <a:extLst>
-                  <a:ext uri="{FF2B5EF4-FFF2-40B4-BE49-F238E27FC236}">
-                    <a16:creationId xmlns:a16="http://schemas.microsoft.com/office/drawing/2014/main" id="{9D840451-CF6B-5B63-AE0E-D6A19467266D}"/>
-                  </a:ext>
-                </a:extLst>
-              </p:cNvPr>
-              <p:cNvPicPr>
-                <a:picLocks noChangeAspect="1"/>
-              </p:cNvPicPr>
-              <p:nvPr/>
-            </p:nvPicPr>
-            <p:blipFill rotWithShape="1">
-              <a:blip r:embed="rId3"/>
-              <a:srcRect l="7265" t="2149" r="2137"/>
-              <a:stretch/>
-            </p:blipFill>
-            <p:spPr>
-              <a:xfrm rot="13424503" flipH="1">
-                <a:off x="7049354" y="966826"/>
-                <a:ext cx="501300" cy="1119886"/>
-              </a:xfrm>
-              <a:prstGeom prst="rect">
-                <a:avLst/>
-              </a:prstGeom>
-            </p:spPr>
-          </p:pic>
-        </p:grpSp>
-        <p:grpSp>
-          <p:nvGrpSpPr>
-            <p:cNvPr id="89" name="Group 88">
-              <a:extLst>
-                <a:ext uri="{FF2B5EF4-FFF2-40B4-BE49-F238E27FC236}">
-                  <a16:creationId xmlns:a16="http://schemas.microsoft.com/office/drawing/2014/main" id="{FEF045B2-0948-65B1-3362-7DB766FFBBE7}"/>
-                </a:ext>
-              </a:extLst>
-            </p:cNvPr>
-            <p:cNvGrpSpPr/>
-            <p:nvPr/>
-          </p:nvGrpSpPr>
-          <p:grpSpPr>
-            <a:xfrm rot="5400000">
-              <a:off x="6704456" y="2000299"/>
-              <a:ext cx="2327564" cy="1339103"/>
-              <a:chOff x="5223090" y="758463"/>
-              <a:chExt cx="2327564" cy="1339103"/>
-            </a:xfrm>
-          </p:grpSpPr>
-          <p:pic>
-            <p:nvPicPr>
-              <p:cNvPr id="90" name="Picture 89">
-                <a:extLst>
-                  <a:ext uri="{FF2B5EF4-FFF2-40B4-BE49-F238E27FC236}">
-                    <a16:creationId xmlns:a16="http://schemas.microsoft.com/office/drawing/2014/main" id="{F04C856E-A956-D0A5-EDBC-8D14833F86DC}"/>
-                  </a:ext>
-                </a:extLst>
-              </p:cNvPr>
-              <p:cNvPicPr>
-                <a:picLocks noChangeAspect="1"/>
-              </p:cNvPicPr>
-              <p:nvPr/>
-            </p:nvPicPr>
-            <p:blipFill rotWithShape="1">
-              <a:blip r:embed="rId3"/>
-              <a:srcRect l="7265" t="2149" r="2137"/>
-              <a:stretch/>
-            </p:blipFill>
-            <p:spPr>
-              <a:xfrm rot="9499472">
-                <a:off x="5791200" y="758463"/>
-                <a:ext cx="501300" cy="1119886"/>
-              </a:xfrm>
-              <a:prstGeom prst="rect">
-                <a:avLst/>
-              </a:prstGeom>
-            </p:spPr>
-          </p:pic>
-          <p:pic>
-            <p:nvPicPr>
-              <p:cNvPr id="91" name="Picture 90">
-                <a:extLst>
-                  <a:ext uri="{FF2B5EF4-FFF2-40B4-BE49-F238E27FC236}">
-                    <a16:creationId xmlns:a16="http://schemas.microsoft.com/office/drawing/2014/main" id="{7363800B-F2BB-4F5F-FE92-1CFB48C58F42}"/>
-                  </a:ext>
-                </a:extLst>
-              </p:cNvPr>
-              <p:cNvPicPr>
-                <a:picLocks noChangeAspect="1"/>
-              </p:cNvPicPr>
-              <p:nvPr/>
-            </p:nvPicPr>
-            <p:blipFill rotWithShape="1">
-              <a:blip r:embed="rId3"/>
-              <a:srcRect l="7265" t="2149" r="2137"/>
-              <a:stretch/>
-            </p:blipFill>
-            <p:spPr>
-              <a:xfrm rot="11335141">
-                <a:off x="6459893" y="776279"/>
-                <a:ext cx="501300" cy="1119886"/>
-              </a:xfrm>
-              <a:prstGeom prst="rect">
-                <a:avLst/>
-              </a:prstGeom>
-            </p:spPr>
-          </p:pic>
-          <p:pic>
-            <p:nvPicPr>
-              <p:cNvPr id="92" name="Picture 91">
-                <a:extLst>
-                  <a:ext uri="{FF2B5EF4-FFF2-40B4-BE49-F238E27FC236}">
-                    <a16:creationId xmlns:a16="http://schemas.microsoft.com/office/drawing/2014/main" id="{1AD0E70B-066F-9828-19B3-5877D64FA2F6}"/>
-                  </a:ext>
-                </a:extLst>
-              </p:cNvPr>
-              <p:cNvPicPr>
-                <a:picLocks noChangeAspect="1"/>
-              </p:cNvPicPr>
-              <p:nvPr/>
-            </p:nvPicPr>
-            <p:blipFill rotWithShape="1">
-              <a:blip r:embed="rId3"/>
-              <a:srcRect l="7265" t="2149" r="2137"/>
-              <a:stretch/>
-            </p:blipFill>
-            <p:spPr>
-              <a:xfrm rot="9323264" flipH="1">
-                <a:off x="5223090" y="977680"/>
-                <a:ext cx="501300" cy="1119886"/>
-              </a:xfrm>
-              <a:prstGeom prst="rect">
-                <a:avLst/>
-              </a:prstGeom>
-            </p:spPr>
-          </p:pic>
-          <p:pic>
-            <p:nvPicPr>
-              <p:cNvPr id="93" name="Picture 92">
-                <a:extLst>
-                  <a:ext uri="{FF2B5EF4-FFF2-40B4-BE49-F238E27FC236}">
-                    <a16:creationId xmlns:a16="http://schemas.microsoft.com/office/drawing/2014/main" id="{77EA80CC-02E2-AA59-B36E-6C332D55C1F1}"/>
-                  </a:ext>
-                </a:extLst>
-              </p:cNvPr>
-              <p:cNvPicPr>
-                <a:picLocks noChangeAspect="1"/>
-              </p:cNvPicPr>
-              <p:nvPr/>
-            </p:nvPicPr>
-            <p:blipFill rotWithShape="1">
-              <a:blip r:embed="rId3"/>
-              <a:srcRect l="7265" t="2149" r="2137"/>
-              <a:stretch/>
-            </p:blipFill>
-            <p:spPr>
-              <a:xfrm rot="13424503" flipH="1">
-                <a:off x="7049354" y="966826"/>
-                <a:ext cx="501300" cy="1119886"/>
-              </a:xfrm>
-              <a:prstGeom prst="rect">
-                <a:avLst/>
-              </a:prstGeom>
-            </p:spPr>
-          </p:pic>
-        </p:grpSp>
-      </p:grpSp>
       <p:grpSp>
         <p:nvGrpSpPr>
           <p:cNvPr id="13" name="Group 12">
@@ -18186,7 +17382,7 @@
         </p:nvGrpSpPr>
         <p:grpSpPr>
           <a:xfrm>
-            <a:off x="1944633" y="278608"/>
+            <a:off x="3766985" y="263129"/>
             <a:ext cx="1371600" cy="1371600"/>
             <a:chOff x="427081" y="263129"/>
             <a:chExt cx="1371600" cy="1371600"/>
@@ -18284,6 +17480,1363 @@
             </a:fillRef>
             <a:effectRef idx="0">
               <a:scrgbClr r="0" g="0" b="0"/>
+            </a:effectRef>
+            <a:fontRef idx="minor">
+              <a:schemeClr val="dk1"/>
+            </a:fontRef>
+          </p:style>
+          <p:txBody>
+            <a:bodyPr rtlCol="0" anchor="ctr"/>
+            <a:lstStyle/>
+            <a:p>
+              <a:pPr algn="ctr"/>
+              <a:endParaRPr lang="en-US"/>
+            </a:p>
+          </p:txBody>
+        </p:sp>
+      </p:grpSp>
+      <p:grpSp>
+        <p:nvGrpSpPr>
+          <p:cNvPr id="35" name="Group 34">
+            <a:extLst>
+              <a:ext uri="{FF2B5EF4-FFF2-40B4-BE49-F238E27FC236}">
+                <a16:creationId xmlns:a16="http://schemas.microsoft.com/office/drawing/2014/main" id="{F985A505-5ACA-9E14-43B5-58A564CE814A}"/>
+              </a:ext>
+            </a:extLst>
+          </p:cNvPr>
+          <p:cNvGrpSpPr/>
+          <p:nvPr/>
+        </p:nvGrpSpPr>
+        <p:grpSpPr>
+          <a:xfrm>
+            <a:off x="2101497" y="263314"/>
+            <a:ext cx="1371600" cy="1371600"/>
+            <a:chOff x="427081" y="263129"/>
+            <a:chExt cx="1371600" cy="1371600"/>
+          </a:xfrm>
+        </p:grpSpPr>
+        <p:sp>
+          <p:nvSpPr>
+            <p:cNvPr id="36" name="Rectangle 35">
+              <a:extLst>
+                <a:ext uri="{FF2B5EF4-FFF2-40B4-BE49-F238E27FC236}">
+                  <a16:creationId xmlns:a16="http://schemas.microsoft.com/office/drawing/2014/main" id="{09D05DF3-DD40-1AEB-7D57-D5E4C724C096}"/>
+                </a:ext>
+              </a:extLst>
+            </p:cNvPr>
+            <p:cNvSpPr/>
+            <p:nvPr/>
+          </p:nvSpPr>
+          <p:spPr>
+            <a:xfrm>
+              <a:off x="427081" y="263129"/>
+              <a:ext cx="1371600" cy="1371600"/>
+            </a:xfrm>
+            <a:prstGeom prst="rect">
+              <a:avLst/>
+            </a:prstGeom>
+            <a:noFill/>
+            <a:ln w="76200">
+              <a:solidFill>
+                <a:schemeClr val="tx1"/>
+              </a:solidFill>
+            </a:ln>
+          </p:spPr>
+          <p:style>
+            <a:lnRef idx="2">
+              <a:schemeClr val="accent1">
+                <a:shade val="50000"/>
+              </a:schemeClr>
+            </a:lnRef>
+            <a:fillRef idx="1">
+              <a:schemeClr val="accent1"/>
+            </a:fillRef>
+            <a:effectRef idx="0">
+              <a:schemeClr val="accent1"/>
+            </a:effectRef>
+            <a:fontRef idx="minor">
+              <a:schemeClr val="lt1"/>
+            </a:fontRef>
+          </p:style>
+          <p:txBody>
+            <a:bodyPr rtlCol="0" anchor="ctr"/>
+            <a:lstStyle/>
+            <a:p>
+              <a:pPr algn="ctr"/>
+              <a:endParaRPr lang="en-US"/>
+            </a:p>
+          </p:txBody>
+        </p:sp>
+        <p:sp>
+          <p:nvSpPr>
+            <p:cNvPr id="37" name="Plaque 36">
+              <a:extLst>
+                <a:ext uri="{FF2B5EF4-FFF2-40B4-BE49-F238E27FC236}">
+                  <a16:creationId xmlns:a16="http://schemas.microsoft.com/office/drawing/2014/main" id="{7D3FD1FF-3D3C-99F2-F927-A664EB88A6A5}"/>
+                </a:ext>
+              </a:extLst>
+            </p:cNvPr>
+            <p:cNvSpPr/>
+            <p:nvPr/>
+          </p:nvSpPr>
+          <p:spPr>
+            <a:xfrm>
+              <a:off x="573033" y="478473"/>
+              <a:ext cx="1097280" cy="1097280"/>
+            </a:xfrm>
+            <a:prstGeom prst="plaque">
+              <a:avLst/>
+            </a:prstGeom>
+            <a:noFill/>
+            <a:ln w="38100" cap="flat" cmpd="sng" algn="ctr">
+              <a:solidFill>
+                <a:schemeClr val="dk1"/>
+              </a:solidFill>
+              <a:prstDash val="solid"/>
+              <a:round/>
+              <a:headEnd type="none" w="med" len="med"/>
+              <a:tailEnd type="none" w="med" len="med"/>
+            </a:ln>
+          </p:spPr>
+          <p:style>
+            <a:lnRef idx="0">
+              <a:scrgbClr r="0" g="0" b="0"/>
+            </a:lnRef>
+            <a:fillRef idx="0">
+              <a:scrgbClr r="0" g="0" b="0"/>
+            </a:fillRef>
+            <a:effectRef idx="0">
+              <a:scrgbClr r="0" g="0" b="0"/>
+            </a:effectRef>
+            <a:fontRef idx="minor">
+              <a:schemeClr val="dk1"/>
+            </a:fontRef>
+          </p:style>
+          <p:txBody>
+            <a:bodyPr rtlCol="0" anchor="ctr"/>
+            <a:lstStyle/>
+            <a:p>
+              <a:pPr algn="ctr"/>
+              <a:endParaRPr lang="en-US"/>
+            </a:p>
+          </p:txBody>
+        </p:sp>
+      </p:grpSp>
+      <p:grpSp>
+        <p:nvGrpSpPr>
+          <p:cNvPr id="11" name="Group 10">
+            <a:extLst>
+              <a:ext uri="{FF2B5EF4-FFF2-40B4-BE49-F238E27FC236}">
+                <a16:creationId xmlns:a16="http://schemas.microsoft.com/office/drawing/2014/main" id="{C3562DA8-7EC5-D62F-3CD0-47837ED87B1F}"/>
+              </a:ext>
+            </a:extLst>
+          </p:cNvPr>
+          <p:cNvGrpSpPr/>
+          <p:nvPr/>
+        </p:nvGrpSpPr>
+        <p:grpSpPr>
+          <a:xfrm>
+            <a:off x="797409" y="781866"/>
+            <a:ext cx="631137" cy="505972"/>
+            <a:chOff x="5010218" y="2694841"/>
+            <a:chExt cx="2523392" cy="2022962"/>
+          </a:xfrm>
+        </p:grpSpPr>
+        <p:sp>
+          <p:nvSpPr>
+            <p:cNvPr id="5" name="Moon 4">
+              <a:extLst>
+                <a:ext uri="{FF2B5EF4-FFF2-40B4-BE49-F238E27FC236}">
+                  <a16:creationId xmlns:a16="http://schemas.microsoft.com/office/drawing/2014/main" id="{A9874143-2A82-2D3B-F797-BECFB101D068}"/>
+                </a:ext>
+              </a:extLst>
+            </p:cNvPr>
+            <p:cNvSpPr/>
+            <p:nvPr/>
+          </p:nvSpPr>
+          <p:spPr>
+            <a:xfrm rot="16200000">
+              <a:off x="5683528" y="2021531"/>
+              <a:ext cx="1176771" cy="2523392"/>
+            </a:xfrm>
+            <a:prstGeom prst="moon">
+              <a:avLst>
+                <a:gd name="adj" fmla="val 55230"/>
+              </a:avLst>
+            </a:prstGeom>
+          </p:spPr>
+          <p:style>
+            <a:lnRef idx="2">
+              <a:schemeClr val="dk1">
+                <a:shade val="50000"/>
+              </a:schemeClr>
+            </a:lnRef>
+            <a:fillRef idx="1">
+              <a:schemeClr val="dk1"/>
+            </a:fillRef>
+            <a:effectRef idx="0">
+              <a:schemeClr val="dk1"/>
+            </a:effectRef>
+            <a:fontRef idx="minor">
+              <a:schemeClr val="lt1"/>
+            </a:fontRef>
+          </p:style>
+          <p:txBody>
+            <a:bodyPr rtlCol="0" anchor="ctr"/>
+            <a:lstStyle/>
+            <a:p>
+              <a:pPr algn="ctr"/>
+              <a:endParaRPr lang="en-US"/>
+            </a:p>
+          </p:txBody>
+        </p:sp>
+        <p:sp>
+          <p:nvSpPr>
+            <p:cNvPr id="6" name="Isosceles Triangle 5">
+              <a:extLst>
+                <a:ext uri="{FF2B5EF4-FFF2-40B4-BE49-F238E27FC236}">
+                  <a16:creationId xmlns:a16="http://schemas.microsoft.com/office/drawing/2014/main" id="{B6AA356D-404B-7FFC-B885-3A63994A92C0}"/>
+                </a:ext>
+              </a:extLst>
+            </p:cNvPr>
+            <p:cNvSpPr/>
+            <p:nvPr/>
+          </p:nvSpPr>
+          <p:spPr>
+            <a:xfrm>
+              <a:off x="6132701" y="2694841"/>
+              <a:ext cx="278423" cy="1723292"/>
+            </a:xfrm>
+            <a:prstGeom prst="triangle">
+              <a:avLst/>
+            </a:prstGeom>
+          </p:spPr>
+          <p:style>
+            <a:lnRef idx="2">
+              <a:schemeClr val="dk1">
+                <a:shade val="50000"/>
+              </a:schemeClr>
+            </a:lnRef>
+            <a:fillRef idx="1">
+              <a:schemeClr val="dk1"/>
+            </a:fillRef>
+            <a:effectRef idx="0">
+              <a:schemeClr val="dk1"/>
+            </a:effectRef>
+            <a:fontRef idx="minor">
+              <a:schemeClr val="lt1"/>
+            </a:fontRef>
+          </p:style>
+          <p:txBody>
+            <a:bodyPr rtlCol="0" anchor="ctr"/>
+            <a:lstStyle/>
+            <a:p>
+              <a:pPr algn="ctr"/>
+              <a:endParaRPr lang="en-US"/>
+            </a:p>
+          </p:txBody>
+        </p:sp>
+        <p:sp>
+          <p:nvSpPr>
+            <p:cNvPr id="40" name="Moon 39">
+              <a:extLst>
+                <a:ext uri="{FF2B5EF4-FFF2-40B4-BE49-F238E27FC236}">
+                  <a16:creationId xmlns:a16="http://schemas.microsoft.com/office/drawing/2014/main" id="{E3293EBD-1F05-06C9-1DAF-114AB42DFCF7}"/>
+                </a:ext>
+              </a:extLst>
+            </p:cNvPr>
+            <p:cNvSpPr/>
+            <p:nvPr/>
+          </p:nvSpPr>
+          <p:spPr>
+            <a:xfrm rot="5400000">
+              <a:off x="5972241" y="3787285"/>
+              <a:ext cx="599341" cy="1261696"/>
+            </a:xfrm>
+            <a:prstGeom prst="moon">
+              <a:avLst>
+                <a:gd name="adj" fmla="val 37626"/>
+              </a:avLst>
+            </a:prstGeom>
+          </p:spPr>
+          <p:style>
+            <a:lnRef idx="2">
+              <a:schemeClr val="dk1">
+                <a:shade val="50000"/>
+              </a:schemeClr>
+            </a:lnRef>
+            <a:fillRef idx="1">
+              <a:schemeClr val="dk1"/>
+            </a:fillRef>
+            <a:effectRef idx="0">
+              <a:schemeClr val="dk1"/>
+            </a:effectRef>
+            <a:fontRef idx="minor">
+              <a:schemeClr val="lt1"/>
+            </a:fontRef>
+          </p:style>
+          <p:txBody>
+            <a:bodyPr rtlCol="0" anchor="ctr"/>
+            <a:lstStyle/>
+            <a:p>
+              <a:pPr algn="ctr"/>
+              <a:endParaRPr lang="en-US"/>
+            </a:p>
+          </p:txBody>
+        </p:sp>
+        <p:grpSp>
+          <p:nvGrpSpPr>
+            <p:cNvPr id="9" name="Group 8">
+              <a:extLst>
+                <a:ext uri="{FF2B5EF4-FFF2-40B4-BE49-F238E27FC236}">
+                  <a16:creationId xmlns:a16="http://schemas.microsoft.com/office/drawing/2014/main" id="{2D482957-79DD-BCAA-D3A1-FDDBE4B10CF7}"/>
+                </a:ext>
+              </a:extLst>
+            </p:cNvPr>
+            <p:cNvGrpSpPr/>
+            <p:nvPr/>
+          </p:nvGrpSpPr>
+          <p:grpSpPr>
+            <a:xfrm>
+              <a:off x="5240214" y="3072211"/>
+              <a:ext cx="862512" cy="587761"/>
+              <a:chOff x="5240214" y="3072211"/>
+              <a:chExt cx="862512" cy="587761"/>
+            </a:xfrm>
+          </p:grpSpPr>
+          <p:sp>
+            <p:nvSpPr>
+              <p:cNvPr id="7" name="Oval 6">
+                <a:extLst>
+                  <a:ext uri="{FF2B5EF4-FFF2-40B4-BE49-F238E27FC236}">
+                    <a16:creationId xmlns:a16="http://schemas.microsoft.com/office/drawing/2014/main" id="{2735767C-3AA8-47B6-D677-7D4BE75CD5D0}"/>
+                  </a:ext>
+                </a:extLst>
+              </p:cNvPr>
+              <p:cNvSpPr/>
+              <p:nvPr/>
+            </p:nvSpPr>
+            <p:spPr>
+              <a:xfrm>
+                <a:off x="5475402" y="3233279"/>
+                <a:ext cx="274320" cy="274320"/>
+              </a:xfrm>
+              <a:prstGeom prst="ellipse">
+                <a:avLst/>
+              </a:prstGeom>
+            </p:spPr>
+            <p:style>
+              <a:lnRef idx="2">
+                <a:schemeClr val="dk1"/>
+              </a:lnRef>
+              <a:fillRef idx="1">
+                <a:schemeClr val="lt1"/>
+              </a:fillRef>
+              <a:effectRef idx="0">
+                <a:schemeClr val="dk1"/>
+              </a:effectRef>
+              <a:fontRef idx="minor">
+                <a:schemeClr val="dk1"/>
+              </a:fontRef>
+            </p:style>
+            <p:txBody>
+              <a:bodyPr rtlCol="0" anchor="ctr"/>
+              <a:lstStyle/>
+              <a:p>
+                <a:pPr algn="ctr"/>
+                <a:endParaRPr lang="en-US"/>
+              </a:p>
+            </p:txBody>
+          </p:sp>
+          <p:sp>
+            <p:nvSpPr>
+              <p:cNvPr id="42" name="Oval 41">
+                <a:extLst>
+                  <a:ext uri="{FF2B5EF4-FFF2-40B4-BE49-F238E27FC236}">
+                    <a16:creationId xmlns:a16="http://schemas.microsoft.com/office/drawing/2014/main" id="{6F5C74B7-A58D-7D31-DEF0-18727C62BFB7}"/>
+                  </a:ext>
+                </a:extLst>
+              </p:cNvPr>
+              <p:cNvSpPr/>
+              <p:nvPr/>
+            </p:nvSpPr>
+            <p:spPr>
+              <a:xfrm>
+                <a:off x="5240214" y="3072211"/>
+                <a:ext cx="228600" cy="228600"/>
+              </a:xfrm>
+              <a:prstGeom prst="ellipse">
+                <a:avLst/>
+              </a:prstGeom>
+            </p:spPr>
+            <p:style>
+              <a:lnRef idx="2">
+                <a:schemeClr val="dk1"/>
+              </a:lnRef>
+              <a:fillRef idx="1">
+                <a:schemeClr val="lt1"/>
+              </a:fillRef>
+              <a:effectRef idx="0">
+                <a:schemeClr val="dk1"/>
+              </a:effectRef>
+              <a:fontRef idx="minor">
+                <a:schemeClr val="dk1"/>
+              </a:fontRef>
+            </p:style>
+            <p:txBody>
+              <a:bodyPr rtlCol="0" anchor="ctr"/>
+              <a:lstStyle/>
+              <a:p>
+                <a:pPr algn="ctr"/>
+                <a:endParaRPr lang="en-US"/>
+              </a:p>
+            </p:txBody>
+          </p:sp>
+          <p:sp>
+            <p:nvSpPr>
+              <p:cNvPr id="43" name="Oval 42">
+                <a:extLst>
+                  <a:ext uri="{FF2B5EF4-FFF2-40B4-BE49-F238E27FC236}">
+                    <a16:creationId xmlns:a16="http://schemas.microsoft.com/office/drawing/2014/main" id="{526E0C8A-89C5-3741-68F7-CCFFAC180B99}"/>
+                  </a:ext>
+                </a:extLst>
+              </p:cNvPr>
+              <p:cNvSpPr/>
+              <p:nvPr/>
+            </p:nvSpPr>
+            <p:spPr>
+              <a:xfrm>
+                <a:off x="5782686" y="3339932"/>
+                <a:ext cx="320040" cy="320040"/>
+              </a:xfrm>
+              <a:prstGeom prst="ellipse">
+                <a:avLst/>
+              </a:prstGeom>
+            </p:spPr>
+            <p:style>
+              <a:lnRef idx="2">
+                <a:schemeClr val="dk1"/>
+              </a:lnRef>
+              <a:fillRef idx="1">
+                <a:schemeClr val="lt1"/>
+              </a:fillRef>
+              <a:effectRef idx="0">
+                <a:schemeClr val="dk1"/>
+              </a:effectRef>
+              <a:fontRef idx="minor">
+                <a:schemeClr val="dk1"/>
+              </a:fontRef>
+            </p:style>
+            <p:txBody>
+              <a:bodyPr rtlCol="0" anchor="ctr"/>
+              <a:lstStyle/>
+              <a:p>
+                <a:pPr algn="ctr"/>
+                <a:endParaRPr lang="en-US"/>
+              </a:p>
+            </p:txBody>
+          </p:sp>
+        </p:grpSp>
+        <p:grpSp>
+          <p:nvGrpSpPr>
+            <p:cNvPr id="48" name="Group 47">
+              <a:extLst>
+                <a:ext uri="{FF2B5EF4-FFF2-40B4-BE49-F238E27FC236}">
+                  <a16:creationId xmlns:a16="http://schemas.microsoft.com/office/drawing/2014/main" id="{71A6133B-7C99-7283-AAC2-A0CA1651A05E}"/>
+                </a:ext>
+              </a:extLst>
+            </p:cNvPr>
+            <p:cNvGrpSpPr/>
+            <p:nvPr/>
+          </p:nvGrpSpPr>
+          <p:grpSpPr>
+            <a:xfrm flipH="1">
+              <a:off x="6400433" y="3085350"/>
+              <a:ext cx="862512" cy="587761"/>
+              <a:chOff x="5240214" y="3072211"/>
+              <a:chExt cx="862512" cy="587761"/>
+            </a:xfrm>
+          </p:grpSpPr>
+          <p:sp>
+            <p:nvSpPr>
+              <p:cNvPr id="49" name="Oval 48">
+                <a:extLst>
+                  <a:ext uri="{FF2B5EF4-FFF2-40B4-BE49-F238E27FC236}">
+                    <a16:creationId xmlns:a16="http://schemas.microsoft.com/office/drawing/2014/main" id="{AA5D0FA6-B69E-87AA-C31D-6B987901B4D2}"/>
+                  </a:ext>
+                </a:extLst>
+              </p:cNvPr>
+              <p:cNvSpPr/>
+              <p:nvPr/>
+            </p:nvSpPr>
+            <p:spPr>
+              <a:xfrm>
+                <a:off x="5475402" y="3233279"/>
+                <a:ext cx="274320" cy="274320"/>
+              </a:xfrm>
+              <a:prstGeom prst="ellipse">
+                <a:avLst/>
+              </a:prstGeom>
+            </p:spPr>
+            <p:style>
+              <a:lnRef idx="2">
+                <a:schemeClr val="dk1"/>
+              </a:lnRef>
+              <a:fillRef idx="1">
+                <a:schemeClr val="lt1"/>
+              </a:fillRef>
+              <a:effectRef idx="0">
+                <a:schemeClr val="dk1"/>
+              </a:effectRef>
+              <a:fontRef idx="minor">
+                <a:schemeClr val="dk1"/>
+              </a:fontRef>
+            </p:style>
+            <p:txBody>
+              <a:bodyPr rtlCol="0" anchor="ctr"/>
+              <a:lstStyle/>
+              <a:p>
+                <a:pPr algn="ctr"/>
+                <a:endParaRPr lang="en-US"/>
+              </a:p>
+            </p:txBody>
+          </p:sp>
+          <p:sp>
+            <p:nvSpPr>
+              <p:cNvPr id="50" name="Oval 49">
+                <a:extLst>
+                  <a:ext uri="{FF2B5EF4-FFF2-40B4-BE49-F238E27FC236}">
+                    <a16:creationId xmlns:a16="http://schemas.microsoft.com/office/drawing/2014/main" id="{94C1367F-6979-8909-D9D6-3487DAB2ACD3}"/>
+                  </a:ext>
+                </a:extLst>
+              </p:cNvPr>
+              <p:cNvSpPr/>
+              <p:nvPr/>
+            </p:nvSpPr>
+            <p:spPr>
+              <a:xfrm>
+                <a:off x="5240214" y="3072211"/>
+                <a:ext cx="228600" cy="228600"/>
+              </a:xfrm>
+              <a:prstGeom prst="ellipse">
+                <a:avLst/>
+              </a:prstGeom>
+            </p:spPr>
+            <p:style>
+              <a:lnRef idx="2">
+                <a:schemeClr val="dk1"/>
+              </a:lnRef>
+              <a:fillRef idx="1">
+                <a:schemeClr val="lt1"/>
+              </a:fillRef>
+              <a:effectRef idx="0">
+                <a:schemeClr val="dk1"/>
+              </a:effectRef>
+              <a:fontRef idx="minor">
+                <a:schemeClr val="dk1"/>
+              </a:fontRef>
+            </p:style>
+            <p:txBody>
+              <a:bodyPr rtlCol="0" anchor="ctr"/>
+              <a:lstStyle/>
+              <a:p>
+                <a:pPr algn="ctr"/>
+                <a:endParaRPr lang="en-US"/>
+              </a:p>
+            </p:txBody>
+          </p:sp>
+          <p:sp>
+            <p:nvSpPr>
+              <p:cNvPr id="51" name="Oval 50">
+                <a:extLst>
+                  <a:ext uri="{FF2B5EF4-FFF2-40B4-BE49-F238E27FC236}">
+                    <a16:creationId xmlns:a16="http://schemas.microsoft.com/office/drawing/2014/main" id="{0DBD12CD-E674-B369-7759-196E0F918CB0}"/>
+                  </a:ext>
+                </a:extLst>
+              </p:cNvPr>
+              <p:cNvSpPr/>
+              <p:nvPr/>
+            </p:nvSpPr>
+            <p:spPr>
+              <a:xfrm>
+                <a:off x="5782686" y="3339932"/>
+                <a:ext cx="320040" cy="320040"/>
+              </a:xfrm>
+              <a:prstGeom prst="ellipse">
+                <a:avLst/>
+              </a:prstGeom>
+            </p:spPr>
+            <p:style>
+              <a:lnRef idx="2">
+                <a:schemeClr val="dk1"/>
+              </a:lnRef>
+              <a:fillRef idx="1">
+                <a:schemeClr val="lt1"/>
+              </a:fillRef>
+              <a:effectRef idx="0">
+                <a:schemeClr val="dk1"/>
+              </a:effectRef>
+              <a:fontRef idx="minor">
+                <a:schemeClr val="dk1"/>
+              </a:fontRef>
+            </p:style>
+            <p:txBody>
+              <a:bodyPr rtlCol="0" anchor="ctr"/>
+              <a:lstStyle/>
+              <a:p>
+                <a:pPr algn="ctr"/>
+                <a:endParaRPr lang="en-US"/>
+              </a:p>
+            </p:txBody>
+          </p:sp>
+        </p:grpSp>
+      </p:grpSp>
+      <p:grpSp>
+        <p:nvGrpSpPr>
+          <p:cNvPr id="19" name="Group 18">
+            <a:extLst>
+              <a:ext uri="{FF2B5EF4-FFF2-40B4-BE49-F238E27FC236}">
+                <a16:creationId xmlns:a16="http://schemas.microsoft.com/office/drawing/2014/main" id="{F0C5DF98-2563-86F8-66B2-5F473BDD317C}"/>
+              </a:ext>
+            </a:extLst>
+          </p:cNvPr>
+          <p:cNvGrpSpPr/>
+          <p:nvPr/>
+        </p:nvGrpSpPr>
+        <p:grpSpPr>
+          <a:xfrm>
+            <a:off x="2507360" y="554317"/>
+            <a:ext cx="577458" cy="886118"/>
+            <a:chOff x="5275383" y="2444259"/>
+            <a:chExt cx="2101363" cy="3224576"/>
+          </a:xfrm>
+        </p:grpSpPr>
+        <p:sp>
+          <p:nvSpPr>
+            <p:cNvPr id="12" name="Isosceles Triangle 11">
+              <a:extLst>
+                <a:ext uri="{FF2B5EF4-FFF2-40B4-BE49-F238E27FC236}">
+                  <a16:creationId xmlns:a16="http://schemas.microsoft.com/office/drawing/2014/main" id="{2EADF2A1-A28A-D893-3F15-3F31AEB87ECF}"/>
+                </a:ext>
+              </a:extLst>
+            </p:cNvPr>
+            <p:cNvSpPr/>
+            <p:nvPr/>
+          </p:nvSpPr>
+          <p:spPr>
+            <a:xfrm rot="10800000">
+              <a:off x="5653455" y="3974123"/>
+              <a:ext cx="1345223" cy="474785"/>
+            </a:xfrm>
+            <a:prstGeom prst="triangle">
+              <a:avLst/>
+            </a:prstGeom>
+            <a:ln w="28575"/>
+          </p:spPr>
+          <p:style>
+            <a:lnRef idx="2">
+              <a:schemeClr val="dk1"/>
+            </a:lnRef>
+            <a:fillRef idx="1">
+              <a:schemeClr val="lt1"/>
+            </a:fillRef>
+            <a:effectRef idx="0">
+              <a:schemeClr val="dk1"/>
+            </a:effectRef>
+            <a:fontRef idx="minor">
+              <a:schemeClr val="dk1"/>
+            </a:fontRef>
+          </p:style>
+          <p:txBody>
+            <a:bodyPr rtlCol="0" anchor="ctr"/>
+            <a:lstStyle/>
+            <a:p>
+              <a:pPr algn="ctr"/>
+              <a:endParaRPr lang="en-US"/>
+            </a:p>
+          </p:txBody>
+        </p:sp>
+        <p:sp>
+          <p:nvSpPr>
+            <p:cNvPr id="14" name="Isosceles Triangle 13">
+              <a:extLst>
+                <a:ext uri="{FF2B5EF4-FFF2-40B4-BE49-F238E27FC236}">
+                  <a16:creationId xmlns:a16="http://schemas.microsoft.com/office/drawing/2014/main" id="{87195922-C896-82C4-7731-A567421AC31C}"/>
+                </a:ext>
+              </a:extLst>
+            </p:cNvPr>
+            <p:cNvSpPr/>
+            <p:nvPr/>
+          </p:nvSpPr>
+          <p:spPr>
+            <a:xfrm>
+              <a:off x="5675434" y="2699238"/>
+              <a:ext cx="219808" cy="1274885"/>
+            </a:xfrm>
+            <a:prstGeom prst="triangle">
+              <a:avLst/>
+            </a:prstGeom>
+          </p:spPr>
+          <p:style>
+            <a:lnRef idx="2">
+              <a:schemeClr val="dk1">
+                <a:shade val="50000"/>
+              </a:schemeClr>
+            </a:lnRef>
+            <a:fillRef idx="1">
+              <a:schemeClr val="dk1"/>
+            </a:fillRef>
+            <a:effectRef idx="0">
+              <a:schemeClr val="dk1"/>
+            </a:effectRef>
+            <a:fontRef idx="minor">
+              <a:schemeClr val="lt1"/>
+            </a:fontRef>
+          </p:style>
+          <p:txBody>
+            <a:bodyPr rtlCol="0" anchor="ctr"/>
+            <a:lstStyle/>
+            <a:p>
+              <a:pPr algn="ctr"/>
+              <a:endParaRPr lang="en-US"/>
+            </a:p>
+          </p:txBody>
+        </p:sp>
+        <p:sp>
+          <p:nvSpPr>
+            <p:cNvPr id="55" name="Isosceles Triangle 54">
+              <a:extLst>
+                <a:ext uri="{FF2B5EF4-FFF2-40B4-BE49-F238E27FC236}">
+                  <a16:creationId xmlns:a16="http://schemas.microsoft.com/office/drawing/2014/main" id="{73506609-2BD0-91A1-05EF-31098DDB94BC}"/>
+                </a:ext>
+              </a:extLst>
+            </p:cNvPr>
+            <p:cNvSpPr/>
+            <p:nvPr/>
+          </p:nvSpPr>
+          <p:spPr>
+            <a:xfrm>
+              <a:off x="6778870" y="2699237"/>
+              <a:ext cx="219808" cy="1274885"/>
+            </a:xfrm>
+            <a:prstGeom prst="triangle">
+              <a:avLst/>
+            </a:prstGeom>
+          </p:spPr>
+          <p:style>
+            <a:lnRef idx="2">
+              <a:schemeClr val="dk1">
+                <a:shade val="50000"/>
+              </a:schemeClr>
+            </a:lnRef>
+            <a:fillRef idx="1">
+              <a:schemeClr val="dk1"/>
+            </a:fillRef>
+            <a:effectRef idx="0">
+              <a:schemeClr val="dk1"/>
+            </a:effectRef>
+            <a:fontRef idx="minor">
+              <a:schemeClr val="lt1"/>
+            </a:fontRef>
+          </p:style>
+          <p:txBody>
+            <a:bodyPr rtlCol="0" anchor="ctr"/>
+            <a:lstStyle/>
+            <a:p>
+              <a:pPr algn="ctr"/>
+              <a:endParaRPr lang="en-US"/>
+            </a:p>
+          </p:txBody>
+        </p:sp>
+        <p:sp>
+          <p:nvSpPr>
+            <p:cNvPr id="56" name="Isosceles Triangle 55">
+              <a:extLst>
+                <a:ext uri="{FF2B5EF4-FFF2-40B4-BE49-F238E27FC236}">
+                  <a16:creationId xmlns:a16="http://schemas.microsoft.com/office/drawing/2014/main" id="{C30E4588-E89B-61F1-12DA-7A3ED2B4D301}"/>
+                </a:ext>
+              </a:extLst>
+            </p:cNvPr>
+            <p:cNvSpPr/>
+            <p:nvPr/>
+          </p:nvSpPr>
+          <p:spPr>
+            <a:xfrm>
+              <a:off x="6216162" y="2444259"/>
+              <a:ext cx="219808" cy="1529863"/>
+            </a:xfrm>
+            <a:prstGeom prst="triangle">
+              <a:avLst/>
+            </a:prstGeom>
+          </p:spPr>
+          <p:style>
+            <a:lnRef idx="2">
+              <a:schemeClr val="dk1"/>
+            </a:lnRef>
+            <a:fillRef idx="1">
+              <a:schemeClr val="lt1"/>
+            </a:fillRef>
+            <a:effectRef idx="0">
+              <a:schemeClr val="dk1"/>
+            </a:effectRef>
+            <a:fontRef idx="minor">
+              <a:schemeClr val="dk1"/>
+            </a:fontRef>
+          </p:style>
+          <p:txBody>
+            <a:bodyPr rtlCol="0" anchor="ctr"/>
+            <a:lstStyle/>
+            <a:p>
+              <a:pPr algn="ctr"/>
+              <a:endParaRPr lang="en-US"/>
+            </a:p>
+          </p:txBody>
+        </p:sp>
+        <p:sp>
+          <p:nvSpPr>
+            <p:cNvPr id="60" name="Moon 59">
+              <a:extLst>
+                <a:ext uri="{FF2B5EF4-FFF2-40B4-BE49-F238E27FC236}">
+                  <a16:creationId xmlns:a16="http://schemas.microsoft.com/office/drawing/2014/main" id="{87A7BA59-A2B6-709C-00C8-16832E3531D0}"/>
+                </a:ext>
+              </a:extLst>
+            </p:cNvPr>
+            <p:cNvSpPr/>
+            <p:nvPr/>
+          </p:nvSpPr>
+          <p:spPr>
+            <a:xfrm rot="5400000">
+              <a:off x="6060099" y="4769824"/>
+              <a:ext cx="531929" cy="1266094"/>
+            </a:xfrm>
+            <a:prstGeom prst="moon">
+              <a:avLst>
+                <a:gd name="adj" fmla="val 38235"/>
+              </a:avLst>
+            </a:prstGeom>
+          </p:spPr>
+          <p:style>
+            <a:lnRef idx="2">
+              <a:schemeClr val="dk1"/>
+            </a:lnRef>
+            <a:fillRef idx="1">
+              <a:schemeClr val="lt1"/>
+            </a:fillRef>
+            <a:effectRef idx="0">
+              <a:schemeClr val="dk1"/>
+            </a:effectRef>
+            <a:fontRef idx="minor">
+              <a:schemeClr val="dk1"/>
+            </a:fontRef>
+          </p:style>
+          <p:txBody>
+            <a:bodyPr rtlCol="0" anchor="ctr"/>
+            <a:lstStyle/>
+            <a:p>
+              <a:pPr algn="ctr"/>
+              <a:endParaRPr lang="en-US"/>
+            </a:p>
+          </p:txBody>
+        </p:sp>
+        <p:sp>
+          <p:nvSpPr>
+            <p:cNvPr id="17" name="Isosceles Triangle 16">
+              <a:extLst>
+                <a:ext uri="{FF2B5EF4-FFF2-40B4-BE49-F238E27FC236}">
+                  <a16:creationId xmlns:a16="http://schemas.microsoft.com/office/drawing/2014/main" id="{ECBE0F47-3EA0-620C-2D86-AF5078632349}"/>
+                </a:ext>
+              </a:extLst>
+            </p:cNvPr>
+            <p:cNvSpPr/>
+            <p:nvPr/>
+          </p:nvSpPr>
+          <p:spPr>
+            <a:xfrm rot="10800000">
+              <a:off x="6000749" y="4211516"/>
+              <a:ext cx="650633" cy="1424349"/>
+            </a:xfrm>
+            <a:prstGeom prst="triangle">
+              <a:avLst/>
+            </a:prstGeom>
+          </p:spPr>
+          <p:style>
+            <a:lnRef idx="2">
+              <a:schemeClr val="dk1">
+                <a:shade val="50000"/>
+              </a:schemeClr>
+            </a:lnRef>
+            <a:fillRef idx="1">
+              <a:schemeClr val="dk1"/>
+            </a:fillRef>
+            <a:effectRef idx="0">
+              <a:schemeClr val="dk1"/>
+            </a:effectRef>
+            <a:fontRef idx="minor">
+              <a:schemeClr val="lt1"/>
+            </a:fontRef>
+          </p:style>
+          <p:txBody>
+            <a:bodyPr rtlCol="0" anchor="ctr"/>
+            <a:lstStyle/>
+            <a:p>
+              <a:pPr algn="ctr"/>
+              <a:endParaRPr lang="en-US"/>
+            </a:p>
+          </p:txBody>
+        </p:sp>
+        <p:sp>
+          <p:nvSpPr>
+            <p:cNvPr id="18" name="Moon 17">
+              <a:extLst>
+                <a:ext uri="{FF2B5EF4-FFF2-40B4-BE49-F238E27FC236}">
+                  <a16:creationId xmlns:a16="http://schemas.microsoft.com/office/drawing/2014/main" id="{FD6EA14C-83A3-27CE-AD16-7D3EF805E5B4}"/>
+                </a:ext>
+              </a:extLst>
+            </p:cNvPr>
+            <p:cNvSpPr/>
+            <p:nvPr/>
+          </p:nvSpPr>
+          <p:spPr>
+            <a:xfrm rot="5400000">
+              <a:off x="6027126" y="3697166"/>
+              <a:ext cx="597877" cy="2101363"/>
+            </a:xfrm>
+            <a:prstGeom prst="moon">
+              <a:avLst/>
+            </a:prstGeom>
+          </p:spPr>
+          <p:style>
+            <a:lnRef idx="2">
+              <a:schemeClr val="dk1">
+                <a:shade val="50000"/>
+              </a:schemeClr>
+            </a:lnRef>
+            <a:fillRef idx="1">
+              <a:schemeClr val="dk1"/>
+            </a:fillRef>
+            <a:effectRef idx="0">
+              <a:schemeClr val="dk1"/>
+            </a:effectRef>
+            <a:fontRef idx="minor">
+              <a:schemeClr val="lt1"/>
+            </a:fontRef>
+          </p:style>
+          <p:txBody>
+            <a:bodyPr rtlCol="0" anchor="ctr"/>
+            <a:lstStyle/>
+            <a:p>
+              <a:pPr algn="ctr"/>
+              <a:endParaRPr lang="en-US"/>
+            </a:p>
+          </p:txBody>
+        </p:sp>
+      </p:grpSp>
+      <p:grpSp>
+        <p:nvGrpSpPr>
+          <p:cNvPr id="24" name="Group 23">
+            <a:extLst>
+              <a:ext uri="{FF2B5EF4-FFF2-40B4-BE49-F238E27FC236}">
+                <a16:creationId xmlns:a16="http://schemas.microsoft.com/office/drawing/2014/main" id="{28961DD9-2354-5B68-2F7D-5210C746B4E7}"/>
+              </a:ext>
+            </a:extLst>
+          </p:cNvPr>
+          <p:cNvGrpSpPr/>
+          <p:nvPr/>
+        </p:nvGrpSpPr>
+        <p:grpSpPr>
+          <a:xfrm>
+            <a:off x="3943868" y="615737"/>
+            <a:ext cx="1020292" cy="877614"/>
+            <a:chOff x="5664202" y="1634729"/>
+            <a:chExt cx="2809442" cy="2416570"/>
+          </a:xfrm>
+        </p:grpSpPr>
+        <p:sp>
+          <p:nvSpPr>
+            <p:cNvPr id="21" name="Moon 20">
+              <a:extLst>
+                <a:ext uri="{FF2B5EF4-FFF2-40B4-BE49-F238E27FC236}">
+                  <a16:creationId xmlns:a16="http://schemas.microsoft.com/office/drawing/2014/main" id="{E205A88C-A617-A10F-64E8-ACB267143627}"/>
+                </a:ext>
+              </a:extLst>
+            </p:cNvPr>
+            <p:cNvSpPr/>
+            <p:nvPr/>
+          </p:nvSpPr>
+          <p:spPr>
+            <a:xfrm rot="16200000" flipV="1">
+              <a:off x="6630773" y="1057275"/>
+              <a:ext cx="876300" cy="2809442"/>
+            </a:xfrm>
+            <a:prstGeom prst="moon">
+              <a:avLst/>
+            </a:prstGeom>
+          </p:spPr>
+          <p:style>
+            <a:lnRef idx="2">
+              <a:schemeClr val="dk1"/>
+            </a:lnRef>
+            <a:fillRef idx="1">
+              <a:schemeClr val="lt1"/>
+            </a:fillRef>
+            <a:effectRef idx="0">
+              <a:schemeClr val="dk1"/>
+            </a:effectRef>
+            <a:fontRef idx="minor">
+              <a:schemeClr val="dk1"/>
+            </a:fontRef>
+          </p:style>
+          <p:txBody>
+            <a:bodyPr rtlCol="0" anchor="ctr"/>
+            <a:lstStyle/>
+            <a:p>
+              <a:pPr algn="ctr"/>
+              <a:endParaRPr lang="en-US"/>
+            </a:p>
+          </p:txBody>
+        </p:sp>
+        <p:sp>
+          <p:nvSpPr>
+            <p:cNvPr id="67" name="Moon 66">
+              <a:extLst>
+                <a:ext uri="{FF2B5EF4-FFF2-40B4-BE49-F238E27FC236}">
+                  <a16:creationId xmlns:a16="http://schemas.microsoft.com/office/drawing/2014/main" id="{57F01248-854D-FF68-7C19-2D740C67AE52}"/>
+                </a:ext>
+              </a:extLst>
+            </p:cNvPr>
+            <p:cNvSpPr/>
+            <p:nvPr/>
+          </p:nvSpPr>
+          <p:spPr>
+            <a:xfrm rot="16200000" flipV="1">
+              <a:off x="6777590" y="2133133"/>
+              <a:ext cx="658596" cy="2101848"/>
+            </a:xfrm>
+            <a:prstGeom prst="moon">
+              <a:avLst/>
+            </a:prstGeom>
+          </p:spPr>
+          <p:style>
+            <a:lnRef idx="2">
+              <a:schemeClr val="dk1"/>
+            </a:lnRef>
+            <a:fillRef idx="1">
+              <a:schemeClr val="lt1"/>
+            </a:fillRef>
+            <a:effectRef idx="0">
+              <a:schemeClr val="dk1"/>
+            </a:effectRef>
+            <a:fontRef idx="minor">
+              <a:schemeClr val="dk1"/>
+            </a:fontRef>
+          </p:style>
+          <p:txBody>
+            <a:bodyPr rtlCol="0" anchor="ctr"/>
+            <a:lstStyle/>
+            <a:p>
+              <a:pPr algn="ctr"/>
+              <a:endParaRPr lang="en-US"/>
+            </a:p>
+          </p:txBody>
+        </p:sp>
+        <p:sp>
+          <p:nvSpPr>
+            <p:cNvPr id="68" name="Moon 67">
+              <a:extLst>
+                <a:ext uri="{FF2B5EF4-FFF2-40B4-BE49-F238E27FC236}">
+                  <a16:creationId xmlns:a16="http://schemas.microsoft.com/office/drawing/2014/main" id="{958D179A-FCB2-1FAD-E919-831449E3CB87}"/>
+                </a:ext>
+              </a:extLst>
+            </p:cNvPr>
+            <p:cNvSpPr/>
+            <p:nvPr/>
+          </p:nvSpPr>
+          <p:spPr>
+            <a:xfrm rot="16200000" flipV="1">
+              <a:off x="6839285" y="3112240"/>
+              <a:ext cx="535205" cy="1337436"/>
+            </a:xfrm>
+            <a:prstGeom prst="moon">
+              <a:avLst/>
+            </a:prstGeom>
+          </p:spPr>
+          <p:style>
+            <a:lnRef idx="2">
+              <a:schemeClr val="dk1"/>
+            </a:lnRef>
+            <a:fillRef idx="1">
+              <a:schemeClr val="lt1"/>
+            </a:fillRef>
+            <a:effectRef idx="0">
+              <a:schemeClr val="dk1"/>
+            </a:effectRef>
+            <a:fontRef idx="minor">
+              <a:schemeClr val="dk1"/>
+            </a:fontRef>
+          </p:style>
+          <p:txBody>
+            <a:bodyPr rtlCol="0" anchor="ctr"/>
+            <a:lstStyle/>
+            <a:p>
+              <a:pPr algn="ctr"/>
+              <a:endParaRPr lang="en-US"/>
+            </a:p>
+          </p:txBody>
+        </p:sp>
+        <p:sp>
+          <p:nvSpPr>
+            <p:cNvPr id="20" name="Trapezoid 19">
+              <a:extLst>
+                <a:ext uri="{FF2B5EF4-FFF2-40B4-BE49-F238E27FC236}">
+                  <a16:creationId xmlns:a16="http://schemas.microsoft.com/office/drawing/2014/main" id="{B4208B20-59E1-0795-4DAE-F3477F5F5F55}"/>
+                </a:ext>
+              </a:extLst>
+            </p:cNvPr>
+            <p:cNvSpPr/>
+            <p:nvPr/>
+          </p:nvSpPr>
+          <p:spPr>
+            <a:xfrm rot="10800000">
+              <a:off x="6527800" y="2060178"/>
+              <a:ext cx="1168400" cy="1991121"/>
+            </a:xfrm>
+            <a:prstGeom prst="trapezoid">
+              <a:avLst/>
+            </a:prstGeom>
+          </p:spPr>
+          <p:style>
+            <a:lnRef idx="2">
+              <a:schemeClr val="dk1">
+                <a:shade val="50000"/>
+              </a:schemeClr>
+            </a:lnRef>
+            <a:fillRef idx="1">
+              <a:schemeClr val="dk1"/>
+            </a:fillRef>
+            <a:effectRef idx="0">
+              <a:schemeClr val="dk1"/>
+            </a:effectRef>
+            <a:fontRef idx="minor">
+              <a:schemeClr val="lt1"/>
+            </a:fontRef>
+          </p:style>
+          <p:txBody>
+            <a:bodyPr rtlCol="0" anchor="ctr"/>
+            <a:lstStyle/>
+            <a:p>
+              <a:pPr algn="ctr"/>
+              <a:endParaRPr lang="en-US"/>
+            </a:p>
+          </p:txBody>
+        </p:sp>
+        <p:sp>
+          <p:nvSpPr>
+            <p:cNvPr id="66" name="Trapezoid 65">
+              <a:extLst>
+                <a:ext uri="{FF2B5EF4-FFF2-40B4-BE49-F238E27FC236}">
+                  <a16:creationId xmlns:a16="http://schemas.microsoft.com/office/drawing/2014/main" id="{354C1164-4902-CC73-0E27-43A861AB0199}"/>
+                </a:ext>
+              </a:extLst>
+            </p:cNvPr>
+            <p:cNvSpPr/>
+            <p:nvPr/>
+          </p:nvSpPr>
+          <p:spPr>
+            <a:xfrm>
+              <a:off x="6667977" y="1634729"/>
+              <a:ext cx="877823" cy="341783"/>
+            </a:xfrm>
+            <a:prstGeom prst="trapezoid">
+              <a:avLst/>
+            </a:prstGeom>
+          </p:spPr>
+          <p:style>
+            <a:lnRef idx="2">
+              <a:schemeClr val="dk1">
+                <a:shade val="50000"/>
+              </a:schemeClr>
+            </a:lnRef>
+            <a:fillRef idx="1">
+              <a:schemeClr val="dk1"/>
+            </a:fillRef>
+            <a:effectRef idx="0">
+              <a:schemeClr val="dk1"/>
+            </a:effectRef>
+            <a:fontRef idx="minor">
+              <a:schemeClr val="lt1"/>
+            </a:fontRef>
+          </p:style>
+          <p:txBody>
+            <a:bodyPr rtlCol="0" anchor="ctr"/>
+            <a:lstStyle/>
+            <a:p>
+              <a:pPr algn="ctr"/>
+              <a:endParaRPr lang="en-US"/>
+            </a:p>
+          </p:txBody>
+        </p:sp>
+        <p:sp>
+          <p:nvSpPr>
+            <p:cNvPr id="22" name="Oval 21">
+              <a:extLst>
+                <a:ext uri="{FF2B5EF4-FFF2-40B4-BE49-F238E27FC236}">
+                  <a16:creationId xmlns:a16="http://schemas.microsoft.com/office/drawing/2014/main" id="{187BCEC2-D005-ACA5-364B-F687BF13FC73}"/>
+                </a:ext>
+              </a:extLst>
+            </p:cNvPr>
+            <p:cNvSpPr/>
+            <p:nvPr/>
+          </p:nvSpPr>
+          <p:spPr>
+            <a:xfrm>
+              <a:off x="6832567" y="2092176"/>
+              <a:ext cx="548640" cy="548640"/>
+            </a:xfrm>
+            <a:prstGeom prst="ellipse">
+              <a:avLst/>
+            </a:prstGeom>
+          </p:spPr>
+          <p:style>
+            <a:lnRef idx="2">
+              <a:schemeClr val="dk1"/>
+            </a:lnRef>
+            <a:fillRef idx="1">
+              <a:schemeClr val="lt1"/>
+            </a:fillRef>
+            <a:effectRef idx="0">
+              <a:schemeClr val="dk1"/>
+            </a:effectRef>
+            <a:fontRef idx="minor">
+              <a:schemeClr val="dk1"/>
+            </a:fontRef>
+          </p:style>
+          <p:txBody>
+            <a:bodyPr rtlCol="0" anchor="ctr"/>
+            <a:lstStyle/>
+            <a:p>
+              <a:pPr algn="ctr"/>
+              <a:endParaRPr lang="en-US"/>
+            </a:p>
+          </p:txBody>
+        </p:sp>
+        <p:sp>
+          <p:nvSpPr>
+            <p:cNvPr id="69" name="Oval 68">
+              <a:extLst>
+                <a:ext uri="{FF2B5EF4-FFF2-40B4-BE49-F238E27FC236}">
+                  <a16:creationId xmlns:a16="http://schemas.microsoft.com/office/drawing/2014/main" id="{D3CCCD81-AEAF-1D91-1A8A-CA5702635CD6}"/>
+                </a:ext>
+              </a:extLst>
+            </p:cNvPr>
+            <p:cNvSpPr/>
+            <p:nvPr/>
+          </p:nvSpPr>
+          <p:spPr>
+            <a:xfrm>
+              <a:off x="6878287" y="2672814"/>
+              <a:ext cx="457200" cy="457200"/>
+            </a:xfrm>
+            <a:prstGeom prst="ellipse">
+              <a:avLst/>
+            </a:prstGeom>
+          </p:spPr>
+          <p:style>
+            <a:lnRef idx="2">
+              <a:schemeClr val="dk1"/>
+            </a:lnRef>
+            <a:fillRef idx="1">
+              <a:schemeClr val="lt1"/>
+            </a:fillRef>
+            <a:effectRef idx="0">
+              <a:schemeClr val="dk1"/>
+            </a:effectRef>
+            <a:fontRef idx="minor">
+              <a:schemeClr val="dk1"/>
+            </a:fontRef>
+          </p:style>
+          <p:txBody>
+            <a:bodyPr rtlCol="0" anchor="ctr"/>
+            <a:lstStyle/>
+            <a:p>
+              <a:pPr algn="ctr"/>
+              <a:endParaRPr lang="en-US"/>
+            </a:p>
+          </p:txBody>
+        </p:sp>
+        <p:sp>
+          <p:nvSpPr>
+            <p:cNvPr id="70" name="Oval 69">
+              <a:extLst>
+                <a:ext uri="{FF2B5EF4-FFF2-40B4-BE49-F238E27FC236}">
+                  <a16:creationId xmlns:a16="http://schemas.microsoft.com/office/drawing/2014/main" id="{16D2DBA2-511B-A238-4803-4A57DC71210F}"/>
+                </a:ext>
+              </a:extLst>
+            </p:cNvPr>
+            <p:cNvSpPr/>
+            <p:nvPr/>
+          </p:nvSpPr>
+          <p:spPr>
+            <a:xfrm>
+              <a:off x="6924007" y="3160831"/>
+              <a:ext cx="365760" cy="365760"/>
+            </a:xfrm>
+            <a:prstGeom prst="ellipse">
+              <a:avLst/>
+            </a:prstGeom>
+          </p:spPr>
+          <p:style>
+            <a:lnRef idx="2">
+              <a:schemeClr val="dk1"/>
+            </a:lnRef>
+            <a:fillRef idx="1">
+              <a:schemeClr val="lt1"/>
+            </a:fillRef>
+            <a:effectRef idx="0">
+              <a:schemeClr val="dk1"/>
+            </a:effectRef>
+            <a:fontRef idx="minor">
+              <a:schemeClr val="dk1"/>
+            </a:fontRef>
+          </p:style>
+          <p:txBody>
+            <a:bodyPr rtlCol="0" anchor="ctr"/>
+            <a:lstStyle/>
+            <a:p>
+              <a:pPr algn="ctr"/>
+              <a:endParaRPr lang="en-US"/>
+            </a:p>
+          </p:txBody>
+        </p:sp>
+        <p:sp>
+          <p:nvSpPr>
+            <p:cNvPr id="71" name="Oval 70">
+              <a:extLst>
+                <a:ext uri="{FF2B5EF4-FFF2-40B4-BE49-F238E27FC236}">
+                  <a16:creationId xmlns:a16="http://schemas.microsoft.com/office/drawing/2014/main" id="{4D1130D1-136D-1917-4080-6CCCED424C44}"/>
+                </a:ext>
+              </a:extLst>
+            </p:cNvPr>
+            <p:cNvSpPr/>
+            <p:nvPr/>
+          </p:nvSpPr>
+          <p:spPr>
+            <a:xfrm>
+              <a:off x="6969727" y="3583710"/>
+              <a:ext cx="274320" cy="274320"/>
+            </a:xfrm>
+            <a:prstGeom prst="ellipse">
+              <a:avLst/>
+            </a:prstGeom>
+          </p:spPr>
+          <p:style>
+            <a:lnRef idx="2">
+              <a:schemeClr val="dk1"/>
+            </a:lnRef>
+            <a:fillRef idx="1">
+              <a:schemeClr val="lt1"/>
+            </a:fillRef>
+            <a:effectRef idx="0">
+              <a:schemeClr val="dk1"/>
             </a:effectRef>
             <a:fontRef idx="minor">
               <a:schemeClr val="dk1"/>
@@ -23771,6 +24324,1617 @@
             </a:fillRef>
             <a:effectRef idx="0">
               <a:scrgbClr r="0" g="0" b="0"/>
+            </a:effectRef>
+            <a:fontRef idx="minor">
+              <a:schemeClr val="dk1"/>
+            </a:fontRef>
+          </p:style>
+          <p:txBody>
+            <a:bodyPr rtlCol="0" anchor="ctr"/>
+            <a:lstStyle/>
+            <a:p>
+              <a:pPr algn="ctr"/>
+              <a:endParaRPr lang="en-US"/>
+            </a:p>
+          </p:txBody>
+        </p:sp>
+      </p:grpSp>
+      <p:grpSp>
+        <p:nvGrpSpPr>
+          <p:cNvPr id="174" name="Group 173">
+            <a:extLst>
+              <a:ext uri="{FF2B5EF4-FFF2-40B4-BE49-F238E27FC236}">
+                <a16:creationId xmlns:a16="http://schemas.microsoft.com/office/drawing/2014/main" id="{4EE1B358-D077-55B3-E3EF-3502D89D3061}"/>
+              </a:ext>
+            </a:extLst>
+          </p:cNvPr>
+          <p:cNvGrpSpPr/>
+          <p:nvPr/>
+        </p:nvGrpSpPr>
+        <p:grpSpPr>
+          <a:xfrm>
+            <a:off x="3976821" y="3222214"/>
+            <a:ext cx="1371600" cy="1371600"/>
+            <a:chOff x="427081" y="263129"/>
+            <a:chExt cx="1371600" cy="1371600"/>
+          </a:xfrm>
+        </p:grpSpPr>
+        <p:sp>
+          <p:nvSpPr>
+            <p:cNvPr id="175" name="Rectangle 174">
+              <a:extLst>
+                <a:ext uri="{FF2B5EF4-FFF2-40B4-BE49-F238E27FC236}">
+                  <a16:creationId xmlns:a16="http://schemas.microsoft.com/office/drawing/2014/main" id="{2362BCC9-676B-D0EA-55D6-0543234DFEA0}"/>
+                </a:ext>
+              </a:extLst>
+            </p:cNvPr>
+            <p:cNvSpPr/>
+            <p:nvPr/>
+          </p:nvSpPr>
+          <p:spPr>
+            <a:xfrm>
+              <a:off x="427081" y="263129"/>
+              <a:ext cx="1371600" cy="1371600"/>
+            </a:xfrm>
+            <a:prstGeom prst="rect">
+              <a:avLst/>
+            </a:prstGeom>
+            <a:noFill/>
+            <a:ln w="76200">
+              <a:solidFill>
+                <a:schemeClr val="tx1"/>
+              </a:solidFill>
+            </a:ln>
+          </p:spPr>
+          <p:style>
+            <a:lnRef idx="2">
+              <a:schemeClr val="accent1">
+                <a:shade val="50000"/>
+              </a:schemeClr>
+            </a:lnRef>
+            <a:fillRef idx="1">
+              <a:schemeClr val="accent1"/>
+            </a:fillRef>
+            <a:effectRef idx="0">
+              <a:schemeClr val="accent1"/>
+            </a:effectRef>
+            <a:fontRef idx="minor">
+              <a:schemeClr val="lt1"/>
+            </a:fontRef>
+          </p:style>
+          <p:txBody>
+            <a:bodyPr rtlCol="0" anchor="ctr"/>
+            <a:lstStyle/>
+            <a:p>
+              <a:pPr algn="ctr"/>
+              <a:endParaRPr lang="en-US"/>
+            </a:p>
+          </p:txBody>
+        </p:sp>
+        <p:sp>
+          <p:nvSpPr>
+            <p:cNvPr id="176" name="Plaque 175">
+              <a:extLst>
+                <a:ext uri="{FF2B5EF4-FFF2-40B4-BE49-F238E27FC236}">
+                  <a16:creationId xmlns:a16="http://schemas.microsoft.com/office/drawing/2014/main" id="{ACD354BE-71B9-452A-BFA9-F6E184C854CE}"/>
+                </a:ext>
+              </a:extLst>
+            </p:cNvPr>
+            <p:cNvSpPr/>
+            <p:nvPr/>
+          </p:nvSpPr>
+          <p:spPr>
+            <a:xfrm>
+              <a:off x="573033" y="478473"/>
+              <a:ext cx="1097280" cy="1097280"/>
+            </a:xfrm>
+            <a:prstGeom prst="plaque">
+              <a:avLst/>
+            </a:prstGeom>
+            <a:noFill/>
+            <a:ln w="38100" cap="flat" cmpd="sng" algn="ctr">
+              <a:solidFill>
+                <a:schemeClr val="dk1"/>
+              </a:solidFill>
+              <a:prstDash val="solid"/>
+              <a:round/>
+              <a:headEnd type="none" w="med" len="med"/>
+              <a:tailEnd type="none" w="med" len="med"/>
+            </a:ln>
+          </p:spPr>
+          <p:style>
+            <a:lnRef idx="0">
+              <a:scrgbClr r="0" g="0" b="0"/>
+            </a:lnRef>
+            <a:fillRef idx="0">
+              <a:scrgbClr r="0" g="0" b="0"/>
+            </a:fillRef>
+            <a:effectRef idx="0">
+              <a:scrgbClr r="0" g="0" b="0"/>
+            </a:effectRef>
+            <a:fontRef idx="minor">
+              <a:schemeClr val="dk1"/>
+            </a:fontRef>
+          </p:style>
+          <p:txBody>
+            <a:bodyPr rtlCol="0" anchor="ctr"/>
+            <a:lstStyle/>
+            <a:p>
+              <a:pPr algn="ctr"/>
+              <a:endParaRPr lang="en-US"/>
+            </a:p>
+          </p:txBody>
+        </p:sp>
+      </p:grpSp>
+      <p:grpSp>
+        <p:nvGrpSpPr>
+          <p:cNvPr id="177" name="Group 176">
+            <a:extLst>
+              <a:ext uri="{FF2B5EF4-FFF2-40B4-BE49-F238E27FC236}">
+                <a16:creationId xmlns:a16="http://schemas.microsoft.com/office/drawing/2014/main" id="{5EB96501-FE37-49B8-190F-C508957B18C6}"/>
+              </a:ext>
+            </a:extLst>
+          </p:cNvPr>
+          <p:cNvGrpSpPr/>
+          <p:nvPr/>
+        </p:nvGrpSpPr>
+        <p:grpSpPr>
+          <a:xfrm>
+            <a:off x="7316725" y="3222214"/>
+            <a:ext cx="1371600" cy="1371600"/>
+            <a:chOff x="427081" y="263129"/>
+            <a:chExt cx="1371600" cy="1371600"/>
+          </a:xfrm>
+        </p:grpSpPr>
+        <p:sp>
+          <p:nvSpPr>
+            <p:cNvPr id="178" name="Rectangle 177">
+              <a:extLst>
+                <a:ext uri="{FF2B5EF4-FFF2-40B4-BE49-F238E27FC236}">
+                  <a16:creationId xmlns:a16="http://schemas.microsoft.com/office/drawing/2014/main" id="{5A657355-62FB-6E62-211D-DFCF6D8A255C}"/>
+                </a:ext>
+              </a:extLst>
+            </p:cNvPr>
+            <p:cNvSpPr/>
+            <p:nvPr/>
+          </p:nvSpPr>
+          <p:spPr>
+            <a:xfrm>
+              <a:off x="427081" y="263129"/>
+              <a:ext cx="1371600" cy="1371600"/>
+            </a:xfrm>
+            <a:prstGeom prst="rect">
+              <a:avLst/>
+            </a:prstGeom>
+            <a:noFill/>
+            <a:ln w="76200">
+              <a:solidFill>
+                <a:schemeClr val="tx1"/>
+              </a:solidFill>
+            </a:ln>
+          </p:spPr>
+          <p:style>
+            <a:lnRef idx="2">
+              <a:schemeClr val="accent1">
+                <a:shade val="50000"/>
+              </a:schemeClr>
+            </a:lnRef>
+            <a:fillRef idx="1">
+              <a:schemeClr val="accent1"/>
+            </a:fillRef>
+            <a:effectRef idx="0">
+              <a:schemeClr val="accent1"/>
+            </a:effectRef>
+            <a:fontRef idx="minor">
+              <a:schemeClr val="lt1"/>
+            </a:fontRef>
+          </p:style>
+          <p:txBody>
+            <a:bodyPr rtlCol="0" anchor="ctr"/>
+            <a:lstStyle/>
+            <a:p>
+              <a:pPr algn="ctr"/>
+              <a:endParaRPr lang="en-US"/>
+            </a:p>
+          </p:txBody>
+        </p:sp>
+        <p:sp>
+          <p:nvSpPr>
+            <p:cNvPr id="179" name="Plaque 178">
+              <a:extLst>
+                <a:ext uri="{FF2B5EF4-FFF2-40B4-BE49-F238E27FC236}">
+                  <a16:creationId xmlns:a16="http://schemas.microsoft.com/office/drawing/2014/main" id="{E73ED871-7605-3F46-5F0C-E5EBAE589AFC}"/>
+                </a:ext>
+              </a:extLst>
+            </p:cNvPr>
+            <p:cNvSpPr/>
+            <p:nvPr/>
+          </p:nvSpPr>
+          <p:spPr>
+            <a:xfrm>
+              <a:off x="573033" y="478473"/>
+              <a:ext cx="1097280" cy="1097280"/>
+            </a:xfrm>
+            <a:prstGeom prst="plaque">
+              <a:avLst/>
+            </a:prstGeom>
+            <a:noFill/>
+            <a:ln w="38100" cap="flat" cmpd="sng" algn="ctr">
+              <a:solidFill>
+                <a:schemeClr val="dk1"/>
+              </a:solidFill>
+              <a:prstDash val="solid"/>
+              <a:round/>
+              <a:headEnd type="none" w="med" len="med"/>
+              <a:tailEnd type="none" w="med" len="med"/>
+            </a:ln>
+          </p:spPr>
+          <p:style>
+            <a:lnRef idx="0">
+              <a:scrgbClr r="0" g="0" b="0"/>
+            </a:lnRef>
+            <a:fillRef idx="0">
+              <a:scrgbClr r="0" g="0" b="0"/>
+            </a:fillRef>
+            <a:effectRef idx="0">
+              <a:scrgbClr r="0" g="0" b="0"/>
+            </a:effectRef>
+            <a:fontRef idx="minor">
+              <a:schemeClr val="dk1"/>
+            </a:fontRef>
+          </p:style>
+          <p:txBody>
+            <a:bodyPr rtlCol="0" anchor="ctr"/>
+            <a:lstStyle/>
+            <a:p>
+              <a:pPr algn="ctr"/>
+              <a:endParaRPr lang="en-US"/>
+            </a:p>
+          </p:txBody>
+        </p:sp>
+      </p:grpSp>
+      <p:grpSp>
+        <p:nvGrpSpPr>
+          <p:cNvPr id="180" name="Group 179">
+            <a:extLst>
+              <a:ext uri="{FF2B5EF4-FFF2-40B4-BE49-F238E27FC236}">
+                <a16:creationId xmlns:a16="http://schemas.microsoft.com/office/drawing/2014/main" id="{44D65888-F453-86E6-D72E-3CF182B9E272}"/>
+              </a:ext>
+            </a:extLst>
+          </p:cNvPr>
+          <p:cNvGrpSpPr/>
+          <p:nvPr/>
+        </p:nvGrpSpPr>
+        <p:grpSpPr>
+          <a:xfrm>
+            <a:off x="5651237" y="3222399"/>
+            <a:ext cx="1371600" cy="1371600"/>
+            <a:chOff x="427081" y="263129"/>
+            <a:chExt cx="1371600" cy="1371600"/>
+          </a:xfrm>
+        </p:grpSpPr>
+        <p:sp>
+          <p:nvSpPr>
+            <p:cNvPr id="181" name="Rectangle 180">
+              <a:extLst>
+                <a:ext uri="{FF2B5EF4-FFF2-40B4-BE49-F238E27FC236}">
+                  <a16:creationId xmlns:a16="http://schemas.microsoft.com/office/drawing/2014/main" id="{15476A39-10C3-127D-952E-73AD493215BC}"/>
+                </a:ext>
+              </a:extLst>
+            </p:cNvPr>
+            <p:cNvSpPr/>
+            <p:nvPr/>
+          </p:nvSpPr>
+          <p:spPr>
+            <a:xfrm>
+              <a:off x="427081" y="263129"/>
+              <a:ext cx="1371600" cy="1371600"/>
+            </a:xfrm>
+            <a:prstGeom prst="rect">
+              <a:avLst/>
+            </a:prstGeom>
+            <a:noFill/>
+            <a:ln w="76200">
+              <a:solidFill>
+                <a:schemeClr val="tx1"/>
+              </a:solidFill>
+            </a:ln>
+          </p:spPr>
+          <p:style>
+            <a:lnRef idx="2">
+              <a:schemeClr val="accent1">
+                <a:shade val="50000"/>
+              </a:schemeClr>
+            </a:lnRef>
+            <a:fillRef idx="1">
+              <a:schemeClr val="accent1"/>
+            </a:fillRef>
+            <a:effectRef idx="0">
+              <a:schemeClr val="accent1"/>
+            </a:effectRef>
+            <a:fontRef idx="minor">
+              <a:schemeClr val="lt1"/>
+            </a:fontRef>
+          </p:style>
+          <p:txBody>
+            <a:bodyPr rtlCol="0" anchor="ctr"/>
+            <a:lstStyle/>
+            <a:p>
+              <a:pPr algn="ctr"/>
+              <a:endParaRPr lang="en-US"/>
+            </a:p>
+          </p:txBody>
+        </p:sp>
+        <p:sp>
+          <p:nvSpPr>
+            <p:cNvPr id="182" name="Plaque 181">
+              <a:extLst>
+                <a:ext uri="{FF2B5EF4-FFF2-40B4-BE49-F238E27FC236}">
+                  <a16:creationId xmlns:a16="http://schemas.microsoft.com/office/drawing/2014/main" id="{96446AB4-BE97-8FEE-6964-BA45D84A09CC}"/>
+                </a:ext>
+              </a:extLst>
+            </p:cNvPr>
+            <p:cNvSpPr/>
+            <p:nvPr/>
+          </p:nvSpPr>
+          <p:spPr>
+            <a:xfrm>
+              <a:off x="573033" y="478473"/>
+              <a:ext cx="1097280" cy="1097280"/>
+            </a:xfrm>
+            <a:prstGeom prst="plaque">
+              <a:avLst/>
+            </a:prstGeom>
+            <a:noFill/>
+            <a:ln w="38100" cap="flat" cmpd="sng" algn="ctr">
+              <a:solidFill>
+                <a:schemeClr val="dk1"/>
+              </a:solidFill>
+              <a:prstDash val="solid"/>
+              <a:round/>
+              <a:headEnd type="none" w="med" len="med"/>
+              <a:tailEnd type="none" w="med" len="med"/>
+            </a:ln>
+          </p:spPr>
+          <p:style>
+            <a:lnRef idx="0">
+              <a:scrgbClr r="0" g="0" b="0"/>
+            </a:lnRef>
+            <a:fillRef idx="0">
+              <a:scrgbClr r="0" g="0" b="0"/>
+            </a:fillRef>
+            <a:effectRef idx="0">
+              <a:scrgbClr r="0" g="0" b="0"/>
+            </a:effectRef>
+            <a:fontRef idx="minor">
+              <a:schemeClr val="dk1"/>
+            </a:fontRef>
+          </p:style>
+          <p:txBody>
+            <a:bodyPr rtlCol="0" anchor="ctr"/>
+            <a:lstStyle/>
+            <a:p>
+              <a:pPr algn="ctr"/>
+              <a:endParaRPr lang="en-US"/>
+            </a:p>
+          </p:txBody>
+        </p:sp>
+      </p:grpSp>
+      <p:grpSp>
+        <p:nvGrpSpPr>
+          <p:cNvPr id="183" name="Group 182">
+            <a:extLst>
+              <a:ext uri="{FF2B5EF4-FFF2-40B4-BE49-F238E27FC236}">
+                <a16:creationId xmlns:a16="http://schemas.microsoft.com/office/drawing/2014/main" id="{BD7074B7-5CE6-3B9B-8197-F3D1B145AE2B}"/>
+              </a:ext>
+            </a:extLst>
+          </p:cNvPr>
+          <p:cNvGrpSpPr/>
+          <p:nvPr/>
+        </p:nvGrpSpPr>
+        <p:grpSpPr>
+          <a:xfrm>
+            <a:off x="4347149" y="3740951"/>
+            <a:ext cx="631137" cy="505972"/>
+            <a:chOff x="5010218" y="2694841"/>
+            <a:chExt cx="2523392" cy="2022962"/>
+          </a:xfrm>
+        </p:grpSpPr>
+        <p:sp>
+          <p:nvSpPr>
+            <p:cNvPr id="184" name="Moon 183">
+              <a:extLst>
+                <a:ext uri="{FF2B5EF4-FFF2-40B4-BE49-F238E27FC236}">
+                  <a16:creationId xmlns:a16="http://schemas.microsoft.com/office/drawing/2014/main" id="{3D7EBBA5-9CF3-1F53-BE6A-A1F6D6E86D40}"/>
+                </a:ext>
+              </a:extLst>
+            </p:cNvPr>
+            <p:cNvSpPr/>
+            <p:nvPr/>
+          </p:nvSpPr>
+          <p:spPr>
+            <a:xfrm rot="16200000">
+              <a:off x="5683528" y="2021531"/>
+              <a:ext cx="1176771" cy="2523392"/>
+            </a:xfrm>
+            <a:prstGeom prst="moon">
+              <a:avLst>
+                <a:gd name="adj" fmla="val 55230"/>
+              </a:avLst>
+            </a:prstGeom>
+          </p:spPr>
+          <p:style>
+            <a:lnRef idx="2">
+              <a:schemeClr val="dk1">
+                <a:shade val="50000"/>
+              </a:schemeClr>
+            </a:lnRef>
+            <a:fillRef idx="1">
+              <a:schemeClr val="dk1"/>
+            </a:fillRef>
+            <a:effectRef idx="0">
+              <a:schemeClr val="dk1"/>
+            </a:effectRef>
+            <a:fontRef idx="minor">
+              <a:schemeClr val="lt1"/>
+            </a:fontRef>
+          </p:style>
+          <p:txBody>
+            <a:bodyPr rtlCol="0" anchor="ctr"/>
+            <a:lstStyle/>
+            <a:p>
+              <a:pPr algn="ctr"/>
+              <a:endParaRPr lang="en-US"/>
+            </a:p>
+          </p:txBody>
+        </p:sp>
+        <p:sp>
+          <p:nvSpPr>
+            <p:cNvPr id="185" name="Isosceles Triangle 184">
+              <a:extLst>
+                <a:ext uri="{FF2B5EF4-FFF2-40B4-BE49-F238E27FC236}">
+                  <a16:creationId xmlns:a16="http://schemas.microsoft.com/office/drawing/2014/main" id="{E887F0EA-0FFC-8F5C-AEEF-A8D613587A59}"/>
+                </a:ext>
+              </a:extLst>
+            </p:cNvPr>
+            <p:cNvSpPr/>
+            <p:nvPr/>
+          </p:nvSpPr>
+          <p:spPr>
+            <a:xfrm>
+              <a:off x="6132701" y="2694841"/>
+              <a:ext cx="278423" cy="1723292"/>
+            </a:xfrm>
+            <a:prstGeom prst="triangle">
+              <a:avLst/>
+            </a:prstGeom>
+          </p:spPr>
+          <p:style>
+            <a:lnRef idx="2">
+              <a:schemeClr val="dk1">
+                <a:shade val="50000"/>
+              </a:schemeClr>
+            </a:lnRef>
+            <a:fillRef idx="1">
+              <a:schemeClr val="dk1"/>
+            </a:fillRef>
+            <a:effectRef idx="0">
+              <a:schemeClr val="dk1"/>
+            </a:effectRef>
+            <a:fontRef idx="minor">
+              <a:schemeClr val="lt1"/>
+            </a:fontRef>
+          </p:style>
+          <p:txBody>
+            <a:bodyPr rtlCol="0" anchor="ctr"/>
+            <a:lstStyle/>
+            <a:p>
+              <a:pPr algn="ctr"/>
+              <a:endParaRPr lang="en-US"/>
+            </a:p>
+          </p:txBody>
+        </p:sp>
+        <p:sp>
+          <p:nvSpPr>
+            <p:cNvPr id="186" name="Moon 185">
+              <a:extLst>
+                <a:ext uri="{FF2B5EF4-FFF2-40B4-BE49-F238E27FC236}">
+                  <a16:creationId xmlns:a16="http://schemas.microsoft.com/office/drawing/2014/main" id="{5930625C-DAA3-8CD7-47AC-1E199E590909}"/>
+                </a:ext>
+              </a:extLst>
+            </p:cNvPr>
+            <p:cNvSpPr/>
+            <p:nvPr/>
+          </p:nvSpPr>
+          <p:spPr>
+            <a:xfrm rot="5400000">
+              <a:off x="5972241" y="3787285"/>
+              <a:ext cx="599341" cy="1261696"/>
+            </a:xfrm>
+            <a:prstGeom prst="moon">
+              <a:avLst>
+                <a:gd name="adj" fmla="val 37626"/>
+              </a:avLst>
+            </a:prstGeom>
+          </p:spPr>
+          <p:style>
+            <a:lnRef idx="2">
+              <a:schemeClr val="dk1">
+                <a:shade val="50000"/>
+              </a:schemeClr>
+            </a:lnRef>
+            <a:fillRef idx="1">
+              <a:schemeClr val="dk1"/>
+            </a:fillRef>
+            <a:effectRef idx="0">
+              <a:schemeClr val="dk1"/>
+            </a:effectRef>
+            <a:fontRef idx="minor">
+              <a:schemeClr val="lt1"/>
+            </a:fontRef>
+          </p:style>
+          <p:txBody>
+            <a:bodyPr rtlCol="0" anchor="ctr"/>
+            <a:lstStyle/>
+            <a:p>
+              <a:pPr algn="ctr"/>
+              <a:endParaRPr lang="en-US"/>
+            </a:p>
+          </p:txBody>
+        </p:sp>
+        <p:grpSp>
+          <p:nvGrpSpPr>
+            <p:cNvPr id="187" name="Group 186">
+              <a:extLst>
+                <a:ext uri="{FF2B5EF4-FFF2-40B4-BE49-F238E27FC236}">
+                  <a16:creationId xmlns:a16="http://schemas.microsoft.com/office/drawing/2014/main" id="{25396257-336E-7E85-B11C-1AE15822B1B2}"/>
+                </a:ext>
+              </a:extLst>
+            </p:cNvPr>
+            <p:cNvGrpSpPr/>
+            <p:nvPr/>
+          </p:nvGrpSpPr>
+          <p:grpSpPr>
+            <a:xfrm>
+              <a:off x="5240214" y="3072211"/>
+              <a:ext cx="862512" cy="587761"/>
+              <a:chOff x="5240214" y="3072211"/>
+              <a:chExt cx="862512" cy="587761"/>
+            </a:xfrm>
+          </p:grpSpPr>
+          <p:sp>
+            <p:nvSpPr>
+              <p:cNvPr id="192" name="Oval 191">
+                <a:extLst>
+                  <a:ext uri="{FF2B5EF4-FFF2-40B4-BE49-F238E27FC236}">
+                    <a16:creationId xmlns:a16="http://schemas.microsoft.com/office/drawing/2014/main" id="{0D78027D-2290-4C6B-F720-2C9B672D35E2}"/>
+                  </a:ext>
+                </a:extLst>
+              </p:cNvPr>
+              <p:cNvSpPr/>
+              <p:nvPr/>
+            </p:nvSpPr>
+            <p:spPr>
+              <a:xfrm>
+                <a:off x="5475402" y="3233279"/>
+                <a:ext cx="274320" cy="274320"/>
+              </a:xfrm>
+              <a:prstGeom prst="ellipse">
+                <a:avLst/>
+              </a:prstGeom>
+            </p:spPr>
+            <p:style>
+              <a:lnRef idx="2">
+                <a:schemeClr val="dk1"/>
+              </a:lnRef>
+              <a:fillRef idx="1">
+                <a:schemeClr val="lt1"/>
+              </a:fillRef>
+              <a:effectRef idx="0">
+                <a:schemeClr val="dk1"/>
+              </a:effectRef>
+              <a:fontRef idx="minor">
+                <a:schemeClr val="dk1"/>
+              </a:fontRef>
+            </p:style>
+            <p:txBody>
+              <a:bodyPr rtlCol="0" anchor="ctr"/>
+              <a:lstStyle/>
+              <a:p>
+                <a:pPr algn="ctr"/>
+                <a:endParaRPr lang="en-US"/>
+              </a:p>
+            </p:txBody>
+          </p:sp>
+          <p:sp>
+            <p:nvSpPr>
+              <p:cNvPr id="193" name="Oval 192">
+                <a:extLst>
+                  <a:ext uri="{FF2B5EF4-FFF2-40B4-BE49-F238E27FC236}">
+                    <a16:creationId xmlns:a16="http://schemas.microsoft.com/office/drawing/2014/main" id="{88DC8E7C-3845-A2B4-4868-F38A0F271863}"/>
+                  </a:ext>
+                </a:extLst>
+              </p:cNvPr>
+              <p:cNvSpPr/>
+              <p:nvPr/>
+            </p:nvSpPr>
+            <p:spPr>
+              <a:xfrm>
+                <a:off x="5240214" y="3072211"/>
+                <a:ext cx="228600" cy="228600"/>
+              </a:xfrm>
+              <a:prstGeom prst="ellipse">
+                <a:avLst/>
+              </a:prstGeom>
+            </p:spPr>
+            <p:style>
+              <a:lnRef idx="2">
+                <a:schemeClr val="dk1"/>
+              </a:lnRef>
+              <a:fillRef idx="1">
+                <a:schemeClr val="lt1"/>
+              </a:fillRef>
+              <a:effectRef idx="0">
+                <a:schemeClr val="dk1"/>
+              </a:effectRef>
+              <a:fontRef idx="minor">
+                <a:schemeClr val="dk1"/>
+              </a:fontRef>
+            </p:style>
+            <p:txBody>
+              <a:bodyPr rtlCol="0" anchor="ctr"/>
+              <a:lstStyle/>
+              <a:p>
+                <a:pPr algn="ctr"/>
+                <a:endParaRPr lang="en-US"/>
+              </a:p>
+            </p:txBody>
+          </p:sp>
+          <p:sp>
+            <p:nvSpPr>
+              <p:cNvPr id="194" name="Oval 193">
+                <a:extLst>
+                  <a:ext uri="{FF2B5EF4-FFF2-40B4-BE49-F238E27FC236}">
+                    <a16:creationId xmlns:a16="http://schemas.microsoft.com/office/drawing/2014/main" id="{5253FC48-0E0E-6FDD-036D-01053E164AEA}"/>
+                  </a:ext>
+                </a:extLst>
+              </p:cNvPr>
+              <p:cNvSpPr/>
+              <p:nvPr/>
+            </p:nvSpPr>
+            <p:spPr>
+              <a:xfrm>
+                <a:off x="5782686" y="3339932"/>
+                <a:ext cx="320040" cy="320040"/>
+              </a:xfrm>
+              <a:prstGeom prst="ellipse">
+                <a:avLst/>
+              </a:prstGeom>
+            </p:spPr>
+            <p:style>
+              <a:lnRef idx="2">
+                <a:schemeClr val="dk1"/>
+              </a:lnRef>
+              <a:fillRef idx="1">
+                <a:schemeClr val="lt1"/>
+              </a:fillRef>
+              <a:effectRef idx="0">
+                <a:schemeClr val="dk1"/>
+              </a:effectRef>
+              <a:fontRef idx="minor">
+                <a:schemeClr val="dk1"/>
+              </a:fontRef>
+            </p:style>
+            <p:txBody>
+              <a:bodyPr rtlCol="0" anchor="ctr"/>
+              <a:lstStyle/>
+              <a:p>
+                <a:pPr algn="ctr"/>
+                <a:endParaRPr lang="en-US"/>
+              </a:p>
+            </p:txBody>
+          </p:sp>
+        </p:grpSp>
+        <p:grpSp>
+          <p:nvGrpSpPr>
+            <p:cNvPr id="188" name="Group 187">
+              <a:extLst>
+                <a:ext uri="{FF2B5EF4-FFF2-40B4-BE49-F238E27FC236}">
+                  <a16:creationId xmlns:a16="http://schemas.microsoft.com/office/drawing/2014/main" id="{B3CB005E-B57E-B712-DCAF-C02AB5711356}"/>
+                </a:ext>
+              </a:extLst>
+            </p:cNvPr>
+            <p:cNvGrpSpPr/>
+            <p:nvPr/>
+          </p:nvGrpSpPr>
+          <p:grpSpPr>
+            <a:xfrm flipH="1">
+              <a:off x="6400433" y="3085350"/>
+              <a:ext cx="862512" cy="587761"/>
+              <a:chOff x="5240214" y="3072211"/>
+              <a:chExt cx="862512" cy="587761"/>
+            </a:xfrm>
+          </p:grpSpPr>
+          <p:sp>
+            <p:nvSpPr>
+              <p:cNvPr id="189" name="Oval 188">
+                <a:extLst>
+                  <a:ext uri="{FF2B5EF4-FFF2-40B4-BE49-F238E27FC236}">
+                    <a16:creationId xmlns:a16="http://schemas.microsoft.com/office/drawing/2014/main" id="{43BCE9CA-BB0A-081B-CDF5-89A580CEB1FF}"/>
+                  </a:ext>
+                </a:extLst>
+              </p:cNvPr>
+              <p:cNvSpPr/>
+              <p:nvPr/>
+            </p:nvSpPr>
+            <p:spPr>
+              <a:xfrm>
+                <a:off x="5475402" y="3233279"/>
+                <a:ext cx="274320" cy="274320"/>
+              </a:xfrm>
+              <a:prstGeom prst="ellipse">
+                <a:avLst/>
+              </a:prstGeom>
+            </p:spPr>
+            <p:style>
+              <a:lnRef idx="2">
+                <a:schemeClr val="dk1"/>
+              </a:lnRef>
+              <a:fillRef idx="1">
+                <a:schemeClr val="lt1"/>
+              </a:fillRef>
+              <a:effectRef idx="0">
+                <a:schemeClr val="dk1"/>
+              </a:effectRef>
+              <a:fontRef idx="minor">
+                <a:schemeClr val="dk1"/>
+              </a:fontRef>
+            </p:style>
+            <p:txBody>
+              <a:bodyPr rtlCol="0" anchor="ctr"/>
+              <a:lstStyle/>
+              <a:p>
+                <a:pPr algn="ctr"/>
+                <a:endParaRPr lang="en-US"/>
+              </a:p>
+            </p:txBody>
+          </p:sp>
+          <p:sp>
+            <p:nvSpPr>
+              <p:cNvPr id="190" name="Oval 189">
+                <a:extLst>
+                  <a:ext uri="{FF2B5EF4-FFF2-40B4-BE49-F238E27FC236}">
+                    <a16:creationId xmlns:a16="http://schemas.microsoft.com/office/drawing/2014/main" id="{16CA2659-0B0C-FF9B-6901-1573BEE82289}"/>
+                  </a:ext>
+                </a:extLst>
+              </p:cNvPr>
+              <p:cNvSpPr/>
+              <p:nvPr/>
+            </p:nvSpPr>
+            <p:spPr>
+              <a:xfrm>
+                <a:off x="5240214" y="3072211"/>
+                <a:ext cx="228600" cy="228600"/>
+              </a:xfrm>
+              <a:prstGeom prst="ellipse">
+                <a:avLst/>
+              </a:prstGeom>
+            </p:spPr>
+            <p:style>
+              <a:lnRef idx="2">
+                <a:schemeClr val="dk1"/>
+              </a:lnRef>
+              <a:fillRef idx="1">
+                <a:schemeClr val="lt1"/>
+              </a:fillRef>
+              <a:effectRef idx="0">
+                <a:schemeClr val="dk1"/>
+              </a:effectRef>
+              <a:fontRef idx="minor">
+                <a:schemeClr val="dk1"/>
+              </a:fontRef>
+            </p:style>
+            <p:txBody>
+              <a:bodyPr rtlCol="0" anchor="ctr"/>
+              <a:lstStyle/>
+              <a:p>
+                <a:pPr algn="ctr"/>
+                <a:endParaRPr lang="en-US"/>
+              </a:p>
+            </p:txBody>
+          </p:sp>
+          <p:sp>
+            <p:nvSpPr>
+              <p:cNvPr id="191" name="Oval 190">
+                <a:extLst>
+                  <a:ext uri="{FF2B5EF4-FFF2-40B4-BE49-F238E27FC236}">
+                    <a16:creationId xmlns:a16="http://schemas.microsoft.com/office/drawing/2014/main" id="{F543D99B-8F36-DB1C-105C-440D1CE77738}"/>
+                  </a:ext>
+                </a:extLst>
+              </p:cNvPr>
+              <p:cNvSpPr/>
+              <p:nvPr/>
+            </p:nvSpPr>
+            <p:spPr>
+              <a:xfrm>
+                <a:off x="5782686" y="3339932"/>
+                <a:ext cx="320040" cy="320040"/>
+              </a:xfrm>
+              <a:prstGeom prst="ellipse">
+                <a:avLst/>
+              </a:prstGeom>
+            </p:spPr>
+            <p:style>
+              <a:lnRef idx="2">
+                <a:schemeClr val="dk1"/>
+              </a:lnRef>
+              <a:fillRef idx="1">
+                <a:schemeClr val="lt1"/>
+              </a:fillRef>
+              <a:effectRef idx="0">
+                <a:schemeClr val="dk1"/>
+              </a:effectRef>
+              <a:fontRef idx="minor">
+                <a:schemeClr val="dk1"/>
+              </a:fontRef>
+            </p:style>
+            <p:txBody>
+              <a:bodyPr rtlCol="0" anchor="ctr"/>
+              <a:lstStyle/>
+              <a:p>
+                <a:pPr algn="ctr"/>
+                <a:endParaRPr lang="en-US"/>
+              </a:p>
+            </p:txBody>
+          </p:sp>
+        </p:grpSp>
+      </p:grpSp>
+      <p:grpSp>
+        <p:nvGrpSpPr>
+          <p:cNvPr id="195" name="Group 194">
+            <a:extLst>
+              <a:ext uri="{FF2B5EF4-FFF2-40B4-BE49-F238E27FC236}">
+                <a16:creationId xmlns:a16="http://schemas.microsoft.com/office/drawing/2014/main" id="{DB1EAEC0-BE94-7F50-9DEF-9BFBD170356A}"/>
+              </a:ext>
+            </a:extLst>
+          </p:cNvPr>
+          <p:cNvGrpSpPr/>
+          <p:nvPr/>
+        </p:nvGrpSpPr>
+        <p:grpSpPr>
+          <a:xfrm>
+            <a:off x="6057100" y="3513402"/>
+            <a:ext cx="577458" cy="886118"/>
+            <a:chOff x="5275383" y="2444259"/>
+            <a:chExt cx="2101363" cy="3224576"/>
+          </a:xfrm>
+        </p:grpSpPr>
+        <p:sp>
+          <p:nvSpPr>
+            <p:cNvPr id="196" name="Isosceles Triangle 195">
+              <a:extLst>
+                <a:ext uri="{FF2B5EF4-FFF2-40B4-BE49-F238E27FC236}">
+                  <a16:creationId xmlns:a16="http://schemas.microsoft.com/office/drawing/2014/main" id="{C9FAB2E9-76C6-BDD0-5AB3-3FA35378D211}"/>
+                </a:ext>
+              </a:extLst>
+            </p:cNvPr>
+            <p:cNvSpPr/>
+            <p:nvPr/>
+          </p:nvSpPr>
+          <p:spPr>
+            <a:xfrm rot="10800000">
+              <a:off x="5653455" y="3974123"/>
+              <a:ext cx="1345223" cy="474785"/>
+            </a:xfrm>
+            <a:prstGeom prst="triangle">
+              <a:avLst/>
+            </a:prstGeom>
+            <a:ln w="28575"/>
+          </p:spPr>
+          <p:style>
+            <a:lnRef idx="2">
+              <a:schemeClr val="dk1"/>
+            </a:lnRef>
+            <a:fillRef idx="1">
+              <a:schemeClr val="lt1"/>
+            </a:fillRef>
+            <a:effectRef idx="0">
+              <a:schemeClr val="dk1"/>
+            </a:effectRef>
+            <a:fontRef idx="minor">
+              <a:schemeClr val="dk1"/>
+            </a:fontRef>
+          </p:style>
+          <p:txBody>
+            <a:bodyPr rtlCol="0" anchor="ctr"/>
+            <a:lstStyle/>
+            <a:p>
+              <a:pPr algn="ctr"/>
+              <a:endParaRPr lang="en-US"/>
+            </a:p>
+          </p:txBody>
+        </p:sp>
+        <p:sp>
+          <p:nvSpPr>
+            <p:cNvPr id="197" name="Isosceles Triangle 196">
+              <a:extLst>
+                <a:ext uri="{FF2B5EF4-FFF2-40B4-BE49-F238E27FC236}">
+                  <a16:creationId xmlns:a16="http://schemas.microsoft.com/office/drawing/2014/main" id="{7E9CB0F5-9D08-D49C-E28F-02FABF76B268}"/>
+                </a:ext>
+              </a:extLst>
+            </p:cNvPr>
+            <p:cNvSpPr/>
+            <p:nvPr/>
+          </p:nvSpPr>
+          <p:spPr>
+            <a:xfrm>
+              <a:off x="5675434" y="2699238"/>
+              <a:ext cx="219808" cy="1274885"/>
+            </a:xfrm>
+            <a:prstGeom prst="triangle">
+              <a:avLst/>
+            </a:prstGeom>
+          </p:spPr>
+          <p:style>
+            <a:lnRef idx="2">
+              <a:schemeClr val="dk1">
+                <a:shade val="50000"/>
+              </a:schemeClr>
+            </a:lnRef>
+            <a:fillRef idx="1">
+              <a:schemeClr val="dk1"/>
+            </a:fillRef>
+            <a:effectRef idx="0">
+              <a:schemeClr val="dk1"/>
+            </a:effectRef>
+            <a:fontRef idx="minor">
+              <a:schemeClr val="lt1"/>
+            </a:fontRef>
+          </p:style>
+          <p:txBody>
+            <a:bodyPr rtlCol="0" anchor="ctr"/>
+            <a:lstStyle/>
+            <a:p>
+              <a:pPr algn="ctr"/>
+              <a:endParaRPr lang="en-US"/>
+            </a:p>
+          </p:txBody>
+        </p:sp>
+        <p:sp>
+          <p:nvSpPr>
+            <p:cNvPr id="198" name="Isosceles Triangle 197">
+              <a:extLst>
+                <a:ext uri="{FF2B5EF4-FFF2-40B4-BE49-F238E27FC236}">
+                  <a16:creationId xmlns:a16="http://schemas.microsoft.com/office/drawing/2014/main" id="{B6DC7B9D-D2B6-B3DE-A933-C87112D71B06}"/>
+                </a:ext>
+              </a:extLst>
+            </p:cNvPr>
+            <p:cNvSpPr/>
+            <p:nvPr/>
+          </p:nvSpPr>
+          <p:spPr>
+            <a:xfrm>
+              <a:off x="6778870" y="2699237"/>
+              <a:ext cx="219808" cy="1274885"/>
+            </a:xfrm>
+            <a:prstGeom prst="triangle">
+              <a:avLst/>
+            </a:prstGeom>
+          </p:spPr>
+          <p:style>
+            <a:lnRef idx="2">
+              <a:schemeClr val="dk1">
+                <a:shade val="50000"/>
+              </a:schemeClr>
+            </a:lnRef>
+            <a:fillRef idx="1">
+              <a:schemeClr val="dk1"/>
+            </a:fillRef>
+            <a:effectRef idx="0">
+              <a:schemeClr val="dk1"/>
+            </a:effectRef>
+            <a:fontRef idx="minor">
+              <a:schemeClr val="lt1"/>
+            </a:fontRef>
+          </p:style>
+          <p:txBody>
+            <a:bodyPr rtlCol="0" anchor="ctr"/>
+            <a:lstStyle/>
+            <a:p>
+              <a:pPr algn="ctr"/>
+              <a:endParaRPr lang="en-US"/>
+            </a:p>
+          </p:txBody>
+        </p:sp>
+        <p:sp>
+          <p:nvSpPr>
+            <p:cNvPr id="199" name="Isosceles Triangle 198">
+              <a:extLst>
+                <a:ext uri="{FF2B5EF4-FFF2-40B4-BE49-F238E27FC236}">
+                  <a16:creationId xmlns:a16="http://schemas.microsoft.com/office/drawing/2014/main" id="{86F2C79D-630B-FF3B-27B0-ADAFABEEFAA1}"/>
+                </a:ext>
+              </a:extLst>
+            </p:cNvPr>
+            <p:cNvSpPr/>
+            <p:nvPr/>
+          </p:nvSpPr>
+          <p:spPr>
+            <a:xfrm>
+              <a:off x="6216162" y="2444259"/>
+              <a:ext cx="219808" cy="1529863"/>
+            </a:xfrm>
+            <a:prstGeom prst="triangle">
+              <a:avLst/>
+            </a:prstGeom>
+          </p:spPr>
+          <p:style>
+            <a:lnRef idx="2">
+              <a:schemeClr val="dk1"/>
+            </a:lnRef>
+            <a:fillRef idx="1">
+              <a:schemeClr val="lt1"/>
+            </a:fillRef>
+            <a:effectRef idx="0">
+              <a:schemeClr val="dk1"/>
+            </a:effectRef>
+            <a:fontRef idx="minor">
+              <a:schemeClr val="dk1"/>
+            </a:fontRef>
+          </p:style>
+          <p:txBody>
+            <a:bodyPr rtlCol="0" anchor="ctr"/>
+            <a:lstStyle/>
+            <a:p>
+              <a:pPr algn="ctr"/>
+              <a:endParaRPr lang="en-US"/>
+            </a:p>
+          </p:txBody>
+        </p:sp>
+        <p:sp>
+          <p:nvSpPr>
+            <p:cNvPr id="200" name="Moon 199">
+              <a:extLst>
+                <a:ext uri="{FF2B5EF4-FFF2-40B4-BE49-F238E27FC236}">
+                  <a16:creationId xmlns:a16="http://schemas.microsoft.com/office/drawing/2014/main" id="{25622979-1FEC-8A3C-C168-D657104ADDC6}"/>
+                </a:ext>
+              </a:extLst>
+            </p:cNvPr>
+            <p:cNvSpPr/>
+            <p:nvPr/>
+          </p:nvSpPr>
+          <p:spPr>
+            <a:xfrm rot="5400000">
+              <a:off x="6060099" y="4769824"/>
+              <a:ext cx="531929" cy="1266094"/>
+            </a:xfrm>
+            <a:prstGeom prst="moon">
+              <a:avLst>
+                <a:gd name="adj" fmla="val 38235"/>
+              </a:avLst>
+            </a:prstGeom>
+          </p:spPr>
+          <p:style>
+            <a:lnRef idx="2">
+              <a:schemeClr val="dk1"/>
+            </a:lnRef>
+            <a:fillRef idx="1">
+              <a:schemeClr val="lt1"/>
+            </a:fillRef>
+            <a:effectRef idx="0">
+              <a:schemeClr val="dk1"/>
+            </a:effectRef>
+            <a:fontRef idx="minor">
+              <a:schemeClr val="dk1"/>
+            </a:fontRef>
+          </p:style>
+          <p:txBody>
+            <a:bodyPr rtlCol="0" anchor="ctr"/>
+            <a:lstStyle/>
+            <a:p>
+              <a:pPr algn="ctr"/>
+              <a:endParaRPr lang="en-US"/>
+            </a:p>
+          </p:txBody>
+        </p:sp>
+        <p:sp>
+          <p:nvSpPr>
+            <p:cNvPr id="201" name="Isosceles Triangle 200">
+              <a:extLst>
+                <a:ext uri="{FF2B5EF4-FFF2-40B4-BE49-F238E27FC236}">
+                  <a16:creationId xmlns:a16="http://schemas.microsoft.com/office/drawing/2014/main" id="{D5F703A3-E8F4-A41F-99BF-477F8C03022D}"/>
+                </a:ext>
+              </a:extLst>
+            </p:cNvPr>
+            <p:cNvSpPr/>
+            <p:nvPr/>
+          </p:nvSpPr>
+          <p:spPr>
+            <a:xfrm rot="10800000">
+              <a:off x="6000749" y="4211516"/>
+              <a:ext cx="650633" cy="1424349"/>
+            </a:xfrm>
+            <a:prstGeom prst="triangle">
+              <a:avLst/>
+            </a:prstGeom>
+          </p:spPr>
+          <p:style>
+            <a:lnRef idx="2">
+              <a:schemeClr val="dk1">
+                <a:shade val="50000"/>
+              </a:schemeClr>
+            </a:lnRef>
+            <a:fillRef idx="1">
+              <a:schemeClr val="dk1"/>
+            </a:fillRef>
+            <a:effectRef idx="0">
+              <a:schemeClr val="dk1"/>
+            </a:effectRef>
+            <a:fontRef idx="minor">
+              <a:schemeClr val="lt1"/>
+            </a:fontRef>
+          </p:style>
+          <p:txBody>
+            <a:bodyPr rtlCol="0" anchor="ctr"/>
+            <a:lstStyle/>
+            <a:p>
+              <a:pPr algn="ctr"/>
+              <a:endParaRPr lang="en-US"/>
+            </a:p>
+          </p:txBody>
+        </p:sp>
+        <p:sp>
+          <p:nvSpPr>
+            <p:cNvPr id="202" name="Moon 201">
+              <a:extLst>
+                <a:ext uri="{FF2B5EF4-FFF2-40B4-BE49-F238E27FC236}">
+                  <a16:creationId xmlns:a16="http://schemas.microsoft.com/office/drawing/2014/main" id="{8BC6147D-0044-3A8E-2BB9-06C87E4EBFEF}"/>
+                </a:ext>
+              </a:extLst>
+            </p:cNvPr>
+            <p:cNvSpPr/>
+            <p:nvPr/>
+          </p:nvSpPr>
+          <p:spPr>
+            <a:xfrm rot="5400000">
+              <a:off x="6027126" y="3697166"/>
+              <a:ext cx="597877" cy="2101363"/>
+            </a:xfrm>
+            <a:prstGeom prst="moon">
+              <a:avLst/>
+            </a:prstGeom>
+          </p:spPr>
+          <p:style>
+            <a:lnRef idx="2">
+              <a:schemeClr val="dk1">
+                <a:shade val="50000"/>
+              </a:schemeClr>
+            </a:lnRef>
+            <a:fillRef idx="1">
+              <a:schemeClr val="dk1"/>
+            </a:fillRef>
+            <a:effectRef idx="0">
+              <a:schemeClr val="dk1"/>
+            </a:effectRef>
+            <a:fontRef idx="minor">
+              <a:schemeClr val="lt1"/>
+            </a:fontRef>
+          </p:style>
+          <p:txBody>
+            <a:bodyPr rtlCol="0" anchor="ctr"/>
+            <a:lstStyle/>
+            <a:p>
+              <a:pPr algn="ctr"/>
+              <a:endParaRPr lang="en-US"/>
+            </a:p>
+          </p:txBody>
+        </p:sp>
+      </p:grpSp>
+      <p:grpSp>
+        <p:nvGrpSpPr>
+          <p:cNvPr id="203" name="Group 202">
+            <a:extLst>
+              <a:ext uri="{FF2B5EF4-FFF2-40B4-BE49-F238E27FC236}">
+                <a16:creationId xmlns:a16="http://schemas.microsoft.com/office/drawing/2014/main" id="{D8D3A3CE-09CD-16A4-4BBA-2886526A1FAB}"/>
+              </a:ext>
+            </a:extLst>
+          </p:cNvPr>
+          <p:cNvGrpSpPr/>
+          <p:nvPr/>
+        </p:nvGrpSpPr>
+        <p:grpSpPr>
+          <a:xfrm>
+            <a:off x="7493608" y="3574822"/>
+            <a:ext cx="1020292" cy="877614"/>
+            <a:chOff x="5664202" y="1634729"/>
+            <a:chExt cx="2809442" cy="2416570"/>
+          </a:xfrm>
+        </p:grpSpPr>
+        <p:sp>
+          <p:nvSpPr>
+            <p:cNvPr id="204" name="Moon 203">
+              <a:extLst>
+                <a:ext uri="{FF2B5EF4-FFF2-40B4-BE49-F238E27FC236}">
+                  <a16:creationId xmlns:a16="http://schemas.microsoft.com/office/drawing/2014/main" id="{6122CCDF-9E81-2BC5-C471-27D01E1E9E7B}"/>
+                </a:ext>
+              </a:extLst>
+            </p:cNvPr>
+            <p:cNvSpPr/>
+            <p:nvPr/>
+          </p:nvSpPr>
+          <p:spPr>
+            <a:xfrm rot="16200000" flipV="1">
+              <a:off x="6630773" y="1057275"/>
+              <a:ext cx="876300" cy="2809442"/>
+            </a:xfrm>
+            <a:prstGeom prst="moon">
+              <a:avLst/>
+            </a:prstGeom>
+          </p:spPr>
+          <p:style>
+            <a:lnRef idx="2">
+              <a:schemeClr val="dk1"/>
+            </a:lnRef>
+            <a:fillRef idx="1">
+              <a:schemeClr val="lt1"/>
+            </a:fillRef>
+            <a:effectRef idx="0">
+              <a:schemeClr val="dk1"/>
+            </a:effectRef>
+            <a:fontRef idx="minor">
+              <a:schemeClr val="dk1"/>
+            </a:fontRef>
+          </p:style>
+          <p:txBody>
+            <a:bodyPr rtlCol="0" anchor="ctr"/>
+            <a:lstStyle/>
+            <a:p>
+              <a:pPr algn="ctr"/>
+              <a:endParaRPr lang="en-US"/>
+            </a:p>
+          </p:txBody>
+        </p:sp>
+        <p:sp>
+          <p:nvSpPr>
+            <p:cNvPr id="205" name="Moon 204">
+              <a:extLst>
+                <a:ext uri="{FF2B5EF4-FFF2-40B4-BE49-F238E27FC236}">
+                  <a16:creationId xmlns:a16="http://schemas.microsoft.com/office/drawing/2014/main" id="{EAE94984-D4CF-7322-2069-A902D9757E96}"/>
+                </a:ext>
+              </a:extLst>
+            </p:cNvPr>
+            <p:cNvSpPr/>
+            <p:nvPr/>
+          </p:nvSpPr>
+          <p:spPr>
+            <a:xfrm rot="16200000" flipV="1">
+              <a:off x="6777590" y="2133133"/>
+              <a:ext cx="658596" cy="2101848"/>
+            </a:xfrm>
+            <a:prstGeom prst="moon">
+              <a:avLst/>
+            </a:prstGeom>
+          </p:spPr>
+          <p:style>
+            <a:lnRef idx="2">
+              <a:schemeClr val="dk1"/>
+            </a:lnRef>
+            <a:fillRef idx="1">
+              <a:schemeClr val="lt1"/>
+            </a:fillRef>
+            <a:effectRef idx="0">
+              <a:schemeClr val="dk1"/>
+            </a:effectRef>
+            <a:fontRef idx="minor">
+              <a:schemeClr val="dk1"/>
+            </a:fontRef>
+          </p:style>
+          <p:txBody>
+            <a:bodyPr rtlCol="0" anchor="ctr"/>
+            <a:lstStyle/>
+            <a:p>
+              <a:pPr algn="ctr"/>
+              <a:endParaRPr lang="en-US"/>
+            </a:p>
+          </p:txBody>
+        </p:sp>
+        <p:sp>
+          <p:nvSpPr>
+            <p:cNvPr id="206" name="Moon 205">
+              <a:extLst>
+                <a:ext uri="{FF2B5EF4-FFF2-40B4-BE49-F238E27FC236}">
+                  <a16:creationId xmlns:a16="http://schemas.microsoft.com/office/drawing/2014/main" id="{DEDA6087-F2B2-885C-14B1-00F19DCF4AA6}"/>
+                </a:ext>
+              </a:extLst>
+            </p:cNvPr>
+            <p:cNvSpPr/>
+            <p:nvPr/>
+          </p:nvSpPr>
+          <p:spPr>
+            <a:xfrm rot="16200000" flipV="1">
+              <a:off x="6839285" y="3112240"/>
+              <a:ext cx="535205" cy="1337436"/>
+            </a:xfrm>
+            <a:prstGeom prst="moon">
+              <a:avLst/>
+            </a:prstGeom>
+          </p:spPr>
+          <p:style>
+            <a:lnRef idx="2">
+              <a:schemeClr val="dk1"/>
+            </a:lnRef>
+            <a:fillRef idx="1">
+              <a:schemeClr val="lt1"/>
+            </a:fillRef>
+            <a:effectRef idx="0">
+              <a:schemeClr val="dk1"/>
+            </a:effectRef>
+            <a:fontRef idx="minor">
+              <a:schemeClr val="dk1"/>
+            </a:fontRef>
+          </p:style>
+          <p:txBody>
+            <a:bodyPr rtlCol="0" anchor="ctr"/>
+            <a:lstStyle/>
+            <a:p>
+              <a:pPr algn="ctr"/>
+              <a:endParaRPr lang="en-US"/>
+            </a:p>
+          </p:txBody>
+        </p:sp>
+        <p:sp>
+          <p:nvSpPr>
+            <p:cNvPr id="207" name="Trapezoid 206">
+              <a:extLst>
+                <a:ext uri="{FF2B5EF4-FFF2-40B4-BE49-F238E27FC236}">
+                  <a16:creationId xmlns:a16="http://schemas.microsoft.com/office/drawing/2014/main" id="{41F11F10-62C3-32A3-E023-268E5CE7AAD2}"/>
+                </a:ext>
+              </a:extLst>
+            </p:cNvPr>
+            <p:cNvSpPr/>
+            <p:nvPr/>
+          </p:nvSpPr>
+          <p:spPr>
+            <a:xfrm rot="10800000">
+              <a:off x="6527800" y="2060178"/>
+              <a:ext cx="1168400" cy="1991121"/>
+            </a:xfrm>
+            <a:prstGeom prst="trapezoid">
+              <a:avLst/>
+            </a:prstGeom>
+          </p:spPr>
+          <p:style>
+            <a:lnRef idx="2">
+              <a:schemeClr val="dk1">
+                <a:shade val="50000"/>
+              </a:schemeClr>
+            </a:lnRef>
+            <a:fillRef idx="1">
+              <a:schemeClr val="dk1"/>
+            </a:fillRef>
+            <a:effectRef idx="0">
+              <a:schemeClr val="dk1"/>
+            </a:effectRef>
+            <a:fontRef idx="minor">
+              <a:schemeClr val="lt1"/>
+            </a:fontRef>
+          </p:style>
+          <p:txBody>
+            <a:bodyPr rtlCol="0" anchor="ctr"/>
+            <a:lstStyle/>
+            <a:p>
+              <a:pPr algn="ctr"/>
+              <a:endParaRPr lang="en-US"/>
+            </a:p>
+          </p:txBody>
+        </p:sp>
+        <p:sp>
+          <p:nvSpPr>
+            <p:cNvPr id="208" name="Trapezoid 207">
+              <a:extLst>
+                <a:ext uri="{FF2B5EF4-FFF2-40B4-BE49-F238E27FC236}">
+                  <a16:creationId xmlns:a16="http://schemas.microsoft.com/office/drawing/2014/main" id="{9DCE2A57-0658-2E54-27AF-C71209FC1D79}"/>
+                </a:ext>
+              </a:extLst>
+            </p:cNvPr>
+            <p:cNvSpPr/>
+            <p:nvPr/>
+          </p:nvSpPr>
+          <p:spPr>
+            <a:xfrm>
+              <a:off x="6667977" y="1634729"/>
+              <a:ext cx="877823" cy="341783"/>
+            </a:xfrm>
+            <a:prstGeom prst="trapezoid">
+              <a:avLst/>
+            </a:prstGeom>
+          </p:spPr>
+          <p:style>
+            <a:lnRef idx="2">
+              <a:schemeClr val="dk1">
+                <a:shade val="50000"/>
+              </a:schemeClr>
+            </a:lnRef>
+            <a:fillRef idx="1">
+              <a:schemeClr val="dk1"/>
+            </a:fillRef>
+            <a:effectRef idx="0">
+              <a:schemeClr val="dk1"/>
+            </a:effectRef>
+            <a:fontRef idx="minor">
+              <a:schemeClr val="lt1"/>
+            </a:fontRef>
+          </p:style>
+          <p:txBody>
+            <a:bodyPr rtlCol="0" anchor="ctr"/>
+            <a:lstStyle/>
+            <a:p>
+              <a:pPr algn="ctr"/>
+              <a:endParaRPr lang="en-US"/>
+            </a:p>
+          </p:txBody>
+        </p:sp>
+        <p:sp>
+          <p:nvSpPr>
+            <p:cNvPr id="209" name="Oval 208">
+              <a:extLst>
+                <a:ext uri="{FF2B5EF4-FFF2-40B4-BE49-F238E27FC236}">
+                  <a16:creationId xmlns:a16="http://schemas.microsoft.com/office/drawing/2014/main" id="{5C51AE42-9D9A-6F33-2F46-6CF735BDCE15}"/>
+                </a:ext>
+              </a:extLst>
+            </p:cNvPr>
+            <p:cNvSpPr/>
+            <p:nvPr/>
+          </p:nvSpPr>
+          <p:spPr>
+            <a:xfrm>
+              <a:off x="6832567" y="2092176"/>
+              <a:ext cx="548640" cy="548640"/>
+            </a:xfrm>
+            <a:prstGeom prst="ellipse">
+              <a:avLst/>
+            </a:prstGeom>
+          </p:spPr>
+          <p:style>
+            <a:lnRef idx="2">
+              <a:schemeClr val="dk1"/>
+            </a:lnRef>
+            <a:fillRef idx="1">
+              <a:schemeClr val="lt1"/>
+            </a:fillRef>
+            <a:effectRef idx="0">
+              <a:schemeClr val="dk1"/>
+            </a:effectRef>
+            <a:fontRef idx="minor">
+              <a:schemeClr val="dk1"/>
+            </a:fontRef>
+          </p:style>
+          <p:txBody>
+            <a:bodyPr rtlCol="0" anchor="ctr"/>
+            <a:lstStyle/>
+            <a:p>
+              <a:pPr algn="ctr"/>
+              <a:endParaRPr lang="en-US"/>
+            </a:p>
+          </p:txBody>
+        </p:sp>
+        <p:sp>
+          <p:nvSpPr>
+            <p:cNvPr id="210" name="Oval 209">
+              <a:extLst>
+                <a:ext uri="{FF2B5EF4-FFF2-40B4-BE49-F238E27FC236}">
+                  <a16:creationId xmlns:a16="http://schemas.microsoft.com/office/drawing/2014/main" id="{DB76EDFE-A1FE-6ED0-644B-0E9251D57C0F}"/>
+                </a:ext>
+              </a:extLst>
+            </p:cNvPr>
+            <p:cNvSpPr/>
+            <p:nvPr/>
+          </p:nvSpPr>
+          <p:spPr>
+            <a:xfrm>
+              <a:off x="6878287" y="2672814"/>
+              <a:ext cx="457200" cy="457200"/>
+            </a:xfrm>
+            <a:prstGeom prst="ellipse">
+              <a:avLst/>
+            </a:prstGeom>
+          </p:spPr>
+          <p:style>
+            <a:lnRef idx="2">
+              <a:schemeClr val="dk1"/>
+            </a:lnRef>
+            <a:fillRef idx="1">
+              <a:schemeClr val="lt1"/>
+            </a:fillRef>
+            <a:effectRef idx="0">
+              <a:schemeClr val="dk1"/>
+            </a:effectRef>
+            <a:fontRef idx="minor">
+              <a:schemeClr val="dk1"/>
+            </a:fontRef>
+          </p:style>
+          <p:txBody>
+            <a:bodyPr rtlCol="0" anchor="ctr"/>
+            <a:lstStyle/>
+            <a:p>
+              <a:pPr algn="ctr"/>
+              <a:endParaRPr lang="en-US"/>
+            </a:p>
+          </p:txBody>
+        </p:sp>
+        <p:sp>
+          <p:nvSpPr>
+            <p:cNvPr id="211" name="Oval 210">
+              <a:extLst>
+                <a:ext uri="{FF2B5EF4-FFF2-40B4-BE49-F238E27FC236}">
+                  <a16:creationId xmlns:a16="http://schemas.microsoft.com/office/drawing/2014/main" id="{1122EE9D-1EC1-5A79-3DB8-DDF7563F0F0B}"/>
+                </a:ext>
+              </a:extLst>
+            </p:cNvPr>
+            <p:cNvSpPr/>
+            <p:nvPr/>
+          </p:nvSpPr>
+          <p:spPr>
+            <a:xfrm>
+              <a:off x="6924007" y="3160831"/>
+              <a:ext cx="365760" cy="365760"/>
+            </a:xfrm>
+            <a:prstGeom prst="ellipse">
+              <a:avLst/>
+            </a:prstGeom>
+          </p:spPr>
+          <p:style>
+            <a:lnRef idx="2">
+              <a:schemeClr val="dk1"/>
+            </a:lnRef>
+            <a:fillRef idx="1">
+              <a:schemeClr val="lt1"/>
+            </a:fillRef>
+            <a:effectRef idx="0">
+              <a:schemeClr val="dk1"/>
+            </a:effectRef>
+            <a:fontRef idx="minor">
+              <a:schemeClr val="dk1"/>
+            </a:fontRef>
+          </p:style>
+          <p:txBody>
+            <a:bodyPr rtlCol="0" anchor="ctr"/>
+            <a:lstStyle/>
+            <a:p>
+              <a:pPr algn="ctr"/>
+              <a:endParaRPr lang="en-US"/>
+            </a:p>
+          </p:txBody>
+        </p:sp>
+        <p:sp>
+          <p:nvSpPr>
+            <p:cNvPr id="212" name="Oval 211">
+              <a:extLst>
+                <a:ext uri="{FF2B5EF4-FFF2-40B4-BE49-F238E27FC236}">
+                  <a16:creationId xmlns:a16="http://schemas.microsoft.com/office/drawing/2014/main" id="{D7E31F2C-EC79-3E89-2900-0107B740EE4C}"/>
+                </a:ext>
+              </a:extLst>
+            </p:cNvPr>
+            <p:cNvSpPr/>
+            <p:nvPr/>
+          </p:nvSpPr>
+          <p:spPr>
+            <a:xfrm>
+              <a:off x="6969727" y="3583710"/>
+              <a:ext cx="274320" cy="274320"/>
+            </a:xfrm>
+            <a:prstGeom prst="ellipse">
+              <a:avLst/>
+            </a:prstGeom>
+          </p:spPr>
+          <p:style>
+            <a:lnRef idx="2">
+              <a:schemeClr val="dk1"/>
+            </a:lnRef>
+            <a:fillRef idx="1">
+              <a:schemeClr val="lt1"/>
+            </a:fillRef>
+            <a:effectRef idx="0">
+              <a:schemeClr val="dk1"/>
             </a:effectRef>
             <a:fontRef idx="minor">
               <a:schemeClr val="dk1"/>

</xml_diff>

<commit_message>
Add self mend logic
</commit_message>
<xml_diff>
--- a/image process/drawings sifi.pptx
+++ b/image process/drawings sifi.pptx
@@ -200,7 +200,7 @@
           <a:p>
             <a:fld id="{7700C406-2328-4788-AE79-437B6607AD22}" type="datetimeFigureOut">
               <a:rPr lang="en-US" smtClean="0"/>
-              <a:t>6/14/2022</a:t>
+              <a:t>6/16/2022</a:t>
             </a:fld>
             <a:endParaRPr lang="en-US"/>
           </a:p>
@@ -614,7 +614,7 @@
           <a:p>
             <a:fld id="{9EC8CD53-0620-48F2-A3BB-2B10BDA60E52}" type="datetimeFigureOut">
               <a:rPr lang="en-US" smtClean="0"/>
-              <a:t>6/14/2022</a:t>
+              <a:t>6/16/2022</a:t>
             </a:fld>
             <a:endParaRPr lang="en-US"/>
           </a:p>
@@ -812,7 +812,7 @@
           <a:p>
             <a:fld id="{9EC8CD53-0620-48F2-A3BB-2B10BDA60E52}" type="datetimeFigureOut">
               <a:rPr lang="en-US" smtClean="0"/>
-              <a:t>6/14/2022</a:t>
+              <a:t>6/16/2022</a:t>
             </a:fld>
             <a:endParaRPr lang="en-US"/>
           </a:p>
@@ -1020,7 +1020,7 @@
           <a:p>
             <a:fld id="{9EC8CD53-0620-48F2-A3BB-2B10BDA60E52}" type="datetimeFigureOut">
               <a:rPr lang="en-US" smtClean="0"/>
-              <a:t>6/14/2022</a:t>
+              <a:t>6/16/2022</a:t>
             </a:fld>
             <a:endParaRPr lang="en-US"/>
           </a:p>
@@ -1218,7 +1218,7 @@
           <a:p>
             <a:fld id="{9EC8CD53-0620-48F2-A3BB-2B10BDA60E52}" type="datetimeFigureOut">
               <a:rPr lang="en-US" smtClean="0"/>
-              <a:t>6/14/2022</a:t>
+              <a:t>6/16/2022</a:t>
             </a:fld>
             <a:endParaRPr lang="en-US"/>
           </a:p>
@@ -1493,7 +1493,7 @@
           <a:p>
             <a:fld id="{9EC8CD53-0620-48F2-A3BB-2B10BDA60E52}" type="datetimeFigureOut">
               <a:rPr lang="en-US" smtClean="0"/>
-              <a:t>6/14/2022</a:t>
+              <a:t>6/16/2022</a:t>
             </a:fld>
             <a:endParaRPr lang="en-US"/>
           </a:p>
@@ -1758,7 +1758,7 @@
           <a:p>
             <a:fld id="{9EC8CD53-0620-48F2-A3BB-2B10BDA60E52}" type="datetimeFigureOut">
               <a:rPr lang="en-US" smtClean="0"/>
-              <a:t>6/14/2022</a:t>
+              <a:t>6/16/2022</a:t>
             </a:fld>
             <a:endParaRPr lang="en-US"/>
           </a:p>
@@ -2170,7 +2170,7 @@
           <a:p>
             <a:fld id="{9EC8CD53-0620-48F2-A3BB-2B10BDA60E52}" type="datetimeFigureOut">
               <a:rPr lang="en-US" smtClean="0"/>
-              <a:t>6/14/2022</a:t>
+              <a:t>6/16/2022</a:t>
             </a:fld>
             <a:endParaRPr lang="en-US"/>
           </a:p>
@@ -2311,7 +2311,7 @@
           <a:p>
             <a:fld id="{9EC8CD53-0620-48F2-A3BB-2B10BDA60E52}" type="datetimeFigureOut">
               <a:rPr lang="en-US" smtClean="0"/>
-              <a:t>6/14/2022</a:t>
+              <a:t>6/16/2022</a:t>
             </a:fld>
             <a:endParaRPr lang="en-US"/>
           </a:p>
@@ -2424,7 +2424,7 @@
           <a:p>
             <a:fld id="{9EC8CD53-0620-48F2-A3BB-2B10BDA60E52}" type="datetimeFigureOut">
               <a:rPr lang="en-US" smtClean="0"/>
-              <a:t>6/14/2022</a:t>
+              <a:t>6/16/2022</a:t>
             </a:fld>
             <a:endParaRPr lang="en-US"/>
           </a:p>
@@ -2735,7 +2735,7 @@
           <a:p>
             <a:fld id="{9EC8CD53-0620-48F2-A3BB-2B10BDA60E52}" type="datetimeFigureOut">
               <a:rPr lang="en-US" smtClean="0"/>
-              <a:t>6/14/2022</a:t>
+              <a:t>6/16/2022</a:t>
             </a:fld>
             <a:endParaRPr lang="en-US"/>
           </a:p>
@@ -3023,7 +3023,7 @@
           <a:p>
             <a:fld id="{9EC8CD53-0620-48F2-A3BB-2B10BDA60E52}" type="datetimeFigureOut">
               <a:rPr lang="en-US" smtClean="0"/>
-              <a:t>6/14/2022</a:t>
+              <a:t>6/16/2022</a:t>
             </a:fld>
             <a:endParaRPr lang="en-US"/>
           </a:p>
@@ -3264,7 +3264,7 @@
           <a:p>
             <a:fld id="{9EC8CD53-0620-48F2-A3BB-2B10BDA60E52}" type="datetimeFigureOut">
               <a:rPr lang="en-US" smtClean="0"/>
-              <a:t>6/14/2022</a:t>
+              <a:t>6/16/2022</a:t>
             </a:fld>
             <a:endParaRPr lang="en-US"/>
           </a:p>
@@ -23479,6 +23479,183 @@
       </p:grpSpPr>
       <p:grpSp>
         <p:nvGrpSpPr>
+          <p:cNvPr id="4" name="Group 3">
+            <a:extLst>
+              <a:ext uri="{FF2B5EF4-FFF2-40B4-BE49-F238E27FC236}">
+                <a16:creationId xmlns:a16="http://schemas.microsoft.com/office/drawing/2014/main" id="{A83527CF-3368-3F21-540D-F496B300AFF0}"/>
+              </a:ext>
+            </a:extLst>
+          </p:cNvPr>
+          <p:cNvGrpSpPr/>
+          <p:nvPr/>
+        </p:nvGrpSpPr>
+        <p:grpSpPr>
+          <a:xfrm>
+            <a:off x="6874801" y="3761784"/>
+            <a:ext cx="685905" cy="1061625"/>
+            <a:chOff x="4780300" y="4186533"/>
+            <a:chExt cx="685905" cy="1061625"/>
+          </a:xfrm>
+        </p:grpSpPr>
+        <p:grpSp>
+          <p:nvGrpSpPr>
+            <p:cNvPr id="6" name="Group 5">
+              <a:extLst>
+                <a:ext uri="{FF2B5EF4-FFF2-40B4-BE49-F238E27FC236}">
+                  <a16:creationId xmlns:a16="http://schemas.microsoft.com/office/drawing/2014/main" id="{1D845641-42F5-D497-DD80-FBE72BE9A4F2}"/>
+                </a:ext>
+              </a:extLst>
+            </p:cNvPr>
+            <p:cNvGrpSpPr/>
+            <p:nvPr/>
+          </p:nvGrpSpPr>
+          <p:grpSpPr>
+            <a:xfrm>
+              <a:off x="4990276" y="4238288"/>
+              <a:ext cx="475929" cy="507806"/>
+              <a:chOff x="5052457" y="3925688"/>
+              <a:chExt cx="715293" cy="763202"/>
+            </a:xfrm>
+          </p:grpSpPr>
+          <p:pic>
+            <p:nvPicPr>
+              <p:cNvPr id="1036" name="Picture 12" descr="Ninja dart Images, Stock Photos &amp; Vectors | Shutterstock">
+                <a:extLst>
+                  <a:ext uri="{FF2B5EF4-FFF2-40B4-BE49-F238E27FC236}">
+                    <a16:creationId xmlns:a16="http://schemas.microsoft.com/office/drawing/2014/main" id="{6CB2D1BA-B89E-F421-969F-56A0AC897A14}"/>
+                  </a:ext>
+                </a:extLst>
+              </p:cNvPr>
+              <p:cNvPicPr>
+                <a:picLocks noChangeAspect="1" noChangeArrowheads="1"/>
+              </p:cNvPicPr>
+              <p:nvPr/>
+            </p:nvPicPr>
+            <p:blipFill rotWithShape="1">
+              <a:blip r:embed="rId2">
+                <a:extLst>
+                  <a:ext uri="{28A0092B-C50C-407E-A947-70E740481C1C}">
+                    <a14:useLocalDpi xmlns:a14="http://schemas.microsoft.com/office/drawing/2010/main" val="0"/>
+                  </a:ext>
+                </a:extLst>
+              </a:blip>
+              <a:srcRect l="21795" t="20882" r="20930" b="27689"/>
+              <a:stretch/>
+            </p:blipFill>
+            <p:spPr bwMode="auto">
+              <a:xfrm>
+                <a:off x="5052457" y="3925688"/>
+                <a:ext cx="447751" cy="432973"/>
+              </a:xfrm>
+              <a:prstGeom prst="rect">
+                <a:avLst/>
+              </a:prstGeom>
+              <a:noFill/>
+              <a:extLst>
+                <a:ext uri="{909E8E84-426E-40DD-AFC4-6F175D3DCCD1}">
+                  <a14:hiddenFill xmlns:a14="http://schemas.microsoft.com/office/drawing/2010/main">
+                    <a:solidFill>
+                      <a:srgbClr val="FFFFFF"/>
+                    </a:solidFill>
+                  </a14:hiddenFill>
+                </a:ext>
+              </a:extLst>
+            </p:spPr>
+          </p:pic>
+          <p:pic>
+            <p:nvPicPr>
+              <p:cNvPr id="144" name="Picture 12" descr="Ninja dart Images, Stock Photos &amp; Vectors | Shutterstock">
+                <a:extLst>
+                  <a:ext uri="{FF2B5EF4-FFF2-40B4-BE49-F238E27FC236}">
+                    <a16:creationId xmlns:a16="http://schemas.microsoft.com/office/drawing/2014/main" id="{B3F339B1-4624-084E-5B5C-262A1C9A9AA2}"/>
+                  </a:ext>
+                </a:extLst>
+              </p:cNvPr>
+              <p:cNvPicPr>
+                <a:picLocks noChangeAspect="1" noChangeArrowheads="1"/>
+              </p:cNvPicPr>
+              <p:nvPr/>
+            </p:nvPicPr>
+            <p:blipFill rotWithShape="1">
+              <a:blip r:embed="rId2">
+                <a:extLst>
+                  <a:ext uri="{28A0092B-C50C-407E-A947-70E740481C1C}">
+                    <a14:useLocalDpi xmlns:a14="http://schemas.microsoft.com/office/drawing/2010/main" val="0"/>
+                  </a:ext>
+                </a:extLst>
+              </a:blip>
+              <a:srcRect l="21795" t="20882" r="20930" b="27689"/>
+              <a:stretch/>
+            </p:blipFill>
+            <p:spPr bwMode="auto">
+              <a:xfrm>
+                <a:off x="5319999" y="4255917"/>
+                <a:ext cx="447751" cy="432973"/>
+              </a:xfrm>
+              <a:prstGeom prst="rect">
+                <a:avLst/>
+              </a:prstGeom>
+              <a:noFill/>
+              <a:extLst>
+                <a:ext uri="{909E8E84-426E-40DD-AFC4-6F175D3DCCD1}">
+                  <a14:hiddenFill xmlns:a14="http://schemas.microsoft.com/office/drawing/2010/main">
+                    <a:solidFill>
+                      <a:srgbClr val="FFFFFF"/>
+                    </a:solidFill>
+                  </a14:hiddenFill>
+                </a:ext>
+              </a:extLst>
+            </p:spPr>
+          </p:pic>
+        </p:grpSp>
+        <p:pic>
+          <p:nvPicPr>
+            <p:cNvPr id="1026" name="Picture 2" descr="Bat Vector Icon Logo Halloween Character Stock Vector (Royalty Free)  1154282770 | Shutterstock">
+              <a:extLst>
+                <a:ext uri="{FF2B5EF4-FFF2-40B4-BE49-F238E27FC236}">
+                  <a16:creationId xmlns:a16="http://schemas.microsoft.com/office/drawing/2014/main" id="{EFDA77C4-70F9-1F2C-A9F8-81A43B84856A}"/>
+                </a:ext>
+              </a:extLst>
+            </p:cNvPr>
+            <p:cNvPicPr>
+              <a:picLocks noChangeAspect="1" noChangeArrowheads="1"/>
+            </p:cNvPicPr>
+            <p:nvPr/>
+          </p:nvPicPr>
+          <p:blipFill rotWithShape="1">
+            <a:blip r:embed="rId3">
+              <a:extLst>
+                <a:ext uri="{28A0092B-C50C-407E-A947-70E740481C1C}">
+                  <a14:useLocalDpi xmlns:a14="http://schemas.microsoft.com/office/drawing/2010/main" val="0"/>
+                </a:ext>
+              </a:extLst>
+            </a:blip>
+            <a:srcRect l="7315" t="14728" r="6948" b="22285"/>
+            <a:stretch/>
+          </p:blipFill>
+          <p:spPr bwMode="auto">
+            <a:xfrm rot="2797739">
+              <a:off x="4459463" y="4507370"/>
+              <a:ext cx="1061625" cy="419951"/>
+            </a:xfrm>
+            <a:prstGeom prst="rect">
+              <a:avLst/>
+            </a:prstGeom>
+            <a:noFill/>
+            <a:extLst>
+              <a:ext uri="{909E8E84-426E-40DD-AFC4-6F175D3DCCD1}">
+                <a14:hiddenFill xmlns:a14="http://schemas.microsoft.com/office/drawing/2010/main">
+                  <a:solidFill>
+                    <a:srgbClr val="FFFFFF"/>
+                  </a:solidFill>
+                </a14:hiddenFill>
+              </a:ext>
+            </a:extLst>
+          </p:spPr>
+        </p:pic>
+      </p:grpSp>
+      <p:grpSp>
+        <p:nvGrpSpPr>
           <p:cNvPr id="52" name="Group 51">
             <a:extLst>
               <a:ext uri="{FF2B5EF4-FFF2-40B4-BE49-F238E27FC236}">
@@ -23512,7 +23689,7 @@
             <p:nvPr/>
           </p:nvPicPr>
           <p:blipFill>
-            <a:blip r:embed="rId2">
+            <a:blip r:embed="rId4">
               <a:extLst>
                 <a:ext uri="{28A0092B-C50C-407E-A947-70E740481C1C}">
                   <a14:useLocalDpi xmlns:a14="http://schemas.microsoft.com/office/drawing/2010/main" val="0"/>
@@ -23559,7 +23736,7 @@
             <p:nvPr/>
           </p:nvPicPr>
           <p:blipFill>
-            <a:blip r:embed="rId3"/>
+            <a:blip r:embed="rId5"/>
             <a:stretch>
               <a:fillRect/>
             </a:stretch>
@@ -23610,7 +23787,7 @@
             <p:nvPr/>
           </p:nvPicPr>
           <p:blipFill>
-            <a:blip r:embed="rId4"/>
+            <a:blip r:embed="rId6"/>
             <a:stretch>
               <a:fillRect/>
             </a:stretch>
@@ -23640,7 +23817,7 @@
             <p:nvPr/>
           </p:nvPicPr>
           <p:blipFill rotWithShape="1">
-            <a:blip r:embed="rId5">
+            <a:blip r:embed="rId7">
               <a:extLst>
                 <a:ext uri="{28A0092B-C50C-407E-A947-70E740481C1C}">
                   <a14:useLocalDpi xmlns:a14="http://schemas.microsoft.com/office/drawing/2010/main" val="0"/>
@@ -23686,7 +23863,7 @@
           <p:nvPr/>
         </p:nvPicPr>
         <p:blipFill rotWithShape="1">
-          <a:blip r:embed="rId6">
+          <a:blip r:embed="rId8">
             <a:extLst>
               <a:ext uri="{28A0092B-C50C-407E-A947-70E740481C1C}">
                 <a14:useLocalDpi xmlns:a14="http://schemas.microsoft.com/office/drawing/2010/main" val="0"/>
@@ -23751,7 +23928,7 @@
             <p:nvPr/>
           </p:nvPicPr>
           <p:blipFill>
-            <a:blip r:embed="rId7"/>
+            <a:blip r:embed="rId9"/>
             <a:stretch>
               <a:fillRect/>
             </a:stretch>
@@ -23781,7 +23958,7 @@
             <p:nvPr/>
           </p:nvPicPr>
           <p:blipFill>
-            <a:blip r:embed="rId8"/>
+            <a:blip r:embed="rId10"/>
             <a:stretch>
               <a:fillRect/>
             </a:stretch>
@@ -23832,7 +24009,7 @@
             <p:nvPr/>
           </p:nvPicPr>
           <p:blipFill>
-            <a:blip r:embed="rId9"/>
+            <a:blip r:embed="rId11"/>
             <a:stretch>
               <a:fillRect/>
             </a:stretch>
@@ -25506,7 +25683,7 @@
             <p:nvPr/>
           </p:nvPicPr>
           <p:blipFill rotWithShape="1">
-            <a:blip r:embed="rId10">
+            <a:blip r:embed="rId12">
               <a:extLst>
                 <a:ext uri="{28A0092B-C50C-407E-A947-70E740481C1C}">
                   <a14:useLocalDpi xmlns:a14="http://schemas.microsoft.com/office/drawing/2010/main" val="0"/>
@@ -25551,7 +25728,7 @@
             <p:nvPr/>
           </p:nvPicPr>
           <p:blipFill rotWithShape="1">
-            <a:blip r:embed="rId7"/>
+            <a:blip r:embed="rId9"/>
             <a:srcRect b="41100"/>
             <a:stretch/>
           </p:blipFill>
@@ -25813,7 +25990,7 @@
             <p:nvPr/>
           </p:nvPicPr>
           <p:blipFill>
-            <a:blip r:embed="rId11"/>
+            <a:blip r:embed="rId13"/>
             <a:stretch>
               <a:fillRect/>
             </a:stretch>
@@ -25864,7 +26041,7 @@
             <p:nvPr/>
           </p:nvPicPr>
           <p:blipFill rotWithShape="1">
-            <a:blip r:embed="rId5">
+            <a:blip r:embed="rId7">
               <a:extLst>
                 <a:ext uri="{28A0092B-C50C-407E-A947-70E740481C1C}">
                   <a14:useLocalDpi xmlns:a14="http://schemas.microsoft.com/office/drawing/2010/main" val="0"/>
@@ -25929,7 +26106,7 @@
               <p:nvPr/>
             </p:nvPicPr>
             <p:blipFill>
-              <a:blip r:embed="rId12">
+              <a:blip r:embed="rId14">
                 <a:extLst>
                   <a:ext uri="{28A0092B-C50C-407E-A947-70E740481C1C}">
                     <a14:useLocalDpi xmlns:a14="http://schemas.microsoft.com/office/drawing/2010/main" val="0"/>
@@ -25976,7 +26153,7 @@
               <p:nvPr/>
             </p:nvPicPr>
             <p:blipFill>
-              <a:blip r:embed="rId12">
+              <a:blip r:embed="rId14">
                 <a:extLst>
                   <a:ext uri="{28A0092B-C50C-407E-A947-70E740481C1C}">
                     <a14:useLocalDpi xmlns:a14="http://schemas.microsoft.com/office/drawing/2010/main" val="0"/>
@@ -26023,7 +26200,7 @@
               <p:nvPr/>
             </p:nvPicPr>
             <p:blipFill>
-              <a:blip r:embed="rId12">
+              <a:blip r:embed="rId14">
                 <a:extLst>
                   <a:ext uri="{28A0092B-C50C-407E-A947-70E740481C1C}">
                     <a14:useLocalDpi xmlns:a14="http://schemas.microsoft.com/office/drawing/2010/main" val="0"/>
@@ -28087,7 +28264,7 @@
             <p:nvPr/>
           </p:nvPicPr>
           <p:blipFill rotWithShape="1">
-            <a:blip r:embed="rId13">
+            <a:blip r:embed="rId15">
               <a:extLst>
                 <a:ext uri="{28A0092B-C50C-407E-A947-70E740481C1C}">
                   <a14:useLocalDpi xmlns:a14="http://schemas.microsoft.com/office/drawing/2010/main" val="0"/>
@@ -28132,7 +28309,7 @@
             <p:nvPr/>
           </p:nvPicPr>
           <p:blipFill rotWithShape="1">
-            <a:blip r:embed="rId13">
+            <a:blip r:embed="rId15">
               <a:extLst>
                 <a:ext uri="{28A0092B-C50C-407E-A947-70E740481C1C}">
                   <a14:useLocalDpi xmlns:a14="http://schemas.microsoft.com/office/drawing/2010/main" val="0"/>
@@ -28506,7 +28683,7 @@
             <p:nvPr/>
           </p:nvPicPr>
           <p:blipFill rotWithShape="1">
-            <a:blip r:embed="rId13">
+            <a:blip r:embed="rId15">
               <a:extLst>
                 <a:ext uri="{28A0092B-C50C-407E-A947-70E740481C1C}">
                   <a14:useLocalDpi xmlns:a14="http://schemas.microsoft.com/office/drawing/2010/main" val="0"/>
@@ -28551,7 +28728,7 @@
             <p:nvPr/>
           </p:nvPicPr>
           <p:blipFill rotWithShape="1">
-            <a:blip r:embed="rId13">
+            <a:blip r:embed="rId15">
               <a:extLst>
                 <a:ext uri="{28A0092B-C50C-407E-A947-70E740481C1C}">
                   <a14:useLocalDpi xmlns:a14="http://schemas.microsoft.com/office/drawing/2010/main" val="0"/>
@@ -28565,164 +28742,6 @@
             <a:xfrm>
               <a:off x="4849013" y="3586270"/>
               <a:ext cx="1246987" cy="1512204"/>
-            </a:xfrm>
-            <a:prstGeom prst="rect">
-              <a:avLst/>
-            </a:prstGeom>
-            <a:noFill/>
-            <a:extLst>
-              <a:ext uri="{909E8E84-426E-40DD-AFC4-6F175D3DCCD1}">
-                <a14:hiddenFill xmlns:a14="http://schemas.microsoft.com/office/drawing/2010/main">
-                  <a:solidFill>
-                    <a:srgbClr val="FFFFFF"/>
-                  </a:solidFill>
-                </a14:hiddenFill>
-              </a:ext>
-            </a:extLst>
-          </p:spPr>
-        </p:pic>
-      </p:grpSp>
-      <p:grpSp>
-        <p:nvGrpSpPr>
-          <p:cNvPr id="6" name="Group 5">
-            <a:extLst>
-              <a:ext uri="{FF2B5EF4-FFF2-40B4-BE49-F238E27FC236}">
-                <a16:creationId xmlns:a16="http://schemas.microsoft.com/office/drawing/2014/main" id="{1D845641-42F5-D497-DD80-FBE72BE9A4F2}"/>
-              </a:ext>
-            </a:extLst>
-          </p:cNvPr>
-          <p:cNvGrpSpPr/>
-          <p:nvPr/>
-        </p:nvGrpSpPr>
-        <p:grpSpPr>
-          <a:xfrm>
-            <a:off x="6675565" y="3730406"/>
-            <a:ext cx="882536" cy="976400"/>
-            <a:chOff x="4441351" y="3925688"/>
-            <a:chExt cx="1326399" cy="1467471"/>
-          </a:xfrm>
-        </p:grpSpPr>
-        <p:pic>
-          <p:nvPicPr>
-            <p:cNvPr id="1030" name="Picture 6" descr="Wasp Vector Illustration Royalty Free SVG, Cliparts, Vectors, And Stock  Illustration. Image 71871205.">
-              <a:extLst>
-                <a:ext uri="{FF2B5EF4-FFF2-40B4-BE49-F238E27FC236}">
-                  <a16:creationId xmlns:a16="http://schemas.microsoft.com/office/drawing/2014/main" id="{B2E2DC90-4C2F-8C03-E789-24BA71A611BA}"/>
-                </a:ext>
-              </a:extLst>
-            </p:cNvPr>
-            <p:cNvPicPr>
-              <a:picLocks noChangeAspect="1" noChangeArrowheads="1"/>
-            </p:cNvPicPr>
-            <p:nvPr/>
-          </p:nvPicPr>
-          <p:blipFill>
-            <a:blip r:embed="rId14">
-              <a:extLst>
-                <a:ext uri="{28A0092B-C50C-407E-A947-70E740481C1C}">
-                  <a14:useLocalDpi xmlns:a14="http://schemas.microsoft.com/office/drawing/2010/main" val="0"/>
-                </a:ext>
-              </a:extLst>
-            </a:blip>
-            <a:srcRect/>
-            <a:stretch>
-              <a:fillRect/>
-            </a:stretch>
-          </p:blipFill>
-          <p:spPr bwMode="auto">
-            <a:xfrm>
-              <a:off x="4441351" y="4105019"/>
-              <a:ext cx="1238641" cy="1288140"/>
-            </a:xfrm>
-            <a:prstGeom prst="rect">
-              <a:avLst/>
-            </a:prstGeom>
-            <a:noFill/>
-            <a:extLst>
-              <a:ext uri="{909E8E84-426E-40DD-AFC4-6F175D3DCCD1}">
-                <a14:hiddenFill xmlns:a14="http://schemas.microsoft.com/office/drawing/2010/main">
-                  <a:solidFill>
-                    <a:srgbClr val="FFFFFF"/>
-                  </a:solidFill>
-                </a14:hiddenFill>
-              </a:ext>
-            </a:extLst>
-          </p:spPr>
-        </p:pic>
-        <p:pic>
-          <p:nvPicPr>
-            <p:cNvPr id="1036" name="Picture 12" descr="Ninja dart Images, Stock Photos &amp; Vectors | Shutterstock">
-              <a:extLst>
-                <a:ext uri="{FF2B5EF4-FFF2-40B4-BE49-F238E27FC236}">
-                  <a16:creationId xmlns:a16="http://schemas.microsoft.com/office/drawing/2014/main" id="{6CB2D1BA-B89E-F421-969F-56A0AC897A14}"/>
-                </a:ext>
-              </a:extLst>
-            </p:cNvPr>
-            <p:cNvPicPr>
-              <a:picLocks noChangeAspect="1" noChangeArrowheads="1"/>
-            </p:cNvPicPr>
-            <p:nvPr/>
-          </p:nvPicPr>
-          <p:blipFill rotWithShape="1">
-            <a:blip r:embed="rId15">
-              <a:extLst>
-                <a:ext uri="{28A0092B-C50C-407E-A947-70E740481C1C}">
-                  <a14:useLocalDpi xmlns:a14="http://schemas.microsoft.com/office/drawing/2010/main" val="0"/>
-                </a:ext>
-              </a:extLst>
-            </a:blip>
-            <a:srcRect l="21795" t="20882" r="20930" b="27689"/>
-            <a:stretch/>
-          </p:blipFill>
-          <p:spPr bwMode="auto">
-            <a:xfrm>
-              <a:off x="5052457" y="3925688"/>
-              <a:ext cx="447751" cy="432973"/>
-            </a:xfrm>
-            <a:prstGeom prst="rect">
-              <a:avLst/>
-            </a:prstGeom>
-            <a:noFill/>
-            <a:extLst>
-              <a:ext uri="{909E8E84-426E-40DD-AFC4-6F175D3DCCD1}">
-                <a14:hiddenFill xmlns:a14="http://schemas.microsoft.com/office/drawing/2010/main">
-                  <a:solidFill>
-                    <a:srgbClr val="FFFFFF"/>
-                  </a:solidFill>
-                </a14:hiddenFill>
-              </a:ext>
-            </a:extLst>
-          </p:spPr>
-        </p:pic>
-        <p:pic>
-          <p:nvPicPr>
-            <p:cNvPr id="144" name="Picture 12" descr="Ninja dart Images, Stock Photos &amp; Vectors | Shutterstock">
-              <a:extLst>
-                <a:ext uri="{FF2B5EF4-FFF2-40B4-BE49-F238E27FC236}">
-                  <a16:creationId xmlns:a16="http://schemas.microsoft.com/office/drawing/2014/main" id="{B3F339B1-4624-084E-5B5C-262A1C9A9AA2}"/>
-                </a:ext>
-              </a:extLst>
-            </p:cNvPr>
-            <p:cNvPicPr>
-              <a:picLocks noChangeAspect="1" noChangeArrowheads="1"/>
-            </p:cNvPicPr>
-            <p:nvPr/>
-          </p:nvPicPr>
-          <p:blipFill rotWithShape="1">
-            <a:blip r:embed="rId15">
-              <a:extLst>
-                <a:ext uri="{28A0092B-C50C-407E-A947-70E740481C1C}">
-                  <a14:useLocalDpi xmlns:a14="http://schemas.microsoft.com/office/drawing/2010/main" val="0"/>
-                </a:ext>
-              </a:extLst>
-            </a:blip>
-            <a:srcRect l="21795" t="20882" r="20930" b="27689"/>
-            <a:stretch/>
-          </p:blipFill>
-          <p:spPr bwMode="auto">
-            <a:xfrm>
-              <a:off x="5319999" y="4255917"/>
-              <a:ext cx="447751" cy="432973"/>
             </a:xfrm>
             <a:prstGeom prst="rect">
               <a:avLst/>
@@ -29156,6 +29175,1095 @@
             </a:effectRef>
             <a:fontRef idx="minor">
               <a:schemeClr val="dk1"/>
+            </a:fontRef>
+          </p:style>
+          <p:txBody>
+            <a:bodyPr rtlCol="0" anchor="ctr"/>
+            <a:lstStyle/>
+            <a:p>
+              <a:pPr algn="ctr"/>
+              <a:endParaRPr lang="en-US"/>
+            </a:p>
+          </p:txBody>
+        </p:sp>
+      </p:grpSp>
+      <p:grpSp>
+        <p:nvGrpSpPr>
+          <p:cNvPr id="7" name="Group 6">
+            <a:extLst>
+              <a:ext uri="{FF2B5EF4-FFF2-40B4-BE49-F238E27FC236}">
+                <a16:creationId xmlns:a16="http://schemas.microsoft.com/office/drawing/2014/main" id="{EAAA08AF-49E9-532D-06DD-E0AC18A30215}"/>
+              </a:ext>
+            </a:extLst>
+          </p:cNvPr>
+          <p:cNvGrpSpPr/>
+          <p:nvPr/>
+        </p:nvGrpSpPr>
+        <p:grpSpPr>
+          <a:xfrm>
+            <a:off x="9773710" y="2248932"/>
+            <a:ext cx="718107" cy="1009156"/>
+            <a:chOff x="4749318" y="4046015"/>
+            <a:chExt cx="718107" cy="1009156"/>
+          </a:xfrm>
+        </p:grpSpPr>
+        <p:pic>
+          <p:nvPicPr>
+            <p:cNvPr id="163" name="Picture 162">
+              <a:extLst>
+                <a:ext uri="{FF2B5EF4-FFF2-40B4-BE49-F238E27FC236}">
+                  <a16:creationId xmlns:a16="http://schemas.microsoft.com/office/drawing/2014/main" id="{F2E6589B-FD4F-D20F-4ED7-6CD011F3AEED}"/>
+                </a:ext>
+              </a:extLst>
+            </p:cNvPr>
+            <p:cNvPicPr>
+              <a:picLocks noChangeAspect="1"/>
+            </p:cNvPicPr>
+            <p:nvPr/>
+          </p:nvPicPr>
+          <p:blipFill>
+            <a:blip r:embed="rId13"/>
+            <a:stretch>
+              <a:fillRect/>
+            </a:stretch>
+          </p:blipFill>
+          <p:spPr>
+            <a:xfrm>
+              <a:off x="4912582" y="4046015"/>
+              <a:ext cx="554843" cy="508021"/>
+            </a:xfrm>
+            <a:prstGeom prst="rect">
+              <a:avLst/>
+            </a:prstGeom>
+          </p:spPr>
+        </p:pic>
+        <p:pic>
+          <p:nvPicPr>
+            <p:cNvPr id="158" name="Picture 4" descr="2,174 Hornet Vector Illustrations &amp; Clip Art - iStock">
+              <a:extLst>
+                <a:ext uri="{FF2B5EF4-FFF2-40B4-BE49-F238E27FC236}">
+                  <a16:creationId xmlns:a16="http://schemas.microsoft.com/office/drawing/2014/main" id="{CC8B72D1-F6D9-0D6A-160F-6747604DA249}"/>
+                </a:ext>
+              </a:extLst>
+            </p:cNvPr>
+            <p:cNvPicPr>
+              <a:picLocks noChangeAspect="1" noChangeArrowheads="1"/>
+            </p:cNvPicPr>
+            <p:nvPr/>
+          </p:nvPicPr>
+          <p:blipFill rotWithShape="1">
+            <a:blip r:embed="rId15">
+              <a:extLst>
+                <a:ext uri="{28A0092B-C50C-407E-A947-70E740481C1C}">
+                  <a14:useLocalDpi xmlns:a14="http://schemas.microsoft.com/office/drawing/2010/main" val="0"/>
+                </a:ext>
+              </a:extLst>
+            </a:blip>
+            <a:srcRect l="20806" t="14492" r="21220" b="15205"/>
+            <a:stretch/>
+          </p:blipFill>
+          <p:spPr bwMode="auto">
+            <a:xfrm>
+              <a:off x="4749318" y="4500457"/>
+              <a:ext cx="457426" cy="554714"/>
+            </a:xfrm>
+            <a:prstGeom prst="rect">
+              <a:avLst/>
+            </a:prstGeom>
+            <a:noFill/>
+            <a:extLst>
+              <a:ext uri="{909E8E84-426E-40DD-AFC4-6F175D3DCCD1}">
+                <a14:hiddenFill xmlns:a14="http://schemas.microsoft.com/office/drawing/2010/main">
+                  <a:solidFill>
+                    <a:srgbClr val="FFFFFF"/>
+                  </a:solidFill>
+                </a14:hiddenFill>
+              </a:ext>
+            </a:extLst>
+          </p:spPr>
+        </p:pic>
+      </p:grpSp>
+      <p:grpSp>
+        <p:nvGrpSpPr>
+          <p:cNvPr id="160" name="Group 159">
+            <a:extLst>
+              <a:ext uri="{FF2B5EF4-FFF2-40B4-BE49-F238E27FC236}">
+                <a16:creationId xmlns:a16="http://schemas.microsoft.com/office/drawing/2014/main" id="{B43878E5-98CF-4B37-B8F2-CDF8BD9D1855}"/>
+              </a:ext>
+            </a:extLst>
+          </p:cNvPr>
+          <p:cNvGrpSpPr/>
+          <p:nvPr/>
+        </p:nvGrpSpPr>
+        <p:grpSpPr>
+          <a:xfrm>
+            <a:off x="9400072" y="1989758"/>
+            <a:ext cx="1371600" cy="1371600"/>
+            <a:chOff x="213377" y="483633"/>
+            <a:chExt cx="1371600" cy="1371600"/>
+          </a:xfrm>
+        </p:grpSpPr>
+        <p:sp>
+          <p:nvSpPr>
+            <p:cNvPr id="161" name="Rectangle 160">
+              <a:extLst>
+                <a:ext uri="{FF2B5EF4-FFF2-40B4-BE49-F238E27FC236}">
+                  <a16:creationId xmlns:a16="http://schemas.microsoft.com/office/drawing/2014/main" id="{E0D51FF4-706D-F88A-6972-348AAEF50E36}"/>
+                </a:ext>
+              </a:extLst>
+            </p:cNvPr>
+            <p:cNvSpPr/>
+            <p:nvPr/>
+          </p:nvSpPr>
+          <p:spPr>
+            <a:xfrm>
+              <a:off x="213377" y="483633"/>
+              <a:ext cx="1371600" cy="1371600"/>
+            </a:xfrm>
+            <a:prstGeom prst="rect">
+              <a:avLst/>
+            </a:prstGeom>
+            <a:noFill/>
+            <a:ln w="76200">
+              <a:solidFill>
+                <a:schemeClr val="tx1"/>
+              </a:solidFill>
+            </a:ln>
+          </p:spPr>
+          <p:style>
+            <a:lnRef idx="2">
+              <a:schemeClr val="accent1">
+                <a:shade val="50000"/>
+              </a:schemeClr>
+            </a:lnRef>
+            <a:fillRef idx="1">
+              <a:schemeClr val="accent1"/>
+            </a:fillRef>
+            <a:effectRef idx="0">
+              <a:schemeClr val="accent1"/>
+            </a:effectRef>
+            <a:fontRef idx="minor">
+              <a:schemeClr val="lt1"/>
+            </a:fontRef>
+          </p:style>
+          <p:txBody>
+            <a:bodyPr rtlCol="0" anchor="ctr"/>
+            <a:lstStyle/>
+            <a:p>
+              <a:pPr algn="ctr"/>
+              <a:endParaRPr lang="en-US"/>
+            </a:p>
+          </p:txBody>
+        </p:sp>
+        <p:sp>
+          <p:nvSpPr>
+            <p:cNvPr id="162" name="Hexagon 161">
+              <a:extLst>
+                <a:ext uri="{FF2B5EF4-FFF2-40B4-BE49-F238E27FC236}">
+                  <a16:creationId xmlns:a16="http://schemas.microsoft.com/office/drawing/2014/main" id="{4CFE4FAE-EEF3-BC9D-0EC4-488B22A1B829}"/>
+                </a:ext>
+              </a:extLst>
+            </p:cNvPr>
+            <p:cNvSpPr/>
+            <p:nvPr/>
+          </p:nvSpPr>
+          <p:spPr>
+            <a:xfrm>
+              <a:off x="304817" y="699533"/>
+              <a:ext cx="1188720" cy="1097280"/>
+            </a:xfrm>
+            <a:prstGeom prst="hexagon">
+              <a:avLst/>
+            </a:prstGeom>
+            <a:noFill/>
+            <a:ln w="38100" cap="flat" cmpd="sng" algn="ctr">
+              <a:solidFill>
+                <a:schemeClr val="dk1"/>
+              </a:solidFill>
+              <a:prstDash val="solid"/>
+              <a:round/>
+              <a:headEnd type="none" w="med" len="med"/>
+              <a:tailEnd type="none" w="med" len="med"/>
+            </a:ln>
+          </p:spPr>
+          <p:style>
+            <a:lnRef idx="0">
+              <a:scrgbClr r="0" g="0" b="0"/>
+            </a:lnRef>
+            <a:fillRef idx="0">
+              <a:scrgbClr r="0" g="0" b="0"/>
+            </a:fillRef>
+            <a:effectRef idx="0">
+              <a:scrgbClr r="0" g="0" b="0"/>
+            </a:effectRef>
+            <a:fontRef idx="minor">
+              <a:schemeClr val="dk1"/>
+            </a:fontRef>
+          </p:style>
+          <p:txBody>
+            <a:bodyPr rtlCol="0" anchor="ctr"/>
+            <a:lstStyle/>
+            <a:p>
+              <a:pPr algn="ctr"/>
+              <a:endParaRPr lang="en-US"/>
+            </a:p>
+          </p:txBody>
+        </p:sp>
+      </p:grpSp>
+      <p:grpSp>
+        <p:nvGrpSpPr>
+          <p:cNvPr id="169" name="Group 168">
+            <a:extLst>
+              <a:ext uri="{FF2B5EF4-FFF2-40B4-BE49-F238E27FC236}">
+                <a16:creationId xmlns:a16="http://schemas.microsoft.com/office/drawing/2014/main" id="{8C792F6F-2794-BC9E-E550-6B4CFAD5CAE2}"/>
+              </a:ext>
+            </a:extLst>
+          </p:cNvPr>
+          <p:cNvGrpSpPr/>
+          <p:nvPr/>
+        </p:nvGrpSpPr>
+        <p:grpSpPr>
+          <a:xfrm>
+            <a:off x="4815085" y="1981700"/>
+            <a:ext cx="1371600" cy="1371600"/>
+            <a:chOff x="213377" y="483633"/>
+            <a:chExt cx="1371600" cy="1371600"/>
+          </a:xfrm>
+        </p:grpSpPr>
+        <p:sp>
+          <p:nvSpPr>
+            <p:cNvPr id="170" name="Rectangle 169">
+              <a:extLst>
+                <a:ext uri="{FF2B5EF4-FFF2-40B4-BE49-F238E27FC236}">
+                  <a16:creationId xmlns:a16="http://schemas.microsoft.com/office/drawing/2014/main" id="{0BB65367-9733-0F8A-66A3-02C8A0992CF3}"/>
+                </a:ext>
+              </a:extLst>
+            </p:cNvPr>
+            <p:cNvSpPr/>
+            <p:nvPr/>
+          </p:nvSpPr>
+          <p:spPr>
+            <a:xfrm>
+              <a:off x="213377" y="483633"/>
+              <a:ext cx="1371600" cy="1371600"/>
+            </a:xfrm>
+            <a:prstGeom prst="rect">
+              <a:avLst/>
+            </a:prstGeom>
+            <a:noFill/>
+            <a:ln w="76200">
+              <a:solidFill>
+                <a:schemeClr val="tx1"/>
+              </a:solidFill>
+            </a:ln>
+          </p:spPr>
+          <p:style>
+            <a:lnRef idx="2">
+              <a:schemeClr val="accent1">
+                <a:shade val="50000"/>
+              </a:schemeClr>
+            </a:lnRef>
+            <a:fillRef idx="1">
+              <a:schemeClr val="accent1"/>
+            </a:fillRef>
+            <a:effectRef idx="0">
+              <a:schemeClr val="accent1"/>
+            </a:effectRef>
+            <a:fontRef idx="minor">
+              <a:schemeClr val="lt1"/>
+            </a:fontRef>
+          </p:style>
+          <p:txBody>
+            <a:bodyPr rtlCol="0" anchor="ctr"/>
+            <a:lstStyle/>
+            <a:p>
+              <a:pPr algn="ctr"/>
+              <a:endParaRPr lang="en-US"/>
+            </a:p>
+          </p:txBody>
+        </p:sp>
+        <p:sp>
+          <p:nvSpPr>
+            <p:cNvPr id="171" name="Hexagon 170">
+              <a:extLst>
+                <a:ext uri="{FF2B5EF4-FFF2-40B4-BE49-F238E27FC236}">
+                  <a16:creationId xmlns:a16="http://schemas.microsoft.com/office/drawing/2014/main" id="{276D7142-C4FF-0C0B-DF5A-A289805CC05A}"/>
+                </a:ext>
+              </a:extLst>
+            </p:cNvPr>
+            <p:cNvSpPr/>
+            <p:nvPr/>
+          </p:nvSpPr>
+          <p:spPr>
+            <a:xfrm>
+              <a:off x="304817" y="699533"/>
+              <a:ext cx="1188720" cy="1097280"/>
+            </a:xfrm>
+            <a:prstGeom prst="hexagon">
+              <a:avLst/>
+            </a:prstGeom>
+            <a:noFill/>
+            <a:ln w="38100" cap="flat" cmpd="sng" algn="ctr">
+              <a:solidFill>
+                <a:schemeClr val="dk1"/>
+              </a:solidFill>
+              <a:prstDash val="solid"/>
+              <a:round/>
+              <a:headEnd type="none" w="med" len="med"/>
+              <a:tailEnd type="none" w="med" len="med"/>
+            </a:ln>
+          </p:spPr>
+          <p:style>
+            <a:lnRef idx="0">
+              <a:scrgbClr r="0" g="0" b="0"/>
+            </a:lnRef>
+            <a:fillRef idx="0">
+              <a:scrgbClr r="0" g="0" b="0"/>
+            </a:fillRef>
+            <a:effectRef idx="0">
+              <a:scrgbClr r="0" g="0" b="0"/>
+            </a:effectRef>
+            <a:fontRef idx="minor">
+              <a:schemeClr val="dk1"/>
+            </a:fontRef>
+          </p:style>
+          <p:txBody>
+            <a:bodyPr rtlCol="0" anchor="ctr"/>
+            <a:lstStyle/>
+            <a:p>
+              <a:pPr algn="ctr"/>
+              <a:endParaRPr lang="en-US"/>
+            </a:p>
+          </p:txBody>
+        </p:sp>
+      </p:grpSp>
+      <p:grpSp>
+        <p:nvGrpSpPr>
+          <p:cNvPr id="48" name="Group 47">
+            <a:extLst>
+              <a:ext uri="{FF2B5EF4-FFF2-40B4-BE49-F238E27FC236}">
+                <a16:creationId xmlns:a16="http://schemas.microsoft.com/office/drawing/2014/main" id="{2554C6E6-CCBB-5FC2-E67D-1BB567678D8A}"/>
+              </a:ext>
+            </a:extLst>
+          </p:cNvPr>
+          <p:cNvGrpSpPr/>
+          <p:nvPr/>
+        </p:nvGrpSpPr>
+        <p:grpSpPr>
+          <a:xfrm>
+            <a:off x="5217087" y="2364783"/>
+            <a:ext cx="620585" cy="764796"/>
+            <a:chOff x="4499391" y="4049383"/>
+            <a:chExt cx="620585" cy="764796"/>
+          </a:xfrm>
+        </p:grpSpPr>
+        <p:pic>
+          <p:nvPicPr>
+            <p:cNvPr id="165" name="Picture 164">
+              <a:extLst>
+                <a:ext uri="{FF2B5EF4-FFF2-40B4-BE49-F238E27FC236}">
+                  <a16:creationId xmlns:a16="http://schemas.microsoft.com/office/drawing/2014/main" id="{830EEBDB-A77D-90B4-6B8D-BE102247A273}"/>
+                </a:ext>
+              </a:extLst>
+            </p:cNvPr>
+            <p:cNvPicPr>
+              <a:picLocks noChangeAspect="1"/>
+            </p:cNvPicPr>
+            <p:nvPr/>
+          </p:nvPicPr>
+          <p:blipFill rotWithShape="1">
+            <a:blip r:embed="rId11"/>
+            <a:srcRect b="61242"/>
+            <a:stretch/>
+          </p:blipFill>
+          <p:spPr>
+            <a:xfrm>
+              <a:off x="4499391" y="4554822"/>
+              <a:ext cx="620585" cy="259357"/>
+            </a:xfrm>
+            <a:prstGeom prst="rect">
+              <a:avLst/>
+            </a:prstGeom>
+          </p:spPr>
+        </p:pic>
+        <p:cxnSp>
+          <p:nvCxnSpPr>
+            <p:cNvPr id="41" name="Straight Connector 40">
+              <a:extLst>
+                <a:ext uri="{FF2B5EF4-FFF2-40B4-BE49-F238E27FC236}">
+                  <a16:creationId xmlns:a16="http://schemas.microsoft.com/office/drawing/2014/main" id="{0085D065-2E80-77ED-5A99-8C01BA06CF01}"/>
+                </a:ext>
+              </a:extLst>
+            </p:cNvPr>
+            <p:cNvCxnSpPr/>
+            <p:nvPr/>
+          </p:nvCxnSpPr>
+          <p:spPr>
+            <a:xfrm>
+              <a:off x="4515303" y="4499465"/>
+              <a:ext cx="559445" cy="0"/>
+            </a:xfrm>
+            <a:prstGeom prst="line">
+              <a:avLst/>
+            </a:prstGeom>
+            <a:ln w="57150"/>
+          </p:spPr>
+          <p:style>
+            <a:lnRef idx="1">
+              <a:schemeClr val="dk1"/>
+            </a:lnRef>
+            <a:fillRef idx="0">
+              <a:schemeClr val="dk1"/>
+            </a:fillRef>
+            <a:effectRef idx="0">
+              <a:schemeClr val="dk1"/>
+            </a:effectRef>
+            <a:fontRef idx="minor">
+              <a:schemeClr val="tx1"/>
+            </a:fontRef>
+          </p:style>
+        </p:cxnSp>
+        <p:grpSp>
+          <p:nvGrpSpPr>
+            <p:cNvPr id="47" name="Group 46">
+              <a:extLst>
+                <a:ext uri="{FF2B5EF4-FFF2-40B4-BE49-F238E27FC236}">
+                  <a16:creationId xmlns:a16="http://schemas.microsoft.com/office/drawing/2014/main" id="{60527379-96D2-CE28-4F86-0340B8C35EB3}"/>
+                </a:ext>
+              </a:extLst>
+            </p:cNvPr>
+            <p:cNvGrpSpPr/>
+            <p:nvPr/>
+          </p:nvGrpSpPr>
+          <p:grpSpPr>
+            <a:xfrm>
+              <a:off x="4570381" y="4049383"/>
+              <a:ext cx="470893" cy="413068"/>
+              <a:chOff x="4444742" y="3810843"/>
+              <a:chExt cx="470893" cy="413068"/>
+            </a:xfrm>
+          </p:grpSpPr>
+          <p:sp>
+            <p:nvSpPr>
+              <p:cNvPr id="166" name="Oval 165">
+                <a:extLst>
+                  <a:ext uri="{FF2B5EF4-FFF2-40B4-BE49-F238E27FC236}">
+                    <a16:creationId xmlns:a16="http://schemas.microsoft.com/office/drawing/2014/main" id="{76A9F0CE-ECE4-F39B-CB99-0B9E8F459E86}"/>
+                  </a:ext>
+                </a:extLst>
+              </p:cNvPr>
+              <p:cNvSpPr/>
+              <p:nvPr/>
+            </p:nvSpPr>
+            <p:spPr>
+              <a:xfrm>
+                <a:off x="4523150" y="3945507"/>
+                <a:ext cx="141122" cy="141122"/>
+              </a:xfrm>
+              <a:prstGeom prst="ellipse">
+                <a:avLst/>
+              </a:prstGeom>
+            </p:spPr>
+            <p:style>
+              <a:lnRef idx="2">
+                <a:schemeClr val="dk1">
+                  <a:shade val="50000"/>
+                </a:schemeClr>
+              </a:lnRef>
+              <a:fillRef idx="1">
+                <a:schemeClr val="dk1"/>
+              </a:fillRef>
+              <a:effectRef idx="0">
+                <a:schemeClr val="dk1"/>
+              </a:effectRef>
+              <a:fontRef idx="minor">
+                <a:schemeClr val="lt1"/>
+              </a:fontRef>
+            </p:style>
+            <p:txBody>
+              <a:bodyPr rtlCol="0" anchor="ctr"/>
+              <a:lstStyle/>
+              <a:p>
+                <a:pPr algn="ctr"/>
+                <a:endParaRPr lang="en-US"/>
+              </a:p>
+            </p:txBody>
+          </p:sp>
+          <p:sp>
+            <p:nvSpPr>
+              <p:cNvPr id="167" name="Oval 166">
+                <a:extLst>
+                  <a:ext uri="{FF2B5EF4-FFF2-40B4-BE49-F238E27FC236}">
+                    <a16:creationId xmlns:a16="http://schemas.microsoft.com/office/drawing/2014/main" id="{673F00E2-71D1-FE6F-6D45-A0AD4B85C29D}"/>
+                  </a:ext>
+                </a:extLst>
+              </p:cNvPr>
+              <p:cNvSpPr/>
+              <p:nvPr/>
+            </p:nvSpPr>
+            <p:spPr>
+              <a:xfrm>
+                <a:off x="4444742" y="4078949"/>
+                <a:ext cx="141122" cy="141122"/>
+              </a:xfrm>
+              <a:prstGeom prst="ellipse">
+                <a:avLst/>
+              </a:prstGeom>
+            </p:spPr>
+            <p:style>
+              <a:lnRef idx="2">
+                <a:schemeClr val="dk1">
+                  <a:shade val="50000"/>
+                </a:schemeClr>
+              </a:lnRef>
+              <a:fillRef idx="1">
+                <a:schemeClr val="dk1"/>
+              </a:fillRef>
+              <a:effectRef idx="0">
+                <a:schemeClr val="dk1"/>
+              </a:effectRef>
+              <a:fontRef idx="minor">
+                <a:schemeClr val="lt1"/>
+              </a:fontRef>
+            </p:style>
+            <p:txBody>
+              <a:bodyPr rtlCol="0" anchor="ctr"/>
+              <a:lstStyle/>
+              <a:p>
+                <a:pPr algn="ctr"/>
+                <a:endParaRPr lang="en-US"/>
+              </a:p>
+            </p:txBody>
+          </p:sp>
+          <p:sp>
+            <p:nvSpPr>
+              <p:cNvPr id="168" name="Oval 167">
+                <a:extLst>
+                  <a:ext uri="{FF2B5EF4-FFF2-40B4-BE49-F238E27FC236}">
+                    <a16:creationId xmlns:a16="http://schemas.microsoft.com/office/drawing/2014/main" id="{D78CAD1E-7669-F911-158A-AF8FE32C59D6}"/>
+                  </a:ext>
+                </a:extLst>
+              </p:cNvPr>
+              <p:cNvSpPr/>
+              <p:nvPr/>
+            </p:nvSpPr>
+            <p:spPr>
+              <a:xfrm>
+                <a:off x="4601558" y="4082789"/>
+                <a:ext cx="141122" cy="141122"/>
+              </a:xfrm>
+              <a:prstGeom prst="ellipse">
+                <a:avLst/>
+              </a:prstGeom>
+            </p:spPr>
+            <p:style>
+              <a:lnRef idx="2">
+                <a:schemeClr val="dk1">
+                  <a:shade val="50000"/>
+                </a:schemeClr>
+              </a:lnRef>
+              <a:fillRef idx="1">
+                <a:schemeClr val="dk1"/>
+              </a:fillRef>
+              <a:effectRef idx="0">
+                <a:schemeClr val="dk1"/>
+              </a:effectRef>
+              <a:fontRef idx="minor">
+                <a:schemeClr val="lt1"/>
+              </a:fontRef>
+            </p:style>
+            <p:txBody>
+              <a:bodyPr rtlCol="0" anchor="ctr"/>
+              <a:lstStyle/>
+              <a:p>
+                <a:pPr algn="ctr"/>
+                <a:endParaRPr lang="en-US"/>
+              </a:p>
+            </p:txBody>
+          </p:sp>
+          <p:sp>
+            <p:nvSpPr>
+              <p:cNvPr id="172" name="Oval 171">
+                <a:extLst>
+                  <a:ext uri="{FF2B5EF4-FFF2-40B4-BE49-F238E27FC236}">
+                    <a16:creationId xmlns:a16="http://schemas.microsoft.com/office/drawing/2014/main" id="{5EE8A70B-81C2-2328-84D2-2919FC209D49}"/>
+                  </a:ext>
+                </a:extLst>
+              </p:cNvPr>
+              <p:cNvSpPr/>
+              <p:nvPr/>
+            </p:nvSpPr>
+            <p:spPr>
+              <a:xfrm>
+                <a:off x="4606756" y="3810843"/>
+                <a:ext cx="141122" cy="141122"/>
+              </a:xfrm>
+              <a:prstGeom prst="ellipse">
+                <a:avLst/>
+              </a:prstGeom>
+            </p:spPr>
+            <p:style>
+              <a:lnRef idx="2">
+                <a:schemeClr val="dk1">
+                  <a:shade val="50000"/>
+                </a:schemeClr>
+              </a:lnRef>
+              <a:fillRef idx="1">
+                <a:schemeClr val="dk1"/>
+              </a:fillRef>
+              <a:effectRef idx="0">
+                <a:schemeClr val="dk1"/>
+              </a:effectRef>
+              <a:fontRef idx="minor">
+                <a:schemeClr val="lt1"/>
+              </a:fontRef>
+            </p:style>
+            <p:txBody>
+              <a:bodyPr rtlCol="0" anchor="ctr"/>
+              <a:lstStyle/>
+              <a:p>
+                <a:pPr algn="ctr"/>
+                <a:endParaRPr lang="en-US"/>
+              </a:p>
+            </p:txBody>
+          </p:sp>
+          <p:sp>
+            <p:nvSpPr>
+              <p:cNvPr id="173" name="Oval 172">
+                <a:extLst>
+                  <a:ext uri="{FF2B5EF4-FFF2-40B4-BE49-F238E27FC236}">
+                    <a16:creationId xmlns:a16="http://schemas.microsoft.com/office/drawing/2014/main" id="{99B8CE09-2B9B-140C-F8D6-B863359BA236}"/>
+                  </a:ext>
+                </a:extLst>
+              </p:cNvPr>
+              <p:cNvSpPr/>
+              <p:nvPr/>
+            </p:nvSpPr>
+            <p:spPr>
+              <a:xfrm>
+                <a:off x="4774513" y="4078949"/>
+                <a:ext cx="141122" cy="141122"/>
+              </a:xfrm>
+              <a:prstGeom prst="ellipse">
+                <a:avLst/>
+              </a:prstGeom>
+            </p:spPr>
+            <p:style>
+              <a:lnRef idx="2">
+                <a:schemeClr val="dk1">
+                  <a:shade val="50000"/>
+                </a:schemeClr>
+              </a:lnRef>
+              <a:fillRef idx="1">
+                <a:schemeClr val="dk1"/>
+              </a:fillRef>
+              <a:effectRef idx="0">
+                <a:schemeClr val="dk1"/>
+              </a:effectRef>
+              <a:fontRef idx="minor">
+                <a:schemeClr val="lt1"/>
+              </a:fontRef>
+            </p:style>
+            <p:txBody>
+              <a:bodyPr rtlCol="0" anchor="ctr"/>
+              <a:lstStyle/>
+              <a:p>
+                <a:pPr algn="ctr"/>
+                <a:endParaRPr lang="en-US"/>
+              </a:p>
+            </p:txBody>
+          </p:sp>
+          <p:sp>
+            <p:nvSpPr>
+              <p:cNvPr id="174" name="Oval 173">
+                <a:extLst>
+                  <a:ext uri="{FF2B5EF4-FFF2-40B4-BE49-F238E27FC236}">
+                    <a16:creationId xmlns:a16="http://schemas.microsoft.com/office/drawing/2014/main" id="{880454FD-5D8A-665B-296E-11CF9BA7C82B}"/>
+                  </a:ext>
+                </a:extLst>
+              </p:cNvPr>
+              <p:cNvSpPr/>
+              <p:nvPr/>
+            </p:nvSpPr>
+            <p:spPr>
+              <a:xfrm>
+                <a:off x="4691529" y="3936760"/>
+                <a:ext cx="141122" cy="141122"/>
+              </a:xfrm>
+              <a:prstGeom prst="ellipse">
+                <a:avLst/>
+              </a:prstGeom>
+            </p:spPr>
+            <p:style>
+              <a:lnRef idx="2">
+                <a:schemeClr val="dk1">
+                  <a:shade val="50000"/>
+                </a:schemeClr>
+              </a:lnRef>
+              <a:fillRef idx="1">
+                <a:schemeClr val="dk1"/>
+              </a:fillRef>
+              <a:effectRef idx="0">
+                <a:schemeClr val="dk1"/>
+              </a:effectRef>
+              <a:fontRef idx="minor">
+                <a:schemeClr val="lt1"/>
+              </a:fontRef>
+            </p:style>
+            <p:txBody>
+              <a:bodyPr rtlCol="0" anchor="ctr"/>
+              <a:lstStyle/>
+              <a:p>
+                <a:pPr algn="ctr"/>
+                <a:endParaRPr lang="en-US"/>
+              </a:p>
+            </p:txBody>
+          </p:sp>
+        </p:grpSp>
+      </p:grpSp>
+      <p:grpSp>
+        <p:nvGrpSpPr>
+          <p:cNvPr id="175" name="Group 174">
+            <a:extLst>
+              <a:ext uri="{FF2B5EF4-FFF2-40B4-BE49-F238E27FC236}">
+                <a16:creationId xmlns:a16="http://schemas.microsoft.com/office/drawing/2014/main" id="{8FAF9396-85AE-3734-56E8-B32BC8C2727D}"/>
+              </a:ext>
+            </a:extLst>
+          </p:cNvPr>
+          <p:cNvGrpSpPr/>
+          <p:nvPr/>
+        </p:nvGrpSpPr>
+        <p:grpSpPr>
+          <a:xfrm>
+            <a:off x="5110830" y="3967502"/>
+            <a:ext cx="839398" cy="777453"/>
+            <a:chOff x="4849013" y="3586270"/>
+            <a:chExt cx="2288278" cy="2119411"/>
+          </a:xfrm>
+        </p:grpSpPr>
+        <p:pic>
+          <p:nvPicPr>
+            <p:cNvPr id="176" name="Picture 4" descr="2,174 Hornet Vector Illustrations &amp; Clip Art - iStock">
+              <a:extLst>
+                <a:ext uri="{FF2B5EF4-FFF2-40B4-BE49-F238E27FC236}">
+                  <a16:creationId xmlns:a16="http://schemas.microsoft.com/office/drawing/2014/main" id="{0D55E502-6B3E-16A2-CDB5-58735A9EFF86}"/>
+                </a:ext>
+              </a:extLst>
+            </p:cNvPr>
+            <p:cNvPicPr>
+              <a:picLocks noChangeAspect="1" noChangeArrowheads="1"/>
+            </p:cNvPicPr>
+            <p:nvPr/>
+          </p:nvPicPr>
+          <p:blipFill rotWithShape="1">
+            <a:blip r:embed="rId15">
+              <a:extLst>
+                <a:ext uri="{28A0092B-C50C-407E-A947-70E740481C1C}">
+                  <a14:useLocalDpi xmlns:a14="http://schemas.microsoft.com/office/drawing/2010/main" val="0"/>
+                </a:ext>
+              </a:extLst>
+            </a:blip>
+            <a:srcRect l="20806" t="14492" r="21220" b="15205"/>
+            <a:stretch/>
+          </p:blipFill>
+          <p:spPr bwMode="auto">
+            <a:xfrm>
+              <a:off x="5890304" y="4193477"/>
+              <a:ext cx="1246987" cy="1512204"/>
+            </a:xfrm>
+            <a:prstGeom prst="rect">
+              <a:avLst/>
+            </a:prstGeom>
+            <a:noFill/>
+            <a:extLst>
+              <a:ext uri="{909E8E84-426E-40DD-AFC4-6F175D3DCCD1}">
+                <a14:hiddenFill xmlns:a14="http://schemas.microsoft.com/office/drawing/2010/main">
+                  <a:solidFill>
+                    <a:srgbClr val="FFFFFF"/>
+                  </a:solidFill>
+                </a14:hiddenFill>
+              </a:ext>
+            </a:extLst>
+          </p:spPr>
+        </p:pic>
+        <p:pic>
+          <p:nvPicPr>
+            <p:cNvPr id="177" name="Picture 4" descr="2,174 Hornet Vector Illustrations &amp; Clip Art - iStock">
+              <a:extLst>
+                <a:ext uri="{FF2B5EF4-FFF2-40B4-BE49-F238E27FC236}">
+                  <a16:creationId xmlns:a16="http://schemas.microsoft.com/office/drawing/2014/main" id="{1F39564A-F17A-4B9B-C007-4BC1A72F69E0}"/>
+                </a:ext>
+              </a:extLst>
+            </p:cNvPr>
+            <p:cNvPicPr>
+              <a:picLocks noChangeAspect="1" noChangeArrowheads="1"/>
+            </p:cNvPicPr>
+            <p:nvPr/>
+          </p:nvPicPr>
+          <p:blipFill rotWithShape="1">
+            <a:blip r:embed="rId15">
+              <a:extLst>
+                <a:ext uri="{28A0092B-C50C-407E-A947-70E740481C1C}">
+                  <a14:useLocalDpi xmlns:a14="http://schemas.microsoft.com/office/drawing/2010/main" val="0"/>
+                </a:ext>
+              </a:extLst>
+            </a:blip>
+            <a:srcRect l="20806" t="14492" r="21220" b="15205"/>
+            <a:stretch/>
+          </p:blipFill>
+          <p:spPr bwMode="auto">
+            <a:xfrm>
+              <a:off x="4849013" y="3586270"/>
+              <a:ext cx="1246987" cy="1512204"/>
+            </a:xfrm>
+            <a:prstGeom prst="rect">
+              <a:avLst/>
+            </a:prstGeom>
+            <a:noFill/>
+            <a:extLst>
+              <a:ext uri="{909E8E84-426E-40DD-AFC4-6F175D3DCCD1}">
+                <a14:hiddenFill xmlns:a14="http://schemas.microsoft.com/office/drawing/2010/main">
+                  <a:solidFill>
+                    <a:srgbClr val="FFFFFF"/>
+                  </a:solidFill>
+                </a14:hiddenFill>
+              </a:ext>
+            </a:extLst>
+          </p:spPr>
+        </p:pic>
+      </p:grpSp>
+      <p:grpSp>
+        <p:nvGrpSpPr>
+          <p:cNvPr id="178" name="Group 177">
+            <a:extLst>
+              <a:ext uri="{FF2B5EF4-FFF2-40B4-BE49-F238E27FC236}">
+                <a16:creationId xmlns:a16="http://schemas.microsoft.com/office/drawing/2014/main" id="{8928B253-53AD-5D9F-7735-3F8C87B3587B}"/>
+              </a:ext>
+            </a:extLst>
+          </p:cNvPr>
+          <p:cNvGrpSpPr/>
+          <p:nvPr/>
+        </p:nvGrpSpPr>
+        <p:grpSpPr>
+          <a:xfrm>
+            <a:off x="4849594" y="3484353"/>
+            <a:ext cx="1371600" cy="1371600"/>
+            <a:chOff x="213377" y="483633"/>
+            <a:chExt cx="1371600" cy="1371600"/>
+          </a:xfrm>
+        </p:grpSpPr>
+        <p:sp>
+          <p:nvSpPr>
+            <p:cNvPr id="179" name="Rectangle 178">
+              <a:extLst>
+                <a:ext uri="{FF2B5EF4-FFF2-40B4-BE49-F238E27FC236}">
+                  <a16:creationId xmlns:a16="http://schemas.microsoft.com/office/drawing/2014/main" id="{A34DDA84-63BE-0D8E-69B4-71642FD92D2E}"/>
+                </a:ext>
+              </a:extLst>
+            </p:cNvPr>
+            <p:cNvSpPr/>
+            <p:nvPr/>
+          </p:nvSpPr>
+          <p:spPr>
+            <a:xfrm>
+              <a:off x="213377" y="483633"/>
+              <a:ext cx="1371600" cy="1371600"/>
+            </a:xfrm>
+            <a:prstGeom prst="rect">
+              <a:avLst/>
+            </a:prstGeom>
+            <a:noFill/>
+            <a:ln w="76200">
+              <a:solidFill>
+                <a:schemeClr val="tx1"/>
+              </a:solidFill>
+            </a:ln>
+          </p:spPr>
+          <p:style>
+            <a:lnRef idx="2">
+              <a:schemeClr val="accent1">
+                <a:shade val="50000"/>
+              </a:schemeClr>
+            </a:lnRef>
+            <a:fillRef idx="1">
+              <a:schemeClr val="accent1"/>
+            </a:fillRef>
+            <a:effectRef idx="0">
+              <a:schemeClr val="accent1"/>
+            </a:effectRef>
+            <a:fontRef idx="minor">
+              <a:schemeClr val="lt1"/>
+            </a:fontRef>
+          </p:style>
+          <p:txBody>
+            <a:bodyPr rtlCol="0" anchor="ctr"/>
+            <a:lstStyle/>
+            <a:p>
+              <a:pPr algn="ctr"/>
+              <a:endParaRPr lang="en-US"/>
+            </a:p>
+          </p:txBody>
+        </p:sp>
+        <p:sp>
+          <p:nvSpPr>
+            <p:cNvPr id="180" name="Hexagon 179">
+              <a:extLst>
+                <a:ext uri="{FF2B5EF4-FFF2-40B4-BE49-F238E27FC236}">
+                  <a16:creationId xmlns:a16="http://schemas.microsoft.com/office/drawing/2014/main" id="{62557BC6-AF99-6B88-0163-8ECE0B286E19}"/>
+                </a:ext>
+              </a:extLst>
+            </p:cNvPr>
+            <p:cNvSpPr/>
+            <p:nvPr/>
+          </p:nvSpPr>
+          <p:spPr>
+            <a:xfrm>
+              <a:off x="304817" y="699533"/>
+              <a:ext cx="1188720" cy="1097280"/>
+            </a:xfrm>
+            <a:prstGeom prst="hexagon">
+              <a:avLst/>
+            </a:prstGeom>
+            <a:noFill/>
+            <a:ln w="38100" cap="flat" cmpd="sng" algn="ctr">
+              <a:solidFill>
+                <a:schemeClr val="dk1"/>
+              </a:solidFill>
+              <a:prstDash val="solid"/>
+              <a:round/>
+              <a:headEnd type="none" w="med" len="med"/>
+              <a:tailEnd type="none" w="med" len="med"/>
+            </a:ln>
+          </p:spPr>
+          <p:style>
+            <a:lnRef idx="0">
+              <a:scrgbClr r="0" g="0" b="0"/>
+            </a:lnRef>
+            <a:fillRef idx="0">
+              <a:scrgbClr r="0" g="0" b="0"/>
+            </a:fillRef>
+            <a:effectRef idx="0">
+              <a:scrgbClr r="0" g="0" b="0"/>
+            </a:effectRef>
+            <a:fontRef idx="minor">
+              <a:schemeClr val="dk1"/>
+            </a:fontRef>
+          </p:style>
+          <p:txBody>
+            <a:bodyPr rtlCol="0" anchor="ctr"/>
+            <a:lstStyle/>
+            <a:p>
+              <a:pPr algn="ctr"/>
+              <a:endParaRPr lang="en-US"/>
+            </a:p>
+          </p:txBody>
+        </p:sp>
+      </p:grpSp>
+      <p:grpSp>
+        <p:nvGrpSpPr>
+          <p:cNvPr id="50" name="Group 49">
+            <a:extLst>
+              <a:ext uri="{FF2B5EF4-FFF2-40B4-BE49-F238E27FC236}">
+                <a16:creationId xmlns:a16="http://schemas.microsoft.com/office/drawing/2014/main" id="{7EEB4497-93D6-00CC-5D21-783C7500EAA7}"/>
+              </a:ext>
+            </a:extLst>
+          </p:cNvPr>
+          <p:cNvGrpSpPr/>
+          <p:nvPr/>
+        </p:nvGrpSpPr>
+        <p:grpSpPr>
+          <a:xfrm>
+            <a:off x="5530253" y="3739395"/>
+            <a:ext cx="342792" cy="439439"/>
+            <a:chOff x="3657470" y="3702031"/>
+            <a:chExt cx="342792" cy="439439"/>
+          </a:xfrm>
+        </p:grpSpPr>
+        <p:sp>
+          <p:nvSpPr>
+            <p:cNvPr id="49" name="Cross 48">
+              <a:extLst>
+                <a:ext uri="{FF2B5EF4-FFF2-40B4-BE49-F238E27FC236}">
+                  <a16:creationId xmlns:a16="http://schemas.microsoft.com/office/drawing/2014/main" id="{4F947AA7-FE15-CA7E-6678-7EE237843B8E}"/>
+                </a:ext>
+              </a:extLst>
+            </p:cNvPr>
+            <p:cNvSpPr/>
+            <p:nvPr/>
+          </p:nvSpPr>
+          <p:spPr>
+            <a:xfrm>
+              <a:off x="3657470" y="3867150"/>
+              <a:ext cx="274320" cy="274320"/>
+            </a:xfrm>
+            <a:prstGeom prst="plus">
+              <a:avLst>
+                <a:gd name="adj" fmla="val 38889"/>
+              </a:avLst>
+            </a:prstGeom>
+          </p:spPr>
+          <p:style>
+            <a:lnRef idx="2">
+              <a:schemeClr val="dk1">
+                <a:shade val="50000"/>
+              </a:schemeClr>
+            </a:lnRef>
+            <a:fillRef idx="1">
+              <a:schemeClr val="dk1"/>
+            </a:fillRef>
+            <a:effectRef idx="0">
+              <a:schemeClr val="dk1"/>
+            </a:effectRef>
+            <a:fontRef idx="minor">
+              <a:schemeClr val="lt1"/>
+            </a:fontRef>
+          </p:style>
+          <p:txBody>
+            <a:bodyPr rtlCol="0" anchor="ctr"/>
+            <a:lstStyle/>
+            <a:p>
+              <a:pPr algn="ctr"/>
+              <a:endParaRPr lang="en-US"/>
+            </a:p>
+          </p:txBody>
+        </p:sp>
+        <p:sp>
+          <p:nvSpPr>
+            <p:cNvPr id="181" name="Cross 180">
+              <a:extLst>
+                <a:ext uri="{FF2B5EF4-FFF2-40B4-BE49-F238E27FC236}">
+                  <a16:creationId xmlns:a16="http://schemas.microsoft.com/office/drawing/2014/main" id="{105937BB-CFA8-0C83-431B-AF9FAA8B4A9C}"/>
+                </a:ext>
+              </a:extLst>
+            </p:cNvPr>
+            <p:cNvSpPr/>
+            <p:nvPr/>
+          </p:nvSpPr>
+          <p:spPr>
+            <a:xfrm>
+              <a:off x="3808015" y="3702031"/>
+              <a:ext cx="192247" cy="192247"/>
+            </a:xfrm>
+            <a:prstGeom prst="plus">
+              <a:avLst>
+                <a:gd name="adj" fmla="val 38889"/>
+              </a:avLst>
+            </a:prstGeom>
+          </p:spPr>
+          <p:style>
+            <a:lnRef idx="2">
+              <a:schemeClr val="dk1">
+                <a:shade val="50000"/>
+              </a:schemeClr>
+            </a:lnRef>
+            <a:fillRef idx="1">
+              <a:schemeClr val="dk1"/>
+            </a:fillRef>
+            <a:effectRef idx="0">
+              <a:schemeClr val="dk1"/>
+            </a:effectRef>
+            <a:fontRef idx="minor">
+              <a:schemeClr val="lt1"/>
             </a:fontRef>
           </p:style>
           <p:txBody>

</xml_diff>

<commit_message>
Brood can be auto cast
</commit_message>
<xml_diff>
--- a/image process/drawings sifi.pptx
+++ b/image process/drawings sifi.pptx
@@ -200,7 +200,7 @@
           <a:p>
             <a:fld id="{7700C406-2328-4788-AE79-437B6607AD22}" type="datetimeFigureOut">
               <a:rPr lang="en-US" smtClean="0"/>
-              <a:t>6/16/2022</a:t>
+              <a:t>6/19/2022</a:t>
             </a:fld>
             <a:endParaRPr lang="en-US"/>
           </a:p>
@@ -614,7 +614,7 @@
           <a:p>
             <a:fld id="{9EC8CD53-0620-48F2-A3BB-2B10BDA60E52}" type="datetimeFigureOut">
               <a:rPr lang="en-US" smtClean="0"/>
-              <a:t>6/16/2022</a:t>
+              <a:t>6/19/2022</a:t>
             </a:fld>
             <a:endParaRPr lang="en-US"/>
           </a:p>
@@ -812,7 +812,7 @@
           <a:p>
             <a:fld id="{9EC8CD53-0620-48F2-A3BB-2B10BDA60E52}" type="datetimeFigureOut">
               <a:rPr lang="en-US" smtClean="0"/>
-              <a:t>6/16/2022</a:t>
+              <a:t>6/19/2022</a:t>
             </a:fld>
             <a:endParaRPr lang="en-US"/>
           </a:p>
@@ -1020,7 +1020,7 @@
           <a:p>
             <a:fld id="{9EC8CD53-0620-48F2-A3BB-2B10BDA60E52}" type="datetimeFigureOut">
               <a:rPr lang="en-US" smtClean="0"/>
-              <a:t>6/16/2022</a:t>
+              <a:t>6/19/2022</a:t>
             </a:fld>
             <a:endParaRPr lang="en-US"/>
           </a:p>
@@ -1218,7 +1218,7 @@
           <a:p>
             <a:fld id="{9EC8CD53-0620-48F2-A3BB-2B10BDA60E52}" type="datetimeFigureOut">
               <a:rPr lang="en-US" smtClean="0"/>
-              <a:t>6/16/2022</a:t>
+              <a:t>6/19/2022</a:t>
             </a:fld>
             <a:endParaRPr lang="en-US"/>
           </a:p>
@@ -1493,7 +1493,7 @@
           <a:p>
             <a:fld id="{9EC8CD53-0620-48F2-A3BB-2B10BDA60E52}" type="datetimeFigureOut">
               <a:rPr lang="en-US" smtClean="0"/>
-              <a:t>6/16/2022</a:t>
+              <a:t>6/19/2022</a:t>
             </a:fld>
             <a:endParaRPr lang="en-US"/>
           </a:p>
@@ -1758,7 +1758,7 @@
           <a:p>
             <a:fld id="{9EC8CD53-0620-48F2-A3BB-2B10BDA60E52}" type="datetimeFigureOut">
               <a:rPr lang="en-US" smtClean="0"/>
-              <a:t>6/16/2022</a:t>
+              <a:t>6/19/2022</a:t>
             </a:fld>
             <a:endParaRPr lang="en-US"/>
           </a:p>
@@ -2170,7 +2170,7 @@
           <a:p>
             <a:fld id="{9EC8CD53-0620-48F2-A3BB-2B10BDA60E52}" type="datetimeFigureOut">
               <a:rPr lang="en-US" smtClean="0"/>
-              <a:t>6/16/2022</a:t>
+              <a:t>6/19/2022</a:t>
             </a:fld>
             <a:endParaRPr lang="en-US"/>
           </a:p>
@@ -2311,7 +2311,7 @@
           <a:p>
             <a:fld id="{9EC8CD53-0620-48F2-A3BB-2B10BDA60E52}" type="datetimeFigureOut">
               <a:rPr lang="en-US" smtClean="0"/>
-              <a:t>6/16/2022</a:t>
+              <a:t>6/19/2022</a:t>
             </a:fld>
             <a:endParaRPr lang="en-US"/>
           </a:p>
@@ -2424,7 +2424,7 @@
           <a:p>
             <a:fld id="{9EC8CD53-0620-48F2-A3BB-2B10BDA60E52}" type="datetimeFigureOut">
               <a:rPr lang="en-US" smtClean="0"/>
-              <a:t>6/16/2022</a:t>
+              <a:t>6/19/2022</a:t>
             </a:fld>
             <a:endParaRPr lang="en-US"/>
           </a:p>
@@ -2735,7 +2735,7 @@
           <a:p>
             <a:fld id="{9EC8CD53-0620-48F2-A3BB-2B10BDA60E52}" type="datetimeFigureOut">
               <a:rPr lang="en-US" smtClean="0"/>
-              <a:t>6/16/2022</a:t>
+              <a:t>6/19/2022</a:t>
             </a:fld>
             <a:endParaRPr lang="en-US"/>
           </a:p>
@@ -3023,7 +3023,7 @@
           <a:p>
             <a:fld id="{9EC8CD53-0620-48F2-A3BB-2B10BDA60E52}" type="datetimeFigureOut">
               <a:rPr lang="en-US" smtClean="0"/>
-              <a:t>6/16/2022</a:t>
+              <a:t>6/19/2022</a:t>
             </a:fld>
             <a:endParaRPr lang="en-US"/>
           </a:p>
@@ -3264,7 +3264,7 @@
           <a:p>
             <a:fld id="{9EC8CD53-0620-48F2-A3BB-2B10BDA60E52}" type="datetimeFigureOut">
               <a:rPr lang="en-US" smtClean="0"/>
-              <a:t>6/16/2022</a:t>
+              <a:t>6/19/2022</a:t>
             </a:fld>
             <a:endParaRPr lang="en-US"/>
           </a:p>
@@ -16017,6 +16017,36 @@
           <a:chExt cx="0" cy="0"/>
         </a:xfrm>
       </p:grpSpPr>
+      <p:pic>
+        <p:nvPicPr>
+          <p:cNvPr id="144" name="Picture 143">
+            <a:extLst>
+              <a:ext uri="{FF2B5EF4-FFF2-40B4-BE49-F238E27FC236}">
+                <a16:creationId xmlns:a16="http://schemas.microsoft.com/office/drawing/2014/main" id="{C7E93A14-ECA2-44CE-2A0A-26C4B3781477}"/>
+              </a:ext>
+            </a:extLst>
+          </p:cNvPr>
+          <p:cNvPicPr>
+            <a:picLocks noChangeAspect="1"/>
+          </p:cNvPicPr>
+          <p:nvPr/>
+        </p:nvPicPr>
+        <p:blipFill>
+          <a:blip r:embed="rId2"/>
+          <a:stretch>
+            <a:fillRect/>
+          </a:stretch>
+        </p:blipFill>
+        <p:spPr>
+          <a:xfrm>
+            <a:off x="6556612" y="934681"/>
+            <a:ext cx="277209" cy="415814"/>
+          </a:xfrm>
+          <a:prstGeom prst="rect">
+            <a:avLst/>
+          </a:prstGeom>
+        </p:spPr>
+      </p:pic>
       <p:sp>
         <p:nvSpPr>
           <p:cNvPr id="2" name="TextBox 1">
@@ -16067,10 +16097,10 @@
         </p:nvGrpSpPr>
         <p:grpSpPr>
           <a:xfrm>
-            <a:off x="9122738" y="3515455"/>
-            <a:ext cx="735385" cy="928816"/>
-            <a:chOff x="2752725" y="1271400"/>
-            <a:chExt cx="1871663" cy="2363975"/>
+            <a:off x="9116388" y="3515455"/>
+            <a:ext cx="741738" cy="928816"/>
+            <a:chOff x="2736559" y="1271400"/>
+            <a:chExt cx="1887829" cy="2363975"/>
           </a:xfrm>
         </p:grpSpPr>
         <p:sp>
@@ -16087,8 +16117,8 @@
           </p:nvSpPr>
           <p:spPr>
             <a:xfrm rot="16200000">
-              <a:off x="2319338" y="2703909"/>
-              <a:ext cx="1174750" cy="307975"/>
+              <a:off x="2303172" y="2703909"/>
+              <a:ext cx="1174749" cy="307975"/>
             </a:xfrm>
             <a:prstGeom prst="trapezoid">
               <a:avLst/>
@@ -16115,7 +16145,7 @@
             <a:lstStyle/>
             <a:p>
               <a:pPr algn="ctr"/>
-              <a:endParaRPr lang="en-US"/>
+              <a:endParaRPr lang="en-US" dirty="0"/>
             </a:p>
           </p:txBody>
         </p:sp>
@@ -16225,8 +16255,8 @@
           </p:nvSpPr>
           <p:spPr>
             <a:xfrm>
-              <a:off x="3214687" y="1634729"/>
-              <a:ext cx="469900" cy="317896"/>
+              <a:off x="3214688" y="1537760"/>
+              <a:ext cx="469900" cy="317897"/>
             </a:xfrm>
             <a:prstGeom prst="trapezoid">
               <a:avLst/>
@@ -16503,7 +16533,7 @@
           </p:nvSpPr>
           <p:spPr>
             <a:xfrm>
-              <a:off x="573033" y="478473"/>
+              <a:off x="566683" y="478473"/>
               <a:ext cx="1097280" cy="1097280"/>
             </a:xfrm>
             <a:prstGeom prst="plaque">
@@ -16532,209 +16562,6 @@
             </a:effectRef>
             <a:fontRef idx="minor">
               <a:schemeClr val="dk1"/>
-            </a:fontRef>
-          </p:style>
-          <p:txBody>
-            <a:bodyPr rtlCol="0" anchor="ctr"/>
-            <a:lstStyle/>
-            <a:p>
-              <a:pPr algn="ctr"/>
-              <a:endParaRPr lang="en-US"/>
-            </a:p>
-          </p:txBody>
-        </p:sp>
-      </p:grpSp>
-      <p:grpSp>
-        <p:nvGrpSpPr>
-          <p:cNvPr id="27" name="Group 26">
-            <a:extLst>
-              <a:ext uri="{FF2B5EF4-FFF2-40B4-BE49-F238E27FC236}">
-                <a16:creationId xmlns:a16="http://schemas.microsoft.com/office/drawing/2014/main" id="{2CD3CB12-E2D0-5C30-4A6F-506F54B07124}"/>
-              </a:ext>
-            </a:extLst>
-          </p:cNvPr>
-          <p:cNvGrpSpPr/>
-          <p:nvPr/>
-        </p:nvGrpSpPr>
-        <p:grpSpPr>
-          <a:xfrm>
-            <a:off x="10250825" y="3427092"/>
-            <a:ext cx="961844" cy="961844"/>
-            <a:chOff x="3282950" y="1689100"/>
-            <a:chExt cx="1371600" cy="1371600"/>
-          </a:xfrm>
-        </p:grpSpPr>
-        <p:sp>
-          <p:nvSpPr>
-            <p:cNvPr id="28" name="Oval 27">
-              <a:extLst>
-                <a:ext uri="{FF2B5EF4-FFF2-40B4-BE49-F238E27FC236}">
-                  <a16:creationId xmlns:a16="http://schemas.microsoft.com/office/drawing/2014/main" id="{A32074B7-5055-399D-A4AE-A1104E3499F6}"/>
-                </a:ext>
-              </a:extLst>
-            </p:cNvPr>
-            <p:cNvSpPr/>
-            <p:nvPr/>
-          </p:nvSpPr>
-          <p:spPr>
-            <a:xfrm>
-              <a:off x="3282950" y="1689100"/>
-              <a:ext cx="1371600" cy="1371600"/>
-            </a:xfrm>
-            <a:prstGeom prst="ellipse">
-              <a:avLst/>
-            </a:prstGeom>
-          </p:spPr>
-          <p:style>
-            <a:lnRef idx="2">
-              <a:schemeClr val="dk1"/>
-            </a:lnRef>
-            <a:fillRef idx="1">
-              <a:schemeClr val="lt1"/>
-            </a:fillRef>
-            <a:effectRef idx="0">
-              <a:schemeClr val="dk1"/>
-            </a:effectRef>
-            <a:fontRef idx="minor">
-              <a:schemeClr val="dk1"/>
-            </a:fontRef>
-          </p:style>
-          <p:txBody>
-            <a:bodyPr rtlCol="0" anchor="ctr"/>
-            <a:lstStyle/>
-            <a:p>
-              <a:pPr algn="ctr"/>
-              <a:endParaRPr lang="en-US"/>
-            </a:p>
-          </p:txBody>
-        </p:sp>
-        <p:sp>
-          <p:nvSpPr>
-            <p:cNvPr id="29" name="Isosceles Triangle 28">
-              <a:extLst>
-                <a:ext uri="{FF2B5EF4-FFF2-40B4-BE49-F238E27FC236}">
-                  <a16:creationId xmlns:a16="http://schemas.microsoft.com/office/drawing/2014/main" id="{C2DD6A86-C952-C453-D0D6-ECA34B6DCED7}"/>
-                </a:ext>
-              </a:extLst>
-            </p:cNvPr>
-            <p:cNvSpPr/>
-            <p:nvPr/>
-          </p:nvSpPr>
-          <p:spPr>
-            <a:xfrm>
-              <a:off x="3706811" y="1689100"/>
-              <a:ext cx="547689" cy="501650"/>
-            </a:xfrm>
-            <a:prstGeom prst="triangle">
-              <a:avLst/>
-            </a:prstGeom>
-          </p:spPr>
-          <p:style>
-            <a:lnRef idx="2">
-              <a:schemeClr val="dk1">
-                <a:shade val="50000"/>
-              </a:schemeClr>
-            </a:lnRef>
-            <a:fillRef idx="1">
-              <a:schemeClr val="dk1"/>
-            </a:fillRef>
-            <a:effectRef idx="0">
-              <a:schemeClr val="dk1"/>
-            </a:effectRef>
-            <a:fontRef idx="minor">
-              <a:schemeClr val="lt1"/>
-            </a:fontRef>
-          </p:style>
-          <p:txBody>
-            <a:bodyPr rtlCol="0" anchor="ctr"/>
-            <a:lstStyle/>
-            <a:p>
-              <a:pPr algn="ctr"/>
-              <a:endParaRPr lang="en-US"/>
-            </a:p>
-          </p:txBody>
-        </p:sp>
-        <p:sp>
-          <p:nvSpPr>
-            <p:cNvPr id="30" name="Isosceles Triangle 29">
-              <a:extLst>
-                <a:ext uri="{FF2B5EF4-FFF2-40B4-BE49-F238E27FC236}">
-                  <a16:creationId xmlns:a16="http://schemas.microsoft.com/office/drawing/2014/main" id="{C7BEC5FE-DAD5-FA0F-88AD-8A0014D1261F}"/>
-                </a:ext>
-              </a:extLst>
-            </p:cNvPr>
-            <p:cNvSpPr/>
-            <p:nvPr/>
-          </p:nvSpPr>
-          <p:spPr>
-            <a:xfrm>
-              <a:off x="3409950" y="2266950"/>
-              <a:ext cx="547689" cy="501650"/>
-            </a:xfrm>
-            <a:prstGeom prst="triangle">
-              <a:avLst/>
-            </a:prstGeom>
-          </p:spPr>
-          <p:style>
-            <a:lnRef idx="2">
-              <a:schemeClr val="dk1">
-                <a:shade val="50000"/>
-              </a:schemeClr>
-            </a:lnRef>
-            <a:fillRef idx="1">
-              <a:schemeClr val="dk1"/>
-            </a:fillRef>
-            <a:effectRef idx="0">
-              <a:schemeClr val="dk1"/>
-            </a:effectRef>
-            <a:fontRef idx="minor">
-              <a:schemeClr val="lt1"/>
-            </a:fontRef>
-          </p:style>
-          <p:txBody>
-            <a:bodyPr rtlCol="0" anchor="ctr"/>
-            <a:lstStyle/>
-            <a:p>
-              <a:pPr algn="ctr"/>
-              <a:endParaRPr lang="en-US"/>
-            </a:p>
-          </p:txBody>
-        </p:sp>
-        <p:sp>
-          <p:nvSpPr>
-            <p:cNvPr id="31" name="Isosceles Triangle 30">
-              <a:extLst>
-                <a:ext uri="{FF2B5EF4-FFF2-40B4-BE49-F238E27FC236}">
-                  <a16:creationId xmlns:a16="http://schemas.microsoft.com/office/drawing/2014/main" id="{0D04A301-12DC-CAA7-64D2-E7C43DF7446F}"/>
-                </a:ext>
-              </a:extLst>
-            </p:cNvPr>
-            <p:cNvSpPr/>
-            <p:nvPr/>
-          </p:nvSpPr>
-          <p:spPr>
-            <a:xfrm>
-              <a:off x="3998910" y="2260600"/>
-              <a:ext cx="547689" cy="501650"/>
-            </a:xfrm>
-            <a:prstGeom prst="triangle">
-              <a:avLst/>
-            </a:prstGeom>
-          </p:spPr>
-          <p:style>
-            <a:lnRef idx="2">
-              <a:schemeClr val="dk1">
-                <a:shade val="50000"/>
-              </a:schemeClr>
-            </a:lnRef>
-            <a:fillRef idx="1">
-              <a:schemeClr val="dk1"/>
-            </a:fillRef>
-            <a:effectRef idx="0">
-              <a:schemeClr val="dk1"/>
-            </a:effectRef>
-            <a:fontRef idx="minor">
-              <a:schemeClr val="lt1"/>
             </a:fontRef>
           </p:style>
           <p:txBody>
@@ -16762,7 +16589,7 @@
           <p:nvPr/>
         </p:nvPicPr>
         <p:blipFill>
-          <a:blip r:embed="rId2"/>
+          <a:blip r:embed="rId3"/>
           <a:stretch>
             <a:fillRect/>
           </a:stretch>
@@ -16863,7 +16690,7 @@
           </p:nvSpPr>
           <p:spPr>
             <a:xfrm>
-              <a:off x="573033" y="478473"/>
+              <a:off x="566683" y="478473"/>
               <a:ext cx="1097280" cy="1097280"/>
             </a:xfrm>
             <a:prstGeom prst="plaque">
@@ -16990,7 +16817,7 @@
           </p:nvSpPr>
           <p:spPr>
             <a:xfrm>
-              <a:off x="573033" y="478473"/>
+              <a:off x="566683" y="478473"/>
               <a:ext cx="1097280" cy="1097280"/>
             </a:xfrm>
             <a:prstGeom prst="plaque">
@@ -17828,7 +17655,7 @@
           </p:nvSpPr>
           <p:spPr>
             <a:xfrm>
-              <a:off x="573033" y="478473"/>
+              <a:off x="566683" y="478473"/>
               <a:ext cx="1097280" cy="1097280"/>
             </a:xfrm>
             <a:prstGeom prst="plaque">
@@ -18593,7 +18420,7 @@
           </p:nvSpPr>
           <p:spPr>
             <a:xfrm>
-              <a:off x="573033" y="478473"/>
+              <a:off x="566683" y="478473"/>
               <a:ext cx="1097280" cy="1097280"/>
             </a:xfrm>
             <a:prstGeom prst="plaque">
@@ -18885,7 +18712,7 @@
           </p:nvSpPr>
           <p:spPr>
             <a:xfrm>
-              <a:off x="573033" y="478473"/>
+              <a:off x="566683" y="478473"/>
               <a:ext cx="1097280" cy="1097280"/>
             </a:xfrm>
             <a:prstGeom prst="plaque">
@@ -19236,14 +19063,14 @@
           <p:nvPr/>
         </p:nvPicPr>
         <p:blipFill>
-          <a:blip r:embed="rId3"/>
+          <a:blip r:embed="rId4"/>
           <a:stretch>
             <a:fillRect/>
           </a:stretch>
         </p:blipFill>
         <p:spPr>
           <a:xfrm>
-            <a:off x="6483418" y="1143969"/>
+            <a:off x="8602121" y="953412"/>
             <a:ext cx="433388" cy="444277"/>
           </a:xfrm>
           <a:prstGeom prst="rect">
@@ -19337,7 +19164,7 @@
           </p:nvSpPr>
           <p:spPr>
             <a:xfrm>
-              <a:off x="573033" y="478473"/>
+              <a:off x="566683" y="478473"/>
               <a:ext cx="1097280" cy="1097280"/>
             </a:xfrm>
             <a:prstGeom prst="plaque">
@@ -19911,7 +19738,7 @@
         </p:nvGrpSpPr>
         <p:grpSpPr>
           <a:xfrm>
-            <a:off x="8185405" y="850161"/>
+            <a:off x="8108359" y="845004"/>
             <a:ext cx="502920" cy="1014984"/>
             <a:chOff x="5380031" y="966102"/>
             <a:chExt cx="1727200" cy="3248141"/>
@@ -20430,7 +20257,7 @@
         </p:nvGrpSpPr>
         <p:grpSpPr>
           <a:xfrm>
-            <a:off x="7833615" y="580700"/>
+            <a:off x="7794856" y="567502"/>
             <a:ext cx="1371600" cy="1371600"/>
             <a:chOff x="427081" y="263129"/>
             <a:chExt cx="1371600" cy="1371600"/>
@@ -20502,7 +20329,7 @@
           </p:nvSpPr>
           <p:spPr>
             <a:xfrm>
-              <a:off x="573033" y="478473"/>
+              <a:off x="566683" y="478473"/>
               <a:ext cx="1097280" cy="1097280"/>
             </a:xfrm>
             <a:prstGeom prst="plaque">
@@ -20543,36 +20370,6 @@
           </p:txBody>
         </p:sp>
       </p:grpSp>
-      <p:pic>
-        <p:nvPicPr>
-          <p:cNvPr id="144" name="Picture 143">
-            <a:extLst>
-              <a:ext uri="{FF2B5EF4-FFF2-40B4-BE49-F238E27FC236}">
-                <a16:creationId xmlns:a16="http://schemas.microsoft.com/office/drawing/2014/main" id="{C7E93A14-ECA2-44CE-2A0A-26C4B3781477}"/>
-              </a:ext>
-            </a:extLst>
-          </p:cNvPr>
-          <p:cNvPicPr>
-            <a:picLocks noChangeAspect="1"/>
-          </p:cNvPicPr>
-          <p:nvPr/>
-        </p:nvPicPr>
-        <p:blipFill>
-          <a:blip r:embed="rId4"/>
-          <a:stretch>
-            <a:fillRect/>
-          </a:stretch>
-        </p:blipFill>
-        <p:spPr>
-          <a:xfrm>
-            <a:off x="8725218" y="1115210"/>
-            <a:ext cx="277209" cy="415814"/>
-          </a:xfrm>
-          <a:prstGeom prst="rect">
-            <a:avLst/>
-          </a:prstGeom>
-        </p:spPr>
-      </p:pic>
       <p:grpSp>
         <p:nvGrpSpPr>
           <p:cNvPr id="145" name="Group 144">
@@ -21433,7 +21230,7 @@
           </p:nvSpPr>
           <p:spPr>
             <a:xfrm>
-              <a:off x="573033" y="478473"/>
+              <a:off x="566683" y="478473"/>
               <a:ext cx="1097280" cy="1097280"/>
             </a:xfrm>
             <a:prstGeom prst="plaque">
@@ -21560,7 +21357,7 @@
           </p:nvSpPr>
           <p:spPr>
             <a:xfrm>
-              <a:off x="573033" y="478473"/>
+              <a:off x="566683" y="478473"/>
               <a:ext cx="1097280" cy="1097280"/>
             </a:xfrm>
             <a:prstGeom prst="plaque">
@@ -22186,7 +21983,7 @@
           </p:nvSpPr>
           <p:spPr>
             <a:xfrm>
-              <a:off x="573033" y="478473"/>
+              <a:off x="566683" y="478473"/>
               <a:ext cx="1097280" cy="1097280"/>
             </a:xfrm>
             <a:prstGeom prst="plaque">
@@ -22313,7 +22110,7 @@
           </p:nvSpPr>
           <p:spPr>
             <a:xfrm>
-              <a:off x="573033" y="478473"/>
+              <a:off x="566683" y="478473"/>
               <a:ext cx="1097280" cy="1097280"/>
             </a:xfrm>
             <a:prstGeom prst="plaque">
@@ -22349,7 +22146,7 @@
             <a:lstStyle/>
             <a:p>
               <a:pPr algn="ctr"/>
-              <a:endParaRPr lang="en-US"/>
+              <a:endParaRPr lang="en-US" dirty="0"/>
             </a:p>
           </p:txBody>
         </p:sp>
@@ -22440,7 +22237,7 @@
           </p:nvSpPr>
           <p:spPr>
             <a:xfrm>
-              <a:off x="573033" y="478473"/>
+              <a:off x="566683" y="478473"/>
               <a:ext cx="1097280" cy="1097280"/>
             </a:xfrm>
             <a:prstGeom prst="plaque">
@@ -23419,6 +23216,292 @@
               <a:avLst>
                 <a:gd name="adj" fmla="val 37993"/>
               </a:avLst>
+            </a:prstGeom>
+          </p:spPr>
+          <p:style>
+            <a:lnRef idx="2">
+              <a:schemeClr val="dk1">
+                <a:shade val="50000"/>
+              </a:schemeClr>
+            </a:lnRef>
+            <a:fillRef idx="1">
+              <a:schemeClr val="dk1"/>
+            </a:fillRef>
+            <a:effectRef idx="0">
+              <a:schemeClr val="dk1"/>
+            </a:effectRef>
+            <a:fontRef idx="minor">
+              <a:schemeClr val="lt1"/>
+            </a:fontRef>
+          </p:style>
+          <p:txBody>
+            <a:bodyPr rtlCol="0" anchor="ctr"/>
+            <a:lstStyle/>
+            <a:p>
+              <a:pPr algn="ctr"/>
+              <a:endParaRPr lang="en-US"/>
+            </a:p>
+          </p:txBody>
+        </p:sp>
+      </p:grpSp>
+      <p:grpSp>
+        <p:nvGrpSpPr>
+          <p:cNvPr id="195" name="Group 194">
+            <a:extLst>
+              <a:ext uri="{FF2B5EF4-FFF2-40B4-BE49-F238E27FC236}">
+                <a16:creationId xmlns:a16="http://schemas.microsoft.com/office/drawing/2014/main" id="{6F5B4EC1-259E-F326-8537-AEA962D1D33A}"/>
+              </a:ext>
+            </a:extLst>
+          </p:cNvPr>
+          <p:cNvGrpSpPr/>
+          <p:nvPr/>
+        </p:nvGrpSpPr>
+        <p:grpSpPr>
+          <a:xfrm>
+            <a:off x="10276129" y="3200894"/>
+            <a:ext cx="1371600" cy="1371600"/>
+            <a:chOff x="427081" y="263129"/>
+            <a:chExt cx="1371600" cy="1371600"/>
+          </a:xfrm>
+        </p:grpSpPr>
+        <p:sp>
+          <p:nvSpPr>
+            <p:cNvPr id="196" name="Rectangle 195">
+              <a:extLst>
+                <a:ext uri="{FF2B5EF4-FFF2-40B4-BE49-F238E27FC236}">
+                  <a16:creationId xmlns:a16="http://schemas.microsoft.com/office/drawing/2014/main" id="{E8CEDA50-61F0-CF72-1260-59ADC2A93262}"/>
+                </a:ext>
+              </a:extLst>
+            </p:cNvPr>
+            <p:cNvSpPr/>
+            <p:nvPr/>
+          </p:nvSpPr>
+          <p:spPr>
+            <a:xfrm>
+              <a:off x="427081" y="263129"/>
+              <a:ext cx="1371600" cy="1371600"/>
+            </a:xfrm>
+            <a:prstGeom prst="rect">
+              <a:avLst/>
+            </a:prstGeom>
+            <a:noFill/>
+            <a:ln w="76200">
+              <a:solidFill>
+                <a:schemeClr val="tx1"/>
+              </a:solidFill>
+            </a:ln>
+          </p:spPr>
+          <p:style>
+            <a:lnRef idx="2">
+              <a:schemeClr val="accent1">
+                <a:shade val="50000"/>
+              </a:schemeClr>
+            </a:lnRef>
+            <a:fillRef idx="1">
+              <a:schemeClr val="accent1"/>
+            </a:fillRef>
+            <a:effectRef idx="0">
+              <a:schemeClr val="accent1"/>
+            </a:effectRef>
+            <a:fontRef idx="minor">
+              <a:schemeClr val="lt1"/>
+            </a:fontRef>
+          </p:style>
+          <p:txBody>
+            <a:bodyPr rtlCol="0" anchor="ctr"/>
+            <a:lstStyle/>
+            <a:p>
+              <a:pPr algn="ctr"/>
+              <a:endParaRPr lang="en-US"/>
+            </a:p>
+          </p:txBody>
+        </p:sp>
+        <p:sp>
+          <p:nvSpPr>
+            <p:cNvPr id="197" name="Plaque 196">
+              <a:extLst>
+                <a:ext uri="{FF2B5EF4-FFF2-40B4-BE49-F238E27FC236}">
+                  <a16:creationId xmlns:a16="http://schemas.microsoft.com/office/drawing/2014/main" id="{82C70602-E460-393B-9878-38430C24AD16}"/>
+                </a:ext>
+              </a:extLst>
+            </p:cNvPr>
+            <p:cNvSpPr/>
+            <p:nvPr/>
+          </p:nvSpPr>
+          <p:spPr>
+            <a:xfrm>
+              <a:off x="566683" y="478473"/>
+              <a:ext cx="1097280" cy="1097280"/>
+            </a:xfrm>
+            <a:prstGeom prst="plaque">
+              <a:avLst/>
+            </a:prstGeom>
+            <a:noFill/>
+            <a:ln w="38100" cap="flat" cmpd="sng" algn="ctr">
+              <a:solidFill>
+                <a:schemeClr val="dk1"/>
+              </a:solidFill>
+              <a:prstDash val="solid"/>
+              <a:round/>
+              <a:headEnd type="none" w="med" len="med"/>
+              <a:tailEnd type="none" w="med" len="med"/>
+            </a:ln>
+          </p:spPr>
+          <p:style>
+            <a:lnRef idx="0">
+              <a:scrgbClr r="0" g="0" b="0"/>
+            </a:lnRef>
+            <a:fillRef idx="0">
+              <a:scrgbClr r="0" g="0" b="0"/>
+            </a:fillRef>
+            <a:effectRef idx="0">
+              <a:scrgbClr r="0" g="0" b="0"/>
+            </a:effectRef>
+            <a:fontRef idx="minor">
+              <a:schemeClr val="dk1"/>
+            </a:fontRef>
+          </p:style>
+          <p:txBody>
+            <a:bodyPr rtlCol="0" anchor="ctr"/>
+            <a:lstStyle/>
+            <a:p>
+              <a:pPr algn="ctr"/>
+              <a:endParaRPr lang="en-US"/>
+            </a:p>
+          </p:txBody>
+        </p:sp>
+      </p:grpSp>
+      <p:grpSp>
+        <p:nvGrpSpPr>
+          <p:cNvPr id="203" name="Group 202">
+            <a:extLst>
+              <a:ext uri="{FF2B5EF4-FFF2-40B4-BE49-F238E27FC236}">
+                <a16:creationId xmlns:a16="http://schemas.microsoft.com/office/drawing/2014/main" id="{193A70C2-9665-D76B-1AE2-B41DB7F9141F}"/>
+              </a:ext>
+            </a:extLst>
+          </p:cNvPr>
+          <p:cNvGrpSpPr/>
+          <p:nvPr/>
+        </p:nvGrpSpPr>
+        <p:grpSpPr>
+          <a:xfrm>
+            <a:off x="10648352" y="3515455"/>
+            <a:ext cx="625640" cy="825748"/>
+            <a:chOff x="5200606" y="948929"/>
+            <a:chExt cx="895394" cy="1181783"/>
+          </a:xfrm>
+        </p:grpSpPr>
+        <p:sp>
+          <p:nvSpPr>
+            <p:cNvPr id="204" name="Isosceles Triangle 203">
+              <a:extLst>
+                <a:ext uri="{FF2B5EF4-FFF2-40B4-BE49-F238E27FC236}">
+                  <a16:creationId xmlns:a16="http://schemas.microsoft.com/office/drawing/2014/main" id="{89427A9A-54E6-F795-237A-D115541B06D0}"/>
+                </a:ext>
+              </a:extLst>
+            </p:cNvPr>
+            <p:cNvSpPr/>
+            <p:nvPr/>
+          </p:nvSpPr>
+          <p:spPr>
+            <a:xfrm>
+              <a:off x="5448300" y="948929"/>
+              <a:ext cx="406400" cy="558800"/>
+            </a:xfrm>
+            <a:prstGeom prst="triangle">
+              <a:avLst/>
+            </a:prstGeom>
+          </p:spPr>
+          <p:style>
+            <a:lnRef idx="2">
+              <a:schemeClr val="dk1">
+                <a:shade val="50000"/>
+              </a:schemeClr>
+            </a:lnRef>
+            <a:fillRef idx="1">
+              <a:schemeClr val="dk1"/>
+            </a:fillRef>
+            <a:effectRef idx="0">
+              <a:schemeClr val="dk1"/>
+            </a:effectRef>
+            <a:fontRef idx="minor">
+              <a:schemeClr val="lt1"/>
+            </a:fontRef>
+          </p:style>
+          <p:txBody>
+            <a:bodyPr rtlCol="0" anchor="ctr"/>
+            <a:lstStyle/>
+            <a:p>
+              <a:pPr algn="ctr"/>
+              <a:endParaRPr lang="en-US"/>
+            </a:p>
+          </p:txBody>
+        </p:sp>
+        <p:sp>
+          <p:nvSpPr>
+            <p:cNvPr id="205" name="Isosceles Triangle 204">
+              <a:extLst>
+                <a:ext uri="{FF2B5EF4-FFF2-40B4-BE49-F238E27FC236}">
+                  <a16:creationId xmlns:a16="http://schemas.microsoft.com/office/drawing/2014/main" id="{B48E1623-CE3A-F72D-7B9F-0C07FF4B307A}"/>
+                </a:ext>
+              </a:extLst>
+            </p:cNvPr>
+            <p:cNvSpPr/>
+            <p:nvPr/>
+          </p:nvSpPr>
+          <p:spPr>
+            <a:xfrm>
+              <a:off x="5200606" y="1571912"/>
+              <a:ext cx="406400" cy="558800"/>
+            </a:xfrm>
+            <a:prstGeom prst="triangle">
+              <a:avLst/>
+            </a:prstGeom>
+          </p:spPr>
+          <p:style>
+            <a:lnRef idx="2">
+              <a:schemeClr val="dk1">
+                <a:shade val="50000"/>
+              </a:schemeClr>
+            </a:lnRef>
+            <a:fillRef idx="1">
+              <a:schemeClr val="dk1"/>
+            </a:fillRef>
+            <a:effectRef idx="0">
+              <a:schemeClr val="dk1"/>
+            </a:effectRef>
+            <a:fontRef idx="minor">
+              <a:schemeClr val="lt1"/>
+            </a:fontRef>
+          </p:style>
+          <p:txBody>
+            <a:bodyPr rtlCol="0" anchor="ctr"/>
+            <a:lstStyle/>
+            <a:p>
+              <a:pPr algn="ctr"/>
+              <a:endParaRPr lang="en-US"/>
+            </a:p>
+          </p:txBody>
+        </p:sp>
+        <p:sp>
+          <p:nvSpPr>
+            <p:cNvPr id="206" name="Isosceles Triangle 205">
+              <a:extLst>
+                <a:ext uri="{FF2B5EF4-FFF2-40B4-BE49-F238E27FC236}">
+                  <a16:creationId xmlns:a16="http://schemas.microsoft.com/office/drawing/2014/main" id="{F4F6E9D9-F70F-4815-9849-71406CAADFFE}"/>
+                </a:ext>
+              </a:extLst>
+            </p:cNvPr>
+            <p:cNvSpPr/>
+            <p:nvPr/>
+          </p:nvSpPr>
+          <p:spPr>
+            <a:xfrm>
+              <a:off x="5689600" y="1571912"/>
+              <a:ext cx="406400" cy="558800"/>
+            </a:xfrm>
+            <a:prstGeom prst="triangle">
+              <a:avLst/>
             </a:prstGeom>
           </p:spPr>
           <p:style>

</xml_diff>

<commit_message>
Heal bio and heal mech
</commit_message>
<xml_diff>
--- a/image process/drawings sifi.pptx
+++ b/image process/drawings sifi.pptx
@@ -200,7 +200,7 @@
           <a:p>
             <a:fld id="{7700C406-2328-4788-AE79-437B6607AD22}" type="datetimeFigureOut">
               <a:rPr lang="en-US" smtClean="0"/>
-              <a:t>6/20/2022</a:t>
+              <a:t>6/23/2022</a:t>
             </a:fld>
             <a:endParaRPr lang="en-US"/>
           </a:p>
@@ -614,7 +614,7 @@
           <a:p>
             <a:fld id="{9EC8CD53-0620-48F2-A3BB-2B10BDA60E52}" type="datetimeFigureOut">
               <a:rPr lang="en-US" smtClean="0"/>
-              <a:t>6/20/2022</a:t>
+              <a:t>6/23/2022</a:t>
             </a:fld>
             <a:endParaRPr lang="en-US"/>
           </a:p>
@@ -812,7 +812,7 @@
           <a:p>
             <a:fld id="{9EC8CD53-0620-48F2-A3BB-2B10BDA60E52}" type="datetimeFigureOut">
               <a:rPr lang="en-US" smtClean="0"/>
-              <a:t>6/20/2022</a:t>
+              <a:t>6/23/2022</a:t>
             </a:fld>
             <a:endParaRPr lang="en-US"/>
           </a:p>
@@ -1020,7 +1020,7 @@
           <a:p>
             <a:fld id="{9EC8CD53-0620-48F2-A3BB-2B10BDA60E52}" type="datetimeFigureOut">
               <a:rPr lang="en-US" smtClean="0"/>
-              <a:t>6/20/2022</a:t>
+              <a:t>6/23/2022</a:t>
             </a:fld>
             <a:endParaRPr lang="en-US"/>
           </a:p>
@@ -1218,7 +1218,7 @@
           <a:p>
             <a:fld id="{9EC8CD53-0620-48F2-A3BB-2B10BDA60E52}" type="datetimeFigureOut">
               <a:rPr lang="en-US" smtClean="0"/>
-              <a:t>6/20/2022</a:t>
+              <a:t>6/23/2022</a:t>
             </a:fld>
             <a:endParaRPr lang="en-US"/>
           </a:p>
@@ -1493,7 +1493,7 @@
           <a:p>
             <a:fld id="{9EC8CD53-0620-48F2-A3BB-2B10BDA60E52}" type="datetimeFigureOut">
               <a:rPr lang="en-US" smtClean="0"/>
-              <a:t>6/20/2022</a:t>
+              <a:t>6/23/2022</a:t>
             </a:fld>
             <a:endParaRPr lang="en-US"/>
           </a:p>
@@ -1758,7 +1758,7 @@
           <a:p>
             <a:fld id="{9EC8CD53-0620-48F2-A3BB-2B10BDA60E52}" type="datetimeFigureOut">
               <a:rPr lang="en-US" smtClean="0"/>
-              <a:t>6/20/2022</a:t>
+              <a:t>6/23/2022</a:t>
             </a:fld>
             <a:endParaRPr lang="en-US"/>
           </a:p>
@@ -2170,7 +2170,7 @@
           <a:p>
             <a:fld id="{9EC8CD53-0620-48F2-A3BB-2B10BDA60E52}" type="datetimeFigureOut">
               <a:rPr lang="en-US" smtClean="0"/>
-              <a:t>6/20/2022</a:t>
+              <a:t>6/23/2022</a:t>
             </a:fld>
             <a:endParaRPr lang="en-US"/>
           </a:p>
@@ -2311,7 +2311,7 @@
           <a:p>
             <a:fld id="{9EC8CD53-0620-48F2-A3BB-2B10BDA60E52}" type="datetimeFigureOut">
               <a:rPr lang="en-US" smtClean="0"/>
-              <a:t>6/20/2022</a:t>
+              <a:t>6/23/2022</a:t>
             </a:fld>
             <a:endParaRPr lang="en-US"/>
           </a:p>
@@ -2424,7 +2424,7 @@
           <a:p>
             <a:fld id="{9EC8CD53-0620-48F2-A3BB-2B10BDA60E52}" type="datetimeFigureOut">
               <a:rPr lang="en-US" smtClean="0"/>
-              <a:t>6/20/2022</a:t>
+              <a:t>6/23/2022</a:t>
             </a:fld>
             <a:endParaRPr lang="en-US"/>
           </a:p>
@@ -2735,7 +2735,7 @@
           <a:p>
             <a:fld id="{9EC8CD53-0620-48F2-A3BB-2B10BDA60E52}" type="datetimeFigureOut">
               <a:rPr lang="en-US" smtClean="0"/>
-              <a:t>6/20/2022</a:t>
+              <a:t>6/23/2022</a:t>
             </a:fld>
             <a:endParaRPr lang="en-US"/>
           </a:p>
@@ -3023,7 +3023,7 @@
           <a:p>
             <a:fld id="{9EC8CD53-0620-48F2-A3BB-2B10BDA60E52}" type="datetimeFigureOut">
               <a:rPr lang="en-US" smtClean="0"/>
-              <a:t>6/20/2022</a:t>
+              <a:t>6/23/2022</a:t>
             </a:fld>
             <a:endParaRPr lang="en-US"/>
           </a:p>
@@ -3264,7 +3264,7 @@
           <a:p>
             <a:fld id="{9EC8CD53-0620-48F2-A3BB-2B10BDA60E52}" type="datetimeFigureOut">
               <a:rPr lang="en-US" smtClean="0"/>
-              <a:t>6/20/2022</a:t>
+              <a:t>6/23/2022</a:t>
             </a:fld>
             <a:endParaRPr lang="en-US"/>
           </a:p>
@@ -13145,833 +13145,6 @@
       </p:grpSp>
       <p:grpSp>
         <p:nvGrpSpPr>
-          <p:cNvPr id="316" name="Group 315">
-            <a:extLst>
-              <a:ext uri="{FF2B5EF4-FFF2-40B4-BE49-F238E27FC236}">
-                <a16:creationId xmlns:a16="http://schemas.microsoft.com/office/drawing/2014/main" id="{F60BF70D-4541-E619-77CA-869A5DFBFD6F}"/>
-              </a:ext>
-            </a:extLst>
-          </p:cNvPr>
-          <p:cNvGrpSpPr/>
-          <p:nvPr/>
-        </p:nvGrpSpPr>
-        <p:grpSpPr>
-          <a:xfrm>
-            <a:off x="3586655" y="3952065"/>
-            <a:ext cx="1371600" cy="1371600"/>
-            <a:chOff x="1298501" y="962272"/>
-            <a:chExt cx="1371600" cy="1371600"/>
-          </a:xfrm>
-        </p:grpSpPr>
-        <p:sp>
-          <p:nvSpPr>
-            <p:cNvPr id="317" name="Rectangle 316">
-              <a:extLst>
-                <a:ext uri="{FF2B5EF4-FFF2-40B4-BE49-F238E27FC236}">
-                  <a16:creationId xmlns:a16="http://schemas.microsoft.com/office/drawing/2014/main" id="{5BB1C7F4-DD07-87C7-8EEC-ECA813D66FDA}"/>
-                </a:ext>
-              </a:extLst>
-            </p:cNvPr>
-            <p:cNvSpPr/>
-            <p:nvPr/>
-          </p:nvSpPr>
-          <p:spPr>
-            <a:xfrm>
-              <a:off x="1298501" y="962272"/>
-              <a:ext cx="1371600" cy="1371600"/>
-            </a:xfrm>
-            <a:prstGeom prst="rect">
-              <a:avLst/>
-            </a:prstGeom>
-            <a:noFill/>
-            <a:ln w="76200">
-              <a:solidFill>
-                <a:schemeClr val="tx1"/>
-              </a:solidFill>
-            </a:ln>
-          </p:spPr>
-          <p:style>
-            <a:lnRef idx="2">
-              <a:schemeClr val="accent1">
-                <a:shade val="50000"/>
-              </a:schemeClr>
-            </a:lnRef>
-            <a:fillRef idx="1">
-              <a:schemeClr val="accent1"/>
-            </a:fillRef>
-            <a:effectRef idx="0">
-              <a:schemeClr val="accent1"/>
-            </a:effectRef>
-            <a:fontRef idx="minor">
-              <a:schemeClr val="lt1"/>
-            </a:fontRef>
-          </p:style>
-          <p:txBody>
-            <a:bodyPr rtlCol="0" anchor="ctr"/>
-            <a:lstStyle/>
-            <a:p>
-              <a:pPr algn="ctr"/>
-              <a:endParaRPr lang="en-US"/>
-            </a:p>
-          </p:txBody>
-        </p:sp>
-        <p:sp>
-          <p:nvSpPr>
-            <p:cNvPr id="318" name="Arrow: Pentagon 317">
-              <a:extLst>
-                <a:ext uri="{FF2B5EF4-FFF2-40B4-BE49-F238E27FC236}">
-                  <a16:creationId xmlns:a16="http://schemas.microsoft.com/office/drawing/2014/main" id="{D77226D2-7D91-71A7-FFE2-CF1918DC1710}"/>
-                </a:ext>
-              </a:extLst>
-            </p:cNvPr>
-            <p:cNvSpPr/>
-            <p:nvPr/>
-          </p:nvSpPr>
-          <p:spPr>
-            <a:xfrm rot="5400000">
-              <a:off x="1435661" y="1173775"/>
-              <a:ext cx="1097280" cy="1097280"/>
-            </a:xfrm>
-            <a:prstGeom prst="homePlate">
-              <a:avLst/>
-            </a:prstGeom>
-            <a:noFill/>
-            <a:ln w="38100" cap="flat" cmpd="sng" algn="ctr">
-              <a:solidFill>
-                <a:schemeClr val="dk1"/>
-              </a:solidFill>
-              <a:prstDash val="solid"/>
-              <a:round/>
-              <a:headEnd type="none" w="med" len="med"/>
-              <a:tailEnd type="none" w="med" len="med"/>
-            </a:ln>
-          </p:spPr>
-          <p:style>
-            <a:lnRef idx="0">
-              <a:scrgbClr r="0" g="0" b="0"/>
-            </a:lnRef>
-            <a:fillRef idx="0">
-              <a:scrgbClr r="0" g="0" b="0"/>
-            </a:fillRef>
-            <a:effectRef idx="0">
-              <a:scrgbClr r="0" g="0" b="0"/>
-            </a:effectRef>
-            <a:fontRef idx="minor">
-              <a:schemeClr val="dk1"/>
-            </a:fontRef>
-          </p:style>
-          <p:txBody>
-            <a:bodyPr rtlCol="0" anchor="ctr"/>
-            <a:lstStyle/>
-            <a:p>
-              <a:pPr algn="ctr"/>
-              <a:endParaRPr lang="en-US"/>
-            </a:p>
-          </p:txBody>
-        </p:sp>
-      </p:grpSp>
-      <p:grpSp>
-        <p:nvGrpSpPr>
-          <p:cNvPr id="319" name="Group 318">
-            <a:extLst>
-              <a:ext uri="{FF2B5EF4-FFF2-40B4-BE49-F238E27FC236}">
-                <a16:creationId xmlns:a16="http://schemas.microsoft.com/office/drawing/2014/main" id="{E25D332D-EB93-80E6-B702-019112BF178E}"/>
-              </a:ext>
-            </a:extLst>
-          </p:cNvPr>
-          <p:cNvGrpSpPr/>
-          <p:nvPr/>
-        </p:nvGrpSpPr>
-        <p:grpSpPr>
-          <a:xfrm>
-            <a:off x="3843598" y="4223525"/>
-            <a:ext cx="870414" cy="803280"/>
-            <a:chOff x="2841994" y="930562"/>
-            <a:chExt cx="3529486" cy="3257264"/>
-          </a:xfrm>
-        </p:grpSpPr>
-        <p:sp>
-          <p:nvSpPr>
-            <p:cNvPr id="320" name="Oval 319">
-              <a:extLst>
-                <a:ext uri="{FF2B5EF4-FFF2-40B4-BE49-F238E27FC236}">
-                  <a16:creationId xmlns:a16="http://schemas.microsoft.com/office/drawing/2014/main" id="{85B12C62-ADBA-DDB9-AC76-430E72EAD4F8}"/>
-                </a:ext>
-              </a:extLst>
-            </p:cNvPr>
-            <p:cNvSpPr/>
-            <p:nvPr/>
-          </p:nvSpPr>
-          <p:spPr>
-            <a:xfrm>
-              <a:off x="4305300" y="930562"/>
-              <a:ext cx="590550" cy="3181350"/>
-            </a:xfrm>
-            <a:prstGeom prst="ellipse">
-              <a:avLst/>
-            </a:prstGeom>
-            <a:ln/>
-          </p:spPr>
-          <p:style>
-            <a:lnRef idx="2">
-              <a:schemeClr val="dk1">
-                <a:shade val="50000"/>
-              </a:schemeClr>
-            </a:lnRef>
-            <a:fillRef idx="1">
-              <a:schemeClr val="dk1"/>
-            </a:fillRef>
-            <a:effectRef idx="0">
-              <a:schemeClr val="dk1"/>
-            </a:effectRef>
-            <a:fontRef idx="minor">
-              <a:schemeClr val="lt1"/>
-            </a:fontRef>
-          </p:style>
-          <p:txBody>
-            <a:bodyPr rtlCol="0" anchor="ctr"/>
-            <a:lstStyle/>
-            <a:p>
-              <a:pPr algn="ctr"/>
-              <a:endParaRPr lang="en-US"/>
-            </a:p>
-          </p:txBody>
-        </p:sp>
-        <p:sp>
-          <p:nvSpPr>
-            <p:cNvPr id="321" name="Isosceles Triangle 320">
-              <a:extLst>
-                <a:ext uri="{FF2B5EF4-FFF2-40B4-BE49-F238E27FC236}">
-                  <a16:creationId xmlns:a16="http://schemas.microsoft.com/office/drawing/2014/main" id="{5F17EBD1-A0DE-D2AA-1F38-E7D0DE10B186}"/>
-                </a:ext>
-              </a:extLst>
-            </p:cNvPr>
-            <p:cNvSpPr/>
-            <p:nvPr/>
-          </p:nvSpPr>
-          <p:spPr>
-            <a:xfrm rot="15097803">
-              <a:off x="3816522" y="3530601"/>
-              <a:ext cx="590550" cy="723900"/>
-            </a:xfrm>
-            <a:prstGeom prst="triangle">
-              <a:avLst/>
-            </a:prstGeom>
-          </p:spPr>
-          <p:style>
-            <a:lnRef idx="2">
-              <a:schemeClr val="dk1">
-                <a:shade val="50000"/>
-              </a:schemeClr>
-            </a:lnRef>
-            <a:fillRef idx="1">
-              <a:schemeClr val="dk1"/>
-            </a:fillRef>
-            <a:effectRef idx="0">
-              <a:schemeClr val="dk1"/>
-            </a:effectRef>
-            <a:fontRef idx="minor">
-              <a:schemeClr val="lt1"/>
-            </a:fontRef>
-          </p:style>
-          <p:txBody>
-            <a:bodyPr rtlCol="0" anchor="ctr"/>
-            <a:lstStyle/>
-            <a:p>
-              <a:pPr algn="ctr"/>
-              <a:endParaRPr lang="en-US"/>
-            </a:p>
-          </p:txBody>
-        </p:sp>
-        <p:sp>
-          <p:nvSpPr>
-            <p:cNvPr id="322" name="Isosceles Triangle 321">
-              <a:extLst>
-                <a:ext uri="{FF2B5EF4-FFF2-40B4-BE49-F238E27FC236}">
-                  <a16:creationId xmlns:a16="http://schemas.microsoft.com/office/drawing/2014/main" id="{8C714315-EE69-66F0-541A-EF5DD3EBD261}"/>
-                </a:ext>
-              </a:extLst>
-            </p:cNvPr>
-            <p:cNvSpPr/>
-            <p:nvPr/>
-          </p:nvSpPr>
-          <p:spPr>
-            <a:xfrm rot="6456753">
-              <a:off x="4789963" y="3527597"/>
-              <a:ext cx="590550" cy="723900"/>
-            </a:xfrm>
-            <a:prstGeom prst="triangle">
-              <a:avLst/>
-            </a:prstGeom>
-          </p:spPr>
-          <p:style>
-            <a:lnRef idx="2">
-              <a:schemeClr val="dk1">
-                <a:shade val="50000"/>
-              </a:schemeClr>
-            </a:lnRef>
-            <a:fillRef idx="1">
-              <a:schemeClr val="dk1"/>
-            </a:fillRef>
-            <a:effectRef idx="0">
-              <a:schemeClr val="dk1"/>
-            </a:effectRef>
-            <a:fontRef idx="minor">
-              <a:schemeClr val="lt1"/>
-            </a:fontRef>
-          </p:style>
-          <p:txBody>
-            <a:bodyPr rtlCol="0" anchor="ctr"/>
-            <a:lstStyle/>
-            <a:p>
-              <a:pPr algn="ctr"/>
-              <a:endParaRPr lang="en-US"/>
-            </a:p>
-          </p:txBody>
-        </p:sp>
-        <p:grpSp>
-          <p:nvGrpSpPr>
-            <p:cNvPr id="323" name="Group 322">
-              <a:extLst>
-                <a:ext uri="{FF2B5EF4-FFF2-40B4-BE49-F238E27FC236}">
-                  <a16:creationId xmlns:a16="http://schemas.microsoft.com/office/drawing/2014/main" id="{489FCEB9-6581-0E22-6109-EEBBABAA705A}"/>
-                </a:ext>
-              </a:extLst>
-            </p:cNvPr>
-            <p:cNvGrpSpPr/>
-            <p:nvPr/>
-          </p:nvGrpSpPr>
-          <p:grpSpPr>
-            <a:xfrm>
-              <a:off x="2841994" y="1514299"/>
-              <a:ext cx="1562063" cy="1372483"/>
-              <a:chOff x="2841994" y="1514299"/>
-              <a:chExt cx="1562063" cy="1372483"/>
-            </a:xfrm>
-          </p:grpSpPr>
-          <p:sp>
-            <p:nvSpPr>
-              <p:cNvPr id="331" name="Rectangle 330">
-                <a:extLst>
-                  <a:ext uri="{FF2B5EF4-FFF2-40B4-BE49-F238E27FC236}">
-                    <a16:creationId xmlns:a16="http://schemas.microsoft.com/office/drawing/2014/main" id="{977D2C1C-FF87-596D-3AB2-64083F8571DD}"/>
-                  </a:ext>
-                </a:extLst>
-              </p:cNvPr>
-              <p:cNvSpPr/>
-              <p:nvPr/>
-            </p:nvSpPr>
-            <p:spPr>
-              <a:xfrm>
-                <a:off x="3453258" y="1667895"/>
-                <a:ext cx="241300" cy="1016415"/>
-              </a:xfrm>
-              <a:prstGeom prst="rect">
-                <a:avLst/>
-              </a:prstGeom>
-            </p:spPr>
-            <p:style>
-              <a:lnRef idx="2">
-                <a:schemeClr val="dk1"/>
-              </a:lnRef>
-              <a:fillRef idx="1">
-                <a:schemeClr val="lt1"/>
-              </a:fillRef>
-              <a:effectRef idx="0">
-                <a:schemeClr val="dk1"/>
-              </a:effectRef>
-              <a:fontRef idx="minor">
-                <a:schemeClr val="dk1"/>
-              </a:fontRef>
-            </p:style>
-            <p:txBody>
-              <a:bodyPr rtlCol="0" anchor="ctr"/>
-              <a:lstStyle/>
-              <a:p>
-                <a:pPr algn="ctr"/>
-                <a:endParaRPr lang="en-US"/>
-              </a:p>
-            </p:txBody>
-          </p:sp>
-          <p:sp>
-            <p:nvSpPr>
-              <p:cNvPr id="332" name="Rectangle 331">
-                <a:extLst>
-                  <a:ext uri="{FF2B5EF4-FFF2-40B4-BE49-F238E27FC236}">
-                    <a16:creationId xmlns:a16="http://schemas.microsoft.com/office/drawing/2014/main" id="{62137CB9-7201-79C3-3084-6CB5C9587369}"/>
-                  </a:ext>
-                </a:extLst>
-              </p:cNvPr>
-              <p:cNvSpPr/>
-              <p:nvPr/>
-            </p:nvSpPr>
-            <p:spPr>
-              <a:xfrm>
-                <a:off x="3879279" y="1514299"/>
-                <a:ext cx="241300" cy="1016415"/>
-              </a:xfrm>
-              <a:prstGeom prst="rect">
-                <a:avLst/>
-              </a:prstGeom>
-            </p:spPr>
-            <p:style>
-              <a:lnRef idx="2">
-                <a:schemeClr val="dk1"/>
-              </a:lnRef>
-              <a:fillRef idx="1">
-                <a:schemeClr val="lt1"/>
-              </a:fillRef>
-              <a:effectRef idx="0">
-                <a:schemeClr val="dk1"/>
-              </a:effectRef>
-              <a:fontRef idx="minor">
-                <a:schemeClr val="dk1"/>
-              </a:fontRef>
-            </p:style>
-            <p:txBody>
-              <a:bodyPr rtlCol="0" anchor="ctr"/>
-              <a:lstStyle/>
-              <a:p>
-                <a:pPr algn="ctr"/>
-                <a:endParaRPr lang="en-US"/>
-              </a:p>
-            </p:txBody>
-          </p:sp>
-          <p:sp>
-            <p:nvSpPr>
-              <p:cNvPr id="333" name="Trapezoid 332">
-                <a:extLst>
-                  <a:ext uri="{FF2B5EF4-FFF2-40B4-BE49-F238E27FC236}">
-                    <a16:creationId xmlns:a16="http://schemas.microsoft.com/office/drawing/2014/main" id="{6FA67849-F3A4-D169-FBD0-2987BE6B9DA3}"/>
-                  </a:ext>
-                </a:extLst>
-              </p:cNvPr>
-              <p:cNvSpPr/>
-              <p:nvPr/>
-            </p:nvSpPr>
-            <p:spPr>
-              <a:xfrm rot="15639411">
-                <a:off x="3588611" y="1898339"/>
-                <a:ext cx="806450" cy="824442"/>
-              </a:xfrm>
-              <a:prstGeom prst="trapezoid">
-                <a:avLst>
-                  <a:gd name="adj" fmla="val 15303"/>
-                </a:avLst>
-              </a:prstGeom>
-            </p:spPr>
-            <p:style>
-              <a:lnRef idx="2">
-                <a:schemeClr val="dk1">
-                  <a:shade val="50000"/>
-                </a:schemeClr>
-              </a:lnRef>
-              <a:fillRef idx="1">
-                <a:schemeClr val="dk1"/>
-              </a:fillRef>
-              <a:effectRef idx="0">
-                <a:schemeClr val="dk1"/>
-              </a:effectRef>
-              <a:fontRef idx="minor">
-                <a:schemeClr val="lt1"/>
-              </a:fontRef>
-            </p:style>
-            <p:txBody>
-              <a:bodyPr rtlCol="0" anchor="ctr"/>
-              <a:lstStyle/>
-              <a:p>
-                <a:pPr algn="ctr"/>
-                <a:endParaRPr lang="en-US"/>
-              </a:p>
-            </p:txBody>
-          </p:sp>
-          <p:sp>
-            <p:nvSpPr>
-              <p:cNvPr id="334" name="Isosceles Triangle 333">
-                <a:extLst>
-                  <a:ext uri="{FF2B5EF4-FFF2-40B4-BE49-F238E27FC236}">
-                    <a16:creationId xmlns:a16="http://schemas.microsoft.com/office/drawing/2014/main" id="{F875D4DC-7385-1E3A-92DE-9B40A84E4BD9}"/>
-                  </a:ext>
-                </a:extLst>
-              </p:cNvPr>
-              <p:cNvSpPr/>
-              <p:nvPr/>
-            </p:nvSpPr>
-            <p:spPr>
-              <a:xfrm rot="14248003">
-                <a:off x="2851235" y="2409712"/>
-                <a:ext cx="388815" cy="407297"/>
-              </a:xfrm>
-              <a:prstGeom prst="triangle">
-                <a:avLst/>
-              </a:prstGeom>
-            </p:spPr>
-            <p:style>
-              <a:lnRef idx="2">
-                <a:schemeClr val="dk1">
-                  <a:shade val="50000"/>
-                </a:schemeClr>
-              </a:lnRef>
-              <a:fillRef idx="1">
-                <a:schemeClr val="dk1"/>
-              </a:fillRef>
-              <a:effectRef idx="0">
-                <a:schemeClr val="dk1"/>
-              </a:effectRef>
-              <a:fontRef idx="minor">
-                <a:schemeClr val="lt1"/>
-              </a:fontRef>
-            </p:style>
-            <p:txBody>
-              <a:bodyPr rtlCol="0" anchor="ctr"/>
-              <a:lstStyle/>
-              <a:p>
-                <a:pPr algn="ctr"/>
-                <a:endParaRPr lang="en-US"/>
-              </a:p>
-            </p:txBody>
-          </p:sp>
-          <p:sp>
-            <p:nvSpPr>
-              <p:cNvPr id="335" name="Oval 334">
-                <a:extLst>
-                  <a:ext uri="{FF2B5EF4-FFF2-40B4-BE49-F238E27FC236}">
-                    <a16:creationId xmlns:a16="http://schemas.microsoft.com/office/drawing/2014/main" id="{C7DDC445-B33C-8CB5-68CE-C55C65096E7A}"/>
-                  </a:ext>
-                </a:extLst>
-              </p:cNvPr>
-              <p:cNvSpPr/>
-              <p:nvPr/>
-            </p:nvSpPr>
-            <p:spPr>
-              <a:xfrm>
-                <a:off x="3087822" y="1907372"/>
-                <a:ext cx="979410" cy="979410"/>
-              </a:xfrm>
-              <a:prstGeom prst="ellipse">
-                <a:avLst/>
-              </a:prstGeom>
-              <a:ln w="19050"/>
-            </p:spPr>
-            <p:style>
-              <a:lnRef idx="2">
-                <a:schemeClr val="dk1"/>
-              </a:lnRef>
-              <a:fillRef idx="1">
-                <a:schemeClr val="lt1"/>
-              </a:fillRef>
-              <a:effectRef idx="0">
-                <a:schemeClr val="dk1"/>
-              </a:effectRef>
-              <a:fontRef idx="minor">
-                <a:schemeClr val="dk1"/>
-              </a:fontRef>
-            </p:style>
-            <p:txBody>
-              <a:bodyPr rtlCol="0" anchor="ctr"/>
-              <a:lstStyle/>
-              <a:p>
-                <a:pPr algn="ctr"/>
-                <a:endParaRPr lang="en-US"/>
-              </a:p>
-            </p:txBody>
-          </p:sp>
-        </p:grpSp>
-        <p:sp>
-          <p:nvSpPr>
-            <p:cNvPr id="324" name="Trapezoid 323">
-              <a:extLst>
-                <a:ext uri="{FF2B5EF4-FFF2-40B4-BE49-F238E27FC236}">
-                  <a16:creationId xmlns:a16="http://schemas.microsoft.com/office/drawing/2014/main" id="{D4781322-EF42-0A95-0672-83C3F93E7A17}"/>
-                </a:ext>
-              </a:extLst>
-            </p:cNvPr>
-            <p:cNvSpPr/>
-            <p:nvPr/>
-          </p:nvSpPr>
-          <p:spPr>
-            <a:xfrm>
-              <a:off x="4391733" y="1120756"/>
-              <a:ext cx="417684" cy="428229"/>
-            </a:xfrm>
-            <a:prstGeom prst="trapezoid">
-              <a:avLst/>
-            </a:prstGeom>
-          </p:spPr>
-          <p:style>
-            <a:lnRef idx="2">
-              <a:schemeClr val="dk1"/>
-            </a:lnRef>
-            <a:fillRef idx="1">
-              <a:schemeClr val="lt1"/>
-            </a:fillRef>
-            <a:effectRef idx="0">
-              <a:schemeClr val="dk1"/>
-            </a:effectRef>
-            <a:fontRef idx="minor">
-              <a:schemeClr val="dk1"/>
-            </a:fontRef>
-          </p:style>
-          <p:txBody>
-            <a:bodyPr rtlCol="0" anchor="ctr"/>
-            <a:lstStyle/>
-            <a:p>
-              <a:pPr algn="ctr"/>
-              <a:endParaRPr lang="en-US"/>
-            </a:p>
-          </p:txBody>
-        </p:sp>
-        <p:grpSp>
-          <p:nvGrpSpPr>
-            <p:cNvPr id="325" name="Group 324">
-              <a:extLst>
-                <a:ext uri="{FF2B5EF4-FFF2-40B4-BE49-F238E27FC236}">
-                  <a16:creationId xmlns:a16="http://schemas.microsoft.com/office/drawing/2014/main" id="{5DF009FB-EF3B-77E6-2E7E-99F4B2FD04F4}"/>
-                </a:ext>
-              </a:extLst>
-            </p:cNvPr>
-            <p:cNvGrpSpPr/>
-            <p:nvPr/>
-          </p:nvGrpSpPr>
-          <p:grpSpPr>
-            <a:xfrm flipH="1">
-              <a:off x="4809417" y="1514012"/>
-              <a:ext cx="1562063" cy="1372483"/>
-              <a:chOff x="2841994" y="1514299"/>
-              <a:chExt cx="1562063" cy="1372483"/>
-            </a:xfrm>
-          </p:grpSpPr>
-          <p:sp>
-            <p:nvSpPr>
-              <p:cNvPr id="326" name="Rectangle 325">
-                <a:extLst>
-                  <a:ext uri="{FF2B5EF4-FFF2-40B4-BE49-F238E27FC236}">
-                    <a16:creationId xmlns:a16="http://schemas.microsoft.com/office/drawing/2014/main" id="{CE9A6C7A-7F94-4551-0B54-77AE8C822945}"/>
-                  </a:ext>
-                </a:extLst>
-              </p:cNvPr>
-              <p:cNvSpPr/>
-              <p:nvPr/>
-            </p:nvSpPr>
-            <p:spPr>
-              <a:xfrm>
-                <a:off x="3453258" y="1667895"/>
-                <a:ext cx="241300" cy="1016415"/>
-              </a:xfrm>
-              <a:prstGeom prst="rect">
-                <a:avLst/>
-              </a:prstGeom>
-            </p:spPr>
-            <p:style>
-              <a:lnRef idx="2">
-                <a:schemeClr val="dk1"/>
-              </a:lnRef>
-              <a:fillRef idx="1">
-                <a:schemeClr val="lt1"/>
-              </a:fillRef>
-              <a:effectRef idx="0">
-                <a:schemeClr val="dk1"/>
-              </a:effectRef>
-              <a:fontRef idx="minor">
-                <a:schemeClr val="dk1"/>
-              </a:fontRef>
-            </p:style>
-            <p:txBody>
-              <a:bodyPr rtlCol="0" anchor="ctr"/>
-              <a:lstStyle/>
-              <a:p>
-                <a:pPr algn="ctr"/>
-                <a:endParaRPr lang="en-US"/>
-              </a:p>
-            </p:txBody>
-          </p:sp>
-          <p:sp>
-            <p:nvSpPr>
-              <p:cNvPr id="327" name="Rectangle 326">
-                <a:extLst>
-                  <a:ext uri="{FF2B5EF4-FFF2-40B4-BE49-F238E27FC236}">
-                    <a16:creationId xmlns:a16="http://schemas.microsoft.com/office/drawing/2014/main" id="{7461F050-8672-4098-9A68-50D6750708BB}"/>
-                  </a:ext>
-                </a:extLst>
-              </p:cNvPr>
-              <p:cNvSpPr/>
-              <p:nvPr/>
-            </p:nvSpPr>
-            <p:spPr>
-              <a:xfrm>
-                <a:off x="3879279" y="1514299"/>
-                <a:ext cx="241300" cy="1016415"/>
-              </a:xfrm>
-              <a:prstGeom prst="rect">
-                <a:avLst/>
-              </a:prstGeom>
-            </p:spPr>
-            <p:style>
-              <a:lnRef idx="2">
-                <a:schemeClr val="dk1"/>
-              </a:lnRef>
-              <a:fillRef idx="1">
-                <a:schemeClr val="lt1"/>
-              </a:fillRef>
-              <a:effectRef idx="0">
-                <a:schemeClr val="dk1"/>
-              </a:effectRef>
-              <a:fontRef idx="minor">
-                <a:schemeClr val="dk1"/>
-              </a:fontRef>
-            </p:style>
-            <p:txBody>
-              <a:bodyPr rtlCol="0" anchor="ctr"/>
-              <a:lstStyle/>
-              <a:p>
-                <a:pPr algn="ctr"/>
-                <a:endParaRPr lang="en-US"/>
-              </a:p>
-            </p:txBody>
-          </p:sp>
-          <p:sp>
-            <p:nvSpPr>
-              <p:cNvPr id="328" name="Trapezoid 327">
-                <a:extLst>
-                  <a:ext uri="{FF2B5EF4-FFF2-40B4-BE49-F238E27FC236}">
-                    <a16:creationId xmlns:a16="http://schemas.microsoft.com/office/drawing/2014/main" id="{BB5AB281-6ACA-E753-6DB4-32918352C272}"/>
-                  </a:ext>
-                </a:extLst>
-              </p:cNvPr>
-              <p:cNvSpPr/>
-              <p:nvPr/>
-            </p:nvSpPr>
-            <p:spPr>
-              <a:xfrm rot="15639411">
-                <a:off x="3588611" y="1898339"/>
-                <a:ext cx="806450" cy="824442"/>
-              </a:xfrm>
-              <a:prstGeom prst="trapezoid">
-                <a:avLst>
-                  <a:gd name="adj" fmla="val 15303"/>
-                </a:avLst>
-              </a:prstGeom>
-            </p:spPr>
-            <p:style>
-              <a:lnRef idx="2">
-                <a:schemeClr val="dk1">
-                  <a:shade val="50000"/>
-                </a:schemeClr>
-              </a:lnRef>
-              <a:fillRef idx="1">
-                <a:schemeClr val="dk1"/>
-              </a:fillRef>
-              <a:effectRef idx="0">
-                <a:schemeClr val="dk1"/>
-              </a:effectRef>
-              <a:fontRef idx="minor">
-                <a:schemeClr val="lt1"/>
-              </a:fontRef>
-            </p:style>
-            <p:txBody>
-              <a:bodyPr rtlCol="0" anchor="ctr"/>
-              <a:lstStyle/>
-              <a:p>
-                <a:pPr algn="ctr"/>
-                <a:endParaRPr lang="en-US"/>
-              </a:p>
-            </p:txBody>
-          </p:sp>
-          <p:sp>
-            <p:nvSpPr>
-              <p:cNvPr id="329" name="Isosceles Triangle 328">
-                <a:extLst>
-                  <a:ext uri="{FF2B5EF4-FFF2-40B4-BE49-F238E27FC236}">
-                    <a16:creationId xmlns:a16="http://schemas.microsoft.com/office/drawing/2014/main" id="{7D7AC445-6078-CB06-53BE-27E528AABA29}"/>
-                  </a:ext>
-                </a:extLst>
-              </p:cNvPr>
-              <p:cNvSpPr/>
-              <p:nvPr/>
-            </p:nvSpPr>
-            <p:spPr>
-              <a:xfrm rot="14248003">
-                <a:off x="2851235" y="2409712"/>
-                <a:ext cx="388815" cy="407297"/>
-              </a:xfrm>
-              <a:prstGeom prst="triangle">
-                <a:avLst/>
-              </a:prstGeom>
-            </p:spPr>
-            <p:style>
-              <a:lnRef idx="2">
-                <a:schemeClr val="dk1">
-                  <a:shade val="50000"/>
-                </a:schemeClr>
-              </a:lnRef>
-              <a:fillRef idx="1">
-                <a:schemeClr val="dk1"/>
-              </a:fillRef>
-              <a:effectRef idx="0">
-                <a:schemeClr val="dk1"/>
-              </a:effectRef>
-              <a:fontRef idx="minor">
-                <a:schemeClr val="lt1"/>
-              </a:fontRef>
-            </p:style>
-            <p:txBody>
-              <a:bodyPr rtlCol="0" anchor="ctr"/>
-              <a:lstStyle/>
-              <a:p>
-                <a:pPr algn="ctr"/>
-                <a:endParaRPr lang="en-US"/>
-              </a:p>
-            </p:txBody>
-          </p:sp>
-          <p:sp>
-            <p:nvSpPr>
-              <p:cNvPr id="330" name="Oval 329">
-                <a:extLst>
-                  <a:ext uri="{FF2B5EF4-FFF2-40B4-BE49-F238E27FC236}">
-                    <a16:creationId xmlns:a16="http://schemas.microsoft.com/office/drawing/2014/main" id="{9C876087-7DB7-C733-8899-D07F6D9A07C1}"/>
-                  </a:ext>
-                </a:extLst>
-              </p:cNvPr>
-              <p:cNvSpPr/>
-              <p:nvPr/>
-            </p:nvSpPr>
-            <p:spPr>
-              <a:xfrm>
-                <a:off x="3087822" y="1907372"/>
-                <a:ext cx="979410" cy="979410"/>
-              </a:xfrm>
-              <a:prstGeom prst="ellipse">
-                <a:avLst/>
-              </a:prstGeom>
-              <a:ln w="19050"/>
-            </p:spPr>
-            <p:style>
-              <a:lnRef idx="2">
-                <a:schemeClr val="dk1"/>
-              </a:lnRef>
-              <a:fillRef idx="1">
-                <a:schemeClr val="lt1"/>
-              </a:fillRef>
-              <a:effectRef idx="0">
-                <a:schemeClr val="dk1"/>
-              </a:effectRef>
-              <a:fontRef idx="minor">
-                <a:schemeClr val="dk1"/>
-              </a:fontRef>
-            </p:style>
-            <p:txBody>
-              <a:bodyPr rtlCol="0" anchor="ctr"/>
-              <a:lstStyle/>
-              <a:p>
-                <a:pPr algn="ctr"/>
-                <a:endParaRPr lang="en-US"/>
-              </a:p>
-            </p:txBody>
-          </p:sp>
-        </p:grpSp>
-      </p:grpSp>
-      <p:grpSp>
-        <p:nvGrpSpPr>
           <p:cNvPr id="313" name="Group 312">
             <a:extLst>
               <a:ext uri="{FF2B5EF4-FFF2-40B4-BE49-F238E27FC236}">
@@ -15975,6 +15148,180 @@
             </a:effectRef>
             <a:fontRef idx="minor">
               <a:schemeClr val="lt1"/>
+            </a:fontRef>
+          </p:style>
+          <p:txBody>
+            <a:bodyPr rtlCol="0" anchor="ctr"/>
+            <a:lstStyle/>
+            <a:p>
+              <a:pPr algn="ctr"/>
+              <a:endParaRPr lang="en-US"/>
+            </a:p>
+          </p:txBody>
+        </p:sp>
+      </p:grpSp>
+      <p:pic>
+        <p:nvPicPr>
+          <p:cNvPr id="382" name="Picture 2" descr="Apache helicopter | Stock vector | Colourbox">
+            <a:extLst>
+              <a:ext uri="{FF2B5EF4-FFF2-40B4-BE49-F238E27FC236}">
+                <a16:creationId xmlns:a16="http://schemas.microsoft.com/office/drawing/2014/main" id="{C2DF8D61-4337-5458-818A-2158BC02D8EA}"/>
+              </a:ext>
+            </a:extLst>
+          </p:cNvPr>
+          <p:cNvPicPr>
+            <a:picLocks noChangeAspect="1" noChangeArrowheads="1"/>
+          </p:cNvPicPr>
+          <p:nvPr/>
+        </p:nvPicPr>
+        <p:blipFill>
+          <a:blip r:embed="rId7">
+            <a:extLst>
+              <a:ext uri="{28A0092B-C50C-407E-A947-70E740481C1C}">
+                <a14:useLocalDpi xmlns:a14="http://schemas.microsoft.com/office/drawing/2010/main" val="0"/>
+              </a:ext>
+            </a:extLst>
+          </a:blip>
+          <a:srcRect/>
+          <a:stretch>
+            <a:fillRect/>
+          </a:stretch>
+        </p:blipFill>
+        <p:spPr bwMode="auto">
+          <a:xfrm rot="858473">
+            <a:off x="3845270" y="4089744"/>
+            <a:ext cx="841728" cy="655496"/>
+          </a:xfrm>
+          <a:prstGeom prst="rect">
+            <a:avLst/>
+          </a:prstGeom>
+          <a:noFill/>
+          <a:extLst>
+            <a:ext uri="{909E8E84-426E-40DD-AFC4-6F175D3DCCD1}">
+              <a14:hiddenFill xmlns:a14="http://schemas.microsoft.com/office/drawing/2010/main">
+                <a:solidFill>
+                  <a:srgbClr val="FFFFFF"/>
+                </a:solidFill>
+              </a14:hiddenFill>
+            </a:ext>
+          </a:extLst>
+        </p:spPr>
+      </p:pic>
+      <p:grpSp>
+        <p:nvGrpSpPr>
+          <p:cNvPr id="383" name="Group 382">
+            <a:extLst>
+              <a:ext uri="{FF2B5EF4-FFF2-40B4-BE49-F238E27FC236}">
+                <a16:creationId xmlns:a16="http://schemas.microsoft.com/office/drawing/2014/main" id="{D44689B5-EC73-57FD-5184-0121E6688C9F}"/>
+              </a:ext>
+            </a:extLst>
+          </p:cNvPr>
+          <p:cNvGrpSpPr/>
+          <p:nvPr/>
+        </p:nvGrpSpPr>
+        <p:grpSpPr>
+          <a:xfrm>
+            <a:off x="3580335" y="3896688"/>
+            <a:ext cx="1371600" cy="1371600"/>
+            <a:chOff x="1298501" y="962272"/>
+            <a:chExt cx="1371600" cy="1371600"/>
+          </a:xfrm>
+        </p:grpSpPr>
+        <p:sp>
+          <p:nvSpPr>
+            <p:cNvPr id="384" name="Rectangle 383">
+              <a:extLst>
+                <a:ext uri="{FF2B5EF4-FFF2-40B4-BE49-F238E27FC236}">
+                  <a16:creationId xmlns:a16="http://schemas.microsoft.com/office/drawing/2014/main" id="{FE3BBA60-C1E2-A7A2-757B-CE332EF2F26D}"/>
+                </a:ext>
+              </a:extLst>
+            </p:cNvPr>
+            <p:cNvSpPr/>
+            <p:nvPr/>
+          </p:nvSpPr>
+          <p:spPr>
+            <a:xfrm>
+              <a:off x="1298501" y="962272"/>
+              <a:ext cx="1371600" cy="1371600"/>
+            </a:xfrm>
+            <a:prstGeom prst="rect">
+              <a:avLst/>
+            </a:prstGeom>
+            <a:noFill/>
+            <a:ln w="76200">
+              <a:solidFill>
+                <a:schemeClr val="tx1"/>
+              </a:solidFill>
+            </a:ln>
+          </p:spPr>
+          <p:style>
+            <a:lnRef idx="2">
+              <a:schemeClr val="accent1">
+                <a:shade val="50000"/>
+              </a:schemeClr>
+            </a:lnRef>
+            <a:fillRef idx="1">
+              <a:schemeClr val="accent1"/>
+            </a:fillRef>
+            <a:effectRef idx="0">
+              <a:schemeClr val="accent1"/>
+            </a:effectRef>
+            <a:fontRef idx="minor">
+              <a:schemeClr val="lt1"/>
+            </a:fontRef>
+          </p:style>
+          <p:txBody>
+            <a:bodyPr rtlCol="0" anchor="ctr"/>
+            <a:lstStyle/>
+            <a:p>
+              <a:pPr algn="ctr"/>
+              <a:endParaRPr lang="en-US"/>
+            </a:p>
+          </p:txBody>
+        </p:sp>
+        <p:sp>
+          <p:nvSpPr>
+            <p:cNvPr id="385" name="Arrow: Pentagon 384">
+              <a:extLst>
+                <a:ext uri="{FF2B5EF4-FFF2-40B4-BE49-F238E27FC236}">
+                  <a16:creationId xmlns:a16="http://schemas.microsoft.com/office/drawing/2014/main" id="{404C6780-37D4-CE10-0EFA-6FB3A3A5D7EE}"/>
+                </a:ext>
+              </a:extLst>
+            </p:cNvPr>
+            <p:cNvSpPr/>
+            <p:nvPr/>
+          </p:nvSpPr>
+          <p:spPr>
+            <a:xfrm rot="5400000">
+              <a:off x="1435661" y="1173775"/>
+              <a:ext cx="1097280" cy="1097280"/>
+            </a:xfrm>
+            <a:prstGeom prst="homePlate">
+              <a:avLst/>
+            </a:prstGeom>
+            <a:noFill/>
+            <a:ln w="38100" cap="flat" cmpd="sng" algn="ctr">
+              <a:solidFill>
+                <a:schemeClr val="dk1"/>
+              </a:solidFill>
+              <a:prstDash val="solid"/>
+              <a:round/>
+              <a:headEnd type="none" w="med" len="med"/>
+              <a:tailEnd type="none" w="med" len="med"/>
+            </a:ln>
+          </p:spPr>
+          <p:style>
+            <a:lnRef idx="0">
+              <a:scrgbClr r="0" g="0" b="0"/>
+            </a:lnRef>
+            <a:fillRef idx="0">
+              <a:scrgbClr r="0" g="0" b="0"/>
+            </a:fillRef>
+            <a:effectRef idx="0">
+              <a:scrgbClr r="0" g="0" b="0"/>
+            </a:effectRef>
+            <a:fontRef idx="minor">
+              <a:schemeClr val="dk1"/>
             </a:fontRef>
           </p:style>
           <p:txBody>
@@ -32376,6 +31723,53 @@
       </p:grpSpPr>
       <p:pic>
         <p:nvPicPr>
+          <p:cNvPr id="1026" name="Picture 2" descr="Apache helicopter | Stock vector | Colourbox">
+            <a:extLst>
+              <a:ext uri="{FF2B5EF4-FFF2-40B4-BE49-F238E27FC236}">
+                <a16:creationId xmlns:a16="http://schemas.microsoft.com/office/drawing/2014/main" id="{BD2C1E31-2083-6A06-13B2-5C29A223DB60}"/>
+              </a:ext>
+            </a:extLst>
+          </p:cNvPr>
+          <p:cNvPicPr>
+            <a:picLocks noChangeAspect="1" noChangeArrowheads="1"/>
+          </p:cNvPicPr>
+          <p:nvPr/>
+        </p:nvPicPr>
+        <p:blipFill>
+          <a:blip r:embed="rId2">
+            <a:extLst>
+              <a:ext uri="{28A0092B-C50C-407E-A947-70E740481C1C}">
+                <a14:useLocalDpi xmlns:a14="http://schemas.microsoft.com/office/drawing/2010/main" val="0"/>
+              </a:ext>
+            </a:extLst>
+          </a:blip>
+          <a:srcRect/>
+          <a:stretch>
+            <a:fillRect/>
+          </a:stretch>
+        </p:blipFill>
+        <p:spPr bwMode="auto">
+          <a:xfrm rot="858473">
+            <a:off x="4765990" y="756281"/>
+            <a:ext cx="841728" cy="655496"/>
+          </a:xfrm>
+          <a:prstGeom prst="rect">
+            <a:avLst/>
+          </a:prstGeom>
+          <a:noFill/>
+          <a:extLst>
+            <a:ext uri="{909E8E84-426E-40DD-AFC4-6F175D3DCCD1}">
+              <a14:hiddenFill xmlns:a14="http://schemas.microsoft.com/office/drawing/2010/main">
+                <a:solidFill>
+                  <a:srgbClr val="FFFFFF"/>
+                </a:solidFill>
+              </a14:hiddenFill>
+            </a:ext>
+          </a:extLst>
+        </p:spPr>
+      </p:pic>
+      <p:pic>
+        <p:nvPicPr>
           <p:cNvPr id="60" name="Picture 2" descr="Mantis Silhouette Design Stock Vector (Royalty Free) 696869110 |  Shutterstock">
             <a:extLst>
               <a:ext uri="{FF2B5EF4-FFF2-40B4-BE49-F238E27FC236}">
@@ -32389,7 +31783,7 @@
           <p:nvPr/>
         </p:nvPicPr>
         <p:blipFill rotWithShape="1">
-          <a:blip r:embed="rId2">
+          <a:blip r:embed="rId3">
             <a:extLst>
               <a:ext uri="{28A0092B-C50C-407E-A947-70E740481C1C}">
                 <a14:useLocalDpi xmlns:a14="http://schemas.microsoft.com/office/drawing/2010/main" val="0"/>
@@ -32434,7 +31828,7 @@
           <p:nvPr/>
         </p:nvPicPr>
         <p:blipFill rotWithShape="1">
-          <a:blip r:embed="rId2">
+          <a:blip r:embed="rId3">
             <a:extLst>
               <a:ext uri="{28A0092B-C50C-407E-A947-70E740481C1C}">
                 <a14:useLocalDpi xmlns:a14="http://schemas.microsoft.com/office/drawing/2010/main" val="0"/>
@@ -32934,7 +32328,7 @@
             <p:nvPr/>
           </p:nvPicPr>
           <p:blipFill rotWithShape="1">
-            <a:blip r:embed="rId2">
+            <a:blip r:embed="rId3">
               <a:extLst>
                 <a:ext uri="{28A0092B-C50C-407E-A947-70E740481C1C}">
                   <a14:useLocalDpi xmlns:a14="http://schemas.microsoft.com/office/drawing/2010/main" val="0"/>
@@ -33295,6 +32689,133 @@
             </p:txBody>
           </p:sp>
         </p:grpSp>
+      </p:grpSp>
+      <p:grpSp>
+        <p:nvGrpSpPr>
+          <p:cNvPr id="24" name="Group 23">
+            <a:extLst>
+              <a:ext uri="{FF2B5EF4-FFF2-40B4-BE49-F238E27FC236}">
+                <a16:creationId xmlns:a16="http://schemas.microsoft.com/office/drawing/2014/main" id="{C6535718-ED7C-8F2D-D975-8C3231CCBB84}"/>
+              </a:ext>
+            </a:extLst>
+          </p:cNvPr>
+          <p:cNvGrpSpPr/>
+          <p:nvPr/>
+        </p:nvGrpSpPr>
+        <p:grpSpPr>
+          <a:xfrm>
+            <a:off x="4501055" y="563225"/>
+            <a:ext cx="1371600" cy="1371600"/>
+            <a:chOff x="1298501" y="962272"/>
+            <a:chExt cx="1371600" cy="1371600"/>
+          </a:xfrm>
+        </p:grpSpPr>
+        <p:sp>
+          <p:nvSpPr>
+            <p:cNvPr id="25" name="Rectangle 24">
+              <a:extLst>
+                <a:ext uri="{FF2B5EF4-FFF2-40B4-BE49-F238E27FC236}">
+                  <a16:creationId xmlns:a16="http://schemas.microsoft.com/office/drawing/2014/main" id="{81B6D15A-D3E6-2C30-C75B-9FDA374FEA83}"/>
+                </a:ext>
+              </a:extLst>
+            </p:cNvPr>
+            <p:cNvSpPr/>
+            <p:nvPr/>
+          </p:nvSpPr>
+          <p:spPr>
+            <a:xfrm>
+              <a:off x="1298501" y="962272"/>
+              <a:ext cx="1371600" cy="1371600"/>
+            </a:xfrm>
+            <a:prstGeom prst="rect">
+              <a:avLst/>
+            </a:prstGeom>
+            <a:noFill/>
+            <a:ln w="76200">
+              <a:solidFill>
+                <a:schemeClr val="tx1"/>
+              </a:solidFill>
+            </a:ln>
+          </p:spPr>
+          <p:style>
+            <a:lnRef idx="2">
+              <a:schemeClr val="accent1">
+                <a:shade val="50000"/>
+              </a:schemeClr>
+            </a:lnRef>
+            <a:fillRef idx="1">
+              <a:schemeClr val="accent1"/>
+            </a:fillRef>
+            <a:effectRef idx="0">
+              <a:schemeClr val="accent1"/>
+            </a:effectRef>
+            <a:fontRef idx="minor">
+              <a:schemeClr val="lt1"/>
+            </a:fontRef>
+          </p:style>
+          <p:txBody>
+            <a:bodyPr rtlCol="0" anchor="ctr"/>
+            <a:lstStyle/>
+            <a:p>
+              <a:pPr algn="ctr"/>
+              <a:endParaRPr lang="en-US"/>
+            </a:p>
+          </p:txBody>
+        </p:sp>
+        <p:sp>
+          <p:nvSpPr>
+            <p:cNvPr id="26" name="Arrow: Pentagon 25">
+              <a:extLst>
+                <a:ext uri="{FF2B5EF4-FFF2-40B4-BE49-F238E27FC236}">
+                  <a16:creationId xmlns:a16="http://schemas.microsoft.com/office/drawing/2014/main" id="{62B76B23-3C28-9CE4-3EA8-5EB675CD4D76}"/>
+                </a:ext>
+              </a:extLst>
+            </p:cNvPr>
+            <p:cNvSpPr/>
+            <p:nvPr/>
+          </p:nvSpPr>
+          <p:spPr>
+            <a:xfrm rot="5400000">
+              <a:off x="1435661" y="1173775"/>
+              <a:ext cx="1097280" cy="1097280"/>
+            </a:xfrm>
+            <a:prstGeom prst="homePlate">
+              <a:avLst/>
+            </a:prstGeom>
+            <a:noFill/>
+            <a:ln w="38100" cap="flat" cmpd="sng" algn="ctr">
+              <a:solidFill>
+                <a:schemeClr val="dk1"/>
+              </a:solidFill>
+              <a:prstDash val="solid"/>
+              <a:round/>
+              <a:headEnd type="none" w="med" len="med"/>
+              <a:tailEnd type="none" w="med" len="med"/>
+            </a:ln>
+          </p:spPr>
+          <p:style>
+            <a:lnRef idx="0">
+              <a:scrgbClr r="0" g="0" b="0"/>
+            </a:lnRef>
+            <a:fillRef idx="0">
+              <a:scrgbClr r="0" g="0" b="0"/>
+            </a:fillRef>
+            <a:effectRef idx="0">
+              <a:scrgbClr r="0" g="0" b="0"/>
+            </a:effectRef>
+            <a:fontRef idx="minor">
+              <a:schemeClr val="dk1"/>
+            </a:fontRef>
+          </p:style>
+          <p:txBody>
+            <a:bodyPr rtlCol="0" anchor="ctr"/>
+            <a:lstStyle/>
+            <a:p>
+              <a:pPr algn="ctr"/>
+              <a:endParaRPr lang="en-US"/>
+            </a:p>
+          </p:txBody>
+        </p:sp>
       </p:grpSp>
     </p:spTree>
     <p:extLst>

</xml_diff>

<commit_message>
Add HellfireChariot and KillDrone to terran
</commit_message>
<xml_diff>
--- a/image process/drawings sifi.pptx
+++ b/image process/drawings sifi.pptx
@@ -200,7 +200,7 @@
           <a:p>
             <a:fld id="{7700C406-2328-4788-AE79-437B6607AD22}" type="datetimeFigureOut">
               <a:rPr lang="en-US" smtClean="0"/>
-              <a:t>12/10/2022</a:t>
+              <a:t>1/7/2023</a:t>
             </a:fld>
             <a:endParaRPr lang="en-US"/>
           </a:p>
@@ -614,7 +614,7 @@
           <a:p>
             <a:fld id="{9EC8CD53-0620-48F2-A3BB-2B10BDA60E52}" type="datetimeFigureOut">
               <a:rPr lang="en-US" smtClean="0"/>
-              <a:t>12/10/2022</a:t>
+              <a:t>1/7/2023</a:t>
             </a:fld>
             <a:endParaRPr lang="en-US"/>
           </a:p>
@@ -812,7 +812,7 @@
           <a:p>
             <a:fld id="{9EC8CD53-0620-48F2-A3BB-2B10BDA60E52}" type="datetimeFigureOut">
               <a:rPr lang="en-US" smtClean="0"/>
-              <a:t>12/10/2022</a:t>
+              <a:t>1/7/2023</a:t>
             </a:fld>
             <a:endParaRPr lang="en-US"/>
           </a:p>
@@ -1020,7 +1020,7 @@
           <a:p>
             <a:fld id="{9EC8CD53-0620-48F2-A3BB-2B10BDA60E52}" type="datetimeFigureOut">
               <a:rPr lang="en-US" smtClean="0"/>
-              <a:t>12/10/2022</a:t>
+              <a:t>1/7/2023</a:t>
             </a:fld>
             <a:endParaRPr lang="en-US"/>
           </a:p>
@@ -1218,7 +1218,7 @@
           <a:p>
             <a:fld id="{9EC8CD53-0620-48F2-A3BB-2B10BDA60E52}" type="datetimeFigureOut">
               <a:rPr lang="en-US" smtClean="0"/>
-              <a:t>12/10/2022</a:t>
+              <a:t>1/7/2023</a:t>
             </a:fld>
             <a:endParaRPr lang="en-US"/>
           </a:p>
@@ -1493,7 +1493,7 @@
           <a:p>
             <a:fld id="{9EC8CD53-0620-48F2-A3BB-2B10BDA60E52}" type="datetimeFigureOut">
               <a:rPr lang="en-US" smtClean="0"/>
-              <a:t>12/10/2022</a:t>
+              <a:t>1/7/2023</a:t>
             </a:fld>
             <a:endParaRPr lang="en-US"/>
           </a:p>
@@ -1758,7 +1758,7 @@
           <a:p>
             <a:fld id="{9EC8CD53-0620-48F2-A3BB-2B10BDA60E52}" type="datetimeFigureOut">
               <a:rPr lang="en-US" smtClean="0"/>
-              <a:t>12/10/2022</a:t>
+              <a:t>1/7/2023</a:t>
             </a:fld>
             <a:endParaRPr lang="en-US"/>
           </a:p>
@@ -2170,7 +2170,7 @@
           <a:p>
             <a:fld id="{9EC8CD53-0620-48F2-A3BB-2B10BDA60E52}" type="datetimeFigureOut">
               <a:rPr lang="en-US" smtClean="0"/>
-              <a:t>12/10/2022</a:t>
+              <a:t>1/7/2023</a:t>
             </a:fld>
             <a:endParaRPr lang="en-US"/>
           </a:p>
@@ -2311,7 +2311,7 @@
           <a:p>
             <a:fld id="{9EC8CD53-0620-48F2-A3BB-2B10BDA60E52}" type="datetimeFigureOut">
               <a:rPr lang="en-US" smtClean="0"/>
-              <a:t>12/10/2022</a:t>
+              <a:t>1/7/2023</a:t>
             </a:fld>
             <a:endParaRPr lang="en-US"/>
           </a:p>
@@ -2424,7 +2424,7 @@
           <a:p>
             <a:fld id="{9EC8CD53-0620-48F2-A3BB-2B10BDA60E52}" type="datetimeFigureOut">
               <a:rPr lang="en-US" smtClean="0"/>
-              <a:t>12/10/2022</a:t>
+              <a:t>1/7/2023</a:t>
             </a:fld>
             <a:endParaRPr lang="en-US"/>
           </a:p>
@@ -2735,7 +2735,7 @@
           <a:p>
             <a:fld id="{9EC8CD53-0620-48F2-A3BB-2B10BDA60E52}" type="datetimeFigureOut">
               <a:rPr lang="en-US" smtClean="0"/>
-              <a:t>12/10/2022</a:t>
+              <a:t>1/7/2023</a:t>
             </a:fld>
             <a:endParaRPr lang="en-US"/>
           </a:p>
@@ -3023,7 +3023,7 @@
           <a:p>
             <a:fld id="{9EC8CD53-0620-48F2-A3BB-2B10BDA60E52}" type="datetimeFigureOut">
               <a:rPr lang="en-US" smtClean="0"/>
-              <a:t>12/10/2022</a:t>
+              <a:t>1/7/2023</a:t>
             </a:fld>
             <a:endParaRPr lang="en-US"/>
           </a:p>
@@ -3264,7 +3264,7 @@
           <a:p>
             <a:fld id="{9EC8CD53-0620-48F2-A3BB-2B10BDA60E52}" type="datetimeFigureOut">
               <a:rPr lang="en-US" smtClean="0"/>
-              <a:t>12/10/2022</a:t>
+              <a:t>1/7/2023</a:t>
             </a:fld>
             <a:endParaRPr lang="en-US"/>
           </a:p>
@@ -15160,180 +15160,6 @@
           </p:txBody>
         </p:sp>
       </p:grpSp>
-      <p:pic>
-        <p:nvPicPr>
-          <p:cNvPr id="382" name="Picture 2" descr="Apache helicopter | Stock vector | Colourbox">
-            <a:extLst>
-              <a:ext uri="{FF2B5EF4-FFF2-40B4-BE49-F238E27FC236}">
-                <a16:creationId xmlns:a16="http://schemas.microsoft.com/office/drawing/2014/main" id="{C2DF8D61-4337-5458-818A-2158BC02D8EA}"/>
-              </a:ext>
-            </a:extLst>
-          </p:cNvPr>
-          <p:cNvPicPr>
-            <a:picLocks noChangeAspect="1" noChangeArrowheads="1"/>
-          </p:cNvPicPr>
-          <p:nvPr/>
-        </p:nvPicPr>
-        <p:blipFill>
-          <a:blip r:embed="rId7">
-            <a:extLst>
-              <a:ext uri="{28A0092B-C50C-407E-A947-70E740481C1C}">
-                <a14:useLocalDpi xmlns:a14="http://schemas.microsoft.com/office/drawing/2010/main" val="0"/>
-              </a:ext>
-            </a:extLst>
-          </a:blip>
-          <a:srcRect/>
-          <a:stretch>
-            <a:fillRect/>
-          </a:stretch>
-        </p:blipFill>
-        <p:spPr bwMode="auto">
-          <a:xfrm rot="858473">
-            <a:off x="3845270" y="4089744"/>
-            <a:ext cx="841728" cy="655496"/>
-          </a:xfrm>
-          <a:prstGeom prst="rect">
-            <a:avLst/>
-          </a:prstGeom>
-          <a:noFill/>
-          <a:extLst>
-            <a:ext uri="{909E8E84-426E-40DD-AFC4-6F175D3DCCD1}">
-              <a14:hiddenFill xmlns:a14="http://schemas.microsoft.com/office/drawing/2010/main">
-                <a:solidFill>
-                  <a:srgbClr val="FFFFFF"/>
-                </a:solidFill>
-              </a14:hiddenFill>
-            </a:ext>
-          </a:extLst>
-        </p:spPr>
-      </p:pic>
-      <p:grpSp>
-        <p:nvGrpSpPr>
-          <p:cNvPr id="383" name="Group 382">
-            <a:extLst>
-              <a:ext uri="{FF2B5EF4-FFF2-40B4-BE49-F238E27FC236}">
-                <a16:creationId xmlns:a16="http://schemas.microsoft.com/office/drawing/2014/main" id="{D44689B5-EC73-57FD-5184-0121E6688C9F}"/>
-              </a:ext>
-            </a:extLst>
-          </p:cNvPr>
-          <p:cNvGrpSpPr/>
-          <p:nvPr/>
-        </p:nvGrpSpPr>
-        <p:grpSpPr>
-          <a:xfrm>
-            <a:off x="3580335" y="3896688"/>
-            <a:ext cx="1371600" cy="1371600"/>
-            <a:chOff x="1298501" y="962272"/>
-            <a:chExt cx="1371600" cy="1371600"/>
-          </a:xfrm>
-        </p:grpSpPr>
-        <p:sp>
-          <p:nvSpPr>
-            <p:cNvPr id="384" name="Rectangle 383">
-              <a:extLst>
-                <a:ext uri="{FF2B5EF4-FFF2-40B4-BE49-F238E27FC236}">
-                  <a16:creationId xmlns:a16="http://schemas.microsoft.com/office/drawing/2014/main" id="{FE3BBA60-C1E2-A7A2-757B-CE332EF2F26D}"/>
-                </a:ext>
-              </a:extLst>
-            </p:cNvPr>
-            <p:cNvSpPr/>
-            <p:nvPr/>
-          </p:nvSpPr>
-          <p:spPr>
-            <a:xfrm>
-              <a:off x="1298501" y="962272"/>
-              <a:ext cx="1371600" cy="1371600"/>
-            </a:xfrm>
-            <a:prstGeom prst="rect">
-              <a:avLst/>
-            </a:prstGeom>
-            <a:noFill/>
-            <a:ln w="76200">
-              <a:solidFill>
-                <a:schemeClr val="tx1"/>
-              </a:solidFill>
-            </a:ln>
-          </p:spPr>
-          <p:style>
-            <a:lnRef idx="2">
-              <a:schemeClr val="accent1">
-                <a:shade val="50000"/>
-              </a:schemeClr>
-            </a:lnRef>
-            <a:fillRef idx="1">
-              <a:schemeClr val="accent1"/>
-            </a:fillRef>
-            <a:effectRef idx="0">
-              <a:schemeClr val="accent1"/>
-            </a:effectRef>
-            <a:fontRef idx="minor">
-              <a:schemeClr val="lt1"/>
-            </a:fontRef>
-          </p:style>
-          <p:txBody>
-            <a:bodyPr rtlCol="0" anchor="ctr"/>
-            <a:lstStyle/>
-            <a:p>
-              <a:pPr algn="ctr"/>
-              <a:endParaRPr lang="en-US"/>
-            </a:p>
-          </p:txBody>
-        </p:sp>
-        <p:sp>
-          <p:nvSpPr>
-            <p:cNvPr id="385" name="Arrow: Pentagon 384">
-              <a:extLst>
-                <a:ext uri="{FF2B5EF4-FFF2-40B4-BE49-F238E27FC236}">
-                  <a16:creationId xmlns:a16="http://schemas.microsoft.com/office/drawing/2014/main" id="{404C6780-37D4-CE10-0EFA-6FB3A3A5D7EE}"/>
-                </a:ext>
-              </a:extLst>
-            </p:cNvPr>
-            <p:cNvSpPr/>
-            <p:nvPr/>
-          </p:nvSpPr>
-          <p:spPr>
-            <a:xfrm rot="5400000">
-              <a:off x="1435661" y="1173775"/>
-              <a:ext cx="1097280" cy="1097280"/>
-            </a:xfrm>
-            <a:prstGeom prst="homePlate">
-              <a:avLst/>
-            </a:prstGeom>
-            <a:noFill/>
-            <a:ln w="38100" cap="flat" cmpd="sng" algn="ctr">
-              <a:solidFill>
-                <a:schemeClr val="dk1"/>
-              </a:solidFill>
-              <a:prstDash val="solid"/>
-              <a:round/>
-              <a:headEnd type="none" w="med" len="med"/>
-              <a:tailEnd type="none" w="med" len="med"/>
-            </a:ln>
-          </p:spPr>
-          <p:style>
-            <a:lnRef idx="0">
-              <a:scrgbClr r="0" g="0" b="0"/>
-            </a:lnRef>
-            <a:fillRef idx="0">
-              <a:scrgbClr r="0" g="0" b="0"/>
-            </a:fillRef>
-            <a:effectRef idx="0">
-              <a:scrgbClr r="0" g="0" b="0"/>
-            </a:effectRef>
-            <a:fontRef idx="minor">
-              <a:schemeClr val="dk1"/>
-            </a:fontRef>
-          </p:style>
-          <p:txBody>
-            <a:bodyPr rtlCol="0" anchor="ctr"/>
-            <a:lstStyle/>
-            <a:p>
-              <a:pPr algn="ctr"/>
-              <a:endParaRPr lang="en-US"/>
-            </a:p>
-          </p:txBody>
-        </p:sp>
-      </p:grpSp>
       <p:grpSp>
         <p:nvGrpSpPr>
           <p:cNvPr id="316" name="Group 315">
@@ -16225,6 +16051,2979 @@
             </a:p>
           </p:txBody>
         </p:sp>
+      </p:grpSp>
+      <p:grpSp>
+        <p:nvGrpSpPr>
+          <p:cNvPr id="128" name="Group 127">
+            <a:extLst>
+              <a:ext uri="{FF2B5EF4-FFF2-40B4-BE49-F238E27FC236}">
+                <a16:creationId xmlns:a16="http://schemas.microsoft.com/office/drawing/2014/main" id="{0B84C4B5-AF52-5E8A-40AA-C9ECA2E1A76A}"/>
+              </a:ext>
+            </a:extLst>
+          </p:cNvPr>
+          <p:cNvGrpSpPr/>
+          <p:nvPr/>
+        </p:nvGrpSpPr>
+        <p:grpSpPr>
+          <a:xfrm>
+            <a:off x="3616187" y="3920973"/>
+            <a:ext cx="1371600" cy="1371600"/>
+            <a:chOff x="715109" y="5486400"/>
+            <a:chExt cx="1371600" cy="1371600"/>
+          </a:xfrm>
+        </p:grpSpPr>
+        <p:grpSp>
+          <p:nvGrpSpPr>
+            <p:cNvPr id="6" name="Group 5">
+              <a:extLst>
+                <a:ext uri="{FF2B5EF4-FFF2-40B4-BE49-F238E27FC236}">
+                  <a16:creationId xmlns:a16="http://schemas.microsoft.com/office/drawing/2014/main" id="{E1FB66F4-F153-7662-72E3-19A36A599D5A}"/>
+                </a:ext>
+              </a:extLst>
+            </p:cNvPr>
+            <p:cNvGrpSpPr/>
+            <p:nvPr/>
+          </p:nvGrpSpPr>
+          <p:grpSpPr>
+            <a:xfrm>
+              <a:off x="715109" y="5486400"/>
+              <a:ext cx="1371600" cy="1371600"/>
+              <a:chOff x="1298501" y="962272"/>
+              <a:chExt cx="1371600" cy="1371600"/>
+            </a:xfrm>
+          </p:grpSpPr>
+          <p:sp>
+            <p:nvSpPr>
+              <p:cNvPr id="25" name="Rectangle 24">
+                <a:extLst>
+                  <a:ext uri="{FF2B5EF4-FFF2-40B4-BE49-F238E27FC236}">
+                    <a16:creationId xmlns:a16="http://schemas.microsoft.com/office/drawing/2014/main" id="{32B74246-1CFA-F53C-D040-BB935974204F}"/>
+                  </a:ext>
+                </a:extLst>
+              </p:cNvPr>
+              <p:cNvSpPr/>
+              <p:nvPr/>
+            </p:nvSpPr>
+            <p:spPr>
+              <a:xfrm>
+                <a:off x="1298501" y="962272"/>
+                <a:ext cx="1371600" cy="1371600"/>
+              </a:xfrm>
+              <a:prstGeom prst="rect">
+                <a:avLst/>
+              </a:prstGeom>
+              <a:noFill/>
+              <a:ln w="76200">
+                <a:solidFill>
+                  <a:schemeClr val="tx1"/>
+                </a:solidFill>
+              </a:ln>
+            </p:spPr>
+            <p:style>
+              <a:lnRef idx="2">
+                <a:schemeClr val="accent1">
+                  <a:shade val="50000"/>
+                </a:schemeClr>
+              </a:lnRef>
+              <a:fillRef idx="1">
+                <a:schemeClr val="accent1"/>
+              </a:fillRef>
+              <a:effectRef idx="0">
+                <a:schemeClr val="accent1"/>
+              </a:effectRef>
+              <a:fontRef idx="minor">
+                <a:schemeClr val="lt1"/>
+              </a:fontRef>
+            </p:style>
+            <p:txBody>
+              <a:bodyPr rtlCol="0" anchor="ctr"/>
+              <a:lstStyle/>
+              <a:p>
+                <a:pPr algn="ctr"/>
+                <a:endParaRPr lang="en-US"/>
+              </a:p>
+            </p:txBody>
+          </p:sp>
+          <p:sp>
+            <p:nvSpPr>
+              <p:cNvPr id="27" name="Arrow: Pentagon 26">
+                <a:extLst>
+                  <a:ext uri="{FF2B5EF4-FFF2-40B4-BE49-F238E27FC236}">
+                    <a16:creationId xmlns:a16="http://schemas.microsoft.com/office/drawing/2014/main" id="{6206E87F-D348-92D4-BC1F-8C927C03E2E9}"/>
+                  </a:ext>
+                </a:extLst>
+              </p:cNvPr>
+              <p:cNvSpPr/>
+              <p:nvPr/>
+            </p:nvSpPr>
+            <p:spPr>
+              <a:xfrm rot="5400000">
+                <a:off x="1435661" y="1173775"/>
+                <a:ext cx="1097280" cy="1097280"/>
+              </a:xfrm>
+              <a:prstGeom prst="homePlate">
+                <a:avLst/>
+              </a:prstGeom>
+              <a:noFill/>
+              <a:ln w="38100" cap="flat" cmpd="sng" algn="ctr">
+                <a:solidFill>
+                  <a:schemeClr val="dk1"/>
+                </a:solidFill>
+                <a:prstDash val="solid"/>
+                <a:round/>
+                <a:headEnd type="none" w="med" len="med"/>
+                <a:tailEnd type="none" w="med" len="med"/>
+              </a:ln>
+            </p:spPr>
+            <p:style>
+              <a:lnRef idx="0">
+                <a:scrgbClr r="0" g="0" b="0"/>
+              </a:lnRef>
+              <a:fillRef idx="0">
+                <a:scrgbClr r="0" g="0" b="0"/>
+              </a:fillRef>
+              <a:effectRef idx="0">
+                <a:scrgbClr r="0" g="0" b="0"/>
+              </a:effectRef>
+              <a:fontRef idx="minor">
+                <a:schemeClr val="dk1"/>
+              </a:fontRef>
+            </p:style>
+            <p:txBody>
+              <a:bodyPr rtlCol="0" anchor="ctr"/>
+              <a:lstStyle/>
+              <a:p>
+                <a:pPr algn="ctr"/>
+                <a:endParaRPr lang="en-US"/>
+              </a:p>
+            </p:txBody>
+          </p:sp>
+        </p:grpSp>
+        <p:grpSp>
+          <p:nvGrpSpPr>
+            <p:cNvPr id="63" name="Group 62">
+              <a:extLst>
+                <a:ext uri="{FF2B5EF4-FFF2-40B4-BE49-F238E27FC236}">
+                  <a16:creationId xmlns:a16="http://schemas.microsoft.com/office/drawing/2014/main" id="{F374823A-B688-61AC-7732-4F4F2C4E9469}"/>
+                </a:ext>
+              </a:extLst>
+            </p:cNvPr>
+            <p:cNvGrpSpPr/>
+            <p:nvPr/>
+          </p:nvGrpSpPr>
+          <p:grpSpPr>
+            <a:xfrm>
+              <a:off x="988438" y="5737981"/>
+              <a:ext cx="824942" cy="550241"/>
+              <a:chOff x="2788414" y="3003550"/>
+              <a:chExt cx="2665648" cy="1778000"/>
+            </a:xfrm>
+          </p:grpSpPr>
+          <p:sp>
+            <p:nvSpPr>
+              <p:cNvPr id="79" name="Oval 78">
+                <a:extLst>
+                  <a:ext uri="{FF2B5EF4-FFF2-40B4-BE49-F238E27FC236}">
+                    <a16:creationId xmlns:a16="http://schemas.microsoft.com/office/drawing/2014/main" id="{87AB890A-D8AD-D493-115B-FD92AAC5DDBD}"/>
+                  </a:ext>
+                </a:extLst>
+              </p:cNvPr>
+              <p:cNvSpPr/>
+              <p:nvPr/>
+            </p:nvSpPr>
+            <p:spPr>
+              <a:xfrm>
+                <a:off x="3903803" y="3003550"/>
+                <a:ext cx="439245" cy="1778000"/>
+              </a:xfrm>
+              <a:prstGeom prst="ellipse">
+                <a:avLst/>
+              </a:prstGeom>
+            </p:spPr>
+            <p:style>
+              <a:lnRef idx="2">
+                <a:schemeClr val="dk1">
+                  <a:shade val="50000"/>
+                </a:schemeClr>
+              </a:lnRef>
+              <a:fillRef idx="1">
+                <a:schemeClr val="dk1"/>
+              </a:fillRef>
+              <a:effectRef idx="0">
+                <a:schemeClr val="dk1"/>
+              </a:effectRef>
+              <a:fontRef idx="minor">
+                <a:schemeClr val="lt1"/>
+              </a:fontRef>
+            </p:style>
+            <p:txBody>
+              <a:bodyPr rtlCol="0" anchor="ctr"/>
+              <a:lstStyle/>
+              <a:p>
+                <a:pPr algn="ctr"/>
+                <a:endParaRPr lang="en-US"/>
+              </a:p>
+            </p:txBody>
+          </p:sp>
+          <p:sp>
+            <p:nvSpPr>
+              <p:cNvPr id="80" name="Isosceles Triangle 79">
+                <a:extLst>
+                  <a:ext uri="{FF2B5EF4-FFF2-40B4-BE49-F238E27FC236}">
+                    <a16:creationId xmlns:a16="http://schemas.microsoft.com/office/drawing/2014/main" id="{A1ED84D3-550F-7D93-ED9C-E1865F7114CD}"/>
+                  </a:ext>
+                </a:extLst>
+              </p:cNvPr>
+              <p:cNvSpPr/>
+              <p:nvPr/>
+            </p:nvSpPr>
+            <p:spPr>
+              <a:xfrm>
+                <a:off x="2788414" y="3612890"/>
+                <a:ext cx="2665648" cy="1168660"/>
+              </a:xfrm>
+              <a:prstGeom prst="triangle">
+                <a:avLst/>
+              </a:prstGeom>
+            </p:spPr>
+            <p:style>
+              <a:lnRef idx="2">
+                <a:schemeClr val="dk1">
+                  <a:shade val="50000"/>
+                </a:schemeClr>
+              </a:lnRef>
+              <a:fillRef idx="1">
+                <a:schemeClr val="dk1"/>
+              </a:fillRef>
+              <a:effectRef idx="0">
+                <a:schemeClr val="dk1"/>
+              </a:effectRef>
+              <a:fontRef idx="minor">
+                <a:schemeClr val="lt1"/>
+              </a:fontRef>
+            </p:style>
+            <p:txBody>
+              <a:bodyPr rtlCol="0" anchor="ctr"/>
+              <a:lstStyle/>
+              <a:p>
+                <a:pPr algn="ctr"/>
+                <a:endParaRPr lang="en-US"/>
+              </a:p>
+            </p:txBody>
+          </p:sp>
+          <p:sp>
+            <p:nvSpPr>
+              <p:cNvPr id="81" name="Oval 80">
+                <a:extLst>
+                  <a:ext uri="{FF2B5EF4-FFF2-40B4-BE49-F238E27FC236}">
+                    <a16:creationId xmlns:a16="http://schemas.microsoft.com/office/drawing/2014/main" id="{804E6619-72FA-7F8A-BE5D-23C3A6397219}"/>
+                  </a:ext>
+                </a:extLst>
+              </p:cNvPr>
+              <p:cNvSpPr/>
+              <p:nvPr/>
+            </p:nvSpPr>
+            <p:spPr>
+              <a:xfrm>
+                <a:off x="3346707" y="4263156"/>
+                <a:ext cx="458369" cy="458369"/>
+              </a:xfrm>
+              <a:prstGeom prst="ellipse">
+                <a:avLst/>
+              </a:prstGeom>
+            </p:spPr>
+            <p:style>
+              <a:lnRef idx="2">
+                <a:schemeClr val="dk1"/>
+              </a:lnRef>
+              <a:fillRef idx="1">
+                <a:schemeClr val="lt1"/>
+              </a:fillRef>
+              <a:effectRef idx="0">
+                <a:schemeClr val="dk1"/>
+              </a:effectRef>
+              <a:fontRef idx="minor">
+                <a:schemeClr val="dk1"/>
+              </a:fontRef>
+            </p:style>
+            <p:txBody>
+              <a:bodyPr rtlCol="0" anchor="ctr"/>
+              <a:lstStyle/>
+              <a:p>
+                <a:pPr algn="ctr"/>
+                <a:endParaRPr lang="en-US"/>
+              </a:p>
+            </p:txBody>
+          </p:sp>
+          <p:sp>
+            <p:nvSpPr>
+              <p:cNvPr id="82" name="Oval 81">
+                <a:extLst>
+                  <a:ext uri="{FF2B5EF4-FFF2-40B4-BE49-F238E27FC236}">
+                    <a16:creationId xmlns:a16="http://schemas.microsoft.com/office/drawing/2014/main" id="{77F153C3-9CC3-C59F-BF76-4EEE46B37266}"/>
+                  </a:ext>
+                </a:extLst>
+              </p:cNvPr>
+              <p:cNvSpPr/>
+              <p:nvPr/>
+            </p:nvSpPr>
+            <p:spPr>
+              <a:xfrm>
+                <a:off x="4436723" y="4263156"/>
+                <a:ext cx="458369" cy="458369"/>
+              </a:xfrm>
+              <a:prstGeom prst="ellipse">
+                <a:avLst/>
+              </a:prstGeom>
+            </p:spPr>
+            <p:style>
+              <a:lnRef idx="2">
+                <a:schemeClr val="dk1"/>
+              </a:lnRef>
+              <a:fillRef idx="1">
+                <a:schemeClr val="lt1"/>
+              </a:fillRef>
+              <a:effectRef idx="0">
+                <a:schemeClr val="dk1"/>
+              </a:effectRef>
+              <a:fontRef idx="minor">
+                <a:schemeClr val="dk1"/>
+              </a:fontRef>
+            </p:style>
+            <p:txBody>
+              <a:bodyPr rtlCol="0" anchor="ctr"/>
+              <a:lstStyle/>
+              <a:p>
+                <a:pPr algn="ctr"/>
+                <a:endParaRPr lang="en-US"/>
+              </a:p>
+            </p:txBody>
+          </p:sp>
+        </p:grpSp>
+      </p:grpSp>
+      <p:grpSp>
+        <p:nvGrpSpPr>
+          <p:cNvPr id="129" name="Group 128">
+            <a:extLst>
+              <a:ext uri="{FF2B5EF4-FFF2-40B4-BE49-F238E27FC236}">
+                <a16:creationId xmlns:a16="http://schemas.microsoft.com/office/drawing/2014/main" id="{637DA29B-6C95-5204-DD7C-A5F435AB5129}"/>
+              </a:ext>
+            </a:extLst>
+          </p:cNvPr>
+          <p:cNvGrpSpPr/>
+          <p:nvPr/>
+        </p:nvGrpSpPr>
+        <p:grpSpPr>
+          <a:xfrm>
+            <a:off x="3624438" y="5458408"/>
+            <a:ext cx="1371600" cy="1371600"/>
+            <a:chOff x="2259485" y="5495736"/>
+            <a:chExt cx="1371600" cy="1371600"/>
+          </a:xfrm>
+        </p:grpSpPr>
+        <p:grpSp>
+          <p:nvGrpSpPr>
+            <p:cNvPr id="83" name="Group 82">
+              <a:extLst>
+                <a:ext uri="{FF2B5EF4-FFF2-40B4-BE49-F238E27FC236}">
+                  <a16:creationId xmlns:a16="http://schemas.microsoft.com/office/drawing/2014/main" id="{694F0217-E941-0DD7-CCAD-F7C4D35DF73E}"/>
+                </a:ext>
+              </a:extLst>
+            </p:cNvPr>
+            <p:cNvGrpSpPr/>
+            <p:nvPr/>
+          </p:nvGrpSpPr>
+          <p:grpSpPr>
+            <a:xfrm>
+              <a:off x="2558744" y="5779095"/>
+              <a:ext cx="770328" cy="575178"/>
+              <a:chOff x="7066650" y="3003550"/>
+              <a:chExt cx="2381250" cy="1778000"/>
+            </a:xfrm>
+          </p:grpSpPr>
+          <p:sp>
+            <p:nvSpPr>
+              <p:cNvPr id="84" name="Rectangle 83">
+                <a:extLst>
+                  <a:ext uri="{FF2B5EF4-FFF2-40B4-BE49-F238E27FC236}">
+                    <a16:creationId xmlns:a16="http://schemas.microsoft.com/office/drawing/2014/main" id="{E0044D38-0555-0DDA-2AEE-D1FA5C9DC32F}"/>
+                  </a:ext>
+                </a:extLst>
+              </p:cNvPr>
+              <p:cNvSpPr/>
+              <p:nvPr/>
+            </p:nvSpPr>
+            <p:spPr>
+              <a:xfrm>
+                <a:off x="7066650" y="3429000"/>
+                <a:ext cx="2381250" cy="1352550"/>
+              </a:xfrm>
+              <a:prstGeom prst="rect">
+                <a:avLst/>
+              </a:prstGeom>
+            </p:spPr>
+            <p:style>
+              <a:lnRef idx="2">
+                <a:schemeClr val="dk1">
+                  <a:shade val="50000"/>
+                </a:schemeClr>
+              </a:lnRef>
+              <a:fillRef idx="1">
+                <a:schemeClr val="dk1"/>
+              </a:fillRef>
+              <a:effectRef idx="0">
+                <a:schemeClr val="dk1"/>
+              </a:effectRef>
+              <a:fontRef idx="minor">
+                <a:schemeClr val="lt1"/>
+              </a:fontRef>
+            </p:style>
+            <p:txBody>
+              <a:bodyPr rtlCol="0" anchor="ctr"/>
+              <a:lstStyle/>
+              <a:p>
+                <a:pPr algn="ctr"/>
+                <a:endParaRPr lang="en-US"/>
+              </a:p>
+            </p:txBody>
+          </p:sp>
+          <p:sp>
+            <p:nvSpPr>
+              <p:cNvPr id="87" name="Oval 86">
+                <a:extLst>
+                  <a:ext uri="{FF2B5EF4-FFF2-40B4-BE49-F238E27FC236}">
+                    <a16:creationId xmlns:a16="http://schemas.microsoft.com/office/drawing/2014/main" id="{9231ED0F-0E39-4F4B-FBB7-3F216B8E8A81}"/>
+                  </a:ext>
+                </a:extLst>
+              </p:cNvPr>
+              <p:cNvSpPr/>
+              <p:nvPr/>
+            </p:nvSpPr>
+            <p:spPr>
+              <a:xfrm>
+                <a:off x="8037653" y="3003550"/>
+                <a:ext cx="439245" cy="1778000"/>
+              </a:xfrm>
+              <a:prstGeom prst="ellipse">
+                <a:avLst/>
+              </a:prstGeom>
+            </p:spPr>
+            <p:style>
+              <a:lnRef idx="2">
+                <a:schemeClr val="dk1">
+                  <a:shade val="50000"/>
+                </a:schemeClr>
+              </a:lnRef>
+              <a:fillRef idx="1">
+                <a:schemeClr val="dk1"/>
+              </a:fillRef>
+              <a:effectRef idx="0">
+                <a:schemeClr val="dk1"/>
+              </a:effectRef>
+              <a:fontRef idx="minor">
+                <a:schemeClr val="lt1"/>
+              </a:fontRef>
+            </p:style>
+            <p:txBody>
+              <a:bodyPr rtlCol="0" anchor="ctr"/>
+              <a:lstStyle/>
+              <a:p>
+                <a:pPr algn="ctr"/>
+                <a:endParaRPr lang="en-US"/>
+              </a:p>
+            </p:txBody>
+          </p:sp>
+          <p:sp>
+            <p:nvSpPr>
+              <p:cNvPr id="89" name="Oval 88">
+                <a:extLst>
+                  <a:ext uri="{FF2B5EF4-FFF2-40B4-BE49-F238E27FC236}">
+                    <a16:creationId xmlns:a16="http://schemas.microsoft.com/office/drawing/2014/main" id="{E0155EBA-A744-104B-95EE-3120731F0709}"/>
+                  </a:ext>
+                </a:extLst>
+              </p:cNvPr>
+              <p:cNvSpPr/>
+              <p:nvPr/>
+            </p:nvSpPr>
+            <p:spPr>
+              <a:xfrm>
+                <a:off x="7480557" y="3512687"/>
+                <a:ext cx="458369" cy="458369"/>
+              </a:xfrm>
+              <a:prstGeom prst="ellipse">
+                <a:avLst/>
+              </a:prstGeom>
+            </p:spPr>
+            <p:style>
+              <a:lnRef idx="2">
+                <a:schemeClr val="dk1"/>
+              </a:lnRef>
+              <a:fillRef idx="1">
+                <a:schemeClr val="lt1"/>
+              </a:fillRef>
+              <a:effectRef idx="0">
+                <a:schemeClr val="dk1"/>
+              </a:effectRef>
+              <a:fontRef idx="minor">
+                <a:schemeClr val="dk1"/>
+              </a:fontRef>
+            </p:style>
+            <p:txBody>
+              <a:bodyPr rtlCol="0" anchor="ctr"/>
+              <a:lstStyle/>
+              <a:p>
+                <a:pPr algn="ctr"/>
+                <a:endParaRPr lang="en-US"/>
+              </a:p>
+            </p:txBody>
+          </p:sp>
+          <p:sp>
+            <p:nvSpPr>
+              <p:cNvPr id="122" name="Oval 121">
+                <a:extLst>
+                  <a:ext uri="{FF2B5EF4-FFF2-40B4-BE49-F238E27FC236}">
+                    <a16:creationId xmlns:a16="http://schemas.microsoft.com/office/drawing/2014/main" id="{B90A0BAD-227B-7CCB-B39E-4E81B5C634C5}"/>
+                  </a:ext>
+                </a:extLst>
+              </p:cNvPr>
+              <p:cNvSpPr/>
+              <p:nvPr/>
+            </p:nvSpPr>
+            <p:spPr>
+              <a:xfrm>
+                <a:off x="8570573" y="3512687"/>
+                <a:ext cx="458369" cy="458369"/>
+              </a:xfrm>
+              <a:prstGeom prst="ellipse">
+                <a:avLst/>
+              </a:prstGeom>
+            </p:spPr>
+            <p:style>
+              <a:lnRef idx="2">
+                <a:schemeClr val="dk1"/>
+              </a:lnRef>
+              <a:fillRef idx="1">
+                <a:schemeClr val="lt1"/>
+              </a:fillRef>
+              <a:effectRef idx="0">
+                <a:schemeClr val="dk1"/>
+              </a:effectRef>
+              <a:fontRef idx="minor">
+                <a:schemeClr val="dk1"/>
+              </a:fontRef>
+            </p:style>
+            <p:txBody>
+              <a:bodyPr rtlCol="0" anchor="ctr"/>
+              <a:lstStyle/>
+              <a:p>
+                <a:pPr algn="ctr"/>
+                <a:endParaRPr lang="en-US"/>
+              </a:p>
+            </p:txBody>
+          </p:sp>
+          <p:sp>
+            <p:nvSpPr>
+              <p:cNvPr id="123" name="Oval 122">
+                <a:extLst>
+                  <a:ext uri="{FF2B5EF4-FFF2-40B4-BE49-F238E27FC236}">
+                    <a16:creationId xmlns:a16="http://schemas.microsoft.com/office/drawing/2014/main" id="{0F155BBB-48CB-E971-438A-76B70FFB5622}"/>
+                  </a:ext>
+                </a:extLst>
+              </p:cNvPr>
+              <p:cNvSpPr/>
+              <p:nvPr/>
+            </p:nvSpPr>
+            <p:spPr>
+              <a:xfrm>
+                <a:off x="7480557" y="4167321"/>
+                <a:ext cx="458369" cy="458369"/>
+              </a:xfrm>
+              <a:prstGeom prst="ellipse">
+                <a:avLst/>
+              </a:prstGeom>
+            </p:spPr>
+            <p:style>
+              <a:lnRef idx="2">
+                <a:schemeClr val="dk1"/>
+              </a:lnRef>
+              <a:fillRef idx="1">
+                <a:schemeClr val="lt1"/>
+              </a:fillRef>
+              <a:effectRef idx="0">
+                <a:schemeClr val="dk1"/>
+              </a:effectRef>
+              <a:fontRef idx="minor">
+                <a:schemeClr val="dk1"/>
+              </a:fontRef>
+            </p:style>
+            <p:txBody>
+              <a:bodyPr rtlCol="0" anchor="ctr"/>
+              <a:lstStyle/>
+              <a:p>
+                <a:pPr algn="ctr"/>
+                <a:endParaRPr lang="en-US"/>
+              </a:p>
+            </p:txBody>
+          </p:sp>
+          <p:sp>
+            <p:nvSpPr>
+              <p:cNvPr id="124" name="Oval 123">
+                <a:extLst>
+                  <a:ext uri="{FF2B5EF4-FFF2-40B4-BE49-F238E27FC236}">
+                    <a16:creationId xmlns:a16="http://schemas.microsoft.com/office/drawing/2014/main" id="{9AF0B8D7-2096-54C1-C1A3-940CD48B1548}"/>
+                  </a:ext>
+                </a:extLst>
+              </p:cNvPr>
+              <p:cNvSpPr/>
+              <p:nvPr/>
+            </p:nvSpPr>
+            <p:spPr>
+              <a:xfrm>
+                <a:off x="8570573" y="4167321"/>
+                <a:ext cx="458369" cy="458369"/>
+              </a:xfrm>
+              <a:prstGeom prst="ellipse">
+                <a:avLst/>
+              </a:prstGeom>
+            </p:spPr>
+            <p:style>
+              <a:lnRef idx="2">
+                <a:schemeClr val="dk1"/>
+              </a:lnRef>
+              <a:fillRef idx="1">
+                <a:schemeClr val="lt1"/>
+              </a:fillRef>
+              <a:effectRef idx="0">
+                <a:schemeClr val="dk1"/>
+              </a:effectRef>
+              <a:fontRef idx="minor">
+                <a:schemeClr val="dk1"/>
+              </a:fontRef>
+            </p:style>
+            <p:txBody>
+              <a:bodyPr rtlCol="0" anchor="ctr"/>
+              <a:lstStyle/>
+              <a:p>
+                <a:pPr algn="ctr"/>
+                <a:endParaRPr lang="en-US"/>
+              </a:p>
+            </p:txBody>
+          </p:sp>
+        </p:grpSp>
+        <p:grpSp>
+          <p:nvGrpSpPr>
+            <p:cNvPr id="125" name="Group 124">
+              <a:extLst>
+                <a:ext uri="{FF2B5EF4-FFF2-40B4-BE49-F238E27FC236}">
+                  <a16:creationId xmlns:a16="http://schemas.microsoft.com/office/drawing/2014/main" id="{5E2E00E3-481E-2DDC-50DC-CF92CF33C4C7}"/>
+                </a:ext>
+              </a:extLst>
+            </p:cNvPr>
+            <p:cNvGrpSpPr/>
+            <p:nvPr/>
+          </p:nvGrpSpPr>
+          <p:grpSpPr>
+            <a:xfrm>
+              <a:off x="2259485" y="5495736"/>
+              <a:ext cx="1371600" cy="1371600"/>
+              <a:chOff x="1298501" y="962272"/>
+              <a:chExt cx="1371600" cy="1371600"/>
+            </a:xfrm>
+          </p:grpSpPr>
+          <p:sp>
+            <p:nvSpPr>
+              <p:cNvPr id="126" name="Rectangle 125">
+                <a:extLst>
+                  <a:ext uri="{FF2B5EF4-FFF2-40B4-BE49-F238E27FC236}">
+                    <a16:creationId xmlns:a16="http://schemas.microsoft.com/office/drawing/2014/main" id="{381458B9-6C49-2FA1-F8E1-85C9205E31CD}"/>
+                  </a:ext>
+                </a:extLst>
+              </p:cNvPr>
+              <p:cNvSpPr/>
+              <p:nvPr/>
+            </p:nvSpPr>
+            <p:spPr>
+              <a:xfrm>
+                <a:off x="1298501" y="962272"/>
+                <a:ext cx="1371600" cy="1371600"/>
+              </a:xfrm>
+              <a:prstGeom prst="rect">
+                <a:avLst/>
+              </a:prstGeom>
+              <a:noFill/>
+              <a:ln w="76200">
+                <a:solidFill>
+                  <a:schemeClr val="tx1"/>
+                </a:solidFill>
+              </a:ln>
+            </p:spPr>
+            <p:style>
+              <a:lnRef idx="2">
+                <a:schemeClr val="accent1">
+                  <a:shade val="50000"/>
+                </a:schemeClr>
+              </a:lnRef>
+              <a:fillRef idx="1">
+                <a:schemeClr val="accent1"/>
+              </a:fillRef>
+              <a:effectRef idx="0">
+                <a:schemeClr val="accent1"/>
+              </a:effectRef>
+              <a:fontRef idx="minor">
+                <a:schemeClr val="lt1"/>
+              </a:fontRef>
+            </p:style>
+            <p:txBody>
+              <a:bodyPr rtlCol="0" anchor="ctr"/>
+              <a:lstStyle/>
+              <a:p>
+                <a:pPr algn="ctr"/>
+                <a:endParaRPr lang="en-US"/>
+              </a:p>
+            </p:txBody>
+          </p:sp>
+          <p:sp>
+            <p:nvSpPr>
+              <p:cNvPr id="127" name="Arrow: Pentagon 126">
+                <a:extLst>
+                  <a:ext uri="{FF2B5EF4-FFF2-40B4-BE49-F238E27FC236}">
+                    <a16:creationId xmlns:a16="http://schemas.microsoft.com/office/drawing/2014/main" id="{71967356-3E44-C94E-5B8A-EC5A97CB1291}"/>
+                  </a:ext>
+                </a:extLst>
+              </p:cNvPr>
+              <p:cNvSpPr/>
+              <p:nvPr/>
+            </p:nvSpPr>
+            <p:spPr>
+              <a:xfrm rot="5400000">
+                <a:off x="1435661" y="1173775"/>
+                <a:ext cx="1097280" cy="1097280"/>
+              </a:xfrm>
+              <a:prstGeom prst="homePlate">
+                <a:avLst/>
+              </a:prstGeom>
+              <a:noFill/>
+              <a:ln w="38100" cap="flat" cmpd="sng" algn="ctr">
+                <a:solidFill>
+                  <a:schemeClr val="dk1"/>
+                </a:solidFill>
+                <a:prstDash val="solid"/>
+                <a:round/>
+                <a:headEnd type="none" w="med" len="med"/>
+                <a:tailEnd type="none" w="med" len="med"/>
+              </a:ln>
+            </p:spPr>
+            <p:style>
+              <a:lnRef idx="0">
+                <a:scrgbClr r="0" g="0" b="0"/>
+              </a:lnRef>
+              <a:fillRef idx="0">
+                <a:scrgbClr r="0" g="0" b="0"/>
+              </a:fillRef>
+              <a:effectRef idx="0">
+                <a:scrgbClr r="0" g="0" b="0"/>
+              </a:effectRef>
+              <a:fontRef idx="minor">
+                <a:schemeClr val="dk1"/>
+              </a:fontRef>
+            </p:style>
+            <p:txBody>
+              <a:bodyPr rtlCol="0" anchor="ctr"/>
+              <a:lstStyle/>
+              <a:p>
+                <a:pPr algn="ctr"/>
+                <a:endParaRPr lang="en-US"/>
+              </a:p>
+            </p:txBody>
+          </p:sp>
+        </p:grpSp>
+      </p:grpSp>
+      <p:grpSp>
+        <p:nvGrpSpPr>
+          <p:cNvPr id="130" name="Group 129">
+            <a:extLst>
+              <a:ext uri="{FF2B5EF4-FFF2-40B4-BE49-F238E27FC236}">
+                <a16:creationId xmlns:a16="http://schemas.microsoft.com/office/drawing/2014/main" id="{5F292E58-1623-C95C-98B7-C753B7D5DD09}"/>
+              </a:ext>
+            </a:extLst>
+          </p:cNvPr>
+          <p:cNvGrpSpPr/>
+          <p:nvPr/>
+        </p:nvGrpSpPr>
+        <p:grpSpPr>
+          <a:xfrm>
+            <a:off x="180817" y="5390177"/>
+            <a:ext cx="1371600" cy="1371600"/>
+            <a:chOff x="243475" y="146351"/>
+            <a:chExt cx="1371600" cy="1371600"/>
+          </a:xfrm>
+        </p:grpSpPr>
+        <p:grpSp>
+          <p:nvGrpSpPr>
+            <p:cNvPr id="131" name="Group 130">
+              <a:extLst>
+                <a:ext uri="{FF2B5EF4-FFF2-40B4-BE49-F238E27FC236}">
+                  <a16:creationId xmlns:a16="http://schemas.microsoft.com/office/drawing/2014/main" id="{A6A14D18-C9E6-58A8-F0EE-B1ECE4CF3D11}"/>
+                </a:ext>
+              </a:extLst>
+            </p:cNvPr>
+            <p:cNvGrpSpPr/>
+            <p:nvPr/>
+          </p:nvGrpSpPr>
+          <p:grpSpPr>
+            <a:xfrm>
+              <a:off x="243475" y="146351"/>
+              <a:ext cx="1371600" cy="1371600"/>
+              <a:chOff x="1298501" y="962272"/>
+              <a:chExt cx="1371600" cy="1371600"/>
+            </a:xfrm>
+          </p:grpSpPr>
+          <p:sp>
+            <p:nvSpPr>
+              <p:cNvPr id="157" name="Rectangle 156">
+                <a:extLst>
+                  <a:ext uri="{FF2B5EF4-FFF2-40B4-BE49-F238E27FC236}">
+                    <a16:creationId xmlns:a16="http://schemas.microsoft.com/office/drawing/2014/main" id="{1F00A8C5-04C2-C708-5FB1-D2288907E83E}"/>
+                  </a:ext>
+                </a:extLst>
+              </p:cNvPr>
+              <p:cNvSpPr/>
+              <p:nvPr/>
+            </p:nvSpPr>
+            <p:spPr>
+              <a:xfrm>
+                <a:off x="1298501" y="962272"/>
+                <a:ext cx="1371600" cy="1371600"/>
+              </a:xfrm>
+              <a:prstGeom prst="rect">
+                <a:avLst/>
+              </a:prstGeom>
+              <a:noFill/>
+              <a:ln w="76200">
+                <a:solidFill>
+                  <a:schemeClr val="tx1"/>
+                </a:solidFill>
+              </a:ln>
+            </p:spPr>
+            <p:style>
+              <a:lnRef idx="2">
+                <a:schemeClr val="accent1">
+                  <a:shade val="50000"/>
+                </a:schemeClr>
+              </a:lnRef>
+              <a:fillRef idx="1">
+                <a:schemeClr val="accent1"/>
+              </a:fillRef>
+              <a:effectRef idx="0">
+                <a:schemeClr val="accent1"/>
+              </a:effectRef>
+              <a:fontRef idx="minor">
+                <a:schemeClr val="lt1"/>
+              </a:fontRef>
+            </p:style>
+            <p:txBody>
+              <a:bodyPr rtlCol="0" anchor="ctr"/>
+              <a:lstStyle/>
+              <a:p>
+                <a:pPr algn="ctr"/>
+                <a:endParaRPr lang="en-US"/>
+              </a:p>
+            </p:txBody>
+          </p:sp>
+          <p:sp>
+            <p:nvSpPr>
+              <p:cNvPr id="158" name="Arrow: Pentagon 157">
+                <a:extLst>
+                  <a:ext uri="{FF2B5EF4-FFF2-40B4-BE49-F238E27FC236}">
+                    <a16:creationId xmlns:a16="http://schemas.microsoft.com/office/drawing/2014/main" id="{A466F8C8-ADC3-DB20-A030-A0A8912CA9A0}"/>
+                  </a:ext>
+                </a:extLst>
+              </p:cNvPr>
+              <p:cNvSpPr/>
+              <p:nvPr/>
+            </p:nvSpPr>
+            <p:spPr>
+              <a:xfrm rot="5400000">
+                <a:off x="1435661" y="1173775"/>
+                <a:ext cx="1097280" cy="1097280"/>
+              </a:xfrm>
+              <a:prstGeom prst="homePlate">
+                <a:avLst/>
+              </a:prstGeom>
+              <a:noFill/>
+              <a:ln w="38100" cap="flat" cmpd="sng" algn="ctr">
+                <a:solidFill>
+                  <a:schemeClr val="dk1"/>
+                </a:solidFill>
+                <a:prstDash val="solid"/>
+                <a:round/>
+                <a:headEnd type="none" w="med" len="med"/>
+                <a:tailEnd type="none" w="med" len="med"/>
+              </a:ln>
+            </p:spPr>
+            <p:style>
+              <a:lnRef idx="0">
+                <a:scrgbClr r="0" g="0" b="0"/>
+              </a:lnRef>
+              <a:fillRef idx="0">
+                <a:scrgbClr r="0" g="0" b="0"/>
+              </a:fillRef>
+              <a:effectRef idx="0">
+                <a:scrgbClr r="0" g="0" b="0"/>
+              </a:effectRef>
+              <a:fontRef idx="minor">
+                <a:schemeClr val="dk1"/>
+              </a:fontRef>
+            </p:style>
+            <p:txBody>
+              <a:bodyPr rtlCol="0" anchor="ctr"/>
+              <a:lstStyle/>
+              <a:p>
+                <a:pPr algn="ctr"/>
+                <a:endParaRPr lang="en-US"/>
+              </a:p>
+            </p:txBody>
+          </p:sp>
+        </p:grpSp>
+        <p:grpSp>
+          <p:nvGrpSpPr>
+            <p:cNvPr id="133" name="Group 132">
+              <a:extLst>
+                <a:ext uri="{FF2B5EF4-FFF2-40B4-BE49-F238E27FC236}">
+                  <a16:creationId xmlns:a16="http://schemas.microsoft.com/office/drawing/2014/main" id="{854231A7-B370-1C74-88F1-0CB8B58AD926}"/>
+                </a:ext>
+              </a:extLst>
+            </p:cNvPr>
+            <p:cNvGrpSpPr/>
+            <p:nvPr/>
+          </p:nvGrpSpPr>
+          <p:grpSpPr>
+            <a:xfrm>
+              <a:off x="422295" y="508928"/>
+              <a:ext cx="884120" cy="519527"/>
+              <a:chOff x="1858637" y="2247118"/>
+              <a:chExt cx="3556602" cy="2089932"/>
+            </a:xfrm>
+          </p:grpSpPr>
+          <p:sp>
+            <p:nvSpPr>
+              <p:cNvPr id="134" name="Rectangle 133">
+                <a:extLst>
+                  <a:ext uri="{FF2B5EF4-FFF2-40B4-BE49-F238E27FC236}">
+                    <a16:creationId xmlns:a16="http://schemas.microsoft.com/office/drawing/2014/main" id="{B3FABB1E-BC2A-FCB5-4094-ADDDA2A36FCC}"/>
+                  </a:ext>
+                </a:extLst>
+              </p:cNvPr>
+              <p:cNvSpPr/>
+              <p:nvPr/>
+            </p:nvSpPr>
+            <p:spPr>
+              <a:xfrm>
+                <a:off x="3241413" y="2942864"/>
+                <a:ext cx="1848262" cy="248868"/>
+              </a:xfrm>
+              <a:prstGeom prst="rect">
+                <a:avLst/>
+              </a:prstGeom>
+            </p:spPr>
+            <p:style>
+              <a:lnRef idx="2">
+                <a:schemeClr val="dk1">
+                  <a:shade val="50000"/>
+                </a:schemeClr>
+              </a:lnRef>
+              <a:fillRef idx="1">
+                <a:schemeClr val="dk1"/>
+              </a:fillRef>
+              <a:effectRef idx="0">
+                <a:schemeClr val="dk1"/>
+              </a:effectRef>
+              <a:fontRef idx="minor">
+                <a:schemeClr val="lt1"/>
+              </a:fontRef>
+            </p:style>
+            <p:txBody>
+              <a:bodyPr rtlCol="0" anchor="ctr"/>
+              <a:lstStyle/>
+              <a:p>
+                <a:pPr algn="ctr"/>
+                <a:endParaRPr lang="en-US"/>
+              </a:p>
+            </p:txBody>
+          </p:sp>
+          <p:sp>
+            <p:nvSpPr>
+              <p:cNvPr id="135" name="Rectangle 134">
+                <a:extLst>
+                  <a:ext uri="{FF2B5EF4-FFF2-40B4-BE49-F238E27FC236}">
+                    <a16:creationId xmlns:a16="http://schemas.microsoft.com/office/drawing/2014/main" id="{212E7F84-5B45-77BC-80EE-58C693B4BA7E}"/>
+                  </a:ext>
+                </a:extLst>
+              </p:cNvPr>
+              <p:cNvSpPr/>
+              <p:nvPr/>
+            </p:nvSpPr>
+            <p:spPr>
+              <a:xfrm rot="19876836">
+                <a:off x="2246449" y="3191249"/>
+                <a:ext cx="1097536" cy="248868"/>
+              </a:xfrm>
+              <a:prstGeom prst="rect">
+                <a:avLst/>
+              </a:prstGeom>
+            </p:spPr>
+            <p:style>
+              <a:lnRef idx="2">
+                <a:schemeClr val="dk1">
+                  <a:shade val="50000"/>
+                </a:schemeClr>
+              </a:lnRef>
+              <a:fillRef idx="1">
+                <a:schemeClr val="dk1"/>
+              </a:fillRef>
+              <a:effectRef idx="0">
+                <a:schemeClr val="dk1"/>
+              </a:effectRef>
+              <a:fontRef idx="minor">
+                <a:schemeClr val="lt1"/>
+              </a:fontRef>
+            </p:style>
+            <p:txBody>
+              <a:bodyPr rtlCol="0" anchor="ctr"/>
+              <a:lstStyle/>
+              <a:p>
+                <a:pPr algn="ctr"/>
+                <a:endParaRPr lang="en-US"/>
+              </a:p>
+            </p:txBody>
+          </p:sp>
+          <p:sp>
+            <p:nvSpPr>
+              <p:cNvPr id="136" name="Rectangle 135">
+                <a:extLst>
+                  <a:ext uri="{FF2B5EF4-FFF2-40B4-BE49-F238E27FC236}">
+                    <a16:creationId xmlns:a16="http://schemas.microsoft.com/office/drawing/2014/main" id="{1CF90107-A265-8B84-5456-D5F8D1DCFFE8}"/>
+                  </a:ext>
+                </a:extLst>
+              </p:cNvPr>
+              <p:cNvSpPr/>
+              <p:nvPr/>
+            </p:nvSpPr>
+            <p:spPr>
+              <a:xfrm rot="3856563">
+                <a:off x="4763390" y="3211519"/>
+                <a:ext cx="752766" cy="248868"/>
+              </a:xfrm>
+              <a:prstGeom prst="rect">
+                <a:avLst/>
+              </a:prstGeom>
+            </p:spPr>
+            <p:style>
+              <a:lnRef idx="2">
+                <a:schemeClr val="dk1">
+                  <a:shade val="50000"/>
+                </a:schemeClr>
+              </a:lnRef>
+              <a:fillRef idx="1">
+                <a:schemeClr val="dk1"/>
+              </a:fillRef>
+              <a:effectRef idx="0">
+                <a:schemeClr val="dk1"/>
+              </a:effectRef>
+              <a:fontRef idx="minor">
+                <a:schemeClr val="lt1"/>
+              </a:fontRef>
+            </p:style>
+            <p:txBody>
+              <a:bodyPr rtlCol="0" anchor="ctr"/>
+              <a:lstStyle/>
+              <a:p>
+                <a:pPr algn="ctr"/>
+                <a:endParaRPr lang="en-US"/>
+              </a:p>
+            </p:txBody>
+          </p:sp>
+          <p:sp>
+            <p:nvSpPr>
+              <p:cNvPr id="137" name="Rectangle 136">
+                <a:extLst>
+                  <a:ext uri="{FF2B5EF4-FFF2-40B4-BE49-F238E27FC236}">
+                    <a16:creationId xmlns:a16="http://schemas.microsoft.com/office/drawing/2014/main" id="{C711D3E0-24C4-784F-1077-CDFF039E03EA}"/>
+                  </a:ext>
+                </a:extLst>
+              </p:cNvPr>
+              <p:cNvSpPr/>
+              <p:nvPr/>
+            </p:nvSpPr>
+            <p:spPr>
+              <a:xfrm>
+                <a:off x="2254160" y="3467849"/>
+                <a:ext cx="3161079" cy="522388"/>
+              </a:xfrm>
+              <a:prstGeom prst="rect">
+                <a:avLst/>
+              </a:prstGeom>
+            </p:spPr>
+            <p:style>
+              <a:lnRef idx="2">
+                <a:schemeClr val="dk1">
+                  <a:shade val="50000"/>
+                </a:schemeClr>
+              </a:lnRef>
+              <a:fillRef idx="1">
+                <a:schemeClr val="dk1"/>
+              </a:fillRef>
+              <a:effectRef idx="0">
+                <a:schemeClr val="dk1"/>
+              </a:effectRef>
+              <a:fontRef idx="minor">
+                <a:schemeClr val="lt1"/>
+              </a:fontRef>
+            </p:style>
+            <p:txBody>
+              <a:bodyPr rtlCol="0" anchor="ctr"/>
+              <a:lstStyle/>
+              <a:p>
+                <a:pPr algn="ctr"/>
+                <a:endParaRPr lang="en-US"/>
+              </a:p>
+            </p:txBody>
+          </p:sp>
+          <p:sp>
+            <p:nvSpPr>
+              <p:cNvPr id="138" name="Oval 137">
+                <a:extLst>
+                  <a:ext uri="{FF2B5EF4-FFF2-40B4-BE49-F238E27FC236}">
+                    <a16:creationId xmlns:a16="http://schemas.microsoft.com/office/drawing/2014/main" id="{DAC33096-BCD2-0051-558F-97E451268A20}"/>
+                  </a:ext>
+                </a:extLst>
+              </p:cNvPr>
+              <p:cNvSpPr/>
+              <p:nvPr/>
+            </p:nvSpPr>
+            <p:spPr>
+              <a:xfrm>
+                <a:off x="2518799" y="3643429"/>
+                <a:ext cx="693622" cy="693621"/>
+              </a:xfrm>
+              <a:prstGeom prst="ellipse">
+                <a:avLst/>
+              </a:prstGeom>
+              <a:ln w="76200"/>
+            </p:spPr>
+            <p:style>
+              <a:lnRef idx="2">
+                <a:schemeClr val="dk1"/>
+              </a:lnRef>
+              <a:fillRef idx="1">
+                <a:schemeClr val="lt1"/>
+              </a:fillRef>
+              <a:effectRef idx="0">
+                <a:schemeClr val="dk1"/>
+              </a:effectRef>
+              <a:fontRef idx="minor">
+                <a:schemeClr val="dk1"/>
+              </a:fontRef>
+            </p:style>
+            <p:txBody>
+              <a:bodyPr rtlCol="0" anchor="ctr"/>
+              <a:lstStyle/>
+              <a:p>
+                <a:pPr algn="ctr"/>
+                <a:endParaRPr lang="en-US"/>
+              </a:p>
+            </p:txBody>
+          </p:sp>
+          <p:sp>
+            <p:nvSpPr>
+              <p:cNvPr id="139" name="Oval 138">
+                <a:extLst>
+                  <a:ext uri="{FF2B5EF4-FFF2-40B4-BE49-F238E27FC236}">
+                    <a16:creationId xmlns:a16="http://schemas.microsoft.com/office/drawing/2014/main" id="{D5769792-68E4-358B-4DA7-FA374971FD17}"/>
+                  </a:ext>
+                </a:extLst>
+              </p:cNvPr>
+              <p:cNvSpPr/>
+              <p:nvPr/>
+            </p:nvSpPr>
+            <p:spPr>
+              <a:xfrm>
+                <a:off x="3775260" y="3643429"/>
+                <a:ext cx="693622" cy="693621"/>
+              </a:xfrm>
+              <a:prstGeom prst="ellipse">
+                <a:avLst/>
+              </a:prstGeom>
+              <a:ln w="76200"/>
+            </p:spPr>
+            <p:style>
+              <a:lnRef idx="2">
+                <a:schemeClr val="dk1"/>
+              </a:lnRef>
+              <a:fillRef idx="1">
+                <a:schemeClr val="lt1"/>
+              </a:fillRef>
+              <a:effectRef idx="0">
+                <a:schemeClr val="dk1"/>
+              </a:effectRef>
+              <a:fontRef idx="minor">
+                <a:schemeClr val="dk1"/>
+              </a:fontRef>
+            </p:style>
+            <p:txBody>
+              <a:bodyPr rtlCol="0" anchor="ctr"/>
+              <a:lstStyle/>
+              <a:p>
+                <a:pPr algn="ctr"/>
+                <a:endParaRPr lang="en-US"/>
+              </a:p>
+            </p:txBody>
+          </p:sp>
+          <p:sp>
+            <p:nvSpPr>
+              <p:cNvPr id="140" name="Oval 139">
+                <a:extLst>
+                  <a:ext uri="{FF2B5EF4-FFF2-40B4-BE49-F238E27FC236}">
+                    <a16:creationId xmlns:a16="http://schemas.microsoft.com/office/drawing/2014/main" id="{8B976AF7-CC7D-4FC1-B04B-C15A767B4640}"/>
+                  </a:ext>
+                </a:extLst>
+              </p:cNvPr>
+              <p:cNvSpPr/>
+              <p:nvPr/>
+            </p:nvSpPr>
+            <p:spPr>
+              <a:xfrm>
+                <a:off x="4612351" y="3643429"/>
+                <a:ext cx="693622" cy="693621"/>
+              </a:xfrm>
+              <a:prstGeom prst="ellipse">
+                <a:avLst/>
+              </a:prstGeom>
+              <a:ln w="76200"/>
+            </p:spPr>
+            <p:style>
+              <a:lnRef idx="2">
+                <a:schemeClr val="dk1"/>
+              </a:lnRef>
+              <a:fillRef idx="1">
+                <a:schemeClr val="lt1"/>
+              </a:fillRef>
+              <a:effectRef idx="0">
+                <a:schemeClr val="dk1"/>
+              </a:effectRef>
+              <a:fontRef idx="minor">
+                <a:schemeClr val="dk1"/>
+              </a:fontRef>
+            </p:style>
+            <p:txBody>
+              <a:bodyPr rtlCol="0" anchor="ctr"/>
+              <a:lstStyle/>
+              <a:p>
+                <a:pPr algn="ctr"/>
+                <a:endParaRPr lang="en-US"/>
+              </a:p>
+            </p:txBody>
+          </p:sp>
+          <p:sp>
+            <p:nvSpPr>
+              <p:cNvPr id="141" name="Rectangle: Single Corner Snipped 140">
+                <a:extLst>
+                  <a:ext uri="{FF2B5EF4-FFF2-40B4-BE49-F238E27FC236}">
+                    <a16:creationId xmlns:a16="http://schemas.microsoft.com/office/drawing/2014/main" id="{84F81E0B-D1BB-4DFF-F949-AEEFF30666E6}"/>
+                  </a:ext>
+                </a:extLst>
+              </p:cNvPr>
+              <p:cNvSpPr/>
+              <p:nvPr/>
+            </p:nvSpPr>
+            <p:spPr>
+              <a:xfrm flipH="1" flipV="1">
+                <a:off x="3799869" y="2247118"/>
+                <a:ext cx="903248" cy="688340"/>
+              </a:xfrm>
+              <a:prstGeom prst="snip1Rect">
+                <a:avLst>
+                  <a:gd name="adj" fmla="val 50000"/>
+                </a:avLst>
+              </a:prstGeom>
+            </p:spPr>
+            <p:style>
+              <a:lnRef idx="2">
+                <a:schemeClr val="dk1">
+                  <a:shade val="50000"/>
+                </a:schemeClr>
+              </a:lnRef>
+              <a:fillRef idx="1">
+                <a:schemeClr val="dk1"/>
+              </a:fillRef>
+              <a:effectRef idx="0">
+                <a:schemeClr val="dk1"/>
+              </a:effectRef>
+              <a:fontRef idx="minor">
+                <a:schemeClr val="lt1"/>
+              </a:fontRef>
+            </p:style>
+            <p:txBody>
+              <a:bodyPr rtlCol="0" anchor="ctr"/>
+              <a:lstStyle/>
+              <a:p>
+                <a:pPr algn="ctr"/>
+                <a:endParaRPr lang="en-US"/>
+              </a:p>
+            </p:txBody>
+          </p:sp>
+          <p:pic>
+            <p:nvPicPr>
+              <p:cNvPr id="142" name="Picture 10" descr="✓ flamethrower free vector eps, cdr, ai, svg vector illustration graphic art">
+                <a:extLst>
+                  <a:ext uri="{FF2B5EF4-FFF2-40B4-BE49-F238E27FC236}">
+                    <a16:creationId xmlns:a16="http://schemas.microsoft.com/office/drawing/2014/main" id="{C331E98E-7679-779E-1852-0665ED0659F0}"/>
+                  </a:ext>
+                </a:extLst>
+              </p:cNvPr>
+              <p:cNvPicPr>
+                <a:picLocks noChangeAspect="1" noChangeArrowheads="1"/>
+              </p:cNvPicPr>
+              <p:nvPr/>
+            </p:nvPicPr>
+            <p:blipFill rotWithShape="1">
+              <a:blip r:embed="rId5">
+                <a:extLst>
+                  <a:ext uri="{28A0092B-C50C-407E-A947-70E740481C1C}">
+                    <a14:useLocalDpi xmlns:a14="http://schemas.microsoft.com/office/drawing/2010/main" val="0"/>
+                  </a:ext>
+                </a:extLst>
+              </a:blip>
+              <a:srcRect l="29258" b="25887"/>
+              <a:stretch/>
+            </p:blipFill>
+            <p:spPr bwMode="auto">
+              <a:xfrm rot="10405411">
+                <a:off x="1858637" y="2508599"/>
+                <a:ext cx="1848262" cy="416708"/>
+              </a:xfrm>
+              <a:prstGeom prst="rect">
+                <a:avLst/>
+              </a:prstGeom>
+              <a:noFill/>
+              <a:extLst>
+                <a:ext uri="{909E8E84-426E-40DD-AFC4-6F175D3DCCD1}">
+                  <a14:hiddenFill xmlns:a14="http://schemas.microsoft.com/office/drawing/2010/main">
+                    <a:solidFill>
+                      <a:srgbClr val="FFFFFF"/>
+                    </a:solidFill>
+                  </a14:hiddenFill>
+                </a:ext>
+              </a:extLst>
+            </p:spPr>
+          </p:pic>
+        </p:grpSp>
+      </p:grpSp>
+      <p:grpSp>
+        <p:nvGrpSpPr>
+          <p:cNvPr id="159" name="Group 158">
+            <a:extLst>
+              <a:ext uri="{FF2B5EF4-FFF2-40B4-BE49-F238E27FC236}">
+                <a16:creationId xmlns:a16="http://schemas.microsoft.com/office/drawing/2014/main" id="{AF1C2160-2340-6ECD-5D9B-9E6DED3A13D7}"/>
+              </a:ext>
+            </a:extLst>
+          </p:cNvPr>
+          <p:cNvGrpSpPr/>
+          <p:nvPr/>
+        </p:nvGrpSpPr>
+        <p:grpSpPr>
+          <a:xfrm>
+            <a:off x="1753154" y="5441259"/>
+            <a:ext cx="1371600" cy="1371600"/>
+            <a:chOff x="827965" y="2006552"/>
+            <a:chExt cx="1371600" cy="1371600"/>
+          </a:xfrm>
+        </p:grpSpPr>
+        <p:grpSp>
+          <p:nvGrpSpPr>
+            <p:cNvPr id="176" name="Group 175">
+              <a:extLst>
+                <a:ext uri="{FF2B5EF4-FFF2-40B4-BE49-F238E27FC236}">
+                  <a16:creationId xmlns:a16="http://schemas.microsoft.com/office/drawing/2014/main" id="{020FB8FA-A247-891C-CB92-DD8242BBB914}"/>
+                </a:ext>
+              </a:extLst>
+            </p:cNvPr>
+            <p:cNvGrpSpPr/>
+            <p:nvPr/>
+          </p:nvGrpSpPr>
+          <p:grpSpPr>
+            <a:xfrm>
+              <a:off x="827965" y="2006552"/>
+              <a:ext cx="1371600" cy="1371600"/>
+              <a:chOff x="1298501" y="962272"/>
+              <a:chExt cx="1371600" cy="1371600"/>
+            </a:xfrm>
+          </p:grpSpPr>
+          <p:sp>
+            <p:nvSpPr>
+              <p:cNvPr id="188" name="Rectangle 187">
+                <a:extLst>
+                  <a:ext uri="{FF2B5EF4-FFF2-40B4-BE49-F238E27FC236}">
+                    <a16:creationId xmlns:a16="http://schemas.microsoft.com/office/drawing/2014/main" id="{BD2A6F8B-BE8B-9D23-074A-7FEA724D4B44}"/>
+                  </a:ext>
+                </a:extLst>
+              </p:cNvPr>
+              <p:cNvSpPr/>
+              <p:nvPr/>
+            </p:nvSpPr>
+            <p:spPr>
+              <a:xfrm>
+                <a:off x="1298501" y="962272"/>
+                <a:ext cx="1371600" cy="1371600"/>
+              </a:xfrm>
+              <a:prstGeom prst="rect">
+                <a:avLst/>
+              </a:prstGeom>
+              <a:noFill/>
+              <a:ln w="76200">
+                <a:solidFill>
+                  <a:schemeClr val="tx1"/>
+                </a:solidFill>
+              </a:ln>
+            </p:spPr>
+            <p:style>
+              <a:lnRef idx="2">
+                <a:schemeClr val="accent1">
+                  <a:shade val="50000"/>
+                </a:schemeClr>
+              </a:lnRef>
+              <a:fillRef idx="1">
+                <a:schemeClr val="accent1"/>
+              </a:fillRef>
+              <a:effectRef idx="0">
+                <a:schemeClr val="accent1"/>
+              </a:effectRef>
+              <a:fontRef idx="minor">
+                <a:schemeClr val="lt1"/>
+              </a:fontRef>
+            </p:style>
+            <p:txBody>
+              <a:bodyPr rtlCol="0" anchor="ctr"/>
+              <a:lstStyle/>
+              <a:p>
+                <a:pPr algn="ctr"/>
+                <a:endParaRPr lang="en-US"/>
+              </a:p>
+            </p:txBody>
+          </p:sp>
+          <p:sp>
+            <p:nvSpPr>
+              <p:cNvPr id="189" name="Arrow: Pentagon 188">
+                <a:extLst>
+                  <a:ext uri="{FF2B5EF4-FFF2-40B4-BE49-F238E27FC236}">
+                    <a16:creationId xmlns:a16="http://schemas.microsoft.com/office/drawing/2014/main" id="{D25FAAE0-1B80-C10C-D9BF-D9F6DA66AEB7}"/>
+                  </a:ext>
+                </a:extLst>
+              </p:cNvPr>
+              <p:cNvSpPr/>
+              <p:nvPr/>
+            </p:nvSpPr>
+            <p:spPr>
+              <a:xfrm rot="5400000">
+                <a:off x="1435661" y="1173775"/>
+                <a:ext cx="1097280" cy="1097280"/>
+              </a:xfrm>
+              <a:prstGeom prst="homePlate">
+                <a:avLst/>
+              </a:prstGeom>
+              <a:noFill/>
+              <a:ln w="38100" cap="flat" cmpd="sng" algn="ctr">
+                <a:solidFill>
+                  <a:schemeClr val="dk1"/>
+                </a:solidFill>
+                <a:prstDash val="solid"/>
+                <a:round/>
+                <a:headEnd type="none" w="med" len="med"/>
+                <a:tailEnd type="none" w="med" len="med"/>
+              </a:ln>
+            </p:spPr>
+            <p:style>
+              <a:lnRef idx="0">
+                <a:scrgbClr r="0" g="0" b="0"/>
+              </a:lnRef>
+              <a:fillRef idx="0">
+                <a:scrgbClr r="0" g="0" b="0"/>
+              </a:fillRef>
+              <a:effectRef idx="0">
+                <a:scrgbClr r="0" g="0" b="0"/>
+              </a:effectRef>
+              <a:fontRef idx="minor">
+                <a:schemeClr val="dk1"/>
+              </a:fontRef>
+            </p:style>
+            <p:txBody>
+              <a:bodyPr rtlCol="0" anchor="ctr"/>
+              <a:lstStyle/>
+              <a:p>
+                <a:pPr algn="ctr"/>
+                <a:endParaRPr lang="en-US"/>
+              </a:p>
+            </p:txBody>
+          </p:sp>
+        </p:grpSp>
+        <p:grpSp>
+          <p:nvGrpSpPr>
+            <p:cNvPr id="177" name="Group 176">
+              <a:extLst>
+                <a:ext uri="{FF2B5EF4-FFF2-40B4-BE49-F238E27FC236}">
+                  <a16:creationId xmlns:a16="http://schemas.microsoft.com/office/drawing/2014/main" id="{841B93C7-9B9B-3BA7-447C-BBBD359D9496}"/>
+                </a:ext>
+              </a:extLst>
+            </p:cNvPr>
+            <p:cNvGrpSpPr/>
+            <p:nvPr/>
+          </p:nvGrpSpPr>
+          <p:grpSpPr>
+            <a:xfrm>
+              <a:off x="1007024" y="2298700"/>
+              <a:ext cx="941781" cy="527050"/>
+              <a:chOff x="3151975" y="2276550"/>
+              <a:chExt cx="3511685" cy="1965250"/>
+            </a:xfrm>
+          </p:grpSpPr>
+          <p:sp>
+            <p:nvSpPr>
+              <p:cNvPr id="178" name="Oval 177">
+                <a:extLst>
+                  <a:ext uri="{FF2B5EF4-FFF2-40B4-BE49-F238E27FC236}">
+                    <a16:creationId xmlns:a16="http://schemas.microsoft.com/office/drawing/2014/main" id="{B0051498-7DD7-09B8-2A47-250A89EF7290}"/>
+                  </a:ext>
+                </a:extLst>
+              </p:cNvPr>
+              <p:cNvSpPr/>
+              <p:nvPr/>
+            </p:nvSpPr>
+            <p:spPr>
+              <a:xfrm>
+                <a:off x="4900694" y="2644379"/>
+                <a:ext cx="416527" cy="245033"/>
+              </a:xfrm>
+              <a:prstGeom prst="ellipse">
+                <a:avLst/>
+              </a:prstGeom>
+              <a:ln w="19050"/>
+            </p:spPr>
+            <p:style>
+              <a:lnRef idx="2">
+                <a:schemeClr val="dk1"/>
+              </a:lnRef>
+              <a:fillRef idx="1">
+                <a:schemeClr val="lt1"/>
+              </a:fillRef>
+              <a:effectRef idx="0">
+                <a:schemeClr val="dk1"/>
+              </a:effectRef>
+              <a:fontRef idx="minor">
+                <a:schemeClr val="dk1"/>
+              </a:fontRef>
+            </p:style>
+            <p:txBody>
+              <a:bodyPr rtlCol="0" anchor="ctr"/>
+              <a:lstStyle/>
+              <a:p>
+                <a:pPr algn="ctr"/>
+                <a:endParaRPr lang="en-US"/>
+              </a:p>
+            </p:txBody>
+          </p:sp>
+          <p:sp>
+            <p:nvSpPr>
+              <p:cNvPr id="179" name="Oval 178">
+                <a:extLst>
+                  <a:ext uri="{FF2B5EF4-FFF2-40B4-BE49-F238E27FC236}">
+                    <a16:creationId xmlns:a16="http://schemas.microsoft.com/office/drawing/2014/main" id="{770A30A8-34EB-B684-74C1-F3EED3611450}"/>
+                  </a:ext>
+                </a:extLst>
+              </p:cNvPr>
+              <p:cNvSpPr/>
+              <p:nvPr/>
+            </p:nvSpPr>
+            <p:spPr>
+              <a:xfrm>
+                <a:off x="4900695" y="2318626"/>
+                <a:ext cx="416527" cy="245033"/>
+              </a:xfrm>
+              <a:prstGeom prst="ellipse">
+                <a:avLst/>
+              </a:prstGeom>
+              <a:ln w="19050"/>
+            </p:spPr>
+            <p:style>
+              <a:lnRef idx="2">
+                <a:schemeClr val="dk1"/>
+              </a:lnRef>
+              <a:fillRef idx="1">
+                <a:schemeClr val="lt1"/>
+              </a:fillRef>
+              <a:effectRef idx="0">
+                <a:schemeClr val="dk1"/>
+              </a:effectRef>
+              <a:fontRef idx="minor">
+                <a:schemeClr val="dk1"/>
+              </a:fontRef>
+            </p:style>
+            <p:txBody>
+              <a:bodyPr rtlCol="0" anchor="ctr"/>
+              <a:lstStyle/>
+              <a:p>
+                <a:pPr algn="ctr"/>
+                <a:endParaRPr lang="en-US"/>
+              </a:p>
+            </p:txBody>
+          </p:sp>
+          <p:sp>
+            <p:nvSpPr>
+              <p:cNvPr id="180" name="Rectangle 179">
+                <a:extLst>
+                  <a:ext uri="{FF2B5EF4-FFF2-40B4-BE49-F238E27FC236}">
+                    <a16:creationId xmlns:a16="http://schemas.microsoft.com/office/drawing/2014/main" id="{B73787A2-F72B-6B6A-A1D1-05B14CBCF617}"/>
+                  </a:ext>
+                </a:extLst>
+              </p:cNvPr>
+              <p:cNvSpPr/>
+              <p:nvPr/>
+            </p:nvSpPr>
+            <p:spPr>
+              <a:xfrm>
+                <a:off x="4680918" y="3141347"/>
+                <a:ext cx="1293843" cy="264953"/>
+              </a:xfrm>
+              <a:prstGeom prst="rect">
+                <a:avLst/>
+              </a:prstGeom>
+            </p:spPr>
+            <p:style>
+              <a:lnRef idx="2">
+                <a:schemeClr val="dk1">
+                  <a:shade val="50000"/>
+                </a:schemeClr>
+              </a:lnRef>
+              <a:fillRef idx="1">
+                <a:schemeClr val="dk1"/>
+              </a:fillRef>
+              <a:effectRef idx="0">
+                <a:schemeClr val="dk1"/>
+              </a:effectRef>
+              <a:fontRef idx="minor">
+                <a:schemeClr val="lt1"/>
+              </a:fontRef>
+            </p:style>
+            <p:txBody>
+              <a:bodyPr rtlCol="0" anchor="ctr"/>
+              <a:lstStyle/>
+              <a:p>
+                <a:pPr algn="ctr"/>
+                <a:endParaRPr lang="en-US"/>
+              </a:p>
+            </p:txBody>
+          </p:sp>
+          <p:sp>
+            <p:nvSpPr>
+              <p:cNvPr id="181" name="Rectangle 180">
+                <a:extLst>
+                  <a:ext uri="{FF2B5EF4-FFF2-40B4-BE49-F238E27FC236}">
+                    <a16:creationId xmlns:a16="http://schemas.microsoft.com/office/drawing/2014/main" id="{760B4293-23BD-765F-BB58-8BD254DB499E}"/>
+                  </a:ext>
+                </a:extLst>
+              </p:cNvPr>
+              <p:cNvSpPr/>
+              <p:nvPr/>
+            </p:nvSpPr>
+            <p:spPr>
+              <a:xfrm rot="18924703">
+                <a:off x="3786366" y="3518395"/>
+                <a:ext cx="1168464" cy="264953"/>
+              </a:xfrm>
+              <a:prstGeom prst="rect">
+                <a:avLst/>
+              </a:prstGeom>
+            </p:spPr>
+            <p:style>
+              <a:lnRef idx="2">
+                <a:schemeClr val="dk1">
+                  <a:shade val="50000"/>
+                </a:schemeClr>
+              </a:lnRef>
+              <a:fillRef idx="1">
+                <a:schemeClr val="dk1"/>
+              </a:fillRef>
+              <a:effectRef idx="0">
+                <a:schemeClr val="dk1"/>
+              </a:effectRef>
+              <a:fontRef idx="minor">
+                <a:schemeClr val="lt1"/>
+              </a:fontRef>
+            </p:style>
+            <p:txBody>
+              <a:bodyPr rtlCol="0" anchor="ctr"/>
+              <a:lstStyle/>
+              <a:p>
+                <a:pPr algn="ctr"/>
+                <a:endParaRPr lang="en-US"/>
+              </a:p>
+            </p:txBody>
+          </p:sp>
+          <p:sp>
+            <p:nvSpPr>
+              <p:cNvPr id="182" name="Rectangle 181">
+                <a:extLst>
+                  <a:ext uri="{FF2B5EF4-FFF2-40B4-BE49-F238E27FC236}">
+                    <a16:creationId xmlns:a16="http://schemas.microsoft.com/office/drawing/2014/main" id="{BB894740-B994-95DC-C286-54FCCFAD009A}"/>
+                  </a:ext>
+                </a:extLst>
+              </p:cNvPr>
+              <p:cNvSpPr/>
+              <p:nvPr/>
+            </p:nvSpPr>
+            <p:spPr>
+              <a:xfrm rot="5400000">
+                <a:off x="4997481" y="2316923"/>
+                <a:ext cx="855031" cy="774285"/>
+              </a:xfrm>
+              <a:prstGeom prst="rect">
+                <a:avLst/>
+              </a:prstGeom>
+            </p:spPr>
+            <p:style>
+              <a:lnRef idx="2">
+                <a:schemeClr val="dk1">
+                  <a:shade val="50000"/>
+                </a:schemeClr>
+              </a:lnRef>
+              <a:fillRef idx="1">
+                <a:schemeClr val="dk1"/>
+              </a:fillRef>
+              <a:effectRef idx="0">
+                <a:schemeClr val="dk1"/>
+              </a:effectRef>
+              <a:fontRef idx="minor">
+                <a:schemeClr val="lt1"/>
+              </a:fontRef>
+            </p:style>
+            <p:txBody>
+              <a:bodyPr rtlCol="0" anchor="ctr"/>
+              <a:lstStyle/>
+              <a:p>
+                <a:pPr algn="ctr"/>
+                <a:endParaRPr lang="en-US"/>
+              </a:p>
+            </p:txBody>
+          </p:sp>
+          <p:sp>
+            <p:nvSpPr>
+              <p:cNvPr id="183" name="Rectangle 182">
+                <a:extLst>
+                  <a:ext uri="{FF2B5EF4-FFF2-40B4-BE49-F238E27FC236}">
+                    <a16:creationId xmlns:a16="http://schemas.microsoft.com/office/drawing/2014/main" id="{38CEE4F4-EC35-FAF8-C7C7-24ACCBCAFE2E}"/>
+                  </a:ext>
+                </a:extLst>
+              </p:cNvPr>
+              <p:cNvSpPr/>
+              <p:nvPr/>
+            </p:nvSpPr>
+            <p:spPr>
+              <a:xfrm rot="13813249">
+                <a:off x="5671555" y="3510875"/>
+                <a:ext cx="1085838" cy="264952"/>
+              </a:xfrm>
+              <a:prstGeom prst="rect">
+                <a:avLst/>
+              </a:prstGeom>
+            </p:spPr>
+            <p:style>
+              <a:lnRef idx="2">
+                <a:schemeClr val="dk1">
+                  <a:shade val="50000"/>
+                </a:schemeClr>
+              </a:lnRef>
+              <a:fillRef idx="1">
+                <a:schemeClr val="dk1"/>
+              </a:fillRef>
+              <a:effectRef idx="0">
+                <a:schemeClr val="dk1"/>
+              </a:effectRef>
+              <a:fontRef idx="minor">
+                <a:schemeClr val="lt1"/>
+              </a:fontRef>
+            </p:style>
+            <p:txBody>
+              <a:bodyPr rtlCol="0" anchor="ctr"/>
+              <a:lstStyle/>
+              <a:p>
+                <a:pPr algn="ctr"/>
+                <a:endParaRPr lang="en-US"/>
+              </a:p>
+            </p:txBody>
+          </p:sp>
+          <p:sp>
+            <p:nvSpPr>
+              <p:cNvPr id="184" name="Rectangle 183">
+                <a:extLst>
+                  <a:ext uri="{FF2B5EF4-FFF2-40B4-BE49-F238E27FC236}">
+                    <a16:creationId xmlns:a16="http://schemas.microsoft.com/office/drawing/2014/main" id="{92E3FDD2-0BBA-19AF-1A3F-6269B63D266B}"/>
+                  </a:ext>
+                </a:extLst>
+              </p:cNvPr>
+              <p:cNvSpPr/>
+              <p:nvPr/>
+            </p:nvSpPr>
+            <p:spPr>
+              <a:xfrm>
+                <a:off x="3853893" y="3976847"/>
+                <a:ext cx="2809767" cy="264953"/>
+              </a:xfrm>
+              <a:prstGeom prst="rect">
+                <a:avLst/>
+              </a:prstGeom>
+            </p:spPr>
+            <p:style>
+              <a:lnRef idx="2">
+                <a:schemeClr val="dk1">
+                  <a:shade val="50000"/>
+                </a:schemeClr>
+              </a:lnRef>
+              <a:fillRef idx="1">
+                <a:schemeClr val="dk1"/>
+              </a:fillRef>
+              <a:effectRef idx="0">
+                <a:schemeClr val="dk1"/>
+              </a:effectRef>
+              <a:fontRef idx="minor">
+                <a:schemeClr val="lt1"/>
+              </a:fontRef>
+            </p:style>
+            <p:txBody>
+              <a:bodyPr rtlCol="0" anchor="ctr"/>
+              <a:lstStyle/>
+              <a:p>
+                <a:pPr algn="ctr"/>
+                <a:endParaRPr lang="en-US"/>
+              </a:p>
+            </p:txBody>
+          </p:sp>
+          <p:sp>
+            <p:nvSpPr>
+              <p:cNvPr id="185" name="Rectangle 184">
+                <a:extLst>
+                  <a:ext uri="{FF2B5EF4-FFF2-40B4-BE49-F238E27FC236}">
+                    <a16:creationId xmlns:a16="http://schemas.microsoft.com/office/drawing/2014/main" id="{0B276AD9-E91C-73DA-D472-1B496D58C5DC}"/>
+                  </a:ext>
+                </a:extLst>
+              </p:cNvPr>
+              <p:cNvSpPr/>
+              <p:nvPr/>
+            </p:nvSpPr>
+            <p:spPr>
+              <a:xfrm>
+                <a:off x="4231210" y="3678253"/>
+                <a:ext cx="2151835" cy="427677"/>
+              </a:xfrm>
+              <a:prstGeom prst="rect">
+                <a:avLst/>
+              </a:prstGeom>
+            </p:spPr>
+            <p:style>
+              <a:lnRef idx="2">
+                <a:schemeClr val="dk1">
+                  <a:shade val="50000"/>
+                </a:schemeClr>
+              </a:lnRef>
+              <a:fillRef idx="1">
+                <a:schemeClr val="dk1"/>
+              </a:fillRef>
+              <a:effectRef idx="0">
+                <a:schemeClr val="dk1"/>
+              </a:effectRef>
+              <a:fontRef idx="minor">
+                <a:schemeClr val="lt1"/>
+              </a:fontRef>
+            </p:style>
+            <p:txBody>
+              <a:bodyPr rtlCol="0" anchor="ctr"/>
+              <a:lstStyle/>
+              <a:p>
+                <a:pPr algn="ctr"/>
+                <a:endParaRPr lang="en-US"/>
+              </a:p>
+            </p:txBody>
+          </p:sp>
+          <p:pic>
+            <p:nvPicPr>
+              <p:cNvPr id="186" name="Picture 10" descr="✓ flamethrower free vector eps, cdr, ai, svg vector illustration graphic art">
+                <a:extLst>
+                  <a:ext uri="{FF2B5EF4-FFF2-40B4-BE49-F238E27FC236}">
+                    <a16:creationId xmlns:a16="http://schemas.microsoft.com/office/drawing/2014/main" id="{43A20FB9-4800-281F-823C-C502717F1532}"/>
+                  </a:ext>
+                </a:extLst>
+              </p:cNvPr>
+              <p:cNvPicPr>
+                <a:picLocks noChangeAspect="1" noChangeArrowheads="1"/>
+              </p:cNvPicPr>
+              <p:nvPr/>
+            </p:nvPicPr>
+            <p:blipFill rotWithShape="1">
+              <a:blip r:embed="rId5">
+                <a:extLst>
+                  <a:ext uri="{28A0092B-C50C-407E-A947-70E740481C1C}">
+                    <a14:useLocalDpi xmlns:a14="http://schemas.microsoft.com/office/drawing/2010/main" val="0"/>
+                  </a:ext>
+                </a:extLst>
+              </a:blip>
+              <a:srcRect l="29258" b="25887"/>
+              <a:stretch/>
+            </p:blipFill>
+            <p:spPr bwMode="auto">
+              <a:xfrm rot="10405411">
+                <a:off x="3151975" y="2371698"/>
+                <a:ext cx="1711232" cy="385815"/>
+              </a:xfrm>
+              <a:prstGeom prst="rect">
+                <a:avLst/>
+              </a:prstGeom>
+              <a:noFill/>
+              <a:extLst>
+                <a:ext uri="{909E8E84-426E-40DD-AFC4-6F175D3DCCD1}">
+                  <a14:hiddenFill xmlns:a14="http://schemas.microsoft.com/office/drawing/2010/main">
+                    <a:solidFill>
+                      <a:srgbClr val="FFFFFF"/>
+                    </a:solidFill>
+                  </a14:hiddenFill>
+                </a:ext>
+              </a:extLst>
+            </p:spPr>
+          </p:pic>
+          <p:pic>
+            <p:nvPicPr>
+              <p:cNvPr id="187" name="Picture 10" descr="✓ flamethrower free vector eps, cdr, ai, svg vector illustration graphic art">
+                <a:extLst>
+                  <a:ext uri="{FF2B5EF4-FFF2-40B4-BE49-F238E27FC236}">
+                    <a16:creationId xmlns:a16="http://schemas.microsoft.com/office/drawing/2014/main" id="{E0059DD8-232B-6BF1-F773-4DA2EA2840EF}"/>
+                  </a:ext>
+                </a:extLst>
+              </p:cNvPr>
+              <p:cNvPicPr>
+                <a:picLocks noChangeAspect="1" noChangeArrowheads="1"/>
+              </p:cNvPicPr>
+              <p:nvPr/>
+            </p:nvPicPr>
+            <p:blipFill rotWithShape="1">
+              <a:blip r:embed="rId5">
+                <a:extLst>
+                  <a:ext uri="{28A0092B-C50C-407E-A947-70E740481C1C}">
+                    <a14:useLocalDpi xmlns:a14="http://schemas.microsoft.com/office/drawing/2010/main" val="0"/>
+                  </a:ext>
+                </a:extLst>
+              </a:blip>
+              <a:srcRect l="29258" b="25887"/>
+              <a:stretch/>
+            </p:blipFill>
+            <p:spPr bwMode="auto">
+              <a:xfrm rot="10405411">
+                <a:off x="3172999" y="2759003"/>
+                <a:ext cx="1711232" cy="385815"/>
+              </a:xfrm>
+              <a:prstGeom prst="rect">
+                <a:avLst/>
+              </a:prstGeom>
+              <a:noFill/>
+              <a:extLst>
+                <a:ext uri="{909E8E84-426E-40DD-AFC4-6F175D3DCCD1}">
+                  <a14:hiddenFill xmlns:a14="http://schemas.microsoft.com/office/drawing/2010/main">
+                    <a:solidFill>
+                      <a:srgbClr val="FFFFFF"/>
+                    </a:solidFill>
+                  </a14:hiddenFill>
+                </a:ext>
+              </a:extLst>
+            </p:spPr>
+          </p:pic>
+        </p:grpSp>
+      </p:grpSp>
+      <p:grpSp>
+        <p:nvGrpSpPr>
+          <p:cNvPr id="190" name="Group 189">
+            <a:extLst>
+              <a:ext uri="{FF2B5EF4-FFF2-40B4-BE49-F238E27FC236}">
+                <a16:creationId xmlns:a16="http://schemas.microsoft.com/office/drawing/2014/main" id="{B4E527ED-C855-F16F-83EE-9791A4ACE499}"/>
+              </a:ext>
+            </a:extLst>
+          </p:cNvPr>
+          <p:cNvGrpSpPr/>
+          <p:nvPr/>
+        </p:nvGrpSpPr>
+        <p:grpSpPr>
+          <a:xfrm>
+            <a:off x="6845317" y="5459212"/>
+            <a:ext cx="1371600" cy="1371600"/>
+            <a:chOff x="3505447" y="2057400"/>
+            <a:chExt cx="1371600" cy="1371600"/>
+          </a:xfrm>
+        </p:grpSpPr>
+        <p:grpSp>
+          <p:nvGrpSpPr>
+            <p:cNvPr id="191" name="Group 190">
+              <a:extLst>
+                <a:ext uri="{FF2B5EF4-FFF2-40B4-BE49-F238E27FC236}">
+                  <a16:creationId xmlns:a16="http://schemas.microsoft.com/office/drawing/2014/main" id="{CC879EFF-D6AD-B749-C607-4FCD95305842}"/>
+                </a:ext>
+              </a:extLst>
+            </p:cNvPr>
+            <p:cNvGrpSpPr/>
+            <p:nvPr/>
+          </p:nvGrpSpPr>
+          <p:grpSpPr>
+            <a:xfrm>
+              <a:off x="3505447" y="2057400"/>
+              <a:ext cx="1371600" cy="1371600"/>
+              <a:chOff x="1298501" y="962272"/>
+              <a:chExt cx="1371600" cy="1371600"/>
+            </a:xfrm>
+          </p:grpSpPr>
+          <p:sp>
+            <p:nvSpPr>
+              <p:cNvPr id="201" name="Rectangle 200">
+                <a:extLst>
+                  <a:ext uri="{FF2B5EF4-FFF2-40B4-BE49-F238E27FC236}">
+                    <a16:creationId xmlns:a16="http://schemas.microsoft.com/office/drawing/2014/main" id="{2883E491-1EA4-642D-87C0-003037C65BAF}"/>
+                  </a:ext>
+                </a:extLst>
+              </p:cNvPr>
+              <p:cNvSpPr/>
+              <p:nvPr/>
+            </p:nvSpPr>
+            <p:spPr>
+              <a:xfrm>
+                <a:off x="1298501" y="962272"/>
+                <a:ext cx="1371600" cy="1371600"/>
+              </a:xfrm>
+              <a:prstGeom prst="rect">
+                <a:avLst/>
+              </a:prstGeom>
+              <a:noFill/>
+              <a:ln w="76200">
+                <a:solidFill>
+                  <a:schemeClr val="tx1"/>
+                </a:solidFill>
+              </a:ln>
+            </p:spPr>
+            <p:style>
+              <a:lnRef idx="2">
+                <a:schemeClr val="accent1">
+                  <a:shade val="50000"/>
+                </a:schemeClr>
+              </a:lnRef>
+              <a:fillRef idx="1">
+                <a:schemeClr val="accent1"/>
+              </a:fillRef>
+              <a:effectRef idx="0">
+                <a:schemeClr val="accent1"/>
+              </a:effectRef>
+              <a:fontRef idx="minor">
+                <a:schemeClr val="lt1"/>
+              </a:fontRef>
+            </p:style>
+            <p:txBody>
+              <a:bodyPr rtlCol="0" anchor="ctr"/>
+              <a:lstStyle/>
+              <a:p>
+                <a:pPr algn="ctr"/>
+                <a:endParaRPr lang="en-US"/>
+              </a:p>
+            </p:txBody>
+          </p:sp>
+          <p:sp>
+            <p:nvSpPr>
+              <p:cNvPr id="202" name="Arrow: Pentagon 201">
+                <a:extLst>
+                  <a:ext uri="{FF2B5EF4-FFF2-40B4-BE49-F238E27FC236}">
+                    <a16:creationId xmlns:a16="http://schemas.microsoft.com/office/drawing/2014/main" id="{0D753BBE-FAC4-D15E-EA3E-805D3B206945}"/>
+                  </a:ext>
+                </a:extLst>
+              </p:cNvPr>
+              <p:cNvSpPr/>
+              <p:nvPr/>
+            </p:nvSpPr>
+            <p:spPr>
+              <a:xfrm rot="5400000">
+                <a:off x="1435661" y="1173775"/>
+                <a:ext cx="1097280" cy="1097280"/>
+              </a:xfrm>
+              <a:prstGeom prst="homePlate">
+                <a:avLst/>
+              </a:prstGeom>
+              <a:noFill/>
+              <a:ln w="38100" cap="flat" cmpd="sng" algn="ctr">
+                <a:solidFill>
+                  <a:schemeClr val="dk1"/>
+                </a:solidFill>
+                <a:prstDash val="solid"/>
+                <a:round/>
+                <a:headEnd type="none" w="med" len="med"/>
+                <a:tailEnd type="none" w="med" len="med"/>
+              </a:ln>
+            </p:spPr>
+            <p:style>
+              <a:lnRef idx="0">
+                <a:scrgbClr r="0" g="0" b="0"/>
+              </a:lnRef>
+              <a:fillRef idx="0">
+                <a:scrgbClr r="0" g="0" b="0"/>
+              </a:fillRef>
+              <a:effectRef idx="0">
+                <a:scrgbClr r="0" g="0" b="0"/>
+              </a:effectRef>
+              <a:fontRef idx="minor">
+                <a:schemeClr val="dk1"/>
+              </a:fontRef>
+            </p:style>
+            <p:txBody>
+              <a:bodyPr rtlCol="0" anchor="ctr"/>
+              <a:lstStyle/>
+              <a:p>
+                <a:pPr algn="ctr"/>
+                <a:endParaRPr lang="en-US"/>
+              </a:p>
+            </p:txBody>
+          </p:sp>
+        </p:grpSp>
+        <p:grpSp>
+          <p:nvGrpSpPr>
+            <p:cNvPr id="192" name="Group 191">
+              <a:extLst>
+                <a:ext uri="{FF2B5EF4-FFF2-40B4-BE49-F238E27FC236}">
+                  <a16:creationId xmlns:a16="http://schemas.microsoft.com/office/drawing/2014/main" id="{CA7CE95B-A6EB-1766-1106-B6411BA9081E}"/>
+                </a:ext>
+              </a:extLst>
+            </p:cNvPr>
+            <p:cNvGrpSpPr/>
+            <p:nvPr/>
+          </p:nvGrpSpPr>
+          <p:grpSpPr>
+            <a:xfrm>
+              <a:off x="3833985" y="2339828"/>
+              <a:ext cx="714523" cy="781908"/>
+              <a:chOff x="6264127" y="1307188"/>
+              <a:chExt cx="1391653" cy="1522897"/>
+            </a:xfrm>
+          </p:grpSpPr>
+          <p:sp>
+            <p:nvSpPr>
+              <p:cNvPr id="193" name="Rectangle 192">
+                <a:extLst>
+                  <a:ext uri="{FF2B5EF4-FFF2-40B4-BE49-F238E27FC236}">
+                    <a16:creationId xmlns:a16="http://schemas.microsoft.com/office/drawing/2014/main" id="{00CAD98A-0E5C-7F1F-D0C2-3987E99569ED}"/>
+                  </a:ext>
+                </a:extLst>
+              </p:cNvPr>
+              <p:cNvSpPr/>
+              <p:nvPr/>
+            </p:nvSpPr>
+            <p:spPr>
+              <a:xfrm>
+                <a:off x="6521307" y="1710168"/>
+                <a:ext cx="369217" cy="471814"/>
+              </a:xfrm>
+              <a:prstGeom prst="rect">
+                <a:avLst/>
+              </a:prstGeom>
+            </p:spPr>
+            <p:style>
+              <a:lnRef idx="2">
+                <a:schemeClr val="dk1">
+                  <a:shade val="50000"/>
+                </a:schemeClr>
+              </a:lnRef>
+              <a:fillRef idx="1">
+                <a:schemeClr val="dk1"/>
+              </a:fillRef>
+              <a:effectRef idx="0">
+                <a:schemeClr val="dk1"/>
+              </a:effectRef>
+              <a:fontRef idx="minor">
+                <a:schemeClr val="lt1"/>
+              </a:fontRef>
+            </p:style>
+            <p:txBody>
+              <a:bodyPr rtlCol="0" anchor="ctr"/>
+              <a:lstStyle/>
+              <a:p>
+                <a:pPr algn="ctr"/>
+                <a:endParaRPr lang="en-US"/>
+              </a:p>
+            </p:txBody>
+          </p:sp>
+          <p:sp>
+            <p:nvSpPr>
+              <p:cNvPr id="194" name="Rectangle 193">
+                <a:extLst>
+                  <a:ext uri="{FF2B5EF4-FFF2-40B4-BE49-F238E27FC236}">
+                    <a16:creationId xmlns:a16="http://schemas.microsoft.com/office/drawing/2014/main" id="{36C9DA6E-7F46-CA0D-A63C-C21F32EEF218}"/>
+                  </a:ext>
+                </a:extLst>
+              </p:cNvPr>
+              <p:cNvSpPr/>
+              <p:nvPr/>
+            </p:nvSpPr>
+            <p:spPr>
+              <a:xfrm flipH="1">
+                <a:off x="7011908" y="1710134"/>
+                <a:ext cx="369217" cy="471814"/>
+              </a:xfrm>
+              <a:prstGeom prst="rect">
+                <a:avLst/>
+              </a:prstGeom>
+            </p:spPr>
+            <p:style>
+              <a:lnRef idx="2">
+                <a:schemeClr val="dk1">
+                  <a:shade val="50000"/>
+                </a:schemeClr>
+              </a:lnRef>
+              <a:fillRef idx="1">
+                <a:schemeClr val="dk1"/>
+              </a:fillRef>
+              <a:effectRef idx="0">
+                <a:schemeClr val="dk1"/>
+              </a:effectRef>
+              <a:fontRef idx="minor">
+                <a:schemeClr val="lt1"/>
+              </a:fontRef>
+            </p:style>
+            <p:txBody>
+              <a:bodyPr rtlCol="0" anchor="ctr"/>
+              <a:lstStyle/>
+              <a:p>
+                <a:pPr algn="ctr"/>
+                <a:endParaRPr lang="en-US"/>
+              </a:p>
+            </p:txBody>
+          </p:sp>
+          <p:sp>
+            <p:nvSpPr>
+              <p:cNvPr id="195" name="Isosceles Triangle 194">
+                <a:extLst>
+                  <a:ext uri="{FF2B5EF4-FFF2-40B4-BE49-F238E27FC236}">
+                    <a16:creationId xmlns:a16="http://schemas.microsoft.com/office/drawing/2014/main" id="{5A36E031-5098-AB55-3F38-24563219B5FE}"/>
+                  </a:ext>
+                </a:extLst>
+              </p:cNvPr>
+              <p:cNvSpPr/>
+              <p:nvPr/>
+            </p:nvSpPr>
+            <p:spPr>
+              <a:xfrm rot="10800000">
+                <a:off x="6775345" y="2266431"/>
+                <a:ext cx="369217" cy="563654"/>
+              </a:xfrm>
+              <a:prstGeom prst="triangle">
+                <a:avLst/>
+              </a:prstGeom>
+            </p:spPr>
+            <p:style>
+              <a:lnRef idx="2">
+                <a:schemeClr val="dk1">
+                  <a:shade val="50000"/>
+                </a:schemeClr>
+              </a:lnRef>
+              <a:fillRef idx="1">
+                <a:schemeClr val="dk1"/>
+              </a:fillRef>
+              <a:effectRef idx="0">
+                <a:schemeClr val="dk1"/>
+              </a:effectRef>
+              <a:fontRef idx="minor">
+                <a:schemeClr val="lt1"/>
+              </a:fontRef>
+            </p:style>
+            <p:txBody>
+              <a:bodyPr rtlCol="0" anchor="ctr"/>
+              <a:lstStyle/>
+              <a:p>
+                <a:pPr algn="ctr"/>
+                <a:endParaRPr lang="en-US"/>
+              </a:p>
+            </p:txBody>
+          </p:sp>
+          <p:sp>
+            <p:nvSpPr>
+              <p:cNvPr id="196" name="Isosceles Triangle 195">
+                <a:extLst>
+                  <a:ext uri="{FF2B5EF4-FFF2-40B4-BE49-F238E27FC236}">
+                    <a16:creationId xmlns:a16="http://schemas.microsoft.com/office/drawing/2014/main" id="{1F98A65B-59C7-2D4F-0889-014237F86382}"/>
+                  </a:ext>
+                </a:extLst>
+              </p:cNvPr>
+              <p:cNvSpPr/>
+              <p:nvPr/>
+            </p:nvSpPr>
+            <p:spPr>
+              <a:xfrm rot="10800000" flipV="1">
+                <a:off x="6775345" y="1312217"/>
+                <a:ext cx="369217" cy="365940"/>
+              </a:xfrm>
+              <a:prstGeom prst="triangle">
+                <a:avLst/>
+              </a:prstGeom>
+            </p:spPr>
+            <p:style>
+              <a:lnRef idx="2">
+                <a:schemeClr val="dk1">
+                  <a:shade val="50000"/>
+                </a:schemeClr>
+              </a:lnRef>
+              <a:fillRef idx="1">
+                <a:schemeClr val="dk1"/>
+              </a:fillRef>
+              <a:effectRef idx="0">
+                <a:schemeClr val="dk1"/>
+              </a:effectRef>
+              <a:fontRef idx="minor">
+                <a:schemeClr val="lt1"/>
+              </a:fontRef>
+            </p:style>
+            <p:txBody>
+              <a:bodyPr rtlCol="0" anchor="ctr"/>
+              <a:lstStyle/>
+              <a:p>
+                <a:pPr algn="ctr"/>
+                <a:endParaRPr lang="en-US"/>
+              </a:p>
+            </p:txBody>
+          </p:sp>
+          <p:sp>
+            <p:nvSpPr>
+              <p:cNvPr id="197" name="Rectangle 196">
+                <a:extLst>
+                  <a:ext uri="{FF2B5EF4-FFF2-40B4-BE49-F238E27FC236}">
+                    <a16:creationId xmlns:a16="http://schemas.microsoft.com/office/drawing/2014/main" id="{E771373C-063A-B02C-748E-FE49A4014B20}"/>
+                  </a:ext>
+                </a:extLst>
+              </p:cNvPr>
+              <p:cNvSpPr/>
+              <p:nvPr/>
+            </p:nvSpPr>
+            <p:spPr>
+              <a:xfrm>
+                <a:off x="6658821" y="1315488"/>
+                <a:ext cx="94188" cy="394646"/>
+              </a:xfrm>
+              <a:prstGeom prst="rect">
+                <a:avLst/>
+              </a:prstGeom>
+            </p:spPr>
+            <p:style>
+              <a:lnRef idx="2">
+                <a:schemeClr val="dk1">
+                  <a:shade val="50000"/>
+                </a:schemeClr>
+              </a:lnRef>
+              <a:fillRef idx="1">
+                <a:schemeClr val="dk1"/>
+              </a:fillRef>
+              <a:effectRef idx="0">
+                <a:schemeClr val="dk1"/>
+              </a:effectRef>
+              <a:fontRef idx="minor">
+                <a:schemeClr val="lt1"/>
+              </a:fontRef>
+            </p:style>
+            <p:txBody>
+              <a:bodyPr rtlCol="0" anchor="ctr"/>
+              <a:lstStyle/>
+              <a:p>
+                <a:pPr algn="ctr"/>
+                <a:endParaRPr lang="en-US"/>
+              </a:p>
+            </p:txBody>
+          </p:sp>
+          <p:sp>
+            <p:nvSpPr>
+              <p:cNvPr id="198" name="Rectangle 197">
+                <a:extLst>
+                  <a:ext uri="{FF2B5EF4-FFF2-40B4-BE49-F238E27FC236}">
+                    <a16:creationId xmlns:a16="http://schemas.microsoft.com/office/drawing/2014/main" id="{EB82AEFC-8F58-D7B1-6BB5-74B6EBD82FAA}"/>
+                  </a:ext>
+                </a:extLst>
+              </p:cNvPr>
+              <p:cNvSpPr/>
+              <p:nvPr/>
+            </p:nvSpPr>
+            <p:spPr>
+              <a:xfrm>
+                <a:off x="7163130" y="1307188"/>
+                <a:ext cx="94188" cy="394646"/>
+              </a:xfrm>
+              <a:prstGeom prst="rect">
+                <a:avLst/>
+              </a:prstGeom>
+            </p:spPr>
+            <p:style>
+              <a:lnRef idx="2">
+                <a:schemeClr val="dk1">
+                  <a:shade val="50000"/>
+                </a:schemeClr>
+              </a:lnRef>
+              <a:fillRef idx="1">
+                <a:schemeClr val="dk1"/>
+              </a:fillRef>
+              <a:effectRef idx="0">
+                <a:schemeClr val="dk1"/>
+              </a:effectRef>
+              <a:fontRef idx="minor">
+                <a:schemeClr val="lt1"/>
+              </a:fontRef>
+            </p:style>
+            <p:txBody>
+              <a:bodyPr rtlCol="0" anchor="ctr"/>
+              <a:lstStyle/>
+              <a:p>
+                <a:pPr algn="ctr"/>
+                <a:endParaRPr lang="en-US"/>
+              </a:p>
+            </p:txBody>
+          </p:sp>
+          <p:sp>
+            <p:nvSpPr>
+              <p:cNvPr id="199" name="Moon 198">
+                <a:extLst>
+                  <a:ext uri="{FF2B5EF4-FFF2-40B4-BE49-F238E27FC236}">
+                    <a16:creationId xmlns:a16="http://schemas.microsoft.com/office/drawing/2014/main" id="{E71F3053-EB02-8211-2C85-DDA6F16D766D}"/>
+                  </a:ext>
+                </a:extLst>
+              </p:cNvPr>
+              <p:cNvSpPr/>
+              <p:nvPr/>
+            </p:nvSpPr>
+            <p:spPr>
+              <a:xfrm rot="20131114">
+                <a:off x="6264127" y="1862570"/>
+                <a:ext cx="419100" cy="902348"/>
+              </a:xfrm>
+              <a:prstGeom prst="moon">
+                <a:avLst/>
+              </a:prstGeom>
+            </p:spPr>
+            <p:style>
+              <a:lnRef idx="2">
+                <a:schemeClr val="dk1">
+                  <a:shade val="50000"/>
+                </a:schemeClr>
+              </a:lnRef>
+              <a:fillRef idx="1">
+                <a:schemeClr val="dk1"/>
+              </a:fillRef>
+              <a:effectRef idx="0">
+                <a:schemeClr val="dk1"/>
+              </a:effectRef>
+              <a:fontRef idx="minor">
+                <a:schemeClr val="lt1"/>
+              </a:fontRef>
+            </p:style>
+            <p:txBody>
+              <a:bodyPr rtlCol="0" anchor="ctr"/>
+              <a:lstStyle/>
+              <a:p>
+                <a:pPr algn="ctr"/>
+                <a:endParaRPr lang="en-US"/>
+              </a:p>
+            </p:txBody>
+          </p:sp>
+          <p:sp>
+            <p:nvSpPr>
+              <p:cNvPr id="200" name="Moon 199">
+                <a:extLst>
+                  <a:ext uri="{FF2B5EF4-FFF2-40B4-BE49-F238E27FC236}">
+                    <a16:creationId xmlns:a16="http://schemas.microsoft.com/office/drawing/2014/main" id="{56141787-B4A6-D4DB-07EC-CDB94D26AFFA}"/>
+                  </a:ext>
+                </a:extLst>
+              </p:cNvPr>
+              <p:cNvSpPr/>
+              <p:nvPr/>
+            </p:nvSpPr>
+            <p:spPr>
+              <a:xfrm rot="1468886" flipH="1">
+                <a:off x="7236680" y="1853886"/>
+                <a:ext cx="419100" cy="902348"/>
+              </a:xfrm>
+              <a:prstGeom prst="moon">
+                <a:avLst/>
+              </a:prstGeom>
+            </p:spPr>
+            <p:style>
+              <a:lnRef idx="2">
+                <a:schemeClr val="dk1">
+                  <a:shade val="50000"/>
+                </a:schemeClr>
+              </a:lnRef>
+              <a:fillRef idx="1">
+                <a:schemeClr val="dk1"/>
+              </a:fillRef>
+              <a:effectRef idx="0">
+                <a:schemeClr val="dk1"/>
+              </a:effectRef>
+              <a:fontRef idx="minor">
+                <a:schemeClr val="lt1"/>
+              </a:fontRef>
+            </p:style>
+            <p:txBody>
+              <a:bodyPr rtlCol="0" anchor="ctr"/>
+              <a:lstStyle/>
+              <a:p>
+                <a:pPr algn="ctr"/>
+                <a:endParaRPr lang="en-US"/>
+              </a:p>
+            </p:txBody>
+          </p:sp>
+        </p:grpSp>
+      </p:grpSp>
+      <p:grpSp>
+        <p:nvGrpSpPr>
+          <p:cNvPr id="203" name="Group 202">
+            <a:extLst>
+              <a:ext uri="{FF2B5EF4-FFF2-40B4-BE49-F238E27FC236}">
+                <a16:creationId xmlns:a16="http://schemas.microsoft.com/office/drawing/2014/main" id="{C7EB9757-33F3-9FF5-CA93-B849058C6A92}"/>
+              </a:ext>
+            </a:extLst>
+          </p:cNvPr>
+          <p:cNvGrpSpPr/>
+          <p:nvPr/>
+        </p:nvGrpSpPr>
+        <p:grpSpPr>
+          <a:xfrm>
+            <a:off x="8349845" y="5459212"/>
+            <a:ext cx="1371600" cy="1371600"/>
+            <a:chOff x="5009975" y="2057400"/>
+            <a:chExt cx="1371600" cy="1371600"/>
+          </a:xfrm>
+        </p:grpSpPr>
+        <p:grpSp>
+          <p:nvGrpSpPr>
+            <p:cNvPr id="204" name="Group 203">
+              <a:extLst>
+                <a:ext uri="{FF2B5EF4-FFF2-40B4-BE49-F238E27FC236}">
+                  <a16:creationId xmlns:a16="http://schemas.microsoft.com/office/drawing/2014/main" id="{1BB9C3D4-E6FA-2446-B18E-5E02F49C6653}"/>
+                </a:ext>
+              </a:extLst>
+            </p:cNvPr>
+            <p:cNvGrpSpPr/>
+            <p:nvPr/>
+          </p:nvGrpSpPr>
+          <p:grpSpPr>
+            <a:xfrm>
+              <a:off x="5009975" y="2057400"/>
+              <a:ext cx="1371600" cy="1371600"/>
+              <a:chOff x="1298501" y="962272"/>
+              <a:chExt cx="1371600" cy="1371600"/>
+            </a:xfrm>
+          </p:grpSpPr>
+          <p:sp>
+            <p:nvSpPr>
+              <p:cNvPr id="212" name="Rectangle 211">
+                <a:extLst>
+                  <a:ext uri="{FF2B5EF4-FFF2-40B4-BE49-F238E27FC236}">
+                    <a16:creationId xmlns:a16="http://schemas.microsoft.com/office/drawing/2014/main" id="{403F25F4-B361-49D4-7219-372DFF5090E7}"/>
+                  </a:ext>
+                </a:extLst>
+              </p:cNvPr>
+              <p:cNvSpPr/>
+              <p:nvPr/>
+            </p:nvSpPr>
+            <p:spPr>
+              <a:xfrm>
+                <a:off x="1298501" y="962272"/>
+                <a:ext cx="1371600" cy="1371600"/>
+              </a:xfrm>
+              <a:prstGeom prst="rect">
+                <a:avLst/>
+              </a:prstGeom>
+              <a:noFill/>
+              <a:ln w="76200">
+                <a:solidFill>
+                  <a:schemeClr val="tx1"/>
+                </a:solidFill>
+              </a:ln>
+            </p:spPr>
+            <p:style>
+              <a:lnRef idx="2">
+                <a:schemeClr val="accent1">
+                  <a:shade val="50000"/>
+                </a:schemeClr>
+              </a:lnRef>
+              <a:fillRef idx="1">
+                <a:schemeClr val="accent1"/>
+              </a:fillRef>
+              <a:effectRef idx="0">
+                <a:schemeClr val="accent1"/>
+              </a:effectRef>
+              <a:fontRef idx="minor">
+                <a:schemeClr val="lt1"/>
+              </a:fontRef>
+            </p:style>
+            <p:txBody>
+              <a:bodyPr rtlCol="0" anchor="ctr"/>
+              <a:lstStyle/>
+              <a:p>
+                <a:pPr algn="ctr"/>
+                <a:endParaRPr lang="en-US"/>
+              </a:p>
+            </p:txBody>
+          </p:sp>
+          <p:sp>
+            <p:nvSpPr>
+              <p:cNvPr id="213" name="Arrow: Pentagon 212">
+                <a:extLst>
+                  <a:ext uri="{FF2B5EF4-FFF2-40B4-BE49-F238E27FC236}">
+                    <a16:creationId xmlns:a16="http://schemas.microsoft.com/office/drawing/2014/main" id="{4393A72D-008E-104C-2391-A8E81491B5CE}"/>
+                  </a:ext>
+                </a:extLst>
+              </p:cNvPr>
+              <p:cNvSpPr/>
+              <p:nvPr/>
+            </p:nvSpPr>
+            <p:spPr>
+              <a:xfrm rot="5400000">
+                <a:off x="1435661" y="1173775"/>
+                <a:ext cx="1097280" cy="1097280"/>
+              </a:xfrm>
+              <a:prstGeom prst="homePlate">
+                <a:avLst/>
+              </a:prstGeom>
+              <a:noFill/>
+              <a:ln w="38100" cap="flat" cmpd="sng" algn="ctr">
+                <a:solidFill>
+                  <a:schemeClr val="dk1"/>
+                </a:solidFill>
+                <a:prstDash val="solid"/>
+                <a:round/>
+                <a:headEnd type="none" w="med" len="med"/>
+                <a:tailEnd type="none" w="med" len="med"/>
+              </a:ln>
+            </p:spPr>
+            <p:style>
+              <a:lnRef idx="0">
+                <a:scrgbClr r="0" g="0" b="0"/>
+              </a:lnRef>
+              <a:fillRef idx="0">
+                <a:scrgbClr r="0" g="0" b="0"/>
+              </a:fillRef>
+              <a:effectRef idx="0">
+                <a:scrgbClr r="0" g="0" b="0"/>
+              </a:effectRef>
+              <a:fontRef idx="minor">
+                <a:schemeClr val="dk1"/>
+              </a:fontRef>
+            </p:style>
+            <p:txBody>
+              <a:bodyPr rtlCol="0" anchor="ctr"/>
+              <a:lstStyle/>
+              <a:p>
+                <a:pPr algn="ctr"/>
+                <a:endParaRPr lang="en-US"/>
+              </a:p>
+            </p:txBody>
+          </p:sp>
+        </p:grpSp>
+        <p:grpSp>
+          <p:nvGrpSpPr>
+            <p:cNvPr id="205" name="Group 204">
+              <a:extLst>
+                <a:ext uri="{FF2B5EF4-FFF2-40B4-BE49-F238E27FC236}">
+                  <a16:creationId xmlns:a16="http://schemas.microsoft.com/office/drawing/2014/main" id="{8EBBE19C-B08E-1324-69CE-2F06CA721042}"/>
+                </a:ext>
+              </a:extLst>
+            </p:cNvPr>
+            <p:cNvGrpSpPr/>
+            <p:nvPr/>
+          </p:nvGrpSpPr>
+          <p:grpSpPr>
+            <a:xfrm rot="2403354">
+              <a:off x="5520349" y="2333220"/>
+              <a:ext cx="478022" cy="763020"/>
+              <a:chOff x="7639767" y="607131"/>
+              <a:chExt cx="1348536" cy="2152538"/>
+            </a:xfrm>
+          </p:grpSpPr>
+          <p:sp>
+            <p:nvSpPr>
+              <p:cNvPr id="206" name="Oval 205">
+                <a:extLst>
+                  <a:ext uri="{FF2B5EF4-FFF2-40B4-BE49-F238E27FC236}">
+                    <a16:creationId xmlns:a16="http://schemas.microsoft.com/office/drawing/2014/main" id="{323B5CF8-EECA-3149-2043-8EDC418A2B4E}"/>
+                  </a:ext>
+                </a:extLst>
+              </p:cNvPr>
+              <p:cNvSpPr/>
+              <p:nvPr/>
+            </p:nvSpPr>
+            <p:spPr>
+              <a:xfrm>
+                <a:off x="8043666" y="607131"/>
+                <a:ext cx="535184" cy="755481"/>
+              </a:xfrm>
+              <a:prstGeom prst="ellipse">
+                <a:avLst/>
+              </a:prstGeom>
+              <a:ln w="19050"/>
+            </p:spPr>
+            <p:style>
+              <a:lnRef idx="2">
+                <a:schemeClr val="dk1"/>
+              </a:lnRef>
+              <a:fillRef idx="1">
+                <a:schemeClr val="lt1"/>
+              </a:fillRef>
+              <a:effectRef idx="0">
+                <a:schemeClr val="dk1"/>
+              </a:effectRef>
+              <a:fontRef idx="minor">
+                <a:schemeClr val="dk1"/>
+              </a:fontRef>
+            </p:style>
+            <p:txBody>
+              <a:bodyPr rtlCol="0" anchor="ctr"/>
+              <a:lstStyle/>
+              <a:p>
+                <a:pPr algn="ctr"/>
+                <a:endParaRPr lang="en-US"/>
+              </a:p>
+            </p:txBody>
+          </p:sp>
+          <p:sp>
+            <p:nvSpPr>
+              <p:cNvPr id="207" name="Rectangle 206">
+                <a:extLst>
+                  <a:ext uri="{FF2B5EF4-FFF2-40B4-BE49-F238E27FC236}">
+                    <a16:creationId xmlns:a16="http://schemas.microsoft.com/office/drawing/2014/main" id="{A04ECD2A-FD47-9737-3C24-7D72D1BBFF32}"/>
+                  </a:ext>
+                </a:extLst>
+              </p:cNvPr>
+              <p:cNvSpPr/>
+              <p:nvPr/>
+            </p:nvSpPr>
+            <p:spPr>
+              <a:xfrm>
+                <a:off x="8043666" y="939800"/>
+                <a:ext cx="535184" cy="1819116"/>
+              </a:xfrm>
+              <a:prstGeom prst="rect">
+                <a:avLst/>
+              </a:prstGeom>
+            </p:spPr>
+            <p:style>
+              <a:lnRef idx="2">
+                <a:schemeClr val="dk1">
+                  <a:shade val="50000"/>
+                </a:schemeClr>
+              </a:lnRef>
+              <a:fillRef idx="1">
+                <a:schemeClr val="dk1"/>
+              </a:fillRef>
+              <a:effectRef idx="0">
+                <a:schemeClr val="dk1"/>
+              </a:effectRef>
+              <a:fontRef idx="minor">
+                <a:schemeClr val="lt1"/>
+              </a:fontRef>
+            </p:style>
+            <p:txBody>
+              <a:bodyPr rtlCol="0" anchor="ctr"/>
+              <a:lstStyle/>
+              <a:p>
+                <a:pPr algn="ctr"/>
+                <a:endParaRPr lang="en-US"/>
+              </a:p>
+            </p:txBody>
+          </p:sp>
+          <p:sp>
+            <p:nvSpPr>
+              <p:cNvPr id="208" name="Right Triangle 207">
+                <a:extLst>
+                  <a:ext uri="{FF2B5EF4-FFF2-40B4-BE49-F238E27FC236}">
+                    <a16:creationId xmlns:a16="http://schemas.microsoft.com/office/drawing/2014/main" id="{01B959A6-4776-F890-9E2E-418D558ED4CF}"/>
+                  </a:ext>
+                </a:extLst>
+              </p:cNvPr>
+              <p:cNvSpPr/>
+              <p:nvPr/>
+            </p:nvSpPr>
+            <p:spPr>
+              <a:xfrm>
+                <a:off x="8638501" y="1309133"/>
+                <a:ext cx="247895" cy="419100"/>
+              </a:xfrm>
+              <a:prstGeom prst="rtTriangle">
+                <a:avLst/>
+              </a:prstGeom>
+            </p:spPr>
+            <p:style>
+              <a:lnRef idx="2">
+                <a:schemeClr val="dk1">
+                  <a:shade val="50000"/>
+                </a:schemeClr>
+              </a:lnRef>
+              <a:fillRef idx="1">
+                <a:schemeClr val="dk1"/>
+              </a:fillRef>
+              <a:effectRef idx="0">
+                <a:schemeClr val="dk1"/>
+              </a:effectRef>
+              <a:fontRef idx="minor">
+                <a:schemeClr val="lt1"/>
+              </a:fontRef>
+            </p:style>
+            <p:txBody>
+              <a:bodyPr rtlCol="0" anchor="ctr"/>
+              <a:lstStyle/>
+              <a:p>
+                <a:pPr algn="ctr"/>
+                <a:endParaRPr lang="en-US"/>
+              </a:p>
+            </p:txBody>
+          </p:sp>
+          <p:sp>
+            <p:nvSpPr>
+              <p:cNvPr id="209" name="Right Triangle 208">
+                <a:extLst>
+                  <a:ext uri="{FF2B5EF4-FFF2-40B4-BE49-F238E27FC236}">
+                    <a16:creationId xmlns:a16="http://schemas.microsoft.com/office/drawing/2014/main" id="{BC919DB5-44F7-5148-B21C-F9764F51AED5}"/>
+                  </a:ext>
+                </a:extLst>
+              </p:cNvPr>
+              <p:cNvSpPr/>
+              <p:nvPr/>
+            </p:nvSpPr>
+            <p:spPr>
+              <a:xfrm>
+                <a:off x="8638501" y="2202347"/>
+                <a:ext cx="349802" cy="557322"/>
+              </a:xfrm>
+              <a:prstGeom prst="rtTriangle">
+                <a:avLst/>
+              </a:prstGeom>
+            </p:spPr>
+            <p:style>
+              <a:lnRef idx="2">
+                <a:schemeClr val="dk1">
+                  <a:shade val="50000"/>
+                </a:schemeClr>
+              </a:lnRef>
+              <a:fillRef idx="1">
+                <a:schemeClr val="dk1"/>
+              </a:fillRef>
+              <a:effectRef idx="0">
+                <a:schemeClr val="dk1"/>
+              </a:effectRef>
+              <a:fontRef idx="minor">
+                <a:schemeClr val="lt1"/>
+              </a:fontRef>
+            </p:style>
+            <p:txBody>
+              <a:bodyPr rtlCol="0" anchor="ctr"/>
+              <a:lstStyle/>
+              <a:p>
+                <a:pPr algn="ctr"/>
+                <a:endParaRPr lang="en-US"/>
+              </a:p>
+            </p:txBody>
+          </p:sp>
+          <p:sp>
+            <p:nvSpPr>
+              <p:cNvPr id="210" name="Right Triangle 209">
+                <a:extLst>
+                  <a:ext uri="{FF2B5EF4-FFF2-40B4-BE49-F238E27FC236}">
+                    <a16:creationId xmlns:a16="http://schemas.microsoft.com/office/drawing/2014/main" id="{E4B56F33-AC59-B4AB-0C8D-696AFD82762F}"/>
+                  </a:ext>
+                </a:extLst>
+              </p:cNvPr>
+              <p:cNvSpPr/>
+              <p:nvPr/>
+            </p:nvSpPr>
+            <p:spPr>
+              <a:xfrm flipH="1">
+                <a:off x="7747717" y="1287886"/>
+                <a:ext cx="247895" cy="419100"/>
+              </a:xfrm>
+              <a:prstGeom prst="rtTriangle">
+                <a:avLst/>
+              </a:prstGeom>
+            </p:spPr>
+            <p:style>
+              <a:lnRef idx="2">
+                <a:schemeClr val="dk1">
+                  <a:shade val="50000"/>
+                </a:schemeClr>
+              </a:lnRef>
+              <a:fillRef idx="1">
+                <a:schemeClr val="dk1"/>
+              </a:fillRef>
+              <a:effectRef idx="0">
+                <a:schemeClr val="dk1"/>
+              </a:effectRef>
+              <a:fontRef idx="minor">
+                <a:schemeClr val="lt1"/>
+              </a:fontRef>
+            </p:style>
+            <p:txBody>
+              <a:bodyPr rtlCol="0" anchor="ctr"/>
+              <a:lstStyle/>
+              <a:p>
+                <a:pPr algn="ctr"/>
+                <a:endParaRPr lang="en-US"/>
+              </a:p>
+            </p:txBody>
+          </p:sp>
+          <p:sp>
+            <p:nvSpPr>
+              <p:cNvPr id="211" name="Right Triangle 210">
+                <a:extLst>
+                  <a:ext uri="{FF2B5EF4-FFF2-40B4-BE49-F238E27FC236}">
+                    <a16:creationId xmlns:a16="http://schemas.microsoft.com/office/drawing/2014/main" id="{F240BE8C-47CF-F48A-622F-E78795C08A3B}"/>
+                  </a:ext>
+                </a:extLst>
+              </p:cNvPr>
+              <p:cNvSpPr/>
+              <p:nvPr/>
+            </p:nvSpPr>
+            <p:spPr>
+              <a:xfrm flipH="1">
+                <a:off x="7639767" y="2181100"/>
+                <a:ext cx="349802" cy="557322"/>
+              </a:xfrm>
+              <a:prstGeom prst="rtTriangle">
+                <a:avLst/>
+              </a:prstGeom>
+            </p:spPr>
+            <p:style>
+              <a:lnRef idx="2">
+                <a:schemeClr val="dk1">
+                  <a:shade val="50000"/>
+                </a:schemeClr>
+              </a:lnRef>
+              <a:fillRef idx="1">
+                <a:schemeClr val="dk1"/>
+              </a:fillRef>
+              <a:effectRef idx="0">
+                <a:schemeClr val="dk1"/>
+              </a:effectRef>
+              <a:fontRef idx="minor">
+                <a:schemeClr val="lt1"/>
+              </a:fontRef>
+            </p:style>
+            <p:txBody>
+              <a:bodyPr rtlCol="0" anchor="ctr"/>
+              <a:lstStyle/>
+              <a:p>
+                <a:pPr algn="ctr"/>
+                <a:endParaRPr lang="en-US"/>
+              </a:p>
+            </p:txBody>
+          </p:sp>
+        </p:grpSp>
       </p:grpSp>
     </p:spTree>
     <p:extLst>
@@ -34113,750 +36912,6 @@
             </p:txBody>
           </p:sp>
         </p:grpSp>
-      </p:grpSp>
-      <p:grpSp>
-        <p:nvGrpSpPr>
-          <p:cNvPr id="14" name="Group 13">
-            <a:extLst>
-              <a:ext uri="{FF2B5EF4-FFF2-40B4-BE49-F238E27FC236}">
-                <a16:creationId xmlns:a16="http://schemas.microsoft.com/office/drawing/2014/main" id="{A565361B-D1B3-E892-B8A5-A85F03C76292}"/>
-              </a:ext>
-            </a:extLst>
-          </p:cNvPr>
-          <p:cNvGrpSpPr/>
-          <p:nvPr/>
-        </p:nvGrpSpPr>
-        <p:grpSpPr>
-          <a:xfrm>
-            <a:off x="5410200" y="221426"/>
-            <a:ext cx="1371600" cy="1371600"/>
-            <a:chOff x="1298501" y="962272"/>
-            <a:chExt cx="1371600" cy="1371600"/>
-          </a:xfrm>
-        </p:grpSpPr>
-        <p:sp>
-          <p:nvSpPr>
-            <p:cNvPr id="30" name="Rectangle 29">
-              <a:extLst>
-                <a:ext uri="{FF2B5EF4-FFF2-40B4-BE49-F238E27FC236}">
-                  <a16:creationId xmlns:a16="http://schemas.microsoft.com/office/drawing/2014/main" id="{85DC672F-078E-86F7-6992-3E3835492468}"/>
-                </a:ext>
-              </a:extLst>
-            </p:cNvPr>
-            <p:cNvSpPr/>
-            <p:nvPr/>
-          </p:nvSpPr>
-          <p:spPr>
-            <a:xfrm>
-              <a:off x="1298501" y="962272"/>
-              <a:ext cx="1371600" cy="1371600"/>
-            </a:xfrm>
-            <a:prstGeom prst="rect">
-              <a:avLst/>
-            </a:prstGeom>
-            <a:noFill/>
-            <a:ln w="76200">
-              <a:solidFill>
-                <a:schemeClr val="tx1"/>
-              </a:solidFill>
-            </a:ln>
-          </p:spPr>
-          <p:style>
-            <a:lnRef idx="2">
-              <a:schemeClr val="accent1">
-                <a:shade val="50000"/>
-              </a:schemeClr>
-            </a:lnRef>
-            <a:fillRef idx="1">
-              <a:schemeClr val="accent1"/>
-            </a:fillRef>
-            <a:effectRef idx="0">
-              <a:schemeClr val="accent1"/>
-            </a:effectRef>
-            <a:fontRef idx="minor">
-              <a:schemeClr val="lt1"/>
-            </a:fontRef>
-          </p:style>
-          <p:txBody>
-            <a:bodyPr rtlCol="0" anchor="ctr"/>
-            <a:lstStyle/>
-            <a:p>
-              <a:pPr algn="ctr"/>
-              <a:endParaRPr lang="en-US"/>
-            </a:p>
-          </p:txBody>
-        </p:sp>
-        <p:sp>
-          <p:nvSpPr>
-            <p:cNvPr id="34" name="Arrow: Pentagon 33">
-              <a:extLst>
-                <a:ext uri="{FF2B5EF4-FFF2-40B4-BE49-F238E27FC236}">
-                  <a16:creationId xmlns:a16="http://schemas.microsoft.com/office/drawing/2014/main" id="{922F7BD9-14B2-69A7-7E42-82ADB159EC59}"/>
-                </a:ext>
-              </a:extLst>
-            </p:cNvPr>
-            <p:cNvSpPr/>
-            <p:nvPr/>
-          </p:nvSpPr>
-          <p:spPr>
-            <a:xfrm rot="5400000">
-              <a:off x="1435661" y="1173775"/>
-              <a:ext cx="1097280" cy="1097280"/>
-            </a:xfrm>
-            <a:prstGeom prst="homePlate">
-              <a:avLst/>
-            </a:prstGeom>
-            <a:noFill/>
-            <a:ln w="38100" cap="flat" cmpd="sng" algn="ctr">
-              <a:solidFill>
-                <a:schemeClr val="dk1"/>
-              </a:solidFill>
-              <a:prstDash val="solid"/>
-              <a:round/>
-              <a:headEnd type="none" w="med" len="med"/>
-              <a:tailEnd type="none" w="med" len="med"/>
-            </a:ln>
-          </p:spPr>
-          <p:style>
-            <a:lnRef idx="0">
-              <a:scrgbClr r="0" g="0" b="0"/>
-            </a:lnRef>
-            <a:fillRef idx="0">
-              <a:scrgbClr r="0" g="0" b="0"/>
-            </a:fillRef>
-            <a:effectRef idx="0">
-              <a:scrgbClr r="0" g="0" b="0"/>
-            </a:effectRef>
-            <a:fontRef idx="minor">
-              <a:schemeClr val="dk1"/>
-            </a:fontRef>
-          </p:style>
-          <p:txBody>
-            <a:bodyPr rtlCol="0" anchor="ctr"/>
-            <a:lstStyle/>
-            <a:p>
-              <a:pPr algn="ctr"/>
-              <a:endParaRPr lang="en-US"/>
-            </a:p>
-          </p:txBody>
-        </p:sp>
-      </p:grpSp>
-      <p:grpSp>
-        <p:nvGrpSpPr>
-          <p:cNvPr id="66" name="Group 65">
-            <a:extLst>
-              <a:ext uri="{FF2B5EF4-FFF2-40B4-BE49-F238E27FC236}">
-                <a16:creationId xmlns:a16="http://schemas.microsoft.com/office/drawing/2014/main" id="{190F21FA-0FD6-7EA8-A718-ADDF7B488C35}"/>
-              </a:ext>
-            </a:extLst>
-          </p:cNvPr>
-          <p:cNvGrpSpPr/>
-          <p:nvPr/>
-        </p:nvGrpSpPr>
-        <p:grpSpPr>
-          <a:xfrm>
-            <a:off x="5683529" y="473007"/>
-            <a:ext cx="824942" cy="550241"/>
-            <a:chOff x="2788414" y="3003550"/>
-            <a:chExt cx="2665648" cy="1778000"/>
-          </a:xfrm>
-        </p:grpSpPr>
-        <p:sp>
-          <p:nvSpPr>
-            <p:cNvPr id="36" name="Oval 35">
-              <a:extLst>
-                <a:ext uri="{FF2B5EF4-FFF2-40B4-BE49-F238E27FC236}">
-                  <a16:creationId xmlns:a16="http://schemas.microsoft.com/office/drawing/2014/main" id="{AC2BCBBD-A6B2-5611-903A-3FB0AE560434}"/>
-                </a:ext>
-              </a:extLst>
-            </p:cNvPr>
-            <p:cNvSpPr/>
-            <p:nvPr/>
-          </p:nvSpPr>
-          <p:spPr>
-            <a:xfrm>
-              <a:off x="3903803" y="3003550"/>
-              <a:ext cx="439245" cy="1778000"/>
-            </a:xfrm>
-            <a:prstGeom prst="ellipse">
-              <a:avLst/>
-            </a:prstGeom>
-          </p:spPr>
-          <p:style>
-            <a:lnRef idx="2">
-              <a:schemeClr val="dk1">
-                <a:shade val="50000"/>
-              </a:schemeClr>
-            </a:lnRef>
-            <a:fillRef idx="1">
-              <a:schemeClr val="dk1"/>
-            </a:fillRef>
-            <a:effectRef idx="0">
-              <a:schemeClr val="dk1"/>
-            </a:effectRef>
-            <a:fontRef idx="minor">
-              <a:schemeClr val="lt1"/>
-            </a:fontRef>
-          </p:style>
-          <p:txBody>
-            <a:bodyPr rtlCol="0" anchor="ctr"/>
-            <a:lstStyle/>
-            <a:p>
-              <a:pPr algn="ctr"/>
-              <a:endParaRPr lang="en-US"/>
-            </a:p>
-          </p:txBody>
-        </p:sp>
-        <p:sp>
-          <p:nvSpPr>
-            <p:cNvPr id="38" name="Isosceles Triangle 37">
-              <a:extLst>
-                <a:ext uri="{FF2B5EF4-FFF2-40B4-BE49-F238E27FC236}">
-                  <a16:creationId xmlns:a16="http://schemas.microsoft.com/office/drawing/2014/main" id="{185CD5BD-54AA-2E6E-5A64-BE9D833FEF31}"/>
-                </a:ext>
-              </a:extLst>
-            </p:cNvPr>
-            <p:cNvSpPr/>
-            <p:nvPr/>
-          </p:nvSpPr>
-          <p:spPr>
-            <a:xfrm>
-              <a:off x="2788414" y="3612890"/>
-              <a:ext cx="2665648" cy="1168660"/>
-            </a:xfrm>
-            <a:prstGeom prst="triangle">
-              <a:avLst/>
-            </a:prstGeom>
-          </p:spPr>
-          <p:style>
-            <a:lnRef idx="2">
-              <a:schemeClr val="dk1">
-                <a:shade val="50000"/>
-              </a:schemeClr>
-            </a:lnRef>
-            <a:fillRef idx="1">
-              <a:schemeClr val="dk1"/>
-            </a:fillRef>
-            <a:effectRef idx="0">
-              <a:schemeClr val="dk1"/>
-            </a:effectRef>
-            <a:fontRef idx="minor">
-              <a:schemeClr val="lt1"/>
-            </a:fontRef>
-          </p:style>
-          <p:txBody>
-            <a:bodyPr rtlCol="0" anchor="ctr"/>
-            <a:lstStyle/>
-            <a:p>
-              <a:pPr algn="ctr"/>
-              <a:endParaRPr lang="en-US"/>
-            </a:p>
-          </p:txBody>
-        </p:sp>
-        <p:sp>
-          <p:nvSpPr>
-            <p:cNvPr id="53" name="Oval 52">
-              <a:extLst>
-                <a:ext uri="{FF2B5EF4-FFF2-40B4-BE49-F238E27FC236}">
-                  <a16:creationId xmlns:a16="http://schemas.microsoft.com/office/drawing/2014/main" id="{9DF49ED0-E56C-2F63-DA42-7D534C286B42}"/>
-                </a:ext>
-              </a:extLst>
-            </p:cNvPr>
-            <p:cNvSpPr/>
-            <p:nvPr/>
-          </p:nvSpPr>
-          <p:spPr>
-            <a:xfrm>
-              <a:off x="3346707" y="4263156"/>
-              <a:ext cx="458369" cy="458369"/>
-            </a:xfrm>
-            <a:prstGeom prst="ellipse">
-              <a:avLst/>
-            </a:prstGeom>
-          </p:spPr>
-          <p:style>
-            <a:lnRef idx="2">
-              <a:schemeClr val="dk1"/>
-            </a:lnRef>
-            <a:fillRef idx="1">
-              <a:schemeClr val="lt1"/>
-            </a:fillRef>
-            <a:effectRef idx="0">
-              <a:schemeClr val="dk1"/>
-            </a:effectRef>
-            <a:fontRef idx="minor">
-              <a:schemeClr val="dk1"/>
-            </a:fontRef>
-          </p:style>
-          <p:txBody>
-            <a:bodyPr rtlCol="0" anchor="ctr"/>
-            <a:lstStyle/>
-            <a:p>
-              <a:pPr algn="ctr"/>
-              <a:endParaRPr lang="en-US"/>
-            </a:p>
-          </p:txBody>
-        </p:sp>
-        <p:sp>
-          <p:nvSpPr>
-            <p:cNvPr id="54" name="Oval 53">
-              <a:extLst>
-                <a:ext uri="{FF2B5EF4-FFF2-40B4-BE49-F238E27FC236}">
-                  <a16:creationId xmlns:a16="http://schemas.microsoft.com/office/drawing/2014/main" id="{46F060C6-AD38-DA21-F39D-93FB72E0EE81}"/>
-                </a:ext>
-              </a:extLst>
-            </p:cNvPr>
-            <p:cNvSpPr/>
-            <p:nvPr/>
-          </p:nvSpPr>
-          <p:spPr>
-            <a:xfrm>
-              <a:off x="4436723" y="4263156"/>
-              <a:ext cx="458369" cy="458369"/>
-            </a:xfrm>
-            <a:prstGeom prst="ellipse">
-              <a:avLst/>
-            </a:prstGeom>
-          </p:spPr>
-          <p:style>
-            <a:lnRef idx="2">
-              <a:schemeClr val="dk1"/>
-            </a:lnRef>
-            <a:fillRef idx="1">
-              <a:schemeClr val="lt1"/>
-            </a:fillRef>
-            <a:effectRef idx="0">
-              <a:schemeClr val="dk1"/>
-            </a:effectRef>
-            <a:fontRef idx="minor">
-              <a:schemeClr val="dk1"/>
-            </a:fontRef>
-          </p:style>
-          <p:txBody>
-            <a:bodyPr rtlCol="0" anchor="ctr"/>
-            <a:lstStyle/>
-            <a:p>
-              <a:pPr algn="ctr"/>
-              <a:endParaRPr lang="en-US"/>
-            </a:p>
-          </p:txBody>
-        </p:sp>
-      </p:grpSp>
-      <p:grpSp>
-        <p:nvGrpSpPr>
-          <p:cNvPr id="65" name="Group 64">
-            <a:extLst>
-              <a:ext uri="{FF2B5EF4-FFF2-40B4-BE49-F238E27FC236}">
-                <a16:creationId xmlns:a16="http://schemas.microsoft.com/office/drawing/2014/main" id="{1D60BB50-A86F-6A8C-9E06-CC7CAD599DA7}"/>
-              </a:ext>
-            </a:extLst>
-          </p:cNvPr>
-          <p:cNvGrpSpPr/>
-          <p:nvPr/>
-        </p:nvGrpSpPr>
-        <p:grpSpPr>
-          <a:xfrm>
-            <a:off x="7253835" y="514121"/>
-            <a:ext cx="770328" cy="575178"/>
-            <a:chOff x="7066650" y="3003550"/>
-            <a:chExt cx="2381250" cy="1778000"/>
-          </a:xfrm>
-        </p:grpSpPr>
-        <p:sp>
-          <p:nvSpPr>
-            <p:cNvPr id="62" name="Rectangle 61">
-              <a:extLst>
-                <a:ext uri="{FF2B5EF4-FFF2-40B4-BE49-F238E27FC236}">
-                  <a16:creationId xmlns:a16="http://schemas.microsoft.com/office/drawing/2014/main" id="{57B154D4-ED69-F1D3-9B28-42BE1780598C}"/>
-                </a:ext>
-              </a:extLst>
-            </p:cNvPr>
-            <p:cNvSpPr/>
-            <p:nvPr/>
-          </p:nvSpPr>
-          <p:spPr>
-            <a:xfrm>
-              <a:off x="7066650" y="3429000"/>
-              <a:ext cx="2381250" cy="1352550"/>
-            </a:xfrm>
-            <a:prstGeom prst="rect">
-              <a:avLst/>
-            </a:prstGeom>
-          </p:spPr>
-          <p:style>
-            <a:lnRef idx="2">
-              <a:schemeClr val="dk1">
-                <a:shade val="50000"/>
-              </a:schemeClr>
-            </a:lnRef>
-            <a:fillRef idx="1">
-              <a:schemeClr val="dk1"/>
-            </a:fillRef>
-            <a:effectRef idx="0">
-              <a:schemeClr val="dk1"/>
-            </a:effectRef>
-            <a:fontRef idx="minor">
-              <a:schemeClr val="lt1"/>
-            </a:fontRef>
-          </p:style>
-          <p:txBody>
-            <a:bodyPr rtlCol="0" anchor="ctr"/>
-            <a:lstStyle/>
-            <a:p>
-              <a:pPr algn="ctr"/>
-              <a:endParaRPr lang="en-US"/>
-            </a:p>
-          </p:txBody>
-        </p:sp>
-        <p:sp>
-          <p:nvSpPr>
-            <p:cNvPr id="57" name="Oval 56">
-              <a:extLst>
-                <a:ext uri="{FF2B5EF4-FFF2-40B4-BE49-F238E27FC236}">
-                  <a16:creationId xmlns:a16="http://schemas.microsoft.com/office/drawing/2014/main" id="{60E26D81-2B4E-3E99-6951-414CC2576DFE}"/>
-                </a:ext>
-              </a:extLst>
-            </p:cNvPr>
-            <p:cNvSpPr/>
-            <p:nvPr/>
-          </p:nvSpPr>
-          <p:spPr>
-            <a:xfrm>
-              <a:off x="8037653" y="3003550"/>
-              <a:ext cx="439245" cy="1778000"/>
-            </a:xfrm>
-            <a:prstGeom prst="ellipse">
-              <a:avLst/>
-            </a:prstGeom>
-          </p:spPr>
-          <p:style>
-            <a:lnRef idx="2">
-              <a:schemeClr val="dk1">
-                <a:shade val="50000"/>
-              </a:schemeClr>
-            </a:lnRef>
-            <a:fillRef idx="1">
-              <a:schemeClr val="dk1"/>
-            </a:fillRef>
-            <a:effectRef idx="0">
-              <a:schemeClr val="dk1"/>
-            </a:effectRef>
-            <a:fontRef idx="minor">
-              <a:schemeClr val="lt1"/>
-            </a:fontRef>
-          </p:style>
-          <p:txBody>
-            <a:bodyPr rtlCol="0" anchor="ctr"/>
-            <a:lstStyle/>
-            <a:p>
-              <a:pPr algn="ctr"/>
-              <a:endParaRPr lang="en-US"/>
-            </a:p>
-          </p:txBody>
-        </p:sp>
-        <p:sp>
-          <p:nvSpPr>
-            <p:cNvPr id="58" name="Oval 57">
-              <a:extLst>
-                <a:ext uri="{FF2B5EF4-FFF2-40B4-BE49-F238E27FC236}">
-                  <a16:creationId xmlns:a16="http://schemas.microsoft.com/office/drawing/2014/main" id="{1EAAD573-AE7F-038C-AA6A-C4FC18589CFC}"/>
-                </a:ext>
-              </a:extLst>
-            </p:cNvPr>
-            <p:cNvSpPr/>
-            <p:nvPr/>
-          </p:nvSpPr>
-          <p:spPr>
-            <a:xfrm>
-              <a:off x="7480557" y="3512687"/>
-              <a:ext cx="458369" cy="458369"/>
-            </a:xfrm>
-            <a:prstGeom prst="ellipse">
-              <a:avLst/>
-            </a:prstGeom>
-          </p:spPr>
-          <p:style>
-            <a:lnRef idx="2">
-              <a:schemeClr val="dk1"/>
-            </a:lnRef>
-            <a:fillRef idx="1">
-              <a:schemeClr val="lt1"/>
-            </a:fillRef>
-            <a:effectRef idx="0">
-              <a:schemeClr val="dk1"/>
-            </a:effectRef>
-            <a:fontRef idx="minor">
-              <a:schemeClr val="dk1"/>
-            </a:fontRef>
-          </p:style>
-          <p:txBody>
-            <a:bodyPr rtlCol="0" anchor="ctr"/>
-            <a:lstStyle/>
-            <a:p>
-              <a:pPr algn="ctr"/>
-              <a:endParaRPr lang="en-US"/>
-            </a:p>
-          </p:txBody>
-        </p:sp>
-        <p:sp>
-          <p:nvSpPr>
-            <p:cNvPr id="61" name="Oval 60">
-              <a:extLst>
-                <a:ext uri="{FF2B5EF4-FFF2-40B4-BE49-F238E27FC236}">
-                  <a16:creationId xmlns:a16="http://schemas.microsoft.com/office/drawing/2014/main" id="{19E40176-D9B8-40ED-2980-6BE673F2ADB0}"/>
-                </a:ext>
-              </a:extLst>
-            </p:cNvPr>
-            <p:cNvSpPr/>
-            <p:nvPr/>
-          </p:nvSpPr>
-          <p:spPr>
-            <a:xfrm>
-              <a:off x="8570573" y="3512687"/>
-              <a:ext cx="458369" cy="458369"/>
-            </a:xfrm>
-            <a:prstGeom prst="ellipse">
-              <a:avLst/>
-            </a:prstGeom>
-          </p:spPr>
-          <p:style>
-            <a:lnRef idx="2">
-              <a:schemeClr val="dk1"/>
-            </a:lnRef>
-            <a:fillRef idx="1">
-              <a:schemeClr val="lt1"/>
-            </a:fillRef>
-            <a:effectRef idx="0">
-              <a:schemeClr val="dk1"/>
-            </a:effectRef>
-            <a:fontRef idx="minor">
-              <a:schemeClr val="dk1"/>
-            </a:fontRef>
-          </p:style>
-          <p:txBody>
-            <a:bodyPr rtlCol="0" anchor="ctr"/>
-            <a:lstStyle/>
-            <a:p>
-              <a:pPr algn="ctr"/>
-              <a:endParaRPr lang="en-US"/>
-            </a:p>
-          </p:txBody>
-        </p:sp>
-        <p:sp>
-          <p:nvSpPr>
-            <p:cNvPr id="63" name="Oval 62">
-              <a:extLst>
-                <a:ext uri="{FF2B5EF4-FFF2-40B4-BE49-F238E27FC236}">
-                  <a16:creationId xmlns:a16="http://schemas.microsoft.com/office/drawing/2014/main" id="{5CE3E423-54A6-774B-CF2F-AEFB806F52F3}"/>
-                </a:ext>
-              </a:extLst>
-            </p:cNvPr>
-            <p:cNvSpPr/>
-            <p:nvPr/>
-          </p:nvSpPr>
-          <p:spPr>
-            <a:xfrm>
-              <a:off x="7480557" y="4167321"/>
-              <a:ext cx="458369" cy="458369"/>
-            </a:xfrm>
-            <a:prstGeom prst="ellipse">
-              <a:avLst/>
-            </a:prstGeom>
-          </p:spPr>
-          <p:style>
-            <a:lnRef idx="2">
-              <a:schemeClr val="dk1"/>
-            </a:lnRef>
-            <a:fillRef idx="1">
-              <a:schemeClr val="lt1"/>
-            </a:fillRef>
-            <a:effectRef idx="0">
-              <a:schemeClr val="dk1"/>
-            </a:effectRef>
-            <a:fontRef idx="minor">
-              <a:schemeClr val="dk1"/>
-            </a:fontRef>
-          </p:style>
-          <p:txBody>
-            <a:bodyPr rtlCol="0" anchor="ctr"/>
-            <a:lstStyle/>
-            <a:p>
-              <a:pPr algn="ctr"/>
-              <a:endParaRPr lang="en-US"/>
-            </a:p>
-          </p:txBody>
-        </p:sp>
-        <p:sp>
-          <p:nvSpPr>
-            <p:cNvPr id="64" name="Oval 63">
-              <a:extLst>
-                <a:ext uri="{FF2B5EF4-FFF2-40B4-BE49-F238E27FC236}">
-                  <a16:creationId xmlns:a16="http://schemas.microsoft.com/office/drawing/2014/main" id="{6D30A8C5-61B7-B967-A1E5-AD845CD0AAC8}"/>
-                </a:ext>
-              </a:extLst>
-            </p:cNvPr>
-            <p:cNvSpPr/>
-            <p:nvPr/>
-          </p:nvSpPr>
-          <p:spPr>
-            <a:xfrm>
-              <a:off x="8570573" y="4167321"/>
-              <a:ext cx="458369" cy="458369"/>
-            </a:xfrm>
-            <a:prstGeom prst="ellipse">
-              <a:avLst/>
-            </a:prstGeom>
-          </p:spPr>
-          <p:style>
-            <a:lnRef idx="2">
-              <a:schemeClr val="dk1"/>
-            </a:lnRef>
-            <a:fillRef idx="1">
-              <a:schemeClr val="lt1"/>
-            </a:fillRef>
-            <a:effectRef idx="0">
-              <a:schemeClr val="dk1"/>
-            </a:effectRef>
-            <a:fontRef idx="minor">
-              <a:schemeClr val="dk1"/>
-            </a:fontRef>
-          </p:style>
-          <p:txBody>
-            <a:bodyPr rtlCol="0" anchor="ctr"/>
-            <a:lstStyle/>
-            <a:p>
-              <a:pPr algn="ctr"/>
-              <a:endParaRPr lang="en-US"/>
-            </a:p>
-          </p:txBody>
-        </p:sp>
-      </p:grpSp>
-      <p:grpSp>
-        <p:nvGrpSpPr>
-          <p:cNvPr id="67" name="Group 66">
-            <a:extLst>
-              <a:ext uri="{FF2B5EF4-FFF2-40B4-BE49-F238E27FC236}">
-                <a16:creationId xmlns:a16="http://schemas.microsoft.com/office/drawing/2014/main" id="{482DF19A-4B0D-8758-DC4E-573890DEF054}"/>
-              </a:ext>
-            </a:extLst>
-          </p:cNvPr>
-          <p:cNvGrpSpPr/>
-          <p:nvPr/>
-        </p:nvGrpSpPr>
-        <p:grpSpPr>
-          <a:xfrm>
-            <a:off x="6954576" y="230762"/>
-            <a:ext cx="1371600" cy="1371600"/>
-            <a:chOff x="1298501" y="962272"/>
-            <a:chExt cx="1371600" cy="1371600"/>
-          </a:xfrm>
-        </p:grpSpPr>
-        <p:sp>
-          <p:nvSpPr>
-            <p:cNvPr id="72" name="Rectangle 71">
-              <a:extLst>
-                <a:ext uri="{FF2B5EF4-FFF2-40B4-BE49-F238E27FC236}">
-                  <a16:creationId xmlns:a16="http://schemas.microsoft.com/office/drawing/2014/main" id="{75391A79-2257-A007-CDA1-3BD2DAA828FE}"/>
-                </a:ext>
-              </a:extLst>
-            </p:cNvPr>
-            <p:cNvSpPr/>
-            <p:nvPr/>
-          </p:nvSpPr>
-          <p:spPr>
-            <a:xfrm>
-              <a:off x="1298501" y="962272"/>
-              <a:ext cx="1371600" cy="1371600"/>
-            </a:xfrm>
-            <a:prstGeom prst="rect">
-              <a:avLst/>
-            </a:prstGeom>
-            <a:noFill/>
-            <a:ln w="76200">
-              <a:solidFill>
-                <a:schemeClr val="tx1"/>
-              </a:solidFill>
-            </a:ln>
-          </p:spPr>
-          <p:style>
-            <a:lnRef idx="2">
-              <a:schemeClr val="accent1">
-                <a:shade val="50000"/>
-              </a:schemeClr>
-            </a:lnRef>
-            <a:fillRef idx="1">
-              <a:schemeClr val="accent1"/>
-            </a:fillRef>
-            <a:effectRef idx="0">
-              <a:schemeClr val="accent1"/>
-            </a:effectRef>
-            <a:fontRef idx="minor">
-              <a:schemeClr val="lt1"/>
-            </a:fontRef>
-          </p:style>
-          <p:txBody>
-            <a:bodyPr rtlCol="0" anchor="ctr"/>
-            <a:lstStyle/>
-            <a:p>
-              <a:pPr algn="ctr"/>
-              <a:endParaRPr lang="en-US"/>
-            </a:p>
-          </p:txBody>
-        </p:sp>
-        <p:sp>
-          <p:nvSpPr>
-            <p:cNvPr id="77" name="Arrow: Pentagon 76">
-              <a:extLst>
-                <a:ext uri="{FF2B5EF4-FFF2-40B4-BE49-F238E27FC236}">
-                  <a16:creationId xmlns:a16="http://schemas.microsoft.com/office/drawing/2014/main" id="{46094833-5784-28D6-A952-8CD6B5F92095}"/>
-                </a:ext>
-              </a:extLst>
-            </p:cNvPr>
-            <p:cNvSpPr/>
-            <p:nvPr/>
-          </p:nvSpPr>
-          <p:spPr>
-            <a:xfrm rot="5400000">
-              <a:off x="1435661" y="1173775"/>
-              <a:ext cx="1097280" cy="1097280"/>
-            </a:xfrm>
-            <a:prstGeom prst="homePlate">
-              <a:avLst/>
-            </a:prstGeom>
-            <a:noFill/>
-            <a:ln w="38100" cap="flat" cmpd="sng" algn="ctr">
-              <a:solidFill>
-                <a:schemeClr val="dk1"/>
-              </a:solidFill>
-              <a:prstDash val="solid"/>
-              <a:round/>
-              <a:headEnd type="none" w="med" len="med"/>
-              <a:tailEnd type="none" w="med" len="med"/>
-            </a:ln>
-          </p:spPr>
-          <p:style>
-            <a:lnRef idx="0">
-              <a:scrgbClr r="0" g="0" b="0"/>
-            </a:lnRef>
-            <a:fillRef idx="0">
-              <a:scrgbClr r="0" g="0" b="0"/>
-            </a:fillRef>
-            <a:effectRef idx="0">
-              <a:scrgbClr r="0" g="0" b="0"/>
-            </a:effectRef>
-            <a:fontRef idx="minor">
-              <a:schemeClr val="dk1"/>
-            </a:fontRef>
-          </p:style>
-          <p:txBody>
-            <a:bodyPr rtlCol="0" anchor="ctr"/>
-            <a:lstStyle/>
-            <a:p>
-              <a:pPr algn="ctr"/>
-              <a:endParaRPr lang="en-US"/>
-            </a:p>
-          </p:txBody>
-        </p:sp>
       </p:grpSp>
     </p:spTree>
     <p:extLst>

</xml_diff>

<commit_message>
Add Caelumanians to para
</commit_message>
<xml_diff>
--- a/image process/drawings sifi.pptx
+++ b/image process/drawings sifi.pptx
@@ -36198,6 +36198,164 @@
       </p:grpSpPr>
       <p:grpSp>
         <p:nvGrpSpPr>
+          <p:cNvPr id="18" name="Group 17">
+            <a:extLst>
+              <a:ext uri="{FF2B5EF4-FFF2-40B4-BE49-F238E27FC236}">
+                <a16:creationId xmlns:a16="http://schemas.microsoft.com/office/drawing/2014/main" id="{CA4E8565-C494-2847-4139-CE7FBB29D620}"/>
+              </a:ext>
+            </a:extLst>
+          </p:cNvPr>
+          <p:cNvGrpSpPr/>
+          <p:nvPr/>
+        </p:nvGrpSpPr>
+        <p:grpSpPr>
+          <a:xfrm rot="2664439">
+            <a:off x="2104930" y="2492095"/>
+            <a:ext cx="1042110" cy="677639"/>
+            <a:chOff x="4562810" y="2584397"/>
+            <a:chExt cx="3211859" cy="2088532"/>
+          </a:xfrm>
+        </p:grpSpPr>
+        <p:pic>
+          <p:nvPicPr>
+            <p:cNvPr id="5" name="Picture 10" descr="Angel Wings Vector&quot; Images – Browse 68 Stock Photos, Vectors, and Video |  Adobe Stock">
+              <a:extLst>
+                <a:ext uri="{FF2B5EF4-FFF2-40B4-BE49-F238E27FC236}">
+                  <a16:creationId xmlns:a16="http://schemas.microsoft.com/office/drawing/2014/main" id="{8312E913-F35E-A847-B68F-D27771F355B3}"/>
+                </a:ext>
+              </a:extLst>
+            </p:cNvPr>
+            <p:cNvPicPr>
+              <a:picLocks noChangeAspect="1" noChangeArrowheads="1"/>
+            </p:cNvPicPr>
+            <p:nvPr/>
+          </p:nvPicPr>
+          <p:blipFill rotWithShape="1">
+            <a:blip r:embed="rId2">
+              <a:extLst>
+                <a:ext uri="{28A0092B-C50C-407E-A947-70E740481C1C}">
+                  <a14:useLocalDpi xmlns:a14="http://schemas.microsoft.com/office/drawing/2010/main" val="0"/>
+                </a:ext>
+              </a:extLst>
+            </a:blip>
+            <a:srcRect l="32998" t="50000" r="54564"/>
+            <a:stretch/>
+          </p:blipFill>
+          <p:spPr bwMode="auto">
+            <a:xfrm rot="8161281">
+              <a:off x="4562810" y="2584398"/>
+              <a:ext cx="794494" cy="1932450"/>
+            </a:xfrm>
+            <a:prstGeom prst="rect">
+              <a:avLst/>
+            </a:prstGeom>
+            <a:noFill/>
+            <a:extLst>
+              <a:ext uri="{909E8E84-426E-40DD-AFC4-6F175D3DCCD1}">
+                <a14:hiddenFill xmlns:a14="http://schemas.microsoft.com/office/drawing/2010/main">
+                  <a:solidFill>
+                    <a:srgbClr val="FFFFFF"/>
+                  </a:solidFill>
+                </a14:hiddenFill>
+              </a:ext>
+            </a:extLst>
+          </p:spPr>
+        </p:pic>
+        <p:pic>
+          <p:nvPicPr>
+            <p:cNvPr id="17" name="Picture 10" descr="Angel Wings Vector&quot; Images – Browse 68 Stock Photos, Vectors, and Video |  Adobe Stock">
+              <a:extLst>
+                <a:ext uri="{FF2B5EF4-FFF2-40B4-BE49-F238E27FC236}">
+                  <a16:creationId xmlns:a16="http://schemas.microsoft.com/office/drawing/2014/main" id="{B63343D1-F97C-6740-E20F-FEFC6577171D}"/>
+                </a:ext>
+              </a:extLst>
+            </p:cNvPr>
+            <p:cNvPicPr>
+              <a:picLocks noChangeAspect="1" noChangeArrowheads="1"/>
+            </p:cNvPicPr>
+            <p:nvPr/>
+          </p:nvPicPr>
+          <p:blipFill rotWithShape="1">
+            <a:blip r:embed="rId2">
+              <a:extLst>
+                <a:ext uri="{28A0092B-C50C-407E-A947-70E740481C1C}">
+                  <a14:useLocalDpi xmlns:a14="http://schemas.microsoft.com/office/drawing/2010/main" val="0"/>
+                </a:ext>
+              </a:extLst>
+            </a:blip>
+            <a:srcRect l="32998" t="50000" r="54564"/>
+            <a:stretch/>
+          </p:blipFill>
+          <p:spPr bwMode="auto">
+            <a:xfrm rot="13438719" flipH="1">
+              <a:off x="6980175" y="2584397"/>
+              <a:ext cx="794494" cy="1932450"/>
+            </a:xfrm>
+            <a:prstGeom prst="rect">
+              <a:avLst/>
+            </a:prstGeom>
+            <a:noFill/>
+            <a:extLst>
+              <a:ext uri="{909E8E84-426E-40DD-AFC4-6F175D3DCCD1}">
+                <a14:hiddenFill xmlns:a14="http://schemas.microsoft.com/office/drawing/2010/main">
+                  <a:solidFill>
+                    <a:srgbClr val="FFFFFF"/>
+                  </a:solidFill>
+                </a14:hiddenFill>
+              </a:ext>
+            </a:extLst>
+          </p:spPr>
+        </p:pic>
+        <p:pic>
+          <p:nvPicPr>
+            <p:cNvPr id="7" name="Picture 8" descr="Shield Badge With Outline - Badge Vector Png - 882x980 PNG Download - PNGkit">
+              <a:extLst>
+                <a:ext uri="{FF2B5EF4-FFF2-40B4-BE49-F238E27FC236}">
+                  <a16:creationId xmlns:a16="http://schemas.microsoft.com/office/drawing/2014/main" id="{718038E7-32B2-F487-0E83-9EEB5F9A029D}"/>
+                </a:ext>
+              </a:extLst>
+            </p:cNvPr>
+            <p:cNvPicPr>
+              <a:picLocks noChangeAspect="1" noChangeArrowheads="1"/>
+            </p:cNvPicPr>
+            <p:nvPr/>
+          </p:nvPicPr>
+          <p:blipFill>
+            <a:blip r:embed="rId3">
+              <a:extLst>
+                <a:ext uri="{28A0092B-C50C-407E-A947-70E740481C1C}">
+                  <a14:useLocalDpi xmlns:a14="http://schemas.microsoft.com/office/drawing/2010/main" val="0"/>
+                </a:ext>
+              </a:extLst>
+            </a:blip>
+            <a:srcRect/>
+            <a:stretch>
+              <a:fillRect/>
+            </a:stretch>
+          </p:blipFill>
+          <p:spPr bwMode="auto">
+            <a:xfrm>
+              <a:off x="5694170" y="3550624"/>
+              <a:ext cx="967728" cy="1122305"/>
+            </a:xfrm>
+            <a:prstGeom prst="rect">
+              <a:avLst/>
+            </a:prstGeom>
+            <a:noFill/>
+            <a:extLst>
+              <a:ext uri="{909E8E84-426E-40DD-AFC4-6F175D3DCCD1}">
+                <a14:hiddenFill xmlns:a14="http://schemas.microsoft.com/office/drawing/2010/main">
+                  <a:solidFill>
+                    <a:srgbClr val="FFFFFF"/>
+                  </a:solidFill>
+                </a14:hiddenFill>
+              </a:ext>
+            </a:extLst>
+          </p:spPr>
+        </p:pic>
+      </p:grpSp>
+      <p:grpSp>
+        <p:nvGrpSpPr>
           <p:cNvPr id="9" name="Group 8">
             <a:extLst>
               <a:ext uri="{FF2B5EF4-FFF2-40B4-BE49-F238E27FC236}">
@@ -36231,7 +36389,7 @@
             <p:nvPr/>
           </p:nvPicPr>
           <p:blipFill>
-            <a:blip r:embed="rId2">
+            <a:blip r:embed="rId4">
               <a:extLst>
                 <a:ext uri="{28A0092B-C50C-407E-A947-70E740481C1C}">
                   <a14:useLocalDpi xmlns:a14="http://schemas.microsoft.com/office/drawing/2010/main" val="0"/>
@@ -36278,7 +36436,7 @@
             <p:nvPr/>
           </p:nvPicPr>
           <p:blipFill>
-            <a:blip r:embed="rId3"/>
+            <a:blip r:embed="rId5"/>
             <a:stretch>
               <a:fillRect/>
             </a:stretch>
@@ -37037,7 +37195,7 @@
             <p:nvPr/>
           </p:nvPicPr>
           <p:blipFill>
-            <a:blip r:embed="rId4"/>
+            <a:blip r:embed="rId6"/>
             <a:stretch>
               <a:fillRect/>
             </a:stretch>
@@ -37576,7 +37734,7 @@
               <p:nvPr/>
             </p:nvPicPr>
             <p:blipFill>
-              <a:blip r:embed="rId5">
+              <a:blip r:embed="rId7">
                 <a:extLst>
                   <a:ext uri="{28A0092B-C50C-407E-A947-70E740481C1C}">
                     <a14:useLocalDpi xmlns:a14="http://schemas.microsoft.com/office/drawing/2010/main" val="0"/>
@@ -37623,7 +37781,7 @@
               <p:nvPr/>
             </p:nvPicPr>
             <p:blipFill>
-              <a:blip r:embed="rId5">
+              <a:blip r:embed="rId7">
                 <a:extLst>
                   <a:ext uri="{28A0092B-C50C-407E-A947-70E740481C1C}">
                     <a14:useLocalDpi xmlns:a14="http://schemas.microsoft.com/office/drawing/2010/main" val="0"/>
@@ -37670,7 +37828,7 @@
               <p:nvPr/>
             </p:nvPicPr>
             <p:blipFill>
-              <a:blip r:embed="rId5">
+              <a:blip r:embed="rId7">
                 <a:extLst>
                   <a:ext uri="{28A0092B-C50C-407E-A947-70E740481C1C}">
                     <a14:useLocalDpi xmlns:a14="http://schemas.microsoft.com/office/drawing/2010/main" val="0"/>
@@ -37739,7 +37897,7 @@
             <p:nvPr/>
           </p:nvPicPr>
           <p:blipFill rotWithShape="1">
-            <a:blip r:embed="rId6">
+            <a:blip r:embed="rId8">
               <a:extLst>
                 <a:ext uri="{28A0092B-C50C-407E-A947-70E740481C1C}">
                   <a14:useLocalDpi xmlns:a14="http://schemas.microsoft.com/office/drawing/2010/main" val="0"/>
@@ -37911,7 +38069,7 @@
             <p:nvPr/>
           </p:nvPicPr>
           <p:blipFill rotWithShape="1">
-            <a:blip r:embed="rId7">
+            <a:blip r:embed="rId9">
               <a:extLst>
                 <a:ext uri="{28A0092B-C50C-407E-A947-70E740481C1C}">
                   <a14:useLocalDpi xmlns:a14="http://schemas.microsoft.com/office/drawing/2010/main" val="0"/>
@@ -37977,7 +38135,7 @@
             <p:nvPr/>
           </p:nvPicPr>
           <p:blipFill>
-            <a:blip r:embed="rId8"/>
+            <a:blip r:embed="rId10"/>
             <a:stretch>
               <a:fillRect/>
             </a:stretch>
@@ -38007,7 +38165,7 @@
             <p:nvPr/>
           </p:nvPicPr>
           <p:blipFill>
-            <a:blip r:embed="rId9"/>
+            <a:blip r:embed="rId11"/>
             <a:stretch>
               <a:fillRect/>
             </a:stretch>
@@ -38332,7 +38490,7 @@
               <p:nvPr/>
             </p:nvPicPr>
             <p:blipFill rotWithShape="1">
-              <a:blip r:embed="rId10">
+              <a:blip r:embed="rId2">
                 <a:extLst>
                   <a:ext uri="{28A0092B-C50C-407E-A947-70E740481C1C}">
                     <a14:useLocalDpi xmlns:a14="http://schemas.microsoft.com/office/drawing/2010/main" val="0"/>
@@ -38377,7 +38535,7 @@
               <p:nvPr/>
             </p:nvPicPr>
             <p:blipFill rotWithShape="1">
-              <a:blip r:embed="rId10">
+              <a:blip r:embed="rId2">
                 <a:extLst>
                   <a:ext uri="{28A0092B-C50C-407E-A947-70E740481C1C}">
                     <a14:useLocalDpi xmlns:a14="http://schemas.microsoft.com/office/drawing/2010/main" val="0"/>
@@ -38422,7 +38580,7 @@
               <p:nvPr/>
             </p:nvPicPr>
             <p:blipFill>
-              <a:blip r:embed="rId11">
+              <a:blip r:embed="rId3">
                 <a:extLst>
                   <a:ext uri="{28A0092B-C50C-407E-A947-70E740481C1C}">
                     <a14:useLocalDpi xmlns:a14="http://schemas.microsoft.com/office/drawing/2010/main" val="0"/>
@@ -38455,6 +38613,133 @@
             </p:spPr>
           </p:pic>
         </p:grpSp>
+      </p:grpSp>
+      <p:grpSp>
+        <p:nvGrpSpPr>
+          <p:cNvPr id="3" name="Group 2">
+            <a:extLst>
+              <a:ext uri="{FF2B5EF4-FFF2-40B4-BE49-F238E27FC236}">
+                <a16:creationId xmlns:a16="http://schemas.microsoft.com/office/drawing/2014/main" id="{54079B8B-1159-BB98-2A7B-847EEF95F4DD}"/>
+              </a:ext>
+            </a:extLst>
+          </p:cNvPr>
+          <p:cNvGrpSpPr/>
+          <p:nvPr/>
+        </p:nvGrpSpPr>
+        <p:grpSpPr>
+          <a:xfrm>
+            <a:off x="1998426" y="1957955"/>
+            <a:ext cx="1371600" cy="1371600"/>
+            <a:chOff x="427081" y="263129"/>
+            <a:chExt cx="1371600" cy="1371600"/>
+          </a:xfrm>
+        </p:grpSpPr>
+        <p:sp>
+          <p:nvSpPr>
+            <p:cNvPr id="8" name="Rectangle 7">
+              <a:extLst>
+                <a:ext uri="{FF2B5EF4-FFF2-40B4-BE49-F238E27FC236}">
+                  <a16:creationId xmlns:a16="http://schemas.microsoft.com/office/drawing/2014/main" id="{2BBFB801-2217-07C5-7B02-6D1DCFE2B612}"/>
+                </a:ext>
+              </a:extLst>
+            </p:cNvPr>
+            <p:cNvSpPr/>
+            <p:nvPr/>
+          </p:nvSpPr>
+          <p:spPr>
+            <a:xfrm>
+              <a:off x="427081" y="263129"/>
+              <a:ext cx="1371600" cy="1371600"/>
+            </a:xfrm>
+            <a:prstGeom prst="rect">
+              <a:avLst/>
+            </a:prstGeom>
+            <a:noFill/>
+            <a:ln w="76200">
+              <a:solidFill>
+                <a:schemeClr val="tx1"/>
+              </a:solidFill>
+            </a:ln>
+          </p:spPr>
+          <p:style>
+            <a:lnRef idx="2">
+              <a:schemeClr val="accent1">
+                <a:shade val="50000"/>
+              </a:schemeClr>
+            </a:lnRef>
+            <a:fillRef idx="1">
+              <a:schemeClr val="accent1"/>
+            </a:fillRef>
+            <a:effectRef idx="0">
+              <a:schemeClr val="accent1"/>
+            </a:effectRef>
+            <a:fontRef idx="minor">
+              <a:schemeClr val="lt1"/>
+            </a:fontRef>
+          </p:style>
+          <p:txBody>
+            <a:bodyPr rtlCol="0" anchor="ctr"/>
+            <a:lstStyle/>
+            <a:p>
+              <a:pPr algn="ctr"/>
+              <a:endParaRPr lang="en-US"/>
+            </a:p>
+          </p:txBody>
+        </p:sp>
+        <p:sp>
+          <p:nvSpPr>
+            <p:cNvPr id="12" name="Plaque 11">
+              <a:extLst>
+                <a:ext uri="{FF2B5EF4-FFF2-40B4-BE49-F238E27FC236}">
+                  <a16:creationId xmlns:a16="http://schemas.microsoft.com/office/drawing/2014/main" id="{6EFD24D8-7CAB-07DA-C1CC-A840802DC837}"/>
+                </a:ext>
+              </a:extLst>
+            </p:cNvPr>
+            <p:cNvSpPr/>
+            <p:nvPr/>
+          </p:nvSpPr>
+          <p:spPr>
+            <a:xfrm>
+              <a:off x="566683" y="478473"/>
+              <a:ext cx="1097280" cy="1097280"/>
+            </a:xfrm>
+            <a:prstGeom prst="plaque">
+              <a:avLst/>
+            </a:prstGeom>
+            <a:noFill/>
+            <a:ln w="38100" cap="flat" cmpd="sng" algn="ctr">
+              <a:solidFill>
+                <a:schemeClr val="dk1"/>
+              </a:solidFill>
+              <a:prstDash val="solid"/>
+              <a:round/>
+              <a:headEnd type="none" w="med" len="med"/>
+              <a:tailEnd type="none" w="med" len="med"/>
+            </a:ln>
+          </p:spPr>
+          <p:style>
+            <a:lnRef idx="0">
+              <a:scrgbClr r="0" g="0" b="0"/>
+            </a:lnRef>
+            <a:fillRef idx="0">
+              <a:scrgbClr r="0" g="0" b="0"/>
+            </a:fillRef>
+            <a:effectRef idx="0">
+              <a:scrgbClr r="0" g="0" b="0"/>
+            </a:effectRef>
+            <a:fontRef idx="minor">
+              <a:schemeClr val="dk1"/>
+            </a:fontRef>
+          </p:style>
+          <p:txBody>
+            <a:bodyPr rtlCol="0" anchor="ctr"/>
+            <a:lstStyle/>
+            <a:p>
+              <a:pPr algn="ctr"/>
+              <a:endParaRPr lang="en-US" dirty="0"/>
+            </a:p>
+          </p:txBody>
+        </p:sp>
       </p:grpSp>
     </p:spTree>
     <p:extLst>

</xml_diff>